<commit_message>
Separate 2025 follow-up observations from new 2026 ones; add per-year detail to timeline slide
Co-Authored-By: Claude Opus 5.5 <noreply@anthropic.com>
Claude-Session: https://claude.ai/code/session_01F1WXR13Nv8neEtLhaK3ELa
</commit_message>
<xml_diff>
--- a/supervision-gobierno-corporativo/Supervision_GC_SSF_COMEDICA_2025-2026.pptx
+++ b/supervision-gobierno-corporativo/Supervision_GC_SSF_COMEDICA_2025-2026.pptx
@@ -110,22 +110,22 @@
   <p:extLst>
     <p:ext uri="{521415D9-36F7-43E2-AB2F-B90AF26B5E84}">
       <p14:sectionLst xmlns:p14="http://schemas.microsoft.com/office/powerpoint/2010/main">
-        <p14:section name="1 · Resumen de notas SSF" id="{8ece2e2f-c120-34a5-4e28-95fcdfe0e678}">
+        <p14:section name="1 · Resumen de notas SSF" id="{0af96d93-5c4c-7280-46fd-ff1a3e29c353}">
           <p14:sldIdLst>
             <p14:sldId id="256"/>
           </p14:sldIdLst>
         </p14:section>
-        <p14:section name="2 · Observaciones 2025" id="{fd0e32ea-9e9e-a672-42e4-feb7fb224f4a}">
+        <p14:section name="2 · Observaciones 2025" id="{91fb50bf-dd51-b62a-6699-ab5b62a1e3bd}">
           <p14:sldIdLst>
             <p14:sldId id="257"/>
           </p14:sldIdLst>
         </p14:section>
-        <p14:section name="3 · Observaciones 2026" id="{6a166e19-8089-133b-26ec-5c1bae9f9705}">
+        <p14:section name="3 · Observaciones 2026" id="{35a45ce6-d975-1685-af17-f9ab2f8b42fe}">
           <p14:sldIdLst>
             <p14:sldId id="258"/>
           </p14:sldIdLst>
         </p14:section>
-        <p14:section name="4 · Línea de tiempo y evolución" id="{b83de5a8-c859-f69c-9859-1f36feb7d7bd}">
+        <p14:section name="4 · Línea de tiempo y evolución" id="{dcff3e0a-b1ea-1978-c5f7-a6ced01321f6}">
           <p14:sldIdLst>
             <p14:sldId id="259"/>
           </p14:sldIdLst>
@@ -534,7 +534,7 @@
           <a:p>
             <a:r>
               <a:rPr lang="en-US" dirty="0"/>
-              <a:t>Cuatro comunicados oficiales. Cada año la SSF primero notifica el nombramiento de la visita ampliada y luego remite el informe de resultados preliminares. 2025: 9 observaciones. 2026: 7 nuevas (Anexo A) y 2 de seguimiento (Anexo B), de las cuales 1 no está superada y 1 está parcialmente superada.</a:t>
+              <a:t>Cuatro comunicados oficiales. Cada año la SSF primero notifica el nombramiento de la visita ampliada y luego remite el informe de resultados preliminares. 2025: 9 observaciones. 2026: 7 observaciones nuevas (Anexo A) y seguimiento a 2 de las 9 observaciones de 2025 (Anexo B): la obs. 3 no superada y la obs. 5 parcialmente superada.</a:t>
             </a:r>
             <a:endParaRPr lang="en-US" dirty="0"/>
           </a:p>
@@ -622,7 +622,7 @@
           <a:p>
             <a:r>
               <a:rPr lang="en-US" dirty="0"/>
-              <a:t>Nueve observaciones de la Nota 17003. En rojo y ámbar, las que siguen abiertas en la visita 2026: comités sin ejecutivos (no superada), normativa desactualizada (parcialmente superada) y Fondo de Educación (reincide).</a:t>
+              <a:t>Nueve observaciones de la Nota 17003. En rojo y ámbar, las 2 observaciones a las que la SSF dio seguimiento en la visita 2026 (Anexo B): obs. 3 comités sin ejecutivos (no superada) y obs. 5 normativa desactualizada (parcialmente superada).</a:t>
             </a:r>
             <a:endParaRPr lang="en-US" dirty="0"/>
           </a:p>
@@ -710,7 +710,7 @@
           <a:p>
             <a:r>
               <a:rPr lang="en-US" dirty="0"/>
-              <a:t>Anexo A: siete observaciones nuevas; plazo de 10 días hábiles desde el día hábil siguiente a la recepción para remitir pruebas de descargo, previo conocimiento del Consejo de Administración. Anexo B: dos observaciones anteriores siguen abiertas; plan de solución en 15 días hábiles con acciones, responsable, plazo por acción y certificación del punto de acta del Consejo. Fechas aproximadas sin asuetos; validar con el Sistema de Control de Envíos.</a:t>
+              <a:t>Anexo A: siete observaciones nuevas; plazo de 10 días hábiles desde el día hábil siguiente a la recepción para remitir pruebas de descargo, previo conocimiento del Consejo de Administración. Anexo B: no son observaciones nuevas, es el seguimiento a las obs. 3 y 5 de 2025, que siguen abiertas; plan de solución en 15 días hábiles con acciones, responsable, plazo por acción y certificación del punto de acta del Consejo. Fechas aproximadas sin asuetos; validar con el Sistema de Control de Envíos.</a:t>
             </a:r>
             <a:endParaRPr lang="en-US" dirty="0"/>
           </a:p>
@@ -798,7 +798,7 @@
           <a:p>
             <a:r>
               <a:rPr lang="en-US" dirty="0"/>
-              <a:t>Ambas visitas siguieron el mismo ciclo: nombramiento, inicio de visita e informe preliminar, con 8 meses entre el informe de 2025 y el nuevo nombramiento. Hoy corren los plazos: 10 días hábiles para descargos del Anexo A (aprox. 23/10/2026) y 15 días hábiles para el plan de solución del Anexo B (aprox. 30/10/2026). Persisten tres temas: comités sin ejecutivos (no superada), normativa interna (parcialmente superada) y Fondo de Educación (reincide). Paleta: azul marino #173A6E 2025, verde #1D7A4B 2026, rojo #B42318 no superada, ámbar #D99A1E parcial.</a:t>
+              <a:t>Bloque 2025: nombramiento (09/04/2025), inicio de visita (19/05/2025) e informe preliminar con 9 observaciones (05/11/2025); hallazgos críticos: Política de Operaciones Vinculadas, normativa desactualizada y Fondo de Educación. Bloque 2026: nombramiento (31/07/2026), inicio (21/08/2026) e informe preliminar (09/10/2026) con 7 observaciones nuevas (Anexo A) y seguimiento a 2 observaciones de 2025 (Anexo B). Plazos: 10 días hábiles para descargos y 15 días hábiles para plan de solución. Seguimiento: obs. 3 de 2025 no superada; obs. 5 de 2025 parcialmente superada. El Fondo de Educación vuelve a aparecer como tema, pero con observaciones nuevas, no como seguimiento.</a:t>
             </a:r>
             <a:endParaRPr lang="en-US" dirty="0"/>
           </a:p>
@@ -1924,7 +1924,7 @@
                 <a:ea typeface="Cambria" pitchFamily="34" charset="-122"/>
                 <a:cs typeface="Cambria" pitchFamily="34" charset="-120"/>
               </a:rPr>
-              <a:t>7 + 2</a:t>
+              <a:t>7</a:t>
             </a:r>
             <a:endParaRPr lang="en-US" sz="3400" dirty="0"/>
           </a:p>
@@ -1960,7 +1960,7 @@
                   <a:schemeClr val="bg2"/>
                 </a:solidFill>
               </a:rPr>
-              <a:t>nuevas y de seguimiento en 2026</a:t>
+              <a:t>observaciones nuevas en 2026</a:t>
             </a:r>
             <a:endParaRPr lang="en-US" sz="1200" dirty="0"/>
           </a:p>
@@ -1999,7 +1999,7 @@
                 <a:ea typeface="Cambria" pitchFamily="34" charset="-122"/>
                 <a:cs typeface="Cambria" pitchFamily="34" charset="-120"/>
               </a:rPr>
-              <a:t>1 · 1</a:t>
+              <a:t>2</a:t>
             </a:r>
             <a:endParaRPr lang="en-US" sz="3400" dirty="0"/>
           </a:p>
@@ -2035,7 +2035,7 @@
                   <a:schemeClr val="bg2"/>
                 </a:solidFill>
               </a:rPr>
-              <a:t>no superada · parcialmente superada</a:t>
+              <a:t>de 2025 en seguimiento: 1 no superada, 1 parcial</a:t>
             </a:r>
             <a:endParaRPr lang="en-US" sz="1200" dirty="0"/>
           </a:p>
@@ -3288,7 +3288,7 @@
                   <a:schemeClr val="bg1"/>
                 </a:solidFill>
               </a:rPr>
-              <a:t>7 nuevas + 2 de seguimiento</a:t>
+              <a:t>7 nuevas + seguimiento a 2 de 2025</a:t>
             </a:r>
             <a:endParaRPr lang="en-US" sz="1100" dirty="0"/>
           </a:p>
@@ -3541,7 +3541,7 @@
         </p:nvSpPr>
         <p:spPr>
           <a:xfrm>
-            <a:off x="9966960" y="841248"/>
+            <a:off x="9921240" y="841248"/>
             <a:ext cx="146304" cy="146304"/>
           </a:xfrm>
           <a:prstGeom prst="ellipse">
@@ -3568,8 +3568,8 @@
         </p:nvSpPr>
         <p:spPr>
           <a:xfrm>
-            <a:off x="10186416" y="777240"/>
-            <a:ext cx="1737360" cy="274320"/>
+            <a:off x="10140696" y="777240"/>
+            <a:ext cx="1783080" cy="274320"/>
           </a:xfrm>
           <a:prstGeom prst="rect">
             <a:avLst/>
@@ -3590,7 +3590,7 @@
                   <a:schemeClr val="accent5"/>
                 </a:solidFill>
               </a:rPr>
-              <a:t>Sigue abierta en 2026</a:t>
+              <a:t>En seguimiento SSF 2026</a:t>
             </a:r>
             <a:endParaRPr lang="en-US" sz="1100" dirty="0"/>
           </a:p>
@@ -4252,7 +4252,7 @@
                   <a:schemeClr val="accent3"/>
                 </a:solidFill>
               </a:rPr>
-              <a:t>↳ 2026: NO SUPERADA</a:t>
+              <a:t>↳ Seguimiento 2026: NO SUPERADA</a:t>
             </a:r>
             <a:endParaRPr lang="en-US" sz="1050" dirty="0"/>
           </a:p>
@@ -4699,7 +4699,7 @@
                   <a:schemeClr val="accent6"/>
                 </a:solidFill>
               </a:rPr>
-              <a:t>↳ 2026: PARCIALMENTE SUPERADA</a:t>
+              <a:t>↳ Seguimiento 2026: PARCIALMENTE SUPERADA</a:t>
             </a:r>
             <a:endParaRPr lang="en-US" sz="1050" dirty="0"/>
           </a:p>
@@ -5394,11 +5394,11 @@
             <a:avLst/>
           </a:prstGeom>
           <a:solidFill>
-            <a:schemeClr val="accent6"/>
+            <a:schemeClr val="accent1"/>
           </a:solidFill>
           <a:ln w="12700">
             <a:solidFill>
-              <a:schemeClr val="accent6">
+              <a:schemeClr val="accent1">
                 <a:alpha val="0"/>
               </a:schemeClr>
             </a:solidFill>
@@ -5560,23 +5560,6 @@
                 </a:solidFill>
               </a:rPr>
               <a:t>Fuera del Art. 59 Ley de Cooperativas</a:t>
-            </a:r>
-            <a:endParaRPr lang="en-US" sz="1050" dirty="0"/>
-          </a:p>
-          <a:p>
-            <a:pPr indent="0" marL="0">
-              <a:spcAft>
-                <a:spcPts val="100"/>
-              </a:spcAft>
-              <a:buNone/>
-            </a:pPr>
-            <a:r>
-              <a:rPr lang="en-US" sz="1050" b="1" dirty="0">
-                <a:solidFill>
-                  <a:schemeClr val="accent6"/>
-                </a:solidFill>
-              </a:rPr>
-              <a:t>↳ 2026: REINCIDE</a:t>
             </a:r>
             <a:endParaRPr lang="en-US" sz="1050" dirty="0"/>
           </a:p>
@@ -5739,7 +5722,7 @@
         </p:nvSpPr>
         <p:spPr>
           <a:xfrm>
-            <a:off x="8229600" y="841248"/>
+            <a:off x="8046720" y="841248"/>
             <a:ext cx="146304" cy="146304"/>
           </a:xfrm>
           <a:prstGeom prst="ellipse">
@@ -5766,7 +5749,7 @@
         </p:nvSpPr>
         <p:spPr>
           <a:xfrm>
-            <a:off x="8449056" y="777240"/>
+            <a:off x="8266176" y="777240"/>
             <a:ext cx="1371600" cy="274320"/>
           </a:xfrm>
           <a:prstGeom prst="rect">
@@ -5802,18 +5785,18 @@
         </p:nvSpPr>
         <p:spPr>
           <a:xfrm>
-            <a:off x="9829800" y="841248"/>
+            <a:off x="9646920" y="841248"/>
             <a:ext cx="146304" cy="146304"/>
           </a:xfrm>
           <a:prstGeom prst="ellipse">
             <a:avLst/>
           </a:prstGeom>
           <a:solidFill>
-            <a:schemeClr val="accent4"/>
+            <a:schemeClr val="accent1"/>
           </a:solidFill>
           <a:ln w="12700">
             <a:solidFill>
-              <a:schemeClr val="accent4">
+              <a:schemeClr val="accent1">
                 <a:alpha val="0"/>
               </a:schemeClr>
             </a:solidFill>
@@ -5829,8 +5812,8 @@
         </p:nvSpPr>
         <p:spPr>
           <a:xfrm>
-            <a:off x="10049256" y="777240"/>
-            <a:ext cx="1737360" cy="274320"/>
+            <a:off x="9866376" y="777240"/>
+            <a:ext cx="1920240" cy="274320"/>
           </a:xfrm>
           <a:prstGeom prst="rect">
             <a:avLst/>
@@ -5851,7 +5834,7 @@
                   <a:schemeClr val="accent5"/>
                 </a:solidFill>
               </a:rPr>
-              <a:t>Anexo B · seguimiento</a:t>
+              <a:t>Anexo B · seguimiento 2025</a:t>
             </a:r>
             <a:endParaRPr lang="en-US" sz="1100" dirty="0"/>
           </a:p>
@@ -7498,7 +7481,7 @@
                   <a:schemeClr val="accent6"/>
                 </a:solidFill>
               </a:rPr>
-              <a:t>ANEXO B · SEGUIMIENTO A OBSERVACIONES DE VISITAS ANTERIORES</a:t>
+              <a:t>ANEXO B · SEGUIMIENTO A 2 DE LAS 9 OBSERVACIONES DE 2025 (NO SON NUEVAS)</a:t>
             </a:r>
             <a:endParaRPr lang="en-US" sz="1100" dirty="0"/>
           </a:p>
@@ -7537,17 +7520,84 @@
       </p:sp>
       <p:sp>
         <p:nvSpPr>
-          <p:cNvPr id="57" name="Número B-8 círculo"/>
+          <p:cNvPr id="57" name="Origen B-3 fondo"/>
           <p:cNvSpPr/>
           <p:nvPr/>
         </p:nvSpPr>
         <p:spPr>
           <a:xfrm>
-            <a:off x="731520" y="5248656"/>
-            <a:ext cx="365760" cy="365760"/>
-          </a:xfrm>
-          <a:prstGeom prst="ellipse">
-            <a:avLst/>
+            <a:off x="731520" y="5294376"/>
+            <a:ext cx="1325880" cy="274320"/>
+          </a:xfrm>
+          <a:prstGeom prst="roundRect">
+            <a:avLst>
+              <a:gd name="adj" fmla="val 50000"/>
+            </a:avLst>
+          </a:prstGeom>
+          <a:solidFill>
+            <a:schemeClr val="accent1"/>
+          </a:solidFill>
+          <a:ln w="12700">
+            <a:solidFill>
+              <a:schemeClr val="accent1">
+                <a:alpha val="0"/>
+              </a:schemeClr>
+            </a:solidFill>
+            <a:prstDash val="solid"/>
+          </a:ln>
+        </p:spPr>
+      </p:sp>
+      <p:sp>
+        <p:nvSpPr>
+          <p:cNvPr id="58" name="Origen B-3"/>
+          <p:cNvSpPr txBox="1"/>
+          <p:nvPr/>
+        </p:nvSpPr>
+        <p:spPr>
+          <a:xfrm>
+            <a:off x="731520" y="5294376"/>
+            <a:ext cx="1325880" cy="274320"/>
+          </a:xfrm>
+          <a:prstGeom prst="rect">
+            <a:avLst/>
+          </a:prstGeom>
+          <a:noFill/>
+          <a:ln/>
+        </p:spPr>
+        <p:txBody>
+          <a:bodyPr wrap="square" lIns="0" tIns="0" rIns="0" bIns="0" rtlCol="0" anchor="ctr"/>
+          <a:lstStyle/>
+          <a:p>
+            <a:pPr algn="ctr" indent="0" marL="0">
+              <a:buNone/>
+            </a:pPr>
+            <a:r>
+              <a:rPr lang="en-US" sz="1050" b="1" spc="100" kern="0" dirty="0">
+                <a:solidFill>
+                  <a:schemeClr val="bg1"/>
+                </a:solidFill>
+              </a:rPr>
+              <a:t>OBS. 3 DE 2025</a:t>
+            </a:r>
+            <a:endParaRPr lang="en-US" sz="1050" dirty="0"/>
+          </a:p>
+        </p:txBody>
+      </p:sp>
+      <p:sp>
+        <p:nvSpPr>
+          <p:cNvPr id="59" name="Estado B-3 fondo"/>
+          <p:cNvSpPr/>
+          <p:nvPr/>
+        </p:nvSpPr>
+        <p:spPr>
+          <a:xfrm>
+            <a:off x="2194560" y="5294376"/>
+            <a:ext cx="1325880" cy="274320"/>
+          </a:xfrm>
+          <a:prstGeom prst="roundRect">
+            <a:avLst>
+              <a:gd name="adj" fmla="val 50000"/>
+            </a:avLst>
           </a:prstGeom>
           <a:solidFill>
             <a:schemeClr val="accent3"/>
@@ -7564,81 +7614,13 @@
       </p:sp>
       <p:sp>
         <p:nvSpPr>
-          <p:cNvPr id="58" name="Número B-8"/>
-          <p:cNvSpPr txBox="1"/>
-          <p:nvPr/>
-        </p:nvSpPr>
-        <p:spPr>
-          <a:xfrm>
-            <a:off x="731520" y="5248656"/>
-            <a:ext cx="365760" cy="365760"/>
-          </a:xfrm>
-          <a:prstGeom prst="rect">
-            <a:avLst/>
-          </a:prstGeom>
-          <a:noFill/>
-          <a:ln/>
-        </p:spPr>
-        <p:txBody>
-          <a:bodyPr wrap="square" lIns="0" tIns="0" rIns="0" bIns="0" rtlCol="0" anchor="ctr"/>
-          <a:lstStyle/>
-          <a:p>
-            <a:pPr algn="ctr" indent="0" marL="0">
-              <a:buNone/>
-            </a:pPr>
-            <a:r>
-              <a:rPr lang="en-US" sz="1200" b="1" dirty="0">
-                <a:solidFill>
-                  <a:schemeClr val="bg1"/>
-                </a:solidFill>
-                <a:latin typeface="Cambria" pitchFamily="34" charset="0"/>
-                <a:ea typeface="Cambria" pitchFamily="34" charset="-122"/>
-                <a:cs typeface="Cambria" pitchFamily="34" charset="-120"/>
-              </a:rPr>
-              <a:t>8</a:t>
-            </a:r>
-            <a:endParaRPr lang="en-US" sz="1200" dirty="0"/>
-          </a:p>
-        </p:txBody>
-      </p:sp>
-      <p:sp>
-        <p:nvSpPr>
-          <p:cNvPr id="59" name="Estado B-8 fondo"/>
-          <p:cNvSpPr/>
-          <p:nvPr/>
-        </p:nvSpPr>
-        <p:spPr>
-          <a:xfrm>
-            <a:off x="1234440" y="5294376"/>
-            <a:ext cx="1325880" cy="274320"/>
-          </a:xfrm>
-          <a:prstGeom prst="roundRect">
-            <a:avLst>
-              <a:gd name="adj" fmla="val 50000"/>
-            </a:avLst>
-          </a:prstGeom>
-          <a:solidFill>
-            <a:schemeClr val="accent3"/>
-          </a:solidFill>
-          <a:ln w="12700">
-            <a:solidFill>
-              <a:schemeClr val="accent3">
-                <a:alpha val="0"/>
-              </a:schemeClr>
-            </a:solidFill>
-            <a:prstDash val="solid"/>
-          </a:ln>
-        </p:spPr>
-      </p:sp>
-      <p:sp>
-        <p:nvSpPr>
-          <p:cNvPr id="60" name="Estado B-8"/>
-          <p:cNvSpPr txBox="1"/>
-          <p:nvPr/>
-        </p:nvSpPr>
-        <p:spPr>
-          <a:xfrm>
-            <a:off x="1234440" y="5294376"/>
+          <p:cNvPr id="60" name="Estado B-3"/>
+          <p:cNvSpPr txBox="1"/>
+          <p:nvPr/>
+        </p:nvSpPr>
+        <p:spPr>
+          <a:xfrm>
+            <a:off x="2194560" y="5294376"/>
             <a:ext cx="1325880" cy="274320"/>
           </a:xfrm>
           <a:prstGeom prst="rect">
@@ -7771,17 +7753,84 @@
       </p:sp>
       <p:sp>
         <p:nvSpPr>
-          <p:cNvPr id="64" name="Número B-9 círculo"/>
+          <p:cNvPr id="64" name="Origen B-5 fondo"/>
           <p:cNvSpPr/>
           <p:nvPr/>
         </p:nvSpPr>
         <p:spPr>
           <a:xfrm>
-            <a:off x="4943361" y="5248656"/>
-            <a:ext cx="365760" cy="365760"/>
-          </a:xfrm>
-          <a:prstGeom prst="ellipse">
-            <a:avLst/>
+            <a:off x="4943361" y="5294376"/>
+            <a:ext cx="1325880" cy="274320"/>
+          </a:xfrm>
+          <a:prstGeom prst="roundRect">
+            <a:avLst>
+              <a:gd name="adj" fmla="val 50000"/>
+            </a:avLst>
+          </a:prstGeom>
+          <a:solidFill>
+            <a:schemeClr val="accent1"/>
+          </a:solidFill>
+          <a:ln w="12700">
+            <a:solidFill>
+              <a:schemeClr val="accent1">
+                <a:alpha val="0"/>
+              </a:schemeClr>
+            </a:solidFill>
+            <a:prstDash val="solid"/>
+          </a:ln>
+        </p:spPr>
+      </p:sp>
+      <p:sp>
+        <p:nvSpPr>
+          <p:cNvPr id="65" name="Origen B-5"/>
+          <p:cNvSpPr txBox="1"/>
+          <p:nvPr/>
+        </p:nvSpPr>
+        <p:spPr>
+          <a:xfrm>
+            <a:off x="4943361" y="5294376"/>
+            <a:ext cx="1325880" cy="274320"/>
+          </a:xfrm>
+          <a:prstGeom prst="rect">
+            <a:avLst/>
+          </a:prstGeom>
+          <a:noFill/>
+          <a:ln/>
+        </p:spPr>
+        <p:txBody>
+          <a:bodyPr wrap="square" lIns="0" tIns="0" rIns="0" bIns="0" rtlCol="0" anchor="ctr"/>
+          <a:lstStyle/>
+          <a:p>
+            <a:pPr algn="ctr" indent="0" marL="0">
+              <a:buNone/>
+            </a:pPr>
+            <a:r>
+              <a:rPr lang="en-US" sz="1050" b="1" spc="100" kern="0" dirty="0">
+                <a:solidFill>
+                  <a:schemeClr val="bg1"/>
+                </a:solidFill>
+              </a:rPr>
+              <a:t>OBS. 5 DE 2025</a:t>
+            </a:r>
+            <a:endParaRPr lang="en-US" sz="1050" dirty="0"/>
+          </a:p>
+        </p:txBody>
+      </p:sp>
+      <p:sp>
+        <p:nvSpPr>
+          <p:cNvPr id="66" name="Estado B-5 fondo"/>
+          <p:cNvSpPr/>
+          <p:nvPr/>
+        </p:nvSpPr>
+        <p:spPr>
+          <a:xfrm>
+            <a:off x="6406401" y="5294376"/>
+            <a:ext cx="2194560" cy="274320"/>
+          </a:xfrm>
+          <a:prstGeom prst="roundRect">
+            <a:avLst>
+              <a:gd name="adj" fmla="val 50000"/>
+            </a:avLst>
           </a:prstGeom>
           <a:solidFill>
             <a:schemeClr val="accent4"/>
@@ -7798,81 +7847,13 @@
       </p:sp>
       <p:sp>
         <p:nvSpPr>
-          <p:cNvPr id="65" name="Número B-9"/>
-          <p:cNvSpPr txBox="1"/>
-          <p:nvPr/>
-        </p:nvSpPr>
-        <p:spPr>
-          <a:xfrm>
-            <a:off x="4943361" y="5248656"/>
-            <a:ext cx="365760" cy="365760"/>
-          </a:xfrm>
-          <a:prstGeom prst="rect">
-            <a:avLst/>
-          </a:prstGeom>
-          <a:noFill/>
-          <a:ln/>
-        </p:spPr>
-        <p:txBody>
-          <a:bodyPr wrap="square" lIns="0" tIns="0" rIns="0" bIns="0" rtlCol="0" anchor="ctr"/>
-          <a:lstStyle/>
-          <a:p>
-            <a:pPr algn="ctr" indent="0" marL="0">
-              <a:buNone/>
-            </a:pPr>
-            <a:r>
-              <a:rPr lang="en-US" sz="1200" b="1" dirty="0">
-                <a:solidFill>
-                  <a:schemeClr val="bg1"/>
-                </a:solidFill>
-                <a:latin typeface="Cambria" pitchFamily="34" charset="0"/>
-                <a:ea typeface="Cambria" pitchFamily="34" charset="-122"/>
-                <a:cs typeface="Cambria" pitchFamily="34" charset="-120"/>
-              </a:rPr>
-              <a:t>9</a:t>
-            </a:r>
-            <a:endParaRPr lang="en-US" sz="1200" dirty="0"/>
-          </a:p>
-        </p:txBody>
-      </p:sp>
-      <p:sp>
-        <p:nvSpPr>
-          <p:cNvPr id="66" name="Estado B-9 fondo"/>
-          <p:cNvSpPr/>
-          <p:nvPr/>
-        </p:nvSpPr>
-        <p:spPr>
-          <a:xfrm>
-            <a:off x="5446281" y="5294376"/>
-            <a:ext cx="2194560" cy="274320"/>
-          </a:xfrm>
-          <a:prstGeom prst="roundRect">
-            <a:avLst>
-              <a:gd name="adj" fmla="val 50000"/>
-            </a:avLst>
-          </a:prstGeom>
-          <a:solidFill>
-            <a:schemeClr val="accent4"/>
-          </a:solidFill>
-          <a:ln w="12700">
-            <a:solidFill>
-              <a:schemeClr val="accent4">
-                <a:alpha val="0"/>
-              </a:schemeClr>
-            </a:solidFill>
-            <a:prstDash val="solid"/>
-          </a:ln>
-        </p:spPr>
-      </p:sp>
-      <p:sp>
-        <p:nvSpPr>
-          <p:cNvPr id="67" name="Estado B-9"/>
-          <p:cNvSpPr txBox="1"/>
-          <p:nvPr/>
-        </p:nvSpPr>
-        <p:spPr>
-          <a:xfrm>
-            <a:off x="5446281" y="5294376"/>
+          <p:cNvPr id="67" name="Estado B-5"/>
+          <p:cNvSpPr txBox="1"/>
+          <p:nvPr/>
+        </p:nvSpPr>
+        <p:spPr>
+          <a:xfrm>
+            <a:off x="6406401" y="5294376"/>
             <a:ext cx="2194560" cy="274320"/>
           </a:xfrm>
           <a:prstGeom prst="rect">
@@ -8269,7 +8250,7 @@
                 <a:ea typeface="Cambria" pitchFamily="34" charset="-122"/>
                 <a:cs typeface="Cambria" pitchFamily="34" charset="-120"/>
               </a:rPr>
-              <a:t>De 2025 a 2026</a:t>
+              <a:t>Línea de tiempo 2025 vs. 2026</a:t>
             </a:r>
             <a:endParaRPr lang="en-US" sz="3000" dirty="0"/>
           </a:p>
@@ -8277,309 +8258,18 @@
       </p:sp>
       <p:sp>
         <p:nvSpPr>
-          <p:cNvPr id="4" name="Leyenda 2025 punto"/>
+          <p:cNvPr id="4" name="Bloque 2025"/>
           <p:cNvSpPr/>
           <p:nvPr/>
         </p:nvSpPr>
         <p:spPr>
           <a:xfrm>
-            <a:off x="8778240" y="841248"/>
-            <a:ext cx="146304" cy="146304"/>
-          </a:xfrm>
-          <a:prstGeom prst="ellipse">
-            <a:avLst/>
-          </a:prstGeom>
-          <a:solidFill>
-            <a:schemeClr val="accent1"/>
-          </a:solidFill>
-          <a:ln w="12700">
-            <a:solidFill>
-              <a:schemeClr val="accent1">
-                <a:alpha val="0"/>
-              </a:schemeClr>
-            </a:solidFill>
-            <a:prstDash val="solid"/>
-          </a:ln>
-        </p:spPr>
-      </p:sp>
-      <p:sp>
-        <p:nvSpPr>
-          <p:cNvPr id="5" name="Leyenda 2025"/>
-          <p:cNvSpPr txBox="1"/>
-          <p:nvPr/>
-        </p:nvSpPr>
-        <p:spPr>
-          <a:xfrm>
-            <a:off x="8997696" y="777240"/>
-            <a:ext cx="1188720" cy="274320"/>
-          </a:xfrm>
-          <a:prstGeom prst="rect">
-            <a:avLst/>
-          </a:prstGeom>
-          <a:noFill/>
-          <a:ln/>
-        </p:spPr>
-        <p:txBody>
-          <a:bodyPr wrap="square" lIns="0" tIns="0" rIns="0" bIns="0" rtlCol="0" anchor="ctr"/>
-          <a:lstStyle/>
-          <a:p>
-            <a:pPr indent="0" marL="0">
-              <a:buNone/>
-            </a:pPr>
-            <a:r>
-              <a:rPr lang="en-US" sz="1100" dirty="0">
-                <a:solidFill>
-                  <a:schemeClr val="accent5"/>
-                </a:solidFill>
-              </a:rPr>
-              <a:t>2025 · Visita 1</a:t>
-            </a:r>
-            <a:endParaRPr lang="en-US" sz="1100" dirty="0"/>
-          </a:p>
-        </p:txBody>
-      </p:sp>
-      <p:sp>
-        <p:nvSpPr>
-          <p:cNvPr id="6" name="Leyenda 2026 punto"/>
-          <p:cNvSpPr/>
-          <p:nvPr/>
-        </p:nvSpPr>
-        <p:spPr>
-          <a:xfrm>
-            <a:off x="10149840" y="841248"/>
-            <a:ext cx="146304" cy="146304"/>
-          </a:xfrm>
-          <a:prstGeom prst="ellipse">
-            <a:avLst/>
-          </a:prstGeom>
-          <a:solidFill>
-            <a:schemeClr val="accent2"/>
-          </a:solidFill>
-          <a:ln w="12700">
-            <a:solidFill>
-              <a:schemeClr val="accent2">
-                <a:alpha val="0"/>
-              </a:schemeClr>
-            </a:solidFill>
-            <a:prstDash val="solid"/>
-          </a:ln>
-        </p:spPr>
-      </p:sp>
-      <p:sp>
-        <p:nvSpPr>
-          <p:cNvPr id="7" name="Leyenda 2026"/>
-          <p:cNvSpPr txBox="1"/>
-          <p:nvPr/>
-        </p:nvSpPr>
-        <p:spPr>
-          <a:xfrm>
-            <a:off x="10369296" y="777240"/>
-            <a:ext cx="1188720" cy="274320"/>
-          </a:xfrm>
-          <a:prstGeom prst="rect">
-            <a:avLst/>
-          </a:prstGeom>
-          <a:noFill/>
-          <a:ln/>
-        </p:spPr>
-        <p:txBody>
-          <a:bodyPr wrap="square" lIns="0" tIns="0" rIns="0" bIns="0" rtlCol="0" anchor="ctr"/>
-          <a:lstStyle/>
-          <a:p>
-            <a:pPr indent="0" marL="0">
-              <a:buNone/>
-            </a:pPr>
-            <a:r>
-              <a:rPr lang="en-US" sz="1100" dirty="0">
-                <a:solidFill>
-                  <a:schemeClr val="accent5"/>
-                </a:solidFill>
-              </a:rPr>
-              <a:t>2026 · Visita 2</a:t>
-            </a:r>
-            <a:endParaRPr lang="en-US" sz="1100" dirty="0"/>
-          </a:p>
-        </p:txBody>
-      </p:sp>
-      <p:sp>
-        <p:nvSpPr>
-          <p:cNvPr id="8" name="Eje 2025"/>
-          <p:cNvSpPr/>
-          <p:nvPr/>
-        </p:nvSpPr>
-        <p:spPr>
-          <a:xfrm>
-            <a:off x="548640" y="2688336"/>
-            <a:ext cx="4109618" cy="109728"/>
+            <a:off x="548640" y="1325880"/>
+            <a:ext cx="5410048" cy="3063240"/>
           </a:xfrm>
           <a:prstGeom prst="roundRect">
             <a:avLst>
-              <a:gd name="adj" fmla="val 50000"/>
-            </a:avLst>
-          </a:prstGeom>
-          <a:solidFill>
-            <a:schemeClr val="accent1"/>
-          </a:solidFill>
-          <a:ln w="12700">
-            <a:solidFill>
-              <a:schemeClr val="accent1">
-                <a:alpha val="0"/>
-              </a:schemeClr>
-            </a:solidFill>
-            <a:prstDash val="solid"/>
-          </a:ln>
-        </p:spPr>
-      </p:sp>
-      <p:sp>
-        <p:nvSpPr>
-          <p:cNvPr id="9" name="Pausa entre visitas"/>
-          <p:cNvSpPr/>
-          <p:nvPr/>
-        </p:nvSpPr>
-        <p:spPr>
-          <a:xfrm>
-            <a:off x="4749698" y="2743200"/>
-            <a:ext cx="1117549" cy="0"/>
-          </a:xfrm>
-          <a:prstGeom prst="line">
-            <a:avLst/>
-          </a:prstGeom>
-          <a:noFill/>
-          <a:ln w="19050">
-            <a:solidFill>
-              <a:schemeClr val="accent5"/>
-            </a:solidFill>
-            <a:prstDash val="dash"/>
-          </a:ln>
-        </p:spPr>
-      </p:sp>
-      <p:sp>
-        <p:nvSpPr>
-          <p:cNvPr id="10" name="Eje 2026"/>
-          <p:cNvSpPr/>
-          <p:nvPr/>
-        </p:nvSpPr>
-        <p:spPr>
-          <a:xfrm>
-            <a:off x="5958688" y="2688336"/>
-            <a:ext cx="5684368" cy="109728"/>
-          </a:xfrm>
-          <a:prstGeom prst="roundRect">
-            <a:avLst>
-              <a:gd name="adj" fmla="val 50000"/>
-            </a:avLst>
-          </a:prstGeom>
-          <a:solidFill>
-            <a:schemeClr val="accent2"/>
-          </a:solidFill>
-          <a:ln w="12700">
-            <a:solidFill>
-              <a:schemeClr val="accent2">
-                <a:alpha val="0"/>
-              </a:schemeClr>
-            </a:solidFill>
-            <a:prstDash val="solid"/>
-          </a:ln>
-        </p:spPr>
-      </p:sp>
-      <p:sp>
-        <p:nvSpPr>
-          <p:cNvPr id="11" name="Pausa texto"/>
-          <p:cNvSpPr txBox="1"/>
-          <p:nvPr/>
-        </p:nvSpPr>
-        <p:spPr>
-          <a:xfrm>
-            <a:off x="4759833" y="2825496"/>
-            <a:ext cx="1097280" cy="182880"/>
-          </a:xfrm>
-          <a:prstGeom prst="rect">
-            <a:avLst/>
-          </a:prstGeom>
-          <a:noFill/>
-          <a:ln/>
-        </p:spPr>
-        <p:txBody>
-          <a:bodyPr wrap="square" lIns="0" tIns="0" rIns="0" bIns="0" rtlCol="0" anchor="t"/>
-          <a:lstStyle/>
-          <a:p>
-            <a:pPr algn="ctr" indent="0" marL="0">
-              <a:buNone/>
-            </a:pPr>
-            <a:r>
-              <a:rPr lang="en-US" sz="1000" i="1" dirty="0">
-                <a:solidFill>
-                  <a:schemeClr val="accent5"/>
-                </a:solidFill>
-              </a:rPr>
-              <a:t>8 meses</a:t>
-            </a:r>
-            <a:endParaRPr lang="en-US" sz="1000" dirty="0"/>
-          </a:p>
-        </p:txBody>
-      </p:sp>
-      <p:sp>
-        <p:nvSpPr>
-          <p:cNvPr id="12" name="Conector 1"/>
-          <p:cNvSpPr/>
-          <p:nvPr/>
-        </p:nvSpPr>
-        <p:spPr>
-          <a:xfrm>
-            <a:off x="1371600" y="2450592"/>
-            <a:ext cx="0" cy="292608"/>
-          </a:xfrm>
-          <a:prstGeom prst="line">
-            <a:avLst/>
-          </a:prstGeom>
-          <a:noFill/>
-          <a:ln w="15875">
-            <a:solidFill>
-              <a:schemeClr val="accent1"/>
-            </a:solidFill>
-            <a:prstDash val="solid"/>
-          </a:ln>
-        </p:spPr>
-      </p:sp>
-      <p:sp>
-        <p:nvSpPr>
-          <p:cNvPr id="13" name="Hito 1"/>
-          <p:cNvSpPr/>
-          <p:nvPr/>
-        </p:nvSpPr>
-        <p:spPr>
-          <a:xfrm>
-            <a:off x="1252728" y="2624328"/>
-            <a:ext cx="237744" cy="237744"/>
-          </a:xfrm>
-          <a:prstGeom prst="ellipse">
-            <a:avLst/>
-          </a:prstGeom>
-          <a:solidFill>
-            <a:schemeClr val="bg1"/>
-          </a:solidFill>
-          <a:ln w="38100">
-            <a:solidFill>
-              <a:schemeClr val="accent1"/>
-            </a:solidFill>
-            <a:prstDash val="solid"/>
-          </a:ln>
-        </p:spPr>
-      </p:sp>
-      <p:sp>
-        <p:nvSpPr>
-          <p:cNvPr id="14" name="Tarjeta hito 1"/>
-          <p:cNvSpPr/>
-          <p:nvPr/>
-        </p:nvSpPr>
-        <p:spPr>
-          <a:xfrm>
-            <a:off x="548640" y="1426464"/>
-            <a:ext cx="2514600" cy="1024128"/>
-          </a:xfrm>
-          <a:prstGeom prst="roundRect">
-            <a:avLst>
-              <a:gd name="adj" fmla="val 8929"/>
+              <a:gd name="adj" fmla="val 2985"/>
             </a:avLst>
           </a:prstGeom>
           <a:solidFill>
@@ -8597,23 +8287,62 @@
       </p:sp>
       <p:sp>
         <p:nvSpPr>
-          <p:cNvPr id="15" name="Fecha hito 1"/>
-          <p:cNvSpPr txBox="1"/>
-          <p:nvPr/>
-        </p:nvSpPr>
-        <p:spPr>
-          <a:xfrm>
-            <a:off x="713232" y="1536192"/>
-            <a:ext cx="2185416" cy="237744"/>
-          </a:xfrm>
-          <a:prstGeom prst="rect">
-            <a:avLst/>
-          </a:prstGeom>
-          <a:noFill/>
-          <a:ln/>
-        </p:spPr>
-        <p:txBody>
-          <a:bodyPr wrap="square" lIns="0" tIns="0" rIns="0" bIns="0" rtlCol="0" anchor="t"/>
+          <p:cNvPr id="5" name="Año bloque 2025"/>
+          <p:cNvSpPr txBox="1"/>
+          <p:nvPr/>
+        </p:nvSpPr>
+        <p:spPr>
+          <a:xfrm>
+            <a:off x="777240" y="1463040"/>
+            <a:ext cx="1097280" cy="457200"/>
+          </a:xfrm>
+          <a:prstGeom prst="rect">
+            <a:avLst/>
+          </a:prstGeom>
+          <a:noFill/>
+          <a:ln/>
+        </p:spPr>
+        <p:txBody>
+          <a:bodyPr wrap="square" lIns="0" tIns="0" rIns="0" bIns="0" rtlCol="0" anchor="ctr"/>
+          <a:lstStyle/>
+          <a:p>
+            <a:pPr indent="0" marL="0">
+              <a:buNone/>
+            </a:pPr>
+            <a:r>
+              <a:rPr lang="en-US" sz="2600" b="1" dirty="0">
+                <a:solidFill>
+                  <a:schemeClr val="accent1"/>
+                </a:solidFill>
+                <a:latin typeface="Cambria" pitchFamily="34" charset="0"/>
+                <a:ea typeface="Cambria" pitchFamily="34" charset="-122"/>
+                <a:cs typeface="Cambria" pitchFamily="34" charset="-120"/>
+              </a:rPr>
+              <a:t>2025</a:t>
+            </a:r>
+            <a:endParaRPr lang="en-US" sz="2600" dirty="0"/>
+          </a:p>
+        </p:txBody>
+      </p:sp>
+      <p:sp>
+        <p:nvSpPr>
+          <p:cNvPr id="6" name="Subtítulo bloque 2025"/>
+          <p:cNvSpPr txBox="1"/>
+          <p:nvPr/>
+        </p:nvSpPr>
+        <p:spPr>
+          <a:xfrm>
+            <a:off x="1828800" y="1463040"/>
+            <a:ext cx="3947008" cy="457200"/>
+          </a:xfrm>
+          <a:prstGeom prst="rect">
+            <a:avLst/>
+          </a:prstGeom>
+          <a:noFill/>
+          <a:ln/>
+        </p:spPr>
+        <p:txBody>
+          <a:bodyPr wrap="square" lIns="0" tIns="0" rIns="0" bIns="0" rtlCol="0" anchor="ctr"/>
           <a:lstStyle/>
           <a:p>
             <a:pPr indent="0" marL="0">
@@ -8622,13 +8351,10 @@
             <a:r>
               <a:rPr lang="en-US" sz="1200" b="1" dirty="0">
                 <a:solidFill>
-                  <a:schemeClr val="accent1"/>
-                </a:solidFill>
-                <a:latin typeface="Courier New" pitchFamily="34" charset="0"/>
-                <a:ea typeface="Courier New" pitchFamily="34" charset="-122"/>
-                <a:cs typeface="Courier New" pitchFamily="34" charset="-120"/>
-              </a:rPr>
-              <a:t>09 ABR 2025</a:t>
+                  <a:schemeClr val="accent5"/>
+                </a:solidFill>
+              </a:rPr>
+              <a:t>Visita 1 · Nota 17003 · 9 observaciones</a:t>
             </a:r>
             <a:endParaRPr lang="en-US" sz="1200" dirty="0"/>
           </a:p>
@@ -8636,92 +8362,20 @@
       </p:sp>
       <p:sp>
         <p:nvSpPr>
-          <p:cNvPr id="16" name="Texto hito 1"/>
-          <p:cNvSpPr txBox="1"/>
-          <p:nvPr/>
-        </p:nvSpPr>
-        <p:spPr>
-          <a:xfrm>
-            <a:off x="713232" y="1792224"/>
-            <a:ext cx="2185416" cy="274320"/>
-          </a:xfrm>
-          <a:prstGeom prst="rect">
-            <a:avLst/>
-          </a:prstGeom>
-          <a:noFill/>
-          <a:ln/>
-        </p:spPr>
-        <p:txBody>
-          <a:bodyPr wrap="square" lIns="0" tIns="0" rIns="0" bIns="0" rtlCol="0" anchor="t"/>
-          <a:lstStyle/>
-          <a:p>
-            <a:pPr indent="0" marL="0">
-              <a:buNone/>
-            </a:pPr>
-            <a:r>
-              <a:rPr lang="en-US" sz="1350" b="1" dirty="0">
-                <a:solidFill>
-                  <a:schemeClr val="tx1"/>
-                </a:solidFill>
-              </a:rPr>
-              <a:t>Nombramiento SSF</a:t>
-            </a:r>
-            <a:endParaRPr lang="en-US" sz="1350" dirty="0"/>
-          </a:p>
-        </p:txBody>
-      </p:sp>
-      <p:sp>
-        <p:nvSpPr>
-          <p:cNvPr id="17" name="Detalle hito 1"/>
-          <p:cNvSpPr txBox="1"/>
-          <p:nvPr/>
-        </p:nvSpPr>
-        <p:spPr>
-          <a:xfrm>
-            <a:off x="713232" y="2093976"/>
-            <a:ext cx="2185416" cy="256032"/>
-          </a:xfrm>
-          <a:prstGeom prst="rect">
-            <a:avLst/>
-          </a:prstGeom>
-          <a:noFill/>
-          <a:ln/>
-        </p:spPr>
-        <p:txBody>
-          <a:bodyPr wrap="square" lIns="0" tIns="0" rIns="0" bIns="0" rtlCol="0" anchor="t"/>
-          <a:lstStyle/>
-          <a:p>
-            <a:pPr indent="0" marL="0">
-              <a:buNone/>
-            </a:pPr>
-            <a:r>
-              <a:rPr lang="en-US" sz="1100" dirty="0">
-                <a:solidFill>
-                  <a:schemeClr val="accent5"/>
-                </a:solidFill>
-              </a:rPr>
-              <a:t>Nota 9337 · corte 30/04</a:t>
-            </a:r>
-            <a:endParaRPr lang="en-US" sz="1100" dirty="0"/>
-          </a:p>
-        </p:txBody>
-      </p:sp>
-      <p:sp>
-        <p:nvSpPr>
-          <p:cNvPr id="18" name="Conector 2"/>
+          <p:cNvPr id="7" name="Eje 2025"/>
           <p:cNvSpPr/>
           <p:nvPr/>
         </p:nvSpPr>
         <p:spPr>
           <a:xfrm>
-            <a:off x="2946349" y="2743200"/>
-            <a:ext cx="0" cy="292608"/>
+            <a:off x="877824" y="2231136"/>
+            <a:ext cx="0" cy="1463040"/>
           </a:xfrm>
           <a:prstGeom prst="line">
             <a:avLst/>
           </a:prstGeom>
           <a:noFill/>
-          <a:ln w="15875">
+          <a:ln w="31750">
             <a:solidFill>
               <a:schemeClr val="accent1"/>
             </a:solidFill>
@@ -8731,14 +8385,14 @@
       </p:sp>
       <p:sp>
         <p:nvSpPr>
-          <p:cNvPr id="19" name="Hito 2"/>
+          <p:cNvPr id="8" name="Hito 2025-1"/>
           <p:cNvSpPr/>
           <p:nvPr/>
         </p:nvSpPr>
         <p:spPr>
           <a:xfrm>
-            <a:off x="2827477" y="2624328"/>
-            <a:ext cx="237744" cy="237744"/>
+            <a:off x="777240" y="2130552"/>
+            <a:ext cx="201168" cy="201168"/>
           </a:xfrm>
           <a:prstGeom prst="ellipse">
             <a:avLst/>
@@ -8746,7 +8400,7 @@
           <a:solidFill>
             <a:schemeClr val="bg1"/>
           </a:solidFill>
-          <a:ln w="38100">
+          <a:ln w="31750">
             <a:solidFill>
               <a:schemeClr val="accent1"/>
             </a:solidFill>
@@ -8756,18 +8410,490 @@
       </p:sp>
       <p:sp>
         <p:nvSpPr>
-          <p:cNvPr id="20" name="Tarjeta hito 2"/>
+          <p:cNvPr id="9" name="Fecha 2025-1"/>
+          <p:cNvSpPr txBox="1"/>
+          <p:nvPr/>
+        </p:nvSpPr>
+        <p:spPr>
+          <a:xfrm>
+            <a:off x="1143000" y="2103120"/>
+            <a:ext cx="2606040" cy="219456"/>
+          </a:xfrm>
+          <a:prstGeom prst="rect">
+            <a:avLst/>
+          </a:prstGeom>
+          <a:noFill/>
+          <a:ln/>
+        </p:spPr>
+        <p:txBody>
+          <a:bodyPr wrap="square" lIns="0" tIns="0" rIns="0" bIns="0" rtlCol="0" anchor="t"/>
+          <a:lstStyle/>
+          <a:p>
+            <a:pPr indent="0" marL="0">
+              <a:buNone/>
+            </a:pPr>
+            <a:r>
+              <a:rPr lang="en-US" sz="1100" b="1" dirty="0">
+                <a:solidFill>
+                  <a:schemeClr val="accent1"/>
+                </a:solidFill>
+                <a:latin typeface="Courier New" pitchFamily="34" charset="0"/>
+                <a:ea typeface="Courier New" pitchFamily="34" charset="-122"/>
+                <a:cs typeface="Courier New" pitchFamily="34" charset="-120"/>
+              </a:rPr>
+              <a:t>09 ABR 2025</a:t>
+            </a:r>
+            <a:endParaRPr lang="en-US" sz="1100" dirty="0"/>
+          </a:p>
+        </p:txBody>
+      </p:sp>
+      <p:sp>
+        <p:nvSpPr>
+          <p:cNvPr id="10" name="Hito 2025-1 texto"/>
+          <p:cNvSpPr txBox="1"/>
+          <p:nvPr/>
+        </p:nvSpPr>
+        <p:spPr>
+          <a:xfrm>
+            <a:off x="1143000" y="2322576"/>
+            <a:ext cx="2606040" cy="365760"/>
+          </a:xfrm>
+          <a:prstGeom prst="rect">
+            <a:avLst/>
+          </a:prstGeom>
+          <a:noFill/>
+          <a:ln/>
+        </p:spPr>
+        <p:txBody>
+          <a:bodyPr wrap="square" lIns="0" tIns="0" rIns="0" bIns="0" rtlCol="0" anchor="t"/>
+          <a:lstStyle/>
+          <a:p>
+            <a:pPr indent="0" marL="0">
+              <a:buNone/>
+            </a:pPr>
+            <a:r>
+              <a:rPr lang="en-US" sz="1150" dirty="0">
+                <a:solidFill>
+                  <a:schemeClr val="tx1"/>
+                </a:solidFill>
+              </a:rPr>
+              <a:t>Nombramiento SSF · Nota 9337</a:t>
+            </a:r>
+            <a:endParaRPr lang="en-US" sz="1150" dirty="0"/>
+          </a:p>
+        </p:txBody>
+      </p:sp>
+      <p:sp>
+        <p:nvSpPr>
+          <p:cNvPr id="11" name="Hito 2025-2"/>
           <p:cNvSpPr/>
           <p:nvPr/>
         </p:nvSpPr>
         <p:spPr>
           <a:xfrm>
-            <a:off x="1689049" y="3035808"/>
-            <a:ext cx="2514600" cy="1024128"/>
+            <a:off x="777240" y="2862072"/>
+            <a:ext cx="201168" cy="201168"/>
+          </a:xfrm>
+          <a:prstGeom prst="ellipse">
+            <a:avLst/>
+          </a:prstGeom>
+          <a:solidFill>
+            <a:schemeClr val="bg1"/>
+          </a:solidFill>
+          <a:ln w="31750">
+            <a:solidFill>
+              <a:schemeClr val="accent1"/>
+            </a:solidFill>
+            <a:prstDash val="solid"/>
+          </a:ln>
+        </p:spPr>
+      </p:sp>
+      <p:sp>
+        <p:nvSpPr>
+          <p:cNvPr id="12" name="Fecha 2025-2"/>
+          <p:cNvSpPr txBox="1"/>
+          <p:nvPr/>
+        </p:nvSpPr>
+        <p:spPr>
+          <a:xfrm>
+            <a:off x="1143000" y="2834640"/>
+            <a:ext cx="2606040" cy="219456"/>
+          </a:xfrm>
+          <a:prstGeom prst="rect">
+            <a:avLst/>
+          </a:prstGeom>
+          <a:noFill/>
+          <a:ln/>
+        </p:spPr>
+        <p:txBody>
+          <a:bodyPr wrap="square" lIns="0" tIns="0" rIns="0" bIns="0" rtlCol="0" anchor="t"/>
+          <a:lstStyle/>
+          <a:p>
+            <a:pPr indent="0" marL="0">
+              <a:buNone/>
+            </a:pPr>
+            <a:r>
+              <a:rPr lang="en-US" sz="1100" b="1" dirty="0">
+                <a:solidFill>
+                  <a:schemeClr val="accent1"/>
+                </a:solidFill>
+                <a:latin typeface="Courier New" pitchFamily="34" charset="0"/>
+                <a:ea typeface="Courier New" pitchFamily="34" charset="-122"/>
+                <a:cs typeface="Courier New" pitchFamily="34" charset="-120"/>
+              </a:rPr>
+              <a:t>19 MAY 2025</a:t>
+            </a:r>
+            <a:endParaRPr lang="en-US" sz="1100" dirty="0"/>
+          </a:p>
+        </p:txBody>
+      </p:sp>
+      <p:sp>
+        <p:nvSpPr>
+          <p:cNvPr id="13" name="Hito 2025-2 texto"/>
+          <p:cNvSpPr txBox="1"/>
+          <p:nvPr/>
+        </p:nvSpPr>
+        <p:spPr>
+          <a:xfrm>
+            <a:off x="1143000" y="3054096"/>
+            <a:ext cx="2606040" cy="365760"/>
+          </a:xfrm>
+          <a:prstGeom prst="rect">
+            <a:avLst/>
+          </a:prstGeom>
+          <a:noFill/>
+          <a:ln/>
+        </p:spPr>
+        <p:txBody>
+          <a:bodyPr wrap="square" lIns="0" tIns="0" rIns="0" bIns="0" rtlCol="0" anchor="t"/>
+          <a:lstStyle/>
+          <a:p>
+            <a:pPr indent="0" marL="0">
+              <a:buNone/>
+            </a:pPr>
+            <a:r>
+              <a:rPr lang="en-US" sz="1150" dirty="0">
+                <a:solidFill>
+                  <a:schemeClr val="tx1"/>
+                </a:solidFill>
+              </a:rPr>
+              <a:t>Inicio formal de la visita en sitio</a:t>
+            </a:r>
+            <a:endParaRPr lang="en-US" sz="1150" dirty="0"/>
+          </a:p>
+        </p:txBody>
+      </p:sp>
+      <p:sp>
+        <p:nvSpPr>
+          <p:cNvPr id="14" name="Hito 2025-3"/>
+          <p:cNvSpPr/>
+          <p:nvPr/>
+        </p:nvSpPr>
+        <p:spPr>
+          <a:xfrm>
+            <a:off x="777240" y="3593592"/>
+            <a:ext cx="201168" cy="201168"/>
+          </a:xfrm>
+          <a:prstGeom prst="ellipse">
+            <a:avLst/>
+          </a:prstGeom>
+          <a:solidFill>
+            <a:schemeClr val="bg1"/>
+          </a:solidFill>
+          <a:ln w="31750">
+            <a:solidFill>
+              <a:schemeClr val="accent1"/>
+            </a:solidFill>
+            <a:prstDash val="solid"/>
+          </a:ln>
+        </p:spPr>
+      </p:sp>
+      <p:sp>
+        <p:nvSpPr>
+          <p:cNvPr id="15" name="Fecha 2025-3"/>
+          <p:cNvSpPr txBox="1"/>
+          <p:nvPr/>
+        </p:nvSpPr>
+        <p:spPr>
+          <a:xfrm>
+            <a:off x="1143000" y="3566160"/>
+            <a:ext cx="2606040" cy="219456"/>
+          </a:xfrm>
+          <a:prstGeom prst="rect">
+            <a:avLst/>
+          </a:prstGeom>
+          <a:noFill/>
+          <a:ln/>
+        </p:spPr>
+        <p:txBody>
+          <a:bodyPr wrap="square" lIns="0" tIns="0" rIns="0" bIns="0" rtlCol="0" anchor="t"/>
+          <a:lstStyle/>
+          <a:p>
+            <a:pPr indent="0" marL="0">
+              <a:buNone/>
+            </a:pPr>
+            <a:r>
+              <a:rPr lang="en-US" sz="1100" b="1" dirty="0">
+                <a:solidFill>
+                  <a:schemeClr val="accent1"/>
+                </a:solidFill>
+                <a:latin typeface="Courier New" pitchFamily="34" charset="0"/>
+                <a:ea typeface="Courier New" pitchFamily="34" charset="-122"/>
+                <a:cs typeface="Courier New" pitchFamily="34" charset="-120"/>
+              </a:rPr>
+              <a:t>05 NOV 2025</a:t>
+            </a:r>
+            <a:endParaRPr lang="en-US" sz="1100" dirty="0"/>
+          </a:p>
+        </p:txBody>
+      </p:sp>
+      <p:sp>
+        <p:nvSpPr>
+          <p:cNvPr id="16" name="Hito 2025-3 texto"/>
+          <p:cNvSpPr txBox="1"/>
+          <p:nvPr/>
+        </p:nvSpPr>
+        <p:spPr>
+          <a:xfrm>
+            <a:off x="1143000" y="3785616"/>
+            <a:ext cx="2606040" cy="365760"/>
+          </a:xfrm>
+          <a:prstGeom prst="rect">
+            <a:avLst/>
+          </a:prstGeom>
+          <a:noFill/>
+          <a:ln/>
+        </p:spPr>
+        <p:txBody>
+          <a:bodyPr wrap="square" lIns="0" tIns="0" rIns="0" bIns="0" rtlCol="0" anchor="t"/>
+          <a:lstStyle/>
+          <a:p>
+            <a:pPr indent="0" marL="0">
+              <a:buNone/>
+            </a:pPr>
+            <a:r>
+              <a:rPr lang="en-US" sz="1150" dirty="0">
+                <a:solidFill>
+                  <a:schemeClr val="tx1"/>
+                </a:solidFill>
+              </a:rPr>
+              <a:t>Informe preliminar · Nota 17003 · 9 obs.</a:t>
+            </a:r>
+            <a:endParaRPr lang="en-US" sz="1150" dirty="0"/>
+          </a:p>
+        </p:txBody>
+      </p:sp>
+      <p:sp>
+        <p:nvSpPr>
+          <p:cNvPr id="17" name="Detalle 2025"/>
+          <p:cNvSpPr/>
+          <p:nvPr/>
+        </p:nvSpPr>
+        <p:spPr>
+          <a:xfrm>
+            <a:off x="3840480" y="2103120"/>
+            <a:ext cx="1935328" cy="2103120"/>
           </a:xfrm>
           <a:prstGeom prst="roundRect">
             <a:avLst>
-              <a:gd name="adj" fmla="val 8929"/>
+              <a:gd name="adj" fmla="val 4725"/>
+            </a:avLst>
+          </a:prstGeom>
+          <a:solidFill>
+            <a:schemeClr val="bg1"/>
+          </a:solidFill>
+          <a:ln w="12700">
+            <a:solidFill>
+              <a:schemeClr val="bg1">
+                <a:alpha val="0"/>
+              </a:schemeClr>
+            </a:solidFill>
+            <a:prstDash val="solid"/>
+          </a:ln>
+        </p:spPr>
+      </p:sp>
+      <p:sp>
+        <p:nvSpPr>
+          <p:cNvPr id="18" name="Detalle título 2025"/>
+          <p:cNvSpPr txBox="1"/>
+          <p:nvPr/>
+        </p:nvSpPr>
+        <p:spPr>
+          <a:xfrm>
+            <a:off x="4005072" y="2240280"/>
+            <a:ext cx="1606144" cy="274320"/>
+          </a:xfrm>
+          <a:prstGeom prst="rect">
+            <a:avLst/>
+          </a:prstGeom>
+          <a:noFill/>
+          <a:ln/>
+        </p:spPr>
+        <p:txBody>
+          <a:bodyPr wrap="square" lIns="0" tIns="0" rIns="0" bIns="0" rtlCol="0" anchor="t"/>
+          <a:lstStyle/>
+          <a:p>
+            <a:pPr indent="0" marL="0">
+              <a:buNone/>
+            </a:pPr>
+            <a:r>
+              <a:rPr lang="en-US" sz="1250" b="1" dirty="0">
+                <a:solidFill>
+                  <a:schemeClr val="accent1"/>
+                </a:solidFill>
+              </a:rPr>
+              <a:t>Hallazgos críticos 2025</a:t>
+            </a:r>
+            <a:endParaRPr lang="en-US" sz="1250" dirty="0"/>
+          </a:p>
+        </p:txBody>
+      </p:sp>
+      <p:sp>
+        <p:nvSpPr>
+          <p:cNvPr id="19" name="Detalle lista 2025"/>
+          <p:cNvSpPr txBox="1"/>
+          <p:nvPr/>
+        </p:nvSpPr>
+        <p:spPr>
+          <a:xfrm>
+            <a:off x="4005072" y="2587752"/>
+            <a:ext cx="1661008" cy="1554480"/>
+          </a:xfrm>
+          <a:prstGeom prst="rect">
+            <a:avLst/>
+          </a:prstGeom>
+          <a:noFill/>
+          <a:ln/>
+        </p:spPr>
+        <p:txBody>
+          <a:bodyPr wrap="square" lIns="0" tIns="0" rIns="0" bIns="0" rtlCol="0" anchor="t"/>
+          <a:lstStyle/>
+          <a:p>
+            <a:pPr marL="342900" indent="-342900">
+              <a:spcAft>
+                <a:spcPts val="400"/>
+              </a:spcAft>
+              <a:buSzPct val="100000"/>
+              <a:buChar char="•"/>
+            </a:pPr>
+            <a:r>
+              <a:rPr lang="en-US" sz="1100" dirty="0">
+                <a:solidFill>
+                  <a:schemeClr val="tx1"/>
+                </a:solidFill>
+              </a:rPr>
+              <a:t>Ausencia de Política de </a:t>
+            </a:r>
+            <a:pPr indent="0" marL="0">
+              <a:spcAft>
+                <a:spcPts val="400"/>
+              </a:spcAft>
+              <a:buNone/>
+            </a:pPr>
+            <a:r>
+              <a:rPr lang="en-US" sz="1100" b="1" dirty="0">
+                <a:solidFill>
+                  <a:schemeClr val="tx1"/>
+                </a:solidFill>
+              </a:rPr>
+              <a:t>Operaciones Vinculadas</a:t>
+            </a:r>
+            <a:endParaRPr lang="en-US" sz="1100" dirty="0"/>
+          </a:p>
+          <a:p>
+            <a:pPr marL="342900" indent="-342900">
+              <a:spcAft>
+                <a:spcPts val="400"/>
+              </a:spcAft>
+              <a:buSzPct val="100000"/>
+              <a:buChar char="•"/>
+            </a:pPr>
+            <a:r>
+              <a:rPr lang="en-US" sz="1100" dirty="0">
+                <a:solidFill>
+                  <a:schemeClr val="tx1"/>
+                </a:solidFill>
+              </a:rPr>
+              <a:t>Normativa interna </a:t>
+            </a:r>
+            <a:pPr indent="0" marL="0">
+              <a:spcAft>
+                <a:spcPts val="400"/>
+              </a:spcAft>
+              <a:buNone/>
+            </a:pPr>
+            <a:r>
+              <a:rPr lang="en-US" sz="1100" b="1" dirty="0">
+                <a:solidFill>
+                  <a:schemeClr val="tx1"/>
+                </a:solidFill>
+              </a:rPr>
+              <a:t>desactualizada</a:t>
+            </a:r>
+            <a:pPr indent="0" marL="0">
+              <a:spcAft>
+                <a:spcPts val="400"/>
+              </a:spcAft>
+              <a:buNone/>
+            </a:pPr>
+            <a:r>
+              <a:rPr lang="en-US" sz="1100" dirty="0">
+                <a:solidFill>
+                  <a:schemeClr val="tx1"/>
+                </a:solidFill>
+              </a:rPr>
+              <a:t> (9 documentos)</a:t>
+            </a:r>
+            <a:endParaRPr lang="en-US" sz="1100" dirty="0"/>
+          </a:p>
+          <a:p>
+            <a:pPr marL="342900" indent="-342900">
+              <a:spcAft>
+                <a:spcPts val="400"/>
+              </a:spcAft>
+              <a:buSzPct val="100000"/>
+              <a:buChar char="•"/>
+            </a:pPr>
+            <a:r>
+              <a:rPr lang="en-US" sz="1100" dirty="0">
+                <a:solidFill>
+                  <a:schemeClr val="tx1"/>
+                </a:solidFill>
+              </a:rPr>
+              <a:t>Uso inapropiado del </a:t>
+            </a:r>
+            <a:pPr indent="0" marL="0">
+              <a:spcAft>
+                <a:spcPts val="400"/>
+              </a:spcAft>
+              <a:buNone/>
+            </a:pPr>
+            <a:r>
+              <a:rPr lang="en-US" sz="1100" b="1" dirty="0">
+                <a:solidFill>
+                  <a:schemeClr val="tx1"/>
+                </a:solidFill>
+              </a:rPr>
+              <a:t>Fondo de Educación</a:t>
+            </a:r>
+            <a:endParaRPr lang="en-US" sz="1100" dirty="0"/>
+          </a:p>
+        </p:txBody>
+      </p:sp>
+      <p:sp>
+        <p:nvSpPr>
+          <p:cNvPr id="20" name="Bloque 2026"/>
+          <p:cNvSpPr/>
+          <p:nvPr/>
+        </p:nvSpPr>
+        <p:spPr>
+          <a:xfrm>
+            <a:off x="6233008" y="1325880"/>
+            <a:ext cx="5410048" cy="3063240"/>
+          </a:xfrm>
+          <a:prstGeom prst="roundRect">
+            <a:avLst>
+              <a:gd name="adj" fmla="val 2985"/>
             </a:avLst>
           </a:prstGeom>
           <a:solidFill>
@@ -8785,23 +8911,62 @@
       </p:sp>
       <p:sp>
         <p:nvSpPr>
-          <p:cNvPr id="21" name="Fecha hito 2"/>
-          <p:cNvSpPr txBox="1"/>
-          <p:nvPr/>
-        </p:nvSpPr>
-        <p:spPr>
-          <a:xfrm>
-            <a:off x="1853641" y="3145536"/>
-            <a:ext cx="2185416" cy="237744"/>
-          </a:xfrm>
-          <a:prstGeom prst="rect">
-            <a:avLst/>
-          </a:prstGeom>
-          <a:noFill/>
-          <a:ln/>
-        </p:spPr>
-        <p:txBody>
-          <a:bodyPr wrap="square" lIns="0" tIns="0" rIns="0" bIns="0" rtlCol="0" anchor="t"/>
+          <p:cNvPr id="21" name="Año bloque 2026"/>
+          <p:cNvSpPr txBox="1"/>
+          <p:nvPr/>
+        </p:nvSpPr>
+        <p:spPr>
+          <a:xfrm>
+            <a:off x="6461608" y="1463040"/>
+            <a:ext cx="1097280" cy="457200"/>
+          </a:xfrm>
+          <a:prstGeom prst="rect">
+            <a:avLst/>
+          </a:prstGeom>
+          <a:noFill/>
+          <a:ln/>
+        </p:spPr>
+        <p:txBody>
+          <a:bodyPr wrap="square" lIns="0" tIns="0" rIns="0" bIns="0" rtlCol="0" anchor="ctr"/>
+          <a:lstStyle/>
+          <a:p>
+            <a:pPr indent="0" marL="0">
+              <a:buNone/>
+            </a:pPr>
+            <a:r>
+              <a:rPr lang="en-US" sz="2600" b="1" dirty="0">
+                <a:solidFill>
+                  <a:schemeClr val="accent2"/>
+                </a:solidFill>
+                <a:latin typeface="Cambria" pitchFamily="34" charset="0"/>
+                <a:ea typeface="Cambria" pitchFamily="34" charset="-122"/>
+                <a:cs typeface="Cambria" pitchFamily="34" charset="-120"/>
+              </a:rPr>
+              <a:t>2026</a:t>
+            </a:r>
+            <a:endParaRPr lang="en-US" sz="2600" dirty="0"/>
+          </a:p>
+        </p:txBody>
+      </p:sp>
+      <p:sp>
+        <p:nvSpPr>
+          <p:cNvPr id="22" name="Subtítulo bloque 2026"/>
+          <p:cNvSpPr txBox="1"/>
+          <p:nvPr/>
+        </p:nvSpPr>
+        <p:spPr>
+          <a:xfrm>
+            <a:off x="7513168" y="1463040"/>
+            <a:ext cx="3947008" cy="457200"/>
+          </a:xfrm>
+          <a:prstGeom prst="rect">
+            <a:avLst/>
+          </a:prstGeom>
+          <a:noFill/>
+          <a:ln/>
+        </p:spPr>
+        <p:txBody>
+          <a:bodyPr wrap="square" lIns="0" tIns="0" rIns="0" bIns="0" rtlCol="0" anchor="ctr"/>
           <a:lstStyle/>
           <a:p>
             <a:pPr indent="0" marL="0">
@@ -8810,13 +8975,10 @@
             <a:r>
               <a:rPr lang="en-US" sz="1200" b="1" dirty="0">
                 <a:solidFill>
-                  <a:schemeClr val="accent1"/>
-                </a:solidFill>
-                <a:latin typeface="Courier New" pitchFamily="34" charset="0"/>
-                <a:ea typeface="Courier New" pitchFamily="34" charset="-122"/>
-                <a:cs typeface="Courier New" pitchFamily="34" charset="-120"/>
-              </a:rPr>
-              <a:t>19 MAY 2025</a:t>
+                  <a:schemeClr val="accent5"/>
+                </a:solidFill>
+              </a:rPr>
+              <a:t>Visita 2 · Nota 22741 · 7 nuevas + 2 de 2025</a:t>
             </a:r>
             <a:endParaRPr lang="en-US" sz="1200" dirty="0"/>
           </a:p>
@@ -8824,280 +8986,20 @@
       </p:sp>
       <p:sp>
         <p:nvSpPr>
-          <p:cNvPr id="22" name="Texto hito 2"/>
-          <p:cNvSpPr txBox="1"/>
-          <p:nvPr/>
-        </p:nvSpPr>
-        <p:spPr>
-          <a:xfrm>
-            <a:off x="1853641" y="3401568"/>
-            <a:ext cx="2185416" cy="274320"/>
-          </a:xfrm>
-          <a:prstGeom prst="rect">
-            <a:avLst/>
-          </a:prstGeom>
-          <a:noFill/>
-          <a:ln/>
-        </p:spPr>
-        <p:txBody>
-          <a:bodyPr wrap="square" lIns="0" tIns="0" rIns="0" bIns="0" rtlCol="0" anchor="t"/>
-          <a:lstStyle/>
-          <a:p>
-            <a:pPr indent="0" marL="0">
-              <a:buNone/>
-            </a:pPr>
-            <a:r>
-              <a:rPr lang="en-US" sz="1350" b="1" dirty="0">
-                <a:solidFill>
-                  <a:schemeClr val="tx1"/>
-                </a:solidFill>
-              </a:rPr>
-              <a:t>Inicio de visita en sitio</a:t>
-            </a:r>
-            <a:endParaRPr lang="en-US" sz="1350" dirty="0"/>
-          </a:p>
-        </p:txBody>
-      </p:sp>
-      <p:sp>
-        <p:nvSpPr>
-          <p:cNvPr id="23" name="Detalle hito 2"/>
-          <p:cNvSpPr txBox="1"/>
-          <p:nvPr/>
-        </p:nvSpPr>
-        <p:spPr>
-          <a:xfrm>
-            <a:off x="1853641" y="3703320"/>
-            <a:ext cx="2185416" cy="256032"/>
-          </a:xfrm>
-          <a:prstGeom prst="rect">
-            <a:avLst/>
-          </a:prstGeom>
-          <a:noFill/>
-          <a:ln/>
-        </p:spPr>
-        <p:txBody>
-          <a:bodyPr wrap="square" lIns="0" tIns="0" rIns="0" bIns="0" rtlCol="0" anchor="t"/>
-          <a:lstStyle/>
-          <a:p>
-            <a:pPr indent="0" marL="0">
-              <a:buNone/>
-            </a:pPr>
-            <a:r>
-              <a:rPr lang="en-US" sz="1100" dirty="0">
-                <a:solidFill>
-                  <a:schemeClr val="accent5"/>
-                </a:solidFill>
-              </a:rPr>
-              <a:t>Supervisión ampliada</a:t>
-            </a:r>
-            <a:endParaRPr lang="en-US" sz="1100" dirty="0"/>
-          </a:p>
-        </p:txBody>
-      </p:sp>
-      <p:sp>
-        <p:nvSpPr>
-          <p:cNvPr id="24" name="Conector 3"/>
+          <p:cNvPr id="23" name="Eje 2026"/>
           <p:cNvSpPr/>
           <p:nvPr/>
         </p:nvSpPr>
         <p:spPr>
           <a:xfrm>
-            <a:off x="4521098" y="2450592"/>
-            <a:ext cx="0" cy="292608"/>
+            <a:off x="6562192" y="2231136"/>
+            <a:ext cx="0" cy="1645920"/>
           </a:xfrm>
           <a:prstGeom prst="line">
             <a:avLst/>
           </a:prstGeom>
           <a:noFill/>
-          <a:ln w="15875">
-            <a:solidFill>
-              <a:schemeClr val="accent1"/>
-            </a:solidFill>
-            <a:prstDash val="solid"/>
-          </a:ln>
-        </p:spPr>
-      </p:sp>
-      <p:sp>
-        <p:nvSpPr>
-          <p:cNvPr id="25" name="Hito 3"/>
-          <p:cNvSpPr/>
-          <p:nvPr/>
-        </p:nvSpPr>
-        <p:spPr>
-          <a:xfrm>
-            <a:off x="4402226" y="2624328"/>
-            <a:ext cx="237744" cy="237744"/>
-          </a:xfrm>
-          <a:prstGeom prst="ellipse">
-            <a:avLst/>
-          </a:prstGeom>
-          <a:solidFill>
-            <a:schemeClr val="bg1"/>
-          </a:solidFill>
-          <a:ln w="38100">
-            <a:solidFill>
-              <a:schemeClr val="accent1"/>
-            </a:solidFill>
-            <a:prstDash val="solid"/>
-          </a:ln>
-        </p:spPr>
-      </p:sp>
-      <p:sp>
-        <p:nvSpPr>
-          <p:cNvPr id="26" name="Tarjeta hito 3"/>
-          <p:cNvSpPr/>
-          <p:nvPr/>
-        </p:nvSpPr>
-        <p:spPr>
-          <a:xfrm>
-            <a:off x="3263798" y="1426464"/>
-            <a:ext cx="2514600" cy="1024128"/>
-          </a:xfrm>
-          <a:prstGeom prst="roundRect">
-            <a:avLst>
-              <a:gd name="adj" fmla="val 8929"/>
-            </a:avLst>
-          </a:prstGeom>
-          <a:solidFill>
-            <a:schemeClr val="bg2"/>
-          </a:solidFill>
-          <a:ln w="12700">
-            <a:solidFill>
-              <a:schemeClr val="bg2">
-                <a:alpha val="0"/>
-              </a:schemeClr>
-            </a:solidFill>
-            <a:prstDash val="solid"/>
-          </a:ln>
-        </p:spPr>
-      </p:sp>
-      <p:sp>
-        <p:nvSpPr>
-          <p:cNvPr id="27" name="Fecha hito 3"/>
-          <p:cNvSpPr txBox="1"/>
-          <p:nvPr/>
-        </p:nvSpPr>
-        <p:spPr>
-          <a:xfrm>
-            <a:off x="3428390" y="1536192"/>
-            <a:ext cx="2185416" cy="237744"/>
-          </a:xfrm>
-          <a:prstGeom prst="rect">
-            <a:avLst/>
-          </a:prstGeom>
-          <a:noFill/>
-          <a:ln/>
-        </p:spPr>
-        <p:txBody>
-          <a:bodyPr wrap="square" lIns="0" tIns="0" rIns="0" bIns="0" rtlCol="0" anchor="t"/>
-          <a:lstStyle/>
-          <a:p>
-            <a:pPr indent="0" marL="0">
-              <a:buNone/>
-            </a:pPr>
-            <a:r>
-              <a:rPr lang="en-US" sz="1200" b="1" dirty="0">
-                <a:solidFill>
-                  <a:schemeClr val="accent1"/>
-                </a:solidFill>
-                <a:latin typeface="Courier New" pitchFamily="34" charset="0"/>
-                <a:ea typeface="Courier New" pitchFamily="34" charset="-122"/>
-                <a:cs typeface="Courier New" pitchFamily="34" charset="-120"/>
-              </a:rPr>
-              <a:t>05 NOV 2025</a:t>
-            </a:r>
-            <a:endParaRPr lang="en-US" sz="1200" dirty="0"/>
-          </a:p>
-        </p:txBody>
-      </p:sp>
-      <p:sp>
-        <p:nvSpPr>
-          <p:cNvPr id="28" name="Texto hito 3"/>
-          <p:cNvSpPr txBox="1"/>
-          <p:nvPr/>
-        </p:nvSpPr>
-        <p:spPr>
-          <a:xfrm>
-            <a:off x="3428390" y="1792224"/>
-            <a:ext cx="2185416" cy="274320"/>
-          </a:xfrm>
-          <a:prstGeom prst="rect">
-            <a:avLst/>
-          </a:prstGeom>
-          <a:noFill/>
-          <a:ln/>
-        </p:spPr>
-        <p:txBody>
-          <a:bodyPr wrap="square" lIns="0" tIns="0" rIns="0" bIns="0" rtlCol="0" anchor="t"/>
-          <a:lstStyle/>
-          <a:p>
-            <a:pPr indent="0" marL="0">
-              <a:buNone/>
-            </a:pPr>
-            <a:r>
-              <a:rPr lang="en-US" sz="1350" b="1" dirty="0">
-                <a:solidFill>
-                  <a:schemeClr val="tx1"/>
-                </a:solidFill>
-              </a:rPr>
-              <a:t>Informe preliminar</a:t>
-            </a:r>
-            <a:endParaRPr lang="en-US" sz="1350" dirty="0"/>
-          </a:p>
-        </p:txBody>
-      </p:sp>
-      <p:sp>
-        <p:nvSpPr>
-          <p:cNvPr id="29" name="Detalle hito 3"/>
-          <p:cNvSpPr txBox="1"/>
-          <p:nvPr/>
-        </p:nvSpPr>
-        <p:spPr>
-          <a:xfrm>
-            <a:off x="3428390" y="2093976"/>
-            <a:ext cx="2185416" cy="256032"/>
-          </a:xfrm>
-          <a:prstGeom prst="rect">
-            <a:avLst/>
-          </a:prstGeom>
-          <a:noFill/>
-          <a:ln/>
-        </p:spPr>
-        <p:txBody>
-          <a:bodyPr wrap="square" lIns="0" tIns="0" rIns="0" bIns="0" rtlCol="0" anchor="t"/>
-          <a:lstStyle/>
-          <a:p>
-            <a:pPr indent="0" marL="0">
-              <a:buNone/>
-            </a:pPr>
-            <a:r>
-              <a:rPr lang="en-US" sz="1100" dirty="0">
-                <a:solidFill>
-                  <a:schemeClr val="accent5"/>
-                </a:solidFill>
-              </a:rPr>
-              <a:t>Nota 17003 · 9 observaciones</a:t>
-            </a:r>
-            <a:endParaRPr lang="en-US" sz="1100" dirty="0"/>
-          </a:p>
-        </p:txBody>
-      </p:sp>
-      <p:sp>
-        <p:nvSpPr>
-          <p:cNvPr id="30" name="Conector 4"/>
-          <p:cNvSpPr/>
-          <p:nvPr/>
-        </p:nvSpPr>
-        <p:spPr>
-          <a:xfrm>
-            <a:off x="6095848" y="2743200"/>
-            <a:ext cx="0" cy="292608"/>
-          </a:xfrm>
-          <a:prstGeom prst="line">
-            <a:avLst/>
-          </a:prstGeom>
-          <a:noFill/>
-          <a:ln w="15875">
+          <a:ln w="31750">
             <a:solidFill>
               <a:schemeClr val="accent2"/>
             </a:solidFill>
@@ -9107,14 +9009,14 @@
       </p:sp>
       <p:sp>
         <p:nvSpPr>
-          <p:cNvPr id="31" name="Hito 4"/>
+          <p:cNvPr id="24" name="Hito 2026-1"/>
           <p:cNvSpPr/>
           <p:nvPr/>
         </p:nvSpPr>
         <p:spPr>
           <a:xfrm>
-            <a:off x="5976976" y="2624328"/>
-            <a:ext cx="237744" cy="237744"/>
+            <a:off x="6461608" y="2130552"/>
+            <a:ext cx="201168" cy="201168"/>
           </a:xfrm>
           <a:prstGeom prst="ellipse">
             <a:avLst/>
@@ -9122,7 +9024,7 @@
           <a:solidFill>
             <a:schemeClr val="bg1"/>
           </a:solidFill>
-          <a:ln w="38100">
+          <a:ln w="31750">
             <a:solidFill>
               <a:schemeClr val="accent2"/>
             </a:solidFill>
@@ -9132,43 +9034,14 @@
       </p:sp>
       <p:sp>
         <p:nvSpPr>
-          <p:cNvPr id="32" name="Tarjeta hito 4"/>
-          <p:cNvSpPr/>
-          <p:nvPr/>
-        </p:nvSpPr>
-        <p:spPr>
-          <a:xfrm>
-            <a:off x="4838548" y="3035808"/>
-            <a:ext cx="2514600" cy="1024128"/>
-          </a:xfrm>
-          <a:prstGeom prst="roundRect">
-            <a:avLst>
-              <a:gd name="adj" fmla="val 8929"/>
-            </a:avLst>
-          </a:prstGeom>
-          <a:solidFill>
-            <a:schemeClr val="bg2"/>
-          </a:solidFill>
-          <a:ln w="12700">
-            <a:solidFill>
-              <a:schemeClr val="bg2">
-                <a:alpha val="0"/>
-              </a:schemeClr>
-            </a:solidFill>
-            <a:prstDash val="solid"/>
-          </a:ln>
-        </p:spPr>
-      </p:sp>
-      <p:sp>
-        <p:nvSpPr>
-          <p:cNvPr id="33" name="Fecha hito 4"/>
-          <p:cNvSpPr txBox="1"/>
-          <p:nvPr/>
-        </p:nvSpPr>
-        <p:spPr>
-          <a:xfrm>
-            <a:off x="5003140" y="3145536"/>
-            <a:ext cx="2185416" cy="237744"/>
+          <p:cNvPr id="25" name="Fecha 2026-1"/>
+          <p:cNvSpPr txBox="1"/>
+          <p:nvPr/>
+        </p:nvSpPr>
+        <p:spPr>
+          <a:xfrm>
+            <a:off x="6827368" y="2103120"/>
+            <a:ext cx="2606040" cy="219456"/>
           </a:xfrm>
           <a:prstGeom prst="rect">
             <a:avLst/>
@@ -9184,7 +9057,7 @@
               <a:buNone/>
             </a:pPr>
             <a:r>
-              <a:rPr lang="en-US" sz="1200" b="1" dirty="0">
+              <a:rPr lang="en-US" sz="1100" b="1" dirty="0">
                 <a:solidFill>
                   <a:schemeClr val="accent2"/>
                 </a:solidFill>
@@ -9194,20 +9067,20 @@
               </a:rPr>
               <a:t>31 JUL 2026</a:t>
             </a:r>
-            <a:endParaRPr lang="en-US" sz="1200" dirty="0"/>
-          </a:p>
-        </p:txBody>
-      </p:sp>
-      <p:sp>
-        <p:nvSpPr>
-          <p:cNvPr id="34" name="Texto hito 4"/>
-          <p:cNvSpPr txBox="1"/>
-          <p:nvPr/>
-        </p:nvSpPr>
-        <p:spPr>
-          <a:xfrm>
-            <a:off x="5003140" y="3401568"/>
-            <a:ext cx="2185416" cy="274320"/>
+            <a:endParaRPr lang="en-US" sz="1100" dirty="0"/>
+          </a:p>
+        </p:txBody>
+      </p:sp>
+      <p:sp>
+        <p:nvSpPr>
+          <p:cNvPr id="26" name="Hito 2026-1 texto"/>
+          <p:cNvSpPr txBox="1"/>
+          <p:nvPr/>
+        </p:nvSpPr>
+        <p:spPr>
+          <a:xfrm>
+            <a:off x="6827368" y="2322576"/>
+            <a:ext cx="2606040" cy="365760"/>
           </a:xfrm>
           <a:prstGeom prst="rect">
             <a:avLst/>
@@ -9223,69 +9096,35 @@
               <a:buNone/>
             </a:pPr>
             <a:r>
-              <a:rPr lang="en-US" sz="1350" b="1" dirty="0">
+              <a:rPr lang="en-US" sz="1150" dirty="0">
                 <a:solidFill>
                   <a:schemeClr val="tx1"/>
                 </a:solidFill>
               </a:rPr>
-              <a:t>Nombramiento SSF</a:t>
-            </a:r>
-            <a:endParaRPr lang="en-US" sz="1350" dirty="0"/>
-          </a:p>
-        </p:txBody>
-      </p:sp>
-      <p:sp>
-        <p:nvSpPr>
-          <p:cNvPr id="35" name="Detalle hito 4"/>
-          <p:cNvSpPr txBox="1"/>
-          <p:nvPr/>
-        </p:nvSpPr>
-        <p:spPr>
-          <a:xfrm>
-            <a:off x="5003140" y="3703320"/>
-            <a:ext cx="2185416" cy="256032"/>
-          </a:xfrm>
-          <a:prstGeom prst="rect">
-            <a:avLst/>
-          </a:prstGeom>
-          <a:noFill/>
-          <a:ln/>
-        </p:spPr>
-        <p:txBody>
-          <a:bodyPr wrap="square" lIns="0" tIns="0" rIns="0" bIns="0" rtlCol="0" anchor="t"/>
-          <a:lstStyle/>
-          <a:p>
-            <a:pPr indent="0" marL="0">
-              <a:buNone/>
-            </a:pPr>
-            <a:r>
-              <a:rPr lang="en-US" sz="1100" dirty="0">
-                <a:solidFill>
-                  <a:schemeClr val="accent5"/>
-                </a:solidFill>
-              </a:rPr>
-              <a:t>Nota 18432 · corte 31/07</a:t>
-            </a:r>
-            <a:endParaRPr lang="en-US" sz="1100" dirty="0"/>
-          </a:p>
-        </p:txBody>
-      </p:sp>
-      <p:sp>
-        <p:nvSpPr>
-          <p:cNvPr id="36" name="Conector 5"/>
+              <a:t>Nombramiento SSF · Nota 18432</a:t>
+            </a:r>
+            <a:endParaRPr lang="en-US" sz="1150" dirty="0"/>
+          </a:p>
+        </p:txBody>
+      </p:sp>
+      <p:sp>
+        <p:nvSpPr>
+          <p:cNvPr id="27" name="Hito 2026-2"/>
           <p:cNvSpPr/>
           <p:nvPr/>
         </p:nvSpPr>
         <p:spPr>
           <a:xfrm>
-            <a:off x="7670597" y="2450592"/>
-            <a:ext cx="0" cy="292608"/>
-          </a:xfrm>
-          <a:prstGeom prst="line">
-            <a:avLst/>
-          </a:prstGeom>
-          <a:noFill/>
-          <a:ln w="15875">
+            <a:off x="6461608" y="2679192"/>
+            <a:ext cx="201168" cy="201168"/>
+          </a:xfrm>
+          <a:prstGeom prst="ellipse">
+            <a:avLst/>
+          </a:prstGeom>
+          <a:solidFill>
+            <a:schemeClr val="bg1"/>
+          </a:solidFill>
+          <a:ln w="31750">
             <a:solidFill>
               <a:schemeClr val="accent2"/>
             </a:solidFill>
@@ -9295,14 +9134,89 @@
       </p:sp>
       <p:sp>
         <p:nvSpPr>
-          <p:cNvPr id="37" name="Hito 5"/>
+          <p:cNvPr id="28" name="Fecha 2026-2"/>
+          <p:cNvSpPr txBox="1"/>
+          <p:nvPr/>
+        </p:nvSpPr>
+        <p:spPr>
+          <a:xfrm>
+            <a:off x="6827368" y="2651760"/>
+            <a:ext cx="2606040" cy="219456"/>
+          </a:xfrm>
+          <a:prstGeom prst="rect">
+            <a:avLst/>
+          </a:prstGeom>
+          <a:noFill/>
+          <a:ln/>
+        </p:spPr>
+        <p:txBody>
+          <a:bodyPr wrap="square" lIns="0" tIns="0" rIns="0" bIns="0" rtlCol="0" anchor="t"/>
+          <a:lstStyle/>
+          <a:p>
+            <a:pPr indent="0" marL="0">
+              <a:buNone/>
+            </a:pPr>
+            <a:r>
+              <a:rPr lang="en-US" sz="1100" b="1" dirty="0">
+                <a:solidFill>
+                  <a:schemeClr val="accent2"/>
+                </a:solidFill>
+                <a:latin typeface="Courier New" pitchFamily="34" charset="0"/>
+                <a:ea typeface="Courier New" pitchFamily="34" charset="-122"/>
+                <a:cs typeface="Courier New" pitchFamily="34" charset="-120"/>
+              </a:rPr>
+              <a:t>21 AGO 2026</a:t>
+            </a:r>
+            <a:endParaRPr lang="en-US" sz="1100" dirty="0"/>
+          </a:p>
+        </p:txBody>
+      </p:sp>
+      <p:sp>
+        <p:nvSpPr>
+          <p:cNvPr id="29" name="Hito 2026-2 texto"/>
+          <p:cNvSpPr txBox="1"/>
+          <p:nvPr/>
+        </p:nvSpPr>
+        <p:spPr>
+          <a:xfrm>
+            <a:off x="6827368" y="2871216"/>
+            <a:ext cx="2606040" cy="365760"/>
+          </a:xfrm>
+          <a:prstGeom prst="rect">
+            <a:avLst/>
+          </a:prstGeom>
+          <a:noFill/>
+          <a:ln/>
+        </p:spPr>
+        <p:txBody>
+          <a:bodyPr wrap="square" lIns="0" tIns="0" rIns="0" bIns="0" rtlCol="0" anchor="t"/>
+          <a:lstStyle/>
+          <a:p>
+            <a:pPr indent="0" marL="0">
+              <a:buNone/>
+            </a:pPr>
+            <a:r>
+              <a:rPr lang="en-US" sz="1150" dirty="0">
+                <a:solidFill>
+                  <a:schemeClr val="tx1"/>
+                </a:solidFill>
+              </a:rPr>
+              <a:t>Inicio de la visita ampliada</a:t>
+            </a:r>
+            <a:endParaRPr lang="en-US" sz="1150" dirty="0"/>
+          </a:p>
+        </p:txBody>
+      </p:sp>
+      <p:sp>
+        <p:nvSpPr>
+          <p:cNvPr id="30" name="Hito 2026-3"/>
           <p:cNvSpPr/>
           <p:nvPr/>
         </p:nvSpPr>
         <p:spPr>
           <a:xfrm>
-            <a:off x="7551725" y="2624328"/>
-            <a:ext cx="237744" cy="237744"/>
+            <a:off x="6461608" y="3227832"/>
+            <a:ext cx="201168" cy="201168"/>
           </a:xfrm>
           <a:prstGeom prst="ellipse">
             <a:avLst/>
@@ -9310,7 +9224,7 @@
           <a:solidFill>
             <a:schemeClr val="bg1"/>
           </a:solidFill>
-          <a:ln w="38100">
+          <a:ln w="31750">
             <a:solidFill>
               <a:schemeClr val="accent2"/>
             </a:solidFill>
@@ -9320,43 +9234,14 @@
       </p:sp>
       <p:sp>
         <p:nvSpPr>
-          <p:cNvPr id="38" name="Tarjeta hito 5"/>
-          <p:cNvSpPr/>
-          <p:nvPr/>
-        </p:nvSpPr>
-        <p:spPr>
-          <a:xfrm>
-            <a:off x="6413297" y="1426464"/>
-            <a:ext cx="2514600" cy="1024128"/>
-          </a:xfrm>
-          <a:prstGeom prst="roundRect">
-            <a:avLst>
-              <a:gd name="adj" fmla="val 8929"/>
-            </a:avLst>
-          </a:prstGeom>
-          <a:solidFill>
-            <a:schemeClr val="bg2"/>
-          </a:solidFill>
-          <a:ln w="12700">
-            <a:solidFill>
-              <a:schemeClr val="bg2">
-                <a:alpha val="0"/>
-              </a:schemeClr>
-            </a:solidFill>
-            <a:prstDash val="solid"/>
-          </a:ln>
-        </p:spPr>
-      </p:sp>
-      <p:sp>
-        <p:nvSpPr>
-          <p:cNvPr id="39" name="Fecha hito 5"/>
-          <p:cNvSpPr txBox="1"/>
-          <p:nvPr/>
-        </p:nvSpPr>
-        <p:spPr>
-          <a:xfrm>
-            <a:off x="6577889" y="1536192"/>
-            <a:ext cx="2185416" cy="237744"/>
+          <p:cNvPr id="31" name="Fecha 2026-3"/>
+          <p:cNvSpPr txBox="1"/>
+          <p:nvPr/>
+        </p:nvSpPr>
+        <p:spPr>
+          <a:xfrm>
+            <a:off x="6827368" y="3200400"/>
+            <a:ext cx="2606040" cy="219456"/>
           </a:xfrm>
           <a:prstGeom prst="rect">
             <a:avLst/>
@@ -9372,7 +9257,7 @@
               <a:buNone/>
             </a:pPr>
             <a:r>
-              <a:rPr lang="en-US" sz="1200" b="1" dirty="0">
+              <a:rPr lang="en-US" sz="1100" b="1" dirty="0">
                 <a:solidFill>
                   <a:schemeClr val="accent2"/>
                 </a:solidFill>
@@ -9380,22 +9265,22 @@
                 <a:ea typeface="Courier New" pitchFamily="34" charset="-122"/>
                 <a:cs typeface="Courier New" pitchFamily="34" charset="-120"/>
               </a:rPr>
-              <a:t>21 AGO 2026</a:t>
-            </a:r>
-            <a:endParaRPr lang="en-US" sz="1200" dirty="0"/>
-          </a:p>
-        </p:txBody>
-      </p:sp>
-      <p:sp>
-        <p:nvSpPr>
-          <p:cNvPr id="40" name="Texto hito 5"/>
-          <p:cNvSpPr txBox="1"/>
-          <p:nvPr/>
-        </p:nvSpPr>
-        <p:spPr>
-          <a:xfrm>
-            <a:off x="6577889" y="1792224"/>
-            <a:ext cx="2185416" cy="274320"/>
+              <a:t>09 OCT 2026</a:t>
+            </a:r>
+            <a:endParaRPr lang="en-US" sz="1100" dirty="0"/>
+          </a:p>
+        </p:txBody>
+      </p:sp>
+      <p:sp>
+        <p:nvSpPr>
+          <p:cNvPr id="32" name="Hito 2026-3 texto"/>
+          <p:cNvSpPr txBox="1"/>
+          <p:nvPr/>
+        </p:nvSpPr>
+        <p:spPr>
+          <a:xfrm>
+            <a:off x="6827368" y="3419856"/>
+            <a:ext cx="2606040" cy="365760"/>
           </a:xfrm>
           <a:prstGeom prst="rect">
             <a:avLst/>
@@ -9411,281 +9296,34 @@
               <a:buNone/>
             </a:pPr>
             <a:r>
-              <a:rPr lang="en-US" sz="1350" b="1" dirty="0">
+              <a:rPr lang="en-US" sz="1150" dirty="0">
                 <a:solidFill>
                   <a:schemeClr val="tx1"/>
                 </a:solidFill>
               </a:rPr>
-              <a:t>Inicio de visita ampliada</a:t>
-            </a:r>
-            <a:endParaRPr lang="en-US" sz="1350" dirty="0"/>
-          </a:p>
-        </p:txBody>
-      </p:sp>
-      <p:sp>
-        <p:nvSpPr>
-          <p:cNvPr id="41" name="Detalle hito 5"/>
-          <p:cNvSpPr txBox="1"/>
-          <p:nvPr/>
-        </p:nvSpPr>
-        <p:spPr>
-          <a:xfrm>
-            <a:off x="6577889" y="2093976"/>
-            <a:ext cx="2185416" cy="256032"/>
-          </a:xfrm>
-          <a:prstGeom prst="rect">
-            <a:avLst/>
-          </a:prstGeom>
-          <a:noFill/>
-          <a:ln/>
-        </p:spPr>
-        <p:txBody>
-          <a:bodyPr wrap="square" lIns="0" tIns="0" rIns="0" bIns="0" rtlCol="0" anchor="t"/>
-          <a:lstStyle/>
-          <a:p>
-            <a:pPr indent="0" marL="0">
-              <a:buNone/>
-            </a:pPr>
-            <a:r>
-              <a:rPr lang="en-US" sz="1100" dirty="0">
-                <a:solidFill>
-                  <a:schemeClr val="accent5"/>
-                </a:solidFill>
-              </a:rPr>
-              <a:t>Supervisión ampliada</a:t>
-            </a:r>
-            <a:endParaRPr lang="en-US" sz="1100" dirty="0"/>
-          </a:p>
-        </p:txBody>
-      </p:sp>
-      <p:sp>
-        <p:nvSpPr>
-          <p:cNvPr id="42" name="Conector 6"/>
+              <a:t>Informe preliminar · Nota 22741 · 7 + 2</a:t>
+            </a:r>
+            <a:endParaRPr lang="en-US" sz="1150" dirty="0"/>
+          </a:p>
+        </p:txBody>
+      </p:sp>
+      <p:sp>
+        <p:nvSpPr>
+          <p:cNvPr id="33" name="Halo hoy"/>
           <p:cNvSpPr/>
           <p:nvPr/>
         </p:nvSpPr>
         <p:spPr>
           <a:xfrm>
-            <a:off x="9245346" y="2743200"/>
-            <a:ext cx="0" cy="292608"/>
-          </a:xfrm>
-          <a:prstGeom prst="line">
-            <a:avLst/>
-          </a:prstGeom>
-          <a:noFill/>
-          <a:ln w="15875">
-            <a:solidFill>
-              <a:schemeClr val="accent2"/>
-            </a:solidFill>
-            <a:prstDash val="solid"/>
-          </a:ln>
-        </p:spPr>
-      </p:sp>
-      <p:sp>
-        <p:nvSpPr>
-          <p:cNvPr id="43" name="Hito 6"/>
-          <p:cNvSpPr/>
-          <p:nvPr/>
-        </p:nvSpPr>
-        <p:spPr>
-          <a:xfrm>
-            <a:off x="9126474" y="2624328"/>
-            <a:ext cx="237744" cy="237744"/>
-          </a:xfrm>
-          <a:prstGeom prst="ellipse">
-            <a:avLst/>
-          </a:prstGeom>
-          <a:solidFill>
-            <a:schemeClr val="bg1"/>
-          </a:solidFill>
-          <a:ln w="38100">
-            <a:solidFill>
-              <a:schemeClr val="accent2"/>
-            </a:solidFill>
-            <a:prstDash val="solid"/>
-          </a:ln>
-        </p:spPr>
-      </p:sp>
-      <p:sp>
-        <p:nvSpPr>
-          <p:cNvPr id="44" name="Tarjeta hito 6"/>
-          <p:cNvSpPr/>
-          <p:nvPr/>
-        </p:nvSpPr>
-        <p:spPr>
-          <a:xfrm>
-            <a:off x="7988046" y="3035808"/>
-            <a:ext cx="2514600" cy="1024128"/>
-          </a:xfrm>
-          <a:prstGeom prst="roundRect">
-            <a:avLst>
-              <a:gd name="adj" fmla="val 8929"/>
-            </a:avLst>
-          </a:prstGeom>
-          <a:solidFill>
-            <a:schemeClr val="bg2"/>
-          </a:solidFill>
-          <a:ln w="12700">
-            <a:solidFill>
-              <a:schemeClr val="bg2">
-                <a:alpha val="0"/>
-              </a:schemeClr>
-            </a:solidFill>
-            <a:prstDash val="solid"/>
-          </a:ln>
-        </p:spPr>
-      </p:sp>
-      <p:sp>
-        <p:nvSpPr>
-          <p:cNvPr id="45" name="Fecha hito 6"/>
-          <p:cNvSpPr txBox="1"/>
-          <p:nvPr/>
-        </p:nvSpPr>
-        <p:spPr>
-          <a:xfrm>
-            <a:off x="8152638" y="3145536"/>
-            <a:ext cx="2185416" cy="237744"/>
-          </a:xfrm>
-          <a:prstGeom prst="rect">
-            <a:avLst/>
-          </a:prstGeom>
-          <a:noFill/>
-          <a:ln/>
-        </p:spPr>
-        <p:txBody>
-          <a:bodyPr wrap="square" lIns="0" tIns="0" rIns="0" bIns="0" rtlCol="0" anchor="t"/>
-          <a:lstStyle/>
-          <a:p>
-            <a:pPr indent="0" marL="0">
-              <a:buNone/>
-            </a:pPr>
-            <a:r>
-              <a:rPr lang="en-US" sz="1200" b="1" dirty="0">
-                <a:solidFill>
-                  <a:schemeClr val="accent2"/>
-                </a:solidFill>
-                <a:latin typeface="Courier New" pitchFamily="34" charset="0"/>
-                <a:ea typeface="Courier New" pitchFamily="34" charset="-122"/>
-                <a:cs typeface="Courier New" pitchFamily="34" charset="-120"/>
-              </a:rPr>
-              <a:t>09 OCT 2026</a:t>
-            </a:r>
-            <a:endParaRPr lang="en-US" sz="1200" dirty="0"/>
-          </a:p>
-        </p:txBody>
-      </p:sp>
-      <p:sp>
-        <p:nvSpPr>
-          <p:cNvPr id="46" name="Texto hito 6"/>
-          <p:cNvSpPr txBox="1"/>
-          <p:nvPr/>
-        </p:nvSpPr>
-        <p:spPr>
-          <a:xfrm>
-            <a:off x="8152638" y="3401568"/>
-            <a:ext cx="2185416" cy="274320"/>
-          </a:xfrm>
-          <a:prstGeom prst="rect">
-            <a:avLst/>
-          </a:prstGeom>
-          <a:noFill/>
-          <a:ln/>
-        </p:spPr>
-        <p:txBody>
-          <a:bodyPr wrap="square" lIns="0" tIns="0" rIns="0" bIns="0" rtlCol="0" anchor="t"/>
-          <a:lstStyle/>
-          <a:p>
-            <a:pPr indent="0" marL="0">
-              <a:buNone/>
-            </a:pPr>
-            <a:r>
-              <a:rPr lang="en-US" sz="1350" b="1" dirty="0">
-                <a:solidFill>
-                  <a:schemeClr val="tx1"/>
-                </a:solidFill>
-              </a:rPr>
-              <a:t>Informe preliminar</a:t>
-            </a:r>
-            <a:endParaRPr lang="en-US" sz="1350" dirty="0"/>
-          </a:p>
-        </p:txBody>
-      </p:sp>
-      <p:sp>
-        <p:nvSpPr>
-          <p:cNvPr id="47" name="Detalle hito 6"/>
-          <p:cNvSpPr txBox="1"/>
-          <p:nvPr/>
-        </p:nvSpPr>
-        <p:spPr>
-          <a:xfrm>
-            <a:off x="8152638" y="3703320"/>
-            <a:ext cx="2185416" cy="256032"/>
-          </a:xfrm>
-          <a:prstGeom prst="rect">
-            <a:avLst/>
-          </a:prstGeom>
-          <a:noFill/>
-          <a:ln/>
-        </p:spPr>
-        <p:txBody>
-          <a:bodyPr wrap="square" lIns="0" tIns="0" rIns="0" bIns="0" rtlCol="0" anchor="t"/>
-          <a:lstStyle/>
-          <a:p>
-            <a:pPr indent="0" marL="0">
-              <a:buNone/>
-            </a:pPr>
-            <a:r>
-              <a:rPr lang="en-US" sz="1100" dirty="0">
-                <a:solidFill>
-                  <a:schemeClr val="accent5"/>
-                </a:solidFill>
-              </a:rPr>
-              <a:t>Nota 22741 · 7 nuevas + 2</a:t>
-            </a:r>
-            <a:endParaRPr lang="en-US" sz="1100" dirty="0"/>
-          </a:p>
-        </p:txBody>
-      </p:sp>
-      <p:sp>
-        <p:nvSpPr>
-          <p:cNvPr id="48" name="Conector 7"/>
-          <p:cNvSpPr/>
-          <p:nvPr/>
-        </p:nvSpPr>
-        <p:spPr>
-          <a:xfrm>
-            <a:off x="10820095" y="2450592"/>
-            <a:ext cx="0" cy="292608"/>
-          </a:xfrm>
-          <a:prstGeom prst="line">
-            <a:avLst/>
-          </a:prstGeom>
-          <a:noFill/>
-          <a:ln w="15875">
-            <a:solidFill>
-              <a:schemeClr val="accent2"/>
-            </a:solidFill>
-            <a:prstDash val="solid"/>
-          </a:ln>
-        </p:spPr>
-      </p:sp>
-      <p:sp>
-        <p:nvSpPr>
-          <p:cNvPr id="49" name="Halo hoy"/>
-          <p:cNvSpPr/>
-          <p:nvPr/>
-        </p:nvSpPr>
-        <p:spPr>
-          <a:xfrm>
-            <a:off x="10600639" y="2523744"/>
-            <a:ext cx="438912" cy="438912"/>
+            <a:off x="6397600" y="3712464"/>
+            <a:ext cx="329184" cy="329184"/>
           </a:xfrm>
           <a:prstGeom prst="ellipse">
             <a:avLst/>
           </a:prstGeom>
           <a:solidFill>
             <a:schemeClr val="accent2">
-              <a:alpha val="25000"/>
+              <a:alpha val="30000"/>
             </a:schemeClr>
           </a:solidFill>
           <a:ln w="12700">
@@ -9700,14 +9338,14 @@
       </p:sp>
       <p:sp>
         <p:nvSpPr>
-          <p:cNvPr id="50" name="Hito 7"/>
+          <p:cNvPr id="34" name="Hito 2026-4"/>
           <p:cNvSpPr/>
           <p:nvPr/>
         </p:nvSpPr>
         <p:spPr>
           <a:xfrm>
-            <a:off x="10701223" y="2624328"/>
-            <a:ext cx="237744" cy="237744"/>
+            <a:off x="6461608" y="3776472"/>
+            <a:ext cx="201168" cy="201168"/>
           </a:xfrm>
           <a:prstGeom prst="ellipse">
             <a:avLst/>
@@ -9715,7 +9353,7 @@
           <a:solidFill>
             <a:schemeClr val="accent2"/>
           </a:solidFill>
-          <a:ln w="38100">
+          <a:ln w="31750">
             <a:solidFill>
               <a:schemeClr val="accent2"/>
             </a:solidFill>
@@ -9725,26 +9363,101 @@
       </p:sp>
       <p:sp>
         <p:nvSpPr>
-          <p:cNvPr id="51" name="Tarjeta hito 7"/>
+          <p:cNvPr id="35" name="Fecha 2026-4"/>
+          <p:cNvSpPr txBox="1"/>
+          <p:nvPr/>
+        </p:nvSpPr>
+        <p:spPr>
+          <a:xfrm>
+            <a:off x="6827368" y="3749040"/>
+            <a:ext cx="2606040" cy="219456"/>
+          </a:xfrm>
+          <a:prstGeom prst="rect">
+            <a:avLst/>
+          </a:prstGeom>
+          <a:noFill/>
+          <a:ln/>
+        </p:spPr>
+        <p:txBody>
+          <a:bodyPr wrap="square" lIns="0" tIns="0" rIns="0" bIns="0" rtlCol="0" anchor="t"/>
+          <a:lstStyle/>
+          <a:p>
+            <a:pPr indent="0" marL="0">
+              <a:buNone/>
+            </a:pPr>
+            <a:r>
+              <a:rPr lang="en-US" sz="1100" b="1" dirty="0">
+                <a:solidFill>
+                  <a:schemeClr val="accent2"/>
+                </a:solidFill>
+                <a:latin typeface="Courier New" pitchFamily="34" charset="0"/>
+                <a:ea typeface="Courier New" pitchFamily="34" charset="-122"/>
+                <a:cs typeface="Courier New" pitchFamily="34" charset="-120"/>
+              </a:rPr>
+              <a:t>HOY</a:t>
+            </a:r>
+            <a:endParaRPr lang="en-US" sz="1100" dirty="0"/>
+          </a:p>
+        </p:txBody>
+      </p:sp>
+      <p:sp>
+        <p:nvSpPr>
+          <p:cNvPr id="36" name="Hito 2026-4 texto"/>
+          <p:cNvSpPr txBox="1"/>
+          <p:nvPr/>
+        </p:nvSpPr>
+        <p:spPr>
+          <a:xfrm>
+            <a:off x="6827368" y="3968496"/>
+            <a:ext cx="2606040" cy="365760"/>
+          </a:xfrm>
+          <a:prstGeom prst="rect">
+            <a:avLst/>
+          </a:prstGeom>
+          <a:noFill/>
+          <a:ln/>
+        </p:spPr>
+        <p:txBody>
+          <a:bodyPr wrap="square" lIns="0" tIns="0" rIns="0" bIns="0" rtlCol="0" anchor="t"/>
+          <a:lstStyle/>
+          <a:p>
+            <a:pPr indent="0" marL="0">
+              <a:buNone/>
+            </a:pPr>
+            <a:r>
+              <a:rPr lang="en-US" sz="1150" b="1" dirty="0">
+                <a:solidFill>
+                  <a:schemeClr val="tx1"/>
+                </a:solidFill>
+              </a:rPr>
+              <a:t>Plazos de respuesta en curso</a:t>
+            </a:r>
+            <a:endParaRPr lang="en-US" sz="1150" dirty="0"/>
+          </a:p>
+        </p:txBody>
+      </p:sp>
+      <p:sp>
+        <p:nvSpPr>
+          <p:cNvPr id="37" name="Detalle 2026"/>
           <p:cNvSpPr/>
           <p:nvPr/>
         </p:nvSpPr>
         <p:spPr>
           <a:xfrm>
-            <a:off x="9128455" y="1426464"/>
-            <a:ext cx="2514600" cy="1024128"/>
+            <a:off x="9524848" y="2103120"/>
+            <a:ext cx="1935328" cy="2103120"/>
           </a:xfrm>
           <a:prstGeom prst="roundRect">
             <a:avLst>
-              <a:gd name="adj" fmla="val 8929"/>
+              <a:gd name="adj" fmla="val 4725"/>
             </a:avLst>
           </a:prstGeom>
           <a:solidFill>
-            <a:schemeClr val="accent2"/>
+            <a:schemeClr val="bg1"/>
           </a:solidFill>
           <a:ln w="12700">
             <a:solidFill>
-              <a:schemeClr val="accent2">
+              <a:schemeClr val="bg1">
                 <a:alpha val="0"/>
               </a:schemeClr>
             </a:solidFill>
@@ -9754,14 +9467,14 @@
       </p:sp>
       <p:sp>
         <p:nvSpPr>
-          <p:cNvPr id="52" name="Fecha hito 7"/>
-          <p:cNvSpPr txBox="1"/>
-          <p:nvPr/>
-        </p:nvSpPr>
-        <p:spPr>
-          <a:xfrm>
-            <a:off x="9293047" y="1536192"/>
-            <a:ext cx="2185416" cy="237744"/>
+          <p:cNvPr id="38" name="Detalle título 2026"/>
+          <p:cNvSpPr txBox="1"/>
+          <p:nvPr/>
+        </p:nvSpPr>
+        <p:spPr>
+          <a:xfrm>
+            <a:off x="9689440" y="2240280"/>
+            <a:ext cx="1606144" cy="274320"/>
           </a:xfrm>
           <a:prstGeom prst="rect">
             <a:avLst/>
@@ -9777,203 +9490,27 @@
               <a:buNone/>
             </a:pPr>
             <a:r>
-              <a:rPr lang="en-US" sz="1200" b="1" dirty="0">
-                <a:solidFill>
-                  <a:schemeClr val="bg1"/>
-                </a:solidFill>
-                <a:latin typeface="Courier New" pitchFamily="34" charset="0"/>
-                <a:ea typeface="Courier New" pitchFamily="34" charset="-122"/>
-                <a:cs typeface="Courier New" pitchFamily="34" charset="-120"/>
-              </a:rPr>
-              <a:t>HOY</a:t>
-            </a:r>
-            <a:endParaRPr lang="en-US" sz="1200" dirty="0"/>
-          </a:p>
-        </p:txBody>
-      </p:sp>
-      <p:sp>
-        <p:nvSpPr>
-          <p:cNvPr id="53" name="Texto hito 7"/>
-          <p:cNvSpPr txBox="1"/>
-          <p:nvPr/>
-        </p:nvSpPr>
-        <p:spPr>
-          <a:xfrm>
-            <a:off x="9293047" y="1792224"/>
-            <a:ext cx="2185416" cy="274320"/>
-          </a:xfrm>
-          <a:prstGeom prst="rect">
-            <a:avLst/>
-          </a:prstGeom>
-          <a:noFill/>
-          <a:ln/>
-        </p:spPr>
-        <p:txBody>
-          <a:bodyPr wrap="square" lIns="0" tIns="0" rIns="0" bIns="0" rtlCol="0" anchor="t"/>
-          <a:lstStyle/>
-          <a:p>
-            <a:pPr indent="0" marL="0">
-              <a:buNone/>
-            </a:pPr>
-            <a:r>
-              <a:rPr lang="en-US" sz="1350" b="1" dirty="0">
-                <a:solidFill>
-                  <a:schemeClr val="bg1"/>
-                </a:solidFill>
-              </a:rPr>
-              <a:t>Plazos de respuesta</a:t>
-            </a:r>
-            <a:endParaRPr lang="en-US" sz="1350" dirty="0"/>
-          </a:p>
-        </p:txBody>
-      </p:sp>
-      <p:sp>
-        <p:nvSpPr>
-          <p:cNvPr id="54" name="Detalle hito 7"/>
-          <p:cNvSpPr txBox="1"/>
-          <p:nvPr/>
-        </p:nvSpPr>
-        <p:spPr>
-          <a:xfrm>
-            <a:off x="9293047" y="2093976"/>
-            <a:ext cx="2185416" cy="256032"/>
-          </a:xfrm>
-          <a:prstGeom prst="rect">
-            <a:avLst/>
-          </a:prstGeom>
-          <a:noFill/>
-          <a:ln/>
-        </p:spPr>
-        <p:txBody>
-          <a:bodyPr wrap="square" lIns="0" tIns="0" rIns="0" bIns="0" rtlCol="0" anchor="t"/>
-          <a:lstStyle/>
-          <a:p>
-            <a:pPr indent="0" marL="0">
-              <a:buNone/>
-            </a:pPr>
-            <a:r>
-              <a:rPr lang="en-US" sz="1100" dirty="0">
-                <a:solidFill>
-                  <a:schemeClr val="bg1"/>
-                </a:solidFill>
-              </a:rPr>
-              <a:t>Descargos 10 d.h. · Plan 15 d.h.</a:t>
-            </a:r>
-            <a:endParaRPr lang="en-US" sz="1100" dirty="0"/>
-          </a:p>
-        </p:txBody>
-      </p:sp>
-      <p:sp>
-        <p:nvSpPr>
-          <p:cNvPr id="55" name="Evolución título"/>
-          <p:cNvSpPr txBox="1"/>
-          <p:nvPr/>
-        </p:nvSpPr>
-        <p:spPr>
-          <a:xfrm>
-            <a:off x="548640" y="4507992"/>
-            <a:ext cx="7315200" cy="256032"/>
-          </a:xfrm>
-          <a:prstGeom prst="rect">
-            <a:avLst/>
-          </a:prstGeom>
-          <a:noFill/>
-          <a:ln/>
-        </p:spPr>
-        <p:txBody>
-          <a:bodyPr wrap="square" lIns="0" tIns="0" rIns="0" bIns="0" rtlCol="0" anchor="t"/>
-          <a:lstStyle/>
-          <a:p>
-            <a:pPr indent="0" marL="0">
-              <a:buNone/>
-            </a:pPr>
-            <a:r>
-              <a:rPr lang="en-US" sz="1100" b="1" spc="200" kern="0" dirty="0">
-                <a:solidFill>
-                  <a:schemeClr val="accent5"/>
-                </a:solidFill>
-              </a:rPr>
-              <a:t>EVOLUCIÓN · LO QUE PERSISTE DE 2025 A 2026</a:t>
-            </a:r>
-            <a:endParaRPr lang="en-US" sz="1100" dirty="0"/>
-          </a:p>
-        </p:txBody>
-      </p:sp>
-      <p:sp>
-        <p:nvSpPr>
-          <p:cNvPr id="56" name="Hallazgos críticos 2025"/>
-          <p:cNvSpPr/>
-          <p:nvPr/>
-        </p:nvSpPr>
-        <p:spPr>
-          <a:xfrm>
-            <a:off x="548640" y="4846320"/>
-            <a:ext cx="2636444" cy="1463040"/>
-          </a:xfrm>
-          <a:prstGeom prst="roundRect">
-            <a:avLst>
-              <a:gd name="adj" fmla="val 6250"/>
-            </a:avLst>
-          </a:prstGeom>
-          <a:solidFill>
-            <a:schemeClr val="accent1"/>
-          </a:solidFill>
-          <a:ln w="12700">
-            <a:solidFill>
-              <a:schemeClr val="accent1">
-                <a:alpha val="0"/>
-              </a:schemeClr>
-            </a:solidFill>
-            <a:prstDash val="solid"/>
-          </a:ln>
-        </p:spPr>
-      </p:sp>
-      <p:sp>
-        <p:nvSpPr>
-          <p:cNvPr id="57" name="Hallazgos título"/>
-          <p:cNvSpPr txBox="1"/>
-          <p:nvPr/>
-        </p:nvSpPr>
-        <p:spPr>
-          <a:xfrm>
-            <a:off x="731520" y="4974336"/>
-            <a:ext cx="2270684" cy="274320"/>
-          </a:xfrm>
-          <a:prstGeom prst="rect">
-            <a:avLst/>
-          </a:prstGeom>
-          <a:noFill/>
-          <a:ln/>
-        </p:spPr>
-        <p:txBody>
-          <a:bodyPr wrap="square" lIns="0" tIns="0" rIns="0" bIns="0" rtlCol="0" anchor="t"/>
-          <a:lstStyle/>
-          <a:p>
-            <a:pPr indent="0" marL="0">
-              <a:buNone/>
-            </a:pPr>
-            <a:r>
-              <a:rPr lang="en-US" sz="1300" b="1" dirty="0">
-                <a:solidFill>
-                  <a:schemeClr val="bg1"/>
-                </a:solidFill>
-              </a:rPr>
-              <a:t>Hallazgos críticos 2025</a:t>
-            </a:r>
-            <a:endParaRPr lang="en-US" sz="1300" dirty="0"/>
-          </a:p>
-        </p:txBody>
-      </p:sp>
-      <p:sp>
-        <p:nvSpPr>
-          <p:cNvPr id="58" name="Hallazgos lista"/>
-          <p:cNvSpPr txBox="1"/>
-          <p:nvPr/>
-        </p:nvSpPr>
-        <p:spPr>
-          <a:xfrm>
-            <a:off x="731520" y="5303520"/>
-            <a:ext cx="2316404" cy="914400"/>
+              <a:rPr lang="en-US" sz="1250" b="1" dirty="0">
+                <a:solidFill>
+                  <a:schemeClr val="accent2"/>
+                </a:solidFill>
+              </a:rPr>
+              <a:t>Resultado y plazos 2026</a:t>
+            </a:r>
+            <a:endParaRPr lang="en-US" sz="1250" dirty="0"/>
+          </a:p>
+        </p:txBody>
+      </p:sp>
+      <p:sp>
+        <p:nvSpPr>
+          <p:cNvPr id="39" name="Detalle lista 2026"/>
+          <p:cNvSpPr txBox="1"/>
+          <p:nvPr/>
+        </p:nvSpPr>
+        <p:spPr>
+          <a:xfrm>
+            <a:off x="9689440" y="2587752"/>
+            <a:ext cx="1661008" cy="1554480"/>
           </a:xfrm>
           <a:prstGeom prst="rect">
             <a:avLst/>
@@ -9987,54 +9524,100 @@
           <a:p>
             <a:pPr marL="342900" indent="-342900">
               <a:spcAft>
-                <a:spcPts val="200"/>
+                <a:spcPts val="400"/>
               </a:spcAft>
               <a:buSzPct val="100000"/>
               <a:buChar char="•"/>
             </a:pPr>
             <a:r>
+              <a:rPr lang="en-US" sz="1100" b="1" dirty="0">
+                <a:solidFill>
+                  <a:schemeClr val="tx1"/>
+                </a:solidFill>
+              </a:rPr>
+              <a:t>Anexo A: </a:t>
+            </a:r>
+            <a:pPr indent="0" marL="0">
+              <a:spcAft>
+                <a:spcPts val="400"/>
+              </a:spcAft>
+              <a:buNone/>
+            </a:pPr>
+            <a:r>
               <a:rPr lang="en-US" sz="1100" dirty="0">
                 <a:solidFill>
-                  <a:schemeClr val="bg1"/>
-                </a:solidFill>
-              </a:rPr>
-              <a:t>Sin Política de Operaciones Vinculadas</a:t>
+                  <a:schemeClr val="tx1"/>
+                </a:solidFill>
+              </a:rPr>
+              <a:t>7 observaciones nuevas · descargos en 10 días hábiles (aprox. 23/10/2026)</a:t>
             </a:r>
             <a:endParaRPr lang="en-US" sz="1100" dirty="0"/>
           </a:p>
           <a:p>
             <a:pPr marL="342900" indent="-342900">
               <a:spcAft>
-                <a:spcPts val="200"/>
+                <a:spcPts val="400"/>
               </a:spcAft>
               <a:buSzPct val="100000"/>
               <a:buChar char="•"/>
             </a:pPr>
             <a:r>
+              <a:rPr lang="en-US" sz="1100" b="1" dirty="0">
+                <a:solidFill>
+                  <a:schemeClr val="tx1"/>
+                </a:solidFill>
+              </a:rPr>
+              <a:t>Anexo B: </a:t>
+            </a:r>
+            <a:pPr indent="0" marL="0">
+              <a:spcAft>
+                <a:spcPts val="400"/>
+              </a:spcAft>
+              <a:buNone/>
+            </a:pPr>
+            <a:r>
               <a:rPr lang="en-US" sz="1100" dirty="0">
                 <a:solidFill>
-                  <a:schemeClr val="bg1"/>
-                </a:solidFill>
-              </a:rPr>
-              <a:t>Normativa interna desactualizada</a:t>
+                  <a:schemeClr val="tx1"/>
+                </a:solidFill>
+              </a:rPr>
+              <a:t>seguimiento a obs. 3 y 5 de 2025 · plan de solución en 15 días hábiles (aprox. 30/10/2026)</a:t>
             </a:r>
             <a:endParaRPr lang="en-US" sz="1100" dirty="0"/>
           </a:p>
-          <a:p>
-            <a:pPr marL="342900" indent="-342900">
-              <a:spcAft>
-                <a:spcPts val="200"/>
-              </a:spcAft>
-              <a:buSzPct val="100000"/>
-              <a:buChar char="•"/>
-            </a:pPr>
-            <a:r>
-              <a:rPr lang="en-US" sz="1100" dirty="0">
-                <a:solidFill>
-                  <a:schemeClr val="bg1"/>
-                </a:solidFill>
-              </a:rPr>
-              <a:t>Uso inapropiado del Fondo de Educación</a:t>
+        </p:txBody>
+      </p:sp>
+      <p:sp>
+        <p:nvSpPr>
+          <p:cNvPr id="40" name="Evolución título"/>
+          <p:cNvSpPr txBox="1"/>
+          <p:nvPr/>
+        </p:nvSpPr>
+        <p:spPr>
+          <a:xfrm>
+            <a:off x="548640" y="4572000"/>
+            <a:ext cx="7315200" cy="237744"/>
+          </a:xfrm>
+          <a:prstGeom prst="rect">
+            <a:avLst/>
+          </a:prstGeom>
+          <a:noFill/>
+          <a:ln/>
+        </p:spPr>
+        <p:txBody>
+          <a:bodyPr wrap="square" lIns="0" tIns="0" rIns="0" bIns="0" rtlCol="0" anchor="t"/>
+          <a:lstStyle/>
+          <a:p>
+            <a:pPr indent="0" marL="0">
+              <a:buNone/>
+            </a:pPr>
+            <a:r>
+              <a:rPr lang="en-US" sz="1100" b="1" spc="200" kern="0" dirty="0">
+                <a:solidFill>
+                  <a:schemeClr val="accent5"/>
+                </a:solidFill>
+              </a:rPr>
+              <a:t>EVOLUCIÓN · SEGUIMIENTO A OBSERVACIONES 2025</a:t>
             </a:r>
             <a:endParaRPr lang="en-US" sz="1100" dirty="0"/>
           </a:p>
@@ -10042,18 +9625,18 @@
       </p:sp>
       <p:sp>
         <p:nvSpPr>
-          <p:cNvPr id="59" name="Evolución 1"/>
+          <p:cNvPr id="41" name="Evolución 1"/>
           <p:cNvSpPr/>
           <p:nvPr/>
         </p:nvSpPr>
         <p:spPr>
           <a:xfrm>
-            <a:off x="3367964" y="4846320"/>
-            <a:ext cx="2636444" cy="1463040"/>
+            <a:off x="548640" y="4892040"/>
+            <a:ext cx="3576218" cy="1371600"/>
           </a:xfrm>
           <a:prstGeom prst="roundRect">
             <a:avLst>
-              <a:gd name="adj" fmla="val 6250"/>
+              <a:gd name="adj" fmla="val 6667"/>
             </a:avLst>
           </a:prstGeom>
           <a:solidFill>
@@ -10073,13 +9656,13 @@
       </p:sp>
       <p:sp>
         <p:nvSpPr>
-          <p:cNvPr id="60" name="Evolución estado 1 fondo"/>
+          <p:cNvPr id="42" name="Evolución estado 1 fondo"/>
           <p:cNvSpPr/>
           <p:nvPr/>
         </p:nvSpPr>
         <p:spPr>
           <a:xfrm>
-            <a:off x="3550844" y="5010912"/>
+            <a:off x="731520" y="5047488"/>
             <a:ext cx="1188720" cy="274320"/>
           </a:xfrm>
           <a:prstGeom prst="roundRect">
@@ -10102,13 +9685,13 @@
       </p:sp>
       <p:sp>
         <p:nvSpPr>
-          <p:cNvPr id="61" name="Evolución estado 1"/>
-          <p:cNvSpPr txBox="1"/>
-          <p:nvPr/>
-        </p:nvSpPr>
-        <p:spPr>
-          <a:xfrm>
-            <a:off x="3550844" y="5010912"/>
+          <p:cNvPr id="43" name="Evolución estado 1"/>
+          <p:cNvSpPr txBox="1"/>
+          <p:nvPr/>
+        </p:nvSpPr>
+        <p:spPr>
+          <a:xfrm>
+            <a:off x="731520" y="5047488"/>
             <a:ext cx="1188720" cy="274320"/>
           </a:xfrm>
           <a:prstGeom prst="rect">
@@ -10138,14 +9721,14 @@
       </p:sp>
       <p:sp>
         <p:nvSpPr>
-          <p:cNvPr id="62" name="Evolución tema 1"/>
-          <p:cNvSpPr txBox="1"/>
-          <p:nvPr/>
-        </p:nvSpPr>
-        <p:spPr>
-          <a:xfrm>
-            <a:off x="3550844" y="5394960"/>
-            <a:ext cx="2270684" cy="411480"/>
+          <p:cNvPr id="44" name="Evolución tema 1"/>
+          <p:cNvSpPr txBox="1"/>
+          <p:nvPr/>
+        </p:nvSpPr>
+        <p:spPr>
+          <a:xfrm>
+            <a:off x="731520" y="5440680"/>
+            <a:ext cx="3210458" cy="274320"/>
           </a:xfrm>
           <a:prstGeom prst="rect">
             <a:avLst/>
@@ -10174,14 +9757,14 @@
       </p:sp>
       <p:sp>
         <p:nvSpPr>
-          <p:cNvPr id="63" name="Evolución detalle 1"/>
-          <p:cNvSpPr txBox="1"/>
-          <p:nvPr/>
-        </p:nvSpPr>
-        <p:spPr>
-          <a:xfrm>
-            <a:off x="3550844" y="5806440"/>
-            <a:ext cx="2270684" cy="438912"/>
+          <p:cNvPr id="45" name="Evolución detalle 1"/>
+          <p:cNvSpPr txBox="1"/>
+          <p:nvPr/>
+        </p:nvSpPr>
+        <p:spPr>
+          <a:xfrm>
+            <a:off x="731520" y="5742432"/>
+            <a:ext cx="3210458" cy="438912"/>
           </a:xfrm>
           <a:prstGeom prst="rect">
             <a:avLst/>
@@ -10202,7 +9785,7 @@
                   <a:schemeClr val="accent5"/>
                 </a:solidFill>
               </a:rPr>
-              <a:t>2025 obs. 3 → 2026 Anexo B, obs. 8</a:t>
+              <a:t>Obs. 3 de 2025 · seguimiento en Anexo B 2026</a:t>
             </a:r>
             <a:endParaRPr lang="en-US" sz="1050" dirty="0"/>
           </a:p>
@@ -10210,18 +9793,18 @@
       </p:sp>
       <p:sp>
         <p:nvSpPr>
-          <p:cNvPr id="64" name="Evolución 2"/>
+          <p:cNvPr id="46" name="Evolución 2"/>
           <p:cNvSpPr/>
           <p:nvPr/>
         </p:nvSpPr>
         <p:spPr>
           <a:xfrm>
-            <a:off x="6187288" y="4846320"/>
-            <a:ext cx="2636444" cy="1463040"/>
+            <a:off x="4307738" y="4892040"/>
+            <a:ext cx="3576218" cy="1371600"/>
           </a:xfrm>
           <a:prstGeom prst="roundRect">
             <a:avLst>
-              <a:gd name="adj" fmla="val 6250"/>
+              <a:gd name="adj" fmla="val 6667"/>
             </a:avLst>
           </a:prstGeom>
           <a:solidFill>
@@ -10241,13 +9824,13 @@
       </p:sp>
       <p:sp>
         <p:nvSpPr>
-          <p:cNvPr id="65" name="Evolución estado 2 fondo"/>
+          <p:cNvPr id="47" name="Evolución estado 2 fondo"/>
           <p:cNvSpPr/>
           <p:nvPr/>
         </p:nvSpPr>
         <p:spPr>
           <a:xfrm>
-            <a:off x="6370168" y="5010912"/>
+            <a:off x="4490618" y="5047488"/>
             <a:ext cx="2103120" cy="274320"/>
           </a:xfrm>
           <a:prstGeom prst="roundRect">
@@ -10270,13 +9853,13 @@
       </p:sp>
       <p:sp>
         <p:nvSpPr>
-          <p:cNvPr id="66" name="Evolución estado 2"/>
-          <p:cNvSpPr txBox="1"/>
-          <p:nvPr/>
-        </p:nvSpPr>
-        <p:spPr>
-          <a:xfrm>
-            <a:off x="6370168" y="5010912"/>
+          <p:cNvPr id="48" name="Evolución estado 2"/>
+          <p:cNvSpPr txBox="1"/>
+          <p:nvPr/>
+        </p:nvSpPr>
+        <p:spPr>
+          <a:xfrm>
+            <a:off x="4490618" y="5047488"/>
             <a:ext cx="2103120" cy="274320"/>
           </a:xfrm>
           <a:prstGeom prst="rect">
@@ -10306,14 +9889,14 @@
       </p:sp>
       <p:sp>
         <p:nvSpPr>
-          <p:cNvPr id="67" name="Evolución tema 2"/>
-          <p:cNvSpPr txBox="1"/>
-          <p:nvPr/>
-        </p:nvSpPr>
-        <p:spPr>
-          <a:xfrm>
-            <a:off x="6370168" y="5394960"/>
-            <a:ext cx="2270684" cy="411480"/>
+          <p:cNvPr id="49" name="Evolución tema 2"/>
+          <p:cNvSpPr txBox="1"/>
+          <p:nvPr/>
+        </p:nvSpPr>
+        <p:spPr>
+          <a:xfrm>
+            <a:off x="4490618" y="5440680"/>
+            <a:ext cx="3210458" cy="274320"/>
           </a:xfrm>
           <a:prstGeom prst="rect">
             <a:avLst/>
@@ -10342,14 +9925,14 @@
       </p:sp>
       <p:sp>
         <p:nvSpPr>
-          <p:cNvPr id="68" name="Evolución detalle 2"/>
-          <p:cNvSpPr txBox="1"/>
-          <p:nvPr/>
-        </p:nvSpPr>
-        <p:spPr>
-          <a:xfrm>
-            <a:off x="6370168" y="5806440"/>
-            <a:ext cx="2270684" cy="438912"/>
+          <p:cNvPr id="50" name="Evolución detalle 2"/>
+          <p:cNvSpPr txBox="1"/>
+          <p:nvPr/>
+        </p:nvSpPr>
+        <p:spPr>
+          <a:xfrm>
+            <a:off x="4490618" y="5742432"/>
+            <a:ext cx="3210458" cy="438912"/>
           </a:xfrm>
           <a:prstGeom prst="rect">
             <a:avLst/>
@@ -10370,7 +9953,7 @@
                   <a:schemeClr val="accent5"/>
                 </a:solidFill>
               </a:rPr>
-              <a:t>2025 obs. 5 → 2026 Anexo B, obs. 9 (RIT, Auditoría, Compras)</a:t>
+              <a:t>Obs. 5 de 2025 · seguimiento en Anexo B 2026 (RIT, Auditoría, Compras)</a:t>
             </a:r>
             <a:endParaRPr lang="en-US" sz="1050" dirty="0"/>
           </a:p>
@@ -10378,28 +9961,28 @@
       </p:sp>
       <p:sp>
         <p:nvSpPr>
-          <p:cNvPr id="69" name="Evolución 3"/>
+          <p:cNvPr id="51" name="Evolución 3"/>
           <p:cNvSpPr/>
           <p:nvPr/>
         </p:nvSpPr>
         <p:spPr>
           <a:xfrm>
-            <a:off x="9006611" y="4846320"/>
-            <a:ext cx="2636444" cy="1463040"/>
+            <a:off x="8066837" y="4892040"/>
+            <a:ext cx="3576218" cy="1371600"/>
           </a:xfrm>
           <a:prstGeom prst="roundRect">
             <a:avLst>
-              <a:gd name="adj" fmla="val 6250"/>
+              <a:gd name="adj" fmla="val 6667"/>
             </a:avLst>
           </a:prstGeom>
           <a:solidFill>
-            <a:schemeClr val="accent4">
+            <a:schemeClr val="accent2">
               <a:alpha val="12000"/>
             </a:schemeClr>
           </a:solidFill>
           <a:ln w="12700">
             <a:solidFill>
-              <a:schemeClr val="accent4">
+              <a:schemeClr val="accent2">
                 <a:alpha val="0"/>
               </a:schemeClr>
             </a:solidFill>
@@ -10409,14 +9992,14 @@
       </p:sp>
       <p:sp>
         <p:nvSpPr>
-          <p:cNvPr id="70" name="Evolución estado 3 fondo"/>
+          <p:cNvPr id="52" name="Evolución estado 3 fondo"/>
           <p:cNvSpPr/>
           <p:nvPr/>
         </p:nvSpPr>
         <p:spPr>
           <a:xfrm>
-            <a:off x="9189491" y="5010912"/>
-            <a:ext cx="1188720" cy="274320"/>
+            <a:off x="8249717" y="5047488"/>
+            <a:ext cx="2103120" cy="274320"/>
           </a:xfrm>
           <a:prstGeom prst="roundRect">
             <a:avLst>
@@ -10424,11 +10007,11 @@
             </a:avLst>
           </a:prstGeom>
           <a:solidFill>
-            <a:schemeClr val="accent4"/>
+            <a:schemeClr val="accent2"/>
           </a:solidFill>
           <a:ln w="12700">
             <a:solidFill>
-              <a:schemeClr val="accent4">
+              <a:schemeClr val="accent2">
                 <a:alpha val="0"/>
               </a:schemeClr>
             </a:solidFill>
@@ -10438,14 +10021,14 @@
       </p:sp>
       <p:sp>
         <p:nvSpPr>
-          <p:cNvPr id="71" name="Evolución estado 3"/>
-          <p:cNvSpPr txBox="1"/>
-          <p:nvPr/>
-        </p:nvSpPr>
-        <p:spPr>
-          <a:xfrm>
-            <a:off x="9189491" y="5010912"/>
-            <a:ext cx="1188720" cy="274320"/>
+          <p:cNvPr id="53" name="Evolución estado 3"/>
+          <p:cNvSpPr txBox="1"/>
+          <p:nvPr/>
+        </p:nvSpPr>
+        <p:spPr>
+          <a:xfrm>
+            <a:off x="8249717" y="5047488"/>
+            <a:ext cx="2103120" cy="274320"/>
           </a:xfrm>
           <a:prstGeom prst="rect">
             <a:avLst/>
@@ -10466,7 +10049,7 @@
                   <a:schemeClr val="bg1"/>
                 </a:solidFill>
               </a:rPr>
-              <a:t>REINCIDE</a:t>
+              <a:t>MISMO TEMA · NUEVAS</a:t>
             </a:r>
             <a:endParaRPr lang="en-US" sz="1050" dirty="0"/>
           </a:p>
@@ -10474,14 +10057,14 @@
       </p:sp>
       <p:sp>
         <p:nvSpPr>
-          <p:cNvPr id="72" name="Evolución tema 3"/>
-          <p:cNvSpPr txBox="1"/>
-          <p:nvPr/>
-        </p:nvSpPr>
-        <p:spPr>
-          <a:xfrm>
-            <a:off x="9189491" y="5394960"/>
-            <a:ext cx="2270684" cy="411480"/>
+          <p:cNvPr id="54" name="Evolución tema 3"/>
+          <p:cNvSpPr txBox="1"/>
+          <p:nvPr/>
+        </p:nvSpPr>
+        <p:spPr>
+          <a:xfrm>
+            <a:off x="8249717" y="5440680"/>
+            <a:ext cx="3210458" cy="274320"/>
           </a:xfrm>
           <a:prstGeom prst="rect">
             <a:avLst/>
@@ -10502,7 +10085,7 @@
                   <a:schemeClr val="tx1"/>
                 </a:solidFill>
               </a:rPr>
-              <a:t>Gobernanza del Fondo de Educación</a:t>
+              <a:t>Fondo de Educación</a:t>
             </a:r>
             <a:endParaRPr lang="en-US" sz="1300" dirty="0"/>
           </a:p>
@@ -10510,14 +10093,14 @@
       </p:sp>
       <p:sp>
         <p:nvSpPr>
-          <p:cNvPr id="73" name="Evolución detalle 3"/>
-          <p:cNvSpPr txBox="1"/>
-          <p:nvPr/>
-        </p:nvSpPr>
-        <p:spPr>
-          <a:xfrm>
-            <a:off x="9189491" y="5806440"/>
-            <a:ext cx="2270684" cy="438912"/>
+          <p:cNvPr id="55" name="Evolución detalle 3"/>
+          <p:cNvSpPr txBox="1"/>
+          <p:nvPr/>
+        </p:nvSpPr>
+        <p:spPr>
+          <a:xfrm>
+            <a:off x="8249717" y="5742432"/>
+            <a:ext cx="3210458" cy="438912"/>
           </a:xfrm>
           <a:prstGeom prst="rect">
             <a:avLst/>
@@ -10538,7 +10121,7 @@
                   <a:schemeClr val="accent5"/>
                 </a:solidFill>
               </a:rPr>
-              <a:t>2025 obs. 9 → 2026 Anexo A, obs. 6 y 7 ($100,774.28 sin detalle)</a:t>
+              <a:t>No es seguimiento: obs. 6 y 7 de 2026 son nuevas (Anexo A), mismo tema de la obs. 9 de 2025</a:t>
             </a:r>
             <a:endParaRPr lang="en-US" sz="1050" dirty="0"/>
           </a:p>

</xml_diff>

<commit_message>
Timeline slide: vertical, newest-first with today at the top
Co-Authored-By: Claude Opus 5.5 <noreply@anthropic.com>
Claude-Session: https://claude.ai/code/session_01F1WXR13Nv8neEtLhaK3ELa
</commit_message>
<xml_diff>
--- a/supervision-gobierno-corporativo/Supervision_GC_SSF_COMEDICA_2025-2026.pptx
+++ b/supervision-gobierno-corporativo/Supervision_GC_SSF_COMEDICA_2025-2026.pptx
@@ -110,22 +110,22 @@
   <p:extLst>
     <p:ext uri="{521415D9-36F7-43E2-AB2F-B90AF26B5E84}">
       <p14:sectionLst xmlns:p14="http://schemas.microsoft.com/office/powerpoint/2010/main">
-        <p14:section name="1 · Resumen de notas SSF" id="{0af96d93-5c4c-7280-46fd-ff1a3e29c353}">
+        <p14:section name="1 · Resumen de notas SSF" id="{33e2959b-55c3-7a5d-d500-a90e1161012b}">
           <p14:sldIdLst>
             <p14:sldId id="256"/>
           </p14:sldIdLst>
         </p14:section>
-        <p14:section name="2 · Observaciones 2025" id="{91fb50bf-dd51-b62a-6699-ab5b62a1e3bd}">
+        <p14:section name="2 · Observaciones 2025" id="{0162c1be-d6ef-56b3-1f48-41d080df8b7a}">
           <p14:sldIdLst>
             <p14:sldId id="257"/>
           </p14:sldIdLst>
         </p14:section>
-        <p14:section name="3 · Observaciones 2026" id="{35a45ce6-d975-1685-af17-f9ab2f8b42fe}">
+        <p14:section name="3 · Observaciones 2026" id="{341ec66c-ada8-9e87-b474-b87abfc899fa}">
           <p14:sldIdLst>
             <p14:sldId id="258"/>
           </p14:sldIdLst>
         </p14:section>
-        <p14:section name="4 · Línea de tiempo y evolución" id="{dcff3e0a-b1ea-1978-c5f7-a6ced01321f6}">
+        <p14:section name="4 · Línea de tiempo y evolución" id="{6bfa256d-dff9-87c0-5fcc-c0f901ea8dc0}">
           <p14:sldIdLst>
             <p14:sldId id="259"/>
           </p14:sldIdLst>
@@ -798,7 +798,7 @@
           <a:p>
             <a:r>
               <a:rPr lang="en-US" dirty="0"/>
-              <a:t>Bloque 2025: nombramiento (09/04/2025), inicio de visita (19/05/2025) e informe preliminar con 9 observaciones (05/11/2025); hallazgos críticos: Política de Operaciones Vinculadas, normativa desactualizada y Fondo de Educación. Bloque 2026: nombramiento (31/07/2026), inicio (21/08/2026) e informe preliminar (09/10/2026) con 7 observaciones nuevas (Anexo A) y seguimiento a 2 observaciones de 2025 (Anexo B). Plazos: 10 días hábiles para descargos y 15 días hábiles para plan de solución. Seguimiento: obs. 3 de 2025 no superada; obs. 5 de 2025 parcialmente superada. El Fondo de Educación vuelve a aparecer como tema, pero con observaciones nuevas, no como seguimiento.</a:t>
+              <a:t>La línea de tiempo se lee de arriba hacia abajo, de lo más reciente a lo más antiguo. Hoy corren los plazos: 10 días hábiles para descargos del Anexo A (aprox. 23/10/2026) y 15 días hábiles para el plan de solución del Anexo B (aprox. 30/10/2026). 2026: nombramiento 31/07, inicio 21/08 e informe preliminar 09/10 con 7 observaciones nuevas y seguimiento a las obs. 3 y 5 de 2025. 2025: nombramiento 09/04, inicio 19/05 e informe preliminar 05/11 con 9 observaciones. Seguimiento: obs. 3 no superada; obs. 5 parcialmente superada. El Fondo de Educación vuelve como tema, pero con observaciones nuevas.</a:t>
             </a:r>
             <a:endParaRPr lang="en-US" dirty="0"/>
           </a:p>
@@ -8250,7 +8250,7 @@
                 <a:ea typeface="Cambria" pitchFamily="34" charset="-122"/>
                 <a:cs typeface="Cambria" pitchFamily="34" charset="-120"/>
               </a:rPr>
-              <a:t>Línea de tiempo 2025 vs. 2026</a:t>
+              <a:t>Línea de tiempo: de hoy a 2025</a:t>
             </a:r>
             <a:endParaRPr lang="en-US" sz="3000" dirty="0"/>
           </a:p>
@@ -8258,26 +8258,95 @@
       </p:sp>
       <p:sp>
         <p:nvSpPr>
-          <p:cNvPr id="4" name="Bloque 2025"/>
+          <p:cNvPr id="4" name="Eje 2026"/>
           <p:cNvSpPr/>
           <p:nvPr/>
         </p:nvSpPr>
         <p:spPr>
           <a:xfrm>
-            <a:off x="548640" y="1325880"/>
-            <a:ext cx="5410048" cy="3063240"/>
+            <a:off x="1645920" y="1463040"/>
+            <a:ext cx="0" cy="2029968"/>
+          </a:xfrm>
+          <a:prstGeom prst="line">
+            <a:avLst/>
+          </a:prstGeom>
+          <a:noFill/>
+          <a:ln w="38100">
+            <a:solidFill>
+              <a:schemeClr val="accent2"/>
+            </a:solidFill>
+            <a:prstDash val="solid"/>
+          </a:ln>
+        </p:spPr>
+      </p:sp>
+      <p:sp>
+        <p:nvSpPr>
+          <p:cNvPr id="5" name="Pausa entre visitas"/>
+          <p:cNvSpPr/>
+          <p:nvPr/>
+        </p:nvSpPr>
+        <p:spPr>
+          <a:xfrm>
+            <a:off x="1645920" y="3675888"/>
+            <a:ext cx="0" cy="512064"/>
+          </a:xfrm>
+          <a:prstGeom prst="line">
+            <a:avLst/>
+          </a:prstGeom>
+          <a:noFill/>
+          <a:ln w="19050">
+            <a:solidFill>
+              <a:schemeClr val="accent5"/>
+            </a:solidFill>
+            <a:prstDash val="dash"/>
+          </a:ln>
+        </p:spPr>
+      </p:sp>
+      <p:sp>
+        <p:nvSpPr>
+          <p:cNvPr id="6" name="Eje 2025"/>
+          <p:cNvSpPr/>
+          <p:nvPr/>
+        </p:nvSpPr>
+        <p:spPr>
+          <a:xfrm>
+            <a:off x="1645920" y="4370832"/>
+            <a:ext cx="0" cy="1353312"/>
+          </a:xfrm>
+          <a:prstGeom prst="line">
+            <a:avLst/>
+          </a:prstGeom>
+          <a:noFill/>
+          <a:ln w="38100">
+            <a:solidFill>
+              <a:schemeClr val="accent1"/>
+            </a:solidFill>
+            <a:prstDash val="solid"/>
+          </a:ln>
+        </p:spPr>
+      </p:sp>
+      <p:sp>
+        <p:nvSpPr>
+          <p:cNvPr id="7" name="Año 2026 fondo"/>
+          <p:cNvSpPr/>
+          <p:nvPr/>
+        </p:nvSpPr>
+        <p:spPr>
+          <a:xfrm>
+            <a:off x="548640" y="1426464"/>
+            <a:ext cx="777240" cy="274320"/>
           </a:xfrm>
           <a:prstGeom prst="roundRect">
             <a:avLst>
-              <a:gd name="adj" fmla="val 2985"/>
+              <a:gd name="adj" fmla="val 50000"/>
             </a:avLst>
           </a:prstGeom>
           <a:solidFill>
-            <a:schemeClr val="bg2"/>
+            <a:schemeClr val="accent2"/>
           </a:solidFill>
           <a:ln w="12700">
             <a:solidFill>
-              <a:schemeClr val="bg2">
+              <a:schemeClr val="accent2">
                 <a:alpha val="0"/>
               </a:schemeClr>
             </a:solidFill>
@@ -8287,14 +8356,14 @@
       </p:sp>
       <p:sp>
         <p:nvSpPr>
-          <p:cNvPr id="5" name="Año bloque 2025"/>
-          <p:cNvSpPr txBox="1"/>
-          <p:nvPr/>
-        </p:nvSpPr>
-        <p:spPr>
-          <a:xfrm>
-            <a:off x="777240" y="1463040"/>
-            <a:ext cx="1097280" cy="457200"/>
+          <p:cNvPr id="8" name="Año 2026"/>
+          <p:cNvSpPr txBox="1"/>
+          <p:nvPr/>
+        </p:nvSpPr>
+        <p:spPr>
+          <a:xfrm>
+            <a:off x="548640" y="1426464"/>
+            <a:ext cx="777240" cy="274320"/>
           </a:xfrm>
           <a:prstGeom prst="rect">
             <a:avLst/>
@@ -8306,405 +8375,43 @@
           <a:bodyPr wrap="square" lIns="0" tIns="0" rIns="0" bIns="0" rtlCol="0" anchor="ctr"/>
           <a:lstStyle/>
           <a:p>
-            <a:pPr indent="0" marL="0">
-              <a:buNone/>
-            </a:pPr>
-            <a:r>
-              <a:rPr lang="en-US" sz="2600" b="1" dirty="0">
-                <a:solidFill>
-                  <a:schemeClr val="accent1"/>
-                </a:solidFill>
-                <a:latin typeface="Cambria" pitchFamily="34" charset="0"/>
-                <a:ea typeface="Cambria" pitchFamily="34" charset="-122"/>
-                <a:cs typeface="Cambria" pitchFamily="34" charset="-120"/>
-              </a:rPr>
-              <a:t>2025</a:t>
-            </a:r>
-            <a:endParaRPr lang="en-US" sz="2600" dirty="0"/>
-          </a:p>
-        </p:txBody>
-      </p:sp>
-      <p:sp>
-        <p:nvSpPr>
-          <p:cNvPr id="6" name="Subtítulo bloque 2025"/>
-          <p:cNvSpPr txBox="1"/>
-          <p:nvPr/>
-        </p:nvSpPr>
-        <p:spPr>
-          <a:xfrm>
-            <a:off x="1828800" y="1463040"/>
-            <a:ext cx="3947008" cy="457200"/>
-          </a:xfrm>
-          <a:prstGeom prst="rect">
-            <a:avLst/>
-          </a:prstGeom>
-          <a:noFill/>
-          <a:ln/>
-        </p:spPr>
-        <p:txBody>
-          <a:bodyPr wrap="square" lIns="0" tIns="0" rIns="0" bIns="0" rtlCol="0" anchor="ctr"/>
-          <a:lstStyle/>
-          <a:p>
-            <a:pPr indent="0" marL="0">
-              <a:buNone/>
-            </a:pPr>
-            <a:r>
-              <a:rPr lang="en-US" sz="1200" b="1" dirty="0">
-                <a:solidFill>
-                  <a:schemeClr val="accent5"/>
-                </a:solidFill>
-              </a:rPr>
-              <a:t>Visita 1 · Nota 17003 · 9 observaciones</a:t>
-            </a:r>
-            <a:endParaRPr lang="en-US" sz="1200" dirty="0"/>
-          </a:p>
-        </p:txBody>
-      </p:sp>
-      <p:sp>
-        <p:nvSpPr>
-          <p:cNvPr id="7" name="Eje 2025"/>
+            <a:pPr algn="ctr" indent="0" marL="0">
+              <a:buNone/>
+            </a:pPr>
+            <a:r>
+              <a:rPr lang="en-US" sz="1100" b="1" spc="100" kern="0" dirty="0">
+                <a:solidFill>
+                  <a:schemeClr val="bg1"/>
+                </a:solidFill>
+              </a:rPr>
+              <a:t>2026</a:t>
+            </a:r>
+            <a:endParaRPr lang="en-US" sz="1100" dirty="0"/>
+          </a:p>
+        </p:txBody>
+      </p:sp>
+      <p:sp>
+        <p:nvSpPr>
+          <p:cNvPr id="9" name="Año 2025 fondo"/>
           <p:cNvSpPr/>
           <p:nvPr/>
         </p:nvSpPr>
         <p:spPr>
           <a:xfrm>
-            <a:off x="877824" y="2231136"/>
-            <a:ext cx="0" cy="1463040"/>
-          </a:xfrm>
-          <a:prstGeom prst="line">
-            <a:avLst/>
-          </a:prstGeom>
-          <a:noFill/>
-          <a:ln w="31750">
-            <a:solidFill>
-              <a:schemeClr val="accent1"/>
-            </a:solidFill>
-            <a:prstDash val="solid"/>
-          </a:ln>
-        </p:spPr>
-      </p:sp>
-      <p:sp>
-        <p:nvSpPr>
-          <p:cNvPr id="8" name="Hito 2025-1"/>
-          <p:cNvSpPr/>
-          <p:nvPr/>
-        </p:nvSpPr>
-        <p:spPr>
-          <a:xfrm>
-            <a:off x="777240" y="2130552"/>
-            <a:ext cx="201168" cy="201168"/>
-          </a:xfrm>
-          <a:prstGeom prst="ellipse">
-            <a:avLst/>
-          </a:prstGeom>
-          <a:solidFill>
-            <a:schemeClr val="bg1"/>
-          </a:solidFill>
-          <a:ln w="31750">
-            <a:solidFill>
-              <a:schemeClr val="accent1"/>
-            </a:solidFill>
-            <a:prstDash val="solid"/>
-          </a:ln>
-        </p:spPr>
-      </p:sp>
-      <p:sp>
-        <p:nvSpPr>
-          <p:cNvPr id="9" name="Fecha 2025-1"/>
-          <p:cNvSpPr txBox="1"/>
-          <p:nvPr/>
-        </p:nvSpPr>
-        <p:spPr>
-          <a:xfrm>
-            <a:off x="1143000" y="2103120"/>
-            <a:ext cx="2606040" cy="219456"/>
-          </a:xfrm>
-          <a:prstGeom prst="rect">
-            <a:avLst/>
-          </a:prstGeom>
-          <a:noFill/>
-          <a:ln/>
-        </p:spPr>
-        <p:txBody>
-          <a:bodyPr wrap="square" lIns="0" tIns="0" rIns="0" bIns="0" rtlCol="0" anchor="t"/>
-          <a:lstStyle/>
-          <a:p>
-            <a:pPr indent="0" marL="0">
-              <a:buNone/>
-            </a:pPr>
-            <a:r>
-              <a:rPr lang="en-US" sz="1100" b="1" dirty="0">
-                <a:solidFill>
-                  <a:schemeClr val="accent1"/>
-                </a:solidFill>
-                <a:latin typeface="Courier New" pitchFamily="34" charset="0"/>
-                <a:ea typeface="Courier New" pitchFamily="34" charset="-122"/>
-                <a:cs typeface="Courier New" pitchFamily="34" charset="-120"/>
-              </a:rPr>
-              <a:t>09 ABR 2025</a:t>
-            </a:r>
-            <a:endParaRPr lang="en-US" sz="1100" dirty="0"/>
-          </a:p>
-        </p:txBody>
-      </p:sp>
-      <p:sp>
-        <p:nvSpPr>
-          <p:cNvPr id="10" name="Hito 2025-1 texto"/>
-          <p:cNvSpPr txBox="1"/>
-          <p:nvPr/>
-        </p:nvSpPr>
-        <p:spPr>
-          <a:xfrm>
-            <a:off x="1143000" y="2322576"/>
-            <a:ext cx="2606040" cy="365760"/>
-          </a:xfrm>
-          <a:prstGeom prst="rect">
-            <a:avLst/>
-          </a:prstGeom>
-          <a:noFill/>
-          <a:ln/>
-        </p:spPr>
-        <p:txBody>
-          <a:bodyPr wrap="square" lIns="0" tIns="0" rIns="0" bIns="0" rtlCol="0" anchor="t"/>
-          <a:lstStyle/>
-          <a:p>
-            <a:pPr indent="0" marL="0">
-              <a:buNone/>
-            </a:pPr>
-            <a:r>
-              <a:rPr lang="en-US" sz="1150" dirty="0">
-                <a:solidFill>
-                  <a:schemeClr val="tx1"/>
-                </a:solidFill>
-              </a:rPr>
-              <a:t>Nombramiento SSF · Nota 9337</a:t>
-            </a:r>
-            <a:endParaRPr lang="en-US" sz="1150" dirty="0"/>
-          </a:p>
-        </p:txBody>
-      </p:sp>
-      <p:sp>
-        <p:nvSpPr>
-          <p:cNvPr id="11" name="Hito 2025-2"/>
-          <p:cNvSpPr/>
-          <p:nvPr/>
-        </p:nvSpPr>
-        <p:spPr>
-          <a:xfrm>
-            <a:off x="777240" y="2862072"/>
-            <a:ext cx="201168" cy="201168"/>
-          </a:xfrm>
-          <a:prstGeom prst="ellipse">
-            <a:avLst/>
-          </a:prstGeom>
-          <a:solidFill>
-            <a:schemeClr val="bg1"/>
-          </a:solidFill>
-          <a:ln w="31750">
-            <a:solidFill>
-              <a:schemeClr val="accent1"/>
-            </a:solidFill>
-            <a:prstDash val="solid"/>
-          </a:ln>
-        </p:spPr>
-      </p:sp>
-      <p:sp>
-        <p:nvSpPr>
-          <p:cNvPr id="12" name="Fecha 2025-2"/>
-          <p:cNvSpPr txBox="1"/>
-          <p:nvPr/>
-        </p:nvSpPr>
-        <p:spPr>
-          <a:xfrm>
-            <a:off x="1143000" y="2834640"/>
-            <a:ext cx="2606040" cy="219456"/>
-          </a:xfrm>
-          <a:prstGeom prst="rect">
-            <a:avLst/>
-          </a:prstGeom>
-          <a:noFill/>
-          <a:ln/>
-        </p:spPr>
-        <p:txBody>
-          <a:bodyPr wrap="square" lIns="0" tIns="0" rIns="0" bIns="0" rtlCol="0" anchor="t"/>
-          <a:lstStyle/>
-          <a:p>
-            <a:pPr indent="0" marL="0">
-              <a:buNone/>
-            </a:pPr>
-            <a:r>
-              <a:rPr lang="en-US" sz="1100" b="1" dirty="0">
-                <a:solidFill>
-                  <a:schemeClr val="accent1"/>
-                </a:solidFill>
-                <a:latin typeface="Courier New" pitchFamily="34" charset="0"/>
-                <a:ea typeface="Courier New" pitchFamily="34" charset="-122"/>
-                <a:cs typeface="Courier New" pitchFamily="34" charset="-120"/>
-              </a:rPr>
-              <a:t>19 MAY 2025</a:t>
-            </a:r>
-            <a:endParaRPr lang="en-US" sz="1100" dirty="0"/>
-          </a:p>
-        </p:txBody>
-      </p:sp>
-      <p:sp>
-        <p:nvSpPr>
-          <p:cNvPr id="13" name="Hito 2025-2 texto"/>
-          <p:cNvSpPr txBox="1"/>
-          <p:nvPr/>
-        </p:nvSpPr>
-        <p:spPr>
-          <a:xfrm>
-            <a:off x="1143000" y="3054096"/>
-            <a:ext cx="2606040" cy="365760"/>
-          </a:xfrm>
-          <a:prstGeom prst="rect">
-            <a:avLst/>
-          </a:prstGeom>
-          <a:noFill/>
-          <a:ln/>
-        </p:spPr>
-        <p:txBody>
-          <a:bodyPr wrap="square" lIns="0" tIns="0" rIns="0" bIns="0" rtlCol="0" anchor="t"/>
-          <a:lstStyle/>
-          <a:p>
-            <a:pPr indent="0" marL="0">
-              <a:buNone/>
-            </a:pPr>
-            <a:r>
-              <a:rPr lang="en-US" sz="1150" dirty="0">
-                <a:solidFill>
-                  <a:schemeClr val="tx1"/>
-                </a:solidFill>
-              </a:rPr>
-              <a:t>Inicio formal de la visita en sitio</a:t>
-            </a:r>
-            <a:endParaRPr lang="en-US" sz="1150" dirty="0"/>
-          </a:p>
-        </p:txBody>
-      </p:sp>
-      <p:sp>
-        <p:nvSpPr>
-          <p:cNvPr id="14" name="Hito 2025-3"/>
-          <p:cNvSpPr/>
-          <p:nvPr/>
-        </p:nvSpPr>
-        <p:spPr>
-          <a:xfrm>
-            <a:off x="777240" y="3593592"/>
-            <a:ext cx="201168" cy="201168"/>
-          </a:xfrm>
-          <a:prstGeom prst="ellipse">
-            <a:avLst/>
-          </a:prstGeom>
-          <a:solidFill>
-            <a:schemeClr val="bg1"/>
-          </a:solidFill>
-          <a:ln w="31750">
-            <a:solidFill>
-              <a:schemeClr val="accent1"/>
-            </a:solidFill>
-            <a:prstDash val="solid"/>
-          </a:ln>
-        </p:spPr>
-      </p:sp>
-      <p:sp>
-        <p:nvSpPr>
-          <p:cNvPr id="15" name="Fecha 2025-3"/>
-          <p:cNvSpPr txBox="1"/>
-          <p:nvPr/>
-        </p:nvSpPr>
-        <p:spPr>
-          <a:xfrm>
-            <a:off x="1143000" y="3566160"/>
-            <a:ext cx="2606040" cy="219456"/>
-          </a:xfrm>
-          <a:prstGeom prst="rect">
-            <a:avLst/>
-          </a:prstGeom>
-          <a:noFill/>
-          <a:ln/>
-        </p:spPr>
-        <p:txBody>
-          <a:bodyPr wrap="square" lIns="0" tIns="0" rIns="0" bIns="0" rtlCol="0" anchor="t"/>
-          <a:lstStyle/>
-          <a:p>
-            <a:pPr indent="0" marL="0">
-              <a:buNone/>
-            </a:pPr>
-            <a:r>
-              <a:rPr lang="en-US" sz="1100" b="1" dirty="0">
-                <a:solidFill>
-                  <a:schemeClr val="accent1"/>
-                </a:solidFill>
-                <a:latin typeface="Courier New" pitchFamily="34" charset="0"/>
-                <a:ea typeface="Courier New" pitchFamily="34" charset="-122"/>
-                <a:cs typeface="Courier New" pitchFamily="34" charset="-120"/>
-              </a:rPr>
-              <a:t>05 NOV 2025</a:t>
-            </a:r>
-            <a:endParaRPr lang="en-US" sz="1100" dirty="0"/>
-          </a:p>
-        </p:txBody>
-      </p:sp>
-      <p:sp>
-        <p:nvSpPr>
-          <p:cNvPr id="16" name="Hito 2025-3 texto"/>
-          <p:cNvSpPr txBox="1"/>
-          <p:nvPr/>
-        </p:nvSpPr>
-        <p:spPr>
-          <a:xfrm>
-            <a:off x="1143000" y="3785616"/>
-            <a:ext cx="2606040" cy="365760"/>
-          </a:xfrm>
-          <a:prstGeom prst="rect">
-            <a:avLst/>
-          </a:prstGeom>
-          <a:noFill/>
-          <a:ln/>
-        </p:spPr>
-        <p:txBody>
-          <a:bodyPr wrap="square" lIns="0" tIns="0" rIns="0" bIns="0" rtlCol="0" anchor="t"/>
-          <a:lstStyle/>
-          <a:p>
-            <a:pPr indent="0" marL="0">
-              <a:buNone/>
-            </a:pPr>
-            <a:r>
-              <a:rPr lang="en-US" sz="1150" dirty="0">
-                <a:solidFill>
-                  <a:schemeClr val="tx1"/>
-                </a:solidFill>
-              </a:rPr>
-              <a:t>Informe preliminar · Nota 17003 · 9 obs.</a:t>
-            </a:r>
-            <a:endParaRPr lang="en-US" sz="1150" dirty="0"/>
-          </a:p>
-        </p:txBody>
-      </p:sp>
-      <p:sp>
-        <p:nvSpPr>
-          <p:cNvPr id="17" name="Detalle 2025"/>
-          <p:cNvSpPr/>
-          <p:nvPr/>
-        </p:nvSpPr>
-        <p:spPr>
-          <a:xfrm>
-            <a:off x="3840480" y="2103120"/>
-            <a:ext cx="1935328" cy="2103120"/>
+            <a:off x="548640" y="4334256"/>
+            <a:ext cx="777240" cy="274320"/>
           </a:xfrm>
           <a:prstGeom prst="roundRect">
             <a:avLst>
-              <a:gd name="adj" fmla="val 4725"/>
+              <a:gd name="adj" fmla="val 50000"/>
             </a:avLst>
           </a:prstGeom>
           <a:solidFill>
-            <a:schemeClr val="bg1"/>
+            <a:schemeClr val="accent1"/>
           </a:solidFill>
           <a:ln w="12700">
             <a:solidFill>
-              <a:schemeClr val="bg1">
+              <a:schemeClr val="accent1">
                 <a:alpha val="0"/>
               </a:schemeClr>
             </a:solidFill>
@@ -8714,14 +8421,50 @@
       </p:sp>
       <p:sp>
         <p:nvSpPr>
-          <p:cNvPr id="18" name="Detalle título 2025"/>
-          <p:cNvSpPr txBox="1"/>
-          <p:nvPr/>
-        </p:nvSpPr>
-        <p:spPr>
-          <a:xfrm>
-            <a:off x="4005072" y="2240280"/>
-            <a:ext cx="1606144" cy="274320"/>
+          <p:cNvPr id="10" name="Año 2025"/>
+          <p:cNvSpPr txBox="1"/>
+          <p:nvPr/>
+        </p:nvSpPr>
+        <p:spPr>
+          <a:xfrm>
+            <a:off x="548640" y="4334256"/>
+            <a:ext cx="777240" cy="274320"/>
+          </a:xfrm>
+          <a:prstGeom prst="rect">
+            <a:avLst/>
+          </a:prstGeom>
+          <a:noFill/>
+          <a:ln/>
+        </p:spPr>
+        <p:txBody>
+          <a:bodyPr wrap="square" lIns="0" tIns="0" rIns="0" bIns="0" rtlCol="0" anchor="ctr"/>
+          <a:lstStyle/>
+          <a:p>
+            <a:pPr algn="ctr" indent="0" marL="0">
+              <a:buNone/>
+            </a:pPr>
+            <a:r>
+              <a:rPr lang="en-US" sz="1100" b="1" spc="100" kern="0" dirty="0">
+                <a:solidFill>
+                  <a:schemeClr val="bg1"/>
+                </a:solidFill>
+              </a:rPr>
+              <a:t>2025</a:t>
+            </a:r>
+            <a:endParaRPr lang="en-US" sz="1100" dirty="0"/>
+          </a:p>
+        </p:txBody>
+      </p:sp>
+      <p:sp>
+        <p:nvSpPr>
+          <p:cNvPr id="11" name="Pausa texto"/>
+          <p:cNvSpPr txBox="1"/>
+          <p:nvPr/>
+        </p:nvSpPr>
+        <p:spPr>
+          <a:xfrm>
+            <a:off x="502920" y="3840480"/>
+            <a:ext cx="914400" cy="201168"/>
           </a:xfrm>
           <a:prstGeom prst="rect">
             <a:avLst/>
@@ -8733,175 +8476,45 @@
           <a:bodyPr wrap="square" lIns="0" tIns="0" rIns="0" bIns="0" rtlCol="0" anchor="t"/>
           <a:lstStyle/>
           <a:p>
-            <a:pPr indent="0" marL="0">
-              <a:buNone/>
-            </a:pPr>
-            <a:r>
-              <a:rPr lang="en-US" sz="1250" b="1" dirty="0">
-                <a:solidFill>
-                  <a:schemeClr val="accent1"/>
-                </a:solidFill>
-              </a:rPr>
-              <a:t>Hallazgos críticos 2025</a:t>
-            </a:r>
-            <a:endParaRPr lang="en-US" sz="1250" dirty="0"/>
-          </a:p>
-        </p:txBody>
-      </p:sp>
-      <p:sp>
-        <p:nvSpPr>
-          <p:cNvPr id="19" name="Detalle lista 2025"/>
-          <p:cNvSpPr txBox="1"/>
-          <p:nvPr/>
-        </p:nvSpPr>
-        <p:spPr>
-          <a:xfrm>
-            <a:off x="4005072" y="2587752"/>
-            <a:ext cx="1661008" cy="1554480"/>
-          </a:xfrm>
-          <a:prstGeom prst="rect">
-            <a:avLst/>
-          </a:prstGeom>
-          <a:noFill/>
-          <a:ln/>
-        </p:spPr>
-        <p:txBody>
-          <a:bodyPr wrap="square" lIns="0" tIns="0" rIns="0" bIns="0" rtlCol="0" anchor="t"/>
-          <a:lstStyle/>
-          <a:p>
-            <a:pPr marL="342900" indent="-342900">
-              <a:spcAft>
-                <a:spcPts val="400"/>
-              </a:spcAft>
-              <a:buSzPct val="100000"/>
-              <a:buChar char="•"/>
-            </a:pPr>
-            <a:r>
-              <a:rPr lang="en-US" sz="1100" dirty="0">
-                <a:solidFill>
-                  <a:schemeClr val="tx1"/>
-                </a:solidFill>
-              </a:rPr>
-              <a:t>Ausencia de Política de </a:t>
-            </a:r>
-            <a:pPr indent="0" marL="0">
-              <a:spcAft>
-                <a:spcPts val="400"/>
-              </a:spcAft>
-              <a:buNone/>
-            </a:pPr>
-            <a:r>
-              <a:rPr lang="en-US" sz="1100" b="1" dirty="0">
-                <a:solidFill>
-                  <a:schemeClr val="tx1"/>
-                </a:solidFill>
-              </a:rPr>
-              <a:t>Operaciones Vinculadas</a:t>
-            </a:r>
-            <a:endParaRPr lang="en-US" sz="1100" dirty="0"/>
-          </a:p>
-          <a:p>
-            <a:pPr marL="342900" indent="-342900">
-              <a:spcAft>
-                <a:spcPts val="400"/>
-              </a:spcAft>
-              <a:buSzPct val="100000"/>
-              <a:buChar char="•"/>
-            </a:pPr>
-            <a:r>
-              <a:rPr lang="en-US" sz="1100" dirty="0">
-                <a:solidFill>
-                  <a:schemeClr val="tx1"/>
-                </a:solidFill>
-              </a:rPr>
-              <a:t>Normativa interna </a:t>
-            </a:r>
-            <a:pPr indent="0" marL="0">
-              <a:spcAft>
-                <a:spcPts val="400"/>
-              </a:spcAft>
-              <a:buNone/>
-            </a:pPr>
-            <a:r>
-              <a:rPr lang="en-US" sz="1100" b="1" dirty="0">
-                <a:solidFill>
-                  <a:schemeClr val="tx1"/>
-                </a:solidFill>
-              </a:rPr>
-              <a:t>desactualizada</a:t>
-            </a:r>
-            <a:pPr indent="0" marL="0">
-              <a:spcAft>
-                <a:spcPts val="400"/>
-              </a:spcAft>
-              <a:buNone/>
-            </a:pPr>
-            <a:r>
-              <a:rPr lang="en-US" sz="1100" dirty="0">
-                <a:solidFill>
-                  <a:schemeClr val="tx1"/>
-                </a:solidFill>
-              </a:rPr>
-              <a:t> (9 documentos)</a:t>
-            </a:r>
-            <a:endParaRPr lang="en-US" sz="1100" dirty="0"/>
-          </a:p>
-          <a:p>
-            <a:pPr marL="342900" indent="-342900">
-              <a:spcAft>
-                <a:spcPts val="400"/>
-              </a:spcAft>
-              <a:buSzPct val="100000"/>
-              <a:buChar char="•"/>
-            </a:pPr>
-            <a:r>
-              <a:rPr lang="en-US" sz="1100" dirty="0">
-                <a:solidFill>
-                  <a:schemeClr val="tx1"/>
-                </a:solidFill>
-              </a:rPr>
-              <a:t>Uso inapropiado del </a:t>
-            </a:r>
-            <a:pPr indent="0" marL="0">
-              <a:spcAft>
-                <a:spcPts val="400"/>
-              </a:spcAft>
-              <a:buNone/>
-            </a:pPr>
-            <a:r>
-              <a:rPr lang="en-US" sz="1100" b="1" dirty="0">
-                <a:solidFill>
-                  <a:schemeClr val="tx1"/>
-                </a:solidFill>
-              </a:rPr>
-              <a:t>Fondo de Educación</a:t>
-            </a:r>
-            <a:endParaRPr lang="en-US" sz="1100" dirty="0"/>
-          </a:p>
-        </p:txBody>
-      </p:sp>
-      <p:sp>
-        <p:nvSpPr>
-          <p:cNvPr id="20" name="Bloque 2026"/>
+            <a:pPr algn="ctr" indent="0" marL="0">
+              <a:buNone/>
+            </a:pPr>
+            <a:r>
+              <a:rPr lang="en-US" sz="1000" i="1" dirty="0">
+                <a:solidFill>
+                  <a:schemeClr val="accent5"/>
+                </a:solidFill>
+              </a:rPr>
+              <a:t>8 meses</a:t>
+            </a:r>
+            <a:endParaRPr lang="en-US" sz="1000" dirty="0"/>
+          </a:p>
+        </p:txBody>
+      </p:sp>
+      <p:sp>
+        <p:nvSpPr>
+          <p:cNvPr id="12" name="Fondo hoy"/>
           <p:cNvSpPr/>
           <p:nvPr/>
         </p:nvSpPr>
         <p:spPr>
           <a:xfrm>
-            <a:off x="6233008" y="1325880"/>
-            <a:ext cx="5410048" cy="3063240"/>
+            <a:off x="1856232" y="1371600"/>
+            <a:ext cx="4754880" cy="621792"/>
           </a:xfrm>
           <a:prstGeom prst="roundRect">
             <a:avLst>
-              <a:gd name="adj" fmla="val 2985"/>
+              <a:gd name="adj" fmla="val 14706"/>
             </a:avLst>
           </a:prstGeom>
           <a:solidFill>
-            <a:schemeClr val="bg2"/>
+            <a:schemeClr val="accent2">
+              <a:alpha val="15000"/>
+            </a:schemeClr>
           </a:solidFill>
           <a:ln w="12700">
             <a:solidFill>
-              <a:schemeClr val="bg2">
+              <a:schemeClr val="accent2">
                 <a:alpha val="0"/>
               </a:schemeClr>
             </a:solidFill>
@@ -8911,412 +8524,14 @@
       </p:sp>
       <p:sp>
         <p:nvSpPr>
-          <p:cNvPr id="21" name="Año bloque 2026"/>
-          <p:cNvSpPr txBox="1"/>
-          <p:nvPr/>
-        </p:nvSpPr>
-        <p:spPr>
-          <a:xfrm>
-            <a:off x="6461608" y="1463040"/>
-            <a:ext cx="1097280" cy="457200"/>
-          </a:xfrm>
-          <a:prstGeom prst="rect">
-            <a:avLst/>
-          </a:prstGeom>
-          <a:noFill/>
-          <a:ln/>
-        </p:spPr>
-        <p:txBody>
-          <a:bodyPr wrap="square" lIns="0" tIns="0" rIns="0" bIns="0" rtlCol="0" anchor="ctr"/>
-          <a:lstStyle/>
-          <a:p>
-            <a:pPr indent="0" marL="0">
-              <a:buNone/>
-            </a:pPr>
-            <a:r>
-              <a:rPr lang="en-US" sz="2600" b="1" dirty="0">
-                <a:solidFill>
-                  <a:schemeClr val="accent2"/>
-                </a:solidFill>
-                <a:latin typeface="Cambria" pitchFamily="34" charset="0"/>
-                <a:ea typeface="Cambria" pitchFamily="34" charset="-122"/>
-                <a:cs typeface="Cambria" pitchFamily="34" charset="-120"/>
-              </a:rPr>
-              <a:t>2026</a:t>
-            </a:r>
-            <a:endParaRPr lang="en-US" sz="2600" dirty="0"/>
-          </a:p>
-        </p:txBody>
-      </p:sp>
-      <p:sp>
-        <p:nvSpPr>
-          <p:cNvPr id="22" name="Subtítulo bloque 2026"/>
-          <p:cNvSpPr txBox="1"/>
-          <p:nvPr/>
-        </p:nvSpPr>
-        <p:spPr>
-          <a:xfrm>
-            <a:off x="7513168" y="1463040"/>
-            <a:ext cx="3947008" cy="457200"/>
-          </a:xfrm>
-          <a:prstGeom prst="rect">
-            <a:avLst/>
-          </a:prstGeom>
-          <a:noFill/>
-          <a:ln/>
-        </p:spPr>
-        <p:txBody>
-          <a:bodyPr wrap="square" lIns="0" tIns="0" rIns="0" bIns="0" rtlCol="0" anchor="ctr"/>
-          <a:lstStyle/>
-          <a:p>
-            <a:pPr indent="0" marL="0">
-              <a:buNone/>
-            </a:pPr>
-            <a:r>
-              <a:rPr lang="en-US" sz="1200" b="1" dirty="0">
-                <a:solidFill>
-                  <a:schemeClr val="accent5"/>
-                </a:solidFill>
-              </a:rPr>
-              <a:t>Visita 2 · Nota 22741 · 7 nuevas + 2 de 2025</a:t>
-            </a:r>
-            <a:endParaRPr lang="en-US" sz="1200" dirty="0"/>
-          </a:p>
-        </p:txBody>
-      </p:sp>
-      <p:sp>
-        <p:nvSpPr>
-          <p:cNvPr id="23" name="Eje 2026"/>
+          <p:cNvPr id="13" name="Halo hoy"/>
           <p:cNvSpPr/>
           <p:nvPr/>
         </p:nvSpPr>
         <p:spPr>
           <a:xfrm>
-            <a:off x="6562192" y="2231136"/>
-            <a:ext cx="0" cy="1645920"/>
-          </a:xfrm>
-          <a:prstGeom prst="line">
-            <a:avLst/>
-          </a:prstGeom>
-          <a:noFill/>
-          <a:ln w="31750">
-            <a:solidFill>
-              <a:schemeClr val="accent2"/>
-            </a:solidFill>
-            <a:prstDash val="solid"/>
-          </a:ln>
-        </p:spPr>
-      </p:sp>
-      <p:sp>
-        <p:nvSpPr>
-          <p:cNvPr id="24" name="Hito 2026-1"/>
-          <p:cNvSpPr/>
-          <p:nvPr/>
-        </p:nvSpPr>
-        <p:spPr>
-          <a:xfrm>
-            <a:off x="6461608" y="2130552"/>
-            <a:ext cx="201168" cy="201168"/>
-          </a:xfrm>
-          <a:prstGeom prst="ellipse">
-            <a:avLst/>
-          </a:prstGeom>
-          <a:solidFill>
-            <a:schemeClr val="bg1"/>
-          </a:solidFill>
-          <a:ln w="31750">
-            <a:solidFill>
-              <a:schemeClr val="accent2"/>
-            </a:solidFill>
-            <a:prstDash val="solid"/>
-          </a:ln>
-        </p:spPr>
-      </p:sp>
-      <p:sp>
-        <p:nvSpPr>
-          <p:cNvPr id="25" name="Fecha 2026-1"/>
-          <p:cNvSpPr txBox="1"/>
-          <p:nvPr/>
-        </p:nvSpPr>
-        <p:spPr>
-          <a:xfrm>
-            <a:off x="6827368" y="2103120"/>
-            <a:ext cx="2606040" cy="219456"/>
-          </a:xfrm>
-          <a:prstGeom prst="rect">
-            <a:avLst/>
-          </a:prstGeom>
-          <a:noFill/>
-          <a:ln/>
-        </p:spPr>
-        <p:txBody>
-          <a:bodyPr wrap="square" lIns="0" tIns="0" rIns="0" bIns="0" rtlCol="0" anchor="t"/>
-          <a:lstStyle/>
-          <a:p>
-            <a:pPr indent="0" marL="0">
-              <a:buNone/>
-            </a:pPr>
-            <a:r>
-              <a:rPr lang="en-US" sz="1100" b="1" dirty="0">
-                <a:solidFill>
-                  <a:schemeClr val="accent2"/>
-                </a:solidFill>
-                <a:latin typeface="Courier New" pitchFamily="34" charset="0"/>
-                <a:ea typeface="Courier New" pitchFamily="34" charset="-122"/>
-                <a:cs typeface="Courier New" pitchFamily="34" charset="-120"/>
-              </a:rPr>
-              <a:t>31 JUL 2026</a:t>
-            </a:r>
-            <a:endParaRPr lang="en-US" sz="1100" dirty="0"/>
-          </a:p>
-        </p:txBody>
-      </p:sp>
-      <p:sp>
-        <p:nvSpPr>
-          <p:cNvPr id="26" name="Hito 2026-1 texto"/>
-          <p:cNvSpPr txBox="1"/>
-          <p:nvPr/>
-        </p:nvSpPr>
-        <p:spPr>
-          <a:xfrm>
-            <a:off x="6827368" y="2322576"/>
-            <a:ext cx="2606040" cy="365760"/>
-          </a:xfrm>
-          <a:prstGeom prst="rect">
-            <a:avLst/>
-          </a:prstGeom>
-          <a:noFill/>
-          <a:ln/>
-        </p:spPr>
-        <p:txBody>
-          <a:bodyPr wrap="square" lIns="0" tIns="0" rIns="0" bIns="0" rtlCol="0" anchor="t"/>
-          <a:lstStyle/>
-          <a:p>
-            <a:pPr indent="0" marL="0">
-              <a:buNone/>
-            </a:pPr>
-            <a:r>
-              <a:rPr lang="en-US" sz="1150" dirty="0">
-                <a:solidFill>
-                  <a:schemeClr val="tx1"/>
-                </a:solidFill>
-              </a:rPr>
-              <a:t>Nombramiento SSF · Nota 18432</a:t>
-            </a:r>
-            <a:endParaRPr lang="en-US" sz="1150" dirty="0"/>
-          </a:p>
-        </p:txBody>
-      </p:sp>
-      <p:sp>
-        <p:nvSpPr>
-          <p:cNvPr id="27" name="Hito 2026-2"/>
-          <p:cNvSpPr/>
-          <p:nvPr/>
-        </p:nvSpPr>
-        <p:spPr>
-          <a:xfrm>
-            <a:off x="6461608" y="2679192"/>
-            <a:ext cx="201168" cy="201168"/>
-          </a:xfrm>
-          <a:prstGeom prst="ellipse">
-            <a:avLst/>
-          </a:prstGeom>
-          <a:solidFill>
-            <a:schemeClr val="bg1"/>
-          </a:solidFill>
-          <a:ln w="31750">
-            <a:solidFill>
-              <a:schemeClr val="accent2"/>
-            </a:solidFill>
-            <a:prstDash val="solid"/>
-          </a:ln>
-        </p:spPr>
-      </p:sp>
-      <p:sp>
-        <p:nvSpPr>
-          <p:cNvPr id="28" name="Fecha 2026-2"/>
-          <p:cNvSpPr txBox="1"/>
-          <p:nvPr/>
-        </p:nvSpPr>
-        <p:spPr>
-          <a:xfrm>
-            <a:off x="6827368" y="2651760"/>
-            <a:ext cx="2606040" cy="219456"/>
-          </a:xfrm>
-          <a:prstGeom prst="rect">
-            <a:avLst/>
-          </a:prstGeom>
-          <a:noFill/>
-          <a:ln/>
-        </p:spPr>
-        <p:txBody>
-          <a:bodyPr wrap="square" lIns="0" tIns="0" rIns="0" bIns="0" rtlCol="0" anchor="t"/>
-          <a:lstStyle/>
-          <a:p>
-            <a:pPr indent="0" marL="0">
-              <a:buNone/>
-            </a:pPr>
-            <a:r>
-              <a:rPr lang="en-US" sz="1100" b="1" dirty="0">
-                <a:solidFill>
-                  <a:schemeClr val="accent2"/>
-                </a:solidFill>
-                <a:latin typeface="Courier New" pitchFamily="34" charset="0"/>
-                <a:ea typeface="Courier New" pitchFamily="34" charset="-122"/>
-                <a:cs typeface="Courier New" pitchFamily="34" charset="-120"/>
-              </a:rPr>
-              <a:t>21 AGO 2026</a:t>
-            </a:r>
-            <a:endParaRPr lang="en-US" sz="1100" dirty="0"/>
-          </a:p>
-        </p:txBody>
-      </p:sp>
-      <p:sp>
-        <p:nvSpPr>
-          <p:cNvPr id="29" name="Hito 2026-2 texto"/>
-          <p:cNvSpPr txBox="1"/>
-          <p:nvPr/>
-        </p:nvSpPr>
-        <p:spPr>
-          <a:xfrm>
-            <a:off x="6827368" y="2871216"/>
-            <a:ext cx="2606040" cy="365760"/>
-          </a:xfrm>
-          <a:prstGeom prst="rect">
-            <a:avLst/>
-          </a:prstGeom>
-          <a:noFill/>
-          <a:ln/>
-        </p:spPr>
-        <p:txBody>
-          <a:bodyPr wrap="square" lIns="0" tIns="0" rIns="0" bIns="0" rtlCol="0" anchor="t"/>
-          <a:lstStyle/>
-          <a:p>
-            <a:pPr indent="0" marL="0">
-              <a:buNone/>
-            </a:pPr>
-            <a:r>
-              <a:rPr lang="en-US" sz="1150" dirty="0">
-                <a:solidFill>
-                  <a:schemeClr val="tx1"/>
-                </a:solidFill>
-              </a:rPr>
-              <a:t>Inicio de la visita ampliada</a:t>
-            </a:r>
-            <a:endParaRPr lang="en-US" sz="1150" dirty="0"/>
-          </a:p>
-        </p:txBody>
-      </p:sp>
-      <p:sp>
-        <p:nvSpPr>
-          <p:cNvPr id="30" name="Hito 2026-3"/>
-          <p:cNvSpPr/>
-          <p:nvPr/>
-        </p:nvSpPr>
-        <p:spPr>
-          <a:xfrm>
-            <a:off x="6461608" y="3227832"/>
-            <a:ext cx="201168" cy="201168"/>
-          </a:xfrm>
-          <a:prstGeom prst="ellipse">
-            <a:avLst/>
-          </a:prstGeom>
-          <a:solidFill>
-            <a:schemeClr val="bg1"/>
-          </a:solidFill>
-          <a:ln w="31750">
-            <a:solidFill>
-              <a:schemeClr val="accent2"/>
-            </a:solidFill>
-            <a:prstDash val="solid"/>
-          </a:ln>
-        </p:spPr>
-      </p:sp>
-      <p:sp>
-        <p:nvSpPr>
-          <p:cNvPr id="31" name="Fecha 2026-3"/>
-          <p:cNvSpPr txBox="1"/>
-          <p:nvPr/>
-        </p:nvSpPr>
-        <p:spPr>
-          <a:xfrm>
-            <a:off x="6827368" y="3200400"/>
-            <a:ext cx="2606040" cy="219456"/>
-          </a:xfrm>
-          <a:prstGeom prst="rect">
-            <a:avLst/>
-          </a:prstGeom>
-          <a:noFill/>
-          <a:ln/>
-        </p:spPr>
-        <p:txBody>
-          <a:bodyPr wrap="square" lIns="0" tIns="0" rIns="0" bIns="0" rtlCol="0" anchor="t"/>
-          <a:lstStyle/>
-          <a:p>
-            <a:pPr indent="0" marL="0">
-              <a:buNone/>
-            </a:pPr>
-            <a:r>
-              <a:rPr lang="en-US" sz="1100" b="1" dirty="0">
-                <a:solidFill>
-                  <a:schemeClr val="accent2"/>
-                </a:solidFill>
-                <a:latin typeface="Courier New" pitchFamily="34" charset="0"/>
-                <a:ea typeface="Courier New" pitchFamily="34" charset="-122"/>
-                <a:cs typeface="Courier New" pitchFamily="34" charset="-120"/>
-              </a:rPr>
-              <a:t>09 OCT 2026</a:t>
-            </a:r>
-            <a:endParaRPr lang="en-US" sz="1100" dirty="0"/>
-          </a:p>
-        </p:txBody>
-      </p:sp>
-      <p:sp>
-        <p:nvSpPr>
-          <p:cNvPr id="32" name="Hito 2026-3 texto"/>
-          <p:cNvSpPr txBox="1"/>
-          <p:nvPr/>
-        </p:nvSpPr>
-        <p:spPr>
-          <a:xfrm>
-            <a:off x="6827368" y="3419856"/>
-            <a:ext cx="2606040" cy="365760"/>
-          </a:xfrm>
-          <a:prstGeom prst="rect">
-            <a:avLst/>
-          </a:prstGeom>
-          <a:noFill/>
-          <a:ln/>
-        </p:spPr>
-        <p:txBody>
-          <a:bodyPr wrap="square" lIns="0" tIns="0" rIns="0" bIns="0" rtlCol="0" anchor="t"/>
-          <a:lstStyle/>
-          <a:p>
-            <a:pPr indent="0" marL="0">
-              <a:buNone/>
-            </a:pPr>
-            <a:r>
-              <a:rPr lang="en-US" sz="1150" dirty="0">
-                <a:solidFill>
-                  <a:schemeClr val="tx1"/>
-                </a:solidFill>
-              </a:rPr>
-              <a:t>Informe preliminar · Nota 22741 · 7 + 2</a:t>
-            </a:r>
-            <a:endParaRPr lang="en-US" sz="1150" dirty="0"/>
-          </a:p>
-        </p:txBody>
-      </p:sp>
-      <p:sp>
-        <p:nvSpPr>
-          <p:cNvPr id="33" name="Halo hoy"/>
-          <p:cNvSpPr/>
-          <p:nvPr/>
-        </p:nvSpPr>
-        <p:spPr>
-          <a:xfrm>
-            <a:off x="6397600" y="3712464"/>
-            <a:ext cx="329184" cy="329184"/>
+            <a:off x="1463040" y="1426464"/>
+            <a:ext cx="365760" cy="365760"/>
           </a:xfrm>
           <a:prstGeom prst="ellipse">
             <a:avLst/>
@@ -9338,14 +8553,14 @@
       </p:sp>
       <p:sp>
         <p:nvSpPr>
-          <p:cNvPr id="34" name="Hito 2026-4"/>
+          <p:cNvPr id="14" name="Hito 1"/>
           <p:cNvSpPr/>
           <p:nvPr/>
         </p:nvSpPr>
         <p:spPr>
           <a:xfrm>
-            <a:off x="6461608" y="3776472"/>
-            <a:ext cx="201168" cy="201168"/>
+            <a:off x="1536192" y="1499616"/>
+            <a:ext cx="219456" cy="219456"/>
           </a:xfrm>
           <a:prstGeom prst="ellipse">
             <a:avLst/>
@@ -9363,30 +8578,30 @@
       </p:sp>
       <p:sp>
         <p:nvSpPr>
-          <p:cNvPr id="35" name="Fecha 2026-4"/>
-          <p:cNvSpPr txBox="1"/>
-          <p:nvPr/>
-        </p:nvSpPr>
-        <p:spPr>
-          <a:xfrm>
-            <a:off x="6827368" y="3749040"/>
-            <a:ext cx="2606040" cy="219456"/>
-          </a:xfrm>
-          <a:prstGeom prst="rect">
-            <a:avLst/>
-          </a:prstGeom>
-          <a:noFill/>
-          <a:ln/>
-        </p:spPr>
-        <p:txBody>
-          <a:bodyPr wrap="square" lIns="0" tIns="0" rIns="0" bIns="0" rtlCol="0" anchor="t"/>
-          <a:lstStyle/>
-          <a:p>
-            <a:pPr indent="0" marL="0">
-              <a:buNone/>
-            </a:pPr>
-            <a:r>
-              <a:rPr lang="en-US" sz="1100" b="1" dirty="0">
+          <p:cNvPr id="15" name="Hito fecha 1"/>
+          <p:cNvSpPr txBox="1"/>
+          <p:nvPr/>
+        </p:nvSpPr>
+        <p:spPr>
+          <a:xfrm>
+            <a:off x="1965960" y="1463040"/>
+            <a:ext cx="4572000" cy="274320"/>
+          </a:xfrm>
+          <a:prstGeom prst="rect">
+            <a:avLst/>
+          </a:prstGeom>
+          <a:noFill/>
+          <a:ln/>
+        </p:spPr>
+        <p:txBody>
+          <a:bodyPr wrap="square" lIns="0" tIns="0" rIns="0" bIns="0" rtlCol="0" anchor="ctr"/>
+          <a:lstStyle/>
+          <a:p>
+            <a:pPr indent="0" marL="0">
+              <a:buNone/>
+            </a:pPr>
+            <a:r>
+              <a:rPr lang="en-US" sz="1150" b="1" dirty="0">
                 <a:solidFill>
                   <a:schemeClr val="accent2"/>
                 </a:solidFill>
@@ -9394,22 +8609,33 @@
                 <a:ea typeface="Courier New" pitchFamily="34" charset="-122"/>
                 <a:cs typeface="Courier New" pitchFamily="34" charset="-120"/>
               </a:rPr>
-              <a:t>HOY</a:t>
-            </a:r>
-            <a:endParaRPr lang="en-US" sz="1100" dirty="0"/>
-          </a:p>
-        </p:txBody>
-      </p:sp>
-      <p:sp>
-        <p:nvSpPr>
-          <p:cNvPr id="36" name="Hito 2026-4 texto"/>
-          <p:cNvSpPr txBox="1"/>
-          <p:nvPr/>
-        </p:nvSpPr>
-        <p:spPr>
-          <a:xfrm>
-            <a:off x="6827368" y="3968496"/>
-            <a:ext cx="2606040" cy="365760"/>
+              <a:t>HOY   </a:t>
+            </a:r>
+            <a:pPr indent="0" marL="0">
+              <a:buNone/>
+            </a:pPr>
+            <a:r>
+              <a:rPr lang="en-US" sz="1250" b="1" dirty="0">
+                <a:solidFill>
+                  <a:schemeClr val="tx1"/>
+                </a:solidFill>
+              </a:rPr>
+              <a:t>Plazos de respuesta en curso</a:t>
+            </a:r>
+            <a:endParaRPr lang="en-US" sz="1400" dirty="0"/>
+          </a:p>
+        </p:txBody>
+      </p:sp>
+      <p:sp>
+        <p:nvSpPr>
+          <p:cNvPr id="16" name="Hito detalle 1"/>
+          <p:cNvSpPr txBox="1"/>
+          <p:nvPr/>
+        </p:nvSpPr>
+        <p:spPr>
+          <a:xfrm>
+            <a:off x="1965960" y="1737360"/>
+            <a:ext cx="4572000" cy="228600"/>
           </a:xfrm>
           <a:prstGeom prst="rect">
             <a:avLst/>
@@ -9425,39 +8651,635 @@
               <a:buNone/>
             </a:pPr>
             <a:r>
-              <a:rPr lang="en-US" sz="1150" b="1" dirty="0">
-                <a:solidFill>
-                  <a:schemeClr val="tx1"/>
-                </a:solidFill>
-              </a:rPr>
-              <a:t>Plazos de respuesta en curso</a:t>
-            </a:r>
-            <a:endParaRPr lang="en-US" sz="1150" dirty="0"/>
-          </a:p>
-        </p:txBody>
-      </p:sp>
-      <p:sp>
-        <p:nvSpPr>
-          <p:cNvPr id="37" name="Detalle 2026"/>
+              <a:rPr lang="en-US" sz="1050" dirty="0">
+                <a:solidFill>
+                  <a:schemeClr val="accent5"/>
+                </a:solidFill>
+              </a:rPr>
+              <a:t>Descargos 10 días hábiles (≈23/10) · Plan de solución 15 días hábiles (≈30/10)</a:t>
+            </a:r>
+            <a:endParaRPr lang="en-US" sz="1050" dirty="0"/>
+          </a:p>
+        </p:txBody>
+      </p:sp>
+      <p:sp>
+        <p:nvSpPr>
+          <p:cNvPr id="17" name="Hito 2"/>
           <p:cNvSpPr/>
           <p:nvPr/>
         </p:nvSpPr>
         <p:spPr>
           <a:xfrm>
-            <a:off x="9524848" y="2103120"/>
-            <a:ext cx="1935328" cy="2103120"/>
-          </a:xfrm>
-          <a:prstGeom prst="roundRect">
-            <a:avLst>
-              <a:gd name="adj" fmla="val 4725"/>
-            </a:avLst>
+            <a:off x="1536192" y="2176272"/>
+            <a:ext cx="219456" cy="219456"/>
+          </a:xfrm>
+          <a:prstGeom prst="ellipse">
+            <a:avLst/>
           </a:prstGeom>
           <a:solidFill>
             <a:schemeClr val="bg1"/>
           </a:solidFill>
+          <a:ln w="31750">
+            <a:solidFill>
+              <a:schemeClr val="accent2"/>
+            </a:solidFill>
+            <a:prstDash val="solid"/>
+          </a:ln>
+        </p:spPr>
+      </p:sp>
+      <p:sp>
+        <p:nvSpPr>
+          <p:cNvPr id="18" name="Hito fecha 2"/>
+          <p:cNvSpPr txBox="1"/>
+          <p:nvPr/>
+        </p:nvSpPr>
+        <p:spPr>
+          <a:xfrm>
+            <a:off x="1965960" y="2139696"/>
+            <a:ext cx="4572000" cy="274320"/>
+          </a:xfrm>
+          <a:prstGeom prst="rect">
+            <a:avLst/>
+          </a:prstGeom>
+          <a:noFill/>
+          <a:ln/>
+        </p:spPr>
+        <p:txBody>
+          <a:bodyPr wrap="square" lIns="0" tIns="0" rIns="0" bIns="0" rtlCol="0" anchor="ctr"/>
+          <a:lstStyle/>
+          <a:p>
+            <a:pPr indent="0" marL="0">
+              <a:buNone/>
+            </a:pPr>
+            <a:r>
+              <a:rPr lang="en-US" sz="1150" b="1" dirty="0">
+                <a:solidFill>
+                  <a:schemeClr val="accent2"/>
+                </a:solidFill>
+                <a:latin typeface="Courier New" pitchFamily="34" charset="0"/>
+                <a:ea typeface="Courier New" pitchFamily="34" charset="-122"/>
+                <a:cs typeface="Courier New" pitchFamily="34" charset="-120"/>
+              </a:rPr>
+              <a:t>09 OCT 2026   </a:t>
+            </a:r>
+            <a:pPr indent="0" marL="0">
+              <a:buNone/>
+            </a:pPr>
+            <a:r>
+              <a:rPr lang="en-US" sz="1250" b="1" dirty="0">
+                <a:solidFill>
+                  <a:schemeClr val="tx1"/>
+                </a:solidFill>
+              </a:rPr>
+              <a:t>Informe preliminar · Nota 22741</a:t>
+            </a:r>
+            <a:endParaRPr lang="en-US" sz="1400" dirty="0"/>
+          </a:p>
+        </p:txBody>
+      </p:sp>
+      <p:sp>
+        <p:nvSpPr>
+          <p:cNvPr id="19" name="Hito detalle 2"/>
+          <p:cNvSpPr txBox="1"/>
+          <p:nvPr/>
+        </p:nvSpPr>
+        <p:spPr>
+          <a:xfrm>
+            <a:off x="1965960" y="2414016"/>
+            <a:ext cx="4572000" cy="228600"/>
+          </a:xfrm>
+          <a:prstGeom prst="rect">
+            <a:avLst/>
+          </a:prstGeom>
+          <a:noFill/>
+          <a:ln/>
+        </p:spPr>
+        <p:txBody>
+          <a:bodyPr wrap="square" lIns="0" tIns="0" rIns="0" bIns="0" rtlCol="0" anchor="t"/>
+          <a:lstStyle/>
+          <a:p>
+            <a:pPr indent="0" marL="0">
+              <a:buNone/>
+            </a:pPr>
+            <a:r>
+              <a:rPr lang="en-US" sz="1050" dirty="0">
+                <a:solidFill>
+                  <a:schemeClr val="accent5"/>
+                </a:solidFill>
+              </a:rPr>
+              <a:t>7 nuevas (Anexo A) + seguimiento a obs. 3 y 5 de 2025 (Anexo B)</a:t>
+            </a:r>
+            <a:endParaRPr lang="en-US" sz="1050" dirty="0"/>
+          </a:p>
+        </p:txBody>
+      </p:sp>
+      <p:sp>
+        <p:nvSpPr>
+          <p:cNvPr id="20" name="Hito 3"/>
+          <p:cNvSpPr/>
+          <p:nvPr/>
+        </p:nvSpPr>
+        <p:spPr>
+          <a:xfrm>
+            <a:off x="1536192" y="2852928"/>
+            <a:ext cx="219456" cy="219456"/>
+          </a:xfrm>
+          <a:prstGeom prst="ellipse">
+            <a:avLst/>
+          </a:prstGeom>
+          <a:solidFill>
+            <a:schemeClr val="bg1"/>
+          </a:solidFill>
+          <a:ln w="31750">
+            <a:solidFill>
+              <a:schemeClr val="accent2"/>
+            </a:solidFill>
+            <a:prstDash val="solid"/>
+          </a:ln>
+        </p:spPr>
+      </p:sp>
+      <p:sp>
+        <p:nvSpPr>
+          <p:cNvPr id="21" name="Hito fecha 3"/>
+          <p:cNvSpPr txBox="1"/>
+          <p:nvPr/>
+        </p:nvSpPr>
+        <p:spPr>
+          <a:xfrm>
+            <a:off x="1965960" y="2816352"/>
+            <a:ext cx="4572000" cy="274320"/>
+          </a:xfrm>
+          <a:prstGeom prst="rect">
+            <a:avLst/>
+          </a:prstGeom>
+          <a:noFill/>
+          <a:ln/>
+        </p:spPr>
+        <p:txBody>
+          <a:bodyPr wrap="square" lIns="0" tIns="0" rIns="0" bIns="0" rtlCol="0" anchor="ctr"/>
+          <a:lstStyle/>
+          <a:p>
+            <a:pPr indent="0" marL="0">
+              <a:buNone/>
+            </a:pPr>
+            <a:r>
+              <a:rPr lang="en-US" sz="1150" b="1" dirty="0">
+                <a:solidFill>
+                  <a:schemeClr val="accent2"/>
+                </a:solidFill>
+                <a:latin typeface="Courier New" pitchFamily="34" charset="0"/>
+                <a:ea typeface="Courier New" pitchFamily="34" charset="-122"/>
+                <a:cs typeface="Courier New" pitchFamily="34" charset="-120"/>
+              </a:rPr>
+              <a:t>21 AGO 2026   </a:t>
+            </a:r>
+            <a:pPr indent="0" marL="0">
+              <a:buNone/>
+            </a:pPr>
+            <a:r>
+              <a:rPr lang="en-US" sz="1250" b="1" dirty="0">
+                <a:solidFill>
+                  <a:schemeClr val="tx1"/>
+                </a:solidFill>
+              </a:rPr>
+              <a:t>Inicio de la visita de supervisión ampliada</a:t>
+            </a:r>
+            <a:endParaRPr lang="en-US" sz="1400" dirty="0"/>
+          </a:p>
+        </p:txBody>
+      </p:sp>
+      <p:sp>
+        <p:nvSpPr>
+          <p:cNvPr id="22" name="Hito 4"/>
+          <p:cNvSpPr/>
+          <p:nvPr/>
+        </p:nvSpPr>
+        <p:spPr>
+          <a:xfrm>
+            <a:off x="1536192" y="3529584"/>
+            <a:ext cx="219456" cy="219456"/>
+          </a:xfrm>
+          <a:prstGeom prst="ellipse">
+            <a:avLst/>
+          </a:prstGeom>
+          <a:solidFill>
+            <a:schemeClr val="bg1"/>
+          </a:solidFill>
+          <a:ln w="31750">
+            <a:solidFill>
+              <a:schemeClr val="accent2"/>
+            </a:solidFill>
+            <a:prstDash val="solid"/>
+          </a:ln>
+        </p:spPr>
+      </p:sp>
+      <p:sp>
+        <p:nvSpPr>
+          <p:cNvPr id="23" name="Hito fecha 4"/>
+          <p:cNvSpPr txBox="1"/>
+          <p:nvPr/>
+        </p:nvSpPr>
+        <p:spPr>
+          <a:xfrm>
+            <a:off x="1965960" y="3493008"/>
+            <a:ext cx="4572000" cy="274320"/>
+          </a:xfrm>
+          <a:prstGeom prst="rect">
+            <a:avLst/>
+          </a:prstGeom>
+          <a:noFill/>
+          <a:ln/>
+        </p:spPr>
+        <p:txBody>
+          <a:bodyPr wrap="square" lIns="0" tIns="0" rIns="0" bIns="0" rtlCol="0" anchor="ctr"/>
+          <a:lstStyle/>
+          <a:p>
+            <a:pPr indent="0" marL="0">
+              <a:buNone/>
+            </a:pPr>
+            <a:r>
+              <a:rPr lang="en-US" sz="1150" b="1" dirty="0">
+                <a:solidFill>
+                  <a:schemeClr val="accent2"/>
+                </a:solidFill>
+                <a:latin typeface="Courier New" pitchFamily="34" charset="0"/>
+                <a:ea typeface="Courier New" pitchFamily="34" charset="-122"/>
+                <a:cs typeface="Courier New" pitchFamily="34" charset="-120"/>
+              </a:rPr>
+              <a:t>31 JUL 2026   </a:t>
+            </a:r>
+            <a:pPr indent="0" marL="0">
+              <a:buNone/>
+            </a:pPr>
+            <a:r>
+              <a:rPr lang="en-US" sz="1250" b="1" dirty="0">
+                <a:solidFill>
+                  <a:schemeClr val="tx1"/>
+                </a:solidFill>
+              </a:rPr>
+              <a:t>Nombramiento SSF · Nota 18432</a:t>
+            </a:r>
+            <a:endParaRPr lang="en-US" sz="1400" dirty="0"/>
+          </a:p>
+        </p:txBody>
+      </p:sp>
+      <p:sp>
+        <p:nvSpPr>
+          <p:cNvPr id="24" name="Hito detalle 4"/>
+          <p:cNvSpPr txBox="1"/>
+          <p:nvPr/>
+        </p:nvSpPr>
+        <p:spPr>
+          <a:xfrm>
+            <a:off x="1965960" y="3767328"/>
+            <a:ext cx="4572000" cy="228600"/>
+          </a:xfrm>
+          <a:prstGeom prst="rect">
+            <a:avLst/>
+          </a:prstGeom>
+          <a:noFill/>
+          <a:ln/>
+        </p:spPr>
+        <p:txBody>
+          <a:bodyPr wrap="square" lIns="0" tIns="0" rIns="0" bIns="0" rtlCol="0" anchor="t"/>
+          <a:lstStyle/>
+          <a:p>
+            <a:pPr indent="0" marL="0">
+              <a:buNone/>
+            </a:pPr>
+            <a:r>
+              <a:rPr lang="en-US" sz="1050" dirty="0">
+                <a:solidFill>
+                  <a:schemeClr val="accent5"/>
+                </a:solidFill>
+              </a:rPr>
+              <a:t>Visita con corte al 31/07/2026</a:t>
+            </a:r>
+            <a:endParaRPr lang="en-US" sz="1050" dirty="0"/>
+          </a:p>
+        </p:txBody>
+      </p:sp>
+      <p:sp>
+        <p:nvSpPr>
+          <p:cNvPr id="25" name="Hito 5"/>
+          <p:cNvSpPr/>
+          <p:nvPr/>
+        </p:nvSpPr>
+        <p:spPr>
+          <a:xfrm>
+            <a:off x="1536192" y="4407408"/>
+            <a:ext cx="219456" cy="219456"/>
+          </a:xfrm>
+          <a:prstGeom prst="ellipse">
+            <a:avLst/>
+          </a:prstGeom>
+          <a:solidFill>
+            <a:schemeClr val="bg1"/>
+          </a:solidFill>
+          <a:ln w="31750">
+            <a:solidFill>
+              <a:schemeClr val="accent1"/>
+            </a:solidFill>
+            <a:prstDash val="solid"/>
+          </a:ln>
+        </p:spPr>
+      </p:sp>
+      <p:sp>
+        <p:nvSpPr>
+          <p:cNvPr id="26" name="Hito fecha 5"/>
+          <p:cNvSpPr txBox="1"/>
+          <p:nvPr/>
+        </p:nvSpPr>
+        <p:spPr>
+          <a:xfrm>
+            <a:off x="1965960" y="4370832"/>
+            <a:ext cx="4572000" cy="274320"/>
+          </a:xfrm>
+          <a:prstGeom prst="rect">
+            <a:avLst/>
+          </a:prstGeom>
+          <a:noFill/>
+          <a:ln/>
+        </p:spPr>
+        <p:txBody>
+          <a:bodyPr wrap="square" lIns="0" tIns="0" rIns="0" bIns="0" rtlCol="0" anchor="ctr"/>
+          <a:lstStyle/>
+          <a:p>
+            <a:pPr indent="0" marL="0">
+              <a:buNone/>
+            </a:pPr>
+            <a:r>
+              <a:rPr lang="en-US" sz="1150" b="1" dirty="0">
+                <a:solidFill>
+                  <a:schemeClr val="accent1"/>
+                </a:solidFill>
+                <a:latin typeface="Courier New" pitchFamily="34" charset="0"/>
+                <a:ea typeface="Courier New" pitchFamily="34" charset="-122"/>
+                <a:cs typeface="Courier New" pitchFamily="34" charset="-120"/>
+              </a:rPr>
+              <a:t>05 NOV 2025   </a:t>
+            </a:r>
+            <a:pPr indent="0" marL="0">
+              <a:buNone/>
+            </a:pPr>
+            <a:r>
+              <a:rPr lang="en-US" sz="1250" b="1" dirty="0">
+                <a:solidFill>
+                  <a:schemeClr val="tx1"/>
+                </a:solidFill>
+              </a:rPr>
+              <a:t>Informe preliminar · Nota 17003</a:t>
+            </a:r>
+            <a:endParaRPr lang="en-US" sz="1400" dirty="0"/>
+          </a:p>
+        </p:txBody>
+      </p:sp>
+      <p:sp>
+        <p:nvSpPr>
+          <p:cNvPr id="27" name="Hito detalle 5"/>
+          <p:cNvSpPr txBox="1"/>
+          <p:nvPr/>
+        </p:nvSpPr>
+        <p:spPr>
+          <a:xfrm>
+            <a:off x="1965960" y="4645152"/>
+            <a:ext cx="4572000" cy="228600"/>
+          </a:xfrm>
+          <a:prstGeom prst="rect">
+            <a:avLst/>
+          </a:prstGeom>
+          <a:noFill/>
+          <a:ln/>
+        </p:spPr>
+        <p:txBody>
+          <a:bodyPr wrap="square" lIns="0" tIns="0" rIns="0" bIns="0" rtlCol="0" anchor="t"/>
+          <a:lstStyle/>
+          <a:p>
+            <a:pPr indent="0" marL="0">
+              <a:buNone/>
+            </a:pPr>
+            <a:r>
+              <a:rPr lang="en-US" sz="1050" dirty="0">
+                <a:solidFill>
+                  <a:schemeClr val="accent5"/>
+                </a:solidFill>
+              </a:rPr>
+              <a:t>9 observaciones</a:t>
+            </a:r>
+            <a:endParaRPr lang="en-US" sz="1050" dirty="0"/>
+          </a:p>
+        </p:txBody>
+      </p:sp>
+      <p:sp>
+        <p:nvSpPr>
+          <p:cNvPr id="28" name="Hito 6"/>
+          <p:cNvSpPr/>
+          <p:nvPr/>
+        </p:nvSpPr>
+        <p:spPr>
+          <a:xfrm>
+            <a:off x="1536192" y="5084064"/>
+            <a:ext cx="219456" cy="219456"/>
+          </a:xfrm>
+          <a:prstGeom prst="ellipse">
+            <a:avLst/>
+          </a:prstGeom>
+          <a:solidFill>
+            <a:schemeClr val="bg1"/>
+          </a:solidFill>
+          <a:ln w="31750">
+            <a:solidFill>
+              <a:schemeClr val="accent1"/>
+            </a:solidFill>
+            <a:prstDash val="solid"/>
+          </a:ln>
+        </p:spPr>
+      </p:sp>
+      <p:sp>
+        <p:nvSpPr>
+          <p:cNvPr id="29" name="Hito fecha 6"/>
+          <p:cNvSpPr txBox="1"/>
+          <p:nvPr/>
+        </p:nvSpPr>
+        <p:spPr>
+          <a:xfrm>
+            <a:off x="1965960" y="5047488"/>
+            <a:ext cx="4572000" cy="274320"/>
+          </a:xfrm>
+          <a:prstGeom prst="rect">
+            <a:avLst/>
+          </a:prstGeom>
+          <a:noFill/>
+          <a:ln/>
+        </p:spPr>
+        <p:txBody>
+          <a:bodyPr wrap="square" lIns="0" tIns="0" rIns="0" bIns="0" rtlCol="0" anchor="ctr"/>
+          <a:lstStyle/>
+          <a:p>
+            <a:pPr indent="0" marL="0">
+              <a:buNone/>
+            </a:pPr>
+            <a:r>
+              <a:rPr lang="en-US" sz="1150" b="1" dirty="0">
+                <a:solidFill>
+                  <a:schemeClr val="accent1"/>
+                </a:solidFill>
+                <a:latin typeface="Courier New" pitchFamily="34" charset="0"/>
+                <a:ea typeface="Courier New" pitchFamily="34" charset="-122"/>
+                <a:cs typeface="Courier New" pitchFamily="34" charset="-120"/>
+              </a:rPr>
+              <a:t>19 MAY 2025   </a:t>
+            </a:r>
+            <a:pPr indent="0" marL="0">
+              <a:buNone/>
+            </a:pPr>
+            <a:r>
+              <a:rPr lang="en-US" sz="1250" b="1" dirty="0">
+                <a:solidFill>
+                  <a:schemeClr val="tx1"/>
+                </a:solidFill>
+              </a:rPr>
+              <a:t>Inicio formal de la visita en sitio</a:t>
+            </a:r>
+            <a:endParaRPr lang="en-US" sz="1400" dirty="0"/>
+          </a:p>
+        </p:txBody>
+      </p:sp>
+      <p:sp>
+        <p:nvSpPr>
+          <p:cNvPr id="30" name="Hito 7"/>
+          <p:cNvSpPr/>
+          <p:nvPr/>
+        </p:nvSpPr>
+        <p:spPr>
+          <a:xfrm>
+            <a:off x="1536192" y="5760720"/>
+            <a:ext cx="219456" cy="219456"/>
+          </a:xfrm>
+          <a:prstGeom prst="ellipse">
+            <a:avLst/>
+          </a:prstGeom>
+          <a:solidFill>
+            <a:schemeClr val="bg1"/>
+          </a:solidFill>
+          <a:ln w="31750">
+            <a:solidFill>
+              <a:schemeClr val="accent1"/>
+            </a:solidFill>
+            <a:prstDash val="solid"/>
+          </a:ln>
+        </p:spPr>
+      </p:sp>
+      <p:sp>
+        <p:nvSpPr>
+          <p:cNvPr id="31" name="Hito fecha 7"/>
+          <p:cNvSpPr txBox="1"/>
+          <p:nvPr/>
+        </p:nvSpPr>
+        <p:spPr>
+          <a:xfrm>
+            <a:off x="1965960" y="5724144"/>
+            <a:ext cx="4572000" cy="274320"/>
+          </a:xfrm>
+          <a:prstGeom prst="rect">
+            <a:avLst/>
+          </a:prstGeom>
+          <a:noFill/>
+          <a:ln/>
+        </p:spPr>
+        <p:txBody>
+          <a:bodyPr wrap="square" lIns="0" tIns="0" rIns="0" bIns="0" rtlCol="0" anchor="ctr"/>
+          <a:lstStyle/>
+          <a:p>
+            <a:pPr indent="0" marL="0">
+              <a:buNone/>
+            </a:pPr>
+            <a:r>
+              <a:rPr lang="en-US" sz="1150" b="1" dirty="0">
+                <a:solidFill>
+                  <a:schemeClr val="accent1"/>
+                </a:solidFill>
+                <a:latin typeface="Courier New" pitchFamily="34" charset="0"/>
+                <a:ea typeface="Courier New" pitchFamily="34" charset="-122"/>
+                <a:cs typeface="Courier New" pitchFamily="34" charset="-120"/>
+              </a:rPr>
+              <a:t>09 ABR 2025   </a:t>
+            </a:r>
+            <a:pPr indent="0" marL="0">
+              <a:buNone/>
+            </a:pPr>
+            <a:r>
+              <a:rPr lang="en-US" sz="1250" b="1" dirty="0">
+                <a:solidFill>
+                  <a:schemeClr val="tx1"/>
+                </a:solidFill>
+              </a:rPr>
+              <a:t>Nombramiento SSF · Nota 9337</a:t>
+            </a:r>
+            <a:endParaRPr lang="en-US" sz="1400" dirty="0"/>
+          </a:p>
+        </p:txBody>
+      </p:sp>
+      <p:sp>
+        <p:nvSpPr>
+          <p:cNvPr id="32" name="Hito detalle 7"/>
+          <p:cNvSpPr txBox="1"/>
+          <p:nvPr/>
+        </p:nvSpPr>
+        <p:spPr>
+          <a:xfrm>
+            <a:off x="1965960" y="5998464"/>
+            <a:ext cx="4572000" cy="228600"/>
+          </a:xfrm>
+          <a:prstGeom prst="rect">
+            <a:avLst/>
+          </a:prstGeom>
+          <a:noFill/>
+          <a:ln/>
+        </p:spPr>
+        <p:txBody>
+          <a:bodyPr wrap="square" lIns="0" tIns="0" rIns="0" bIns="0" rtlCol="0" anchor="t"/>
+          <a:lstStyle/>
+          <a:p>
+            <a:pPr indent="0" marL="0">
+              <a:buNone/>
+            </a:pPr>
+            <a:r>
+              <a:rPr lang="en-US" sz="1050" dirty="0">
+                <a:solidFill>
+                  <a:schemeClr val="accent5"/>
+                </a:solidFill>
+              </a:rPr>
+              <a:t>Visita con corte al 30/04/2025</a:t>
+            </a:r>
+            <a:endParaRPr lang="en-US" sz="1050" dirty="0"/>
+          </a:p>
+        </p:txBody>
+      </p:sp>
+      <p:sp>
+        <p:nvSpPr>
+          <p:cNvPr id="33" name="Detalle 2026"/>
+          <p:cNvSpPr/>
+          <p:nvPr/>
+        </p:nvSpPr>
+        <p:spPr>
+          <a:xfrm>
+            <a:off x="6720840" y="1325880"/>
+            <a:ext cx="4922215" cy="1298448"/>
+          </a:xfrm>
+          <a:prstGeom prst="roundRect">
+            <a:avLst>
+              <a:gd name="adj" fmla="val 7042"/>
+            </a:avLst>
+          </a:prstGeom>
+          <a:solidFill>
+            <a:schemeClr val="accent2">
+              <a:alpha val="12000"/>
+            </a:schemeClr>
+          </a:solidFill>
           <a:ln w="12700">
             <a:solidFill>
-              <a:schemeClr val="bg1">
+              <a:schemeClr val="accent2">
                 <a:alpha val="0"/>
               </a:schemeClr>
             </a:solidFill>
@@ -9467,14 +9289,14 @@
       </p:sp>
       <p:sp>
         <p:nvSpPr>
-          <p:cNvPr id="38" name="Detalle título 2026"/>
-          <p:cNvSpPr txBox="1"/>
-          <p:nvPr/>
-        </p:nvSpPr>
-        <p:spPr>
-          <a:xfrm>
-            <a:off x="9689440" y="2240280"/>
-            <a:ext cx="1606144" cy="274320"/>
+          <p:cNvPr id="34" name="Detalle 2026 título"/>
+          <p:cNvSpPr txBox="1"/>
+          <p:nvPr/>
+        </p:nvSpPr>
+        <p:spPr>
+          <a:xfrm>
+            <a:off x="6903720" y="1435608"/>
+            <a:ext cx="4556455" cy="256032"/>
           </a:xfrm>
           <a:prstGeom prst="rect">
             <a:avLst/>
@@ -9490,27 +9312,178 @@
               <a:buNone/>
             </a:pPr>
             <a:r>
-              <a:rPr lang="en-US" sz="1250" b="1" dirty="0">
+              <a:rPr lang="en-US" sz="1300" b="1" dirty="0">
                 <a:solidFill>
                   <a:schemeClr val="accent2"/>
                 </a:solidFill>
               </a:rPr>
-              <a:t>Resultado y plazos 2026</a:t>
-            </a:r>
-            <a:endParaRPr lang="en-US" sz="1250" dirty="0"/>
-          </a:p>
-        </p:txBody>
-      </p:sp>
-      <p:sp>
-        <p:nvSpPr>
-          <p:cNvPr id="39" name="Detalle lista 2026"/>
-          <p:cNvSpPr txBox="1"/>
-          <p:nvPr/>
-        </p:nvSpPr>
-        <p:spPr>
-          <a:xfrm>
-            <a:off x="9689440" y="2587752"/>
-            <a:ext cx="1661008" cy="1554480"/>
+              <a:t>Resultado 2026 · Nota 22741</a:t>
+            </a:r>
+            <a:endParaRPr lang="en-US" sz="1300" dirty="0"/>
+          </a:p>
+        </p:txBody>
+      </p:sp>
+      <p:sp>
+        <p:nvSpPr>
+          <p:cNvPr id="35" name="Detalle 2026 texto"/>
+          <p:cNvSpPr txBox="1"/>
+          <p:nvPr/>
+        </p:nvSpPr>
+        <p:spPr>
+          <a:xfrm>
+            <a:off x="6903720" y="1755648"/>
+            <a:ext cx="4556455" cy="804672"/>
+          </a:xfrm>
+          <a:prstGeom prst="rect">
+            <a:avLst/>
+          </a:prstGeom>
+          <a:noFill/>
+          <a:ln/>
+        </p:spPr>
+        <p:txBody>
+          <a:bodyPr wrap="square" lIns="0" tIns="0" rIns="0" bIns="0" rtlCol="0" anchor="t"/>
+          <a:lstStyle/>
+          <a:p>
+            <a:pPr indent="0" marL="0">
+              <a:spcAft>
+                <a:spcPts val="300"/>
+              </a:spcAft>
+              <a:buNone/>
+            </a:pPr>
+            <a:r>
+              <a:rPr lang="en-US" sz="1150" b="1" dirty="0">
+                <a:solidFill>
+                  <a:schemeClr val="tx1"/>
+                </a:solidFill>
+              </a:rPr>
+              <a:t>Anexo A: </a:t>
+            </a:r>
+            <a:pPr indent="0" marL="0">
+              <a:spcAft>
+                <a:spcPts val="300"/>
+              </a:spcAft>
+              <a:buNone/>
+            </a:pPr>
+            <a:r>
+              <a:rPr lang="en-US" sz="1150" dirty="0">
+                <a:solidFill>
+                  <a:schemeClr val="tx1"/>
+                </a:solidFill>
+              </a:rPr>
+              <a:t>7 observaciones nuevas · descargos en 10 días hábiles</a:t>
+            </a:r>
+            <a:endParaRPr lang="en-US" sz="1150" dirty="0"/>
+          </a:p>
+          <a:p>
+            <a:pPr indent="0" marL="0">
+              <a:spcAft>
+                <a:spcPts val="300"/>
+              </a:spcAft>
+              <a:buNone/>
+            </a:pPr>
+            <a:r>
+              <a:rPr lang="en-US" sz="1150" b="1" dirty="0">
+                <a:solidFill>
+                  <a:schemeClr val="tx1"/>
+                </a:solidFill>
+              </a:rPr>
+              <a:t>Anexo B: </a:t>
+            </a:r>
+            <a:pPr indent="0" marL="0">
+              <a:spcAft>
+                <a:spcPts val="300"/>
+              </a:spcAft>
+              <a:buNone/>
+            </a:pPr>
+            <a:r>
+              <a:rPr lang="en-US" sz="1150" dirty="0">
+                <a:solidFill>
+                  <a:schemeClr val="tx1"/>
+                </a:solidFill>
+              </a:rPr>
+              <a:t>seguimiento a obs. 3 y 5 de 2025 · plan de solución en 15 días hábiles</a:t>
+            </a:r>
+            <a:endParaRPr lang="en-US" sz="1150" dirty="0"/>
+          </a:p>
+        </p:txBody>
+      </p:sp>
+      <p:sp>
+        <p:nvSpPr>
+          <p:cNvPr id="36" name="Detalle 2025"/>
+          <p:cNvSpPr/>
+          <p:nvPr/>
+        </p:nvSpPr>
+        <p:spPr>
+          <a:xfrm>
+            <a:off x="6720840" y="2761488"/>
+            <a:ext cx="4922215" cy="1143000"/>
+          </a:xfrm>
+          <a:prstGeom prst="roundRect">
+            <a:avLst>
+              <a:gd name="adj" fmla="val 8000"/>
+            </a:avLst>
+          </a:prstGeom>
+          <a:solidFill>
+            <a:schemeClr val="accent1">
+              <a:alpha val="12000"/>
+            </a:schemeClr>
+          </a:solidFill>
+          <a:ln w="12700">
+            <a:solidFill>
+              <a:schemeClr val="accent1">
+                <a:alpha val="0"/>
+              </a:schemeClr>
+            </a:solidFill>
+            <a:prstDash val="solid"/>
+          </a:ln>
+        </p:spPr>
+      </p:sp>
+      <p:sp>
+        <p:nvSpPr>
+          <p:cNvPr id="37" name="Detalle 2025 título"/>
+          <p:cNvSpPr txBox="1"/>
+          <p:nvPr/>
+        </p:nvSpPr>
+        <p:spPr>
+          <a:xfrm>
+            <a:off x="6903720" y="2871216"/>
+            <a:ext cx="4556455" cy="256032"/>
+          </a:xfrm>
+          <a:prstGeom prst="rect">
+            <a:avLst/>
+          </a:prstGeom>
+          <a:noFill/>
+          <a:ln/>
+        </p:spPr>
+        <p:txBody>
+          <a:bodyPr wrap="square" lIns="0" tIns="0" rIns="0" bIns="0" rtlCol="0" anchor="t"/>
+          <a:lstStyle/>
+          <a:p>
+            <a:pPr indent="0" marL="0">
+              <a:buNone/>
+            </a:pPr>
+            <a:r>
+              <a:rPr lang="en-US" sz="1300" b="1" dirty="0">
+                <a:solidFill>
+                  <a:schemeClr val="accent1"/>
+                </a:solidFill>
+              </a:rPr>
+              <a:t>Hallazgos críticos 2025 · Nota 17003</a:t>
+            </a:r>
+            <a:endParaRPr lang="en-US" sz="1300" dirty="0"/>
+          </a:p>
+        </p:txBody>
+      </p:sp>
+      <p:sp>
+        <p:nvSpPr>
+          <p:cNvPr id="38" name="Detalle 2025 texto"/>
+          <p:cNvSpPr txBox="1"/>
+          <p:nvPr/>
+        </p:nvSpPr>
+        <p:spPr>
+          <a:xfrm>
+            <a:off x="6903720" y="3182112"/>
+            <a:ext cx="4556455" cy="685800"/>
           </a:xfrm>
           <a:prstGeom prst="rect">
             <a:avLst/>
@@ -9524,64 +9497,90 @@
           <a:p>
             <a:pPr marL="342900" indent="-342900">
               <a:spcAft>
-                <a:spcPts val="400"/>
+                <a:spcPts val="100"/>
               </a:spcAft>
               <a:buSzPct val="100000"/>
               <a:buChar char="•"/>
             </a:pPr>
             <a:r>
-              <a:rPr lang="en-US" sz="1100" b="1" dirty="0">
+              <a:rPr lang="en-US" sz="1150" dirty="0">
                 <a:solidFill>
                   <a:schemeClr val="tx1"/>
                 </a:solidFill>
               </a:rPr>
-              <a:t>Anexo A: </a:t>
-            </a:r>
-            <a:pPr indent="0" marL="0">
-              <a:spcAft>
-                <a:spcPts val="400"/>
-              </a:spcAft>
-              <a:buNone/>
-            </a:pPr>
-            <a:r>
-              <a:rPr lang="en-US" sz="1100" dirty="0">
-                <a:solidFill>
-                  <a:schemeClr val="tx1"/>
-                </a:solidFill>
-              </a:rPr>
-              <a:t>7 observaciones nuevas · descargos en 10 días hábiles (aprox. 23/10/2026)</a:t>
-            </a:r>
-            <a:endParaRPr lang="en-US" sz="1100" dirty="0"/>
+              <a:t>Ausencia de Política de Operaciones Vinculadas</a:t>
+            </a:r>
+            <a:endParaRPr lang="en-US" sz="1150" dirty="0"/>
           </a:p>
           <a:p>
             <a:pPr marL="342900" indent="-342900">
               <a:spcAft>
-                <a:spcPts val="400"/>
+                <a:spcPts val="100"/>
               </a:spcAft>
               <a:buSzPct val="100000"/>
               <a:buChar char="•"/>
             </a:pPr>
             <a:r>
-              <a:rPr lang="en-US" sz="1100" b="1" dirty="0">
+              <a:rPr lang="en-US" sz="1150" dirty="0">
                 <a:solidFill>
                   <a:schemeClr val="tx1"/>
                 </a:solidFill>
               </a:rPr>
-              <a:t>Anexo B: </a:t>
-            </a:r>
-            <a:pPr indent="0" marL="0">
+              <a:t>Normativa interna desactualizada (9 documentos)</a:t>
+            </a:r>
+            <a:endParaRPr lang="en-US" sz="1150" dirty="0"/>
+          </a:p>
+          <a:p>
+            <a:pPr marL="342900" indent="-342900">
               <a:spcAft>
-                <a:spcPts val="400"/>
+                <a:spcPts val="100"/>
               </a:spcAft>
-              <a:buNone/>
-            </a:pPr>
-            <a:r>
-              <a:rPr lang="en-US" sz="1100" dirty="0">
+              <a:buSzPct val="100000"/>
+              <a:buChar char="•"/>
+            </a:pPr>
+            <a:r>
+              <a:rPr lang="en-US" sz="1150" dirty="0">
                 <a:solidFill>
                   <a:schemeClr val="tx1"/>
                 </a:solidFill>
               </a:rPr>
-              <a:t>seguimiento a obs. 3 y 5 de 2025 · plan de solución en 15 días hábiles (aprox. 30/10/2026)</a:t>
+              <a:t>Uso inapropiado del Fondo de Educación</a:t>
+            </a:r>
+            <a:endParaRPr lang="en-US" sz="1150" dirty="0"/>
+          </a:p>
+        </p:txBody>
+      </p:sp>
+      <p:sp>
+        <p:nvSpPr>
+          <p:cNvPr id="39" name="Evolución título"/>
+          <p:cNvSpPr txBox="1"/>
+          <p:nvPr/>
+        </p:nvSpPr>
+        <p:spPr>
+          <a:xfrm>
+            <a:off x="6720840" y="4041648"/>
+            <a:ext cx="4922215" cy="237744"/>
+          </a:xfrm>
+          <a:prstGeom prst="rect">
+            <a:avLst/>
+          </a:prstGeom>
+          <a:noFill/>
+          <a:ln/>
+        </p:spPr>
+        <p:txBody>
+          <a:bodyPr wrap="square" lIns="0" tIns="0" rIns="0" bIns="0" rtlCol="0" anchor="t"/>
+          <a:lstStyle/>
+          <a:p>
+            <a:pPr indent="0" marL="0">
+              <a:buNone/>
+            </a:pPr>
+            <a:r>
+              <a:rPr lang="en-US" sz="1100" b="1" spc="200" kern="0" dirty="0">
+                <a:solidFill>
+                  <a:schemeClr val="accent5"/>
+                </a:solidFill>
+              </a:rPr>
+              <a:t>SEGUIMIENTO A OBSERVACIONES 2025</a:t>
             </a:r>
             <a:endParaRPr lang="en-US" sz="1100" dirty="0"/>
           </a:p>
@@ -9589,54 +9588,18 @@
       </p:sp>
       <p:sp>
         <p:nvSpPr>
-          <p:cNvPr id="40" name="Evolución título"/>
-          <p:cNvSpPr txBox="1"/>
-          <p:nvPr/>
-        </p:nvSpPr>
-        <p:spPr>
-          <a:xfrm>
-            <a:off x="548640" y="4572000"/>
-            <a:ext cx="7315200" cy="237744"/>
-          </a:xfrm>
-          <a:prstGeom prst="rect">
-            <a:avLst/>
-          </a:prstGeom>
-          <a:noFill/>
-          <a:ln/>
-        </p:spPr>
-        <p:txBody>
-          <a:bodyPr wrap="square" lIns="0" tIns="0" rIns="0" bIns="0" rtlCol="0" anchor="t"/>
-          <a:lstStyle/>
-          <a:p>
-            <a:pPr indent="0" marL="0">
-              <a:buNone/>
-            </a:pPr>
-            <a:r>
-              <a:rPr lang="en-US" sz="1100" b="1" spc="200" kern="0" dirty="0">
-                <a:solidFill>
-                  <a:schemeClr val="accent5"/>
-                </a:solidFill>
-              </a:rPr>
-              <a:t>EVOLUCIÓN · SEGUIMIENTO A OBSERVACIONES 2025</a:t>
-            </a:r>
-            <a:endParaRPr lang="en-US" sz="1100" dirty="0"/>
-          </a:p>
-        </p:txBody>
-      </p:sp>
-      <p:sp>
-        <p:nvSpPr>
-          <p:cNvPr id="41" name="Evolución 1"/>
+          <p:cNvPr id="40" name="Evolución 1"/>
           <p:cNvSpPr/>
           <p:nvPr/>
         </p:nvSpPr>
         <p:spPr>
           <a:xfrm>
-            <a:off x="548640" y="4892040"/>
-            <a:ext cx="3576218" cy="1371600"/>
+            <a:off x="6720840" y="4343400"/>
+            <a:ext cx="4922215" cy="585216"/>
           </a:xfrm>
           <a:prstGeom prst="roundRect">
             <a:avLst>
-              <a:gd name="adj" fmla="val 6667"/>
+              <a:gd name="adj" fmla="val 15625"/>
             </a:avLst>
           </a:prstGeom>
           <a:solidFill>
@@ -9656,14 +9619,14 @@
       </p:sp>
       <p:sp>
         <p:nvSpPr>
-          <p:cNvPr id="42" name="Evolución estado 1 fondo"/>
+          <p:cNvPr id="41" name="Evolución estado 1 fondo"/>
           <p:cNvSpPr/>
           <p:nvPr/>
         </p:nvSpPr>
         <p:spPr>
           <a:xfrm>
-            <a:off x="731520" y="5047488"/>
-            <a:ext cx="1188720" cy="274320"/>
+            <a:off x="6858000" y="4498848"/>
+            <a:ext cx="2011680" cy="274320"/>
           </a:xfrm>
           <a:prstGeom prst="roundRect">
             <a:avLst>
@@ -9685,14 +9648,14 @@
       </p:sp>
       <p:sp>
         <p:nvSpPr>
-          <p:cNvPr id="43" name="Evolución estado 1"/>
-          <p:cNvSpPr txBox="1"/>
-          <p:nvPr/>
-        </p:nvSpPr>
-        <p:spPr>
-          <a:xfrm>
-            <a:off x="731520" y="5047488"/>
-            <a:ext cx="1188720" cy="274320"/>
+          <p:cNvPr id="42" name="Evolución estado 1"/>
+          <p:cNvSpPr txBox="1"/>
+          <p:nvPr/>
+        </p:nvSpPr>
+        <p:spPr>
+          <a:xfrm>
+            <a:off x="6858000" y="4498848"/>
+            <a:ext cx="2011680" cy="274320"/>
           </a:xfrm>
           <a:prstGeom prst="rect">
             <a:avLst/>
@@ -9708,103 +9671,103 @@
               <a:buNone/>
             </a:pPr>
             <a:r>
-              <a:rPr lang="en-US" sz="1050" b="1" spc="100" kern="0" dirty="0">
+              <a:rPr lang="en-US" sz="1000" b="1" spc="100" kern="0" dirty="0">
                 <a:solidFill>
                   <a:schemeClr val="bg1"/>
                 </a:solidFill>
               </a:rPr>
               <a:t>NO SUPERADA</a:t>
             </a:r>
+            <a:endParaRPr lang="en-US" sz="1000" dirty="0"/>
+          </a:p>
+        </p:txBody>
+      </p:sp>
+      <p:sp>
+        <p:nvSpPr>
+          <p:cNvPr id="43" name="Evolución tema 1"/>
+          <p:cNvSpPr txBox="1"/>
+          <p:nvPr/>
+        </p:nvSpPr>
+        <p:spPr>
+          <a:xfrm>
+            <a:off x="9006840" y="4416552"/>
+            <a:ext cx="2544775" cy="237744"/>
+          </a:xfrm>
+          <a:prstGeom prst="rect">
+            <a:avLst/>
+          </a:prstGeom>
+          <a:noFill/>
+          <a:ln/>
+        </p:spPr>
+        <p:txBody>
+          <a:bodyPr wrap="square" lIns="0" tIns="0" rIns="0" bIns="0" rtlCol="0" anchor="t"/>
+          <a:lstStyle/>
+          <a:p>
+            <a:pPr indent="0" marL="0">
+              <a:buNone/>
+            </a:pPr>
+            <a:r>
+              <a:rPr lang="en-US" sz="1200" b="1" dirty="0">
+                <a:solidFill>
+                  <a:schemeClr val="tx1"/>
+                </a:solidFill>
+              </a:rPr>
+              <a:t>Comités de Apoyo sin ejecutivos</a:t>
+            </a:r>
+            <a:endParaRPr lang="en-US" sz="1200" dirty="0"/>
+          </a:p>
+        </p:txBody>
+      </p:sp>
+      <p:sp>
+        <p:nvSpPr>
+          <p:cNvPr id="44" name="Evolución detalle 1"/>
+          <p:cNvSpPr txBox="1"/>
+          <p:nvPr/>
+        </p:nvSpPr>
+        <p:spPr>
+          <a:xfrm>
+            <a:off x="9006840" y="4654296"/>
+            <a:ext cx="2544775" cy="219456"/>
+          </a:xfrm>
+          <a:prstGeom prst="rect">
+            <a:avLst/>
+          </a:prstGeom>
+          <a:noFill/>
+          <a:ln/>
+        </p:spPr>
+        <p:txBody>
+          <a:bodyPr wrap="square" lIns="0" tIns="0" rIns="0" bIns="0" rtlCol="0" anchor="t"/>
+          <a:lstStyle/>
+          <a:p>
+            <a:pPr indent="0" marL="0">
+              <a:buNone/>
+            </a:pPr>
+            <a:r>
+              <a:rPr lang="en-US" sz="1050" dirty="0">
+                <a:solidFill>
+                  <a:schemeClr val="accent5"/>
+                </a:solidFill>
+              </a:rPr>
+              <a:t>Obs. 3 de 2025 · Anexo B</a:t>
+            </a:r>
             <a:endParaRPr lang="en-US" sz="1050" dirty="0"/>
           </a:p>
         </p:txBody>
       </p:sp>
       <p:sp>
         <p:nvSpPr>
-          <p:cNvPr id="44" name="Evolución tema 1"/>
-          <p:cNvSpPr txBox="1"/>
-          <p:nvPr/>
-        </p:nvSpPr>
-        <p:spPr>
-          <a:xfrm>
-            <a:off x="731520" y="5440680"/>
-            <a:ext cx="3210458" cy="274320"/>
-          </a:xfrm>
-          <a:prstGeom prst="rect">
-            <a:avLst/>
-          </a:prstGeom>
-          <a:noFill/>
-          <a:ln/>
-        </p:spPr>
-        <p:txBody>
-          <a:bodyPr wrap="square" lIns="0" tIns="0" rIns="0" bIns="0" rtlCol="0" anchor="t"/>
-          <a:lstStyle/>
-          <a:p>
-            <a:pPr indent="0" marL="0">
-              <a:buNone/>
-            </a:pPr>
-            <a:r>
-              <a:rPr lang="en-US" sz="1300" b="1" dirty="0">
-                <a:solidFill>
-                  <a:schemeClr val="tx1"/>
-                </a:solidFill>
-              </a:rPr>
-              <a:t>Comités de Apoyo sin personal ejecutivo</a:t>
-            </a:r>
-            <a:endParaRPr lang="en-US" sz="1300" dirty="0"/>
-          </a:p>
-        </p:txBody>
-      </p:sp>
-      <p:sp>
-        <p:nvSpPr>
-          <p:cNvPr id="45" name="Evolución detalle 1"/>
-          <p:cNvSpPr txBox="1"/>
-          <p:nvPr/>
-        </p:nvSpPr>
-        <p:spPr>
-          <a:xfrm>
-            <a:off x="731520" y="5742432"/>
-            <a:ext cx="3210458" cy="438912"/>
-          </a:xfrm>
-          <a:prstGeom prst="rect">
-            <a:avLst/>
-          </a:prstGeom>
-          <a:noFill/>
-          <a:ln/>
-        </p:spPr>
-        <p:txBody>
-          <a:bodyPr wrap="square" lIns="0" tIns="0" rIns="0" bIns="0" rtlCol="0" anchor="t"/>
-          <a:lstStyle/>
-          <a:p>
-            <a:pPr indent="0" marL="0">
-              <a:buNone/>
-            </a:pPr>
-            <a:r>
-              <a:rPr lang="en-US" sz="1050" dirty="0">
-                <a:solidFill>
-                  <a:schemeClr val="accent5"/>
-                </a:solidFill>
-              </a:rPr>
-              <a:t>Obs. 3 de 2025 · seguimiento en Anexo B 2026</a:t>
-            </a:r>
-            <a:endParaRPr lang="en-US" sz="1050" dirty="0"/>
-          </a:p>
-        </p:txBody>
-      </p:sp>
-      <p:sp>
-        <p:nvSpPr>
-          <p:cNvPr id="46" name="Evolución 2"/>
+          <p:cNvPr id="45" name="Evolución 2"/>
           <p:cNvSpPr/>
           <p:nvPr/>
         </p:nvSpPr>
         <p:spPr>
           <a:xfrm>
-            <a:off x="4307738" y="4892040"/>
-            <a:ext cx="3576218" cy="1371600"/>
+            <a:off x="6720840" y="5001768"/>
+            <a:ext cx="4922215" cy="585216"/>
           </a:xfrm>
           <a:prstGeom prst="roundRect">
             <a:avLst>
-              <a:gd name="adj" fmla="val 6667"/>
+              <a:gd name="adj" fmla="val 15625"/>
             </a:avLst>
           </a:prstGeom>
           <a:solidFill>
@@ -9824,14 +9787,14 @@
       </p:sp>
       <p:sp>
         <p:nvSpPr>
-          <p:cNvPr id="47" name="Evolución estado 2 fondo"/>
+          <p:cNvPr id="46" name="Evolución estado 2 fondo"/>
           <p:cNvSpPr/>
           <p:nvPr/>
         </p:nvSpPr>
         <p:spPr>
           <a:xfrm>
-            <a:off x="4490618" y="5047488"/>
-            <a:ext cx="2103120" cy="274320"/>
+            <a:off x="6858000" y="5157216"/>
+            <a:ext cx="2011680" cy="274320"/>
           </a:xfrm>
           <a:prstGeom prst="roundRect">
             <a:avLst>
@@ -9853,14 +9816,14 @@
       </p:sp>
       <p:sp>
         <p:nvSpPr>
-          <p:cNvPr id="48" name="Evolución estado 2"/>
-          <p:cNvSpPr txBox="1"/>
-          <p:nvPr/>
-        </p:nvSpPr>
-        <p:spPr>
-          <a:xfrm>
-            <a:off x="4490618" y="5047488"/>
-            <a:ext cx="2103120" cy="274320"/>
+          <p:cNvPr id="47" name="Evolución estado 2"/>
+          <p:cNvSpPr txBox="1"/>
+          <p:nvPr/>
+        </p:nvSpPr>
+        <p:spPr>
+          <a:xfrm>
+            <a:off x="6858000" y="5157216"/>
+            <a:ext cx="2011680" cy="274320"/>
           </a:xfrm>
           <a:prstGeom prst="rect">
             <a:avLst/>
@@ -9876,103 +9839,103 @@
               <a:buNone/>
             </a:pPr>
             <a:r>
-              <a:rPr lang="en-US" sz="1050" b="1" spc="100" kern="0" dirty="0">
+              <a:rPr lang="en-US" sz="1000" b="1" spc="100" kern="0" dirty="0">
                 <a:solidFill>
                   <a:schemeClr val="bg1"/>
                 </a:solidFill>
               </a:rPr>
               <a:t>PARCIALMENTE SUPERADA</a:t>
             </a:r>
+            <a:endParaRPr lang="en-US" sz="1000" dirty="0"/>
+          </a:p>
+        </p:txBody>
+      </p:sp>
+      <p:sp>
+        <p:nvSpPr>
+          <p:cNvPr id="48" name="Evolución tema 2"/>
+          <p:cNvSpPr txBox="1"/>
+          <p:nvPr/>
+        </p:nvSpPr>
+        <p:spPr>
+          <a:xfrm>
+            <a:off x="9006840" y="5074920"/>
+            <a:ext cx="2544775" cy="237744"/>
+          </a:xfrm>
+          <a:prstGeom prst="rect">
+            <a:avLst/>
+          </a:prstGeom>
+          <a:noFill/>
+          <a:ln/>
+        </p:spPr>
+        <p:txBody>
+          <a:bodyPr wrap="square" lIns="0" tIns="0" rIns="0" bIns="0" rtlCol="0" anchor="t"/>
+          <a:lstStyle/>
+          <a:p>
+            <a:pPr indent="0" marL="0">
+              <a:buNone/>
+            </a:pPr>
+            <a:r>
+              <a:rPr lang="en-US" sz="1200" b="1" dirty="0">
+                <a:solidFill>
+                  <a:schemeClr val="tx1"/>
+                </a:solidFill>
+              </a:rPr>
+              <a:t>Normativa interna desactualizada</a:t>
+            </a:r>
+            <a:endParaRPr lang="en-US" sz="1200" dirty="0"/>
+          </a:p>
+        </p:txBody>
+      </p:sp>
+      <p:sp>
+        <p:nvSpPr>
+          <p:cNvPr id="49" name="Evolución detalle 2"/>
+          <p:cNvSpPr txBox="1"/>
+          <p:nvPr/>
+        </p:nvSpPr>
+        <p:spPr>
+          <a:xfrm>
+            <a:off x="9006840" y="5312664"/>
+            <a:ext cx="2544775" cy="219456"/>
+          </a:xfrm>
+          <a:prstGeom prst="rect">
+            <a:avLst/>
+          </a:prstGeom>
+          <a:noFill/>
+          <a:ln/>
+        </p:spPr>
+        <p:txBody>
+          <a:bodyPr wrap="square" lIns="0" tIns="0" rIns="0" bIns="0" rtlCol="0" anchor="t"/>
+          <a:lstStyle/>
+          <a:p>
+            <a:pPr indent="0" marL="0">
+              <a:buNone/>
+            </a:pPr>
+            <a:r>
+              <a:rPr lang="en-US" sz="1050" dirty="0">
+                <a:solidFill>
+                  <a:schemeClr val="accent5"/>
+                </a:solidFill>
+              </a:rPr>
+              <a:t>Obs. 5 de 2025 · Anexo B</a:t>
+            </a:r>
             <a:endParaRPr lang="en-US" sz="1050" dirty="0"/>
           </a:p>
         </p:txBody>
       </p:sp>
       <p:sp>
         <p:nvSpPr>
-          <p:cNvPr id="49" name="Evolución tema 2"/>
-          <p:cNvSpPr txBox="1"/>
-          <p:nvPr/>
-        </p:nvSpPr>
-        <p:spPr>
-          <a:xfrm>
-            <a:off x="4490618" y="5440680"/>
-            <a:ext cx="3210458" cy="274320"/>
-          </a:xfrm>
-          <a:prstGeom prst="rect">
-            <a:avLst/>
-          </a:prstGeom>
-          <a:noFill/>
-          <a:ln/>
-        </p:spPr>
-        <p:txBody>
-          <a:bodyPr wrap="square" lIns="0" tIns="0" rIns="0" bIns="0" rtlCol="0" anchor="t"/>
-          <a:lstStyle/>
-          <a:p>
-            <a:pPr indent="0" marL="0">
-              <a:buNone/>
-            </a:pPr>
-            <a:r>
-              <a:rPr lang="en-US" sz="1300" b="1" dirty="0">
-                <a:solidFill>
-                  <a:schemeClr val="tx1"/>
-                </a:solidFill>
-              </a:rPr>
-              <a:t>Normativa interna desactualizada</a:t>
-            </a:r>
-            <a:endParaRPr lang="en-US" sz="1300" dirty="0"/>
-          </a:p>
-        </p:txBody>
-      </p:sp>
-      <p:sp>
-        <p:nvSpPr>
-          <p:cNvPr id="50" name="Evolución detalle 2"/>
-          <p:cNvSpPr txBox="1"/>
-          <p:nvPr/>
-        </p:nvSpPr>
-        <p:spPr>
-          <a:xfrm>
-            <a:off x="4490618" y="5742432"/>
-            <a:ext cx="3210458" cy="438912"/>
-          </a:xfrm>
-          <a:prstGeom prst="rect">
-            <a:avLst/>
-          </a:prstGeom>
-          <a:noFill/>
-          <a:ln/>
-        </p:spPr>
-        <p:txBody>
-          <a:bodyPr wrap="square" lIns="0" tIns="0" rIns="0" bIns="0" rtlCol="0" anchor="t"/>
-          <a:lstStyle/>
-          <a:p>
-            <a:pPr indent="0" marL="0">
-              <a:buNone/>
-            </a:pPr>
-            <a:r>
-              <a:rPr lang="en-US" sz="1050" dirty="0">
-                <a:solidFill>
-                  <a:schemeClr val="accent5"/>
-                </a:solidFill>
-              </a:rPr>
-              <a:t>Obs. 5 de 2025 · seguimiento en Anexo B 2026 (RIT, Auditoría, Compras)</a:t>
-            </a:r>
-            <a:endParaRPr lang="en-US" sz="1050" dirty="0"/>
-          </a:p>
-        </p:txBody>
-      </p:sp>
-      <p:sp>
-        <p:nvSpPr>
-          <p:cNvPr id="51" name="Evolución 3"/>
+          <p:cNvPr id="50" name="Evolución 3"/>
           <p:cNvSpPr/>
           <p:nvPr/>
         </p:nvSpPr>
         <p:spPr>
           <a:xfrm>
-            <a:off x="8066837" y="4892040"/>
-            <a:ext cx="3576218" cy="1371600"/>
+            <a:off x="6720840" y="5660136"/>
+            <a:ext cx="4922215" cy="585216"/>
           </a:xfrm>
           <a:prstGeom prst="roundRect">
             <a:avLst>
-              <a:gd name="adj" fmla="val 6667"/>
+              <a:gd name="adj" fmla="val 15625"/>
             </a:avLst>
           </a:prstGeom>
           <a:solidFill>
@@ -9992,14 +9955,14 @@
       </p:sp>
       <p:sp>
         <p:nvSpPr>
-          <p:cNvPr id="52" name="Evolución estado 3 fondo"/>
+          <p:cNvPr id="51" name="Evolución estado 3 fondo"/>
           <p:cNvSpPr/>
           <p:nvPr/>
         </p:nvSpPr>
         <p:spPr>
           <a:xfrm>
-            <a:off x="8249717" y="5047488"/>
-            <a:ext cx="2103120" cy="274320"/>
+            <a:off x="6858000" y="5815584"/>
+            <a:ext cx="2011680" cy="274320"/>
           </a:xfrm>
           <a:prstGeom prst="roundRect">
             <a:avLst>
@@ -10021,14 +9984,14 @@
       </p:sp>
       <p:sp>
         <p:nvSpPr>
-          <p:cNvPr id="53" name="Evolución estado 3"/>
-          <p:cNvSpPr txBox="1"/>
-          <p:nvPr/>
-        </p:nvSpPr>
-        <p:spPr>
-          <a:xfrm>
-            <a:off x="8249717" y="5047488"/>
-            <a:ext cx="2103120" cy="274320"/>
+          <p:cNvPr id="52" name="Evolución estado 3"/>
+          <p:cNvSpPr txBox="1"/>
+          <p:nvPr/>
+        </p:nvSpPr>
+        <p:spPr>
+          <a:xfrm>
+            <a:off x="6858000" y="5815584"/>
+            <a:ext cx="2011680" cy="274320"/>
           </a:xfrm>
           <a:prstGeom prst="rect">
             <a:avLst/>
@@ -10044,27 +10007,27 @@
               <a:buNone/>
             </a:pPr>
             <a:r>
-              <a:rPr lang="en-US" sz="1050" b="1" spc="100" kern="0" dirty="0">
+              <a:rPr lang="en-US" sz="1000" b="1" spc="100" kern="0" dirty="0">
                 <a:solidFill>
                   <a:schemeClr val="bg1"/>
                 </a:solidFill>
               </a:rPr>
               <a:t>MISMO TEMA · NUEVAS</a:t>
             </a:r>
-            <a:endParaRPr lang="en-US" sz="1050" dirty="0"/>
-          </a:p>
-        </p:txBody>
-      </p:sp>
-      <p:sp>
-        <p:nvSpPr>
-          <p:cNvPr id="54" name="Evolución tema 3"/>
-          <p:cNvSpPr txBox="1"/>
-          <p:nvPr/>
-        </p:nvSpPr>
-        <p:spPr>
-          <a:xfrm>
-            <a:off x="8249717" y="5440680"/>
-            <a:ext cx="3210458" cy="274320"/>
+            <a:endParaRPr lang="en-US" sz="1000" dirty="0"/>
+          </a:p>
+        </p:txBody>
+      </p:sp>
+      <p:sp>
+        <p:nvSpPr>
+          <p:cNvPr id="53" name="Evolución tema 3"/>
+          <p:cNvSpPr txBox="1"/>
+          <p:nvPr/>
+        </p:nvSpPr>
+        <p:spPr>
+          <a:xfrm>
+            <a:off x="9006840" y="5733288"/>
+            <a:ext cx="2544775" cy="237744"/>
           </a:xfrm>
           <a:prstGeom prst="rect">
             <a:avLst/>
@@ -10080,27 +10043,27 @@
               <a:buNone/>
             </a:pPr>
             <a:r>
-              <a:rPr lang="en-US" sz="1300" b="1" dirty="0">
+              <a:rPr lang="en-US" sz="1200" b="1" dirty="0">
                 <a:solidFill>
                   <a:schemeClr val="tx1"/>
                 </a:solidFill>
               </a:rPr>
               <a:t>Fondo de Educación</a:t>
             </a:r>
-            <a:endParaRPr lang="en-US" sz="1300" dirty="0"/>
-          </a:p>
-        </p:txBody>
-      </p:sp>
-      <p:sp>
-        <p:nvSpPr>
-          <p:cNvPr id="55" name="Evolución detalle 3"/>
-          <p:cNvSpPr txBox="1"/>
-          <p:nvPr/>
-        </p:nvSpPr>
-        <p:spPr>
-          <a:xfrm>
-            <a:off x="8249717" y="5742432"/>
-            <a:ext cx="3210458" cy="438912"/>
+            <a:endParaRPr lang="en-US" sz="1200" dirty="0"/>
+          </a:p>
+        </p:txBody>
+      </p:sp>
+      <p:sp>
+        <p:nvSpPr>
+          <p:cNvPr id="54" name="Evolución detalle 3"/>
+          <p:cNvSpPr txBox="1"/>
+          <p:nvPr/>
+        </p:nvSpPr>
+        <p:spPr>
+          <a:xfrm>
+            <a:off x="9006840" y="5971032"/>
+            <a:ext cx="2544775" cy="219456"/>
           </a:xfrm>
           <a:prstGeom prst="rect">
             <a:avLst/>
@@ -10121,7 +10084,7 @@
                   <a:schemeClr val="accent5"/>
                 </a:solidFill>
               </a:rPr>
-              <a:t>No es seguimiento: obs. 6 y 7 de 2026 son nuevas (Anexo A), mismo tema de la obs. 9 de 2025</a:t>
+              <a:t>Obs. 6 y 7 nuevas · no es seguimiento</a:t>
             </a:r>
             <a:endParaRPr lang="en-US" sz="1050" dirty="0"/>
           </a:p>

</xml_diff>

<commit_message>
Use 'Circular' naming, take responsables only from the SSF circulars, redesign summary cards
Co-Authored-By: Claude Opus 5.5 <noreply@anthropic.com>
Claude-Session: https://claude.ai/code/session_01F1WXR13Nv8neEtLhaK3ELa
</commit_message>
<xml_diff>
--- a/supervision-gobierno-corporativo/Supervision_GC_SSF_COMEDICA_2025-2026.pptx
+++ b/supervision-gobierno-corporativo/Supervision_GC_SSF_COMEDICA_2025-2026.pptx
@@ -110,22 +110,22 @@
   <p:extLst>
     <p:ext uri="{521415D9-36F7-43E2-AB2F-B90AF26B5E84}">
       <p14:sectionLst xmlns:p14="http://schemas.microsoft.com/office/powerpoint/2010/main">
-        <p14:section name="1 · Resumen de notas SSF" id="{33e2959b-55c3-7a5d-d500-a90e1161012b}">
+        <p14:section name="1 · Resumen de circulares SSF" id="{9c9cef2f-96c7-da3e-9de2-93f489c33286}">
           <p14:sldIdLst>
             <p14:sldId id="256"/>
           </p14:sldIdLst>
         </p14:section>
-        <p14:section name="2 · Observaciones 2025" id="{0162c1be-d6ef-56b3-1f48-41d080df8b7a}">
+        <p14:section name="2 · Observaciones 2025" id="{2cd61f1b-0b52-671a-8a9b-6f782ce87562}">
           <p14:sldIdLst>
             <p14:sldId id="257"/>
           </p14:sldIdLst>
         </p14:section>
-        <p14:section name="3 · Observaciones 2026" id="{341ec66c-ada8-9e87-b474-b87abfc899fa}">
+        <p14:section name="3 · Observaciones 2026" id="{c593cf52-04da-3b88-9970-b33b87bbea4d}">
           <p14:sldIdLst>
             <p14:sldId id="258"/>
           </p14:sldIdLst>
         </p14:section>
-        <p14:section name="4 · Línea de tiempo y evolución" id="{6bfa256d-dff9-87c0-5fcc-c0f901ea8dc0}">
+        <p14:section name="4 · Línea de tiempo y evolución" id="{d63d6be1-b406-d975-6c3e-5cf951955212}">
           <p14:sldIdLst>
             <p14:sldId id="259"/>
           </p14:sldIdLst>
@@ -534,7 +534,7 @@
           <a:p>
             <a:r>
               <a:rPr lang="en-US" dirty="0"/>
-              <a:t>Cuatro comunicados oficiales. Cada año la SSF primero notifica el nombramiento de la visita ampliada y luego remite el informe de resultados preliminares. 2025: 9 observaciones. 2026: 7 observaciones nuevas (Anexo A) y seguimiento a 2 de las 9 observaciones de 2025 (Anexo B): la obs. 3 no superada y la obs. 5 parcialmente superada.</a:t>
+              <a:t>Cuatro circulares de la SSF. Cada año la SSF primero notifica el nombramiento de la visita ampliada y luego remite los resultados preliminares. 2025: Circular 17003 con 9 observaciones. 2026: Circular 22741 con 7 observaciones nuevas (Anexo A) y seguimiento a 2 de las 9 observaciones de 2025 (Anexo B): la obs. 3 no superada y la obs. 5 parcialmente superada.</a:t>
             </a:r>
             <a:endParaRPr lang="en-US" dirty="0"/>
           </a:p>
@@ -622,7 +622,7 @@
           <a:p>
             <a:r>
               <a:rPr lang="en-US" dirty="0"/>
-              <a:t>Nueve observaciones de la Nota 17003. En rojo y ámbar, las 2 observaciones a las que la SSF dio seguimiento en la visita 2026 (Anexo B): obs. 3 comités sin ejecutivos (no superada) y obs. 5 normativa desactualizada (parcialmente superada).</a:t>
+              <a:t>Nueve observaciones de la Circular 17003. Los responsables son los órganos y cargos que señala la propia circular. En rojo y ámbar, las 2 observaciones a las que la SSF dio seguimiento en la visita 2026 (Anexo B): obs. 3 (no superada) y obs. 5 (parcialmente superada).</a:t>
             </a:r>
             <a:endParaRPr lang="en-US" dirty="0"/>
           </a:p>
@@ -710,7 +710,7 @@
           <a:p>
             <a:r>
               <a:rPr lang="en-US" dirty="0"/>
-              <a:t>Anexo A: siete observaciones nuevas; plazo de 10 días hábiles desde el día hábil siguiente a la recepción para remitir pruebas de descargo, previo conocimiento del Consejo de Administración. Anexo B: no son observaciones nuevas, es el seguimiento a las obs. 3 y 5 de 2025, que siguen abiertas; plan de solución en 15 días hábiles con acciones, responsable, plazo por acción y certificación del punto de acta del Consejo. Fechas aproximadas sin asuetos; validar con el Sistema de Control de Envíos.</a:t>
+              <a:t>Anexo A: siete observaciones nuevas; los responsables son los que señala la Circular 22741 (en la obs. 4 la circular no asigna un área específica). Plazo de 10 días hábiles para remitir pruebas de descargo, previo conocimiento del Consejo de Administración. Anexo B: no son observaciones nuevas, es el seguimiento a las obs. 3 y 5 de 2025; plan de solución en 15 días hábiles con acciones, responsable, plazo por acción y certificación del punto de acta del Consejo. Fechas aproximadas sin asuetos.</a:t>
             </a:r>
             <a:endParaRPr lang="en-US" dirty="0"/>
           </a:p>
@@ -1735,7 +1735,7 @@
                 <a:ea typeface="Cambria" pitchFamily="34" charset="-122"/>
                 <a:cs typeface="Cambria" pitchFamily="34" charset="-120"/>
               </a:rPr>
-              <a:t>Notas de notificación SSF 2025 – 2026</a:t>
+              <a:t>Circulares de notificación SSF 2025 – 2026</a:t>
             </a:r>
             <a:endParaRPr lang="en-US" sz="3000" dirty="0"/>
           </a:p>
@@ -1810,7 +1810,7 @@
                   <a:schemeClr val="bg2"/>
                 </a:solidFill>
               </a:rPr>
-              <a:t>notas oficiales recibidas</a:t>
+              <a:t>circulares recibidas de la SSF</a:t>
             </a:r>
             <a:endParaRPr lang="en-US" sz="1200" dirty="0"/>
           </a:p>
@@ -2049,8 +2049,8 @@
         </p:nvSpPr>
         <p:spPr>
           <a:xfrm>
-            <a:off x="4572000" y="502920"/>
-            <a:ext cx="1280160" cy="502920"/>
+            <a:off x="4572000" y="457200"/>
+            <a:ext cx="1188720" cy="502920"/>
           </a:xfrm>
           <a:prstGeom prst="rect">
             <a:avLst/>
@@ -2088,7 +2088,7 @@
         </p:nvSpPr>
         <p:spPr>
           <a:xfrm>
-            <a:off x="5897880" y="502920"/>
+            <a:off x="5806440" y="457200"/>
             <a:ext cx="3657600" cy="502920"/>
           </a:xfrm>
           <a:prstGeom prst="rect">
@@ -2110,7 +2110,7 @@
                   <a:schemeClr val="accent5"/>
                 </a:solidFill>
               </a:rPr>
-              <a:t>Visita 1 · corte 30/04/2025</a:t>
+              <a:t>Visita 1 · supervisión ampliada</a:t>
             </a:r>
             <a:endParaRPr lang="en-US" sz="1400" dirty="0"/>
           </a:p>
@@ -2124,12 +2124,12 @@
         </p:nvSpPr>
         <p:spPr>
           <a:xfrm>
-            <a:off x="4572000" y="1188720"/>
-            <a:ext cx="3261208" cy="1965960"/>
+            <a:off x="4572000" y="1097280"/>
+            <a:ext cx="3306928" cy="2103120"/>
           </a:xfrm>
           <a:prstGeom prst="roundRect">
             <a:avLst>
-              <a:gd name="adj" fmla="val 4651"/>
+              <a:gd name="adj" fmla="val 4348"/>
             </a:avLst>
           </a:prstGeom>
           <a:solidFill>
@@ -2145,17 +2145,19 @@
       </p:sp>
       <p:sp>
         <p:nvSpPr>
-          <p:cNvPr id="15" name="Paso 2025-1 círculo"/>
+          <p:cNvPr id="15" name="Fecha fondo 2025-1"/>
           <p:cNvSpPr/>
           <p:nvPr/>
         </p:nvSpPr>
         <p:spPr>
           <a:xfrm>
-            <a:off x="4800600" y="1417320"/>
-            <a:ext cx="365760" cy="365760"/>
-          </a:xfrm>
-          <a:prstGeom prst="ellipse">
-            <a:avLst/>
+            <a:off x="4709160" y="1234440"/>
+            <a:ext cx="914400" cy="1828800"/>
+          </a:xfrm>
+          <a:prstGeom prst="roundRect">
+            <a:avLst>
+              <a:gd name="adj" fmla="val 10000"/>
+            </a:avLst>
           </a:prstGeom>
           <a:solidFill>
             <a:schemeClr val="accent1"/>
@@ -2172,14 +2174,14 @@
       </p:sp>
       <p:sp>
         <p:nvSpPr>
-          <p:cNvPr id="16" name="Paso 2025-1"/>
-          <p:cNvSpPr txBox="1"/>
-          <p:nvPr/>
-        </p:nvSpPr>
-        <p:spPr>
-          <a:xfrm>
-            <a:off x="4800600" y="1417320"/>
-            <a:ext cx="365760" cy="365760"/>
+          <p:cNvPr id="16" name="Fecha día 2025-1"/>
+          <p:cNvSpPr txBox="1"/>
+          <p:nvPr/>
+        </p:nvSpPr>
+        <p:spPr>
+          <a:xfrm>
+            <a:off x="4709160" y="1463040"/>
+            <a:ext cx="914400" cy="548640"/>
           </a:xfrm>
           <a:prstGeom prst="rect">
             <a:avLst/>
@@ -2195,7 +2197,7 @@
               <a:buNone/>
             </a:pPr>
             <a:r>
-              <a:rPr lang="en-US" sz="1200" b="1" dirty="0">
+              <a:rPr lang="en-US" sz="3400" b="1" dirty="0">
                 <a:solidFill>
                   <a:schemeClr val="bg1"/>
                 </a:solidFill>
@@ -2203,7 +2205,79 @@
                 <a:ea typeface="Cambria" pitchFamily="34" charset="-122"/>
                 <a:cs typeface="Cambria" pitchFamily="34" charset="-120"/>
               </a:rPr>
-              <a:t>1</a:t>
+              <a:t>09</a:t>
+            </a:r>
+            <a:endParaRPr lang="en-US" sz="3400" dirty="0"/>
+          </a:p>
+        </p:txBody>
+      </p:sp>
+      <p:sp>
+        <p:nvSpPr>
+          <p:cNvPr id="17" name="Fecha mes 2025-1"/>
+          <p:cNvSpPr txBox="1"/>
+          <p:nvPr/>
+        </p:nvSpPr>
+        <p:spPr>
+          <a:xfrm>
+            <a:off x="4709160" y="2011680"/>
+            <a:ext cx="914400" cy="274320"/>
+          </a:xfrm>
+          <a:prstGeom prst="rect">
+            <a:avLst/>
+          </a:prstGeom>
+          <a:noFill/>
+          <a:ln/>
+        </p:spPr>
+        <p:txBody>
+          <a:bodyPr wrap="square" lIns="0" tIns="0" rIns="0" bIns="0" rtlCol="0" anchor="t"/>
+          <a:lstStyle/>
+          <a:p>
+            <a:pPr algn="ctr" indent="0" marL="0">
+              <a:buNone/>
+            </a:pPr>
+            <a:r>
+              <a:rPr lang="en-US" sz="1400" b="1" spc="200" kern="0" dirty="0">
+                <a:solidFill>
+                  <a:schemeClr val="bg1"/>
+                </a:solidFill>
+              </a:rPr>
+              <a:t>ABR</a:t>
+            </a:r>
+            <a:endParaRPr lang="en-US" sz="1400" dirty="0"/>
+          </a:p>
+        </p:txBody>
+      </p:sp>
+      <p:sp>
+        <p:nvSpPr>
+          <p:cNvPr id="18" name="Fecha año 2025-1"/>
+          <p:cNvSpPr txBox="1"/>
+          <p:nvPr/>
+        </p:nvSpPr>
+        <p:spPr>
+          <a:xfrm>
+            <a:off x="4709160" y="2286000"/>
+            <a:ext cx="914400" cy="274320"/>
+          </a:xfrm>
+          <a:prstGeom prst="rect">
+            <a:avLst/>
+          </a:prstGeom>
+          <a:noFill/>
+          <a:ln/>
+        </p:spPr>
+        <p:txBody>
+          <a:bodyPr wrap="square" lIns="0" tIns="0" rIns="0" bIns="0" rtlCol="0" anchor="t"/>
+          <a:lstStyle/>
+          <a:p>
+            <a:pPr algn="ctr" indent="0" marL="0">
+              <a:buNone/>
+            </a:pPr>
+            <a:r>
+              <a:rPr lang="en-US" sz="1200" dirty="0">
+                <a:solidFill>
+                  <a:schemeClr val="bg1"/>
+                </a:solidFill>
+              </a:rPr>
+              <a:t>2025</a:t>
             </a:r>
             <a:endParaRPr lang="en-US" sz="1200" dirty="0"/>
           </a:p>
@@ -2211,14 +2285,50 @@
       </p:sp>
       <p:sp>
         <p:nvSpPr>
-          <p:cNvPr id="17" name="Fecha 2025-1"/>
-          <p:cNvSpPr txBox="1"/>
-          <p:nvPr/>
-        </p:nvSpPr>
-        <p:spPr>
-          <a:xfrm>
-            <a:off x="5303520" y="1417320"/>
-            <a:ext cx="2346808" cy="365760"/>
+          <p:cNvPr id="19" name="Paso 2025-1"/>
+          <p:cNvSpPr txBox="1"/>
+          <p:nvPr/>
+        </p:nvSpPr>
+        <p:spPr>
+          <a:xfrm>
+            <a:off x="4709160" y="2697480"/>
+            <a:ext cx="914400" cy="228600"/>
+          </a:xfrm>
+          <a:prstGeom prst="rect">
+            <a:avLst/>
+          </a:prstGeom>
+          <a:noFill/>
+          <a:ln/>
+        </p:spPr>
+        <p:txBody>
+          <a:bodyPr wrap="square" lIns="0" tIns="0" rIns="0" bIns="0" rtlCol="0" anchor="t"/>
+          <a:lstStyle/>
+          <a:p>
+            <a:pPr algn="ctr" indent="0" marL="0">
+              <a:buNone/>
+            </a:pPr>
+            <a:r>
+              <a:rPr lang="en-US" sz="950" b="1" spc="100" kern="0" dirty="0">
+                <a:solidFill>
+                  <a:schemeClr val="bg1"/>
+                </a:solidFill>
+              </a:rPr>
+              <a:t>PASO 1 DE 2</a:t>
+            </a:r>
+            <a:endParaRPr lang="en-US" sz="950" dirty="0"/>
+          </a:p>
+        </p:txBody>
+      </p:sp>
+      <p:sp>
+        <p:nvSpPr>
+          <p:cNvPr id="20" name="Tipo 2025-1"/>
+          <p:cNvSpPr txBox="1"/>
+          <p:nvPr/>
+        </p:nvSpPr>
+        <p:spPr>
+          <a:xfrm>
+            <a:off x="5806440" y="1261872"/>
+            <a:ext cx="1935328" cy="502920"/>
           </a:xfrm>
           <a:prstGeom prst="rect">
             <a:avLst/>
@@ -2234,106 +2344,248 @@
               <a:buNone/>
             </a:pPr>
             <a:r>
-              <a:rPr lang="en-US" sz="1300" b="1" dirty="0">
+              <a:rPr lang="en-US" sz="1400" b="1" dirty="0">
+                <a:solidFill>
+                  <a:schemeClr val="tx1"/>
+                </a:solidFill>
+              </a:rPr>
+              <a:t>Nombramiento de visita ampliada</a:t>
+            </a:r>
+            <a:endParaRPr lang="en-US" sz="1400" dirty="0"/>
+          </a:p>
+        </p:txBody>
+      </p:sp>
+      <p:sp>
+        <p:nvSpPr>
+          <p:cNvPr id="21" name="Circular 2025-1"/>
+          <p:cNvSpPr txBox="1"/>
+          <p:nvPr/>
+        </p:nvSpPr>
+        <p:spPr>
+          <a:xfrm>
+            <a:off x="5806440" y="1828800"/>
+            <a:ext cx="1935328" cy="438912"/>
+          </a:xfrm>
+          <a:prstGeom prst="rect">
+            <a:avLst/>
+          </a:prstGeom>
+          <a:noFill/>
+          <a:ln/>
+        </p:spPr>
+        <p:txBody>
+          <a:bodyPr wrap="square" lIns="0" tIns="0" rIns="0" bIns="0" rtlCol="0" anchor="t"/>
+          <a:lstStyle/>
+          <a:p>
+            <a:pPr indent="0" marL="0">
+              <a:buNone/>
+            </a:pPr>
+            <a:r>
+              <a:rPr lang="en-US" sz="1000" dirty="0">
+                <a:solidFill>
+                  <a:schemeClr val="accent5"/>
+                </a:solidFill>
+              </a:rPr>
+              <a:t>Circular No.</a:t>
+            </a:r>
+            <a:endParaRPr lang="en-US" sz="1100" dirty="0"/>
+          </a:p>
+          <a:p>
+            <a:pPr indent="0" marL="0">
+              <a:buNone/>
+            </a:pPr>
+            <a:r>
+              <a:rPr lang="en-US" sz="1100" b="1" dirty="0">
                 <a:solidFill>
                   <a:schemeClr val="accent1"/>
                 </a:solidFill>
-                <a:latin typeface="Courier New" pitchFamily="34" charset="0"/>
-                <a:ea typeface="Courier New" pitchFamily="34" charset="-122"/>
-                <a:cs typeface="Courier New" pitchFamily="34" charset="-120"/>
-              </a:rPr>
-              <a:t>09/04/2025</a:t>
-            </a:r>
-            <a:endParaRPr lang="en-US" sz="1300" dirty="0"/>
-          </a:p>
-        </p:txBody>
-      </p:sp>
-      <p:sp>
-        <p:nvSpPr>
-          <p:cNvPr id="18" name="Tipo 2025-1"/>
-          <p:cNvSpPr txBox="1"/>
-          <p:nvPr/>
-        </p:nvSpPr>
-        <p:spPr>
-          <a:xfrm>
-            <a:off x="4800600" y="1920240"/>
-            <a:ext cx="2804008" cy="320040"/>
-          </a:xfrm>
-          <a:prstGeom prst="rect">
-            <a:avLst/>
-          </a:prstGeom>
-          <a:noFill/>
-          <a:ln/>
-        </p:spPr>
-        <p:txBody>
-          <a:bodyPr wrap="square" lIns="0" tIns="0" rIns="0" bIns="0" rtlCol="0" anchor="t"/>
-          <a:lstStyle/>
-          <a:p>
-            <a:pPr indent="0" marL="0">
-              <a:buNone/>
-            </a:pPr>
-            <a:r>
-              <a:rPr lang="en-US" sz="1500" b="1" dirty="0">
+              </a:rPr>
+              <a:t>DS-SABAO-BCS-BC-9337</a:t>
+            </a:r>
+            <a:endParaRPr lang="en-US" sz="1100" dirty="0"/>
+          </a:p>
+        </p:txBody>
+      </p:sp>
+      <p:sp>
+        <p:nvSpPr>
+          <p:cNvPr id="22" name="Separador 2025-1-0"/>
+          <p:cNvSpPr/>
+          <p:nvPr/>
+        </p:nvSpPr>
+        <p:spPr>
+          <a:xfrm>
+            <a:off x="5806440" y="2340864"/>
+            <a:ext cx="1935328" cy="0"/>
+          </a:xfrm>
+          <a:prstGeom prst="line">
+            <a:avLst/>
+          </a:prstGeom>
+          <a:noFill/>
+          <a:ln w="9525">
+            <a:solidFill>
+              <a:srgbClr val="D9E0EA"/>
+            </a:solidFill>
+            <a:prstDash val="solid"/>
+          </a:ln>
+        </p:spPr>
+      </p:sp>
+      <p:sp>
+        <p:nvSpPr>
+          <p:cNvPr id="23" name="Dato 2025-1-0"/>
+          <p:cNvSpPr txBox="1"/>
+          <p:nvPr/>
+        </p:nvSpPr>
+        <p:spPr>
+          <a:xfrm>
+            <a:off x="5806440" y="2377440"/>
+            <a:ext cx="1935328" cy="310896"/>
+          </a:xfrm>
+          <a:prstGeom prst="rect">
+            <a:avLst/>
+          </a:prstGeom>
+          <a:noFill/>
+          <a:ln/>
+        </p:spPr>
+        <p:txBody>
+          <a:bodyPr wrap="square" lIns="0" tIns="0" rIns="0" bIns="0" rtlCol="0" anchor="ctr"/>
+          <a:lstStyle/>
+          <a:p>
+            <a:pPr indent="0" marL="0">
+              <a:buNone/>
+            </a:pPr>
+            <a:r>
+              <a:rPr lang="en-US" sz="1150" dirty="0">
+                <a:solidFill>
+                  <a:schemeClr val="accent5"/>
+                </a:solidFill>
+              </a:rPr>
+              <a:t>Corte  </a:t>
+            </a:r>
+            <a:pPr indent="0" marL="0">
+              <a:buNone/>
+            </a:pPr>
+            <a:r>
+              <a:rPr lang="en-US" sz="1150" b="1" dirty="0">
                 <a:solidFill>
                   <a:schemeClr val="tx1"/>
                 </a:solidFill>
               </a:rPr>
-              <a:t>Nombramiento de visita ampliada</a:t>
-            </a:r>
-            <a:endParaRPr lang="en-US" sz="1500" dirty="0"/>
-          </a:p>
-        </p:txBody>
-      </p:sp>
-      <p:sp>
-        <p:nvSpPr>
-          <p:cNvPr id="19" name="Nota 2025-1"/>
-          <p:cNvSpPr txBox="1"/>
-          <p:nvPr/>
-        </p:nvSpPr>
-        <p:spPr>
-          <a:xfrm>
-            <a:off x="4800600" y="2258568"/>
-            <a:ext cx="2804008" cy="274320"/>
-          </a:xfrm>
-          <a:prstGeom prst="rect">
-            <a:avLst/>
-          </a:prstGeom>
-          <a:noFill/>
-          <a:ln/>
-        </p:spPr>
-        <p:txBody>
-          <a:bodyPr wrap="square" lIns="0" tIns="0" rIns="0" bIns="0" rtlCol="0" anchor="t"/>
-          <a:lstStyle/>
-          <a:p>
-            <a:pPr indent="0" marL="0">
-              <a:buNone/>
-            </a:pPr>
-            <a:r>
-              <a:rPr lang="en-US" sz="1200" dirty="0">
+              <a:t>30/04/2025</a:t>
+            </a:r>
+            <a:endParaRPr lang="en-US" sz="1150" dirty="0"/>
+          </a:p>
+        </p:txBody>
+      </p:sp>
+      <p:sp>
+        <p:nvSpPr>
+          <p:cNvPr id="24" name="Separador 2025-1-1"/>
+          <p:cNvSpPr/>
+          <p:nvPr/>
+        </p:nvSpPr>
+        <p:spPr>
+          <a:xfrm>
+            <a:off x="5806440" y="2706624"/>
+            <a:ext cx="1935328" cy="0"/>
+          </a:xfrm>
+          <a:prstGeom prst="line">
+            <a:avLst/>
+          </a:prstGeom>
+          <a:noFill/>
+          <a:ln w="9525">
+            <a:solidFill>
+              <a:srgbClr val="D9E0EA"/>
+            </a:solidFill>
+            <a:prstDash val="solid"/>
+          </a:ln>
+        </p:spPr>
+      </p:sp>
+      <p:sp>
+        <p:nvSpPr>
+          <p:cNvPr id="25" name="Dato 2025-1-1"/>
+          <p:cNvSpPr txBox="1"/>
+          <p:nvPr/>
+        </p:nvSpPr>
+        <p:spPr>
+          <a:xfrm>
+            <a:off x="5806440" y="2743200"/>
+            <a:ext cx="1935328" cy="310896"/>
+          </a:xfrm>
+          <a:prstGeom prst="rect">
+            <a:avLst/>
+          </a:prstGeom>
+          <a:noFill/>
+          <a:ln/>
+        </p:spPr>
+        <p:txBody>
+          <a:bodyPr wrap="square" lIns="0" tIns="0" rIns="0" bIns="0" rtlCol="0" anchor="ctr"/>
+          <a:lstStyle/>
+          <a:p>
+            <a:pPr indent="0" marL="0">
+              <a:buNone/>
+            </a:pPr>
+            <a:r>
+              <a:rPr lang="en-US" sz="1150" dirty="0">
                 <a:solidFill>
                   <a:schemeClr val="accent5"/>
                 </a:solidFill>
               </a:rPr>
-              <a:t>Nota No. DS-SABAO-BCS-BC-9337</a:t>
-            </a:r>
-            <a:endParaRPr lang="en-US" sz="1200" dirty="0"/>
-          </a:p>
-        </p:txBody>
-      </p:sp>
-      <p:sp>
-        <p:nvSpPr>
-          <p:cNvPr id="20" name="Detalle 2025-1 fondo"/>
+              <a:t>Inicio de visita  </a:t>
+            </a:r>
+            <a:pPr indent="0" marL="0">
+              <a:buNone/>
+            </a:pPr>
+            <a:r>
+              <a:rPr lang="en-US" sz="1150" b="1" dirty="0">
+                <a:solidFill>
+                  <a:schemeClr val="tx1"/>
+                </a:solidFill>
+              </a:rPr>
+              <a:t>19/05/2025</a:t>
+            </a:r>
+            <a:endParaRPr lang="en-US" sz="1150" dirty="0"/>
+          </a:p>
+        </p:txBody>
+      </p:sp>
+      <p:sp>
+        <p:nvSpPr>
+          <p:cNvPr id="26" name="Tarjeta 2025-2"/>
           <p:cNvSpPr/>
           <p:nvPr/>
         </p:nvSpPr>
         <p:spPr>
           <a:xfrm>
-            <a:off x="4800600" y="2651760"/>
-            <a:ext cx="2804008" cy="310896"/>
+            <a:off x="8336128" y="1097280"/>
+            <a:ext cx="3306928" cy="2103120"/>
           </a:xfrm>
           <a:prstGeom prst="roundRect">
             <a:avLst>
-              <a:gd name="adj" fmla="val 50000"/>
+              <a:gd name="adj" fmla="val 4348"/>
+            </a:avLst>
+          </a:prstGeom>
+          <a:solidFill>
+            <a:schemeClr val="bg1"/>
+          </a:solidFill>
+          <a:ln w="12700">
+            <a:solidFill>
+              <a:srgbClr val="D9E0EA"/>
+            </a:solidFill>
+            <a:prstDash val="solid"/>
+          </a:ln>
+        </p:spPr>
+      </p:sp>
+      <p:sp>
+        <p:nvSpPr>
+          <p:cNvPr id="27" name="Fecha fondo 2025-2"/>
+          <p:cNvSpPr/>
+          <p:nvPr/>
+        </p:nvSpPr>
+        <p:spPr>
+          <a:xfrm>
+            <a:off x="8473288" y="1234440"/>
+            <a:ext cx="914400" cy="1828800"/>
+          </a:xfrm>
+          <a:prstGeom prst="roundRect">
+            <a:avLst>
+              <a:gd name="adj" fmla="val 10000"/>
             </a:avLst>
           </a:prstGeom>
           <a:solidFill>
@@ -2351,14 +2603,14 @@
       </p:sp>
       <p:sp>
         <p:nvSpPr>
-          <p:cNvPr id="21" name="Detalle 2025-1"/>
-          <p:cNvSpPr txBox="1"/>
-          <p:nvPr/>
-        </p:nvSpPr>
-        <p:spPr>
-          <a:xfrm>
-            <a:off x="4800600" y="2651760"/>
-            <a:ext cx="2804008" cy="310896"/>
+          <p:cNvPr id="28" name="Fecha día 2025-2"/>
+          <p:cNvSpPr txBox="1"/>
+          <p:nvPr/>
+        </p:nvSpPr>
+        <p:spPr>
+          <a:xfrm>
+            <a:off x="8473288" y="1463040"/>
+            <a:ext cx="914400" cy="548640"/>
           </a:xfrm>
           <a:prstGeom prst="rect">
             <a:avLst/>
@@ -2374,37 +2626,230 @@
               <a:buNone/>
             </a:pPr>
             <a:r>
-              <a:rPr lang="en-US" sz="1100" b="1" spc="100" kern="0" dirty="0">
+              <a:rPr lang="en-US" sz="3400" b="1" dirty="0">
                 <a:solidFill>
                   <a:schemeClr val="bg1"/>
                 </a:solidFill>
-              </a:rPr>
-              <a:t>Corte 30/04/2025 · inicio 19/05/2025</a:t>
+                <a:latin typeface="Cambria" pitchFamily="34" charset="0"/>
+                <a:ea typeface="Cambria" pitchFamily="34" charset="-122"/>
+                <a:cs typeface="Cambria" pitchFamily="34" charset="-120"/>
+              </a:rPr>
+              <a:t>05</a:t>
+            </a:r>
+            <a:endParaRPr lang="en-US" sz="3400" dirty="0"/>
+          </a:p>
+        </p:txBody>
+      </p:sp>
+      <p:sp>
+        <p:nvSpPr>
+          <p:cNvPr id="29" name="Fecha mes 2025-2"/>
+          <p:cNvSpPr txBox="1"/>
+          <p:nvPr/>
+        </p:nvSpPr>
+        <p:spPr>
+          <a:xfrm>
+            <a:off x="8473288" y="2011680"/>
+            <a:ext cx="914400" cy="274320"/>
+          </a:xfrm>
+          <a:prstGeom prst="rect">
+            <a:avLst/>
+          </a:prstGeom>
+          <a:noFill/>
+          <a:ln/>
+        </p:spPr>
+        <p:txBody>
+          <a:bodyPr wrap="square" lIns="0" tIns="0" rIns="0" bIns="0" rtlCol="0" anchor="t"/>
+          <a:lstStyle/>
+          <a:p>
+            <a:pPr algn="ctr" indent="0" marL="0">
+              <a:buNone/>
+            </a:pPr>
+            <a:r>
+              <a:rPr lang="en-US" sz="1400" b="1" spc="200" kern="0" dirty="0">
+                <a:solidFill>
+                  <a:schemeClr val="bg1"/>
+                </a:solidFill>
+              </a:rPr>
+              <a:t>NOV</a:t>
+            </a:r>
+            <a:endParaRPr lang="en-US" sz="1400" dirty="0"/>
+          </a:p>
+        </p:txBody>
+      </p:sp>
+      <p:sp>
+        <p:nvSpPr>
+          <p:cNvPr id="30" name="Fecha año 2025-2"/>
+          <p:cNvSpPr txBox="1"/>
+          <p:nvPr/>
+        </p:nvSpPr>
+        <p:spPr>
+          <a:xfrm>
+            <a:off x="8473288" y="2286000"/>
+            <a:ext cx="914400" cy="274320"/>
+          </a:xfrm>
+          <a:prstGeom prst="rect">
+            <a:avLst/>
+          </a:prstGeom>
+          <a:noFill/>
+          <a:ln/>
+        </p:spPr>
+        <p:txBody>
+          <a:bodyPr wrap="square" lIns="0" tIns="0" rIns="0" bIns="0" rtlCol="0" anchor="t"/>
+          <a:lstStyle/>
+          <a:p>
+            <a:pPr algn="ctr" indent="0" marL="0">
+              <a:buNone/>
+            </a:pPr>
+            <a:r>
+              <a:rPr lang="en-US" sz="1200" dirty="0">
+                <a:solidFill>
+                  <a:schemeClr val="bg1"/>
+                </a:solidFill>
+              </a:rPr>
+              <a:t>2025</a:t>
+            </a:r>
+            <a:endParaRPr lang="en-US" sz="1200" dirty="0"/>
+          </a:p>
+        </p:txBody>
+      </p:sp>
+      <p:sp>
+        <p:nvSpPr>
+          <p:cNvPr id="31" name="Paso 2025-2"/>
+          <p:cNvSpPr txBox="1"/>
+          <p:nvPr/>
+        </p:nvSpPr>
+        <p:spPr>
+          <a:xfrm>
+            <a:off x="8473288" y="2697480"/>
+            <a:ext cx="914400" cy="228600"/>
+          </a:xfrm>
+          <a:prstGeom prst="rect">
+            <a:avLst/>
+          </a:prstGeom>
+          <a:noFill/>
+          <a:ln/>
+        </p:spPr>
+        <p:txBody>
+          <a:bodyPr wrap="square" lIns="0" tIns="0" rIns="0" bIns="0" rtlCol="0" anchor="t"/>
+          <a:lstStyle/>
+          <a:p>
+            <a:pPr algn="ctr" indent="0" marL="0">
+              <a:buNone/>
+            </a:pPr>
+            <a:r>
+              <a:rPr lang="en-US" sz="950" b="1" spc="100" kern="0" dirty="0">
+                <a:solidFill>
+                  <a:schemeClr val="bg1"/>
+                </a:solidFill>
+              </a:rPr>
+              <a:t>PASO 2 DE 2</a:t>
+            </a:r>
+            <a:endParaRPr lang="en-US" sz="950" dirty="0"/>
+          </a:p>
+        </p:txBody>
+      </p:sp>
+      <p:sp>
+        <p:nvSpPr>
+          <p:cNvPr id="32" name="Tipo 2025-2"/>
+          <p:cNvSpPr txBox="1"/>
+          <p:nvPr/>
+        </p:nvSpPr>
+        <p:spPr>
+          <a:xfrm>
+            <a:off x="9570568" y="1261872"/>
+            <a:ext cx="1935328" cy="502920"/>
+          </a:xfrm>
+          <a:prstGeom prst="rect">
+            <a:avLst/>
+          </a:prstGeom>
+          <a:noFill/>
+          <a:ln/>
+        </p:spPr>
+        <p:txBody>
+          <a:bodyPr wrap="square" lIns="0" tIns="0" rIns="0" bIns="0" rtlCol="0" anchor="ctr"/>
+          <a:lstStyle/>
+          <a:p>
+            <a:pPr indent="0" marL="0">
+              <a:buNone/>
+            </a:pPr>
+            <a:r>
+              <a:rPr lang="en-US" sz="1400" b="1" dirty="0">
+                <a:solidFill>
+                  <a:schemeClr val="tx1"/>
+                </a:solidFill>
+              </a:rPr>
+              <a:t>Resultados preliminares</a:t>
+            </a:r>
+            <a:endParaRPr lang="en-US" sz="1400" dirty="0"/>
+          </a:p>
+        </p:txBody>
+      </p:sp>
+      <p:sp>
+        <p:nvSpPr>
+          <p:cNvPr id="33" name="Circular 2025-2"/>
+          <p:cNvSpPr txBox="1"/>
+          <p:nvPr/>
+        </p:nvSpPr>
+        <p:spPr>
+          <a:xfrm>
+            <a:off x="9570568" y="1828800"/>
+            <a:ext cx="1935328" cy="438912"/>
+          </a:xfrm>
+          <a:prstGeom prst="rect">
+            <a:avLst/>
+          </a:prstGeom>
+          <a:noFill/>
+          <a:ln/>
+        </p:spPr>
+        <p:txBody>
+          <a:bodyPr wrap="square" lIns="0" tIns="0" rIns="0" bIns="0" rtlCol="0" anchor="t"/>
+          <a:lstStyle/>
+          <a:p>
+            <a:pPr indent="0" marL="0">
+              <a:buNone/>
+            </a:pPr>
+            <a:r>
+              <a:rPr lang="en-US" sz="1000" dirty="0">
+                <a:solidFill>
+                  <a:schemeClr val="accent5"/>
+                </a:solidFill>
+              </a:rPr>
+              <a:t>Circular No.</a:t>
             </a:r>
             <a:endParaRPr lang="en-US" sz="1100" dirty="0"/>
           </a:p>
-        </p:txBody>
-      </p:sp>
-      <p:sp>
-        <p:nvSpPr>
-          <p:cNvPr id="22" name="Tarjeta 2025-2"/>
+          <a:p>
+            <a:pPr indent="0" marL="0">
+              <a:buNone/>
+            </a:pPr>
+            <a:r>
+              <a:rPr lang="en-US" sz="1100" b="1" dirty="0">
+                <a:solidFill>
+                  <a:schemeClr val="accent1"/>
+                </a:solidFill>
+              </a:rPr>
+              <a:t>DS-SABAO-BCS-BC-17003</a:t>
+            </a:r>
+            <a:endParaRPr lang="en-US" sz="1100" dirty="0"/>
+          </a:p>
+        </p:txBody>
+      </p:sp>
+      <p:sp>
+        <p:nvSpPr>
+          <p:cNvPr id="34" name="Separador 2025-2-0"/>
           <p:cNvSpPr/>
           <p:nvPr/>
         </p:nvSpPr>
         <p:spPr>
           <a:xfrm>
-            <a:off x="8381848" y="1188720"/>
-            <a:ext cx="3261208" cy="1965960"/>
-          </a:xfrm>
-          <a:prstGeom prst="roundRect">
-            <a:avLst>
-              <a:gd name="adj" fmla="val 4651"/>
-            </a:avLst>
-          </a:prstGeom>
-          <a:solidFill>
-            <a:schemeClr val="bg1"/>
-          </a:solidFill>
-          <a:ln w="12700">
+            <a:off x="9570568" y="2340864"/>
+            <a:ext cx="1935328" cy="0"/>
+          </a:xfrm>
+          <a:prstGeom prst="line">
+            <a:avLst/>
+          </a:prstGeom>
+          <a:noFill/>
+          <a:ln w="9525">
             <a:solidFill>
               <a:srgbClr val="D9E0EA"/>
             </a:solidFill>
@@ -2414,16 +2859,133 @@
       </p:sp>
       <p:sp>
         <p:nvSpPr>
-          <p:cNvPr id="23" name="Paso 2025-2 círculo"/>
+          <p:cNvPr id="35" name="Dato 2025-2-0"/>
+          <p:cNvSpPr txBox="1"/>
+          <p:nvPr/>
+        </p:nvSpPr>
+        <p:spPr>
+          <a:xfrm>
+            <a:off x="9570568" y="2377440"/>
+            <a:ext cx="1935328" cy="310896"/>
+          </a:xfrm>
+          <a:prstGeom prst="rect">
+            <a:avLst/>
+          </a:prstGeom>
+          <a:noFill/>
+          <a:ln/>
+        </p:spPr>
+        <p:txBody>
+          <a:bodyPr wrap="square" lIns="0" tIns="0" rIns="0" bIns="0" rtlCol="0" anchor="ctr"/>
+          <a:lstStyle/>
+          <a:p>
+            <a:pPr indent="0" marL="0">
+              <a:buNone/>
+            </a:pPr>
+            <a:r>
+              <a:rPr lang="en-US" sz="1150" dirty="0">
+                <a:solidFill>
+                  <a:schemeClr val="accent5"/>
+                </a:solidFill>
+              </a:rPr>
+              <a:t>Resultado  </a:t>
+            </a:r>
+            <a:pPr indent="0" marL="0">
+              <a:buNone/>
+            </a:pPr>
+            <a:r>
+              <a:rPr lang="en-US" sz="1150" b="1" dirty="0">
+                <a:solidFill>
+                  <a:schemeClr val="tx1"/>
+                </a:solidFill>
+              </a:rPr>
+              <a:t>9 observaciones</a:t>
+            </a:r>
+            <a:endParaRPr lang="en-US" sz="1150" dirty="0"/>
+          </a:p>
+        </p:txBody>
+      </p:sp>
+      <p:sp>
+        <p:nvSpPr>
+          <p:cNvPr id="36" name="Separador 2025-2-1"/>
           <p:cNvSpPr/>
           <p:nvPr/>
         </p:nvSpPr>
         <p:spPr>
           <a:xfrm>
-            <a:off x="8610448" y="1417320"/>
-            <a:ext cx="365760" cy="365760"/>
-          </a:xfrm>
-          <a:prstGeom prst="ellipse">
+            <a:off x="9570568" y="2706624"/>
+            <a:ext cx="1935328" cy="0"/>
+          </a:xfrm>
+          <a:prstGeom prst="line">
+            <a:avLst/>
+          </a:prstGeom>
+          <a:noFill/>
+          <a:ln w="9525">
+            <a:solidFill>
+              <a:srgbClr val="D9E0EA"/>
+            </a:solidFill>
+            <a:prstDash val="solid"/>
+          </a:ln>
+        </p:spPr>
+      </p:sp>
+      <p:sp>
+        <p:nvSpPr>
+          <p:cNvPr id="37" name="Dato 2025-2-1"/>
+          <p:cNvSpPr txBox="1"/>
+          <p:nvPr/>
+        </p:nvSpPr>
+        <p:spPr>
+          <a:xfrm>
+            <a:off x="9570568" y="2743200"/>
+            <a:ext cx="1935328" cy="310896"/>
+          </a:xfrm>
+          <a:prstGeom prst="rect">
+            <a:avLst/>
+          </a:prstGeom>
+          <a:noFill/>
+          <a:ln/>
+        </p:spPr>
+        <p:txBody>
+          <a:bodyPr wrap="square" lIns="0" tIns="0" rIns="0" bIns="0" rtlCol="0" anchor="ctr"/>
+          <a:lstStyle/>
+          <a:p>
+            <a:pPr indent="0" marL="0">
+              <a:buNone/>
+            </a:pPr>
+            <a:r>
+              <a:rPr lang="en-US" sz="1150" dirty="0">
+                <a:solidFill>
+                  <a:schemeClr val="accent5"/>
+                </a:solidFill>
+              </a:rPr>
+              <a:t>Descargos  </a:t>
+            </a:r>
+            <a:pPr indent="0" marL="0">
+              <a:buNone/>
+            </a:pPr>
+            <a:r>
+              <a:rPr lang="en-US" sz="1150" b="1" dirty="0">
+                <a:solidFill>
+                  <a:schemeClr val="tx1"/>
+                </a:solidFill>
+              </a:rPr>
+              <a:t>10 días hábiles</a:t>
+            </a:r>
+            <a:endParaRPr lang="en-US" sz="1150" dirty="0"/>
+          </a:p>
+        </p:txBody>
+      </p:sp>
+      <p:sp>
+        <p:nvSpPr>
+          <p:cNvPr id="38" name="Flecha 2025"/>
+          <p:cNvSpPr/>
+          <p:nvPr/>
+        </p:nvSpPr>
+        <p:spPr>
+          <a:xfrm>
+            <a:off x="7970368" y="2011680"/>
+            <a:ext cx="274320" cy="274320"/>
+          </a:xfrm>
+          <a:prstGeom prst="rightArrow">
             <a:avLst/>
           </a:prstGeom>
           <a:solidFill>
@@ -2441,14 +3003,14 @@
       </p:sp>
       <p:sp>
         <p:nvSpPr>
-          <p:cNvPr id="24" name="Paso 2025-2"/>
-          <p:cNvSpPr txBox="1"/>
-          <p:nvPr/>
-        </p:nvSpPr>
-        <p:spPr>
-          <a:xfrm>
-            <a:off x="8610448" y="1417320"/>
-            <a:ext cx="365760" cy="365760"/>
+          <p:cNvPr id="39" name="Año 2026"/>
+          <p:cNvSpPr txBox="1"/>
+          <p:nvPr/>
+        </p:nvSpPr>
+        <p:spPr>
+          <a:xfrm>
+            <a:off x="4572000" y="3401568"/>
+            <a:ext cx="1188720" cy="502920"/>
           </a:xfrm>
           <a:prstGeom prst="rect">
             <a:avLst/>
@@ -2460,34 +3022,34 @@
           <a:bodyPr wrap="square" lIns="0" tIns="0" rIns="0" bIns="0" rtlCol="0" anchor="ctr"/>
           <a:lstStyle/>
           <a:p>
-            <a:pPr algn="ctr" indent="0" marL="0">
-              <a:buNone/>
-            </a:pPr>
-            <a:r>
-              <a:rPr lang="en-US" sz="1200" b="1" dirty="0">
-                <a:solidFill>
-                  <a:schemeClr val="bg1"/>
+            <a:pPr indent="0" marL="0">
+              <a:buNone/>
+            </a:pPr>
+            <a:r>
+              <a:rPr lang="en-US" sz="3000" b="1" dirty="0">
+                <a:solidFill>
+                  <a:schemeClr val="accent2"/>
                 </a:solidFill>
                 <a:latin typeface="Cambria" pitchFamily="34" charset="0"/>
                 <a:ea typeface="Cambria" pitchFamily="34" charset="-122"/>
                 <a:cs typeface="Cambria" pitchFamily="34" charset="-120"/>
               </a:rPr>
-              <a:t>2</a:t>
-            </a:r>
-            <a:endParaRPr lang="en-US" sz="1200" dirty="0"/>
-          </a:p>
-        </p:txBody>
-      </p:sp>
-      <p:sp>
-        <p:nvSpPr>
-          <p:cNvPr id="25" name="Fecha 2025-2"/>
-          <p:cNvSpPr txBox="1"/>
-          <p:nvPr/>
-        </p:nvSpPr>
-        <p:spPr>
-          <a:xfrm>
-            <a:off x="9113368" y="1417320"/>
-            <a:ext cx="2346808" cy="365760"/>
+              <a:t>2026</a:t>
+            </a:r>
+            <a:endParaRPr lang="en-US" sz="3000" dirty="0"/>
+          </a:p>
+        </p:txBody>
+      </p:sp>
+      <p:sp>
+        <p:nvSpPr>
+          <p:cNvPr id="40" name="Visita 2026"/>
+          <p:cNvSpPr txBox="1"/>
+          <p:nvPr/>
+        </p:nvSpPr>
+        <p:spPr>
+          <a:xfrm>
+            <a:off x="5806440" y="3401568"/>
+            <a:ext cx="3657600" cy="502920"/>
           </a:xfrm>
           <a:prstGeom prst="rect">
             <a:avLst/>
@@ -2503,273 +3065,31 @@
               <a:buNone/>
             </a:pPr>
             <a:r>
-              <a:rPr lang="en-US" sz="1300" b="1" dirty="0">
-                <a:solidFill>
-                  <a:schemeClr val="accent1"/>
-                </a:solidFill>
-                <a:latin typeface="Courier New" pitchFamily="34" charset="0"/>
-                <a:ea typeface="Courier New" pitchFamily="34" charset="-122"/>
-                <a:cs typeface="Courier New" pitchFamily="34" charset="-120"/>
-              </a:rPr>
-              <a:t>05/11/2025</a:t>
-            </a:r>
-            <a:endParaRPr lang="en-US" sz="1300" dirty="0"/>
-          </a:p>
-        </p:txBody>
-      </p:sp>
-      <p:sp>
-        <p:nvSpPr>
-          <p:cNvPr id="26" name="Tipo 2025-2"/>
-          <p:cNvSpPr txBox="1"/>
-          <p:nvPr/>
-        </p:nvSpPr>
-        <p:spPr>
-          <a:xfrm>
-            <a:off x="8610448" y="1920240"/>
-            <a:ext cx="2804008" cy="320040"/>
-          </a:xfrm>
-          <a:prstGeom prst="rect">
-            <a:avLst/>
-          </a:prstGeom>
-          <a:noFill/>
-          <a:ln/>
-        </p:spPr>
-        <p:txBody>
-          <a:bodyPr wrap="square" lIns="0" tIns="0" rIns="0" bIns="0" rtlCol="0" anchor="t"/>
-          <a:lstStyle/>
-          <a:p>
-            <a:pPr indent="0" marL="0">
-              <a:buNone/>
-            </a:pPr>
-            <a:r>
-              <a:rPr lang="en-US" sz="1500" b="1" dirty="0">
-                <a:solidFill>
-                  <a:schemeClr val="tx1"/>
-                </a:solidFill>
-              </a:rPr>
-              <a:t>Informe de resultados preliminares</a:t>
-            </a:r>
-            <a:endParaRPr lang="en-US" sz="1500" dirty="0"/>
-          </a:p>
-        </p:txBody>
-      </p:sp>
-      <p:sp>
-        <p:nvSpPr>
-          <p:cNvPr id="27" name="Nota 2025-2"/>
-          <p:cNvSpPr txBox="1"/>
-          <p:nvPr/>
-        </p:nvSpPr>
-        <p:spPr>
-          <a:xfrm>
-            <a:off x="8610448" y="2258568"/>
-            <a:ext cx="2804008" cy="274320"/>
-          </a:xfrm>
-          <a:prstGeom prst="rect">
-            <a:avLst/>
-          </a:prstGeom>
-          <a:noFill/>
-          <a:ln/>
-        </p:spPr>
-        <p:txBody>
-          <a:bodyPr wrap="square" lIns="0" tIns="0" rIns="0" bIns="0" rtlCol="0" anchor="t"/>
-          <a:lstStyle/>
-          <a:p>
-            <a:pPr indent="0" marL="0">
-              <a:buNone/>
-            </a:pPr>
-            <a:r>
-              <a:rPr lang="en-US" sz="1200" dirty="0">
+              <a:rPr lang="en-US" sz="1400" dirty="0">
                 <a:solidFill>
                   <a:schemeClr val="accent5"/>
                 </a:solidFill>
               </a:rPr>
-              <a:t>Nota No. DS-SABAO-BCS-BC-17003</a:t>
-            </a:r>
-            <a:endParaRPr lang="en-US" sz="1200" dirty="0"/>
-          </a:p>
-        </p:txBody>
-      </p:sp>
-      <p:sp>
-        <p:nvSpPr>
-          <p:cNvPr id="28" name="Detalle 2025-2 fondo"/>
+              <a:t>Visita 2 · supervisión ampliada</a:t>
+            </a:r>
+            <a:endParaRPr lang="en-US" sz="1400" dirty="0"/>
+          </a:p>
+        </p:txBody>
+      </p:sp>
+      <p:sp>
+        <p:nvSpPr>
+          <p:cNvPr id="41" name="Tarjeta 2026-1"/>
           <p:cNvSpPr/>
           <p:nvPr/>
         </p:nvSpPr>
         <p:spPr>
           <a:xfrm>
-            <a:off x="8610448" y="2651760"/>
-            <a:ext cx="2804008" cy="310896"/>
+            <a:off x="4572000" y="4041648"/>
+            <a:ext cx="3306928" cy="2103120"/>
           </a:xfrm>
           <a:prstGeom prst="roundRect">
             <a:avLst>
-              <a:gd name="adj" fmla="val 50000"/>
-            </a:avLst>
-          </a:prstGeom>
-          <a:solidFill>
-            <a:schemeClr val="accent1"/>
-          </a:solidFill>
-          <a:ln w="12700">
-            <a:solidFill>
-              <a:schemeClr val="accent1">
-                <a:alpha val="0"/>
-              </a:schemeClr>
-            </a:solidFill>
-            <a:prstDash val="solid"/>
-          </a:ln>
-        </p:spPr>
-      </p:sp>
-      <p:sp>
-        <p:nvSpPr>
-          <p:cNvPr id="29" name="Detalle 2025-2"/>
-          <p:cNvSpPr txBox="1"/>
-          <p:nvPr/>
-        </p:nvSpPr>
-        <p:spPr>
-          <a:xfrm>
-            <a:off x="8610448" y="2651760"/>
-            <a:ext cx="2804008" cy="310896"/>
-          </a:xfrm>
-          <a:prstGeom prst="rect">
-            <a:avLst/>
-          </a:prstGeom>
-          <a:noFill/>
-          <a:ln/>
-        </p:spPr>
-        <p:txBody>
-          <a:bodyPr wrap="square" lIns="0" tIns="0" rIns="0" bIns="0" rtlCol="0" anchor="ctr"/>
-          <a:lstStyle/>
-          <a:p>
-            <a:pPr algn="ctr" indent="0" marL="0">
-              <a:buNone/>
-            </a:pPr>
-            <a:r>
-              <a:rPr lang="en-US" sz="1100" b="1" spc="100" kern="0" dirty="0">
-                <a:solidFill>
-                  <a:schemeClr val="bg1"/>
-                </a:solidFill>
-              </a:rPr>
-              <a:t>9 observaciones</a:t>
-            </a:r>
-            <a:endParaRPr lang="en-US" sz="1100" dirty="0"/>
-          </a:p>
-        </p:txBody>
-      </p:sp>
-      <p:sp>
-        <p:nvSpPr>
-          <p:cNvPr id="30" name="Flecha 2025"/>
-          <p:cNvSpPr/>
-          <p:nvPr/>
-        </p:nvSpPr>
-        <p:spPr>
-          <a:xfrm>
-            <a:off x="7961224" y="2025396"/>
-            <a:ext cx="292608" cy="292608"/>
-          </a:xfrm>
-          <a:prstGeom prst="rightArrow">
-            <a:avLst/>
-          </a:prstGeom>
-          <a:solidFill>
-            <a:schemeClr val="accent1"/>
-          </a:solidFill>
-          <a:ln w="12700">
-            <a:solidFill>
-              <a:schemeClr val="accent1">
-                <a:alpha val="0"/>
-              </a:schemeClr>
-            </a:solidFill>
-            <a:prstDash val="solid"/>
-          </a:ln>
-        </p:spPr>
-      </p:sp>
-      <p:sp>
-        <p:nvSpPr>
-          <p:cNvPr id="31" name="Año 2026"/>
-          <p:cNvSpPr txBox="1"/>
-          <p:nvPr/>
-        </p:nvSpPr>
-        <p:spPr>
-          <a:xfrm>
-            <a:off x="4572000" y="3429000"/>
-            <a:ext cx="1280160" cy="502920"/>
-          </a:xfrm>
-          <a:prstGeom prst="rect">
-            <a:avLst/>
-          </a:prstGeom>
-          <a:noFill/>
-          <a:ln/>
-        </p:spPr>
-        <p:txBody>
-          <a:bodyPr wrap="square" lIns="0" tIns="0" rIns="0" bIns="0" rtlCol="0" anchor="ctr"/>
-          <a:lstStyle/>
-          <a:p>
-            <a:pPr indent="0" marL="0">
-              <a:buNone/>
-            </a:pPr>
-            <a:r>
-              <a:rPr lang="en-US" sz="3000" b="1" dirty="0">
-                <a:solidFill>
-                  <a:schemeClr val="accent2"/>
-                </a:solidFill>
-                <a:latin typeface="Cambria" pitchFamily="34" charset="0"/>
-                <a:ea typeface="Cambria" pitchFamily="34" charset="-122"/>
-                <a:cs typeface="Cambria" pitchFamily="34" charset="-120"/>
-              </a:rPr>
-              <a:t>2026</a:t>
-            </a:r>
-            <a:endParaRPr lang="en-US" sz="3000" dirty="0"/>
-          </a:p>
-        </p:txBody>
-      </p:sp>
-      <p:sp>
-        <p:nvSpPr>
-          <p:cNvPr id="32" name="Visita 2026"/>
-          <p:cNvSpPr txBox="1"/>
-          <p:nvPr/>
-        </p:nvSpPr>
-        <p:spPr>
-          <a:xfrm>
-            <a:off x="5897880" y="3429000"/>
-            <a:ext cx="3657600" cy="502920"/>
-          </a:xfrm>
-          <a:prstGeom prst="rect">
-            <a:avLst/>
-          </a:prstGeom>
-          <a:noFill/>
-          <a:ln/>
-        </p:spPr>
-        <p:txBody>
-          <a:bodyPr wrap="square" lIns="0" tIns="0" rIns="0" bIns="0" rtlCol="0" anchor="ctr"/>
-          <a:lstStyle/>
-          <a:p>
-            <a:pPr indent="0" marL="0">
-              <a:buNone/>
-            </a:pPr>
-            <a:r>
-              <a:rPr lang="en-US" sz="1400" dirty="0">
-                <a:solidFill>
-                  <a:schemeClr val="accent5"/>
-                </a:solidFill>
-              </a:rPr>
-              <a:t>Visita 2 · corte 31/07/2026</a:t>
-            </a:r>
-            <a:endParaRPr lang="en-US" sz="1400" dirty="0"/>
-          </a:p>
-        </p:txBody>
-      </p:sp>
-      <p:sp>
-        <p:nvSpPr>
-          <p:cNvPr id="33" name="Tarjeta 2026-1"/>
-          <p:cNvSpPr/>
-          <p:nvPr/>
-        </p:nvSpPr>
-        <p:spPr>
-          <a:xfrm>
-            <a:off x="4572000" y="4114800"/>
-            <a:ext cx="3261208" cy="1965960"/>
-          </a:xfrm>
-          <a:prstGeom prst="roundRect">
-            <a:avLst>
-              <a:gd name="adj" fmla="val 4651"/>
+              <a:gd name="adj" fmla="val 4348"/>
             </a:avLst>
           </a:prstGeom>
           <a:solidFill>
@@ -2785,17 +3105,19 @@
       </p:sp>
       <p:sp>
         <p:nvSpPr>
-          <p:cNvPr id="34" name="Paso 2026-1 círculo"/>
+          <p:cNvPr id="42" name="Fecha fondo 2026-1"/>
           <p:cNvSpPr/>
           <p:nvPr/>
         </p:nvSpPr>
         <p:spPr>
           <a:xfrm>
-            <a:off x="4800600" y="4343400"/>
-            <a:ext cx="365760" cy="365760"/>
-          </a:xfrm>
-          <a:prstGeom prst="ellipse">
-            <a:avLst/>
+            <a:off x="4709160" y="4178808"/>
+            <a:ext cx="914400" cy="1828800"/>
+          </a:xfrm>
+          <a:prstGeom prst="roundRect">
+            <a:avLst>
+              <a:gd name="adj" fmla="val 10000"/>
+            </a:avLst>
           </a:prstGeom>
           <a:solidFill>
             <a:schemeClr val="accent2"/>
@@ -2812,14 +3134,14 @@
       </p:sp>
       <p:sp>
         <p:nvSpPr>
-          <p:cNvPr id="35" name="Paso 2026-1"/>
-          <p:cNvSpPr txBox="1"/>
-          <p:nvPr/>
-        </p:nvSpPr>
-        <p:spPr>
-          <a:xfrm>
-            <a:off x="4800600" y="4343400"/>
-            <a:ext cx="365760" cy="365760"/>
+          <p:cNvPr id="43" name="Fecha día 2026-1"/>
+          <p:cNvSpPr txBox="1"/>
+          <p:nvPr/>
+        </p:nvSpPr>
+        <p:spPr>
+          <a:xfrm>
+            <a:off x="4709160" y="4407408"/>
+            <a:ext cx="914400" cy="548640"/>
           </a:xfrm>
           <a:prstGeom prst="rect">
             <a:avLst/>
@@ -2835,7 +3157,7 @@
               <a:buNone/>
             </a:pPr>
             <a:r>
-              <a:rPr lang="en-US" sz="1200" b="1" dirty="0">
+              <a:rPr lang="en-US" sz="3400" b="1" dirty="0">
                 <a:solidFill>
                   <a:schemeClr val="bg1"/>
                 </a:solidFill>
@@ -2843,7 +3165,79 @@
                 <a:ea typeface="Cambria" pitchFamily="34" charset="-122"/>
                 <a:cs typeface="Cambria" pitchFamily="34" charset="-120"/>
               </a:rPr>
-              <a:t>1</a:t>
+              <a:t>31</a:t>
+            </a:r>
+            <a:endParaRPr lang="en-US" sz="3400" dirty="0"/>
+          </a:p>
+        </p:txBody>
+      </p:sp>
+      <p:sp>
+        <p:nvSpPr>
+          <p:cNvPr id="44" name="Fecha mes 2026-1"/>
+          <p:cNvSpPr txBox="1"/>
+          <p:nvPr/>
+        </p:nvSpPr>
+        <p:spPr>
+          <a:xfrm>
+            <a:off x="4709160" y="4956048"/>
+            <a:ext cx="914400" cy="274320"/>
+          </a:xfrm>
+          <a:prstGeom prst="rect">
+            <a:avLst/>
+          </a:prstGeom>
+          <a:noFill/>
+          <a:ln/>
+        </p:spPr>
+        <p:txBody>
+          <a:bodyPr wrap="square" lIns="0" tIns="0" rIns="0" bIns="0" rtlCol="0" anchor="t"/>
+          <a:lstStyle/>
+          <a:p>
+            <a:pPr algn="ctr" indent="0" marL="0">
+              <a:buNone/>
+            </a:pPr>
+            <a:r>
+              <a:rPr lang="en-US" sz="1400" b="1" spc="200" kern="0" dirty="0">
+                <a:solidFill>
+                  <a:schemeClr val="bg1"/>
+                </a:solidFill>
+              </a:rPr>
+              <a:t>JUL</a:t>
+            </a:r>
+            <a:endParaRPr lang="en-US" sz="1400" dirty="0"/>
+          </a:p>
+        </p:txBody>
+      </p:sp>
+      <p:sp>
+        <p:nvSpPr>
+          <p:cNvPr id="45" name="Fecha año 2026-1"/>
+          <p:cNvSpPr txBox="1"/>
+          <p:nvPr/>
+        </p:nvSpPr>
+        <p:spPr>
+          <a:xfrm>
+            <a:off x="4709160" y="5230368"/>
+            <a:ext cx="914400" cy="274320"/>
+          </a:xfrm>
+          <a:prstGeom prst="rect">
+            <a:avLst/>
+          </a:prstGeom>
+          <a:noFill/>
+          <a:ln/>
+        </p:spPr>
+        <p:txBody>
+          <a:bodyPr wrap="square" lIns="0" tIns="0" rIns="0" bIns="0" rtlCol="0" anchor="t"/>
+          <a:lstStyle/>
+          <a:p>
+            <a:pPr algn="ctr" indent="0" marL="0">
+              <a:buNone/>
+            </a:pPr>
+            <a:r>
+              <a:rPr lang="en-US" sz="1200" dirty="0">
+                <a:solidFill>
+                  <a:schemeClr val="bg1"/>
+                </a:solidFill>
+              </a:rPr>
+              <a:t>2026</a:t>
             </a:r>
             <a:endParaRPr lang="en-US" sz="1200" dirty="0"/>
           </a:p>
@@ -2851,14 +3245,50 @@
       </p:sp>
       <p:sp>
         <p:nvSpPr>
-          <p:cNvPr id="36" name="Fecha 2026-1"/>
-          <p:cNvSpPr txBox="1"/>
-          <p:nvPr/>
-        </p:nvSpPr>
-        <p:spPr>
-          <a:xfrm>
-            <a:off x="5303520" y="4343400"/>
-            <a:ext cx="2346808" cy="365760"/>
+          <p:cNvPr id="46" name="Paso 2026-1"/>
+          <p:cNvSpPr txBox="1"/>
+          <p:nvPr/>
+        </p:nvSpPr>
+        <p:spPr>
+          <a:xfrm>
+            <a:off x="4709160" y="5641848"/>
+            <a:ext cx="914400" cy="228600"/>
+          </a:xfrm>
+          <a:prstGeom prst="rect">
+            <a:avLst/>
+          </a:prstGeom>
+          <a:noFill/>
+          <a:ln/>
+        </p:spPr>
+        <p:txBody>
+          <a:bodyPr wrap="square" lIns="0" tIns="0" rIns="0" bIns="0" rtlCol="0" anchor="t"/>
+          <a:lstStyle/>
+          <a:p>
+            <a:pPr algn="ctr" indent="0" marL="0">
+              <a:buNone/>
+            </a:pPr>
+            <a:r>
+              <a:rPr lang="en-US" sz="950" b="1" spc="100" kern="0" dirty="0">
+                <a:solidFill>
+                  <a:schemeClr val="bg1"/>
+                </a:solidFill>
+              </a:rPr>
+              <a:t>PASO 1 DE 2</a:t>
+            </a:r>
+            <a:endParaRPr lang="en-US" sz="950" dirty="0"/>
+          </a:p>
+        </p:txBody>
+      </p:sp>
+      <p:sp>
+        <p:nvSpPr>
+          <p:cNvPr id="47" name="Tipo 2026-1"/>
+          <p:cNvSpPr txBox="1"/>
+          <p:nvPr/>
+        </p:nvSpPr>
+        <p:spPr>
+          <a:xfrm>
+            <a:off x="5806440" y="4206240"/>
+            <a:ext cx="1935328" cy="502920"/>
           </a:xfrm>
           <a:prstGeom prst="rect">
             <a:avLst/>
@@ -2874,106 +3304,248 @@
               <a:buNone/>
             </a:pPr>
             <a:r>
-              <a:rPr lang="en-US" sz="1300" b="1" dirty="0">
+              <a:rPr lang="en-US" sz="1400" b="1" dirty="0">
+                <a:solidFill>
+                  <a:schemeClr val="tx1"/>
+                </a:solidFill>
+              </a:rPr>
+              <a:t>Nombramiento de visita ampliada</a:t>
+            </a:r>
+            <a:endParaRPr lang="en-US" sz="1400" dirty="0"/>
+          </a:p>
+        </p:txBody>
+      </p:sp>
+      <p:sp>
+        <p:nvSpPr>
+          <p:cNvPr id="48" name="Circular 2026-1"/>
+          <p:cNvSpPr txBox="1"/>
+          <p:nvPr/>
+        </p:nvSpPr>
+        <p:spPr>
+          <a:xfrm>
+            <a:off x="5806440" y="4773168"/>
+            <a:ext cx="1935328" cy="438912"/>
+          </a:xfrm>
+          <a:prstGeom prst="rect">
+            <a:avLst/>
+          </a:prstGeom>
+          <a:noFill/>
+          <a:ln/>
+        </p:spPr>
+        <p:txBody>
+          <a:bodyPr wrap="square" lIns="0" tIns="0" rIns="0" bIns="0" rtlCol="0" anchor="t"/>
+          <a:lstStyle/>
+          <a:p>
+            <a:pPr indent="0" marL="0">
+              <a:buNone/>
+            </a:pPr>
+            <a:r>
+              <a:rPr lang="en-US" sz="1000" dirty="0">
+                <a:solidFill>
+                  <a:schemeClr val="accent5"/>
+                </a:solidFill>
+              </a:rPr>
+              <a:t>Circular No.</a:t>
+            </a:r>
+            <a:endParaRPr lang="en-US" sz="1100" dirty="0"/>
+          </a:p>
+          <a:p>
+            <a:pPr indent="0" marL="0">
+              <a:buNone/>
+            </a:pPr>
+            <a:r>
+              <a:rPr lang="en-US" sz="1100" b="1" dirty="0">
                 <a:solidFill>
                   <a:schemeClr val="accent2"/>
                 </a:solidFill>
-                <a:latin typeface="Courier New" pitchFamily="34" charset="0"/>
-                <a:ea typeface="Courier New" pitchFamily="34" charset="-122"/>
-                <a:cs typeface="Courier New" pitchFamily="34" charset="-120"/>
+              </a:rPr>
+              <a:t>SABAO-BCS-BC-18432</a:t>
+            </a:r>
+            <a:endParaRPr lang="en-US" sz="1100" dirty="0"/>
+          </a:p>
+        </p:txBody>
+      </p:sp>
+      <p:sp>
+        <p:nvSpPr>
+          <p:cNvPr id="49" name="Separador 2026-1-0"/>
+          <p:cNvSpPr/>
+          <p:nvPr/>
+        </p:nvSpPr>
+        <p:spPr>
+          <a:xfrm>
+            <a:off x="5806440" y="5285232"/>
+            <a:ext cx="1935328" cy="0"/>
+          </a:xfrm>
+          <a:prstGeom prst="line">
+            <a:avLst/>
+          </a:prstGeom>
+          <a:noFill/>
+          <a:ln w="9525">
+            <a:solidFill>
+              <a:srgbClr val="D9E0EA"/>
+            </a:solidFill>
+            <a:prstDash val="solid"/>
+          </a:ln>
+        </p:spPr>
+      </p:sp>
+      <p:sp>
+        <p:nvSpPr>
+          <p:cNvPr id="50" name="Dato 2026-1-0"/>
+          <p:cNvSpPr txBox="1"/>
+          <p:nvPr/>
+        </p:nvSpPr>
+        <p:spPr>
+          <a:xfrm>
+            <a:off x="5806440" y="5321808"/>
+            <a:ext cx="1935328" cy="310896"/>
+          </a:xfrm>
+          <a:prstGeom prst="rect">
+            <a:avLst/>
+          </a:prstGeom>
+          <a:noFill/>
+          <a:ln/>
+        </p:spPr>
+        <p:txBody>
+          <a:bodyPr wrap="square" lIns="0" tIns="0" rIns="0" bIns="0" rtlCol="0" anchor="ctr"/>
+          <a:lstStyle/>
+          <a:p>
+            <a:pPr indent="0" marL="0">
+              <a:buNone/>
+            </a:pPr>
+            <a:r>
+              <a:rPr lang="en-US" sz="1150" dirty="0">
+                <a:solidFill>
+                  <a:schemeClr val="accent5"/>
+                </a:solidFill>
+              </a:rPr>
+              <a:t>Corte  </a:t>
+            </a:r>
+            <a:pPr indent="0" marL="0">
+              <a:buNone/>
+            </a:pPr>
+            <a:r>
+              <a:rPr lang="en-US" sz="1150" b="1" dirty="0">
+                <a:solidFill>
+                  <a:schemeClr val="tx1"/>
+                </a:solidFill>
               </a:rPr>
               <a:t>31/07/2026</a:t>
             </a:r>
-            <a:endParaRPr lang="en-US" sz="1300" dirty="0"/>
-          </a:p>
-        </p:txBody>
-      </p:sp>
-      <p:sp>
-        <p:nvSpPr>
-          <p:cNvPr id="37" name="Tipo 2026-1"/>
-          <p:cNvSpPr txBox="1"/>
-          <p:nvPr/>
-        </p:nvSpPr>
-        <p:spPr>
-          <a:xfrm>
-            <a:off x="4800600" y="4846320"/>
-            <a:ext cx="2804008" cy="320040"/>
-          </a:xfrm>
-          <a:prstGeom prst="rect">
-            <a:avLst/>
-          </a:prstGeom>
-          <a:noFill/>
-          <a:ln/>
-        </p:spPr>
-        <p:txBody>
-          <a:bodyPr wrap="square" lIns="0" tIns="0" rIns="0" bIns="0" rtlCol="0" anchor="t"/>
-          <a:lstStyle/>
-          <a:p>
-            <a:pPr indent="0" marL="0">
-              <a:buNone/>
-            </a:pPr>
-            <a:r>
-              <a:rPr lang="en-US" sz="1500" b="1" dirty="0">
+            <a:endParaRPr lang="en-US" sz="1150" dirty="0"/>
+          </a:p>
+        </p:txBody>
+      </p:sp>
+      <p:sp>
+        <p:nvSpPr>
+          <p:cNvPr id="51" name="Separador 2026-1-1"/>
+          <p:cNvSpPr/>
+          <p:nvPr/>
+        </p:nvSpPr>
+        <p:spPr>
+          <a:xfrm>
+            <a:off x="5806440" y="5650992"/>
+            <a:ext cx="1935328" cy="0"/>
+          </a:xfrm>
+          <a:prstGeom prst="line">
+            <a:avLst/>
+          </a:prstGeom>
+          <a:noFill/>
+          <a:ln w="9525">
+            <a:solidFill>
+              <a:srgbClr val="D9E0EA"/>
+            </a:solidFill>
+            <a:prstDash val="solid"/>
+          </a:ln>
+        </p:spPr>
+      </p:sp>
+      <p:sp>
+        <p:nvSpPr>
+          <p:cNvPr id="52" name="Dato 2026-1-1"/>
+          <p:cNvSpPr txBox="1"/>
+          <p:nvPr/>
+        </p:nvSpPr>
+        <p:spPr>
+          <a:xfrm>
+            <a:off x="5806440" y="5687568"/>
+            <a:ext cx="1935328" cy="310896"/>
+          </a:xfrm>
+          <a:prstGeom prst="rect">
+            <a:avLst/>
+          </a:prstGeom>
+          <a:noFill/>
+          <a:ln/>
+        </p:spPr>
+        <p:txBody>
+          <a:bodyPr wrap="square" lIns="0" tIns="0" rIns="0" bIns="0" rtlCol="0" anchor="ctr"/>
+          <a:lstStyle/>
+          <a:p>
+            <a:pPr indent="0" marL="0">
+              <a:buNone/>
+            </a:pPr>
+            <a:r>
+              <a:rPr lang="en-US" sz="1150" dirty="0">
+                <a:solidFill>
+                  <a:schemeClr val="accent5"/>
+                </a:solidFill>
+              </a:rPr>
+              <a:t>Inicio de visita  </a:t>
+            </a:r>
+            <a:pPr indent="0" marL="0">
+              <a:buNone/>
+            </a:pPr>
+            <a:r>
+              <a:rPr lang="en-US" sz="1150" b="1" dirty="0">
                 <a:solidFill>
                   <a:schemeClr val="tx1"/>
                 </a:solidFill>
               </a:rPr>
-              <a:t>Nombramiento de visita ampliada</a:t>
-            </a:r>
-            <a:endParaRPr lang="en-US" sz="1500" dirty="0"/>
-          </a:p>
-        </p:txBody>
-      </p:sp>
-      <p:sp>
-        <p:nvSpPr>
-          <p:cNvPr id="38" name="Nota 2026-1"/>
-          <p:cNvSpPr txBox="1"/>
-          <p:nvPr/>
-        </p:nvSpPr>
-        <p:spPr>
-          <a:xfrm>
-            <a:off x="4800600" y="5184648"/>
-            <a:ext cx="2804008" cy="274320"/>
-          </a:xfrm>
-          <a:prstGeom prst="rect">
-            <a:avLst/>
-          </a:prstGeom>
-          <a:noFill/>
-          <a:ln/>
-        </p:spPr>
-        <p:txBody>
-          <a:bodyPr wrap="square" lIns="0" tIns="0" rIns="0" bIns="0" rtlCol="0" anchor="t"/>
-          <a:lstStyle/>
-          <a:p>
-            <a:pPr indent="0" marL="0">
-              <a:buNone/>
-            </a:pPr>
-            <a:r>
-              <a:rPr lang="en-US" sz="1200" dirty="0">
-                <a:solidFill>
-                  <a:schemeClr val="accent5"/>
-                </a:solidFill>
-              </a:rPr>
-              <a:t>Nota No. SABAO-BCS-BC-18432</a:t>
-            </a:r>
-            <a:endParaRPr lang="en-US" sz="1200" dirty="0"/>
-          </a:p>
-        </p:txBody>
-      </p:sp>
-      <p:sp>
-        <p:nvSpPr>
-          <p:cNvPr id="39" name="Detalle 2026-1 fondo"/>
+              <a:t>21/08/2026</a:t>
+            </a:r>
+            <a:endParaRPr lang="en-US" sz="1150" dirty="0"/>
+          </a:p>
+        </p:txBody>
+      </p:sp>
+      <p:sp>
+        <p:nvSpPr>
+          <p:cNvPr id="53" name="Tarjeta 2026-2"/>
           <p:cNvSpPr/>
           <p:nvPr/>
         </p:nvSpPr>
         <p:spPr>
           <a:xfrm>
-            <a:off x="4800600" y="5577840"/>
-            <a:ext cx="2804008" cy="310896"/>
+            <a:off x="8336128" y="4041648"/>
+            <a:ext cx="3306928" cy="2103120"/>
           </a:xfrm>
           <a:prstGeom prst="roundRect">
             <a:avLst>
-              <a:gd name="adj" fmla="val 50000"/>
+              <a:gd name="adj" fmla="val 4348"/>
+            </a:avLst>
+          </a:prstGeom>
+          <a:solidFill>
+            <a:schemeClr val="bg1"/>
+          </a:solidFill>
+          <a:ln w="12700">
+            <a:solidFill>
+              <a:srgbClr val="D9E0EA"/>
+            </a:solidFill>
+            <a:prstDash val="solid"/>
+          </a:ln>
+        </p:spPr>
+      </p:sp>
+      <p:sp>
+        <p:nvSpPr>
+          <p:cNvPr id="54" name="Fecha fondo 2026-2"/>
+          <p:cNvSpPr/>
+          <p:nvPr/>
+        </p:nvSpPr>
+        <p:spPr>
+          <a:xfrm>
+            <a:off x="8473288" y="4178808"/>
+            <a:ext cx="914400" cy="1828800"/>
+          </a:xfrm>
+          <a:prstGeom prst="roundRect">
+            <a:avLst>
+              <a:gd name="adj" fmla="val 10000"/>
             </a:avLst>
           </a:prstGeom>
           <a:solidFill>
@@ -2991,14 +3563,14 @@
       </p:sp>
       <p:sp>
         <p:nvSpPr>
-          <p:cNvPr id="40" name="Detalle 2026-1"/>
-          <p:cNvSpPr txBox="1"/>
-          <p:nvPr/>
-        </p:nvSpPr>
-        <p:spPr>
-          <a:xfrm>
-            <a:off x="4800600" y="5577840"/>
-            <a:ext cx="2804008" cy="310896"/>
+          <p:cNvPr id="55" name="Fecha día 2026-2"/>
+          <p:cNvSpPr txBox="1"/>
+          <p:nvPr/>
+        </p:nvSpPr>
+        <p:spPr>
+          <a:xfrm>
+            <a:off x="8473288" y="4407408"/>
+            <a:ext cx="914400" cy="548640"/>
           </a:xfrm>
           <a:prstGeom prst="rect">
             <a:avLst/>
@@ -3014,37 +3586,230 @@
               <a:buNone/>
             </a:pPr>
             <a:r>
-              <a:rPr lang="en-US" sz="1100" b="1" spc="100" kern="0" dirty="0">
+              <a:rPr lang="en-US" sz="3400" b="1" dirty="0">
                 <a:solidFill>
                   <a:schemeClr val="bg1"/>
                 </a:solidFill>
-              </a:rPr>
-              <a:t>Corte 31/07/2026 · inicio 21/08/2026</a:t>
+                <a:latin typeface="Cambria" pitchFamily="34" charset="0"/>
+                <a:ea typeface="Cambria" pitchFamily="34" charset="-122"/>
+                <a:cs typeface="Cambria" pitchFamily="34" charset="-120"/>
+              </a:rPr>
+              <a:t>09</a:t>
+            </a:r>
+            <a:endParaRPr lang="en-US" sz="3400" dirty="0"/>
+          </a:p>
+        </p:txBody>
+      </p:sp>
+      <p:sp>
+        <p:nvSpPr>
+          <p:cNvPr id="56" name="Fecha mes 2026-2"/>
+          <p:cNvSpPr txBox="1"/>
+          <p:nvPr/>
+        </p:nvSpPr>
+        <p:spPr>
+          <a:xfrm>
+            <a:off x="8473288" y="4956048"/>
+            <a:ext cx="914400" cy="274320"/>
+          </a:xfrm>
+          <a:prstGeom prst="rect">
+            <a:avLst/>
+          </a:prstGeom>
+          <a:noFill/>
+          <a:ln/>
+        </p:spPr>
+        <p:txBody>
+          <a:bodyPr wrap="square" lIns="0" tIns="0" rIns="0" bIns="0" rtlCol="0" anchor="t"/>
+          <a:lstStyle/>
+          <a:p>
+            <a:pPr algn="ctr" indent="0" marL="0">
+              <a:buNone/>
+            </a:pPr>
+            <a:r>
+              <a:rPr lang="en-US" sz="1400" b="1" spc="200" kern="0" dirty="0">
+                <a:solidFill>
+                  <a:schemeClr val="bg1"/>
+                </a:solidFill>
+              </a:rPr>
+              <a:t>OCT</a:t>
+            </a:r>
+            <a:endParaRPr lang="en-US" sz="1400" dirty="0"/>
+          </a:p>
+        </p:txBody>
+      </p:sp>
+      <p:sp>
+        <p:nvSpPr>
+          <p:cNvPr id="57" name="Fecha año 2026-2"/>
+          <p:cNvSpPr txBox="1"/>
+          <p:nvPr/>
+        </p:nvSpPr>
+        <p:spPr>
+          <a:xfrm>
+            <a:off x="8473288" y="5230368"/>
+            <a:ext cx="914400" cy="274320"/>
+          </a:xfrm>
+          <a:prstGeom prst="rect">
+            <a:avLst/>
+          </a:prstGeom>
+          <a:noFill/>
+          <a:ln/>
+        </p:spPr>
+        <p:txBody>
+          <a:bodyPr wrap="square" lIns="0" tIns="0" rIns="0" bIns="0" rtlCol="0" anchor="t"/>
+          <a:lstStyle/>
+          <a:p>
+            <a:pPr algn="ctr" indent="0" marL="0">
+              <a:buNone/>
+            </a:pPr>
+            <a:r>
+              <a:rPr lang="en-US" sz="1200" dirty="0">
+                <a:solidFill>
+                  <a:schemeClr val="bg1"/>
+                </a:solidFill>
+              </a:rPr>
+              <a:t>2026</a:t>
+            </a:r>
+            <a:endParaRPr lang="en-US" sz="1200" dirty="0"/>
+          </a:p>
+        </p:txBody>
+      </p:sp>
+      <p:sp>
+        <p:nvSpPr>
+          <p:cNvPr id="58" name="Paso 2026-2"/>
+          <p:cNvSpPr txBox="1"/>
+          <p:nvPr/>
+        </p:nvSpPr>
+        <p:spPr>
+          <a:xfrm>
+            <a:off x="8473288" y="5641848"/>
+            <a:ext cx="914400" cy="228600"/>
+          </a:xfrm>
+          <a:prstGeom prst="rect">
+            <a:avLst/>
+          </a:prstGeom>
+          <a:noFill/>
+          <a:ln/>
+        </p:spPr>
+        <p:txBody>
+          <a:bodyPr wrap="square" lIns="0" tIns="0" rIns="0" bIns="0" rtlCol="0" anchor="t"/>
+          <a:lstStyle/>
+          <a:p>
+            <a:pPr algn="ctr" indent="0" marL="0">
+              <a:buNone/>
+            </a:pPr>
+            <a:r>
+              <a:rPr lang="en-US" sz="950" b="1" spc="100" kern="0" dirty="0">
+                <a:solidFill>
+                  <a:schemeClr val="bg1"/>
+                </a:solidFill>
+              </a:rPr>
+              <a:t>PASO 2 DE 2</a:t>
+            </a:r>
+            <a:endParaRPr lang="en-US" sz="950" dirty="0"/>
+          </a:p>
+        </p:txBody>
+      </p:sp>
+      <p:sp>
+        <p:nvSpPr>
+          <p:cNvPr id="59" name="Tipo 2026-2"/>
+          <p:cNvSpPr txBox="1"/>
+          <p:nvPr/>
+        </p:nvSpPr>
+        <p:spPr>
+          <a:xfrm>
+            <a:off x="9570568" y="4206240"/>
+            <a:ext cx="1935328" cy="502920"/>
+          </a:xfrm>
+          <a:prstGeom prst="rect">
+            <a:avLst/>
+          </a:prstGeom>
+          <a:noFill/>
+          <a:ln/>
+        </p:spPr>
+        <p:txBody>
+          <a:bodyPr wrap="square" lIns="0" tIns="0" rIns="0" bIns="0" rtlCol="0" anchor="ctr"/>
+          <a:lstStyle/>
+          <a:p>
+            <a:pPr indent="0" marL="0">
+              <a:buNone/>
+            </a:pPr>
+            <a:r>
+              <a:rPr lang="en-US" sz="1400" b="1" dirty="0">
+                <a:solidFill>
+                  <a:schemeClr val="tx1"/>
+                </a:solidFill>
+              </a:rPr>
+              <a:t>Resultados preliminares</a:t>
+            </a:r>
+            <a:endParaRPr lang="en-US" sz="1400" dirty="0"/>
+          </a:p>
+        </p:txBody>
+      </p:sp>
+      <p:sp>
+        <p:nvSpPr>
+          <p:cNvPr id="60" name="Circular 2026-2"/>
+          <p:cNvSpPr txBox="1"/>
+          <p:nvPr/>
+        </p:nvSpPr>
+        <p:spPr>
+          <a:xfrm>
+            <a:off x="9570568" y="4773168"/>
+            <a:ext cx="1935328" cy="438912"/>
+          </a:xfrm>
+          <a:prstGeom prst="rect">
+            <a:avLst/>
+          </a:prstGeom>
+          <a:noFill/>
+          <a:ln/>
+        </p:spPr>
+        <p:txBody>
+          <a:bodyPr wrap="square" lIns="0" tIns="0" rIns="0" bIns="0" rtlCol="0" anchor="t"/>
+          <a:lstStyle/>
+          <a:p>
+            <a:pPr indent="0" marL="0">
+              <a:buNone/>
+            </a:pPr>
+            <a:r>
+              <a:rPr lang="en-US" sz="1000" dirty="0">
+                <a:solidFill>
+                  <a:schemeClr val="accent5"/>
+                </a:solidFill>
+              </a:rPr>
+              <a:t>Circular No.</a:t>
             </a:r>
             <a:endParaRPr lang="en-US" sz="1100" dirty="0"/>
           </a:p>
-        </p:txBody>
-      </p:sp>
-      <p:sp>
-        <p:nvSpPr>
-          <p:cNvPr id="41" name="Tarjeta 2026-2"/>
+          <a:p>
+            <a:pPr indent="0" marL="0">
+              <a:buNone/>
+            </a:pPr>
+            <a:r>
+              <a:rPr lang="en-US" sz="1100" b="1" dirty="0">
+                <a:solidFill>
+                  <a:schemeClr val="accent2"/>
+                </a:solidFill>
+              </a:rPr>
+              <a:t>DS-SABAO-BCS-BC-22741</a:t>
+            </a:r>
+            <a:endParaRPr lang="en-US" sz="1100" dirty="0"/>
+          </a:p>
+        </p:txBody>
+      </p:sp>
+      <p:sp>
+        <p:nvSpPr>
+          <p:cNvPr id="61" name="Separador 2026-2-0"/>
           <p:cNvSpPr/>
           <p:nvPr/>
         </p:nvSpPr>
         <p:spPr>
           <a:xfrm>
-            <a:off x="8381848" y="4114800"/>
-            <a:ext cx="3261208" cy="1965960"/>
-          </a:xfrm>
-          <a:prstGeom prst="roundRect">
-            <a:avLst>
-              <a:gd name="adj" fmla="val 4651"/>
-            </a:avLst>
-          </a:prstGeom>
-          <a:solidFill>
-            <a:schemeClr val="bg1"/>
-          </a:solidFill>
-          <a:ln w="12700">
+            <a:off x="9570568" y="5285232"/>
+            <a:ext cx="1935328" cy="0"/>
+          </a:xfrm>
+          <a:prstGeom prst="line">
+            <a:avLst/>
+          </a:prstGeom>
+          <a:noFill/>
+          <a:ln w="9525">
             <a:solidFill>
               <a:srgbClr val="D9E0EA"/>
             </a:solidFill>
@@ -3054,26 +3819,69 @@
       </p:sp>
       <p:sp>
         <p:nvSpPr>
-          <p:cNvPr id="42" name="Paso 2026-2 círculo"/>
+          <p:cNvPr id="62" name="Dato 2026-2-0"/>
+          <p:cNvSpPr txBox="1"/>
+          <p:nvPr/>
+        </p:nvSpPr>
+        <p:spPr>
+          <a:xfrm>
+            <a:off x="9570568" y="5321808"/>
+            <a:ext cx="1935328" cy="310896"/>
+          </a:xfrm>
+          <a:prstGeom prst="rect">
+            <a:avLst/>
+          </a:prstGeom>
+          <a:noFill/>
+          <a:ln/>
+        </p:spPr>
+        <p:txBody>
+          <a:bodyPr wrap="square" lIns="0" tIns="0" rIns="0" bIns="0" rtlCol="0" anchor="ctr"/>
+          <a:lstStyle/>
+          <a:p>
+            <a:pPr indent="0" marL="0">
+              <a:buNone/>
+            </a:pPr>
+            <a:r>
+              <a:rPr lang="en-US" sz="1150" dirty="0">
+                <a:solidFill>
+                  <a:schemeClr val="accent5"/>
+                </a:solidFill>
+              </a:rPr>
+              <a:t>Anexo A  </a:t>
+            </a:r>
+            <a:pPr indent="0" marL="0">
+              <a:buNone/>
+            </a:pPr>
+            <a:r>
+              <a:rPr lang="en-US" sz="1150" b="1" dirty="0">
+                <a:solidFill>
+                  <a:schemeClr val="tx1"/>
+                </a:solidFill>
+              </a:rPr>
+              <a:t>7 nuevas</a:t>
+            </a:r>
+            <a:endParaRPr lang="en-US" sz="1150" dirty="0"/>
+          </a:p>
+        </p:txBody>
+      </p:sp>
+      <p:sp>
+        <p:nvSpPr>
+          <p:cNvPr id="63" name="Separador 2026-2-1"/>
           <p:cNvSpPr/>
           <p:nvPr/>
         </p:nvSpPr>
         <p:spPr>
           <a:xfrm>
-            <a:off x="8610448" y="4343400"/>
-            <a:ext cx="365760" cy="365760"/>
-          </a:xfrm>
-          <a:prstGeom prst="ellipse">
-            <a:avLst/>
-          </a:prstGeom>
-          <a:solidFill>
-            <a:schemeClr val="accent2"/>
-          </a:solidFill>
-          <a:ln w="12700">
+            <a:off x="9570568" y="5650992"/>
+            <a:ext cx="1935328" cy="0"/>
+          </a:xfrm>
+          <a:prstGeom prst="line">
+            <a:avLst/>
+          </a:prstGeom>
+          <a:noFill/>
+          <a:ln w="9525">
             <a:solidFill>
-              <a:schemeClr val="accent2">
-                <a:alpha val="0"/>
-              </a:schemeClr>
+              <a:srgbClr val="D9E0EA"/>
             </a:solidFill>
             <a:prstDash val="solid"/>
           </a:ln>
@@ -3081,14 +3889,14 @@
       </p:sp>
       <p:sp>
         <p:nvSpPr>
-          <p:cNvPr id="43" name="Paso 2026-2"/>
-          <p:cNvSpPr txBox="1"/>
-          <p:nvPr/>
-        </p:nvSpPr>
-        <p:spPr>
-          <a:xfrm>
-            <a:off x="8610448" y="4343400"/>
-            <a:ext cx="365760" cy="365760"/>
+          <p:cNvPr id="64" name="Dato 2026-2-1"/>
+          <p:cNvSpPr txBox="1"/>
+          <p:nvPr/>
+        </p:nvSpPr>
+        <p:spPr>
+          <a:xfrm>
+            <a:off x="9570568" y="5687568"/>
+            <a:ext cx="1935328" cy="310896"/>
           </a:xfrm>
           <a:prstGeom prst="rect">
             <a:avLst/>
@@ -3100,210 +3908,42 @@
           <a:bodyPr wrap="square" lIns="0" tIns="0" rIns="0" bIns="0" rtlCol="0" anchor="ctr"/>
           <a:lstStyle/>
           <a:p>
-            <a:pPr algn="ctr" indent="0" marL="0">
-              <a:buNone/>
-            </a:pPr>
-            <a:r>
-              <a:rPr lang="en-US" sz="1200" b="1" dirty="0">
-                <a:solidFill>
-                  <a:schemeClr val="bg1"/>
-                </a:solidFill>
-                <a:latin typeface="Cambria" pitchFamily="34" charset="0"/>
-                <a:ea typeface="Cambria" pitchFamily="34" charset="-122"/>
-                <a:cs typeface="Cambria" pitchFamily="34" charset="-120"/>
-              </a:rPr>
-              <a:t>2</a:t>
-            </a:r>
-            <a:endParaRPr lang="en-US" sz="1200" dirty="0"/>
-          </a:p>
-        </p:txBody>
-      </p:sp>
-      <p:sp>
-        <p:nvSpPr>
-          <p:cNvPr id="44" name="Fecha 2026-2"/>
-          <p:cNvSpPr txBox="1"/>
-          <p:nvPr/>
-        </p:nvSpPr>
-        <p:spPr>
-          <a:xfrm>
-            <a:off x="9113368" y="4343400"/>
-            <a:ext cx="2346808" cy="365760"/>
-          </a:xfrm>
-          <a:prstGeom prst="rect">
-            <a:avLst/>
-          </a:prstGeom>
-          <a:noFill/>
-          <a:ln/>
-        </p:spPr>
-        <p:txBody>
-          <a:bodyPr wrap="square" lIns="0" tIns="0" rIns="0" bIns="0" rtlCol="0" anchor="ctr"/>
-          <a:lstStyle/>
-          <a:p>
-            <a:pPr indent="0" marL="0">
-              <a:buNone/>
-            </a:pPr>
-            <a:r>
-              <a:rPr lang="en-US" sz="1300" b="1" dirty="0">
-                <a:solidFill>
-                  <a:schemeClr val="accent2"/>
-                </a:solidFill>
-                <a:latin typeface="Courier New" pitchFamily="34" charset="0"/>
-                <a:ea typeface="Courier New" pitchFamily="34" charset="-122"/>
-                <a:cs typeface="Courier New" pitchFamily="34" charset="-120"/>
-              </a:rPr>
-              <a:t>09/10/2026</a:t>
-            </a:r>
-            <a:endParaRPr lang="en-US" sz="1300" dirty="0"/>
-          </a:p>
-        </p:txBody>
-      </p:sp>
-      <p:sp>
-        <p:nvSpPr>
-          <p:cNvPr id="45" name="Tipo 2026-2"/>
-          <p:cNvSpPr txBox="1"/>
-          <p:nvPr/>
-        </p:nvSpPr>
-        <p:spPr>
-          <a:xfrm>
-            <a:off x="8610448" y="4846320"/>
-            <a:ext cx="2804008" cy="320040"/>
-          </a:xfrm>
-          <a:prstGeom prst="rect">
-            <a:avLst/>
-          </a:prstGeom>
-          <a:noFill/>
-          <a:ln/>
-        </p:spPr>
-        <p:txBody>
-          <a:bodyPr wrap="square" lIns="0" tIns="0" rIns="0" bIns="0" rtlCol="0" anchor="t"/>
-          <a:lstStyle/>
-          <a:p>
-            <a:pPr indent="0" marL="0">
-              <a:buNone/>
-            </a:pPr>
-            <a:r>
-              <a:rPr lang="en-US" sz="1500" b="1" dirty="0">
+            <a:pPr indent="0" marL="0">
+              <a:buNone/>
+            </a:pPr>
+            <a:r>
+              <a:rPr lang="en-US" sz="1150" dirty="0">
+                <a:solidFill>
+                  <a:schemeClr val="accent5"/>
+                </a:solidFill>
+              </a:rPr>
+              <a:t>Anexo B  </a:t>
+            </a:r>
+            <a:pPr indent="0" marL="0">
+              <a:buNone/>
+            </a:pPr>
+            <a:r>
+              <a:rPr lang="en-US" sz="1150" b="1" dirty="0">
                 <a:solidFill>
                   <a:schemeClr val="tx1"/>
                 </a:solidFill>
               </a:rPr>
-              <a:t>Informe de resultados preliminares</a:t>
-            </a:r>
-            <a:endParaRPr lang="en-US" sz="1500" dirty="0"/>
-          </a:p>
-        </p:txBody>
-      </p:sp>
-      <p:sp>
-        <p:nvSpPr>
-          <p:cNvPr id="46" name="Nota 2026-2"/>
-          <p:cNvSpPr txBox="1"/>
-          <p:nvPr/>
-        </p:nvSpPr>
-        <p:spPr>
-          <a:xfrm>
-            <a:off x="8610448" y="5184648"/>
-            <a:ext cx="2804008" cy="274320"/>
-          </a:xfrm>
-          <a:prstGeom prst="rect">
-            <a:avLst/>
-          </a:prstGeom>
-          <a:noFill/>
-          <a:ln/>
-        </p:spPr>
-        <p:txBody>
-          <a:bodyPr wrap="square" lIns="0" tIns="0" rIns="0" bIns="0" rtlCol="0" anchor="t"/>
-          <a:lstStyle/>
-          <a:p>
-            <a:pPr indent="0" marL="0">
-              <a:buNone/>
-            </a:pPr>
-            <a:r>
-              <a:rPr lang="en-US" sz="1200" dirty="0">
-                <a:solidFill>
-                  <a:schemeClr val="accent5"/>
-                </a:solidFill>
-              </a:rPr>
-              <a:t>Nota No. DS-SABAO-BCS-BC-22741</a:t>
-            </a:r>
-            <a:endParaRPr lang="en-US" sz="1200" dirty="0"/>
-          </a:p>
-        </p:txBody>
-      </p:sp>
-      <p:sp>
-        <p:nvSpPr>
-          <p:cNvPr id="47" name="Detalle 2026-2 fondo"/>
+              <a:t>obs. 3 y 5 de 2025</a:t>
+            </a:r>
+            <a:endParaRPr lang="en-US" sz="1150" dirty="0"/>
+          </a:p>
+        </p:txBody>
+      </p:sp>
+      <p:sp>
+        <p:nvSpPr>
+          <p:cNvPr id="65" name="Flecha 2026"/>
           <p:cNvSpPr/>
           <p:nvPr/>
         </p:nvSpPr>
         <p:spPr>
           <a:xfrm>
-            <a:off x="8610448" y="5577840"/>
-            <a:ext cx="2804008" cy="310896"/>
-          </a:xfrm>
-          <a:prstGeom prst="roundRect">
-            <a:avLst>
-              <a:gd name="adj" fmla="val 50000"/>
-            </a:avLst>
-          </a:prstGeom>
-          <a:solidFill>
-            <a:schemeClr val="accent2"/>
-          </a:solidFill>
-          <a:ln w="12700">
-            <a:solidFill>
-              <a:schemeClr val="accent2">
-                <a:alpha val="0"/>
-              </a:schemeClr>
-            </a:solidFill>
-            <a:prstDash val="solid"/>
-          </a:ln>
-        </p:spPr>
-      </p:sp>
-      <p:sp>
-        <p:nvSpPr>
-          <p:cNvPr id="48" name="Detalle 2026-2"/>
-          <p:cNvSpPr txBox="1"/>
-          <p:nvPr/>
-        </p:nvSpPr>
-        <p:spPr>
-          <a:xfrm>
-            <a:off x="8610448" y="5577840"/>
-            <a:ext cx="2804008" cy="310896"/>
-          </a:xfrm>
-          <a:prstGeom prst="rect">
-            <a:avLst/>
-          </a:prstGeom>
-          <a:noFill/>
-          <a:ln/>
-        </p:spPr>
-        <p:txBody>
-          <a:bodyPr wrap="square" lIns="0" tIns="0" rIns="0" bIns="0" rtlCol="0" anchor="ctr"/>
-          <a:lstStyle/>
-          <a:p>
-            <a:pPr algn="ctr" indent="0" marL="0">
-              <a:buNone/>
-            </a:pPr>
-            <a:r>
-              <a:rPr lang="en-US" sz="1100" b="1" spc="100" kern="0" dirty="0">
-                <a:solidFill>
-                  <a:schemeClr val="bg1"/>
-                </a:solidFill>
-              </a:rPr>
-              <a:t>7 nuevas + seguimiento a 2 de 2025</a:t>
-            </a:r>
-            <a:endParaRPr lang="en-US" sz="1100" dirty="0"/>
-          </a:p>
-        </p:txBody>
-      </p:sp>
-      <p:sp>
-        <p:nvSpPr>
-          <p:cNvPr id="49" name="Flecha 2026"/>
-          <p:cNvSpPr/>
-          <p:nvPr/>
-        </p:nvSpPr>
-        <p:spPr>
-          <a:xfrm>
-            <a:off x="7961224" y="4951476"/>
-            <a:ext cx="292608" cy="292608"/>
+            <a:off x="7970368" y="4956048"/>
+            <a:ext cx="274320" cy="274320"/>
           </a:xfrm>
           <a:prstGeom prst="rightArrow">
             <a:avLst/>
@@ -3423,7 +4063,7 @@
                   <a:schemeClr val="accent5"/>
                 </a:solidFill>
               </a:rPr>
-              <a:t>NOTA DS-SABAO-BCS-BC-17003 · VISITA CON CORTE AL 30/04/2025</a:t>
+              <a:t>CIRCULAR DS-SABAO-BCS-BC-17003 · VISITA CON CORTE AL 30/04/2025</a:t>
             </a:r>
             <a:endParaRPr lang="en-US" sz="1100" dirty="0"/>
           </a:p>
@@ -3774,7 +4414,7 @@
                   <a:schemeClr val="tx1"/>
                 </a:solidFill>
               </a:rPr>
-              <a:t>Consejo de Administración / Gerencia General</a:t>
+              <a:t>Consejo de Administración</a:t>
             </a:r>
             <a:endParaRPr lang="en-US" sz="1050" dirty="0"/>
           </a:p>
@@ -3791,7 +4431,7 @@
                   <a:schemeClr val="accent5"/>
                 </a:solidFill>
               </a:rPr>
-              <a:t>Criterio SSF  </a:t>
+              <a:t>Criterio  </a:t>
             </a:r>
             <a:pPr indent="0" marL="0">
               <a:spcAft>
@@ -3805,7 +4445,7 @@
                   <a:schemeClr val="tx1"/>
                 </a:solidFill>
               </a:rPr>
-              <a:t>Requerida por Art. 12 NRP-17</a:t>
+              <a:t>Art. 12 literal c) NRP-17</a:t>
             </a:r>
             <a:endParaRPr lang="en-US" sz="1050" dirty="0"/>
           </a:p>
@@ -3936,7 +4576,7 @@
                   <a:schemeClr val="tx1"/>
                 </a:solidFill>
               </a:rPr>
-              <a:t>Sin evidencia de firma de confidencialidad e inducción en actas</a:t>
+              <a:t>Sin evidencia de firma de confidencialidad ni fechas de inducción en actas</a:t>
             </a:r>
             <a:endParaRPr lang="en-US" sz="1250" dirty="0"/>
           </a:p>
@@ -3989,7 +4629,7 @@
                   <a:schemeClr val="tx1"/>
                 </a:solidFill>
               </a:rPr>
-              <a:t>Consejo de Administración / Secretaría</a:t>
+              <a:t>Consejo de Administración (primera sesión con nuevos miembros)</a:t>
             </a:r>
             <a:endParaRPr lang="en-US" sz="1050" dirty="0"/>
           </a:p>
@@ -4006,7 +4646,7 @@
                   <a:schemeClr val="accent5"/>
                 </a:solidFill>
               </a:rPr>
-              <a:t>Criterio SSF  </a:t>
+              <a:t>Criterio  </a:t>
             </a:r>
             <a:pPr indent="0" marL="0">
               <a:spcAft>
@@ -4020,7 +4660,7 @@
                   <a:schemeClr val="tx1"/>
                 </a:solidFill>
               </a:rPr>
-              <a:t>Incumplimiento del Manual de Inducción</a:t>
+              <a:t>Manual de Inducción y Capacitación</a:t>
             </a:r>
             <a:endParaRPr lang="en-US" sz="1050" dirty="0"/>
           </a:p>
@@ -4204,7 +4844,7 @@
                   <a:schemeClr val="tx1"/>
                 </a:solidFill>
               </a:rPr>
-              <a:t>Consejo de Administración / RRHH</a:t>
+              <a:t>Consejo de Administración</a:t>
             </a:r>
             <a:endParaRPr lang="en-US" sz="1050" dirty="0"/>
           </a:p>
@@ -4221,7 +4861,7 @@
                   <a:schemeClr val="accent5"/>
                 </a:solidFill>
               </a:rPr>
-              <a:t>Criterio SSF  </a:t>
+              <a:t>Criterio  </a:t>
             </a:r>
             <a:pPr indent="0" marL="0">
               <a:spcAft>
@@ -4235,7 +4875,7 @@
                   <a:schemeClr val="tx1"/>
                 </a:solidFill>
               </a:rPr>
-              <a:t>Incumplimiento Art. 3 literal h) NRP-17</a:t>
+              <a:t>Art. 3 literal h) NRP-17</a:t>
             </a:r>
             <a:endParaRPr lang="en-US" sz="1050" dirty="0"/>
           </a:p>
@@ -4436,7 +5076,7 @@
                   <a:schemeClr val="tx1"/>
                 </a:solidFill>
               </a:rPr>
-              <a:t>Consejo de Administración / Asamblea</a:t>
+              <a:t>Consejo de Administración · Asamblea General de Asociados</a:t>
             </a:r>
             <a:endParaRPr lang="en-US" sz="1050" dirty="0"/>
           </a:p>
@@ -4453,7 +5093,7 @@
                   <a:schemeClr val="accent5"/>
                 </a:solidFill>
               </a:rPr>
-              <a:t>Criterio SSF  </a:t>
+              <a:t>Criterio  </a:t>
             </a:r>
             <a:pPr indent="0" marL="0">
               <a:spcAft>
@@ -4467,7 +5107,7 @@
                   <a:schemeClr val="tx1"/>
                 </a:solidFill>
               </a:rPr>
-              <a:t>Actualizar Reglamento y autorización de Asamblea</a:t>
+              <a:t>Arts. 12 lit. g) y q), 27 lit. a) NRP-17</a:t>
             </a:r>
             <a:endParaRPr lang="en-US" sz="1050" dirty="0"/>
           </a:p>
@@ -4651,7 +5291,7 @@
                   <a:schemeClr val="tx1"/>
                 </a:solidFill>
               </a:rPr>
-              <a:t>Departamento de Procesos / Líderes de Área</a:t>
+              <a:t>Líderes de procesos · Departamento de Procesos</a:t>
             </a:r>
             <a:endParaRPr lang="en-US" sz="1050" dirty="0"/>
           </a:p>
@@ -4668,7 +5308,7 @@
                   <a:schemeClr val="accent5"/>
                 </a:solidFill>
               </a:rPr>
-              <a:t>Criterio SSF  </a:t>
+              <a:t>Criterio  </a:t>
             </a:r>
             <a:pPr indent="0" marL="0">
               <a:spcAft>
@@ -4682,7 +5322,7 @@
                   <a:schemeClr val="tx1"/>
                 </a:solidFill>
               </a:rPr>
-              <a:t>9 documentos vencidos (RIT, Auditoría, Riesgos, etc.)</a:t>
+              <a:t>Art. 12 lit. n) NRP-17 · 9 documentos</a:t>
             </a:r>
             <a:endParaRPr lang="en-US" sz="1050" dirty="0"/>
           </a:p>
@@ -4883,7 +5523,7 @@
                   <a:schemeClr val="tx1"/>
                 </a:solidFill>
               </a:rPr>
-              <a:t>Gerencia de Créditos / Riesgos</a:t>
+              <a:t>Consejo de Administración (acuerdos de las ferias no identificados)</a:t>
             </a:r>
             <a:endParaRPr lang="en-US" sz="1050" dirty="0"/>
           </a:p>
@@ -4900,7 +5540,7 @@
                   <a:schemeClr val="accent5"/>
                 </a:solidFill>
               </a:rPr>
-              <a:t>Criterio SSF  </a:t>
+              <a:t>Criterio  </a:t>
             </a:r>
             <a:pPr indent="0" marL="0">
               <a:spcAft>
@@ -4914,7 +5554,7 @@
                   <a:schemeClr val="tx1"/>
                 </a:solidFill>
               </a:rPr>
-              <a:t>Sin acuerdos de CA ni soporte de tasas</a:t>
+              <a:t>Sin acuerdos ni soporte de cambios de tasa</a:t>
             </a:r>
             <a:endParaRPr lang="en-US" sz="1050" dirty="0"/>
           </a:p>
@@ -5098,7 +5738,7 @@
                   <a:schemeClr val="tx1"/>
                 </a:solidFill>
               </a:rPr>
-              <a:t>Directivos y Equipo Gerencial</a:t>
+              <a:t>Miembros del Consejo de Administración y equipo gerencial</a:t>
             </a:r>
             <a:endParaRPr lang="en-US" sz="1050" dirty="0"/>
           </a:p>
@@ -5115,7 +5755,7 @@
                   <a:schemeClr val="accent5"/>
                 </a:solidFill>
               </a:rPr>
-              <a:t>Criterio SSF  </a:t>
+              <a:t>Criterio  </a:t>
             </a:r>
             <a:pPr indent="0" marL="0">
               <a:spcAft>
@@ -5129,7 +5769,7 @@
                   <a:schemeClr val="tx1"/>
                 </a:solidFill>
               </a:rPr>
-              <a:t>Incumplimiento Art. 9 NRP-75</a:t>
+              <a:t>Art. 9 NRP-75</a:t>
             </a:r>
             <a:endParaRPr lang="en-US" sz="1050" dirty="0"/>
           </a:p>
@@ -5313,7 +5953,7 @@
                   <a:schemeClr val="tx1"/>
                 </a:solidFill>
               </a:rPr>
-              <a:t>Servicios Generales / Área Contratante</a:t>
+              <a:t>Jefe de Servicios Generales · áreas solicitantes</a:t>
             </a:r>
             <a:endParaRPr lang="en-US" sz="1050" dirty="0"/>
           </a:p>
@@ -5330,7 +5970,7 @@
                   <a:schemeClr val="accent5"/>
                 </a:solidFill>
               </a:rPr>
-              <a:t>Criterio SSF  </a:t>
+              <a:t>Criterio  </a:t>
             </a:r>
             <a:pPr indent="0" marL="0">
               <a:spcAft>
@@ -5344,7 +5984,7 @@
                   <a:schemeClr val="tx1"/>
                 </a:solidFill>
               </a:rPr>
-              <a:t>Cotizaciones sin sellar y falta de cláusula penal</a:t>
+              <a:t>Cotizaciones sin sello · sin cláusula de penalización</a:t>
             </a:r>
             <a:endParaRPr lang="en-US" sz="1050" dirty="0"/>
           </a:p>
@@ -5528,7 +6168,7 @@
                   <a:schemeClr val="tx1"/>
                 </a:solidFill>
               </a:rPr>
-              <a:t>Comité de Educación / Gerencia Financiera</a:t>
+              <a:t>Comité de Educación · Comité Socio Cultural</a:t>
             </a:r>
             <a:endParaRPr lang="en-US" sz="1050" dirty="0"/>
           </a:p>
@@ -5545,7 +6185,7 @@
                   <a:schemeClr val="accent5"/>
                 </a:solidFill>
               </a:rPr>
-              <a:t>Criterio SSF  </a:t>
+              <a:t>Criterio  </a:t>
             </a:r>
             <a:pPr indent="0" marL="0">
               <a:spcAft>
@@ -5559,7 +6199,7 @@
                   <a:schemeClr val="tx1"/>
                 </a:solidFill>
               </a:rPr>
-              <a:t>Fuera del Art. 59 Ley de Cooperativas</a:t>
+              <a:t>Art. 59 LGAC y Art. 69 de su Reglamento</a:t>
             </a:r>
             <a:endParaRPr lang="en-US" sz="1050" dirty="0"/>
           </a:p>
@@ -5667,7 +6307,7 @@
                   <a:schemeClr val="accent5"/>
                 </a:solidFill>
               </a:rPr>
-              <a:t>NOTA DS-SABAO-BCS-BC-22741 · VISITA CON CORTE AL 31/07/2026</a:t>
+              <a:t>CIRCULAR DS-SABAO-BCS-BC-22741 · VISITA CON CORTE AL 31/07/2026</a:t>
             </a:r>
             <a:endParaRPr lang="en-US" sz="1100" dirty="0"/>
           </a:p>
@@ -5849,7 +6489,7 @@
         <p:spPr>
           <a:xfrm>
             <a:off x="548640" y="1298448"/>
-            <a:ext cx="7315200" cy="256032"/>
+            <a:ext cx="8229600" cy="256032"/>
           </a:xfrm>
           <a:prstGeom prst="rect">
             <a:avLst/>
@@ -5870,7 +6510,7 @@
                   <a:schemeClr val="accent2"/>
                 </a:solidFill>
               </a:rPr>
-              <a:t>ANEXO A · OBSERVACIONES DETERMINADAS EN LA VISITA 2026</a:t>
+              <a:t>ANEXO A · OBSERVACIONES NUEVAS DETERMINADAS EN LA VISITA 2026</a:t>
             </a:r>
             <a:endParaRPr lang="en-US" sz="1100" dirty="0"/>
           </a:p>
@@ -5885,11 +6525,11 @@
         <p:spPr>
           <a:xfrm>
             <a:off x="548640" y="1600200"/>
-            <a:ext cx="2670734" cy="1463040"/>
+            <a:ext cx="2670734" cy="1481328"/>
           </a:xfrm>
           <a:prstGeom prst="roundRect">
             <a:avLst>
-              <a:gd name="adj" fmla="val 6250"/>
+              <a:gd name="adj" fmla="val 6173"/>
             </a:avLst>
           </a:prstGeom>
           <a:solidFill>
@@ -5913,7 +6553,7 @@
         </p:nvSpPr>
         <p:spPr>
           <a:xfrm>
-            <a:off x="713232" y="1746504"/>
+            <a:off x="694944" y="1728216"/>
             <a:ext cx="329184" cy="329184"/>
           </a:xfrm>
           <a:prstGeom prst="ellipse">
@@ -5940,7 +6580,7 @@
         </p:nvSpPr>
         <p:spPr>
           <a:xfrm>
-            <a:off x="713232" y="1746504"/>
+            <a:off x="694944" y="1728216"/>
             <a:ext cx="329184" cy="329184"/>
           </a:xfrm>
           <a:prstGeom prst="rect">
@@ -5973,14 +6613,14 @@
       </p:sp>
       <p:sp>
         <p:nvSpPr>
-          <p:cNvPr id="12" name="Responsable A-1"/>
-          <p:cNvSpPr txBox="1"/>
-          <p:nvPr/>
-        </p:nvSpPr>
-        <p:spPr>
-          <a:xfrm>
-            <a:off x="1143000" y="1719072"/>
-            <a:ext cx="1939214" cy="384048"/>
+          <p:cNvPr id="12" name="Criterio A-1"/>
+          <p:cNvSpPr txBox="1"/>
+          <p:nvPr/>
+        </p:nvSpPr>
+        <p:spPr>
+          <a:xfrm>
+            <a:off x="1115568" y="1709928"/>
+            <a:ext cx="1984934" cy="365760"/>
           </a:xfrm>
           <a:prstGeom prst="rect">
             <a:avLst/>
@@ -5996,86 +6636,97 @@
               <a:buNone/>
             </a:pPr>
             <a:r>
-              <a:rPr lang="en-US" sz="1050" dirty="0">
+              <a:rPr lang="en-US" sz="1000" b="1" dirty="0">
+                <a:solidFill>
+                  <a:schemeClr val="accent2"/>
+                </a:solidFill>
+              </a:rPr>
+              <a:t>Art. 11 NRP-17</a:t>
+            </a:r>
+            <a:endParaRPr lang="en-US" sz="1000" dirty="0"/>
+          </a:p>
+        </p:txBody>
+      </p:sp>
+      <p:sp>
+        <p:nvSpPr>
+          <p:cNvPr id="13" name="Título A-1"/>
+          <p:cNvSpPr txBox="1"/>
+          <p:nvPr/>
+        </p:nvSpPr>
+        <p:spPr>
+          <a:xfrm>
+            <a:off x="694944" y="2130552"/>
+            <a:ext cx="2378126" cy="530352"/>
+          </a:xfrm>
+          <a:prstGeom prst="rect">
+            <a:avLst/>
+          </a:prstGeom>
+          <a:noFill/>
+          <a:ln/>
+        </p:spPr>
+        <p:txBody>
+          <a:bodyPr wrap="square" lIns="0" tIns="0" rIns="0" bIns="0" rtlCol="0" anchor="t"/>
+          <a:lstStyle/>
+          <a:p>
+            <a:pPr indent="0" marL="0">
+              <a:buNone/>
+            </a:pPr>
+            <a:r>
+              <a:rPr lang="en-US" sz="1150" b="1" dirty="0">
+                <a:solidFill>
+                  <a:schemeClr val="tx1"/>
+                </a:solidFill>
+              </a:rPr>
+              <a:t>Falta de inducción sobre partidas relevantes de EEFF a nuevos miembros</a:t>
+            </a:r>
+            <a:endParaRPr lang="en-US" sz="1150" dirty="0"/>
+          </a:p>
+        </p:txBody>
+      </p:sp>
+      <p:sp>
+        <p:nvSpPr>
+          <p:cNvPr id="14" name="Responsable A-1"/>
+          <p:cNvSpPr txBox="1"/>
+          <p:nvPr/>
+        </p:nvSpPr>
+        <p:spPr>
+          <a:xfrm>
+            <a:off x="694944" y="2651760"/>
+            <a:ext cx="2378126" cy="384048"/>
+          </a:xfrm>
+          <a:prstGeom prst="rect">
+            <a:avLst/>
+          </a:prstGeom>
+          <a:noFill/>
+          <a:ln/>
+        </p:spPr>
+        <p:txBody>
+          <a:bodyPr wrap="square" lIns="0" tIns="0" rIns="0" bIns="0" rtlCol="0" anchor="t"/>
+          <a:lstStyle/>
+          <a:p>
+            <a:pPr indent="0" marL="0">
+              <a:buNone/>
+            </a:pPr>
+            <a:r>
+              <a:rPr lang="en-US" sz="1000" b="1" dirty="0">
                 <a:solidFill>
                   <a:schemeClr val="accent5"/>
                 </a:solidFill>
               </a:rPr>
-              <a:t>Gerencia Financiera / RRHH</a:t>
-            </a:r>
-            <a:endParaRPr lang="en-US" sz="1050" dirty="0"/>
-          </a:p>
-        </p:txBody>
-      </p:sp>
-      <p:sp>
-        <p:nvSpPr>
-          <p:cNvPr id="13" name="Título A-1"/>
-          <p:cNvSpPr txBox="1"/>
-          <p:nvPr/>
-        </p:nvSpPr>
-        <p:spPr>
-          <a:xfrm>
-            <a:off x="713232" y="2148840"/>
-            <a:ext cx="2341550" cy="594360"/>
-          </a:xfrm>
-          <a:prstGeom prst="rect">
-            <a:avLst/>
-          </a:prstGeom>
-          <a:noFill/>
-          <a:ln/>
-        </p:spPr>
-        <p:txBody>
-          <a:bodyPr wrap="square" lIns="0" tIns="0" rIns="0" bIns="0" rtlCol="0" anchor="t"/>
-          <a:lstStyle/>
-          <a:p>
-            <a:pPr indent="0" marL="0">
-              <a:buNone/>
-            </a:pPr>
-            <a:r>
-              <a:rPr lang="en-US" sz="1150" b="1" dirty="0">
+              <a:t>Responsable: </a:t>
+            </a:r>
+            <a:pPr indent="0" marL="0">
+              <a:buNone/>
+            </a:pPr>
+            <a:r>
+              <a:rPr lang="en-US" sz="1000" dirty="0">
                 <a:solidFill>
                   <a:schemeClr val="tx1"/>
                 </a:solidFill>
               </a:rPr>
-              <a:t>Falta de inducción sobre partidas relevantes de EEFF a nuevos miembros</a:t>
-            </a:r>
-            <a:endParaRPr lang="en-US" sz="1150" dirty="0"/>
-          </a:p>
-        </p:txBody>
-      </p:sp>
-      <p:sp>
-        <p:nvSpPr>
-          <p:cNvPr id="14" name="Criterio A-1"/>
-          <p:cNvSpPr txBox="1"/>
-          <p:nvPr/>
-        </p:nvSpPr>
-        <p:spPr>
-          <a:xfrm>
-            <a:off x="713232" y="2761488"/>
-            <a:ext cx="2341550" cy="219456"/>
-          </a:xfrm>
-          <a:prstGeom prst="rect">
-            <a:avLst/>
-          </a:prstGeom>
-          <a:noFill/>
-          <a:ln/>
-        </p:spPr>
-        <p:txBody>
-          <a:bodyPr wrap="square" lIns="0" tIns="0" rIns="0" bIns="0" rtlCol="0" anchor="t"/>
-          <a:lstStyle/>
-          <a:p>
-            <a:pPr indent="0" marL="0">
-              <a:buNone/>
-            </a:pPr>
-            <a:r>
-              <a:rPr lang="en-US" sz="1050" b="1" dirty="0">
-                <a:solidFill>
-                  <a:schemeClr val="accent2"/>
-                </a:solidFill>
-              </a:rPr>
-              <a:t>Art. 11 NRP-17</a:t>
-            </a:r>
-            <a:endParaRPr lang="en-US" sz="1050" dirty="0"/>
+              <a:t>Gerencia Financiera (imparte la inducción según el Manual)</a:t>
+            </a:r>
+            <a:endParaRPr lang="en-US" sz="1000" dirty="0"/>
           </a:p>
         </p:txBody>
       </p:sp>
@@ -6088,11 +6739,11 @@
         <p:spPr>
           <a:xfrm>
             <a:off x="3356534" y="1600200"/>
-            <a:ext cx="2670734" cy="1463040"/>
+            <a:ext cx="2670734" cy="1481328"/>
           </a:xfrm>
           <a:prstGeom prst="roundRect">
             <a:avLst>
-              <a:gd name="adj" fmla="val 6250"/>
+              <a:gd name="adj" fmla="val 6173"/>
             </a:avLst>
           </a:prstGeom>
           <a:solidFill>
@@ -6116,7 +6767,7 @@
         </p:nvSpPr>
         <p:spPr>
           <a:xfrm>
-            <a:off x="3521126" y="1746504"/>
+            <a:off x="3502838" y="1728216"/>
             <a:ext cx="329184" cy="329184"/>
           </a:xfrm>
           <a:prstGeom prst="ellipse">
@@ -6143,7 +6794,7 @@
         </p:nvSpPr>
         <p:spPr>
           <a:xfrm>
-            <a:off x="3521126" y="1746504"/>
+            <a:off x="3502838" y="1728216"/>
             <a:ext cx="329184" cy="329184"/>
           </a:xfrm>
           <a:prstGeom prst="rect">
@@ -6176,14 +6827,14 @@
       </p:sp>
       <p:sp>
         <p:nvSpPr>
-          <p:cNvPr id="18" name="Responsable A-2"/>
-          <p:cNvSpPr txBox="1"/>
-          <p:nvPr/>
-        </p:nvSpPr>
-        <p:spPr>
-          <a:xfrm>
-            <a:off x="3950894" y="1719072"/>
-            <a:ext cx="1939214" cy="384048"/>
+          <p:cNvPr id="18" name="Criterio A-2"/>
+          <p:cNvSpPr txBox="1"/>
+          <p:nvPr/>
+        </p:nvSpPr>
+        <p:spPr>
+          <a:xfrm>
+            <a:off x="3923462" y="1709928"/>
+            <a:ext cx="1984934" cy="365760"/>
           </a:xfrm>
           <a:prstGeom prst="rect">
             <a:avLst/>
@@ -6199,86 +6850,97 @@
               <a:buNone/>
             </a:pPr>
             <a:r>
-              <a:rPr lang="en-US" sz="1050" dirty="0">
+              <a:rPr lang="en-US" sz="1000" b="1" dirty="0">
+                <a:solidFill>
+                  <a:schemeClr val="accent2"/>
+                </a:solidFill>
+              </a:rPr>
+              <a:t>Cap. XI Código de Conducta</a:t>
+            </a:r>
+            <a:endParaRPr lang="en-US" sz="1000" dirty="0"/>
+          </a:p>
+        </p:txBody>
+      </p:sp>
+      <p:sp>
+        <p:nvSpPr>
+          <p:cNvPr id="19" name="Título A-2"/>
+          <p:cNvSpPr txBox="1"/>
+          <p:nvPr/>
+        </p:nvSpPr>
+        <p:spPr>
+          <a:xfrm>
+            <a:off x="3502838" y="2130552"/>
+            <a:ext cx="2378126" cy="530352"/>
+          </a:xfrm>
+          <a:prstGeom prst="rect">
+            <a:avLst/>
+          </a:prstGeom>
+          <a:noFill/>
+          <a:ln/>
+        </p:spPr>
+        <p:txBody>
+          <a:bodyPr wrap="square" lIns="0" tIns="0" rIns="0" bIns="0" rtlCol="0" anchor="t"/>
+          <a:lstStyle/>
+          <a:p>
+            <a:pPr indent="0" marL="0">
+              <a:buNone/>
+            </a:pPr>
+            <a:r>
+              <a:rPr lang="en-US" sz="1150" b="1" dirty="0">
+                <a:solidFill>
+                  <a:schemeClr val="tx1"/>
+                </a:solidFill>
+              </a:rPr>
+              <a:t>Falta de Certificación de Lectura del Código de Conducta</a:t>
+            </a:r>
+            <a:endParaRPr lang="en-US" sz="1150" dirty="0"/>
+          </a:p>
+        </p:txBody>
+      </p:sp>
+      <p:sp>
+        <p:nvSpPr>
+          <p:cNvPr id="20" name="Responsable A-2"/>
+          <p:cNvSpPr txBox="1"/>
+          <p:nvPr/>
+        </p:nvSpPr>
+        <p:spPr>
+          <a:xfrm>
+            <a:off x="3502838" y="2651760"/>
+            <a:ext cx="2378126" cy="384048"/>
+          </a:xfrm>
+          <a:prstGeom prst="rect">
+            <a:avLst/>
+          </a:prstGeom>
+          <a:noFill/>
+          <a:ln/>
+        </p:spPr>
+        <p:txBody>
+          <a:bodyPr wrap="square" lIns="0" tIns="0" rIns="0" bIns="0" rtlCol="0" anchor="t"/>
+          <a:lstStyle/>
+          <a:p>
+            <a:pPr indent="0" marL="0">
+              <a:buNone/>
+            </a:pPr>
+            <a:r>
+              <a:rPr lang="en-US" sz="1000" b="1" dirty="0">
                 <a:solidFill>
                   <a:schemeClr val="accent5"/>
                 </a:solidFill>
               </a:rPr>
-              <a:t>Junta de Vigilancia / Comités de Apoyo</a:t>
-            </a:r>
-            <a:endParaRPr lang="en-US" sz="1050" dirty="0"/>
-          </a:p>
-        </p:txBody>
-      </p:sp>
-      <p:sp>
-        <p:nvSpPr>
-          <p:cNvPr id="19" name="Título A-2"/>
-          <p:cNvSpPr txBox="1"/>
-          <p:nvPr/>
-        </p:nvSpPr>
-        <p:spPr>
-          <a:xfrm>
-            <a:off x="3521126" y="2148840"/>
-            <a:ext cx="2341550" cy="594360"/>
-          </a:xfrm>
-          <a:prstGeom prst="rect">
-            <a:avLst/>
-          </a:prstGeom>
-          <a:noFill/>
-          <a:ln/>
-        </p:spPr>
-        <p:txBody>
-          <a:bodyPr wrap="square" lIns="0" tIns="0" rIns="0" bIns="0" rtlCol="0" anchor="t"/>
-          <a:lstStyle/>
-          <a:p>
-            <a:pPr indent="0" marL="0">
-              <a:buNone/>
-            </a:pPr>
-            <a:r>
-              <a:rPr lang="en-US" sz="1150" b="1" dirty="0">
+              <a:t>Responsable: </a:t>
+            </a:r>
+            <a:pPr indent="0" marL="0">
+              <a:buNone/>
+            </a:pPr>
+            <a:r>
+              <a:rPr lang="en-US" sz="1000" dirty="0">
                 <a:solidFill>
                   <a:schemeClr val="tx1"/>
                 </a:solidFill>
               </a:rPr>
-              <a:t>Falta de Certificación de Lectura del Código de Conducta</a:t>
-            </a:r>
-            <a:endParaRPr lang="en-US" sz="1150" dirty="0"/>
-          </a:p>
-        </p:txBody>
-      </p:sp>
-      <p:sp>
-        <p:nvSpPr>
-          <p:cNvPr id="20" name="Criterio A-2"/>
-          <p:cNvSpPr txBox="1"/>
-          <p:nvPr/>
-        </p:nvSpPr>
-        <p:spPr>
-          <a:xfrm>
-            <a:off x="3521126" y="2761488"/>
-            <a:ext cx="2341550" cy="219456"/>
-          </a:xfrm>
-          <a:prstGeom prst="rect">
-            <a:avLst/>
-          </a:prstGeom>
-          <a:noFill/>
-          <a:ln/>
-        </p:spPr>
-        <p:txBody>
-          <a:bodyPr wrap="square" lIns="0" tIns="0" rIns="0" bIns="0" rtlCol="0" anchor="t"/>
-          <a:lstStyle/>
-          <a:p>
-            <a:pPr indent="0" marL="0">
-              <a:buNone/>
-            </a:pPr>
-            <a:r>
-              <a:rPr lang="en-US" sz="1050" b="1" dirty="0">
-                <a:solidFill>
-                  <a:schemeClr val="accent2"/>
-                </a:solidFill>
-              </a:rPr>
-              <a:t>Código de Conducta</a:t>
-            </a:r>
-            <a:endParaRPr lang="en-US" sz="1050" dirty="0"/>
+              <a:t>Junta de Vigilancia · Comité de Créditos · Comité de Educación</a:t>
+            </a:r>
+            <a:endParaRPr lang="en-US" sz="1000" dirty="0"/>
           </a:p>
         </p:txBody>
       </p:sp>
@@ -6291,11 +6953,11 @@
         <p:spPr>
           <a:xfrm>
             <a:off x="6164428" y="1600200"/>
-            <a:ext cx="2670734" cy="1463040"/>
+            <a:ext cx="2670734" cy="1481328"/>
           </a:xfrm>
           <a:prstGeom prst="roundRect">
             <a:avLst>
-              <a:gd name="adj" fmla="val 6250"/>
+              <a:gd name="adj" fmla="val 6173"/>
             </a:avLst>
           </a:prstGeom>
           <a:solidFill>
@@ -6319,7 +6981,7 @@
         </p:nvSpPr>
         <p:spPr>
           <a:xfrm>
-            <a:off x="6329020" y="1746504"/>
+            <a:off x="6310732" y="1728216"/>
             <a:ext cx="329184" cy="329184"/>
           </a:xfrm>
           <a:prstGeom prst="ellipse">
@@ -6346,7 +7008,7 @@
         </p:nvSpPr>
         <p:spPr>
           <a:xfrm>
-            <a:off x="6329020" y="1746504"/>
+            <a:off x="6310732" y="1728216"/>
             <a:ext cx="329184" cy="329184"/>
           </a:xfrm>
           <a:prstGeom prst="rect">
@@ -6379,14 +7041,14 @@
       </p:sp>
       <p:sp>
         <p:nvSpPr>
-          <p:cNvPr id="24" name="Responsable A-3"/>
-          <p:cNvSpPr txBox="1"/>
-          <p:nvPr/>
-        </p:nvSpPr>
-        <p:spPr>
-          <a:xfrm>
-            <a:off x="6758788" y="1719072"/>
-            <a:ext cx="1939214" cy="384048"/>
+          <p:cNvPr id="24" name="Criterio A-3"/>
+          <p:cNvSpPr txBox="1"/>
+          <p:nvPr/>
+        </p:nvSpPr>
+        <p:spPr>
+          <a:xfrm>
+            <a:off x="6731356" y="1709928"/>
+            <a:ext cx="1984934" cy="365760"/>
           </a:xfrm>
           <a:prstGeom prst="rect">
             <a:avLst/>
@@ -6402,86 +7064,97 @@
               <a:buNone/>
             </a:pPr>
             <a:r>
-              <a:rPr lang="en-US" sz="1050" dirty="0">
+              <a:rPr lang="en-US" sz="1000" b="1" dirty="0">
+                <a:solidFill>
+                  <a:schemeClr val="accent2"/>
+                </a:solidFill>
+              </a:rPr>
+              <a:t>Art. 12 lit. c) NRP-17</a:t>
+            </a:r>
+            <a:endParaRPr lang="en-US" sz="1000" dirty="0"/>
+          </a:p>
+        </p:txBody>
+      </p:sp>
+      <p:sp>
+        <p:nvSpPr>
+          <p:cNvPr id="25" name="Título A-3"/>
+          <p:cNvSpPr txBox="1"/>
+          <p:nvPr/>
+        </p:nvSpPr>
+        <p:spPr>
+          <a:xfrm>
+            <a:off x="6310732" y="2130552"/>
+            <a:ext cx="2378126" cy="530352"/>
+          </a:xfrm>
+          <a:prstGeom prst="rect">
+            <a:avLst/>
+          </a:prstGeom>
+          <a:noFill/>
+          <a:ln/>
+        </p:spPr>
+        <p:txBody>
+          <a:bodyPr wrap="square" lIns="0" tIns="0" rIns="0" bIns="0" rtlCol="0" anchor="t"/>
+          <a:lstStyle/>
+          <a:p>
+            <a:pPr indent="0" marL="0">
+              <a:buNone/>
+            </a:pPr>
+            <a:r>
+              <a:rPr lang="en-US" sz="1150" b="1" dirty="0">
+                <a:solidFill>
+                  <a:schemeClr val="tx1"/>
+                </a:solidFill>
+              </a:rPr>
+              <a:t>Falta de formalización y aprobación de políticas</a:t>
+            </a:r>
+            <a:endParaRPr lang="en-US" sz="1150" dirty="0"/>
+          </a:p>
+        </p:txBody>
+      </p:sp>
+      <p:sp>
+        <p:nvSpPr>
+          <p:cNvPr id="26" name="Responsable A-3"/>
+          <p:cNvSpPr txBox="1"/>
+          <p:nvPr/>
+        </p:nvSpPr>
+        <p:spPr>
+          <a:xfrm>
+            <a:off x="6310732" y="2651760"/>
+            <a:ext cx="2378126" cy="384048"/>
+          </a:xfrm>
+          <a:prstGeom prst="rect">
+            <a:avLst/>
+          </a:prstGeom>
+          <a:noFill/>
+          <a:ln/>
+        </p:spPr>
+        <p:txBody>
+          <a:bodyPr wrap="square" lIns="0" tIns="0" rIns="0" bIns="0" rtlCol="0" anchor="t"/>
+          <a:lstStyle/>
+          <a:p>
+            <a:pPr indent="0" marL="0">
+              <a:buNone/>
+            </a:pPr>
+            <a:r>
+              <a:rPr lang="en-US" sz="1000" b="1" dirty="0">
                 <a:solidFill>
                   <a:schemeClr val="accent5"/>
                 </a:solidFill>
               </a:rPr>
+              <a:t>Responsable: </a:t>
+            </a:r>
+            <a:pPr indent="0" marL="0">
+              <a:buNone/>
+            </a:pPr>
+            <a:r>
+              <a:rPr lang="en-US" sz="1000" dirty="0">
+                <a:solidFill>
+                  <a:schemeClr val="tx1"/>
+                </a:solidFill>
+              </a:rPr>
               <a:t>Consejo de Administración</a:t>
             </a:r>
-            <a:endParaRPr lang="en-US" sz="1050" dirty="0"/>
-          </a:p>
-        </p:txBody>
-      </p:sp>
-      <p:sp>
-        <p:nvSpPr>
-          <p:cNvPr id="25" name="Título A-3"/>
-          <p:cNvSpPr txBox="1"/>
-          <p:nvPr/>
-        </p:nvSpPr>
-        <p:spPr>
-          <a:xfrm>
-            <a:off x="6329020" y="2148840"/>
-            <a:ext cx="2341550" cy="594360"/>
-          </a:xfrm>
-          <a:prstGeom prst="rect">
-            <a:avLst/>
-          </a:prstGeom>
-          <a:noFill/>
-          <a:ln/>
-        </p:spPr>
-        <p:txBody>
-          <a:bodyPr wrap="square" lIns="0" tIns="0" rIns="0" bIns="0" rtlCol="0" anchor="t"/>
-          <a:lstStyle/>
-          <a:p>
-            <a:pPr indent="0" marL="0">
-              <a:buNone/>
-            </a:pPr>
-            <a:r>
-              <a:rPr lang="en-US" sz="1150" b="1" dirty="0">
-                <a:solidFill>
-                  <a:schemeClr val="tx1"/>
-                </a:solidFill>
-              </a:rPr>
-              <a:t>Falta de formalización y aprobación de Políticas por el Consejo</a:t>
-            </a:r>
-            <a:endParaRPr lang="en-US" sz="1150" dirty="0"/>
-          </a:p>
-        </p:txBody>
-      </p:sp>
-      <p:sp>
-        <p:nvSpPr>
-          <p:cNvPr id="26" name="Criterio A-3"/>
-          <p:cNvSpPr txBox="1"/>
-          <p:nvPr/>
-        </p:nvSpPr>
-        <p:spPr>
-          <a:xfrm>
-            <a:off x="6329020" y="2761488"/>
-            <a:ext cx="2341550" cy="219456"/>
-          </a:xfrm>
-          <a:prstGeom prst="rect">
-            <a:avLst/>
-          </a:prstGeom>
-          <a:noFill/>
-          <a:ln/>
-        </p:spPr>
-        <p:txBody>
-          <a:bodyPr wrap="square" lIns="0" tIns="0" rIns="0" bIns="0" rtlCol="0" anchor="t"/>
-          <a:lstStyle/>
-          <a:p>
-            <a:pPr indent="0" marL="0">
-              <a:buNone/>
-            </a:pPr>
-            <a:r>
-              <a:rPr lang="en-US" sz="1050" b="1" dirty="0">
-                <a:solidFill>
-                  <a:schemeClr val="accent2"/>
-                </a:solidFill>
-              </a:rPr>
-              <a:t>Políticas de Retribución y Control Interno</a:t>
-            </a:r>
-            <a:endParaRPr lang="en-US" sz="1050" dirty="0"/>
+            <a:endParaRPr lang="en-US" sz="1000" dirty="0"/>
           </a:p>
         </p:txBody>
       </p:sp>
@@ -6494,11 +7167,11 @@
         <p:spPr>
           <a:xfrm>
             <a:off x="8972321" y="1600200"/>
-            <a:ext cx="2670734" cy="1463040"/>
+            <a:ext cx="2670734" cy="1481328"/>
           </a:xfrm>
           <a:prstGeom prst="roundRect">
             <a:avLst>
-              <a:gd name="adj" fmla="val 6250"/>
+              <a:gd name="adj" fmla="val 6173"/>
             </a:avLst>
           </a:prstGeom>
           <a:solidFill>
@@ -6522,7 +7195,7 @@
         </p:nvSpPr>
         <p:spPr>
           <a:xfrm>
-            <a:off x="9136913" y="1746504"/>
+            <a:off x="9118625" y="1728216"/>
             <a:ext cx="329184" cy="329184"/>
           </a:xfrm>
           <a:prstGeom prst="ellipse">
@@ -6549,7 +7222,7 @@
         </p:nvSpPr>
         <p:spPr>
           <a:xfrm>
-            <a:off x="9136913" y="1746504"/>
+            <a:off x="9118625" y="1728216"/>
             <a:ext cx="329184" cy="329184"/>
           </a:xfrm>
           <a:prstGeom prst="rect">
@@ -6582,14 +7255,14 @@
       </p:sp>
       <p:sp>
         <p:nvSpPr>
-          <p:cNvPr id="30" name="Responsable A-4"/>
-          <p:cNvSpPr txBox="1"/>
-          <p:nvPr/>
-        </p:nvSpPr>
-        <p:spPr>
-          <a:xfrm>
-            <a:off x="9566681" y="1719072"/>
-            <a:ext cx="1939214" cy="384048"/>
+          <p:cNvPr id="30" name="Criterio A-4"/>
+          <p:cNvSpPr txBox="1"/>
+          <p:nvPr/>
+        </p:nvSpPr>
+        <p:spPr>
+          <a:xfrm>
+            <a:off x="9539249" y="1709928"/>
+            <a:ext cx="1984934" cy="365760"/>
           </a:xfrm>
           <a:prstGeom prst="rect">
             <a:avLst/>
@@ -6605,86 +7278,97 @@
               <a:buNone/>
             </a:pPr>
             <a:r>
-              <a:rPr lang="en-US" sz="1050" dirty="0">
+              <a:rPr lang="en-US" sz="1000" b="1" dirty="0">
+                <a:solidFill>
+                  <a:schemeClr val="accent2"/>
+                </a:solidFill>
+              </a:rPr>
+              <a:t>Arts. 27 y 28 NRP-17</a:t>
+            </a:r>
+            <a:endParaRPr lang="en-US" sz="1000" dirty="0"/>
+          </a:p>
+        </p:txBody>
+      </p:sp>
+      <p:sp>
+        <p:nvSpPr>
+          <p:cNvPr id="31" name="Título A-4"/>
+          <p:cNvSpPr txBox="1"/>
+          <p:nvPr/>
+        </p:nvSpPr>
+        <p:spPr>
+          <a:xfrm>
+            <a:off x="9118625" y="2130552"/>
+            <a:ext cx="2378126" cy="530352"/>
+          </a:xfrm>
+          <a:prstGeom prst="rect">
+            <a:avLst/>
+          </a:prstGeom>
+          <a:noFill/>
+          <a:ln/>
+        </p:spPr>
+        <p:txBody>
+          <a:bodyPr wrap="square" lIns="0" tIns="0" rIns="0" bIns="0" rtlCol="0" anchor="t"/>
+          <a:lstStyle/>
+          <a:p>
+            <a:pPr indent="0" marL="0">
+              <a:buNone/>
+            </a:pPr>
+            <a:r>
+              <a:rPr lang="en-US" sz="1150" b="1" dirty="0">
+                <a:solidFill>
+                  <a:schemeClr val="tx1"/>
+                </a:solidFill>
+              </a:rPr>
+              <a:t>Información de comités desactualizada en el sitio web</a:t>
+            </a:r>
+            <a:endParaRPr lang="en-US" sz="1150" dirty="0"/>
+          </a:p>
+        </p:txBody>
+      </p:sp>
+      <p:sp>
+        <p:nvSpPr>
+          <p:cNvPr id="32" name="Responsable A-4"/>
+          <p:cNvSpPr txBox="1"/>
+          <p:nvPr/>
+        </p:nvSpPr>
+        <p:spPr>
+          <a:xfrm>
+            <a:off x="9118625" y="2651760"/>
+            <a:ext cx="2378126" cy="384048"/>
+          </a:xfrm>
+          <a:prstGeom prst="rect">
+            <a:avLst/>
+          </a:prstGeom>
+          <a:noFill/>
+          <a:ln/>
+        </p:spPr>
+        <p:txBody>
+          <a:bodyPr wrap="square" lIns="0" tIns="0" rIns="0" bIns="0" rtlCol="0" anchor="t"/>
+          <a:lstStyle/>
+          <a:p>
+            <a:pPr indent="0" marL="0">
+              <a:buNone/>
+            </a:pPr>
+            <a:r>
+              <a:rPr lang="en-US" sz="1000" b="1" dirty="0">
                 <a:solidFill>
                   <a:schemeClr val="accent5"/>
                 </a:solidFill>
               </a:rPr>
-              <a:t>Oficialía de Cumplimiento / Comunicaciones</a:t>
-            </a:r>
-            <a:endParaRPr lang="en-US" sz="1050" dirty="0"/>
-          </a:p>
-        </p:txBody>
-      </p:sp>
-      <p:sp>
-        <p:nvSpPr>
-          <p:cNvPr id="31" name="Título A-4"/>
-          <p:cNvSpPr txBox="1"/>
-          <p:nvPr/>
-        </p:nvSpPr>
-        <p:spPr>
-          <a:xfrm>
-            <a:off x="9136913" y="2148840"/>
-            <a:ext cx="2341550" cy="594360"/>
-          </a:xfrm>
-          <a:prstGeom prst="rect">
-            <a:avLst/>
-          </a:prstGeom>
-          <a:noFill/>
-          <a:ln/>
-        </p:spPr>
-        <p:txBody>
-          <a:bodyPr wrap="square" lIns="0" tIns="0" rIns="0" bIns="0" rtlCol="0" anchor="t"/>
-          <a:lstStyle/>
-          <a:p>
-            <a:pPr indent="0" marL="0">
-              <a:buNone/>
-            </a:pPr>
-            <a:r>
-              <a:rPr lang="en-US" sz="1150" b="1" dirty="0">
+              <a:t>Responsable: </a:t>
+            </a:r>
+            <a:pPr indent="0" marL="0">
+              <a:buNone/>
+            </a:pPr>
+            <a:r>
+              <a:rPr lang="en-US" sz="1000" dirty="0">
                 <a:solidFill>
                   <a:schemeClr val="tx1"/>
                 </a:solidFill>
               </a:rPr>
-              <a:t>Información de comités desactualizada en sitio web institucional</a:t>
-            </a:r>
-            <a:endParaRPr lang="en-US" sz="1150" dirty="0"/>
-          </a:p>
-        </p:txBody>
-      </p:sp>
-      <p:sp>
-        <p:nvSpPr>
-          <p:cNvPr id="32" name="Criterio A-4"/>
-          <p:cNvSpPr txBox="1"/>
-          <p:nvPr/>
-        </p:nvSpPr>
-        <p:spPr>
-          <a:xfrm>
-            <a:off x="9136913" y="2761488"/>
-            <a:ext cx="2341550" cy="219456"/>
-          </a:xfrm>
-          <a:prstGeom prst="rect">
-            <a:avLst/>
-          </a:prstGeom>
-          <a:noFill/>
-          <a:ln/>
-        </p:spPr>
-        <p:txBody>
-          <a:bodyPr wrap="square" lIns="0" tIns="0" rIns="0" bIns="0" rtlCol="0" anchor="t"/>
-          <a:lstStyle/>
-          <a:p>
-            <a:pPr indent="0" marL="0">
-              <a:buNone/>
-            </a:pPr>
-            <a:r>
-              <a:rPr lang="en-US" sz="1050" b="1" dirty="0">
-                <a:solidFill>
-                  <a:schemeClr val="accent2"/>
-                </a:solidFill>
-              </a:rPr>
-              <a:t>Arts. 27 y 28 NRP-17</a:t>
-            </a:r>
-            <a:endParaRPr lang="en-US" sz="1050" dirty="0"/>
+              <a:t>La circular no asigna área (Asociación Cooperativa)</a:t>
+            </a:r>
+            <a:endParaRPr lang="en-US" sz="1000" dirty="0"/>
           </a:p>
         </p:txBody>
       </p:sp>
@@ -6696,12 +7380,12 @@
         </p:nvSpPr>
         <p:spPr>
           <a:xfrm>
-            <a:off x="548640" y="3200400"/>
-            <a:ext cx="2670734" cy="1463040"/>
+            <a:off x="548640" y="3218688"/>
+            <a:ext cx="2670734" cy="1481328"/>
           </a:xfrm>
           <a:prstGeom prst="roundRect">
             <a:avLst>
-              <a:gd name="adj" fmla="val 6250"/>
+              <a:gd name="adj" fmla="val 6173"/>
             </a:avLst>
           </a:prstGeom>
           <a:solidFill>
@@ -6725,7 +7409,7 @@
         </p:nvSpPr>
         <p:spPr>
           <a:xfrm>
-            <a:off x="713232" y="3346704"/>
+            <a:off x="694944" y="3346704"/>
             <a:ext cx="329184" cy="329184"/>
           </a:xfrm>
           <a:prstGeom prst="ellipse">
@@ -6752,7 +7436,7 @@
         </p:nvSpPr>
         <p:spPr>
           <a:xfrm>
-            <a:off x="713232" y="3346704"/>
+            <a:off x="694944" y="3346704"/>
             <a:ext cx="329184" cy="329184"/>
           </a:xfrm>
           <a:prstGeom prst="rect">
@@ -6785,14 +7469,14 @@
       </p:sp>
       <p:sp>
         <p:nvSpPr>
-          <p:cNvPr id="36" name="Responsable A-5"/>
-          <p:cNvSpPr txBox="1"/>
-          <p:nvPr/>
-        </p:nvSpPr>
-        <p:spPr>
-          <a:xfrm>
-            <a:off x="1143000" y="3319272"/>
-            <a:ext cx="1939214" cy="384048"/>
+          <p:cNvPr id="36" name="Criterio A-5"/>
+          <p:cNvSpPr txBox="1"/>
+          <p:nvPr/>
+        </p:nvSpPr>
+        <p:spPr>
+          <a:xfrm>
+            <a:off x="1115568" y="3328416"/>
+            <a:ext cx="1984934" cy="365760"/>
           </a:xfrm>
           <a:prstGeom prst="rect">
             <a:avLst/>
@@ -6808,86 +7492,97 @@
               <a:buNone/>
             </a:pPr>
             <a:r>
-              <a:rPr lang="en-US" sz="1050" dirty="0">
+              <a:rPr lang="en-US" sz="1000" b="1" dirty="0">
+                <a:solidFill>
+                  <a:schemeClr val="accent2"/>
+                </a:solidFill>
+              </a:rPr>
+              <a:t>Art. 3 lit. i) y Art. 20 NRP-17</a:t>
+            </a:r>
+            <a:endParaRPr lang="en-US" sz="1000" dirty="0"/>
+          </a:p>
+        </p:txBody>
+      </p:sp>
+      <p:sp>
+        <p:nvSpPr>
+          <p:cNvPr id="37" name="Título A-5"/>
+          <p:cNvSpPr txBox="1"/>
+          <p:nvPr/>
+        </p:nvSpPr>
+        <p:spPr>
+          <a:xfrm>
+            <a:off x="694944" y="3749040"/>
+            <a:ext cx="2378126" cy="530352"/>
+          </a:xfrm>
+          <a:prstGeom prst="rect">
+            <a:avLst/>
+          </a:prstGeom>
+          <a:noFill/>
+          <a:ln/>
+        </p:spPr>
+        <p:txBody>
+          <a:bodyPr wrap="square" lIns="0" tIns="0" rIns="0" bIns="0" rtlCol="0" anchor="t"/>
+          <a:lstStyle/>
+          <a:p>
+            <a:pPr indent="0" marL="0">
+              <a:buNone/>
+            </a:pPr>
+            <a:r>
+              <a:rPr lang="en-US" sz="1150" b="1" dirty="0">
+                <a:solidFill>
+                  <a:schemeClr val="tx1"/>
+                </a:solidFill>
+              </a:rPr>
+              <a:t>Incongruencia entre Estatutos y Código de Gobierno Corporativo</a:t>
+            </a:r>
+            <a:endParaRPr lang="en-US" sz="1150" dirty="0"/>
+          </a:p>
+        </p:txBody>
+      </p:sp>
+      <p:sp>
+        <p:nvSpPr>
+          <p:cNvPr id="38" name="Responsable A-5"/>
+          <p:cNvSpPr txBox="1"/>
+          <p:nvPr/>
+        </p:nvSpPr>
+        <p:spPr>
+          <a:xfrm>
+            <a:off x="694944" y="4270248"/>
+            <a:ext cx="2378126" cy="384048"/>
+          </a:xfrm>
+          <a:prstGeom prst="rect">
+            <a:avLst/>
+          </a:prstGeom>
+          <a:noFill/>
+          <a:ln/>
+        </p:spPr>
+        <p:txBody>
+          <a:bodyPr wrap="square" lIns="0" tIns="0" rIns="0" bIns="0" rtlCol="0" anchor="t"/>
+          <a:lstStyle/>
+          <a:p>
+            <a:pPr indent="0" marL="0">
+              <a:buNone/>
+            </a:pPr>
+            <a:r>
+              <a:rPr lang="en-US" sz="1000" b="1" dirty="0">
                 <a:solidFill>
                   <a:schemeClr val="accent5"/>
                 </a:solidFill>
               </a:rPr>
-              <a:t>Asesoría Legal / Consejo de Administración</a:t>
-            </a:r>
-            <a:endParaRPr lang="en-US" sz="1050" dirty="0"/>
-          </a:p>
-        </p:txBody>
-      </p:sp>
-      <p:sp>
-        <p:nvSpPr>
-          <p:cNvPr id="37" name="Título A-5"/>
-          <p:cNvSpPr txBox="1"/>
-          <p:nvPr/>
-        </p:nvSpPr>
-        <p:spPr>
-          <a:xfrm>
-            <a:off x="713232" y="3749040"/>
-            <a:ext cx="2341550" cy="594360"/>
-          </a:xfrm>
-          <a:prstGeom prst="rect">
-            <a:avLst/>
-          </a:prstGeom>
-          <a:noFill/>
-          <a:ln/>
-        </p:spPr>
-        <p:txBody>
-          <a:bodyPr wrap="square" lIns="0" tIns="0" rIns="0" bIns="0" rtlCol="0" anchor="t"/>
-          <a:lstStyle/>
-          <a:p>
-            <a:pPr indent="0" marL="0">
-              <a:buNone/>
-            </a:pPr>
-            <a:r>
-              <a:rPr lang="en-US" sz="1150" b="1" dirty="0">
+              <a:t>Responsable: </a:t>
+            </a:r>
+            <a:pPr indent="0" marL="0">
+              <a:buNone/>
+            </a:pPr>
+            <a:r>
+              <a:rPr lang="en-US" sz="1000" dirty="0">
                 <a:solidFill>
                   <a:schemeClr val="tx1"/>
                 </a:solidFill>
               </a:rPr>
-              <a:t>Incongruencia entre Estatutos y Código de Gobierno Corporativo</a:t>
-            </a:r>
-            <a:endParaRPr lang="en-US" sz="1150" dirty="0"/>
-          </a:p>
-        </p:txBody>
-      </p:sp>
-      <p:sp>
-        <p:nvSpPr>
-          <p:cNvPr id="38" name="Criterio A-5"/>
-          <p:cNvSpPr txBox="1"/>
-          <p:nvPr/>
-        </p:nvSpPr>
-        <p:spPr>
-          <a:xfrm>
-            <a:off x="713232" y="4361688"/>
-            <a:ext cx="2341550" cy="219456"/>
-          </a:xfrm>
-          <a:prstGeom prst="rect">
-            <a:avLst/>
-          </a:prstGeom>
-          <a:noFill/>
-          <a:ln/>
-        </p:spPr>
-        <p:txBody>
-          <a:bodyPr wrap="square" lIns="0" tIns="0" rIns="0" bIns="0" rtlCol="0" anchor="t"/>
-          <a:lstStyle/>
-          <a:p>
-            <a:pPr indent="0" marL="0">
-              <a:buNone/>
-            </a:pPr>
-            <a:r>
-              <a:rPr lang="en-US" sz="1050" b="1" dirty="0">
-                <a:solidFill>
-                  <a:schemeClr val="accent2"/>
-                </a:solidFill>
-              </a:rPr>
-              <a:t>Restricción de cargos remunerados</a:t>
-            </a:r>
-            <a:endParaRPr lang="en-US" sz="1050" dirty="0"/>
+              <a:t>Consejo de Administración (aprobó el Código, Acta 2,663)</a:t>
+            </a:r>
+            <a:endParaRPr lang="en-US" sz="1000" dirty="0"/>
           </a:p>
         </p:txBody>
       </p:sp>
@@ -6899,12 +7594,12 @@
         </p:nvSpPr>
         <p:spPr>
           <a:xfrm>
-            <a:off x="3356534" y="3200400"/>
-            <a:ext cx="2670734" cy="1463040"/>
+            <a:off x="3356534" y="3218688"/>
+            <a:ext cx="2670734" cy="1481328"/>
           </a:xfrm>
           <a:prstGeom prst="roundRect">
             <a:avLst>
-              <a:gd name="adj" fmla="val 6250"/>
+              <a:gd name="adj" fmla="val 6173"/>
             </a:avLst>
           </a:prstGeom>
           <a:solidFill>
@@ -6928,7 +7623,7 @@
         </p:nvSpPr>
         <p:spPr>
           <a:xfrm>
-            <a:off x="3521126" y="3346704"/>
+            <a:off x="3502838" y="3346704"/>
             <a:ext cx="329184" cy="329184"/>
           </a:xfrm>
           <a:prstGeom prst="ellipse">
@@ -6955,7 +7650,7 @@
         </p:nvSpPr>
         <p:spPr>
           <a:xfrm>
-            <a:off x="3521126" y="3346704"/>
+            <a:off x="3502838" y="3346704"/>
             <a:ext cx="329184" cy="329184"/>
           </a:xfrm>
           <a:prstGeom prst="rect">
@@ -6988,14 +7683,14 @@
       </p:sp>
       <p:sp>
         <p:nvSpPr>
-          <p:cNvPr id="42" name="Responsable A-6"/>
-          <p:cNvSpPr txBox="1"/>
-          <p:nvPr/>
-        </p:nvSpPr>
-        <p:spPr>
-          <a:xfrm>
-            <a:off x="3950894" y="3319272"/>
-            <a:ext cx="1939214" cy="384048"/>
+          <p:cNvPr id="42" name="Criterio A-6"/>
+          <p:cNvSpPr txBox="1"/>
+          <p:nvPr/>
+        </p:nvSpPr>
+        <p:spPr>
+          <a:xfrm>
+            <a:off x="3923462" y="3328416"/>
+            <a:ext cx="1984934" cy="365760"/>
           </a:xfrm>
           <a:prstGeom prst="rect">
             <a:avLst/>
@@ -7011,86 +7706,97 @@
               <a:buNone/>
             </a:pPr>
             <a:r>
-              <a:rPr lang="en-US" sz="1050" dirty="0">
+              <a:rPr lang="en-US" sz="1000" b="1" dirty="0">
+                <a:solidFill>
+                  <a:schemeClr val="accent2"/>
+                </a:solidFill>
+              </a:rPr>
+              <a:t>Art. 59 LGAC · Art. 69 Reglamento</a:t>
+            </a:r>
+            <a:endParaRPr lang="en-US" sz="1000" dirty="0"/>
+          </a:p>
+        </p:txBody>
+      </p:sp>
+      <p:sp>
+        <p:nvSpPr>
+          <p:cNvPr id="43" name="Título A-6"/>
+          <p:cNvSpPr txBox="1"/>
+          <p:nvPr/>
+        </p:nvSpPr>
+        <p:spPr>
+          <a:xfrm>
+            <a:off x="3502838" y="3749040"/>
+            <a:ext cx="2378126" cy="530352"/>
+          </a:xfrm>
+          <a:prstGeom prst="rect">
+            <a:avLst/>
+          </a:prstGeom>
+          <a:noFill/>
+          <a:ln/>
+        </p:spPr>
+        <p:txBody>
+          <a:bodyPr wrap="square" lIns="0" tIns="0" rIns="0" bIns="0" rtlCol="0" anchor="t"/>
+          <a:lstStyle/>
+          <a:p>
+            <a:pPr indent="0" marL="0">
+              <a:buNone/>
+            </a:pPr>
+            <a:r>
+              <a:rPr lang="en-US" sz="1150" b="1" dirty="0">
+                <a:solidFill>
+                  <a:schemeClr val="tx1"/>
+                </a:solidFill>
+              </a:rPr>
+              <a:t>Reglamento del Fondo de Educación con conceptos no delimitados por Ley</a:t>
+            </a:r>
+            <a:endParaRPr lang="en-US" sz="1150" dirty="0"/>
+          </a:p>
+        </p:txBody>
+      </p:sp>
+      <p:sp>
+        <p:nvSpPr>
+          <p:cNvPr id="44" name="Responsable A-6"/>
+          <p:cNvSpPr txBox="1"/>
+          <p:nvPr/>
+        </p:nvSpPr>
+        <p:spPr>
+          <a:xfrm>
+            <a:off x="3502838" y="4270248"/>
+            <a:ext cx="2378126" cy="384048"/>
+          </a:xfrm>
+          <a:prstGeom prst="rect">
+            <a:avLst/>
+          </a:prstGeom>
+          <a:noFill/>
+          <a:ln/>
+        </p:spPr>
+        <p:txBody>
+          <a:bodyPr wrap="square" lIns="0" tIns="0" rIns="0" bIns="0" rtlCol="0" anchor="t"/>
+          <a:lstStyle/>
+          <a:p>
+            <a:pPr indent="0" marL="0">
+              <a:buNone/>
+            </a:pPr>
+            <a:r>
+              <a:rPr lang="en-US" sz="1000" b="1" dirty="0">
                 <a:solidFill>
                   <a:schemeClr val="accent5"/>
                 </a:solidFill>
               </a:rPr>
-              <a:t>Comité de Educación / Gerencia Financiera</a:t>
-            </a:r>
-            <a:endParaRPr lang="en-US" sz="1050" dirty="0"/>
-          </a:p>
-        </p:txBody>
-      </p:sp>
-      <p:sp>
-        <p:nvSpPr>
-          <p:cNvPr id="43" name="Título A-6"/>
-          <p:cNvSpPr txBox="1"/>
-          <p:nvPr/>
-        </p:nvSpPr>
-        <p:spPr>
-          <a:xfrm>
-            <a:off x="3521126" y="3749040"/>
-            <a:ext cx="2341550" cy="594360"/>
-          </a:xfrm>
-          <a:prstGeom prst="rect">
-            <a:avLst/>
-          </a:prstGeom>
-          <a:noFill/>
-          <a:ln/>
-        </p:spPr>
-        <p:txBody>
-          <a:bodyPr wrap="square" lIns="0" tIns="0" rIns="0" bIns="0" rtlCol="0" anchor="t"/>
-          <a:lstStyle/>
-          <a:p>
-            <a:pPr indent="0" marL="0">
-              <a:buNone/>
-            </a:pPr>
-            <a:r>
-              <a:rPr lang="en-US" sz="1150" b="1" dirty="0">
+              <a:t>Responsable: </a:t>
+            </a:r>
+            <a:pPr indent="0" marL="0">
+              <a:buNone/>
+            </a:pPr>
+            <a:r>
+              <a:rPr lang="en-US" sz="1000" dirty="0">
                 <a:solidFill>
                   <a:schemeClr val="tx1"/>
                 </a:solidFill>
               </a:rPr>
-              <a:t>Reglamento del Fondo de Educación incluye conceptos no delimitados por Ley</a:t>
-            </a:r>
-            <a:endParaRPr lang="en-US" sz="1150" dirty="0"/>
-          </a:p>
-        </p:txBody>
-      </p:sp>
-      <p:sp>
-        <p:nvSpPr>
-          <p:cNvPr id="44" name="Criterio A-6"/>
-          <p:cNvSpPr txBox="1"/>
-          <p:nvPr/>
-        </p:nvSpPr>
-        <p:spPr>
-          <a:xfrm>
-            <a:off x="3521126" y="4361688"/>
-            <a:ext cx="2341550" cy="219456"/>
-          </a:xfrm>
-          <a:prstGeom prst="rect">
-            <a:avLst/>
-          </a:prstGeom>
-          <a:noFill/>
-          <a:ln/>
-        </p:spPr>
-        <p:txBody>
-          <a:bodyPr wrap="square" lIns="0" tIns="0" rIns="0" bIns="0" rtlCol="0" anchor="t"/>
-          <a:lstStyle/>
-          <a:p>
-            <a:pPr indent="0" marL="0">
-              <a:buNone/>
-            </a:pPr>
-            <a:r>
-              <a:rPr lang="en-US" sz="1050" b="1" dirty="0">
-                <a:solidFill>
-                  <a:schemeClr val="accent2"/>
-                </a:solidFill>
-              </a:rPr>
-              <a:t>Art. 5 del Reglamento</a:t>
-            </a:r>
-            <a:endParaRPr lang="en-US" sz="1050" dirty="0"/>
+              <a:t>Comité de Educación (Reglamento, art. 5)</a:t>
+            </a:r>
+            <a:endParaRPr lang="en-US" sz="1000" dirty="0"/>
           </a:p>
         </p:txBody>
       </p:sp>
@@ -7102,12 +7808,12 @@
         </p:nvSpPr>
         <p:spPr>
           <a:xfrm>
-            <a:off x="6164428" y="3200400"/>
-            <a:ext cx="2670734" cy="1463040"/>
+            <a:off x="6164428" y="3218688"/>
+            <a:ext cx="2670734" cy="1481328"/>
           </a:xfrm>
           <a:prstGeom prst="roundRect">
             <a:avLst>
-              <a:gd name="adj" fmla="val 6250"/>
+              <a:gd name="adj" fmla="val 6173"/>
             </a:avLst>
           </a:prstGeom>
           <a:solidFill>
@@ -7131,7 +7837,7 @@
         </p:nvSpPr>
         <p:spPr>
           <a:xfrm>
-            <a:off x="6329020" y="3346704"/>
+            <a:off x="6310732" y="3346704"/>
             <a:ext cx="329184" cy="329184"/>
           </a:xfrm>
           <a:prstGeom prst="ellipse">
@@ -7158,7 +7864,7 @@
         </p:nvSpPr>
         <p:spPr>
           <a:xfrm>
-            <a:off x="6329020" y="3346704"/>
+            <a:off x="6310732" y="3346704"/>
             <a:ext cx="329184" cy="329184"/>
           </a:xfrm>
           <a:prstGeom prst="rect">
@@ -7191,14 +7897,14 @@
       </p:sp>
       <p:sp>
         <p:nvSpPr>
-          <p:cNvPr id="48" name="Responsable A-7"/>
-          <p:cNvSpPr txBox="1"/>
-          <p:nvPr/>
-        </p:nvSpPr>
-        <p:spPr>
-          <a:xfrm>
-            <a:off x="6758788" y="3319272"/>
-            <a:ext cx="1939214" cy="384048"/>
+          <p:cNvPr id="48" name="Criterio A-7"/>
+          <p:cNvSpPr txBox="1"/>
+          <p:nvPr/>
+        </p:nvSpPr>
+        <p:spPr>
+          <a:xfrm>
+            <a:off x="6731356" y="3328416"/>
+            <a:ext cx="1984934" cy="365760"/>
           </a:xfrm>
           <a:prstGeom prst="rect">
             <a:avLst/>
@@ -7214,86 +7920,97 @@
               <a:buNone/>
             </a:pPr>
             <a:r>
-              <a:rPr lang="en-US" sz="1050" dirty="0">
+              <a:rPr lang="en-US" sz="1000" b="1" dirty="0">
+                <a:solidFill>
+                  <a:schemeClr val="accent2"/>
+                </a:solidFill>
+              </a:rPr>
+              <a:t>Art. 12 lit. q) NRP-17 · US$100,774.28</a:t>
+            </a:r>
+            <a:endParaRPr lang="en-US" sz="1000" dirty="0"/>
+          </a:p>
+        </p:txBody>
+      </p:sp>
+      <p:sp>
+        <p:nvSpPr>
+          <p:cNvPr id="49" name="Título A-7"/>
+          <p:cNvSpPr txBox="1"/>
+          <p:nvPr/>
+        </p:nvSpPr>
+        <p:spPr>
+          <a:xfrm>
+            <a:off x="6310732" y="3749040"/>
+            <a:ext cx="2378126" cy="530352"/>
+          </a:xfrm>
+          <a:prstGeom prst="rect">
+            <a:avLst/>
+          </a:prstGeom>
+          <a:noFill/>
+          <a:ln/>
+        </p:spPr>
+        <p:txBody>
+          <a:bodyPr wrap="square" lIns="0" tIns="0" rIns="0" bIns="0" rtlCol="0" anchor="t"/>
+          <a:lstStyle/>
+          <a:p>
+            <a:pPr indent="0" marL="0">
+              <a:buNone/>
+            </a:pPr>
+            <a:r>
+              <a:rPr lang="en-US" sz="1150" b="1" dirty="0">
+                <a:solidFill>
+                  <a:schemeClr val="tx1"/>
+                </a:solidFill>
+              </a:rPr>
+              <a:t>Limitada transparencia a la Asamblea sobre el Fondo de Educación</a:t>
+            </a:r>
+            <a:endParaRPr lang="en-US" sz="1150" dirty="0"/>
+          </a:p>
+        </p:txBody>
+      </p:sp>
+      <p:sp>
+        <p:nvSpPr>
+          <p:cNvPr id="50" name="Responsable A-7"/>
+          <p:cNvSpPr txBox="1"/>
+          <p:nvPr/>
+        </p:nvSpPr>
+        <p:spPr>
+          <a:xfrm>
+            <a:off x="6310732" y="4270248"/>
+            <a:ext cx="2378126" cy="384048"/>
+          </a:xfrm>
+          <a:prstGeom prst="rect">
+            <a:avLst/>
+          </a:prstGeom>
+          <a:noFill/>
+          <a:ln/>
+        </p:spPr>
+        <p:txBody>
+          <a:bodyPr wrap="square" lIns="0" tIns="0" rIns="0" bIns="0" rtlCol="0" anchor="t"/>
+          <a:lstStyle/>
+          <a:p>
+            <a:pPr indent="0" marL="0">
+              <a:buNone/>
+            </a:pPr>
+            <a:r>
+              <a:rPr lang="en-US" sz="1000" b="1" dirty="0">
                 <a:solidFill>
                   <a:schemeClr val="accent5"/>
                 </a:solidFill>
               </a:rPr>
-              <a:t>Consejo de Administración / Comité de Educación</a:t>
-            </a:r>
-            <a:endParaRPr lang="en-US" sz="1050" dirty="0"/>
-          </a:p>
-        </p:txBody>
-      </p:sp>
-      <p:sp>
-        <p:nvSpPr>
-          <p:cNvPr id="49" name="Título A-7"/>
-          <p:cNvSpPr txBox="1"/>
-          <p:nvPr/>
-        </p:nvSpPr>
-        <p:spPr>
-          <a:xfrm>
-            <a:off x="6329020" y="3749040"/>
-            <a:ext cx="2341550" cy="594360"/>
-          </a:xfrm>
-          <a:prstGeom prst="rect">
-            <a:avLst/>
-          </a:prstGeom>
-          <a:noFill/>
-          <a:ln/>
-        </p:spPr>
-        <p:txBody>
-          <a:bodyPr wrap="square" lIns="0" tIns="0" rIns="0" bIns="0" rtlCol="0" anchor="t"/>
-          <a:lstStyle/>
-          <a:p>
-            <a:pPr indent="0" marL="0">
-              <a:buNone/>
-            </a:pPr>
-            <a:r>
-              <a:rPr lang="en-US" sz="1150" b="1" dirty="0">
+              <a:t>Responsable: </a:t>
+            </a:r>
+            <a:pPr indent="0" marL="0">
+              <a:buNone/>
+            </a:pPr>
+            <a:r>
+              <a:rPr lang="en-US" sz="1000" dirty="0">
                 <a:solidFill>
                   <a:schemeClr val="tx1"/>
                 </a:solidFill>
               </a:rPr>
-              <a:t>Limitada transparencia a la Asamblea sobre el Fondo de Educación</a:t>
-            </a:r>
-            <a:endParaRPr lang="en-US" sz="1150" dirty="0"/>
-          </a:p>
-        </p:txBody>
-      </p:sp>
-      <p:sp>
-        <p:nvSpPr>
-          <p:cNvPr id="50" name="Criterio A-7"/>
-          <p:cNvSpPr txBox="1"/>
-          <p:nvPr/>
-        </p:nvSpPr>
-        <p:spPr>
-          <a:xfrm>
-            <a:off x="6329020" y="4361688"/>
-            <a:ext cx="2341550" cy="219456"/>
-          </a:xfrm>
-          <a:prstGeom prst="rect">
-            <a:avLst/>
-          </a:prstGeom>
-          <a:noFill/>
-          <a:ln/>
-        </p:spPr>
-        <p:txBody>
-          <a:bodyPr wrap="square" lIns="0" tIns="0" rIns="0" bIns="0" rtlCol="0" anchor="t"/>
-          <a:lstStyle/>
-          <a:p>
-            <a:pPr indent="0" marL="0">
-              <a:buNone/>
-            </a:pPr>
-            <a:r>
-              <a:rPr lang="en-US" sz="1050" b="1" dirty="0">
-                <a:solidFill>
-                  <a:schemeClr val="accent2"/>
-                </a:solidFill>
-              </a:rPr>
-              <a:t>$100,774.28 no detallados</a:t>
-            </a:r>
-            <a:endParaRPr lang="en-US" sz="1050" dirty="0"/>
+              <a:t>Consejo de Administración (Memoria de Labores 2025)</a:t>
+            </a:r>
+            <a:endParaRPr lang="en-US" sz="1000" dirty="0"/>
           </a:p>
         </p:txBody>
       </p:sp>
@@ -7305,12 +8022,12 @@
         </p:nvSpPr>
         <p:spPr>
           <a:xfrm>
-            <a:off x="8972321" y="3200400"/>
-            <a:ext cx="2670734" cy="1463040"/>
+            <a:off x="8972321" y="3218688"/>
+            <a:ext cx="2670734" cy="1481328"/>
           </a:xfrm>
           <a:prstGeom prst="roundRect">
             <a:avLst>
-              <a:gd name="adj" fmla="val 6250"/>
+              <a:gd name="adj" fmla="val 6173"/>
             </a:avLst>
           </a:prstGeom>
           <a:solidFill>
@@ -7334,7 +8051,7 @@
         </p:nvSpPr>
         <p:spPr>
           <a:xfrm>
-            <a:off x="9155201" y="3310128"/>
+            <a:off x="9155201" y="3328416"/>
             <a:ext cx="822960" cy="640080"/>
           </a:xfrm>
           <a:prstGeom prst="rect">
@@ -7373,7 +8090,7 @@
         </p:nvSpPr>
         <p:spPr>
           <a:xfrm>
-            <a:off x="9978161" y="3355848"/>
+            <a:off x="9978161" y="3374136"/>
             <a:ext cx="1527734" cy="548640"/>
           </a:xfrm>
           <a:prstGeom prst="rect">
@@ -7409,8 +8126,8 @@
         </p:nvSpPr>
         <p:spPr>
           <a:xfrm>
-            <a:off x="9155201" y="4005072"/>
-            <a:ext cx="2350694" cy="457200"/>
+            <a:off x="9155201" y="4041648"/>
+            <a:ext cx="2350694" cy="502920"/>
           </a:xfrm>
           <a:prstGeom prst="rect">
             <a:avLst/>
@@ -7460,7 +8177,7 @@
         <p:spPr>
           <a:xfrm>
             <a:off x="548640" y="4828032"/>
-            <a:ext cx="7315200" cy="237744"/>
+            <a:ext cx="8229600" cy="237744"/>
           </a:xfrm>
           <a:prstGeom prst="rect">
             <a:avLst/>
@@ -7489,18 +8206,18 @@
       </p:sp>
       <p:sp>
         <p:nvSpPr>
-          <p:cNvPr id="56" name="Anexo B-8"/>
+          <p:cNvPr id="56" name="Anexo B-3"/>
           <p:cNvSpPr/>
           <p:nvPr/>
         </p:nvSpPr>
         <p:spPr>
           <a:xfrm>
             <a:off x="548640" y="5120640"/>
-            <a:ext cx="4074681" cy="1143000"/>
+            <a:ext cx="4074681" cy="1124712"/>
           </a:xfrm>
           <a:prstGeom prst="roundRect">
             <a:avLst>
-              <a:gd name="adj" fmla="val 8000"/>
+              <a:gd name="adj" fmla="val 8130"/>
             </a:avLst>
           </a:prstGeom>
           <a:solidFill>
@@ -7526,7 +8243,7 @@
         </p:nvSpPr>
         <p:spPr>
           <a:xfrm>
-            <a:off x="731520" y="5294376"/>
+            <a:off x="731520" y="5276088"/>
             <a:ext cx="1325880" cy="274320"/>
           </a:xfrm>
           <a:prstGeom prst="roundRect">
@@ -7555,7 +8272,7 @@
         </p:nvSpPr>
         <p:spPr>
           <a:xfrm>
-            <a:off x="731520" y="5294376"/>
+            <a:off x="731520" y="5276088"/>
             <a:ext cx="1325880" cy="274320"/>
           </a:xfrm>
           <a:prstGeom prst="rect">
@@ -7591,7 +8308,7 @@
         </p:nvSpPr>
         <p:spPr>
           <a:xfrm>
-            <a:off x="2194560" y="5294376"/>
+            <a:off x="2194560" y="5276088"/>
             <a:ext cx="1325880" cy="274320"/>
           </a:xfrm>
           <a:prstGeom prst="roundRect">
@@ -7620,7 +8337,7 @@
         </p:nvSpPr>
         <p:spPr>
           <a:xfrm>
-            <a:off x="2194560" y="5294376"/>
+            <a:off x="2194560" y="5276088"/>
             <a:ext cx="1325880" cy="274320"/>
           </a:xfrm>
           <a:prstGeom prst="rect">
@@ -7650,13 +8367,13 @@
       </p:sp>
       <p:sp>
         <p:nvSpPr>
-          <p:cNvPr id="61" name="Título B-8"/>
-          <p:cNvSpPr txBox="1"/>
-          <p:nvPr/>
-        </p:nvSpPr>
-        <p:spPr>
-          <a:xfrm>
-            <a:off x="731520" y="5687568"/>
+          <p:cNvPr id="61" name="Título B-3"/>
+          <p:cNvSpPr txBox="1"/>
+          <p:nvPr/>
+        </p:nvSpPr>
+        <p:spPr>
+          <a:xfrm>
+            <a:off x="731520" y="5650992"/>
             <a:ext cx="3708921" cy="274320"/>
           </a:xfrm>
           <a:prstGeom prst="rect">
@@ -7686,13 +8403,13 @@
       </p:sp>
       <p:sp>
         <p:nvSpPr>
-          <p:cNvPr id="62" name="Responsable B-8"/>
-          <p:cNvSpPr txBox="1"/>
-          <p:nvPr/>
-        </p:nvSpPr>
-        <p:spPr>
-          <a:xfrm>
-            <a:off x="731520" y="5971032"/>
+          <p:cNvPr id="62" name="Responsable B-3"/>
+          <p:cNvSpPr txBox="1"/>
+          <p:nvPr/>
+        </p:nvSpPr>
+        <p:spPr>
+          <a:xfrm>
+            <a:off x="731520" y="5934456"/>
             <a:ext cx="3708921" cy="228600"/>
           </a:xfrm>
           <a:prstGeom prst="rect">
@@ -7722,18 +8439,18 @@
       </p:sp>
       <p:sp>
         <p:nvSpPr>
-          <p:cNvPr id="63" name="Anexo B-9"/>
+          <p:cNvPr id="63" name="Anexo B-5"/>
           <p:cNvSpPr/>
           <p:nvPr/>
         </p:nvSpPr>
         <p:spPr>
           <a:xfrm>
             <a:off x="4760481" y="5120640"/>
-            <a:ext cx="4074681" cy="1143000"/>
+            <a:ext cx="4074681" cy="1124712"/>
           </a:xfrm>
           <a:prstGeom prst="roundRect">
             <a:avLst>
-              <a:gd name="adj" fmla="val 8000"/>
+              <a:gd name="adj" fmla="val 8130"/>
             </a:avLst>
           </a:prstGeom>
           <a:solidFill>
@@ -7759,7 +8476,7 @@
         </p:nvSpPr>
         <p:spPr>
           <a:xfrm>
-            <a:off x="4943361" y="5294376"/>
+            <a:off x="4943361" y="5276088"/>
             <a:ext cx="1325880" cy="274320"/>
           </a:xfrm>
           <a:prstGeom prst="roundRect">
@@ -7788,7 +8505,7 @@
         </p:nvSpPr>
         <p:spPr>
           <a:xfrm>
-            <a:off x="4943361" y="5294376"/>
+            <a:off x="4943361" y="5276088"/>
             <a:ext cx="1325880" cy="274320"/>
           </a:xfrm>
           <a:prstGeom prst="rect">
@@ -7824,7 +8541,7 @@
         </p:nvSpPr>
         <p:spPr>
           <a:xfrm>
-            <a:off x="6406401" y="5294376"/>
+            <a:off x="6406401" y="5276088"/>
             <a:ext cx="2194560" cy="274320"/>
           </a:xfrm>
           <a:prstGeom prst="roundRect">
@@ -7853,7 +8570,7 @@
         </p:nvSpPr>
         <p:spPr>
           <a:xfrm>
-            <a:off x="6406401" y="5294376"/>
+            <a:off x="6406401" y="5276088"/>
             <a:ext cx="2194560" cy="274320"/>
           </a:xfrm>
           <a:prstGeom prst="rect">
@@ -7883,13 +8600,13 @@
       </p:sp>
       <p:sp>
         <p:nvSpPr>
-          <p:cNvPr id="68" name="Título B-9"/>
-          <p:cNvSpPr txBox="1"/>
-          <p:nvPr/>
-        </p:nvSpPr>
-        <p:spPr>
-          <a:xfrm>
-            <a:off x="4943361" y="5687568"/>
+          <p:cNvPr id="68" name="Título B-5"/>
+          <p:cNvSpPr txBox="1"/>
+          <p:nvPr/>
+        </p:nvSpPr>
+        <p:spPr>
+          <a:xfrm>
+            <a:off x="4943361" y="5650992"/>
             <a:ext cx="3708921" cy="274320"/>
           </a:xfrm>
           <a:prstGeom prst="rect">
@@ -7919,13 +8636,13 @@
       </p:sp>
       <p:sp>
         <p:nvSpPr>
-          <p:cNvPr id="69" name="Responsable B-9"/>
-          <p:cNvSpPr txBox="1"/>
-          <p:nvPr/>
-        </p:nvSpPr>
-        <p:spPr>
-          <a:xfrm>
-            <a:off x="4943361" y="5971032"/>
+          <p:cNvPr id="69" name="Responsable B-5"/>
+          <p:cNvSpPr txBox="1"/>
+          <p:nvPr/>
+        </p:nvSpPr>
+        <p:spPr>
+          <a:xfrm>
+            <a:off x="4943361" y="5934456"/>
             <a:ext cx="3708921" cy="228600"/>
           </a:xfrm>
           <a:prstGeom prst="rect">
@@ -7947,7 +8664,7 @@
                   <a:schemeClr val="accent5"/>
                 </a:solidFill>
               </a:rPr>
-              <a:t>Depto. de Procesos · RIT, Comité de Auditoría, Compras</a:t>
+              <a:t>Responsable: líderes de procesos · Departamento de Procesos</a:t>
             </a:r>
             <a:endParaRPr lang="en-US" sz="1050" dirty="0"/>
           </a:p>
@@ -7962,11 +8679,11 @@
         <p:spPr>
           <a:xfrm>
             <a:off x="8972321" y="5120640"/>
-            <a:ext cx="2670734" cy="1143000"/>
+            <a:ext cx="2670734" cy="1124712"/>
           </a:xfrm>
           <a:prstGeom prst="roundRect">
             <a:avLst>
-              <a:gd name="adj" fmla="val 8000"/>
+              <a:gd name="adj" fmla="val 8130"/>
             </a:avLst>
           </a:prstGeom>
           <a:solidFill>
@@ -8065,7 +8782,7 @@
         </p:nvSpPr>
         <p:spPr>
           <a:xfrm>
-            <a:off x="9155201" y="5806440"/>
+            <a:off x="9155201" y="5788152"/>
             <a:ext cx="2396414" cy="411480"/>
           </a:xfrm>
           <a:prstGeom prst="rect">
@@ -8731,7 +9448,7 @@
                   <a:schemeClr val="tx1"/>
                 </a:solidFill>
               </a:rPr>
-              <a:t>Informe preliminar · Nota 22741</a:t>
+              <a:t>Informe preliminar · Circular 22741</a:t>
             </a:r>
             <a:endParaRPr lang="en-US" sz="1400" dirty="0"/>
           </a:p>
@@ -8917,7 +9634,7 @@
                   <a:schemeClr val="tx1"/>
                 </a:solidFill>
               </a:rPr>
-              <a:t>Nombramiento SSF · Nota 18432</a:t>
+              <a:t>Nombramiento SSF · Circular 18432</a:t>
             </a:r>
             <a:endParaRPr lang="en-US" sz="1400" dirty="0"/>
           </a:p>
@@ -9028,7 +9745,7 @@
                   <a:schemeClr val="tx1"/>
                 </a:solidFill>
               </a:rPr>
-              <a:t>Informe preliminar · Nota 17003</a:t>
+              <a:t>Informe preliminar · Circular 17003</a:t>
             </a:r>
             <a:endParaRPr lang="en-US" sz="1400" dirty="0"/>
           </a:p>
@@ -9214,7 +9931,7 @@
                   <a:schemeClr val="tx1"/>
                 </a:solidFill>
               </a:rPr>
-              <a:t>Nombramiento SSF · Nota 9337</a:t>
+              <a:t>Nombramiento SSF · Circular 9337</a:t>
             </a:r>
             <a:endParaRPr lang="en-US" sz="1400" dirty="0"/>
           </a:p>
@@ -9317,7 +10034,7 @@
                   <a:schemeClr val="accent2"/>
                 </a:solidFill>
               </a:rPr>
-              <a:t>Resultado 2026 · Nota 22741</a:t>
+              <a:t>Resultado 2026 · Circular 22741</a:t>
             </a:r>
             <a:endParaRPr lang="en-US" sz="1300" dirty="0"/>
           </a:p>
@@ -9468,7 +10185,7 @@
                   <a:schemeClr val="accent1"/>
                 </a:solidFill>
               </a:rPr>
-              <a:t>Hallazgos críticos 2025 · Nota 17003</a:t>
+              <a:t>Hallazgos críticos 2025 · Circular 17003</a:t>
             </a:r>
             <a:endParaRPr lang="en-US" sz="1300" dirty="0"/>
           </a:p>

</xml_diff>

<commit_message>
Update responsables for 2026 obs. 4 and Anexo B; same follow-up color on 2025 slide
Co-Authored-By: Claude Opus 5.5 <noreply@anthropic.com>
Claude-Session: https://claude.ai/code/session_01F1WXR13Nv8neEtLhaK3ELa
</commit_message>
<xml_diff>
--- a/supervision-gobierno-corporativo/Supervision_GC_SSF_COMEDICA_2025-2026.pptx
+++ b/supervision-gobierno-corporativo/Supervision_GC_SSF_COMEDICA_2025-2026.pptx
@@ -110,22 +110,22 @@
   <p:extLst>
     <p:ext uri="{521415D9-36F7-43E2-AB2F-B90AF26B5E84}">
       <p14:sectionLst xmlns:p14="http://schemas.microsoft.com/office/powerpoint/2010/main">
-        <p14:section name="1 · Resumen de circulares SSF" id="{9c9cef2f-96c7-da3e-9de2-93f489c33286}">
+        <p14:section name="1 · Resumen de circulares SSF" id="{f9503725-973f-be0f-5b82-dc370838496b}">
           <p14:sldIdLst>
             <p14:sldId id="256"/>
           </p14:sldIdLst>
         </p14:section>
-        <p14:section name="2 · Observaciones 2025" id="{2cd61f1b-0b52-671a-8a9b-6f782ce87562}">
+        <p14:section name="2 · Observaciones 2025" id="{5d0dccff-9e2d-da8d-f81f-339c7cb37267}">
           <p14:sldIdLst>
             <p14:sldId id="257"/>
           </p14:sldIdLst>
         </p14:section>
-        <p14:section name="3 · Observaciones 2026" id="{c593cf52-04da-3b88-9970-b33b87bbea4d}">
+        <p14:section name="3 · Observaciones 2026" id="{e473c08b-67ad-e499-6d52-2b5d5c8ee2b7}">
           <p14:sldIdLst>
             <p14:sldId id="258"/>
           </p14:sldIdLst>
         </p14:section>
-        <p14:section name="4 · Línea de tiempo y evolución" id="{d63d6be1-b406-d975-6c3e-5cf951955212}">
+        <p14:section name="4 · Línea de tiempo y evolución" id="{c2ec5134-aca0-ca02-a64c-f762a9ece58e}">
           <p14:sldIdLst>
             <p14:sldId id="259"/>
           </p14:sldIdLst>
@@ -710,7 +710,7 @@
           <a:p>
             <a:r>
               <a:rPr lang="en-US" dirty="0"/>
-              <a:t>Anexo A: siete observaciones nuevas; los responsables son los que señala la Circular 22741 (en la obs. 4 la circular no asigna un área específica). Plazo de 10 días hábiles para remitir pruebas de descargo, previo conocimiento del Consejo de Administración. Anexo B: no son observaciones nuevas, es el seguimiento a las obs. 3 y 5 de 2025; plan de solución en 15 días hábiles con acciones, responsable, plazo por acción y certificación del punto de acta del Consejo. Fechas aproximadas sin asuetos.</a:t>
+              <a:t>Anexo A: siete observaciones nuevas; los responsables son los que señala la Circular 22741 (en la obs. 4, Administración de Riesgo). Plazo de 10 días hábiles para remitir pruebas de descargo, previo conocimiento del Consejo de Administración. Anexo B: no son observaciones nuevas, es el seguimiento a las obs. 3 y 5 de 2025; plan de solución en 15 días hábiles con acciones, responsable, plazo por acción y certificación del punto de acta del Consejo. Fechas aproximadas sin asuetos.</a:t>
             </a:r>
             <a:endParaRPr lang="en-US" dirty="0"/>
           </a:p>
@@ -5157,11 +5157,11 @@
             <a:avLst/>
           </a:prstGeom>
           <a:solidFill>
-            <a:schemeClr val="accent6"/>
+            <a:schemeClr val="accent3"/>
           </a:solidFill>
           <a:ln w="12700">
             <a:solidFill>
-              <a:schemeClr val="accent6">
+              <a:schemeClr val="accent3">
                 <a:alpha val="0"/>
               </a:schemeClr>
             </a:solidFill>
@@ -5336,7 +5336,7 @@
             <a:r>
               <a:rPr lang="en-US" sz="1050" b="1" dirty="0">
                 <a:solidFill>
-                  <a:schemeClr val="accent6"/>
+                  <a:schemeClr val="accent3"/>
                 </a:solidFill>
               </a:rPr>
               <a:t>↳ Seguimiento 2026: PARCIALMENTE SUPERADA</a:t>
@@ -7366,7 +7366,7 @@
                   <a:schemeClr val="tx1"/>
                 </a:solidFill>
               </a:rPr>
-              <a:t>La circular no asigna área (Asociación Cooperativa)</a:t>
+              <a:t>Administración de Riesgo</a:t>
             </a:r>
             <a:endParaRPr lang="en-US" sz="1000" dirty="0"/>
           </a:p>
@@ -8373,8 +8373,8 @@
         </p:nvSpPr>
         <p:spPr>
           <a:xfrm>
-            <a:off x="731520" y="5650992"/>
-            <a:ext cx="3708921" cy="274320"/>
+            <a:off x="731520" y="5623560"/>
+            <a:ext cx="3708921" cy="256032"/>
           </a:xfrm>
           <a:prstGeom prst="rect">
             <a:avLst/>
@@ -8409,8 +8409,8 @@
         </p:nvSpPr>
         <p:spPr>
           <a:xfrm>
-            <a:off x="731520" y="5934456"/>
-            <a:ext cx="3708921" cy="228600"/>
+            <a:off x="731520" y="5888736"/>
+            <a:ext cx="3708921" cy="310896"/>
           </a:xfrm>
           <a:prstGeom prst="rect">
             <a:avLst/>
@@ -8426,12 +8426,23 @@
               <a:buNone/>
             </a:pPr>
             <a:r>
+              <a:rPr lang="en-US" sz="1050" b="1" dirty="0">
+                <a:solidFill>
+                  <a:schemeClr val="accent5"/>
+                </a:solidFill>
+              </a:rPr>
+              <a:t>Responsable: </a:t>
+            </a:r>
+            <a:pPr indent="0" marL="0">
+              <a:buNone/>
+            </a:pPr>
+            <a:r>
               <a:rPr lang="en-US" sz="1050" dirty="0">
                 <a:solidFill>
-                  <a:schemeClr val="accent5"/>
-                </a:solidFill>
-              </a:rPr>
-              <a:t>Responsable: Consejo de Administración</a:t>
+                  <a:schemeClr val="tx1"/>
+                </a:solidFill>
+              </a:rPr>
+              <a:t>Administración de Riesgo</a:t>
             </a:r>
             <a:endParaRPr lang="en-US" sz="1050" dirty="0"/>
           </a:p>
@@ -8606,8 +8617,8 @@
         </p:nvSpPr>
         <p:spPr>
           <a:xfrm>
-            <a:off x="4943361" y="5650992"/>
-            <a:ext cx="3708921" cy="274320"/>
+            <a:off x="4943361" y="5623560"/>
+            <a:ext cx="3708921" cy="256032"/>
           </a:xfrm>
           <a:prstGeom prst="rect">
             <a:avLst/>
@@ -8642,8 +8653,8 @@
         </p:nvSpPr>
         <p:spPr>
           <a:xfrm>
-            <a:off x="4943361" y="5934456"/>
-            <a:ext cx="3708921" cy="228600"/>
+            <a:off x="4943361" y="5888736"/>
+            <a:ext cx="3708921" cy="310896"/>
           </a:xfrm>
           <a:prstGeom prst="rect">
             <a:avLst/>
@@ -8659,12 +8670,23 @@
               <a:buNone/>
             </a:pPr>
             <a:r>
+              <a:rPr lang="en-US" sz="1050" b="1" dirty="0">
+                <a:solidFill>
+                  <a:schemeClr val="accent5"/>
+                </a:solidFill>
+              </a:rPr>
+              <a:t>Responsables: </a:t>
+            </a:r>
+            <a:pPr indent="0" marL="0">
+              <a:buNone/>
+            </a:pPr>
+            <a:r>
               <a:rPr lang="en-US" sz="1050" dirty="0">
                 <a:solidFill>
-                  <a:schemeClr val="accent5"/>
-                </a:solidFill>
-              </a:rPr>
-              <a:t>Responsable: líderes de procesos · Departamento de Procesos</a:t>
+                  <a:schemeClr val="tx1"/>
+                </a:solidFill>
+              </a:rPr>
+              <a:t>Auditoría Interna, Servicios Generales y Talento Humano</a:t>
             </a:r>
             <a:endParaRPr lang="en-US" sz="1050" dirty="0"/>
           </a:p>

</xml_diff>

<commit_message>
Slide 1: split summary figures by year and remove step labels
Co-Authored-By: Claude Opus 5.5 <noreply@anthropic.com>
Claude-Session: https://claude.ai/code/session_01F1WXR13Nv8neEtLhaK3ELa
</commit_message>
<xml_diff>
--- a/supervision-gobierno-corporativo/Supervision_GC_SSF_COMEDICA_2025-2026.pptx
+++ b/supervision-gobierno-corporativo/Supervision_GC_SSF_COMEDICA_2025-2026.pptx
@@ -110,22 +110,22 @@
   <p:extLst>
     <p:ext uri="{521415D9-36F7-43E2-AB2F-B90AF26B5E84}">
       <p14:sectionLst xmlns:p14="http://schemas.microsoft.com/office/powerpoint/2010/main">
-        <p14:section name="1 · Resumen de circulares SSF" id="{f9503725-973f-be0f-5b82-dc370838496b}">
+        <p14:section name="1 · Resumen de circulares SSF" id="{619f2926-fd99-cca1-1be0-1035ac208998}">
           <p14:sldIdLst>
             <p14:sldId id="256"/>
           </p14:sldIdLst>
         </p14:section>
-        <p14:section name="2 · Observaciones 2025" id="{5d0dccff-9e2d-da8d-f81f-339c7cb37267}">
+        <p14:section name="2 · Observaciones 2025" id="{ccdfb403-7b12-d3a4-9611-e82fe676afd5}">
           <p14:sldIdLst>
             <p14:sldId id="257"/>
           </p14:sldIdLst>
         </p14:section>
-        <p14:section name="3 · Observaciones 2026" id="{e473c08b-67ad-e499-6d52-2b5d5c8ee2b7}">
+        <p14:section name="3 · Observaciones 2026" id="{ad589576-44a1-76d6-d228-14ef33ae39c6}">
           <p14:sldIdLst>
             <p14:sldId id="258"/>
           </p14:sldIdLst>
         </p14:section>
-        <p14:section name="4 · Línea de tiempo y evolución" id="{c2ec5134-aca0-ca02-a64c-f762a9ece58e}">
+        <p14:section name="4 · Línea de tiempo y evolución" id="{372e2051-7d80-12e8-24f4-ab370725ff6b}">
           <p14:sldIdLst>
             <p14:sldId id="259"/>
           </p14:sldIdLst>
@@ -1743,401 +1743,24 @@
       </p:sp>
       <p:sp>
         <p:nvSpPr>
-          <p:cNvPr id="4" name="KPI valor 1"/>
-          <p:cNvSpPr txBox="1"/>
-          <p:nvPr/>
-        </p:nvSpPr>
-        <p:spPr>
-          <a:xfrm>
-            <a:off x="548640" y="3154680"/>
-            <a:ext cx="1463040" cy="594360"/>
-          </a:xfrm>
-          <a:prstGeom prst="rect">
-            <a:avLst/>
-          </a:prstGeom>
-          <a:noFill/>
-          <a:ln/>
-        </p:spPr>
-        <p:txBody>
-          <a:bodyPr wrap="square" lIns="0" tIns="0" rIns="0" bIns="0" rtlCol="0" anchor="b"/>
-          <a:lstStyle/>
-          <a:p>
-            <a:pPr indent="0" marL="0">
-              <a:buNone/>
-            </a:pPr>
-            <a:r>
-              <a:rPr lang="en-US" sz="3400" b="1" dirty="0">
-                <a:solidFill>
-                  <a:schemeClr val="bg1"/>
-                </a:solidFill>
-                <a:latin typeface="Cambria" pitchFamily="34" charset="0"/>
-                <a:ea typeface="Cambria" pitchFamily="34" charset="-122"/>
-                <a:cs typeface="Cambria" pitchFamily="34" charset="-120"/>
-              </a:rPr>
-              <a:t>4</a:t>
-            </a:r>
-            <a:endParaRPr lang="en-US" sz="3400" dirty="0"/>
-          </a:p>
-        </p:txBody>
-      </p:sp>
-      <p:sp>
-        <p:nvSpPr>
-          <p:cNvPr id="5" name="KPI texto 1"/>
-          <p:cNvSpPr txBox="1"/>
-          <p:nvPr/>
-        </p:nvSpPr>
-        <p:spPr>
-          <a:xfrm>
-            <a:off x="548640" y="3794760"/>
-            <a:ext cx="1463040" cy="548640"/>
-          </a:xfrm>
-          <a:prstGeom prst="rect">
-            <a:avLst/>
-          </a:prstGeom>
-          <a:noFill/>
-          <a:ln/>
-        </p:spPr>
-        <p:txBody>
-          <a:bodyPr wrap="square" lIns="0" tIns="0" rIns="0" bIns="0" rtlCol="0" anchor="t"/>
-          <a:lstStyle/>
-          <a:p>
-            <a:pPr indent="0" marL="0">
-              <a:buNone/>
-            </a:pPr>
-            <a:r>
-              <a:rPr lang="en-US" sz="1200" dirty="0">
-                <a:solidFill>
-                  <a:schemeClr val="bg2"/>
-                </a:solidFill>
-              </a:rPr>
-              <a:t>circulares recibidas de la SSF</a:t>
-            </a:r>
-            <a:endParaRPr lang="en-US" sz="1200" dirty="0"/>
-          </a:p>
-        </p:txBody>
-      </p:sp>
-      <p:sp>
-        <p:nvSpPr>
-          <p:cNvPr id="6" name="KPI valor 2"/>
-          <p:cNvSpPr txBox="1"/>
-          <p:nvPr/>
-        </p:nvSpPr>
-        <p:spPr>
-          <a:xfrm>
-            <a:off x="2148840" y="3154680"/>
-            <a:ext cx="1463040" cy="594360"/>
-          </a:xfrm>
-          <a:prstGeom prst="rect">
-            <a:avLst/>
-          </a:prstGeom>
-          <a:noFill/>
-          <a:ln/>
-        </p:spPr>
-        <p:txBody>
-          <a:bodyPr wrap="square" lIns="0" tIns="0" rIns="0" bIns="0" rtlCol="0" anchor="b"/>
-          <a:lstStyle/>
-          <a:p>
-            <a:pPr indent="0" marL="0">
-              <a:buNone/>
-            </a:pPr>
-            <a:r>
-              <a:rPr lang="en-US" sz="3400" b="1" dirty="0">
-                <a:solidFill>
-                  <a:schemeClr val="bg1"/>
-                </a:solidFill>
-                <a:latin typeface="Cambria" pitchFamily="34" charset="0"/>
-                <a:ea typeface="Cambria" pitchFamily="34" charset="-122"/>
-                <a:cs typeface="Cambria" pitchFamily="34" charset="-120"/>
-              </a:rPr>
-              <a:t>9</a:t>
-            </a:r>
-            <a:endParaRPr lang="en-US" sz="3400" dirty="0"/>
-          </a:p>
-        </p:txBody>
-      </p:sp>
-      <p:sp>
-        <p:nvSpPr>
-          <p:cNvPr id="7" name="KPI texto 2"/>
-          <p:cNvSpPr txBox="1"/>
-          <p:nvPr/>
-        </p:nvSpPr>
-        <p:spPr>
-          <a:xfrm>
-            <a:off x="2148840" y="3794760"/>
-            <a:ext cx="1463040" cy="548640"/>
-          </a:xfrm>
-          <a:prstGeom prst="rect">
-            <a:avLst/>
-          </a:prstGeom>
-          <a:noFill/>
-          <a:ln/>
-        </p:spPr>
-        <p:txBody>
-          <a:bodyPr wrap="square" lIns="0" tIns="0" rIns="0" bIns="0" rtlCol="0" anchor="t"/>
-          <a:lstStyle/>
-          <a:p>
-            <a:pPr indent="0" marL="0">
-              <a:buNone/>
-            </a:pPr>
-            <a:r>
-              <a:rPr lang="en-US" sz="1200" dirty="0">
-                <a:solidFill>
-                  <a:schemeClr val="bg2"/>
-                </a:solidFill>
-              </a:rPr>
-              <a:t>observaciones en 2025</a:t>
-            </a:r>
-            <a:endParaRPr lang="en-US" sz="1200" dirty="0"/>
-          </a:p>
-        </p:txBody>
-      </p:sp>
-      <p:sp>
-        <p:nvSpPr>
-          <p:cNvPr id="8" name="KPI valor 3"/>
-          <p:cNvSpPr txBox="1"/>
-          <p:nvPr/>
-        </p:nvSpPr>
-        <p:spPr>
-          <a:xfrm>
-            <a:off x="548640" y="4572000"/>
-            <a:ext cx="1463040" cy="594360"/>
-          </a:xfrm>
-          <a:prstGeom prst="rect">
-            <a:avLst/>
-          </a:prstGeom>
-          <a:noFill/>
-          <a:ln/>
-        </p:spPr>
-        <p:txBody>
-          <a:bodyPr wrap="square" lIns="0" tIns="0" rIns="0" bIns="0" rtlCol="0" anchor="b"/>
-          <a:lstStyle/>
-          <a:p>
-            <a:pPr indent="0" marL="0">
-              <a:buNone/>
-            </a:pPr>
-            <a:r>
-              <a:rPr lang="en-US" sz="3400" b="1" dirty="0">
-                <a:solidFill>
-                  <a:schemeClr val="bg1"/>
-                </a:solidFill>
-                <a:latin typeface="Cambria" pitchFamily="34" charset="0"/>
-                <a:ea typeface="Cambria" pitchFamily="34" charset="-122"/>
-                <a:cs typeface="Cambria" pitchFamily="34" charset="-120"/>
-              </a:rPr>
-              <a:t>7</a:t>
-            </a:r>
-            <a:endParaRPr lang="en-US" sz="3400" dirty="0"/>
-          </a:p>
-        </p:txBody>
-      </p:sp>
-      <p:sp>
-        <p:nvSpPr>
-          <p:cNvPr id="9" name="KPI texto 3"/>
-          <p:cNvSpPr txBox="1"/>
-          <p:nvPr/>
-        </p:nvSpPr>
-        <p:spPr>
-          <a:xfrm>
-            <a:off x="548640" y="5212080"/>
-            <a:ext cx="1463040" cy="548640"/>
-          </a:xfrm>
-          <a:prstGeom prst="rect">
-            <a:avLst/>
-          </a:prstGeom>
-          <a:noFill/>
-          <a:ln/>
-        </p:spPr>
-        <p:txBody>
-          <a:bodyPr wrap="square" lIns="0" tIns="0" rIns="0" bIns="0" rtlCol="0" anchor="t"/>
-          <a:lstStyle/>
-          <a:p>
-            <a:pPr indent="0" marL="0">
-              <a:buNone/>
-            </a:pPr>
-            <a:r>
-              <a:rPr lang="en-US" sz="1200" dirty="0">
-                <a:solidFill>
-                  <a:schemeClr val="bg2"/>
-                </a:solidFill>
-              </a:rPr>
-              <a:t>observaciones nuevas en 2026</a:t>
-            </a:r>
-            <a:endParaRPr lang="en-US" sz="1200" dirty="0"/>
-          </a:p>
-        </p:txBody>
-      </p:sp>
-      <p:sp>
-        <p:nvSpPr>
-          <p:cNvPr id="10" name="KPI valor 4"/>
-          <p:cNvSpPr txBox="1"/>
-          <p:nvPr/>
-        </p:nvSpPr>
-        <p:spPr>
-          <a:xfrm>
-            <a:off x="2148840" y="4572000"/>
-            <a:ext cx="1463040" cy="594360"/>
-          </a:xfrm>
-          <a:prstGeom prst="rect">
-            <a:avLst/>
-          </a:prstGeom>
-          <a:noFill/>
-          <a:ln/>
-        </p:spPr>
-        <p:txBody>
-          <a:bodyPr wrap="square" lIns="0" tIns="0" rIns="0" bIns="0" rtlCol="0" anchor="b"/>
-          <a:lstStyle/>
-          <a:p>
-            <a:pPr indent="0" marL="0">
-              <a:buNone/>
-            </a:pPr>
-            <a:r>
-              <a:rPr lang="en-US" sz="3400" b="1" dirty="0">
-                <a:solidFill>
-                  <a:schemeClr val="bg1"/>
-                </a:solidFill>
-                <a:latin typeface="Cambria" pitchFamily="34" charset="0"/>
-                <a:ea typeface="Cambria" pitchFamily="34" charset="-122"/>
-                <a:cs typeface="Cambria" pitchFamily="34" charset="-120"/>
-              </a:rPr>
-              <a:t>2</a:t>
-            </a:r>
-            <a:endParaRPr lang="en-US" sz="3400" dirty="0"/>
-          </a:p>
-        </p:txBody>
-      </p:sp>
-      <p:sp>
-        <p:nvSpPr>
-          <p:cNvPr id="11" name="KPI texto 4"/>
-          <p:cNvSpPr txBox="1"/>
-          <p:nvPr/>
-        </p:nvSpPr>
-        <p:spPr>
-          <a:xfrm>
-            <a:off x="2148840" y="5212080"/>
-            <a:ext cx="1463040" cy="548640"/>
-          </a:xfrm>
-          <a:prstGeom prst="rect">
-            <a:avLst/>
-          </a:prstGeom>
-          <a:noFill/>
-          <a:ln/>
-        </p:spPr>
-        <p:txBody>
-          <a:bodyPr wrap="square" lIns="0" tIns="0" rIns="0" bIns="0" rtlCol="0" anchor="t"/>
-          <a:lstStyle/>
-          <a:p>
-            <a:pPr indent="0" marL="0">
-              <a:buNone/>
-            </a:pPr>
-            <a:r>
-              <a:rPr lang="en-US" sz="1200" dirty="0">
-                <a:solidFill>
-                  <a:schemeClr val="bg2"/>
-                </a:solidFill>
-              </a:rPr>
-              <a:t>de 2025 en seguimiento: 1 no superada, 1 parcial</a:t>
-            </a:r>
-            <a:endParaRPr lang="en-US" sz="1200" dirty="0"/>
-          </a:p>
-        </p:txBody>
-      </p:sp>
-      <p:sp>
-        <p:nvSpPr>
-          <p:cNvPr id="12" name="Año 2025"/>
-          <p:cNvSpPr txBox="1"/>
-          <p:nvPr/>
-        </p:nvSpPr>
-        <p:spPr>
-          <a:xfrm>
-            <a:off x="4572000" y="457200"/>
-            <a:ext cx="1188720" cy="502920"/>
-          </a:xfrm>
-          <a:prstGeom prst="rect">
-            <a:avLst/>
-          </a:prstGeom>
-          <a:noFill/>
-          <a:ln/>
-        </p:spPr>
-        <p:txBody>
-          <a:bodyPr wrap="square" lIns="0" tIns="0" rIns="0" bIns="0" rtlCol="0" anchor="ctr"/>
-          <a:lstStyle/>
-          <a:p>
-            <a:pPr indent="0" marL="0">
-              <a:buNone/>
-            </a:pPr>
-            <a:r>
-              <a:rPr lang="en-US" sz="3000" b="1" dirty="0">
-                <a:solidFill>
-                  <a:schemeClr val="accent1"/>
-                </a:solidFill>
-                <a:latin typeface="Cambria" pitchFamily="34" charset="0"/>
-                <a:ea typeface="Cambria" pitchFamily="34" charset="-122"/>
-                <a:cs typeface="Cambria" pitchFamily="34" charset="-120"/>
-              </a:rPr>
-              <a:t>2025</a:t>
-            </a:r>
-            <a:endParaRPr lang="en-US" sz="3000" dirty="0"/>
-          </a:p>
-        </p:txBody>
-      </p:sp>
-      <p:sp>
-        <p:nvSpPr>
-          <p:cNvPr id="13" name="Visita 2025"/>
-          <p:cNvSpPr txBox="1"/>
-          <p:nvPr/>
-        </p:nvSpPr>
-        <p:spPr>
-          <a:xfrm>
-            <a:off x="5806440" y="457200"/>
-            <a:ext cx="3657600" cy="502920"/>
-          </a:xfrm>
-          <a:prstGeom prst="rect">
-            <a:avLst/>
-          </a:prstGeom>
-          <a:noFill/>
-          <a:ln/>
-        </p:spPr>
-        <p:txBody>
-          <a:bodyPr wrap="square" lIns="0" tIns="0" rIns="0" bIns="0" rtlCol="0" anchor="ctr"/>
-          <a:lstStyle/>
-          <a:p>
-            <a:pPr indent="0" marL="0">
-              <a:buNone/>
-            </a:pPr>
-            <a:r>
-              <a:rPr lang="en-US" sz="1400" dirty="0">
-                <a:solidFill>
-                  <a:schemeClr val="accent5"/>
-                </a:solidFill>
-              </a:rPr>
-              <a:t>Visita 1 · supervisión ampliada</a:t>
-            </a:r>
-            <a:endParaRPr lang="en-US" sz="1400" dirty="0"/>
-          </a:p>
-        </p:txBody>
-      </p:sp>
-      <p:sp>
-        <p:nvSpPr>
-          <p:cNvPr id="14" name="Tarjeta 2025-1"/>
+          <p:cNvPr id="4" name="Separador panel 2025"/>
           <p:cNvSpPr/>
           <p:nvPr/>
         </p:nvSpPr>
         <p:spPr>
           <a:xfrm>
-            <a:off x="4572000" y="1097280"/>
-            <a:ext cx="3306928" cy="2103120"/>
-          </a:xfrm>
-          <a:prstGeom prst="roundRect">
-            <a:avLst>
-              <a:gd name="adj" fmla="val 4348"/>
-            </a:avLst>
-          </a:prstGeom>
-          <a:solidFill>
-            <a:schemeClr val="bg1"/>
-          </a:solidFill>
-          <a:ln w="12700">
+            <a:off x="548640" y="2788920"/>
+            <a:ext cx="3200400" cy="0"/>
+          </a:xfrm>
+          <a:prstGeom prst="line">
+            <a:avLst/>
+          </a:prstGeom>
+          <a:noFill/>
+          <a:ln w="9525">
             <a:solidFill>
-              <a:srgbClr val="D9E0EA"/>
+              <a:schemeClr val="bg2">
+                <a:alpha val="40000"/>
+              </a:schemeClr>
             </a:solidFill>
             <a:prstDash val="solid"/>
           </a:ln>
@@ -2145,18 +1768,18 @@
       </p:sp>
       <p:sp>
         <p:nvSpPr>
-          <p:cNvPr id="15" name="Fecha fondo 2025-1"/>
+          <p:cNvPr id="5" name="Año panel 2025 fondo"/>
           <p:cNvSpPr/>
           <p:nvPr/>
         </p:nvSpPr>
         <p:spPr>
           <a:xfrm>
-            <a:off x="4709160" y="1234440"/>
-            <a:ext cx="914400" cy="1828800"/>
+            <a:off x="548640" y="2953512"/>
+            <a:ext cx="777240" cy="274320"/>
           </a:xfrm>
           <a:prstGeom prst="roundRect">
             <a:avLst>
-              <a:gd name="adj" fmla="val 10000"/>
+              <a:gd name="adj" fmla="val 50000"/>
             </a:avLst>
           </a:prstGeom>
           <a:solidFill>
@@ -2174,14 +1797,14 @@
       </p:sp>
       <p:sp>
         <p:nvSpPr>
-          <p:cNvPr id="16" name="Fecha día 2025-1"/>
-          <p:cNvSpPr txBox="1"/>
-          <p:nvPr/>
-        </p:nvSpPr>
-        <p:spPr>
-          <a:xfrm>
-            <a:off x="4709160" y="1463040"/>
-            <a:ext cx="914400" cy="548640"/>
+          <p:cNvPr id="6" name="Año panel 2025"/>
+          <p:cNvSpPr txBox="1"/>
+          <p:nvPr/>
+        </p:nvSpPr>
+        <p:spPr>
+          <a:xfrm>
+            <a:off x="548640" y="2953512"/>
+            <a:ext cx="777240" cy="274320"/>
           </a:xfrm>
           <a:prstGeom prst="rect">
             <a:avLst/>
@@ -2197,7 +1820,103 @@
               <a:buNone/>
             </a:pPr>
             <a:r>
-              <a:rPr lang="en-US" sz="3400" b="1" dirty="0">
+              <a:rPr lang="en-US" sz="1100" b="1" spc="100" kern="0" dirty="0">
+                <a:solidFill>
+                  <a:schemeClr val="bg1"/>
+                </a:solidFill>
+              </a:rPr>
+              <a:t>2025</a:t>
+            </a:r>
+            <a:endParaRPr lang="en-US" sz="1100" dirty="0"/>
+          </a:p>
+        </p:txBody>
+      </p:sp>
+      <p:sp>
+        <p:nvSpPr>
+          <p:cNvPr id="7" name="Contorno panel 2025"/>
+          <p:cNvSpPr/>
+          <p:nvPr/>
+        </p:nvSpPr>
+        <p:spPr>
+          <a:xfrm>
+            <a:off x="548640" y="2953512"/>
+            <a:ext cx="777240" cy="274320"/>
+          </a:xfrm>
+          <a:prstGeom prst="roundRect">
+            <a:avLst>
+              <a:gd name="adj" fmla="val 50000"/>
+            </a:avLst>
+          </a:prstGeom>
+          <a:ln w="12700">
+            <a:solidFill>
+              <a:schemeClr val="bg1"/>
+            </a:solidFill>
+            <a:prstDash val="solid"/>
+          </a:ln>
+        </p:spPr>
+      </p:sp>
+      <p:sp>
+        <p:nvSpPr>
+          <p:cNvPr id="8" name="Visita panel 2025"/>
+          <p:cNvSpPr txBox="1"/>
+          <p:nvPr/>
+        </p:nvSpPr>
+        <p:spPr>
+          <a:xfrm>
+            <a:off x="1463040" y="2953512"/>
+            <a:ext cx="2286000" cy="274320"/>
+          </a:xfrm>
+          <a:prstGeom prst="rect">
+            <a:avLst/>
+          </a:prstGeom>
+          <a:noFill/>
+          <a:ln/>
+        </p:spPr>
+        <p:txBody>
+          <a:bodyPr wrap="square" lIns="0" tIns="0" rIns="0" bIns="0" rtlCol="0" anchor="ctr"/>
+          <a:lstStyle/>
+          <a:p>
+            <a:pPr indent="0" marL="0">
+              <a:buNone/>
+            </a:pPr>
+            <a:r>
+              <a:rPr lang="en-US" sz="1100" dirty="0">
+                <a:solidFill>
+                  <a:schemeClr val="bg2"/>
+                </a:solidFill>
+              </a:rPr>
+              <a:t>Visita 1 · Circular 17003</a:t>
+            </a:r>
+            <a:endParaRPr lang="en-US" sz="1100" dirty="0"/>
+          </a:p>
+        </p:txBody>
+      </p:sp>
+      <p:sp>
+        <p:nvSpPr>
+          <p:cNvPr id="9" name="KPI 2025-1"/>
+          <p:cNvSpPr txBox="1"/>
+          <p:nvPr/>
+        </p:nvSpPr>
+        <p:spPr>
+          <a:xfrm>
+            <a:off x="548640" y="3337560"/>
+            <a:ext cx="1508760" cy="548640"/>
+          </a:xfrm>
+          <a:prstGeom prst="rect">
+            <a:avLst/>
+          </a:prstGeom>
+          <a:noFill/>
+          <a:ln/>
+        </p:spPr>
+        <p:txBody>
+          <a:bodyPr wrap="square" lIns="0" tIns="0" rIns="0" bIns="0" rtlCol="0" anchor="b"/>
+          <a:lstStyle/>
+          <a:p>
+            <a:pPr indent="0" marL="0">
+              <a:buNone/>
+            </a:pPr>
+            <a:r>
+              <a:rPr lang="en-US" sz="3200" b="1" dirty="0">
                 <a:solidFill>
                   <a:schemeClr val="bg1"/>
                 </a:solidFill>
@@ -2205,22 +1924,22 @@
                 <a:ea typeface="Cambria" pitchFamily="34" charset="-122"/>
                 <a:cs typeface="Cambria" pitchFamily="34" charset="-120"/>
               </a:rPr>
-              <a:t>09</a:t>
-            </a:r>
-            <a:endParaRPr lang="en-US" sz="3400" dirty="0"/>
-          </a:p>
-        </p:txBody>
-      </p:sp>
-      <p:sp>
-        <p:nvSpPr>
-          <p:cNvPr id="17" name="Fecha mes 2025-1"/>
-          <p:cNvSpPr txBox="1"/>
-          <p:nvPr/>
-        </p:nvSpPr>
-        <p:spPr>
-          <a:xfrm>
-            <a:off x="4709160" y="2011680"/>
-            <a:ext cx="914400" cy="274320"/>
+              <a:t>2</a:t>
+            </a:r>
+            <a:endParaRPr lang="en-US" sz="3200" dirty="0"/>
+          </a:p>
+        </p:txBody>
+      </p:sp>
+      <p:sp>
+        <p:nvSpPr>
+          <p:cNvPr id="10" name="KPI texto 2025-1"/>
+          <p:cNvSpPr txBox="1"/>
+          <p:nvPr/>
+        </p:nvSpPr>
+        <p:spPr>
+          <a:xfrm>
+            <a:off x="548640" y="3904488"/>
+            <a:ext cx="1508760" cy="384048"/>
           </a:xfrm>
           <a:prstGeom prst="rect">
             <a:avLst/>
@@ -2232,31 +1951,70 @@
           <a:bodyPr wrap="square" lIns="0" tIns="0" rIns="0" bIns="0" rtlCol="0" anchor="t"/>
           <a:lstStyle/>
           <a:p>
-            <a:pPr algn="ctr" indent="0" marL="0">
-              <a:buNone/>
-            </a:pPr>
-            <a:r>
-              <a:rPr lang="en-US" sz="1400" b="1" spc="200" kern="0" dirty="0">
+            <a:pPr indent="0" marL="0">
+              <a:buNone/>
+            </a:pPr>
+            <a:r>
+              <a:rPr lang="en-US" sz="1100" dirty="0">
+                <a:solidFill>
+                  <a:schemeClr val="bg2"/>
+                </a:solidFill>
+              </a:rPr>
+              <a:t>circulares</a:t>
+            </a:r>
+            <a:endParaRPr lang="en-US" sz="1100" dirty="0"/>
+          </a:p>
+        </p:txBody>
+      </p:sp>
+      <p:sp>
+        <p:nvSpPr>
+          <p:cNvPr id="11" name="KPI 2025-2"/>
+          <p:cNvSpPr txBox="1"/>
+          <p:nvPr/>
+        </p:nvSpPr>
+        <p:spPr>
+          <a:xfrm>
+            <a:off x="2148840" y="3337560"/>
+            <a:ext cx="1508760" cy="548640"/>
+          </a:xfrm>
+          <a:prstGeom prst="rect">
+            <a:avLst/>
+          </a:prstGeom>
+          <a:noFill/>
+          <a:ln/>
+        </p:spPr>
+        <p:txBody>
+          <a:bodyPr wrap="square" lIns="0" tIns="0" rIns="0" bIns="0" rtlCol="0" anchor="b"/>
+          <a:lstStyle/>
+          <a:p>
+            <a:pPr indent="0" marL="0">
+              <a:buNone/>
+            </a:pPr>
+            <a:r>
+              <a:rPr lang="en-US" sz="3200" b="1" dirty="0">
                 <a:solidFill>
                   <a:schemeClr val="bg1"/>
                 </a:solidFill>
-              </a:rPr>
-              <a:t>ABR</a:t>
-            </a:r>
-            <a:endParaRPr lang="en-US" sz="1400" dirty="0"/>
-          </a:p>
-        </p:txBody>
-      </p:sp>
-      <p:sp>
-        <p:nvSpPr>
-          <p:cNvPr id="18" name="Fecha año 2025-1"/>
-          <p:cNvSpPr txBox="1"/>
-          <p:nvPr/>
-        </p:nvSpPr>
-        <p:spPr>
-          <a:xfrm>
-            <a:off x="4709160" y="2286000"/>
-            <a:ext cx="914400" cy="274320"/>
+                <a:latin typeface="Cambria" pitchFamily="34" charset="0"/>
+                <a:ea typeface="Cambria" pitchFamily="34" charset="-122"/>
+                <a:cs typeface="Cambria" pitchFamily="34" charset="-120"/>
+              </a:rPr>
+              <a:t>9</a:t>
+            </a:r>
+            <a:endParaRPr lang="en-US" sz="3200" dirty="0"/>
+          </a:p>
+        </p:txBody>
+      </p:sp>
+      <p:sp>
+        <p:nvSpPr>
+          <p:cNvPr id="12" name="KPI texto 2025-2"/>
+          <p:cNvSpPr txBox="1"/>
+          <p:nvPr/>
+        </p:nvSpPr>
+        <p:spPr>
+          <a:xfrm>
+            <a:off x="2148840" y="3904488"/>
+            <a:ext cx="1508760" cy="384048"/>
           </a:xfrm>
           <a:prstGeom prst="rect">
             <a:avLst/>
@@ -2268,153 +2026,31 @@
           <a:bodyPr wrap="square" lIns="0" tIns="0" rIns="0" bIns="0" rtlCol="0" anchor="t"/>
           <a:lstStyle/>
           <a:p>
-            <a:pPr algn="ctr" indent="0" marL="0">
-              <a:buNone/>
-            </a:pPr>
-            <a:r>
-              <a:rPr lang="en-US" sz="1200" dirty="0">
-                <a:solidFill>
-                  <a:schemeClr val="bg1"/>
-                </a:solidFill>
-              </a:rPr>
-              <a:t>2025</a:t>
-            </a:r>
-            <a:endParaRPr lang="en-US" sz="1200" dirty="0"/>
-          </a:p>
-        </p:txBody>
-      </p:sp>
-      <p:sp>
-        <p:nvSpPr>
-          <p:cNvPr id="19" name="Paso 2025-1"/>
-          <p:cNvSpPr txBox="1"/>
-          <p:nvPr/>
-        </p:nvSpPr>
-        <p:spPr>
-          <a:xfrm>
-            <a:off x="4709160" y="2697480"/>
-            <a:ext cx="914400" cy="228600"/>
-          </a:xfrm>
-          <a:prstGeom prst="rect">
-            <a:avLst/>
-          </a:prstGeom>
-          <a:noFill/>
-          <a:ln/>
-        </p:spPr>
-        <p:txBody>
-          <a:bodyPr wrap="square" lIns="0" tIns="0" rIns="0" bIns="0" rtlCol="0" anchor="t"/>
-          <a:lstStyle/>
-          <a:p>
-            <a:pPr algn="ctr" indent="0" marL="0">
-              <a:buNone/>
-            </a:pPr>
-            <a:r>
-              <a:rPr lang="en-US" sz="950" b="1" spc="100" kern="0" dirty="0">
-                <a:solidFill>
-                  <a:schemeClr val="bg1"/>
-                </a:solidFill>
-              </a:rPr>
-              <a:t>PASO 1 DE 2</a:t>
-            </a:r>
-            <a:endParaRPr lang="en-US" sz="950" dirty="0"/>
-          </a:p>
-        </p:txBody>
-      </p:sp>
-      <p:sp>
-        <p:nvSpPr>
-          <p:cNvPr id="20" name="Tipo 2025-1"/>
-          <p:cNvSpPr txBox="1"/>
-          <p:nvPr/>
-        </p:nvSpPr>
-        <p:spPr>
-          <a:xfrm>
-            <a:off x="5806440" y="1261872"/>
-            <a:ext cx="1935328" cy="502920"/>
-          </a:xfrm>
-          <a:prstGeom prst="rect">
-            <a:avLst/>
-          </a:prstGeom>
-          <a:noFill/>
-          <a:ln/>
-        </p:spPr>
-        <p:txBody>
-          <a:bodyPr wrap="square" lIns="0" tIns="0" rIns="0" bIns="0" rtlCol="0" anchor="ctr"/>
-          <a:lstStyle/>
-          <a:p>
-            <a:pPr indent="0" marL="0">
-              <a:buNone/>
-            </a:pPr>
-            <a:r>
-              <a:rPr lang="en-US" sz="1400" b="1" dirty="0">
-                <a:solidFill>
-                  <a:schemeClr val="tx1"/>
-                </a:solidFill>
-              </a:rPr>
-              <a:t>Nombramiento de visita ampliada</a:t>
-            </a:r>
-            <a:endParaRPr lang="en-US" sz="1400" dirty="0"/>
-          </a:p>
-        </p:txBody>
-      </p:sp>
-      <p:sp>
-        <p:nvSpPr>
-          <p:cNvPr id="21" name="Circular 2025-1"/>
-          <p:cNvSpPr txBox="1"/>
-          <p:nvPr/>
-        </p:nvSpPr>
-        <p:spPr>
-          <a:xfrm>
-            <a:off x="5806440" y="1828800"/>
-            <a:ext cx="1935328" cy="438912"/>
-          </a:xfrm>
-          <a:prstGeom prst="rect">
-            <a:avLst/>
-          </a:prstGeom>
-          <a:noFill/>
-          <a:ln/>
-        </p:spPr>
-        <p:txBody>
-          <a:bodyPr wrap="square" lIns="0" tIns="0" rIns="0" bIns="0" rtlCol="0" anchor="t"/>
-          <a:lstStyle/>
-          <a:p>
-            <a:pPr indent="0" marL="0">
-              <a:buNone/>
-            </a:pPr>
-            <a:r>
-              <a:rPr lang="en-US" sz="1000" dirty="0">
-                <a:solidFill>
-                  <a:schemeClr val="accent5"/>
-                </a:solidFill>
-              </a:rPr>
-              <a:t>Circular No.</a:t>
+            <a:pPr indent="0" marL="0">
+              <a:buNone/>
+            </a:pPr>
+            <a:r>
+              <a:rPr lang="en-US" sz="1100" dirty="0">
+                <a:solidFill>
+                  <a:schemeClr val="bg2"/>
+                </a:solidFill>
+              </a:rPr>
+              <a:t>observaciones</a:t>
             </a:r>
             <a:endParaRPr lang="en-US" sz="1100" dirty="0"/>
           </a:p>
-          <a:p>
-            <a:pPr indent="0" marL="0">
-              <a:buNone/>
-            </a:pPr>
-            <a:r>
-              <a:rPr lang="en-US" sz="1100" b="1" dirty="0">
-                <a:solidFill>
-                  <a:schemeClr val="accent1"/>
-                </a:solidFill>
-              </a:rPr>
-              <a:t>DS-SABAO-BCS-BC-9337</a:t>
-            </a:r>
-            <a:endParaRPr lang="en-US" sz="1100" dirty="0"/>
-          </a:p>
-        </p:txBody>
-      </p:sp>
-      <p:sp>
-        <p:nvSpPr>
-          <p:cNvPr id="22" name="Separador 2025-1-0"/>
+        </p:txBody>
+      </p:sp>
+      <p:sp>
+        <p:nvSpPr>
+          <p:cNvPr id="13" name="Separador panel 2026"/>
           <p:cNvSpPr/>
           <p:nvPr/>
         </p:nvSpPr>
         <p:spPr>
           <a:xfrm>
-            <a:off x="5806440" y="2340864"/>
-            <a:ext cx="1935328" cy="0"/>
+            <a:off x="548640" y="4434840"/>
+            <a:ext cx="3200400" cy="0"/>
           </a:xfrm>
           <a:prstGeom prst="line">
             <a:avLst/>
@@ -2422,7 +2058,9 @@
           <a:noFill/>
           <a:ln w="9525">
             <a:solidFill>
-              <a:srgbClr val="D9E0EA"/>
+              <a:schemeClr val="bg2">
+                <a:alpha val="40000"/>
+              </a:schemeClr>
             </a:solidFill>
             <a:prstDash val="solid"/>
           </a:ln>
@@ -2430,69 +2068,28 @@
       </p:sp>
       <p:sp>
         <p:nvSpPr>
-          <p:cNvPr id="23" name="Dato 2025-1-0"/>
-          <p:cNvSpPr txBox="1"/>
-          <p:nvPr/>
-        </p:nvSpPr>
-        <p:spPr>
-          <a:xfrm>
-            <a:off x="5806440" y="2377440"/>
-            <a:ext cx="1935328" cy="310896"/>
-          </a:xfrm>
-          <a:prstGeom prst="rect">
-            <a:avLst/>
-          </a:prstGeom>
-          <a:noFill/>
-          <a:ln/>
-        </p:spPr>
-        <p:txBody>
-          <a:bodyPr wrap="square" lIns="0" tIns="0" rIns="0" bIns="0" rtlCol="0" anchor="ctr"/>
-          <a:lstStyle/>
-          <a:p>
-            <a:pPr indent="0" marL="0">
-              <a:buNone/>
-            </a:pPr>
-            <a:r>
-              <a:rPr lang="en-US" sz="1150" dirty="0">
-                <a:solidFill>
-                  <a:schemeClr val="accent5"/>
-                </a:solidFill>
-              </a:rPr>
-              <a:t>Corte  </a:t>
-            </a:r>
-            <a:pPr indent="0" marL="0">
-              <a:buNone/>
-            </a:pPr>
-            <a:r>
-              <a:rPr lang="en-US" sz="1150" b="1" dirty="0">
-                <a:solidFill>
-                  <a:schemeClr val="tx1"/>
-                </a:solidFill>
-              </a:rPr>
-              <a:t>30/04/2025</a:t>
-            </a:r>
-            <a:endParaRPr lang="en-US" sz="1150" dirty="0"/>
-          </a:p>
-        </p:txBody>
-      </p:sp>
-      <p:sp>
-        <p:nvSpPr>
-          <p:cNvPr id="24" name="Separador 2025-1-1"/>
+          <p:cNvPr id="14" name="Año panel 2026 fondo"/>
           <p:cNvSpPr/>
           <p:nvPr/>
         </p:nvSpPr>
         <p:spPr>
           <a:xfrm>
-            <a:off x="5806440" y="2706624"/>
-            <a:ext cx="1935328" cy="0"/>
-          </a:xfrm>
-          <a:prstGeom prst="line">
-            <a:avLst/>
-          </a:prstGeom>
-          <a:noFill/>
-          <a:ln w="9525">
+            <a:off x="548640" y="4599432"/>
+            <a:ext cx="777240" cy="274320"/>
+          </a:xfrm>
+          <a:prstGeom prst="roundRect">
+            <a:avLst>
+              <a:gd name="adj" fmla="val 50000"/>
+            </a:avLst>
+          </a:prstGeom>
+          <a:solidFill>
+            <a:schemeClr val="accent2"/>
+          </a:solidFill>
+          <a:ln w="12700">
             <a:solidFill>
-              <a:srgbClr val="D9E0EA"/>
+              <a:schemeClr val="accent2">
+                <a:alpha val="0"/>
+              </a:schemeClr>
             </a:solidFill>
             <a:prstDash val="solid"/>
           </a:ln>
@@ -2500,14 +2097,14 @@
       </p:sp>
       <p:sp>
         <p:nvSpPr>
-          <p:cNvPr id="25" name="Dato 2025-1-1"/>
-          <p:cNvSpPr txBox="1"/>
-          <p:nvPr/>
-        </p:nvSpPr>
-        <p:spPr>
-          <a:xfrm>
-            <a:off x="5806440" y="2743200"/>
-            <a:ext cx="1935328" cy="310896"/>
+          <p:cNvPr id="15" name="Año panel 2026"/>
+          <p:cNvSpPr txBox="1"/>
+          <p:nvPr/>
+        </p:nvSpPr>
+        <p:spPr>
+          <a:xfrm>
+            <a:off x="548640" y="4599432"/>
+            <a:ext cx="777240" cy="274320"/>
           </a:xfrm>
           <a:prstGeom prst="rect">
             <a:avLst/>
@@ -2519,41 +2116,402 @@
           <a:bodyPr wrap="square" lIns="0" tIns="0" rIns="0" bIns="0" rtlCol="0" anchor="ctr"/>
           <a:lstStyle/>
           <a:p>
-            <a:pPr indent="0" marL="0">
-              <a:buNone/>
-            </a:pPr>
-            <a:r>
-              <a:rPr lang="en-US" sz="1150" dirty="0">
+            <a:pPr algn="ctr" indent="0" marL="0">
+              <a:buNone/>
+            </a:pPr>
+            <a:r>
+              <a:rPr lang="en-US" sz="1100" b="1" spc="100" kern="0" dirty="0">
+                <a:solidFill>
+                  <a:schemeClr val="bg1"/>
+                </a:solidFill>
+              </a:rPr>
+              <a:t>2026</a:t>
+            </a:r>
+            <a:endParaRPr lang="en-US" sz="1100" dirty="0"/>
+          </a:p>
+        </p:txBody>
+      </p:sp>
+      <p:sp>
+        <p:nvSpPr>
+          <p:cNvPr id="16" name="Visita panel 2026"/>
+          <p:cNvSpPr txBox="1"/>
+          <p:nvPr/>
+        </p:nvSpPr>
+        <p:spPr>
+          <a:xfrm>
+            <a:off x="1463040" y="4599432"/>
+            <a:ext cx="2286000" cy="274320"/>
+          </a:xfrm>
+          <a:prstGeom prst="rect">
+            <a:avLst/>
+          </a:prstGeom>
+          <a:noFill/>
+          <a:ln/>
+        </p:spPr>
+        <p:txBody>
+          <a:bodyPr wrap="square" lIns="0" tIns="0" rIns="0" bIns="0" rtlCol="0" anchor="ctr"/>
+          <a:lstStyle/>
+          <a:p>
+            <a:pPr indent="0" marL="0">
+              <a:buNone/>
+            </a:pPr>
+            <a:r>
+              <a:rPr lang="en-US" sz="1100" dirty="0">
+                <a:solidFill>
+                  <a:schemeClr val="bg2"/>
+                </a:solidFill>
+              </a:rPr>
+              <a:t>Visita 2 · Circular 22741</a:t>
+            </a:r>
+            <a:endParaRPr lang="en-US" sz="1100" dirty="0"/>
+          </a:p>
+        </p:txBody>
+      </p:sp>
+      <p:sp>
+        <p:nvSpPr>
+          <p:cNvPr id="17" name="KPI 2026-1"/>
+          <p:cNvSpPr txBox="1"/>
+          <p:nvPr/>
+        </p:nvSpPr>
+        <p:spPr>
+          <a:xfrm>
+            <a:off x="548640" y="4983480"/>
+            <a:ext cx="975360" cy="548640"/>
+          </a:xfrm>
+          <a:prstGeom prst="rect">
+            <a:avLst/>
+          </a:prstGeom>
+          <a:noFill/>
+          <a:ln/>
+        </p:spPr>
+        <p:txBody>
+          <a:bodyPr wrap="square" lIns="0" tIns="0" rIns="0" bIns="0" rtlCol="0" anchor="b"/>
+          <a:lstStyle/>
+          <a:p>
+            <a:pPr indent="0" marL="0">
+              <a:buNone/>
+            </a:pPr>
+            <a:r>
+              <a:rPr lang="en-US" sz="3200" b="1" dirty="0">
+                <a:solidFill>
+                  <a:schemeClr val="bg1"/>
+                </a:solidFill>
+                <a:latin typeface="Cambria" pitchFamily="34" charset="0"/>
+                <a:ea typeface="Cambria" pitchFamily="34" charset="-122"/>
+                <a:cs typeface="Cambria" pitchFamily="34" charset="-120"/>
+              </a:rPr>
+              <a:t>2</a:t>
+            </a:r>
+            <a:endParaRPr lang="en-US" sz="3200" dirty="0"/>
+          </a:p>
+        </p:txBody>
+      </p:sp>
+      <p:sp>
+        <p:nvSpPr>
+          <p:cNvPr id="18" name="KPI texto 2026-1"/>
+          <p:cNvSpPr txBox="1"/>
+          <p:nvPr/>
+        </p:nvSpPr>
+        <p:spPr>
+          <a:xfrm>
+            <a:off x="548640" y="5550408"/>
+            <a:ext cx="975360" cy="384048"/>
+          </a:xfrm>
+          <a:prstGeom prst="rect">
+            <a:avLst/>
+          </a:prstGeom>
+          <a:noFill/>
+          <a:ln/>
+        </p:spPr>
+        <p:txBody>
+          <a:bodyPr wrap="square" lIns="0" tIns="0" rIns="0" bIns="0" rtlCol="0" anchor="t"/>
+          <a:lstStyle/>
+          <a:p>
+            <a:pPr indent="0" marL="0">
+              <a:buNone/>
+            </a:pPr>
+            <a:r>
+              <a:rPr lang="en-US" sz="1100" dirty="0">
+                <a:solidFill>
+                  <a:schemeClr val="bg2"/>
+                </a:solidFill>
+              </a:rPr>
+              <a:t>circulares</a:t>
+            </a:r>
+            <a:endParaRPr lang="en-US" sz="1100" dirty="0"/>
+          </a:p>
+        </p:txBody>
+      </p:sp>
+      <p:sp>
+        <p:nvSpPr>
+          <p:cNvPr id="19" name="KPI 2026-2"/>
+          <p:cNvSpPr txBox="1"/>
+          <p:nvPr/>
+        </p:nvSpPr>
+        <p:spPr>
+          <a:xfrm>
+            <a:off x="1615440" y="4983480"/>
+            <a:ext cx="975360" cy="548640"/>
+          </a:xfrm>
+          <a:prstGeom prst="rect">
+            <a:avLst/>
+          </a:prstGeom>
+          <a:noFill/>
+          <a:ln/>
+        </p:spPr>
+        <p:txBody>
+          <a:bodyPr wrap="square" lIns="0" tIns="0" rIns="0" bIns="0" rtlCol="0" anchor="b"/>
+          <a:lstStyle/>
+          <a:p>
+            <a:pPr indent="0" marL="0">
+              <a:buNone/>
+            </a:pPr>
+            <a:r>
+              <a:rPr lang="en-US" sz="3200" b="1" dirty="0">
+                <a:solidFill>
+                  <a:schemeClr val="bg1"/>
+                </a:solidFill>
+                <a:latin typeface="Cambria" pitchFamily="34" charset="0"/>
+                <a:ea typeface="Cambria" pitchFamily="34" charset="-122"/>
+                <a:cs typeface="Cambria" pitchFamily="34" charset="-120"/>
+              </a:rPr>
+              <a:t>7</a:t>
+            </a:r>
+            <a:endParaRPr lang="en-US" sz="3200" dirty="0"/>
+          </a:p>
+        </p:txBody>
+      </p:sp>
+      <p:sp>
+        <p:nvSpPr>
+          <p:cNvPr id="20" name="KPI texto 2026-2"/>
+          <p:cNvSpPr txBox="1"/>
+          <p:nvPr/>
+        </p:nvSpPr>
+        <p:spPr>
+          <a:xfrm>
+            <a:off x="1615440" y="5550408"/>
+            <a:ext cx="975360" cy="384048"/>
+          </a:xfrm>
+          <a:prstGeom prst="rect">
+            <a:avLst/>
+          </a:prstGeom>
+          <a:noFill/>
+          <a:ln/>
+        </p:spPr>
+        <p:txBody>
+          <a:bodyPr wrap="square" lIns="0" tIns="0" rIns="0" bIns="0" rtlCol="0" anchor="t"/>
+          <a:lstStyle/>
+          <a:p>
+            <a:pPr indent="0" marL="0">
+              <a:buNone/>
+            </a:pPr>
+            <a:r>
+              <a:rPr lang="en-US" sz="1100" dirty="0">
+                <a:solidFill>
+                  <a:schemeClr val="bg2"/>
+                </a:solidFill>
+              </a:rPr>
+              <a:t>observaciones nuevas</a:t>
+            </a:r>
+            <a:endParaRPr lang="en-US" sz="1100" dirty="0"/>
+          </a:p>
+        </p:txBody>
+      </p:sp>
+      <p:sp>
+        <p:nvSpPr>
+          <p:cNvPr id="21" name="KPI 2026-3"/>
+          <p:cNvSpPr txBox="1"/>
+          <p:nvPr/>
+        </p:nvSpPr>
+        <p:spPr>
+          <a:xfrm>
+            <a:off x="2682240" y="4983480"/>
+            <a:ext cx="975360" cy="548640"/>
+          </a:xfrm>
+          <a:prstGeom prst="rect">
+            <a:avLst/>
+          </a:prstGeom>
+          <a:noFill/>
+          <a:ln/>
+        </p:spPr>
+        <p:txBody>
+          <a:bodyPr wrap="square" lIns="0" tIns="0" rIns="0" bIns="0" rtlCol="0" anchor="b"/>
+          <a:lstStyle/>
+          <a:p>
+            <a:pPr indent="0" marL="0">
+              <a:buNone/>
+            </a:pPr>
+            <a:r>
+              <a:rPr lang="en-US" sz="3200" b="1" dirty="0">
+                <a:solidFill>
+                  <a:schemeClr val="bg1"/>
+                </a:solidFill>
+                <a:latin typeface="Cambria" pitchFamily="34" charset="0"/>
+                <a:ea typeface="Cambria" pitchFamily="34" charset="-122"/>
+                <a:cs typeface="Cambria" pitchFamily="34" charset="-120"/>
+              </a:rPr>
+              <a:t>2</a:t>
+            </a:r>
+            <a:endParaRPr lang="en-US" sz="3200" dirty="0"/>
+          </a:p>
+        </p:txBody>
+      </p:sp>
+      <p:sp>
+        <p:nvSpPr>
+          <p:cNvPr id="22" name="KPI texto 2026-3"/>
+          <p:cNvSpPr txBox="1"/>
+          <p:nvPr/>
+        </p:nvSpPr>
+        <p:spPr>
+          <a:xfrm>
+            <a:off x="2682240" y="5550408"/>
+            <a:ext cx="975360" cy="384048"/>
+          </a:xfrm>
+          <a:prstGeom prst="rect">
+            <a:avLst/>
+          </a:prstGeom>
+          <a:noFill/>
+          <a:ln/>
+        </p:spPr>
+        <p:txBody>
+          <a:bodyPr wrap="square" lIns="0" tIns="0" rIns="0" bIns="0" rtlCol="0" anchor="t"/>
+          <a:lstStyle/>
+          <a:p>
+            <a:pPr indent="0" marL="0">
+              <a:buNone/>
+            </a:pPr>
+            <a:r>
+              <a:rPr lang="en-US" sz="1100" dirty="0">
+                <a:solidFill>
+                  <a:schemeClr val="bg2"/>
+                </a:solidFill>
+              </a:rPr>
+              <a:t>de 2025 en seguimiento</a:t>
+            </a:r>
+            <a:endParaRPr lang="en-US" sz="1100" dirty="0"/>
+          </a:p>
+        </p:txBody>
+      </p:sp>
+      <p:sp>
+        <p:nvSpPr>
+          <p:cNvPr id="23" name="Seguimiento panel"/>
+          <p:cNvSpPr txBox="1"/>
+          <p:nvPr/>
+        </p:nvSpPr>
+        <p:spPr>
+          <a:xfrm>
+            <a:off x="548640" y="5989320"/>
+            <a:ext cx="3200400" cy="365760"/>
+          </a:xfrm>
+          <a:prstGeom prst="rect">
+            <a:avLst/>
+          </a:prstGeom>
+          <a:noFill/>
+          <a:ln/>
+        </p:spPr>
+        <p:txBody>
+          <a:bodyPr wrap="square" lIns="0" tIns="0" rIns="0" bIns="0" rtlCol="0" anchor="t"/>
+          <a:lstStyle/>
+          <a:p>
+            <a:pPr indent="0" marL="0">
+              <a:buNone/>
+            </a:pPr>
+            <a:r>
+              <a:rPr lang="en-US" sz="1050" i="1" dirty="0">
+                <a:solidFill>
+                  <a:schemeClr val="bg2"/>
+                </a:solidFill>
+              </a:rPr>
+              <a:t>Seguimiento: obs. 3 no superada · obs. 5 parcialmente superada</a:t>
+            </a:r>
+            <a:endParaRPr lang="en-US" sz="1050" dirty="0"/>
+          </a:p>
+        </p:txBody>
+      </p:sp>
+      <p:sp>
+        <p:nvSpPr>
+          <p:cNvPr id="24" name="Año 2025"/>
+          <p:cNvSpPr txBox="1"/>
+          <p:nvPr/>
+        </p:nvSpPr>
+        <p:spPr>
+          <a:xfrm>
+            <a:off x="4572000" y="457200"/>
+            <a:ext cx="1188720" cy="502920"/>
+          </a:xfrm>
+          <a:prstGeom prst="rect">
+            <a:avLst/>
+          </a:prstGeom>
+          <a:noFill/>
+          <a:ln/>
+        </p:spPr>
+        <p:txBody>
+          <a:bodyPr wrap="square" lIns="0" tIns="0" rIns="0" bIns="0" rtlCol="0" anchor="ctr"/>
+          <a:lstStyle/>
+          <a:p>
+            <a:pPr indent="0" marL="0">
+              <a:buNone/>
+            </a:pPr>
+            <a:r>
+              <a:rPr lang="en-US" sz="3000" b="1" dirty="0">
+                <a:solidFill>
+                  <a:schemeClr val="accent1"/>
+                </a:solidFill>
+                <a:latin typeface="Cambria" pitchFamily="34" charset="0"/>
+                <a:ea typeface="Cambria" pitchFamily="34" charset="-122"/>
+                <a:cs typeface="Cambria" pitchFamily="34" charset="-120"/>
+              </a:rPr>
+              <a:t>2025</a:t>
+            </a:r>
+            <a:endParaRPr lang="en-US" sz="3000" dirty="0"/>
+          </a:p>
+        </p:txBody>
+      </p:sp>
+      <p:sp>
+        <p:nvSpPr>
+          <p:cNvPr id="25" name="Visita 2025"/>
+          <p:cNvSpPr txBox="1"/>
+          <p:nvPr/>
+        </p:nvSpPr>
+        <p:spPr>
+          <a:xfrm>
+            <a:off x="5806440" y="457200"/>
+            <a:ext cx="3657600" cy="502920"/>
+          </a:xfrm>
+          <a:prstGeom prst="rect">
+            <a:avLst/>
+          </a:prstGeom>
+          <a:noFill/>
+          <a:ln/>
+        </p:spPr>
+        <p:txBody>
+          <a:bodyPr wrap="square" lIns="0" tIns="0" rIns="0" bIns="0" rtlCol="0" anchor="ctr"/>
+          <a:lstStyle/>
+          <a:p>
+            <a:pPr indent="0" marL="0">
+              <a:buNone/>
+            </a:pPr>
+            <a:r>
+              <a:rPr lang="en-US" sz="1400" dirty="0">
                 <a:solidFill>
                   <a:schemeClr val="accent5"/>
                 </a:solidFill>
               </a:rPr>
-              <a:t>Inicio de visita  </a:t>
-            </a:r>
-            <a:pPr indent="0" marL="0">
-              <a:buNone/>
-            </a:pPr>
-            <a:r>
-              <a:rPr lang="en-US" sz="1150" b="1" dirty="0">
-                <a:solidFill>
-                  <a:schemeClr val="tx1"/>
-                </a:solidFill>
-              </a:rPr>
-              <a:t>19/05/2025</a:t>
-            </a:r>
-            <a:endParaRPr lang="en-US" sz="1150" dirty="0"/>
-          </a:p>
-        </p:txBody>
-      </p:sp>
-      <p:sp>
-        <p:nvSpPr>
-          <p:cNvPr id="26" name="Tarjeta 2025-2"/>
+              <a:t>Visita 1 · supervisión ampliada</a:t>
+            </a:r>
+            <a:endParaRPr lang="en-US" sz="1400" dirty="0"/>
+          </a:p>
+        </p:txBody>
+      </p:sp>
+      <p:sp>
+        <p:nvSpPr>
+          <p:cNvPr id="26" name="Tarjeta 2025-1"/>
           <p:cNvSpPr/>
           <p:nvPr/>
         </p:nvSpPr>
         <p:spPr>
           <a:xfrm>
-            <a:off x="8336128" y="1097280"/>
+            <a:off x="4572000" y="1097280"/>
             <a:ext cx="3306928" cy="2103120"/>
           </a:xfrm>
           <a:prstGeom prst="roundRect">
@@ -2574,13 +2532,13 @@
       </p:sp>
       <p:sp>
         <p:nvSpPr>
-          <p:cNvPr id="27" name="Fecha fondo 2025-2"/>
+          <p:cNvPr id="27" name="Fecha fondo 2025-1"/>
           <p:cNvSpPr/>
           <p:nvPr/>
         </p:nvSpPr>
         <p:spPr>
           <a:xfrm>
-            <a:off x="8473288" y="1234440"/>
+            <a:off x="4709160" y="1234440"/>
             <a:ext cx="914400" cy="1828800"/>
           </a:xfrm>
           <a:prstGeom prst="roundRect">
@@ -2603,13 +2561,13 @@
       </p:sp>
       <p:sp>
         <p:nvSpPr>
-          <p:cNvPr id="28" name="Fecha día 2025-2"/>
-          <p:cNvSpPr txBox="1"/>
-          <p:nvPr/>
-        </p:nvSpPr>
-        <p:spPr>
-          <a:xfrm>
-            <a:off x="8473288" y="1463040"/>
+          <p:cNvPr id="28" name="Fecha día 2025-1"/>
+          <p:cNvSpPr txBox="1"/>
+          <p:nvPr/>
+        </p:nvSpPr>
+        <p:spPr>
+          <a:xfrm>
+            <a:off x="4709160" y="1554480"/>
             <a:ext cx="914400" cy="548640"/>
           </a:xfrm>
           <a:prstGeom prst="rect">
@@ -2634,7 +2592,7 @@
                 <a:ea typeface="Cambria" pitchFamily="34" charset="-122"/>
                 <a:cs typeface="Cambria" pitchFamily="34" charset="-120"/>
               </a:rPr>
-              <a:t>05</a:t>
+              <a:t>09</a:t>
             </a:r>
             <a:endParaRPr lang="en-US" sz="3400" dirty="0"/>
           </a:p>
@@ -2642,13 +2600,13 @@
       </p:sp>
       <p:sp>
         <p:nvSpPr>
-          <p:cNvPr id="29" name="Fecha mes 2025-2"/>
-          <p:cNvSpPr txBox="1"/>
-          <p:nvPr/>
-        </p:nvSpPr>
-        <p:spPr>
-          <a:xfrm>
-            <a:off x="8473288" y="2011680"/>
+          <p:cNvPr id="29" name="Fecha mes 2025-1"/>
+          <p:cNvSpPr txBox="1"/>
+          <p:nvPr/>
+        </p:nvSpPr>
+        <p:spPr>
+          <a:xfrm>
+            <a:off x="4709160" y="2121408"/>
             <a:ext cx="914400" cy="274320"/>
           </a:xfrm>
           <a:prstGeom prst="rect">
@@ -2670,7 +2628,7 @@
                   <a:schemeClr val="bg1"/>
                 </a:solidFill>
               </a:rPr>
-              <a:t>NOV</a:t>
+              <a:t>ABR</a:t>
             </a:r>
             <a:endParaRPr lang="en-US" sz="1400" dirty="0"/>
           </a:p>
@@ -2678,13 +2636,13 @@
       </p:sp>
       <p:sp>
         <p:nvSpPr>
-          <p:cNvPr id="30" name="Fecha año 2025-2"/>
-          <p:cNvSpPr txBox="1"/>
-          <p:nvPr/>
-        </p:nvSpPr>
-        <p:spPr>
-          <a:xfrm>
-            <a:off x="8473288" y="2286000"/>
+          <p:cNvPr id="30" name="Fecha año 2025-1"/>
+          <p:cNvSpPr txBox="1"/>
+          <p:nvPr/>
+        </p:nvSpPr>
+        <p:spPr>
+          <a:xfrm>
+            <a:off x="4709160" y="2423160"/>
             <a:ext cx="914400" cy="274320"/>
           </a:xfrm>
           <a:prstGeom prst="rect">
@@ -2714,14 +2672,50 @@
       </p:sp>
       <p:sp>
         <p:nvSpPr>
-          <p:cNvPr id="31" name="Paso 2025-2"/>
-          <p:cNvSpPr txBox="1"/>
-          <p:nvPr/>
-        </p:nvSpPr>
-        <p:spPr>
-          <a:xfrm>
-            <a:off x="8473288" y="2697480"/>
-            <a:ext cx="914400" cy="228600"/>
+          <p:cNvPr id="31" name="Tipo 2025-1"/>
+          <p:cNvSpPr txBox="1"/>
+          <p:nvPr/>
+        </p:nvSpPr>
+        <p:spPr>
+          <a:xfrm>
+            <a:off x="5806440" y="1261872"/>
+            <a:ext cx="1935328" cy="502920"/>
+          </a:xfrm>
+          <a:prstGeom prst="rect">
+            <a:avLst/>
+          </a:prstGeom>
+          <a:noFill/>
+          <a:ln/>
+        </p:spPr>
+        <p:txBody>
+          <a:bodyPr wrap="square" lIns="0" tIns="0" rIns="0" bIns="0" rtlCol="0" anchor="ctr"/>
+          <a:lstStyle/>
+          <a:p>
+            <a:pPr indent="0" marL="0">
+              <a:buNone/>
+            </a:pPr>
+            <a:r>
+              <a:rPr lang="en-US" sz="1400" b="1" dirty="0">
+                <a:solidFill>
+                  <a:schemeClr val="tx1"/>
+                </a:solidFill>
+              </a:rPr>
+              <a:t>Nombramiento de visita ampliada</a:t>
+            </a:r>
+            <a:endParaRPr lang="en-US" sz="1400" dirty="0"/>
+          </a:p>
+        </p:txBody>
+      </p:sp>
+      <p:sp>
+        <p:nvSpPr>
+          <p:cNvPr id="32" name="Circular 2025-1"/>
+          <p:cNvSpPr txBox="1"/>
+          <p:nvPr/>
+        </p:nvSpPr>
+        <p:spPr>
+          <a:xfrm>
+            <a:off x="5806440" y="1828800"/>
+            <a:ext cx="1935328" cy="438912"/>
           </a:xfrm>
           <a:prstGeom prst="rect">
             <a:avLst/>
@@ -2733,78 +2727,6 @@
           <a:bodyPr wrap="square" lIns="0" tIns="0" rIns="0" bIns="0" rtlCol="0" anchor="t"/>
           <a:lstStyle/>
           <a:p>
-            <a:pPr algn="ctr" indent="0" marL="0">
-              <a:buNone/>
-            </a:pPr>
-            <a:r>
-              <a:rPr lang="en-US" sz="950" b="1" spc="100" kern="0" dirty="0">
-                <a:solidFill>
-                  <a:schemeClr val="bg1"/>
-                </a:solidFill>
-              </a:rPr>
-              <a:t>PASO 2 DE 2</a:t>
-            </a:r>
-            <a:endParaRPr lang="en-US" sz="950" dirty="0"/>
-          </a:p>
-        </p:txBody>
-      </p:sp>
-      <p:sp>
-        <p:nvSpPr>
-          <p:cNvPr id="32" name="Tipo 2025-2"/>
-          <p:cNvSpPr txBox="1"/>
-          <p:nvPr/>
-        </p:nvSpPr>
-        <p:spPr>
-          <a:xfrm>
-            <a:off x="9570568" y="1261872"/>
-            <a:ext cx="1935328" cy="502920"/>
-          </a:xfrm>
-          <a:prstGeom prst="rect">
-            <a:avLst/>
-          </a:prstGeom>
-          <a:noFill/>
-          <a:ln/>
-        </p:spPr>
-        <p:txBody>
-          <a:bodyPr wrap="square" lIns="0" tIns="0" rIns="0" bIns="0" rtlCol="0" anchor="ctr"/>
-          <a:lstStyle/>
-          <a:p>
-            <a:pPr indent="0" marL="0">
-              <a:buNone/>
-            </a:pPr>
-            <a:r>
-              <a:rPr lang="en-US" sz="1400" b="1" dirty="0">
-                <a:solidFill>
-                  <a:schemeClr val="tx1"/>
-                </a:solidFill>
-              </a:rPr>
-              <a:t>Resultados preliminares</a:t>
-            </a:r>
-            <a:endParaRPr lang="en-US" sz="1400" dirty="0"/>
-          </a:p>
-        </p:txBody>
-      </p:sp>
-      <p:sp>
-        <p:nvSpPr>
-          <p:cNvPr id="33" name="Circular 2025-2"/>
-          <p:cNvSpPr txBox="1"/>
-          <p:nvPr/>
-        </p:nvSpPr>
-        <p:spPr>
-          <a:xfrm>
-            <a:off x="9570568" y="1828800"/>
-            <a:ext cx="1935328" cy="438912"/>
-          </a:xfrm>
-          <a:prstGeom prst="rect">
-            <a:avLst/>
-          </a:prstGeom>
-          <a:noFill/>
-          <a:ln/>
-        </p:spPr>
-        <p:txBody>
-          <a:bodyPr wrap="square" lIns="0" tIns="0" rIns="0" bIns="0" rtlCol="0" anchor="t"/>
-          <a:lstStyle/>
-          <a:p>
             <a:pPr indent="0" marL="0">
               <a:buNone/>
             </a:pPr>
@@ -2828,7 +2750,7 @@
                   <a:schemeClr val="accent1"/>
                 </a:solidFill>
               </a:rPr>
-              <a:t>DS-SABAO-BCS-BC-17003</a:t>
+              <a:t>DS-SABAO-BCS-BC-9337</a:t>
             </a:r>
             <a:endParaRPr lang="en-US" sz="1100" dirty="0"/>
           </a:p>
@@ -2836,13 +2758,13 @@
       </p:sp>
       <p:sp>
         <p:nvSpPr>
-          <p:cNvPr id="34" name="Separador 2025-2-0"/>
+          <p:cNvPr id="33" name="Separador 2025-1-0"/>
           <p:cNvSpPr/>
           <p:nvPr/>
         </p:nvSpPr>
         <p:spPr>
           <a:xfrm>
-            <a:off x="9570568" y="2340864"/>
+            <a:off x="5806440" y="2340864"/>
             <a:ext cx="1935328" cy="0"/>
           </a:xfrm>
           <a:prstGeom prst="line">
@@ -2859,13 +2781,13 @@
       </p:sp>
       <p:sp>
         <p:nvSpPr>
-          <p:cNvPr id="35" name="Dato 2025-2-0"/>
-          <p:cNvSpPr txBox="1"/>
-          <p:nvPr/>
-        </p:nvSpPr>
-        <p:spPr>
-          <a:xfrm>
-            <a:off x="9570568" y="2377440"/>
+          <p:cNvPr id="34" name="Dato 2025-1-0"/>
+          <p:cNvSpPr txBox="1"/>
+          <p:nvPr/>
+        </p:nvSpPr>
+        <p:spPr>
+          <a:xfrm>
+            <a:off x="5806440" y="2377440"/>
             <a:ext cx="1935328" cy="310896"/>
           </a:xfrm>
           <a:prstGeom prst="rect">
@@ -2887,7 +2809,7 @@
                   <a:schemeClr val="accent5"/>
                 </a:solidFill>
               </a:rPr>
-              <a:t>Resultado  </a:t>
+              <a:t>Corte  </a:t>
             </a:r>
             <a:pPr indent="0" marL="0">
               <a:buNone/>
@@ -2898,7 +2820,7 @@
                   <a:schemeClr val="tx1"/>
                 </a:solidFill>
               </a:rPr>
-              <a:t>9 observaciones</a:t>
+              <a:t>30/04/2025</a:t>
             </a:r>
             <a:endParaRPr lang="en-US" sz="1150" dirty="0"/>
           </a:p>
@@ -2906,13 +2828,13 @@
       </p:sp>
       <p:sp>
         <p:nvSpPr>
-          <p:cNvPr id="36" name="Separador 2025-2-1"/>
+          <p:cNvPr id="35" name="Separador 2025-1-1"/>
           <p:cNvSpPr/>
           <p:nvPr/>
         </p:nvSpPr>
         <p:spPr>
           <a:xfrm>
-            <a:off x="9570568" y="2706624"/>
+            <a:off x="5806440" y="2706624"/>
             <a:ext cx="1935328" cy="0"/>
           </a:xfrm>
           <a:prstGeom prst="line">
@@ -2929,13 +2851,13 @@
       </p:sp>
       <p:sp>
         <p:nvSpPr>
-          <p:cNvPr id="37" name="Dato 2025-2-1"/>
-          <p:cNvSpPr txBox="1"/>
-          <p:nvPr/>
-        </p:nvSpPr>
-        <p:spPr>
-          <a:xfrm>
-            <a:off x="9570568" y="2743200"/>
+          <p:cNvPr id="36" name="Dato 2025-1-1"/>
+          <p:cNvSpPr txBox="1"/>
+          <p:nvPr/>
+        </p:nvSpPr>
+        <p:spPr>
+          <a:xfrm>
+            <a:off x="5806440" y="2743200"/>
             <a:ext cx="1935328" cy="310896"/>
           </a:xfrm>
           <a:prstGeom prst="rect">
@@ -2957,7 +2879,7 @@
                   <a:schemeClr val="accent5"/>
                 </a:solidFill>
               </a:rPr>
-              <a:t>Descargos  </a:t>
+              <a:t>Inicio de visita  </a:t>
             </a:r>
             <a:pPr indent="0" marL="0">
               <a:buNone/>
@@ -2968,7 +2890,7 @@
                   <a:schemeClr val="tx1"/>
                 </a:solidFill>
               </a:rPr>
-              <a:t>10 días hábiles</a:t>
+              <a:t>19/05/2025</a:t>
             </a:r>
             <a:endParaRPr lang="en-US" sz="1150" dirty="0"/>
           </a:p>
@@ -2976,17 +2898,46 @@
       </p:sp>
       <p:sp>
         <p:nvSpPr>
-          <p:cNvPr id="38" name="Flecha 2025"/>
+          <p:cNvPr id="37" name="Tarjeta 2025-2"/>
           <p:cNvSpPr/>
           <p:nvPr/>
         </p:nvSpPr>
         <p:spPr>
           <a:xfrm>
-            <a:off x="7970368" y="2011680"/>
-            <a:ext cx="274320" cy="274320"/>
-          </a:xfrm>
-          <a:prstGeom prst="rightArrow">
-            <a:avLst/>
+            <a:off x="8336128" y="1097280"/>
+            <a:ext cx="3306928" cy="2103120"/>
+          </a:xfrm>
+          <a:prstGeom prst="roundRect">
+            <a:avLst>
+              <a:gd name="adj" fmla="val 4348"/>
+            </a:avLst>
+          </a:prstGeom>
+          <a:solidFill>
+            <a:schemeClr val="bg1"/>
+          </a:solidFill>
+          <a:ln w="12700">
+            <a:solidFill>
+              <a:srgbClr val="D9E0EA"/>
+            </a:solidFill>
+            <a:prstDash val="solid"/>
+          </a:ln>
+        </p:spPr>
+      </p:sp>
+      <p:sp>
+        <p:nvSpPr>
+          <p:cNvPr id="38" name="Fecha fondo 2025-2"/>
+          <p:cNvSpPr/>
+          <p:nvPr/>
+        </p:nvSpPr>
+        <p:spPr>
+          <a:xfrm>
+            <a:off x="8473288" y="1234440"/>
+            <a:ext cx="914400" cy="1828800"/>
+          </a:xfrm>
+          <a:prstGeom prst="roundRect">
+            <a:avLst>
+              <a:gd name="adj" fmla="val 10000"/>
+            </a:avLst>
           </a:prstGeom>
           <a:solidFill>
             <a:schemeClr val="accent1"/>
@@ -3003,14 +2954,14 @@
       </p:sp>
       <p:sp>
         <p:nvSpPr>
-          <p:cNvPr id="39" name="Año 2026"/>
-          <p:cNvSpPr txBox="1"/>
-          <p:nvPr/>
-        </p:nvSpPr>
-        <p:spPr>
-          <a:xfrm>
-            <a:off x="4572000" y="3401568"/>
-            <a:ext cx="1188720" cy="502920"/>
+          <p:cNvPr id="39" name="Fecha día 2025-2"/>
+          <p:cNvSpPr txBox="1"/>
+          <p:nvPr/>
+        </p:nvSpPr>
+        <p:spPr>
+          <a:xfrm>
+            <a:off x="8473288" y="1554480"/>
+            <a:ext cx="914400" cy="548640"/>
           </a:xfrm>
           <a:prstGeom prst="rect">
             <a:avLst/>
@@ -3022,18 +2973,382 @@
           <a:bodyPr wrap="square" lIns="0" tIns="0" rIns="0" bIns="0" rtlCol="0" anchor="ctr"/>
           <a:lstStyle/>
           <a:p>
-            <a:pPr indent="0" marL="0">
-              <a:buNone/>
-            </a:pPr>
-            <a:r>
-              <a:rPr lang="en-US" sz="3000" b="1" dirty="0">
-                <a:solidFill>
-                  <a:schemeClr val="accent2"/>
+            <a:pPr algn="ctr" indent="0" marL="0">
+              <a:buNone/>
+            </a:pPr>
+            <a:r>
+              <a:rPr lang="en-US" sz="3400" b="1" dirty="0">
+                <a:solidFill>
+                  <a:schemeClr val="bg1"/>
                 </a:solidFill>
                 <a:latin typeface="Cambria" pitchFamily="34" charset="0"/>
                 <a:ea typeface="Cambria" pitchFamily="34" charset="-122"/>
                 <a:cs typeface="Cambria" pitchFamily="34" charset="-120"/>
               </a:rPr>
+              <a:t>05</a:t>
+            </a:r>
+            <a:endParaRPr lang="en-US" sz="3400" dirty="0"/>
+          </a:p>
+        </p:txBody>
+      </p:sp>
+      <p:sp>
+        <p:nvSpPr>
+          <p:cNvPr id="40" name="Fecha mes 2025-2"/>
+          <p:cNvSpPr txBox="1"/>
+          <p:nvPr/>
+        </p:nvSpPr>
+        <p:spPr>
+          <a:xfrm>
+            <a:off x="8473288" y="2121408"/>
+            <a:ext cx="914400" cy="274320"/>
+          </a:xfrm>
+          <a:prstGeom prst="rect">
+            <a:avLst/>
+          </a:prstGeom>
+          <a:noFill/>
+          <a:ln/>
+        </p:spPr>
+        <p:txBody>
+          <a:bodyPr wrap="square" lIns="0" tIns="0" rIns="0" bIns="0" rtlCol="0" anchor="t"/>
+          <a:lstStyle/>
+          <a:p>
+            <a:pPr algn="ctr" indent="0" marL="0">
+              <a:buNone/>
+            </a:pPr>
+            <a:r>
+              <a:rPr lang="en-US" sz="1400" b="1" spc="200" kern="0" dirty="0">
+                <a:solidFill>
+                  <a:schemeClr val="bg1"/>
+                </a:solidFill>
+              </a:rPr>
+              <a:t>NOV</a:t>
+            </a:r>
+            <a:endParaRPr lang="en-US" sz="1400" dirty="0"/>
+          </a:p>
+        </p:txBody>
+      </p:sp>
+      <p:sp>
+        <p:nvSpPr>
+          <p:cNvPr id="41" name="Fecha año 2025-2"/>
+          <p:cNvSpPr txBox="1"/>
+          <p:nvPr/>
+        </p:nvSpPr>
+        <p:spPr>
+          <a:xfrm>
+            <a:off x="8473288" y="2423160"/>
+            <a:ext cx="914400" cy="274320"/>
+          </a:xfrm>
+          <a:prstGeom prst="rect">
+            <a:avLst/>
+          </a:prstGeom>
+          <a:noFill/>
+          <a:ln/>
+        </p:spPr>
+        <p:txBody>
+          <a:bodyPr wrap="square" lIns="0" tIns="0" rIns="0" bIns="0" rtlCol="0" anchor="t"/>
+          <a:lstStyle/>
+          <a:p>
+            <a:pPr algn="ctr" indent="0" marL="0">
+              <a:buNone/>
+            </a:pPr>
+            <a:r>
+              <a:rPr lang="en-US" sz="1200" dirty="0">
+                <a:solidFill>
+                  <a:schemeClr val="bg1"/>
+                </a:solidFill>
+              </a:rPr>
+              <a:t>2025</a:t>
+            </a:r>
+            <a:endParaRPr lang="en-US" sz="1200" dirty="0"/>
+          </a:p>
+        </p:txBody>
+      </p:sp>
+      <p:sp>
+        <p:nvSpPr>
+          <p:cNvPr id="42" name="Tipo 2025-2"/>
+          <p:cNvSpPr txBox="1"/>
+          <p:nvPr/>
+        </p:nvSpPr>
+        <p:spPr>
+          <a:xfrm>
+            <a:off x="9570568" y="1261872"/>
+            <a:ext cx="1935328" cy="502920"/>
+          </a:xfrm>
+          <a:prstGeom prst="rect">
+            <a:avLst/>
+          </a:prstGeom>
+          <a:noFill/>
+          <a:ln/>
+        </p:spPr>
+        <p:txBody>
+          <a:bodyPr wrap="square" lIns="0" tIns="0" rIns="0" bIns="0" rtlCol="0" anchor="ctr"/>
+          <a:lstStyle/>
+          <a:p>
+            <a:pPr indent="0" marL="0">
+              <a:buNone/>
+            </a:pPr>
+            <a:r>
+              <a:rPr lang="en-US" sz="1400" b="1" dirty="0">
+                <a:solidFill>
+                  <a:schemeClr val="tx1"/>
+                </a:solidFill>
+              </a:rPr>
+              <a:t>Resultados preliminares</a:t>
+            </a:r>
+            <a:endParaRPr lang="en-US" sz="1400" dirty="0"/>
+          </a:p>
+        </p:txBody>
+      </p:sp>
+      <p:sp>
+        <p:nvSpPr>
+          <p:cNvPr id="43" name="Circular 2025-2"/>
+          <p:cNvSpPr txBox="1"/>
+          <p:nvPr/>
+        </p:nvSpPr>
+        <p:spPr>
+          <a:xfrm>
+            <a:off x="9570568" y="1828800"/>
+            <a:ext cx="1935328" cy="438912"/>
+          </a:xfrm>
+          <a:prstGeom prst="rect">
+            <a:avLst/>
+          </a:prstGeom>
+          <a:noFill/>
+          <a:ln/>
+        </p:spPr>
+        <p:txBody>
+          <a:bodyPr wrap="square" lIns="0" tIns="0" rIns="0" bIns="0" rtlCol="0" anchor="t"/>
+          <a:lstStyle/>
+          <a:p>
+            <a:pPr indent="0" marL="0">
+              <a:buNone/>
+            </a:pPr>
+            <a:r>
+              <a:rPr lang="en-US" sz="1000" dirty="0">
+                <a:solidFill>
+                  <a:schemeClr val="accent5"/>
+                </a:solidFill>
+              </a:rPr>
+              <a:t>Circular No.</a:t>
+            </a:r>
+            <a:endParaRPr lang="en-US" sz="1100" dirty="0"/>
+          </a:p>
+          <a:p>
+            <a:pPr indent="0" marL="0">
+              <a:buNone/>
+            </a:pPr>
+            <a:r>
+              <a:rPr lang="en-US" sz="1100" b="1" dirty="0">
+                <a:solidFill>
+                  <a:schemeClr val="accent1"/>
+                </a:solidFill>
+              </a:rPr>
+              <a:t>DS-SABAO-BCS-BC-17003</a:t>
+            </a:r>
+            <a:endParaRPr lang="en-US" sz="1100" dirty="0"/>
+          </a:p>
+        </p:txBody>
+      </p:sp>
+      <p:sp>
+        <p:nvSpPr>
+          <p:cNvPr id="44" name="Separador 2025-2-0"/>
+          <p:cNvSpPr/>
+          <p:nvPr/>
+        </p:nvSpPr>
+        <p:spPr>
+          <a:xfrm>
+            <a:off x="9570568" y="2340864"/>
+            <a:ext cx="1935328" cy="0"/>
+          </a:xfrm>
+          <a:prstGeom prst="line">
+            <a:avLst/>
+          </a:prstGeom>
+          <a:noFill/>
+          <a:ln w="9525">
+            <a:solidFill>
+              <a:srgbClr val="D9E0EA"/>
+            </a:solidFill>
+            <a:prstDash val="solid"/>
+          </a:ln>
+        </p:spPr>
+      </p:sp>
+      <p:sp>
+        <p:nvSpPr>
+          <p:cNvPr id="45" name="Dato 2025-2-0"/>
+          <p:cNvSpPr txBox="1"/>
+          <p:nvPr/>
+        </p:nvSpPr>
+        <p:spPr>
+          <a:xfrm>
+            <a:off x="9570568" y="2377440"/>
+            <a:ext cx="1935328" cy="310896"/>
+          </a:xfrm>
+          <a:prstGeom prst="rect">
+            <a:avLst/>
+          </a:prstGeom>
+          <a:noFill/>
+          <a:ln/>
+        </p:spPr>
+        <p:txBody>
+          <a:bodyPr wrap="square" lIns="0" tIns="0" rIns="0" bIns="0" rtlCol="0" anchor="ctr"/>
+          <a:lstStyle/>
+          <a:p>
+            <a:pPr indent="0" marL="0">
+              <a:buNone/>
+            </a:pPr>
+            <a:r>
+              <a:rPr lang="en-US" sz="1150" dirty="0">
+                <a:solidFill>
+                  <a:schemeClr val="accent5"/>
+                </a:solidFill>
+              </a:rPr>
+              <a:t>Resultado  </a:t>
+            </a:r>
+            <a:pPr indent="0" marL="0">
+              <a:buNone/>
+            </a:pPr>
+            <a:r>
+              <a:rPr lang="en-US" sz="1150" b="1" dirty="0">
+                <a:solidFill>
+                  <a:schemeClr val="tx1"/>
+                </a:solidFill>
+              </a:rPr>
+              <a:t>9 observaciones</a:t>
+            </a:r>
+            <a:endParaRPr lang="en-US" sz="1150" dirty="0"/>
+          </a:p>
+        </p:txBody>
+      </p:sp>
+      <p:sp>
+        <p:nvSpPr>
+          <p:cNvPr id="46" name="Separador 2025-2-1"/>
+          <p:cNvSpPr/>
+          <p:nvPr/>
+        </p:nvSpPr>
+        <p:spPr>
+          <a:xfrm>
+            <a:off x="9570568" y="2706624"/>
+            <a:ext cx="1935328" cy="0"/>
+          </a:xfrm>
+          <a:prstGeom prst="line">
+            <a:avLst/>
+          </a:prstGeom>
+          <a:noFill/>
+          <a:ln w="9525">
+            <a:solidFill>
+              <a:srgbClr val="D9E0EA"/>
+            </a:solidFill>
+            <a:prstDash val="solid"/>
+          </a:ln>
+        </p:spPr>
+      </p:sp>
+      <p:sp>
+        <p:nvSpPr>
+          <p:cNvPr id="47" name="Dato 2025-2-1"/>
+          <p:cNvSpPr txBox="1"/>
+          <p:nvPr/>
+        </p:nvSpPr>
+        <p:spPr>
+          <a:xfrm>
+            <a:off x="9570568" y="2743200"/>
+            <a:ext cx="1935328" cy="310896"/>
+          </a:xfrm>
+          <a:prstGeom prst="rect">
+            <a:avLst/>
+          </a:prstGeom>
+          <a:noFill/>
+          <a:ln/>
+        </p:spPr>
+        <p:txBody>
+          <a:bodyPr wrap="square" lIns="0" tIns="0" rIns="0" bIns="0" rtlCol="0" anchor="ctr"/>
+          <a:lstStyle/>
+          <a:p>
+            <a:pPr indent="0" marL="0">
+              <a:buNone/>
+            </a:pPr>
+            <a:r>
+              <a:rPr lang="en-US" sz="1150" dirty="0">
+                <a:solidFill>
+                  <a:schemeClr val="accent5"/>
+                </a:solidFill>
+              </a:rPr>
+              <a:t>Descargos  </a:t>
+            </a:r>
+            <a:pPr indent="0" marL="0">
+              <a:buNone/>
+            </a:pPr>
+            <a:r>
+              <a:rPr lang="en-US" sz="1150" b="1" dirty="0">
+                <a:solidFill>
+                  <a:schemeClr val="tx1"/>
+                </a:solidFill>
+              </a:rPr>
+              <a:t>10 días hábiles</a:t>
+            </a:r>
+            <a:endParaRPr lang="en-US" sz="1150" dirty="0"/>
+          </a:p>
+        </p:txBody>
+      </p:sp>
+      <p:sp>
+        <p:nvSpPr>
+          <p:cNvPr id="48" name="Flecha 2025"/>
+          <p:cNvSpPr/>
+          <p:nvPr/>
+        </p:nvSpPr>
+        <p:spPr>
+          <a:xfrm>
+            <a:off x="7970368" y="2011680"/>
+            <a:ext cx="274320" cy="274320"/>
+          </a:xfrm>
+          <a:prstGeom prst="rightArrow">
+            <a:avLst/>
+          </a:prstGeom>
+          <a:solidFill>
+            <a:schemeClr val="accent1"/>
+          </a:solidFill>
+          <a:ln w="12700">
+            <a:solidFill>
+              <a:schemeClr val="accent1">
+                <a:alpha val="0"/>
+              </a:schemeClr>
+            </a:solidFill>
+            <a:prstDash val="solid"/>
+          </a:ln>
+        </p:spPr>
+      </p:sp>
+      <p:sp>
+        <p:nvSpPr>
+          <p:cNvPr id="49" name="Año 2026"/>
+          <p:cNvSpPr txBox="1"/>
+          <p:nvPr/>
+        </p:nvSpPr>
+        <p:spPr>
+          <a:xfrm>
+            <a:off x="4572000" y="3401568"/>
+            <a:ext cx="1188720" cy="502920"/>
+          </a:xfrm>
+          <a:prstGeom prst="rect">
+            <a:avLst/>
+          </a:prstGeom>
+          <a:noFill/>
+          <a:ln/>
+        </p:spPr>
+        <p:txBody>
+          <a:bodyPr wrap="square" lIns="0" tIns="0" rIns="0" bIns="0" rtlCol="0" anchor="ctr"/>
+          <a:lstStyle/>
+          <a:p>
+            <a:pPr indent="0" marL="0">
+              <a:buNone/>
+            </a:pPr>
+            <a:r>
+              <a:rPr lang="en-US" sz="3000" b="1" dirty="0">
+                <a:solidFill>
+                  <a:schemeClr val="accent2"/>
+                </a:solidFill>
+                <a:latin typeface="Cambria" pitchFamily="34" charset="0"/>
+                <a:ea typeface="Cambria" pitchFamily="34" charset="-122"/>
+                <a:cs typeface="Cambria" pitchFamily="34" charset="-120"/>
+              </a:rPr>
               <a:t>2026</a:t>
             </a:r>
             <a:endParaRPr lang="en-US" sz="3000" dirty="0"/>
@@ -3042,7 +3357,7 @@
       </p:sp>
       <p:sp>
         <p:nvSpPr>
-          <p:cNvPr id="40" name="Visita 2026"/>
+          <p:cNvPr id="50" name="Visita 2026"/>
           <p:cNvSpPr txBox="1"/>
           <p:nvPr/>
         </p:nvSpPr>
@@ -3078,7 +3393,7 @@
       </p:sp>
       <p:sp>
         <p:nvSpPr>
-          <p:cNvPr id="41" name="Tarjeta 2026-1"/>
+          <p:cNvPr id="51" name="Tarjeta 2026-1"/>
           <p:cNvSpPr/>
           <p:nvPr/>
         </p:nvSpPr>
@@ -3105,7 +3420,7 @@
       </p:sp>
       <p:sp>
         <p:nvSpPr>
-          <p:cNvPr id="42" name="Fecha fondo 2026-1"/>
+          <p:cNvPr id="52" name="Fecha fondo 2026-1"/>
           <p:cNvSpPr/>
           <p:nvPr/>
         </p:nvSpPr>
@@ -3134,13 +3449,13 @@
       </p:sp>
       <p:sp>
         <p:nvSpPr>
-          <p:cNvPr id="43" name="Fecha día 2026-1"/>
-          <p:cNvSpPr txBox="1"/>
-          <p:nvPr/>
-        </p:nvSpPr>
-        <p:spPr>
-          <a:xfrm>
-            <a:off x="4709160" y="4407408"/>
+          <p:cNvPr id="53" name="Fecha día 2026-1"/>
+          <p:cNvSpPr txBox="1"/>
+          <p:nvPr/>
+        </p:nvSpPr>
+        <p:spPr>
+          <a:xfrm>
+            <a:off x="4709160" y="4498848"/>
             <a:ext cx="914400" cy="548640"/>
           </a:xfrm>
           <a:prstGeom prst="rect">
@@ -3173,13 +3488,13 @@
       </p:sp>
       <p:sp>
         <p:nvSpPr>
-          <p:cNvPr id="44" name="Fecha mes 2026-1"/>
-          <p:cNvSpPr txBox="1"/>
-          <p:nvPr/>
-        </p:nvSpPr>
-        <p:spPr>
-          <a:xfrm>
-            <a:off x="4709160" y="4956048"/>
+          <p:cNvPr id="54" name="Fecha mes 2026-1"/>
+          <p:cNvSpPr txBox="1"/>
+          <p:nvPr/>
+        </p:nvSpPr>
+        <p:spPr>
+          <a:xfrm>
+            <a:off x="4709160" y="5065776"/>
             <a:ext cx="914400" cy="274320"/>
           </a:xfrm>
           <a:prstGeom prst="rect">
@@ -3209,13 +3524,13 @@
       </p:sp>
       <p:sp>
         <p:nvSpPr>
-          <p:cNvPr id="45" name="Fecha año 2026-1"/>
-          <p:cNvSpPr txBox="1"/>
-          <p:nvPr/>
-        </p:nvSpPr>
-        <p:spPr>
-          <a:xfrm>
-            <a:off x="4709160" y="5230368"/>
+          <p:cNvPr id="55" name="Fecha año 2026-1"/>
+          <p:cNvSpPr txBox="1"/>
+          <p:nvPr/>
+        </p:nvSpPr>
+        <p:spPr>
+          <a:xfrm>
+            <a:off x="4709160" y="5367528"/>
             <a:ext cx="914400" cy="274320"/>
           </a:xfrm>
           <a:prstGeom prst="rect">
@@ -3245,43 +3560,7 @@
       </p:sp>
       <p:sp>
         <p:nvSpPr>
-          <p:cNvPr id="46" name="Paso 2026-1"/>
-          <p:cNvSpPr txBox="1"/>
-          <p:nvPr/>
-        </p:nvSpPr>
-        <p:spPr>
-          <a:xfrm>
-            <a:off x="4709160" y="5641848"/>
-            <a:ext cx="914400" cy="228600"/>
-          </a:xfrm>
-          <a:prstGeom prst="rect">
-            <a:avLst/>
-          </a:prstGeom>
-          <a:noFill/>
-          <a:ln/>
-        </p:spPr>
-        <p:txBody>
-          <a:bodyPr wrap="square" lIns="0" tIns="0" rIns="0" bIns="0" rtlCol="0" anchor="t"/>
-          <a:lstStyle/>
-          <a:p>
-            <a:pPr algn="ctr" indent="0" marL="0">
-              <a:buNone/>
-            </a:pPr>
-            <a:r>
-              <a:rPr lang="en-US" sz="950" b="1" spc="100" kern="0" dirty="0">
-                <a:solidFill>
-                  <a:schemeClr val="bg1"/>
-                </a:solidFill>
-              </a:rPr>
-              <a:t>PASO 1 DE 2</a:t>
-            </a:r>
-            <a:endParaRPr lang="en-US" sz="950" dirty="0"/>
-          </a:p>
-        </p:txBody>
-      </p:sp>
-      <p:sp>
-        <p:nvSpPr>
-          <p:cNvPr id="47" name="Tipo 2026-1"/>
+          <p:cNvPr id="56" name="Tipo 2026-1"/>
           <p:cNvSpPr txBox="1"/>
           <p:nvPr/>
         </p:nvSpPr>
@@ -3317,7 +3596,7 @@
       </p:sp>
       <p:sp>
         <p:nvSpPr>
-          <p:cNvPr id="48" name="Circular 2026-1"/>
+          <p:cNvPr id="57" name="Circular 2026-1"/>
           <p:cNvSpPr txBox="1"/>
           <p:nvPr/>
         </p:nvSpPr>
@@ -3367,7 +3646,7 @@
       </p:sp>
       <p:sp>
         <p:nvSpPr>
-          <p:cNvPr id="49" name="Separador 2026-1-0"/>
+          <p:cNvPr id="58" name="Separador 2026-1-0"/>
           <p:cNvSpPr/>
           <p:nvPr/>
         </p:nvSpPr>
@@ -3390,7 +3669,7 @@
       </p:sp>
       <p:sp>
         <p:nvSpPr>
-          <p:cNvPr id="50" name="Dato 2026-1-0"/>
+          <p:cNvPr id="59" name="Dato 2026-1-0"/>
           <p:cNvSpPr txBox="1"/>
           <p:nvPr/>
         </p:nvSpPr>
@@ -3437,7 +3716,7 @@
       </p:sp>
       <p:sp>
         <p:nvSpPr>
-          <p:cNvPr id="51" name="Separador 2026-1-1"/>
+          <p:cNvPr id="60" name="Separador 2026-1-1"/>
           <p:cNvSpPr/>
           <p:nvPr/>
         </p:nvSpPr>
@@ -3460,7 +3739,7 @@
       </p:sp>
       <p:sp>
         <p:nvSpPr>
-          <p:cNvPr id="52" name="Dato 2026-1-1"/>
+          <p:cNvPr id="61" name="Dato 2026-1-1"/>
           <p:cNvSpPr txBox="1"/>
           <p:nvPr/>
         </p:nvSpPr>
@@ -3507,7 +3786,7 @@
       </p:sp>
       <p:sp>
         <p:nvSpPr>
-          <p:cNvPr id="53" name="Tarjeta 2026-2"/>
+          <p:cNvPr id="62" name="Tarjeta 2026-2"/>
           <p:cNvSpPr/>
           <p:nvPr/>
         </p:nvSpPr>
@@ -3534,7 +3813,7 @@
       </p:sp>
       <p:sp>
         <p:nvSpPr>
-          <p:cNvPr id="54" name="Fecha fondo 2026-2"/>
+          <p:cNvPr id="63" name="Fecha fondo 2026-2"/>
           <p:cNvSpPr/>
           <p:nvPr/>
         </p:nvSpPr>
@@ -3563,13 +3842,13 @@
       </p:sp>
       <p:sp>
         <p:nvSpPr>
-          <p:cNvPr id="55" name="Fecha día 2026-2"/>
-          <p:cNvSpPr txBox="1"/>
-          <p:nvPr/>
-        </p:nvSpPr>
-        <p:spPr>
-          <a:xfrm>
-            <a:off x="8473288" y="4407408"/>
+          <p:cNvPr id="64" name="Fecha día 2026-2"/>
+          <p:cNvSpPr txBox="1"/>
+          <p:nvPr/>
+        </p:nvSpPr>
+        <p:spPr>
+          <a:xfrm>
+            <a:off x="8473288" y="4498848"/>
             <a:ext cx="914400" cy="548640"/>
           </a:xfrm>
           <a:prstGeom prst="rect">
@@ -3602,13 +3881,13 @@
       </p:sp>
       <p:sp>
         <p:nvSpPr>
-          <p:cNvPr id="56" name="Fecha mes 2026-2"/>
-          <p:cNvSpPr txBox="1"/>
-          <p:nvPr/>
-        </p:nvSpPr>
-        <p:spPr>
-          <a:xfrm>
-            <a:off x="8473288" y="4956048"/>
+          <p:cNvPr id="65" name="Fecha mes 2026-2"/>
+          <p:cNvSpPr txBox="1"/>
+          <p:nvPr/>
+        </p:nvSpPr>
+        <p:spPr>
+          <a:xfrm>
+            <a:off x="8473288" y="5065776"/>
             <a:ext cx="914400" cy="274320"/>
           </a:xfrm>
           <a:prstGeom prst="rect">
@@ -3638,13 +3917,13 @@
       </p:sp>
       <p:sp>
         <p:nvSpPr>
-          <p:cNvPr id="57" name="Fecha año 2026-2"/>
-          <p:cNvSpPr txBox="1"/>
-          <p:nvPr/>
-        </p:nvSpPr>
-        <p:spPr>
-          <a:xfrm>
-            <a:off x="8473288" y="5230368"/>
+          <p:cNvPr id="66" name="Fecha año 2026-2"/>
+          <p:cNvSpPr txBox="1"/>
+          <p:nvPr/>
+        </p:nvSpPr>
+        <p:spPr>
+          <a:xfrm>
+            <a:off x="8473288" y="5367528"/>
             <a:ext cx="914400" cy="274320"/>
           </a:xfrm>
           <a:prstGeom prst="rect">
@@ -3674,43 +3953,7 @@
       </p:sp>
       <p:sp>
         <p:nvSpPr>
-          <p:cNvPr id="58" name="Paso 2026-2"/>
-          <p:cNvSpPr txBox="1"/>
-          <p:nvPr/>
-        </p:nvSpPr>
-        <p:spPr>
-          <a:xfrm>
-            <a:off x="8473288" y="5641848"/>
-            <a:ext cx="914400" cy="228600"/>
-          </a:xfrm>
-          <a:prstGeom prst="rect">
-            <a:avLst/>
-          </a:prstGeom>
-          <a:noFill/>
-          <a:ln/>
-        </p:spPr>
-        <p:txBody>
-          <a:bodyPr wrap="square" lIns="0" tIns="0" rIns="0" bIns="0" rtlCol="0" anchor="t"/>
-          <a:lstStyle/>
-          <a:p>
-            <a:pPr algn="ctr" indent="0" marL="0">
-              <a:buNone/>
-            </a:pPr>
-            <a:r>
-              <a:rPr lang="en-US" sz="950" b="1" spc="100" kern="0" dirty="0">
-                <a:solidFill>
-                  <a:schemeClr val="bg1"/>
-                </a:solidFill>
-              </a:rPr>
-              <a:t>PASO 2 DE 2</a:t>
-            </a:r>
-            <a:endParaRPr lang="en-US" sz="950" dirty="0"/>
-          </a:p>
-        </p:txBody>
-      </p:sp>
-      <p:sp>
-        <p:nvSpPr>
-          <p:cNvPr id="59" name="Tipo 2026-2"/>
+          <p:cNvPr id="67" name="Tipo 2026-2"/>
           <p:cNvSpPr txBox="1"/>
           <p:nvPr/>
         </p:nvSpPr>
@@ -3746,7 +3989,7 @@
       </p:sp>
       <p:sp>
         <p:nvSpPr>
-          <p:cNvPr id="60" name="Circular 2026-2"/>
+          <p:cNvPr id="68" name="Circular 2026-2"/>
           <p:cNvSpPr txBox="1"/>
           <p:nvPr/>
         </p:nvSpPr>
@@ -3796,7 +4039,7 @@
       </p:sp>
       <p:sp>
         <p:nvSpPr>
-          <p:cNvPr id="61" name="Separador 2026-2-0"/>
+          <p:cNvPr id="69" name="Separador 2026-2-0"/>
           <p:cNvSpPr/>
           <p:nvPr/>
         </p:nvSpPr>
@@ -3819,7 +4062,7 @@
       </p:sp>
       <p:sp>
         <p:nvSpPr>
-          <p:cNvPr id="62" name="Dato 2026-2-0"/>
+          <p:cNvPr id="70" name="Dato 2026-2-0"/>
           <p:cNvSpPr txBox="1"/>
           <p:nvPr/>
         </p:nvSpPr>
@@ -3866,7 +4109,7 @@
       </p:sp>
       <p:sp>
         <p:nvSpPr>
-          <p:cNvPr id="63" name="Separador 2026-2-1"/>
+          <p:cNvPr id="71" name="Separador 2026-2-1"/>
           <p:cNvSpPr/>
           <p:nvPr/>
         </p:nvSpPr>
@@ -3889,7 +4132,7 @@
       </p:sp>
       <p:sp>
         <p:nvSpPr>
-          <p:cNvPr id="64" name="Dato 2026-2-1"/>
+          <p:cNvPr id="72" name="Dato 2026-2-1"/>
           <p:cNvSpPr txBox="1"/>
           <p:nvPr/>
         </p:nvSpPr>
@@ -3936,7 +4179,7 @@
       </p:sp>
       <p:sp>
         <p:nvSpPr>
-          <p:cNvPr id="65" name="Flecha 2026"/>
+          <p:cNvPr id="73" name="Flecha 2026"/>
           <p:cNvSpPr/>
           <p:nvPr/>
         </p:nvSpPr>

</xml_diff>

<commit_message>
Update responsables and responses from requirement matrices and solution plan
Co-Authored-By: Claude Opus 5.5 <noreply@anthropic.com>
Claude-Session: https://claude.ai/code/session_01F1WXR13Nv8neEtLhaK3ELa
</commit_message>
<xml_diff>
--- a/supervision-gobierno-corporativo/Supervision_GC_SSF_COMEDICA_2025-2026.pptx
+++ b/supervision-gobierno-corporativo/Supervision_GC_SSF_COMEDICA_2025-2026.pptx
@@ -110,22 +110,22 @@
   <p:extLst>
     <p:ext uri="{521415D9-36F7-43E2-AB2F-B90AF26B5E84}">
       <p14:sectionLst xmlns:p14="http://schemas.microsoft.com/office/powerpoint/2010/main">
-        <p14:section name="1 · Resumen de circulares SSF" id="{619f2926-fd99-cca1-1be0-1035ac208998}">
+        <p14:section name="1 · Resumen de circulares SSF" id="{cd644b79-7029-ba89-e5ea-7a004caeb1d1}">
           <p14:sldIdLst>
             <p14:sldId id="256"/>
           </p14:sldIdLst>
         </p14:section>
-        <p14:section name="2 · Observaciones 2025" id="{ccdfb403-7b12-d3a4-9611-e82fe676afd5}">
+        <p14:section name="2 · Observaciones 2025" id="{47cc28b4-e155-0e32-ba32-07f05acc5604}">
           <p14:sldIdLst>
             <p14:sldId id="257"/>
           </p14:sldIdLst>
         </p14:section>
-        <p14:section name="3 · Observaciones 2026" id="{ad589576-44a1-76d6-d228-14ef33ae39c6}">
+        <p14:section name="3 · Observaciones 2026" id="{ed885da7-e1e1-0cd8-2619-7ac6fb5c8e67}">
           <p14:sldIdLst>
             <p14:sldId id="258"/>
           </p14:sldIdLst>
         </p14:section>
-        <p14:section name="4 · Línea de tiempo y evolución" id="{372e2051-7d80-12e8-24f4-ab370725ff6b}">
+        <p14:section name="4 · Línea de tiempo y evolución" id="{58fbf1f1-8a0d-6b19-fa7c-7d21a3e47fa0}">
           <p14:sldIdLst>
             <p14:sldId id="259"/>
           </p14:sldIdLst>
@@ -622,7 +622,7 @@
           <a:p>
             <a:r>
               <a:rPr lang="en-US" dirty="0"/>
-              <a:t>Nueve observaciones de la Circular 17003. Los responsables son los órganos y cargos que señala la propia circular. En rojo y ámbar, las 2 observaciones a las que la SSF dio seguimiento en la visita 2026 (Anexo B): obs. 3 (no superada) y obs. 5 (parcialmente superada).</a:t>
+              <a:t>Nueve observaciones de la Circular 17003. Responsable y descargo según la Matriz de requerimientos enviada a la SSF el 18/11/2025 (ref. NB07-2025-974, buzón DESCARGOS_OBSERVACIONES). Obs. 5: actualizados el Reglamento del Comité de Finanzas (21/07/2025), la Política de Seguridad de la Información (02/06/2025) y el Manual de Inducción (25/08/2025). En rojo, las 2 observaciones con seguimiento en 2026 (Anexo B): obs. 3 no superada y obs. 5 parcialmente superada.</a:t>
             </a:r>
             <a:endParaRPr lang="en-US" dirty="0"/>
           </a:p>
@@ -710,7 +710,7 @@
           <a:p>
             <a:r>
               <a:rPr lang="en-US" dirty="0"/>
-              <a:t>Anexo A: siete observaciones nuevas; los responsables son los que señala la Circular 22741 (en la obs. 4, Administración de Riesgo). Plazo de 10 días hábiles para remitir pruebas de descargo, previo conocimiento del Consejo de Administración. Anexo B: no son observaciones nuevas, es el seguimiento a las obs. 3 y 5 de 2025; plan de solución en 15 días hábiles con acciones, responsable, plazo por acción y certificación del punto de acta del Consejo. Fechas aproximadas sin asuetos.</a:t>
+              <a:t>Anexo A: siete observaciones nuevas. Responsable y respuesta según la Matriz de requerimientos de la Circular 22741 (las obs. 1, 4 y 5 aún no tienen comentario en la matriz). Anexo B: seguimiento a las obs. 3 y 5 de 2025; responsable y avance según el Plan de solución. Obs. 5: Reglamento Interno de Trabajo en proceso; Reglamento del Comité de Auditoría aprobado por el Comité el 28/08/2026 y remitido el 05/10/2026 al Consejo de Administración para ratificación; Manual de Compras en proceso. Plazos: 10 días hábiles para descargos y 15 días hábiles para el plan de solución (fechas aproximadas sin asuetos).</a:t>
             </a:r>
             <a:endParaRPr lang="en-US" dirty="0"/>
           </a:p>
@@ -3283,7 +3283,7 @@
                   <a:schemeClr val="tx1"/>
                 </a:solidFill>
               </a:rPr>
-              <a:t>10 días hábiles</a:t>
+              <a:t>18/11/2025</a:t>
             </a:r>
             <a:endParaRPr lang="en-US" sz="1150" dirty="0"/>
           </a:p>
@@ -4618,8 +4618,8 @@
         </p:nvSpPr>
         <p:spPr>
           <a:xfrm>
-            <a:off x="731520" y="2093976"/>
-            <a:ext cx="3240938" cy="758952"/>
+            <a:off x="731520" y="2075688"/>
+            <a:ext cx="3240938" cy="795528"/>
           </a:xfrm>
           <a:prstGeom prst="rect">
             <a:avLst/>
@@ -4638,7 +4638,7 @@
               <a:buNone/>
             </a:pPr>
             <a:r>
-              <a:rPr lang="en-US" sz="1050" b="1" dirty="0">
+              <a:rPr lang="en-US" sz="1000" b="1" dirty="0">
                 <a:solidFill>
                   <a:schemeClr val="accent5"/>
                 </a:solidFill>
@@ -4652,14 +4652,14 @@
               <a:buNone/>
             </a:pPr>
             <a:r>
-              <a:rPr lang="en-US" sz="1050" dirty="0">
+              <a:rPr lang="en-US" sz="1000" dirty="0">
                 <a:solidFill>
                   <a:schemeClr val="tx1"/>
                 </a:solidFill>
               </a:rPr>
-              <a:t>Consejo de Administración</a:t>
-            </a:r>
-            <a:endParaRPr lang="en-US" sz="1050" dirty="0"/>
+              <a:t>ADR / Jefe de Riesgos</a:t>
+            </a:r>
+            <a:endParaRPr lang="en-US" sz="1000" dirty="0"/>
           </a:p>
           <a:p>
             <a:pPr indent="0" marL="0">
@@ -4669,12 +4669,12 @@
               <a:buNone/>
             </a:pPr>
             <a:r>
-              <a:rPr lang="en-US" sz="1050" b="1" dirty="0">
+              <a:rPr lang="en-US" sz="1000" b="1" dirty="0">
                 <a:solidFill>
                   <a:schemeClr val="accent5"/>
                 </a:solidFill>
               </a:rPr>
-              <a:t>Criterio  </a:t>
+              <a:t>Descargo  </a:t>
             </a:r>
             <a:pPr indent="0" marL="0">
               <a:spcAft>
@@ -4683,14 +4683,14 @@
               <a:buNone/>
             </a:pPr>
             <a:r>
-              <a:rPr lang="en-US" sz="1050" dirty="0">
+              <a:rPr lang="en-US" sz="1000" dirty="0">
                 <a:solidFill>
                   <a:schemeClr val="tx1"/>
                 </a:solidFill>
               </a:rPr>
-              <a:t>Art. 12 literal c) NRP-17</a:t>
-            </a:r>
-            <a:endParaRPr lang="en-US" sz="1050" dirty="0"/>
+              <a:t>Se creará la política: Comité de Riesgos y aprobación del Consejo</a:t>
+            </a:r>
+            <a:endParaRPr lang="en-US" sz="1000" dirty="0"/>
           </a:p>
         </p:txBody>
       </p:sp>
@@ -4833,8 +4833,8 @@
         </p:nvSpPr>
         <p:spPr>
           <a:xfrm>
-            <a:off x="4475378" y="2093976"/>
-            <a:ext cx="3240938" cy="758952"/>
+            <a:off x="4475378" y="2075688"/>
+            <a:ext cx="3240938" cy="795528"/>
           </a:xfrm>
           <a:prstGeom prst="rect">
             <a:avLst/>
@@ -4853,7 +4853,7 @@
               <a:buNone/>
             </a:pPr>
             <a:r>
-              <a:rPr lang="en-US" sz="1050" b="1" dirty="0">
+              <a:rPr lang="en-US" sz="1000" b="1" dirty="0">
                 <a:solidFill>
                   <a:schemeClr val="accent5"/>
                 </a:solidFill>
@@ -4867,14 +4867,14 @@
               <a:buNone/>
             </a:pPr>
             <a:r>
-              <a:rPr lang="en-US" sz="1050" dirty="0">
+              <a:rPr lang="en-US" sz="1000" dirty="0">
                 <a:solidFill>
                   <a:schemeClr val="tx1"/>
                 </a:solidFill>
               </a:rPr>
-              <a:t>Consejo de Administración (primera sesión con nuevos miembros)</a:t>
-            </a:r>
-            <a:endParaRPr lang="en-US" sz="1050" dirty="0"/>
+              <a:t>ADR / Jefe de Riesgos</a:t>
+            </a:r>
+            <a:endParaRPr lang="en-US" sz="1000" dirty="0"/>
           </a:p>
           <a:p>
             <a:pPr indent="0" marL="0">
@@ -4884,12 +4884,12 @@
               <a:buNone/>
             </a:pPr>
             <a:r>
-              <a:rPr lang="en-US" sz="1050" b="1" dirty="0">
+              <a:rPr lang="en-US" sz="1000" b="1" dirty="0">
                 <a:solidFill>
                   <a:schemeClr val="accent5"/>
                 </a:solidFill>
               </a:rPr>
-              <a:t>Criterio  </a:t>
+              <a:t>Descargo  </a:t>
             </a:r>
             <a:pPr indent="0" marL="0">
               <a:spcAft>
@@ -4898,14 +4898,14 @@
               <a:buNone/>
             </a:pPr>
             <a:r>
-              <a:rPr lang="en-US" sz="1050" dirty="0">
+              <a:rPr lang="en-US" sz="1000" dirty="0">
                 <a:solidFill>
                   <a:schemeClr val="tx1"/>
                 </a:solidFill>
               </a:rPr>
-              <a:t>Manual de Inducción y Capacitación</a:t>
-            </a:r>
-            <a:endParaRPr lang="en-US" sz="1050" dirty="0"/>
+              <a:t>Acta CA 2579 (28/04/2025): convenio sin efecto y fechas de inducción aprobadas</a:t>
+            </a:r>
+            <a:endParaRPr lang="en-US" sz="1000" dirty="0"/>
           </a:p>
         </p:txBody>
       </p:sp>
@@ -5048,8 +5048,8 @@
         </p:nvSpPr>
         <p:spPr>
           <a:xfrm>
-            <a:off x="8219237" y="2093976"/>
-            <a:ext cx="3240938" cy="758952"/>
+            <a:off x="8219237" y="2075688"/>
+            <a:ext cx="3240938" cy="795528"/>
           </a:xfrm>
           <a:prstGeom prst="rect">
             <a:avLst/>
@@ -5068,7 +5068,7 @@
               <a:buNone/>
             </a:pPr>
             <a:r>
-              <a:rPr lang="en-US" sz="1050" b="1" dirty="0">
+              <a:rPr lang="en-US" sz="1000" b="1" dirty="0">
                 <a:solidFill>
                   <a:schemeClr val="accent5"/>
                 </a:solidFill>
@@ -5082,14 +5082,14 @@
               <a:buNone/>
             </a:pPr>
             <a:r>
-              <a:rPr lang="en-US" sz="1050" dirty="0">
+              <a:rPr lang="en-US" sz="1000" dirty="0">
                 <a:solidFill>
                   <a:schemeClr val="tx1"/>
                 </a:solidFill>
               </a:rPr>
-              <a:t>Consejo de Administración</a:t>
-            </a:r>
-            <a:endParaRPr lang="en-US" sz="1050" dirty="0"/>
+              <a:t>ADR / Jefe de Riesgos</a:t>
+            </a:r>
+            <a:endParaRPr lang="en-US" sz="1000" dirty="0"/>
           </a:p>
           <a:p>
             <a:pPr indent="0" marL="0">
@@ -5099,12 +5099,12 @@
               <a:buNone/>
             </a:pPr>
             <a:r>
-              <a:rPr lang="en-US" sz="1050" b="1" dirty="0">
+              <a:rPr lang="en-US" sz="1000" b="1" dirty="0">
                 <a:solidFill>
                   <a:schemeClr val="accent5"/>
                 </a:solidFill>
               </a:rPr>
-              <a:t>Criterio  </a:t>
+              <a:t>Descargo  </a:t>
             </a:r>
             <a:pPr indent="0" marL="0">
               <a:spcAft>
@@ -5113,14 +5113,14 @@
               <a:buNone/>
             </a:pPr>
             <a:r>
-              <a:rPr lang="en-US" sz="1050" dirty="0">
+              <a:rPr lang="en-US" sz="1000" dirty="0">
                 <a:solidFill>
                   <a:schemeClr val="tx1"/>
                 </a:solidFill>
               </a:rPr>
-              <a:t>Art. 3 literal h) NRP-17</a:t>
-            </a:r>
-            <a:endParaRPr lang="en-US" sz="1050" dirty="0"/>
+              <a:t>Integración sustentada en Estatutos (arts. 61 y 73)</a:t>
+            </a:r>
+            <a:endParaRPr lang="en-US" sz="1000" dirty="0"/>
           </a:p>
           <a:p>
             <a:pPr indent="0" marL="0">
@@ -5130,14 +5130,14 @@
               <a:buNone/>
             </a:pPr>
             <a:r>
-              <a:rPr lang="en-US" sz="1050" b="1" dirty="0">
+              <a:rPr lang="en-US" sz="1000" b="1" dirty="0">
                 <a:solidFill>
                   <a:schemeClr val="accent3"/>
                 </a:solidFill>
               </a:rPr>
               <a:t>↳ Seguimiento 2026: NO SUPERADA</a:t>
             </a:r>
-            <a:endParaRPr lang="en-US" sz="1050" dirty="0"/>
+            <a:endParaRPr lang="en-US" sz="1000" dirty="0"/>
           </a:p>
         </p:txBody>
       </p:sp>
@@ -5280,8 +5280,8 @@
         </p:nvSpPr>
         <p:spPr>
           <a:xfrm>
-            <a:off x="731520" y="3831336"/>
-            <a:ext cx="3240938" cy="758952"/>
+            <a:off x="731520" y="3813048"/>
+            <a:ext cx="3240938" cy="795528"/>
           </a:xfrm>
           <a:prstGeom prst="rect">
             <a:avLst/>
@@ -5300,7 +5300,7 @@
               <a:buNone/>
             </a:pPr>
             <a:r>
-              <a:rPr lang="en-US" sz="1050" b="1" dirty="0">
+              <a:rPr lang="en-US" sz="1000" b="1" dirty="0">
                 <a:solidFill>
                   <a:schemeClr val="accent5"/>
                 </a:solidFill>
@@ -5314,14 +5314,14 @@
               <a:buNone/>
             </a:pPr>
             <a:r>
-              <a:rPr lang="en-US" sz="1050" dirty="0">
+              <a:rPr lang="en-US" sz="1000" dirty="0">
                 <a:solidFill>
                   <a:schemeClr val="tx1"/>
                 </a:solidFill>
               </a:rPr>
-              <a:t>Consejo de Administración · Asamblea General de Asociados</a:t>
-            </a:r>
-            <a:endParaRPr lang="en-US" sz="1050" dirty="0"/>
+              <a:t>Jefe de Administración de Riesgos</a:t>
+            </a:r>
+            <a:endParaRPr lang="en-US" sz="1000" dirty="0"/>
           </a:p>
           <a:p>
             <a:pPr indent="0" marL="0">
@@ -5331,12 +5331,12 @@
               <a:buNone/>
             </a:pPr>
             <a:r>
-              <a:rPr lang="en-US" sz="1050" b="1" dirty="0">
+              <a:rPr lang="en-US" sz="1000" b="1" dirty="0">
                 <a:solidFill>
                   <a:schemeClr val="accent5"/>
                 </a:solidFill>
               </a:rPr>
-              <a:t>Criterio  </a:t>
+              <a:t>Descargo  </a:t>
             </a:r>
             <a:pPr indent="0" marL="0">
               <a:spcAft>
@@ -5345,14 +5345,14 @@
               <a:buNone/>
             </a:pPr>
             <a:r>
-              <a:rPr lang="en-US" sz="1050" dirty="0">
+              <a:rPr lang="en-US" sz="1000" dirty="0">
                 <a:solidFill>
                   <a:schemeClr val="tx1"/>
                 </a:solidFill>
               </a:rPr>
-              <a:t>Arts. 12 lit. g) y q), 27 lit. a) NRP-17</a:t>
-            </a:r>
-            <a:endParaRPr lang="en-US" sz="1050" dirty="0"/>
+              <a:t>Se actualizará el Reglamento de Compensaciones Económicas</a:t>
+            </a:r>
+            <a:endParaRPr lang="en-US" sz="1000" dirty="0"/>
           </a:p>
         </p:txBody>
       </p:sp>
@@ -5495,8 +5495,8 @@
         </p:nvSpPr>
         <p:spPr>
           <a:xfrm>
-            <a:off x="4475378" y="3831336"/>
-            <a:ext cx="3240938" cy="758952"/>
+            <a:off x="4475378" y="3813048"/>
+            <a:ext cx="3240938" cy="795528"/>
           </a:xfrm>
           <a:prstGeom prst="rect">
             <a:avLst/>
@@ -5515,7 +5515,7 @@
               <a:buNone/>
             </a:pPr>
             <a:r>
-              <a:rPr lang="en-US" sz="1050" b="1" dirty="0">
+              <a:rPr lang="en-US" sz="1000" b="1" dirty="0">
                 <a:solidFill>
                   <a:schemeClr val="accent5"/>
                 </a:solidFill>
@@ -5529,14 +5529,14 @@
               <a:buNone/>
             </a:pPr>
             <a:r>
-              <a:rPr lang="en-US" sz="1050" dirty="0">
+              <a:rPr lang="en-US" sz="1000" dirty="0">
                 <a:solidFill>
                   <a:schemeClr val="tx1"/>
                 </a:solidFill>
               </a:rPr>
-              <a:t>Líderes de procesos · Departamento de Procesos</a:t>
-            </a:r>
-            <a:endParaRPr lang="en-US" sz="1050" dirty="0"/>
+              <a:t>ADR, Auditoría Interna, G. Financiera, Seg. de la Información y G. Administrativa</a:t>
+            </a:r>
+            <a:endParaRPr lang="en-US" sz="1000" dirty="0"/>
           </a:p>
           <a:p>
             <a:pPr indent="0" marL="0">
@@ -5546,12 +5546,12 @@
               <a:buNone/>
             </a:pPr>
             <a:r>
-              <a:rPr lang="en-US" sz="1050" b="1" dirty="0">
+              <a:rPr lang="en-US" sz="1000" b="1" dirty="0">
                 <a:solidFill>
                   <a:schemeClr val="accent5"/>
                 </a:solidFill>
               </a:rPr>
-              <a:t>Criterio  </a:t>
+              <a:t>Descargo  </a:t>
             </a:r>
             <a:pPr indent="0" marL="0">
               <a:spcAft>
@@ -5560,14 +5560,14 @@
               <a:buNone/>
             </a:pPr>
             <a:r>
-              <a:rPr lang="en-US" sz="1050" dirty="0">
+              <a:rPr lang="en-US" sz="1000" dirty="0">
                 <a:solidFill>
                   <a:schemeClr val="tx1"/>
                 </a:solidFill>
               </a:rPr>
-              <a:t>Art. 12 lit. n) NRP-17 · 9 documentos</a:t>
-            </a:r>
-            <a:endParaRPr lang="en-US" sz="1050" dirty="0"/>
+              <a:t>3 de 9 documentos actualizados; el resto en proceso</a:t>
+            </a:r>
+            <a:endParaRPr lang="en-US" sz="1000" dirty="0"/>
           </a:p>
           <a:p>
             <a:pPr indent="0" marL="0">
@@ -5577,14 +5577,14 @@
               <a:buNone/>
             </a:pPr>
             <a:r>
-              <a:rPr lang="en-US" sz="1050" b="1" dirty="0">
+              <a:rPr lang="en-US" sz="1000" b="1" dirty="0">
                 <a:solidFill>
                   <a:schemeClr val="accent3"/>
                 </a:solidFill>
               </a:rPr>
               <a:t>↳ Seguimiento 2026: PARCIALMENTE SUPERADA</a:t>
             </a:r>
-            <a:endParaRPr lang="en-US" sz="1050" dirty="0"/>
+            <a:endParaRPr lang="en-US" sz="1000" dirty="0"/>
           </a:p>
         </p:txBody>
       </p:sp>
@@ -5727,8 +5727,8 @@
         </p:nvSpPr>
         <p:spPr>
           <a:xfrm>
-            <a:off x="8219237" y="3831336"/>
-            <a:ext cx="3240938" cy="758952"/>
+            <a:off x="8219237" y="3813048"/>
+            <a:ext cx="3240938" cy="795528"/>
           </a:xfrm>
           <a:prstGeom prst="rect">
             <a:avLst/>
@@ -5747,7 +5747,7 @@
               <a:buNone/>
             </a:pPr>
             <a:r>
-              <a:rPr lang="en-US" sz="1050" b="1" dirty="0">
+              <a:rPr lang="en-US" sz="1000" b="1" dirty="0">
                 <a:solidFill>
                   <a:schemeClr val="accent5"/>
                 </a:solidFill>
@@ -5761,14 +5761,14 @@
               <a:buNone/>
             </a:pPr>
             <a:r>
-              <a:rPr lang="en-US" sz="1050" dirty="0">
+              <a:rPr lang="en-US" sz="1000" dirty="0">
                 <a:solidFill>
                   <a:schemeClr val="tx1"/>
                 </a:solidFill>
               </a:rPr>
-              <a:t>Consejo de Administración (acuerdos de las ferias no identificados)</a:t>
-            </a:r>
-            <a:endParaRPr lang="en-US" sz="1050" dirty="0"/>
+              <a:t>Gerencia de Negocios / Administración de Cartera</a:t>
+            </a:r>
+            <a:endParaRPr lang="en-US" sz="1000" dirty="0"/>
           </a:p>
           <a:p>
             <a:pPr indent="0" marL="0">
@@ -5778,12 +5778,12 @@
               <a:buNone/>
             </a:pPr>
             <a:r>
-              <a:rPr lang="en-US" sz="1050" b="1" dirty="0">
+              <a:rPr lang="en-US" sz="1000" b="1" dirty="0">
                 <a:solidFill>
                   <a:schemeClr val="accent5"/>
                 </a:solidFill>
               </a:rPr>
-              <a:t>Criterio  </a:t>
+              <a:t>Descargo  </a:t>
             </a:r>
             <a:pPr indent="0" marL="0">
               <a:spcAft>
@@ -5792,14 +5792,14 @@
               <a:buNone/>
             </a:pPr>
             <a:r>
-              <a:rPr lang="en-US" sz="1050" dirty="0">
+              <a:rPr lang="en-US" sz="1000" dirty="0">
                 <a:solidFill>
                   <a:schemeClr val="tx1"/>
                 </a:solidFill>
               </a:rPr>
-              <a:t>Sin acuerdos ni soporte de cambios de tasa</a:t>
-            </a:r>
-            <a:endParaRPr lang="en-US" sz="1050" dirty="0"/>
+              <a:t>Se remitieron resoluciones y acuerdos del CA de cada feria</a:t>
+            </a:r>
+            <a:endParaRPr lang="en-US" sz="1000" dirty="0"/>
           </a:p>
         </p:txBody>
       </p:sp>
@@ -5942,8 +5942,8 @@
         </p:nvSpPr>
         <p:spPr>
           <a:xfrm>
-            <a:off x="731520" y="5568696"/>
-            <a:ext cx="3240938" cy="758952"/>
+            <a:off x="731520" y="5550408"/>
+            <a:ext cx="3240938" cy="795528"/>
           </a:xfrm>
           <a:prstGeom prst="rect">
             <a:avLst/>
@@ -5962,7 +5962,7 @@
               <a:buNone/>
             </a:pPr>
             <a:r>
-              <a:rPr lang="en-US" sz="1050" b="1" dirty="0">
+              <a:rPr lang="en-US" sz="1000" b="1" dirty="0">
                 <a:solidFill>
                   <a:schemeClr val="accent5"/>
                 </a:solidFill>
@@ -5976,14 +5976,14 @@
               <a:buNone/>
             </a:pPr>
             <a:r>
-              <a:rPr lang="en-US" sz="1050" dirty="0">
+              <a:rPr lang="en-US" sz="1000" dirty="0">
                 <a:solidFill>
                   <a:schemeClr val="tx1"/>
                 </a:solidFill>
               </a:rPr>
-              <a:t>Miembros del Consejo de Administración y equipo gerencial</a:t>
-            </a:r>
-            <a:endParaRPr lang="en-US" sz="1050" dirty="0"/>
+              <a:t>ADR / Jefe de Riesgos</a:t>
+            </a:r>
+            <a:endParaRPr lang="en-US" sz="1000" dirty="0"/>
           </a:p>
           <a:p>
             <a:pPr indent="0" marL="0">
@@ -5993,12 +5993,12 @@
               <a:buNone/>
             </a:pPr>
             <a:r>
-              <a:rPr lang="en-US" sz="1050" b="1" dirty="0">
+              <a:rPr lang="en-US" sz="1000" b="1" dirty="0">
                 <a:solidFill>
                   <a:schemeClr val="accent5"/>
                 </a:solidFill>
               </a:rPr>
-              <a:t>Criterio  </a:t>
+              <a:t>Descargo  </a:t>
             </a:r>
             <a:pPr indent="0" marL="0">
               <a:spcAft>
@@ -6007,14 +6007,14 @@
               <a:buNone/>
             </a:pPr>
             <a:r>
-              <a:rPr lang="en-US" sz="1050" dirty="0">
+              <a:rPr lang="en-US" sz="1000" dirty="0">
                 <a:solidFill>
                   <a:schemeClr val="tx1"/>
                 </a:solidFill>
               </a:rPr>
-              <a:t>Art. 9 NRP-75</a:t>
-            </a:r>
-            <a:endParaRPr lang="en-US" sz="1050" dirty="0"/>
+              <a:t>Se pidió a la SSF el detalle de las personas señaladas</a:t>
+            </a:r>
+            <a:endParaRPr lang="en-US" sz="1000" dirty="0"/>
           </a:p>
         </p:txBody>
       </p:sp>
@@ -6157,8 +6157,8 @@
         </p:nvSpPr>
         <p:spPr>
           <a:xfrm>
-            <a:off x="4475378" y="5568696"/>
-            <a:ext cx="3240938" cy="758952"/>
+            <a:off x="4475378" y="5550408"/>
+            <a:ext cx="3240938" cy="795528"/>
           </a:xfrm>
           <a:prstGeom prst="rect">
             <a:avLst/>
@@ -6177,7 +6177,7 @@
               <a:buNone/>
             </a:pPr>
             <a:r>
-              <a:rPr lang="en-US" sz="1050" b="1" dirty="0">
+              <a:rPr lang="en-US" sz="1000" b="1" dirty="0">
                 <a:solidFill>
                   <a:schemeClr val="accent5"/>
                 </a:solidFill>
@@ -6191,14 +6191,14 @@
               <a:buNone/>
             </a:pPr>
             <a:r>
-              <a:rPr lang="en-US" sz="1050" dirty="0">
+              <a:rPr lang="en-US" sz="1000" dirty="0">
                 <a:solidFill>
                   <a:schemeClr val="tx1"/>
                 </a:solidFill>
               </a:rPr>
-              <a:t>Jefe de Servicios Generales · áreas solicitantes</a:t>
-            </a:r>
-            <a:endParaRPr lang="en-US" sz="1050" dirty="0"/>
+              <a:t>Gerencia Administrativa / Gerente Administrativa</a:t>
+            </a:r>
+            <a:endParaRPr lang="en-US" sz="1000" dirty="0"/>
           </a:p>
           <a:p>
             <a:pPr indent="0" marL="0">
@@ -6208,12 +6208,12 @@
               <a:buNone/>
             </a:pPr>
             <a:r>
-              <a:rPr lang="en-US" sz="1050" b="1" dirty="0">
+              <a:rPr lang="en-US" sz="1000" b="1" dirty="0">
                 <a:solidFill>
                   <a:schemeClr val="accent5"/>
                 </a:solidFill>
               </a:rPr>
-              <a:t>Criterio  </a:t>
+              <a:t>Descargo  </a:t>
             </a:r>
             <a:pPr indent="0" marL="0">
               <a:spcAft>
@@ -6222,14 +6222,14 @@
               <a:buNone/>
             </a:pPr>
             <a:r>
-              <a:rPr lang="en-US" sz="1050" dirty="0">
+              <a:rPr lang="en-US" sz="1000" dirty="0">
                 <a:solidFill>
                   <a:schemeClr val="tx1"/>
                 </a:solidFill>
               </a:rPr>
-              <a:t>Cotizaciones sin sello · sin cláusula de penalización</a:t>
-            </a:r>
-            <a:endParaRPr lang="en-US" sz="1050" dirty="0"/>
+              <a:t>Firmas de Mercadeo y Gerencia General; contrato DLF terminado</a:t>
+            </a:r>
+            <a:endParaRPr lang="en-US" sz="1000" dirty="0"/>
           </a:p>
         </p:txBody>
       </p:sp>
@@ -6372,8 +6372,8 @@
         </p:nvSpPr>
         <p:spPr>
           <a:xfrm>
-            <a:off x="8219237" y="5568696"/>
-            <a:ext cx="3240938" cy="758952"/>
+            <a:off x="8219237" y="5550408"/>
+            <a:ext cx="3240938" cy="795528"/>
           </a:xfrm>
           <a:prstGeom prst="rect">
             <a:avLst/>
@@ -6392,7 +6392,7 @@
               <a:buNone/>
             </a:pPr>
             <a:r>
-              <a:rPr lang="en-US" sz="1050" b="1" dirty="0">
+              <a:rPr lang="en-US" sz="1000" b="1" dirty="0">
                 <a:solidFill>
                   <a:schemeClr val="accent5"/>
                 </a:solidFill>
@@ -6406,14 +6406,14 @@
               <a:buNone/>
             </a:pPr>
             <a:r>
-              <a:rPr lang="en-US" sz="1050" dirty="0">
+              <a:rPr lang="en-US" sz="1000" dirty="0">
                 <a:solidFill>
                   <a:schemeClr val="tx1"/>
                 </a:solidFill>
               </a:rPr>
-              <a:t>Comité de Educación · Comité Socio Cultural</a:t>
-            </a:r>
-            <a:endParaRPr lang="en-US" sz="1050" dirty="0"/>
+              <a:t>Jefe de Administración de Riesgos</a:t>
+            </a:r>
+            <a:endParaRPr lang="en-US" sz="1000" dirty="0"/>
           </a:p>
           <a:p>
             <a:pPr indent="0" marL="0">
@@ -6423,12 +6423,12 @@
               <a:buNone/>
             </a:pPr>
             <a:r>
-              <a:rPr lang="en-US" sz="1050" b="1" dirty="0">
+              <a:rPr lang="en-US" sz="1000" b="1" dirty="0">
                 <a:solidFill>
                   <a:schemeClr val="accent5"/>
                 </a:solidFill>
               </a:rPr>
-              <a:t>Criterio  </a:t>
+              <a:t>Descargo  </a:t>
             </a:r>
             <a:pPr indent="0" marL="0">
               <a:spcAft>
@@ -6437,14 +6437,14 @@
               <a:buNone/>
             </a:pPr>
             <a:r>
-              <a:rPr lang="en-US" sz="1050" dirty="0">
+              <a:rPr lang="en-US" sz="1000" dirty="0">
                 <a:solidFill>
                   <a:schemeClr val="tx1"/>
                 </a:solidFill>
               </a:rPr>
-              <a:t>Art. 59 LGAC y Art. 69 de su Reglamento</a:t>
-            </a:r>
-            <a:endParaRPr lang="en-US" sz="1050" dirty="0"/>
+              <a:t>CA suspendió el Comité Sociocultural (Acta 2576, 07/04/2025)</a:t>
+            </a:r>
+            <a:endParaRPr lang="en-US" sz="1000" dirty="0"/>
           </a:p>
         </p:txBody>
       </p:sp>
@@ -6731,8 +6731,8 @@
         </p:nvSpPr>
         <p:spPr>
           <a:xfrm>
-            <a:off x="548640" y="1298448"/>
-            <a:ext cx="8229600" cy="256032"/>
+            <a:off x="548640" y="1280160"/>
+            <a:ext cx="8229600" cy="237744"/>
           </a:xfrm>
           <a:prstGeom prst="rect">
             <a:avLst/>
@@ -6767,12 +6767,12 @@
         </p:nvSpPr>
         <p:spPr>
           <a:xfrm>
-            <a:off x="548640" y="1600200"/>
-            <a:ext cx="2670734" cy="1481328"/>
+            <a:off x="548640" y="1572768"/>
+            <a:ext cx="2691308" cy="1444752"/>
           </a:xfrm>
           <a:prstGeom prst="roundRect">
             <a:avLst>
-              <a:gd name="adj" fmla="val 6173"/>
+              <a:gd name="adj" fmla="val 6329"/>
             </a:avLst>
           </a:prstGeom>
           <a:solidFill>
@@ -6796,7 +6796,7 @@
         </p:nvSpPr>
         <p:spPr>
           <a:xfrm>
-            <a:off x="694944" y="1728216"/>
+            <a:off x="694944" y="1700784"/>
             <a:ext cx="329184" cy="329184"/>
           </a:xfrm>
           <a:prstGeom prst="ellipse">
@@ -6823,7 +6823,7 @@
         </p:nvSpPr>
         <p:spPr>
           <a:xfrm>
-            <a:off x="694944" y="1728216"/>
+            <a:off x="694944" y="1700784"/>
             <a:ext cx="329184" cy="329184"/>
           </a:xfrm>
           <a:prstGeom prst="rect">
@@ -6856,14 +6856,14 @@
       </p:sp>
       <p:sp>
         <p:nvSpPr>
-          <p:cNvPr id="12" name="Criterio A-1"/>
-          <p:cNvSpPr txBox="1"/>
-          <p:nvPr/>
-        </p:nvSpPr>
-        <p:spPr>
-          <a:xfrm>
-            <a:off x="1115568" y="1709928"/>
-            <a:ext cx="1984934" cy="365760"/>
+          <p:cNvPr id="12" name="Responsable A-1"/>
+          <p:cNvSpPr txBox="1"/>
+          <p:nvPr/>
+        </p:nvSpPr>
+        <p:spPr>
+          <a:xfrm>
+            <a:off x="1115568" y="1645920"/>
+            <a:ext cx="2032940" cy="457200"/>
           </a:xfrm>
           <a:prstGeom prst="rect">
             <a:avLst/>
@@ -6879,15 +6879,29 @@
               <a:buNone/>
             </a:pPr>
             <a:r>
-              <a:rPr lang="en-US" sz="1000" b="1" dirty="0">
+              <a:rPr lang="en-US" sz="950" b="1" dirty="0">
                 <a:solidFill>
                   <a:schemeClr val="accent2"/>
                 </a:solidFill>
               </a:rPr>
-              <a:t>Art. 11 NRP-17</a:t>
+              <a:t>Responsable</a:t>
             </a:r>
             <a:endParaRPr lang="en-US" sz="1000" dirty="0"/>
           </a:p>
+          <a:p>
+            <a:pPr indent="0" marL="0">
+              <a:buNone/>
+            </a:pPr>
+            <a:r>
+              <a:rPr lang="en-US" sz="1000" dirty="0">
+                <a:solidFill>
+                  <a:schemeClr val="tx1"/>
+                </a:solidFill>
+              </a:rPr>
+              <a:t>Gerencia Financiera</a:t>
+            </a:r>
+            <a:endParaRPr lang="en-US" sz="1000" dirty="0"/>
+          </a:p>
         </p:txBody>
       </p:sp>
       <p:sp>
@@ -6898,8 +6912,8 @@
         </p:nvSpPr>
         <p:spPr>
           <a:xfrm>
-            <a:off x="694944" y="2130552"/>
-            <a:ext cx="2378126" cy="530352"/>
+            <a:off x="694944" y="2157984"/>
+            <a:ext cx="2398700" cy="502920"/>
           </a:xfrm>
           <a:prstGeom prst="rect">
             <a:avLst/>
@@ -6928,14 +6942,14 @@
       </p:sp>
       <p:sp>
         <p:nvSpPr>
-          <p:cNvPr id="14" name="Responsable A-1"/>
+          <p:cNvPr id="14" name="Respuesta A-1"/>
           <p:cNvSpPr txBox="1"/>
           <p:nvPr/>
         </p:nvSpPr>
         <p:spPr>
           <a:xfrm>
             <a:off x="694944" y="2651760"/>
-            <a:ext cx="2378126" cy="384048"/>
+            <a:ext cx="2398700" cy="329184"/>
           </a:xfrm>
           <a:prstGeom prst="rect">
             <a:avLst/>
@@ -6951,25 +6965,14 @@
               <a:buNone/>
             </a:pPr>
             <a:r>
-              <a:rPr lang="en-US" sz="1000" b="1" dirty="0">
+              <a:rPr lang="en-US" sz="950" i="1" dirty="0">
                 <a:solidFill>
                   <a:schemeClr val="accent5"/>
                 </a:solidFill>
               </a:rPr>
-              <a:t>Responsable: </a:t>
-            </a:r>
-            <a:pPr indent="0" marL="0">
-              <a:buNone/>
-            </a:pPr>
-            <a:r>
-              <a:rPr lang="en-US" sz="1000" dirty="0">
-                <a:solidFill>
-                  <a:schemeClr val="tx1"/>
-                </a:solidFill>
-              </a:rPr>
-              <a:t>Gerencia Financiera (imparte la inducción según el Manual)</a:t>
-            </a:r>
-            <a:endParaRPr lang="en-US" sz="1000" dirty="0"/>
+              <a:t>Respuesta: sin comentario en la matriz</a:t>
+            </a:r>
+            <a:endParaRPr lang="en-US" sz="950" dirty="0"/>
           </a:p>
         </p:txBody>
       </p:sp>
@@ -6981,12 +6984,12 @@
         </p:nvSpPr>
         <p:spPr>
           <a:xfrm>
-            <a:off x="3356534" y="1600200"/>
-            <a:ext cx="2670734" cy="1481328"/>
+            <a:off x="3349676" y="1572768"/>
+            <a:ext cx="2691308" cy="1444752"/>
           </a:xfrm>
           <a:prstGeom prst="roundRect">
             <a:avLst>
-              <a:gd name="adj" fmla="val 6173"/>
+              <a:gd name="adj" fmla="val 6329"/>
             </a:avLst>
           </a:prstGeom>
           <a:solidFill>
@@ -7010,7 +7013,7 @@
         </p:nvSpPr>
         <p:spPr>
           <a:xfrm>
-            <a:off x="3502838" y="1728216"/>
+            <a:off x="3495980" y="1700784"/>
             <a:ext cx="329184" cy="329184"/>
           </a:xfrm>
           <a:prstGeom prst="ellipse">
@@ -7037,7 +7040,7 @@
         </p:nvSpPr>
         <p:spPr>
           <a:xfrm>
-            <a:off x="3502838" y="1728216"/>
+            <a:off x="3495980" y="1700784"/>
             <a:ext cx="329184" cy="329184"/>
           </a:xfrm>
           <a:prstGeom prst="rect">
@@ -7070,14 +7073,14 @@
       </p:sp>
       <p:sp>
         <p:nvSpPr>
-          <p:cNvPr id="18" name="Criterio A-2"/>
-          <p:cNvSpPr txBox="1"/>
-          <p:nvPr/>
-        </p:nvSpPr>
-        <p:spPr>
-          <a:xfrm>
-            <a:off x="3923462" y="1709928"/>
-            <a:ext cx="1984934" cy="365760"/>
+          <p:cNvPr id="18" name="Responsable A-2"/>
+          <p:cNvSpPr txBox="1"/>
+          <p:nvPr/>
+        </p:nvSpPr>
+        <p:spPr>
+          <a:xfrm>
+            <a:off x="3916604" y="1645920"/>
+            <a:ext cx="2032940" cy="457200"/>
           </a:xfrm>
           <a:prstGeom prst="rect">
             <a:avLst/>
@@ -7093,15 +7096,29 @@
               <a:buNone/>
             </a:pPr>
             <a:r>
-              <a:rPr lang="en-US" sz="1000" b="1" dirty="0">
+              <a:rPr lang="en-US" sz="950" b="1" dirty="0">
                 <a:solidFill>
                   <a:schemeClr val="accent2"/>
                 </a:solidFill>
               </a:rPr>
-              <a:t>Cap. XI Código de Conducta</a:t>
+              <a:t>Responsable</a:t>
             </a:r>
             <a:endParaRPr lang="en-US" sz="1000" dirty="0"/>
           </a:p>
+          <a:p>
+            <a:pPr indent="0" marL="0">
+              <a:buNone/>
+            </a:pPr>
+            <a:r>
+              <a:rPr lang="en-US" sz="1000" dirty="0">
+                <a:solidFill>
+                  <a:schemeClr val="tx1"/>
+                </a:solidFill>
+              </a:rPr>
+              <a:t>Gerencia de Oficialía de Cumplimiento</a:t>
+            </a:r>
+            <a:endParaRPr lang="en-US" sz="1000" dirty="0"/>
+          </a:p>
         </p:txBody>
       </p:sp>
       <p:sp>
@@ -7112,8 +7129,8 @@
         </p:nvSpPr>
         <p:spPr>
           <a:xfrm>
-            <a:off x="3502838" y="2130552"/>
-            <a:ext cx="2378126" cy="530352"/>
+            <a:off x="3495980" y="2157984"/>
+            <a:ext cx="2398700" cy="502920"/>
           </a:xfrm>
           <a:prstGeom prst="rect">
             <a:avLst/>
@@ -7142,14 +7159,14 @@
       </p:sp>
       <p:sp>
         <p:nvSpPr>
-          <p:cNvPr id="20" name="Responsable A-2"/>
-          <p:cNvSpPr txBox="1"/>
-          <p:nvPr/>
-        </p:nvSpPr>
-        <p:spPr>
-          <a:xfrm>
-            <a:off x="3502838" y="2651760"/>
-            <a:ext cx="2378126" cy="384048"/>
+          <p:cNvPr id="20" name="Respuesta A-2"/>
+          <p:cNvSpPr txBox="1"/>
+          <p:nvPr/>
+        </p:nvSpPr>
+        <p:spPr>
+          <a:xfrm>
+            <a:off x="3495980" y="2651760"/>
+            <a:ext cx="2398700" cy="329184"/>
           </a:xfrm>
           <a:prstGeom prst="rect">
             <a:avLst/>
@@ -7165,25 +7182,14 @@
               <a:buNone/>
             </a:pPr>
             <a:r>
-              <a:rPr lang="en-US" sz="1000" b="1" dirty="0">
+              <a:rPr lang="en-US" sz="950" i="1" dirty="0">
                 <a:solidFill>
                   <a:schemeClr val="accent5"/>
                 </a:solidFill>
               </a:rPr>
-              <a:t>Responsable: </a:t>
-            </a:r>
-            <a:pPr indent="0" marL="0">
-              <a:buNone/>
-            </a:pPr>
-            <a:r>
-              <a:rPr lang="en-US" sz="1000" dirty="0">
-                <a:solidFill>
-                  <a:schemeClr val="tx1"/>
-                </a:solidFill>
-              </a:rPr>
-              <a:t>Junta de Vigilancia · Comité de Créditos · Comité de Educación</a:t>
-            </a:r>
-            <a:endParaRPr lang="en-US" sz="1000" dirty="0"/>
+              <a:t>Respuesta: 6 de 7 certificaciones localizadas; se pide reconsiderar</a:t>
+            </a:r>
+            <a:endParaRPr lang="en-US" sz="950" dirty="0"/>
           </a:p>
         </p:txBody>
       </p:sp>
@@ -7195,12 +7201,12 @@
         </p:nvSpPr>
         <p:spPr>
           <a:xfrm>
-            <a:off x="6164428" y="1600200"/>
-            <a:ext cx="2670734" cy="1481328"/>
+            <a:off x="6150712" y="1572768"/>
+            <a:ext cx="2691308" cy="1444752"/>
           </a:xfrm>
           <a:prstGeom prst="roundRect">
             <a:avLst>
-              <a:gd name="adj" fmla="val 6173"/>
+              <a:gd name="adj" fmla="val 6329"/>
             </a:avLst>
           </a:prstGeom>
           <a:solidFill>
@@ -7224,7 +7230,7 @@
         </p:nvSpPr>
         <p:spPr>
           <a:xfrm>
-            <a:off x="6310732" y="1728216"/>
+            <a:off x="6297016" y="1700784"/>
             <a:ext cx="329184" cy="329184"/>
           </a:xfrm>
           <a:prstGeom prst="ellipse">
@@ -7251,7 +7257,7 @@
         </p:nvSpPr>
         <p:spPr>
           <a:xfrm>
-            <a:off x="6310732" y="1728216"/>
+            <a:off x="6297016" y="1700784"/>
             <a:ext cx="329184" cy="329184"/>
           </a:xfrm>
           <a:prstGeom prst="rect">
@@ -7284,14 +7290,14 @@
       </p:sp>
       <p:sp>
         <p:nvSpPr>
-          <p:cNvPr id="24" name="Criterio A-3"/>
-          <p:cNvSpPr txBox="1"/>
-          <p:nvPr/>
-        </p:nvSpPr>
-        <p:spPr>
-          <a:xfrm>
-            <a:off x="6731356" y="1709928"/>
-            <a:ext cx="1984934" cy="365760"/>
+          <p:cNvPr id="24" name="Responsable A-3"/>
+          <p:cNvSpPr txBox="1"/>
+          <p:nvPr/>
+        </p:nvSpPr>
+        <p:spPr>
+          <a:xfrm>
+            <a:off x="6717640" y="1645920"/>
+            <a:ext cx="2032940" cy="457200"/>
           </a:xfrm>
           <a:prstGeom prst="rect">
             <a:avLst/>
@@ -7307,15 +7313,29 @@
               <a:buNone/>
             </a:pPr>
             <a:r>
-              <a:rPr lang="en-US" sz="1000" b="1" dirty="0">
+              <a:rPr lang="en-US" sz="950" b="1" dirty="0">
                 <a:solidFill>
                   <a:schemeClr val="accent2"/>
                 </a:solidFill>
               </a:rPr>
-              <a:t>Art. 12 lit. c) NRP-17</a:t>
+              <a:t>Responsable</a:t>
             </a:r>
             <a:endParaRPr lang="en-US" sz="1000" dirty="0"/>
           </a:p>
+          <a:p>
+            <a:pPr indent="0" marL="0">
+              <a:buNone/>
+            </a:pPr>
+            <a:r>
+              <a:rPr lang="en-US" sz="1000" dirty="0">
+                <a:solidFill>
+                  <a:schemeClr val="tx1"/>
+                </a:solidFill>
+              </a:rPr>
+              <a:t>Talento Humano · Depto. de Procesos</a:t>
+            </a:r>
+            <a:endParaRPr lang="en-US" sz="1000" dirty="0"/>
+          </a:p>
         </p:txBody>
       </p:sp>
       <p:sp>
@@ -7326,8 +7346,8 @@
         </p:nvSpPr>
         <p:spPr>
           <a:xfrm>
-            <a:off x="6310732" y="2130552"/>
-            <a:ext cx="2378126" cy="530352"/>
+            <a:off x="6297016" y="2157984"/>
+            <a:ext cx="2398700" cy="502920"/>
           </a:xfrm>
           <a:prstGeom prst="rect">
             <a:avLst/>
@@ -7356,14 +7376,14 @@
       </p:sp>
       <p:sp>
         <p:nvSpPr>
-          <p:cNvPr id="26" name="Responsable A-3"/>
-          <p:cNvSpPr txBox="1"/>
-          <p:nvPr/>
-        </p:nvSpPr>
-        <p:spPr>
-          <a:xfrm>
-            <a:off x="6310732" y="2651760"/>
-            <a:ext cx="2378126" cy="384048"/>
+          <p:cNvPr id="26" name="Respuesta A-3"/>
+          <p:cNvSpPr txBox="1"/>
+          <p:nvPr/>
+        </p:nvSpPr>
+        <p:spPr>
+          <a:xfrm>
+            <a:off x="6297016" y="2651760"/>
+            <a:ext cx="2398700" cy="329184"/>
           </a:xfrm>
           <a:prstGeom prst="rect">
             <a:avLst/>
@@ -7379,25 +7399,14 @@
               <a:buNone/>
             </a:pPr>
             <a:r>
-              <a:rPr lang="en-US" sz="1000" b="1" dirty="0">
+              <a:rPr lang="en-US" sz="950" i="1" dirty="0">
                 <a:solidFill>
                   <a:schemeClr val="accent5"/>
                 </a:solidFill>
               </a:rPr>
-              <a:t>Responsable: </a:t>
-            </a:r>
-            <a:pPr indent="0" marL="0">
-              <a:buNone/>
-            </a:pPr>
-            <a:r>
-              <a:rPr lang="en-US" sz="1000" dirty="0">
-                <a:solidFill>
-                  <a:schemeClr val="tx1"/>
-                </a:solidFill>
-              </a:rPr>
-              <a:t>Consejo de Administración</a:t>
-            </a:r>
-            <a:endParaRPr lang="en-US" sz="1000" dirty="0"/>
+              <a:t>Respuesta: Se elaborará la Política de Retribución para aprobación del CA</a:t>
+            </a:r>
+            <a:endParaRPr lang="en-US" sz="950" dirty="0"/>
           </a:p>
         </p:txBody>
       </p:sp>
@@ -7409,12 +7418,12 @@
         </p:nvSpPr>
         <p:spPr>
           <a:xfrm>
-            <a:off x="8972321" y="1600200"/>
-            <a:ext cx="2670734" cy="1481328"/>
+            <a:off x="8951747" y="1572768"/>
+            <a:ext cx="2691308" cy="1444752"/>
           </a:xfrm>
           <a:prstGeom prst="roundRect">
             <a:avLst>
-              <a:gd name="adj" fmla="val 6173"/>
+              <a:gd name="adj" fmla="val 6329"/>
             </a:avLst>
           </a:prstGeom>
           <a:solidFill>
@@ -7438,7 +7447,7 @@
         </p:nvSpPr>
         <p:spPr>
           <a:xfrm>
-            <a:off x="9118625" y="1728216"/>
+            <a:off x="9098051" y="1700784"/>
             <a:ext cx="329184" cy="329184"/>
           </a:xfrm>
           <a:prstGeom prst="ellipse">
@@ -7465,7 +7474,7 @@
         </p:nvSpPr>
         <p:spPr>
           <a:xfrm>
-            <a:off x="9118625" y="1728216"/>
+            <a:off x="9098051" y="1700784"/>
             <a:ext cx="329184" cy="329184"/>
           </a:xfrm>
           <a:prstGeom prst="rect">
@@ -7498,14 +7507,14 @@
       </p:sp>
       <p:sp>
         <p:nvSpPr>
-          <p:cNvPr id="30" name="Criterio A-4"/>
-          <p:cNvSpPr txBox="1"/>
-          <p:nvPr/>
-        </p:nvSpPr>
-        <p:spPr>
-          <a:xfrm>
-            <a:off x="9539249" y="1709928"/>
-            <a:ext cx="1984934" cy="365760"/>
+          <p:cNvPr id="30" name="Responsable A-4"/>
+          <p:cNvSpPr txBox="1"/>
+          <p:nvPr/>
+        </p:nvSpPr>
+        <p:spPr>
+          <a:xfrm>
+            <a:off x="9518675" y="1645920"/>
+            <a:ext cx="2032940" cy="457200"/>
           </a:xfrm>
           <a:prstGeom prst="rect">
             <a:avLst/>
@@ -7521,15 +7530,29 @@
               <a:buNone/>
             </a:pPr>
             <a:r>
-              <a:rPr lang="en-US" sz="1000" b="1" dirty="0">
+              <a:rPr lang="en-US" sz="950" b="1" dirty="0">
                 <a:solidFill>
                   <a:schemeClr val="accent2"/>
                 </a:solidFill>
               </a:rPr>
-              <a:t>Arts. 27 y 28 NRP-17</a:t>
+              <a:t>Responsable</a:t>
             </a:r>
             <a:endParaRPr lang="en-US" sz="1000" dirty="0"/>
           </a:p>
+          <a:p>
+            <a:pPr indent="0" marL="0">
+              <a:buNone/>
+            </a:pPr>
+            <a:r>
+              <a:rPr lang="en-US" sz="1000" dirty="0">
+                <a:solidFill>
+                  <a:schemeClr val="tx1"/>
+                </a:solidFill>
+              </a:rPr>
+              <a:t>Administración de Riesgos</a:t>
+            </a:r>
+            <a:endParaRPr lang="en-US" sz="1000" dirty="0"/>
+          </a:p>
         </p:txBody>
       </p:sp>
       <p:sp>
@@ -7540,8 +7563,8 @@
         </p:nvSpPr>
         <p:spPr>
           <a:xfrm>
-            <a:off x="9118625" y="2130552"/>
-            <a:ext cx="2378126" cy="530352"/>
+            <a:off x="9098051" y="2157984"/>
+            <a:ext cx="2398700" cy="502920"/>
           </a:xfrm>
           <a:prstGeom prst="rect">
             <a:avLst/>
@@ -7570,14 +7593,14 @@
       </p:sp>
       <p:sp>
         <p:nvSpPr>
-          <p:cNvPr id="32" name="Responsable A-4"/>
-          <p:cNvSpPr txBox="1"/>
-          <p:nvPr/>
-        </p:nvSpPr>
-        <p:spPr>
-          <a:xfrm>
-            <a:off x="9118625" y="2651760"/>
-            <a:ext cx="2378126" cy="384048"/>
+          <p:cNvPr id="32" name="Respuesta A-4"/>
+          <p:cNvSpPr txBox="1"/>
+          <p:nvPr/>
+        </p:nvSpPr>
+        <p:spPr>
+          <a:xfrm>
+            <a:off x="9098051" y="2651760"/>
+            <a:ext cx="2398700" cy="329184"/>
           </a:xfrm>
           <a:prstGeom prst="rect">
             <a:avLst/>
@@ -7593,25 +7616,14 @@
               <a:buNone/>
             </a:pPr>
             <a:r>
-              <a:rPr lang="en-US" sz="1000" b="1" dirty="0">
+              <a:rPr lang="en-US" sz="950" i="1" dirty="0">
                 <a:solidFill>
                   <a:schemeClr val="accent5"/>
                 </a:solidFill>
               </a:rPr>
-              <a:t>Responsable: </a:t>
-            </a:r>
-            <a:pPr indent="0" marL="0">
-              <a:buNone/>
-            </a:pPr>
-            <a:r>
-              <a:rPr lang="en-US" sz="1000" dirty="0">
-                <a:solidFill>
-                  <a:schemeClr val="tx1"/>
-                </a:solidFill>
-              </a:rPr>
-              <a:t>Administración de Riesgo</a:t>
-            </a:r>
-            <a:endParaRPr lang="en-US" sz="1000" dirty="0"/>
+              <a:t>Respuesta: sin comentario en la matriz</a:t>
+            </a:r>
+            <a:endParaRPr lang="en-US" sz="950" dirty="0"/>
           </a:p>
         </p:txBody>
       </p:sp>
@@ -7623,12 +7635,12 @@
         </p:nvSpPr>
         <p:spPr>
           <a:xfrm>
-            <a:off x="548640" y="3218688"/>
-            <a:ext cx="2670734" cy="1481328"/>
+            <a:off x="548640" y="3127248"/>
+            <a:ext cx="2691308" cy="1444752"/>
           </a:xfrm>
           <a:prstGeom prst="roundRect">
             <a:avLst>
-              <a:gd name="adj" fmla="val 6173"/>
+              <a:gd name="adj" fmla="val 6329"/>
             </a:avLst>
           </a:prstGeom>
           <a:solidFill>
@@ -7652,7 +7664,7 @@
         </p:nvSpPr>
         <p:spPr>
           <a:xfrm>
-            <a:off x="694944" y="3346704"/>
+            <a:off x="694944" y="3255264"/>
             <a:ext cx="329184" cy="329184"/>
           </a:xfrm>
           <a:prstGeom prst="ellipse">
@@ -7679,7 +7691,7 @@
         </p:nvSpPr>
         <p:spPr>
           <a:xfrm>
-            <a:off x="694944" y="3346704"/>
+            <a:off x="694944" y="3255264"/>
             <a:ext cx="329184" cy="329184"/>
           </a:xfrm>
           <a:prstGeom prst="rect">
@@ -7712,14 +7724,14 @@
       </p:sp>
       <p:sp>
         <p:nvSpPr>
-          <p:cNvPr id="36" name="Criterio A-5"/>
-          <p:cNvSpPr txBox="1"/>
-          <p:nvPr/>
-        </p:nvSpPr>
-        <p:spPr>
-          <a:xfrm>
-            <a:off x="1115568" y="3328416"/>
-            <a:ext cx="1984934" cy="365760"/>
+          <p:cNvPr id="36" name="Responsable A-5"/>
+          <p:cNvSpPr txBox="1"/>
+          <p:nvPr/>
+        </p:nvSpPr>
+        <p:spPr>
+          <a:xfrm>
+            <a:off x="1115568" y="3200400"/>
+            <a:ext cx="2032940" cy="457200"/>
           </a:xfrm>
           <a:prstGeom prst="rect">
             <a:avLst/>
@@ -7735,15 +7747,29 @@
               <a:buNone/>
             </a:pPr>
             <a:r>
-              <a:rPr lang="en-US" sz="1000" b="1" dirty="0">
+              <a:rPr lang="en-US" sz="950" b="1" dirty="0">
                 <a:solidFill>
                   <a:schemeClr val="accent2"/>
                 </a:solidFill>
               </a:rPr>
-              <a:t>Art. 3 lit. i) y Art. 20 NRP-17</a:t>
+              <a:t>Responsable</a:t>
             </a:r>
             <a:endParaRPr lang="en-US" sz="1000" dirty="0"/>
           </a:p>
+          <a:p>
+            <a:pPr indent="0" marL="0">
+              <a:buNone/>
+            </a:pPr>
+            <a:r>
+              <a:rPr lang="en-US" sz="1000" dirty="0">
+                <a:solidFill>
+                  <a:schemeClr val="tx1"/>
+                </a:solidFill>
+              </a:rPr>
+              <a:t>Gerencia General · Administración de Riesgos</a:t>
+            </a:r>
+            <a:endParaRPr lang="en-US" sz="1000" dirty="0"/>
+          </a:p>
         </p:txBody>
       </p:sp>
       <p:sp>
@@ -7754,8 +7780,8 @@
         </p:nvSpPr>
         <p:spPr>
           <a:xfrm>
-            <a:off x="694944" y="3749040"/>
-            <a:ext cx="2378126" cy="530352"/>
+            <a:off x="694944" y="3712464"/>
+            <a:ext cx="2398700" cy="502920"/>
           </a:xfrm>
           <a:prstGeom prst="rect">
             <a:avLst/>
@@ -7784,14 +7810,14 @@
       </p:sp>
       <p:sp>
         <p:nvSpPr>
-          <p:cNvPr id="38" name="Responsable A-5"/>
-          <p:cNvSpPr txBox="1"/>
-          <p:nvPr/>
-        </p:nvSpPr>
-        <p:spPr>
-          <a:xfrm>
-            <a:off x="694944" y="4270248"/>
-            <a:ext cx="2378126" cy="384048"/>
+          <p:cNvPr id="38" name="Respuesta A-5"/>
+          <p:cNvSpPr txBox="1"/>
+          <p:nvPr/>
+        </p:nvSpPr>
+        <p:spPr>
+          <a:xfrm>
+            <a:off x="694944" y="4206240"/>
+            <a:ext cx="2398700" cy="329184"/>
           </a:xfrm>
           <a:prstGeom prst="rect">
             <a:avLst/>
@@ -7807,25 +7833,14 @@
               <a:buNone/>
             </a:pPr>
             <a:r>
-              <a:rPr lang="en-US" sz="1000" b="1" dirty="0">
+              <a:rPr lang="en-US" sz="950" i="1" dirty="0">
                 <a:solidFill>
                   <a:schemeClr val="accent5"/>
                 </a:solidFill>
               </a:rPr>
-              <a:t>Responsable: </a:t>
-            </a:r>
-            <a:pPr indent="0" marL="0">
-              <a:buNone/>
-            </a:pPr>
-            <a:r>
-              <a:rPr lang="en-US" sz="1000" dirty="0">
-                <a:solidFill>
-                  <a:schemeClr val="tx1"/>
-                </a:solidFill>
-              </a:rPr>
-              <a:t>Consejo de Administración (aprobó el Código, Acta 2,663)</a:t>
-            </a:r>
-            <a:endParaRPr lang="en-US" sz="1000" dirty="0"/>
+              <a:t>Respuesta: sin comentario en la matriz</a:t>
+            </a:r>
+            <a:endParaRPr lang="en-US" sz="950" dirty="0"/>
           </a:p>
         </p:txBody>
       </p:sp>
@@ -7837,12 +7852,12 @@
         </p:nvSpPr>
         <p:spPr>
           <a:xfrm>
-            <a:off x="3356534" y="3218688"/>
-            <a:ext cx="2670734" cy="1481328"/>
+            <a:off x="3349676" y="3127248"/>
+            <a:ext cx="2691308" cy="1444752"/>
           </a:xfrm>
           <a:prstGeom prst="roundRect">
             <a:avLst>
-              <a:gd name="adj" fmla="val 6173"/>
+              <a:gd name="adj" fmla="val 6329"/>
             </a:avLst>
           </a:prstGeom>
           <a:solidFill>
@@ -7866,7 +7881,7 @@
         </p:nvSpPr>
         <p:spPr>
           <a:xfrm>
-            <a:off x="3502838" y="3346704"/>
+            <a:off x="3495980" y="3255264"/>
             <a:ext cx="329184" cy="329184"/>
           </a:xfrm>
           <a:prstGeom prst="ellipse">
@@ -7893,7 +7908,7 @@
         </p:nvSpPr>
         <p:spPr>
           <a:xfrm>
-            <a:off x="3502838" y="3346704"/>
+            <a:off x="3495980" y="3255264"/>
             <a:ext cx="329184" cy="329184"/>
           </a:xfrm>
           <a:prstGeom prst="rect">
@@ -7926,14 +7941,14 @@
       </p:sp>
       <p:sp>
         <p:nvSpPr>
-          <p:cNvPr id="42" name="Criterio A-6"/>
-          <p:cNvSpPr txBox="1"/>
-          <p:nvPr/>
-        </p:nvSpPr>
-        <p:spPr>
-          <a:xfrm>
-            <a:off x="3923462" y="3328416"/>
-            <a:ext cx="1984934" cy="365760"/>
+          <p:cNvPr id="42" name="Responsable A-6"/>
+          <p:cNvSpPr txBox="1"/>
+          <p:nvPr/>
+        </p:nvSpPr>
+        <p:spPr>
+          <a:xfrm>
+            <a:off x="3916604" y="3200400"/>
+            <a:ext cx="2032940" cy="457200"/>
           </a:xfrm>
           <a:prstGeom prst="rect">
             <a:avLst/>
@@ -7949,15 +7964,29 @@
               <a:buNone/>
             </a:pPr>
             <a:r>
-              <a:rPr lang="en-US" sz="1000" b="1" dirty="0">
+              <a:rPr lang="en-US" sz="950" b="1" dirty="0">
                 <a:solidFill>
                   <a:schemeClr val="accent2"/>
                 </a:solidFill>
               </a:rPr>
-              <a:t>Art. 59 LGAC · Art. 69 Reglamento</a:t>
+              <a:t>Responsable</a:t>
             </a:r>
             <a:endParaRPr lang="en-US" sz="1000" dirty="0"/>
           </a:p>
+          <a:p>
+            <a:pPr indent="0" marL="0">
+              <a:buNone/>
+            </a:pPr>
+            <a:r>
+              <a:rPr lang="en-US" sz="1000" dirty="0">
+                <a:solidFill>
+                  <a:schemeClr val="tx1"/>
+                </a:solidFill>
+              </a:rPr>
+              <a:t>Gerencia Administrativa · Jefe de Educación y Resp. Social</a:t>
+            </a:r>
+            <a:endParaRPr lang="en-US" sz="1000" dirty="0"/>
+          </a:p>
         </p:txBody>
       </p:sp>
       <p:sp>
@@ -7968,8 +7997,8 @@
         </p:nvSpPr>
         <p:spPr>
           <a:xfrm>
-            <a:off x="3502838" y="3749040"/>
-            <a:ext cx="2378126" cy="530352"/>
+            <a:off x="3495980" y="3712464"/>
+            <a:ext cx="2398700" cy="502920"/>
           </a:xfrm>
           <a:prstGeom prst="rect">
             <a:avLst/>
@@ -7998,14 +8027,14 @@
       </p:sp>
       <p:sp>
         <p:nvSpPr>
-          <p:cNvPr id="44" name="Responsable A-6"/>
-          <p:cNvSpPr txBox="1"/>
-          <p:nvPr/>
-        </p:nvSpPr>
-        <p:spPr>
-          <a:xfrm>
-            <a:off x="3502838" y="4270248"/>
-            <a:ext cx="2378126" cy="384048"/>
+          <p:cNvPr id="44" name="Respuesta A-6"/>
+          <p:cNvSpPr txBox="1"/>
+          <p:nvPr/>
+        </p:nvSpPr>
+        <p:spPr>
+          <a:xfrm>
+            <a:off x="3495980" y="4206240"/>
+            <a:ext cx="2398700" cy="329184"/>
           </a:xfrm>
           <a:prstGeom prst="rect">
             <a:avLst/>
@@ -8021,25 +8050,14 @@
               <a:buNone/>
             </a:pPr>
             <a:r>
-              <a:rPr lang="en-US" sz="1000" b="1" dirty="0">
+              <a:rPr lang="en-US" sz="950" i="1" dirty="0">
                 <a:solidFill>
                   <a:schemeClr val="accent5"/>
                 </a:solidFill>
               </a:rPr>
-              <a:t>Responsable: </a:t>
-            </a:r>
-            <a:pPr indent="0" marL="0">
-              <a:buNone/>
-            </a:pPr>
-            <a:r>
-              <a:rPr lang="en-US" sz="1000" dirty="0">
-                <a:solidFill>
-                  <a:schemeClr val="tx1"/>
-                </a:solidFill>
-              </a:rPr>
-              <a:t>Comité de Educación (Reglamento, art. 5)</a:t>
-            </a:r>
-            <a:endParaRPr lang="en-US" sz="1000" dirty="0"/>
+              <a:t>Respuesta: Revisión integral del Reglamento del Fondo</a:t>
+            </a:r>
+            <a:endParaRPr lang="en-US" sz="950" dirty="0"/>
           </a:p>
         </p:txBody>
       </p:sp>
@@ -8051,12 +8069,12 @@
         </p:nvSpPr>
         <p:spPr>
           <a:xfrm>
-            <a:off x="6164428" y="3218688"/>
-            <a:ext cx="2670734" cy="1481328"/>
+            <a:off x="6150712" y="3127248"/>
+            <a:ext cx="2691308" cy="1444752"/>
           </a:xfrm>
           <a:prstGeom prst="roundRect">
             <a:avLst>
-              <a:gd name="adj" fmla="val 6173"/>
+              <a:gd name="adj" fmla="val 6329"/>
             </a:avLst>
           </a:prstGeom>
           <a:solidFill>
@@ -8080,7 +8098,7 @@
         </p:nvSpPr>
         <p:spPr>
           <a:xfrm>
-            <a:off x="6310732" y="3346704"/>
+            <a:off x="6297016" y="3255264"/>
             <a:ext cx="329184" cy="329184"/>
           </a:xfrm>
           <a:prstGeom prst="ellipse">
@@ -8107,7 +8125,7 @@
         </p:nvSpPr>
         <p:spPr>
           <a:xfrm>
-            <a:off x="6310732" y="3346704"/>
+            <a:off x="6297016" y="3255264"/>
             <a:ext cx="329184" cy="329184"/>
           </a:xfrm>
           <a:prstGeom prst="rect">
@@ -8140,14 +8158,14 @@
       </p:sp>
       <p:sp>
         <p:nvSpPr>
-          <p:cNvPr id="48" name="Criterio A-7"/>
-          <p:cNvSpPr txBox="1"/>
-          <p:nvPr/>
-        </p:nvSpPr>
-        <p:spPr>
-          <a:xfrm>
-            <a:off x="6731356" y="3328416"/>
-            <a:ext cx="1984934" cy="365760"/>
+          <p:cNvPr id="48" name="Responsable A-7"/>
+          <p:cNvSpPr txBox="1"/>
+          <p:nvPr/>
+        </p:nvSpPr>
+        <p:spPr>
+          <a:xfrm>
+            <a:off x="6717640" y="3200400"/>
+            <a:ext cx="2032940" cy="457200"/>
           </a:xfrm>
           <a:prstGeom prst="rect">
             <a:avLst/>
@@ -8163,15 +8181,29 @@
               <a:buNone/>
             </a:pPr>
             <a:r>
-              <a:rPr lang="en-US" sz="1000" b="1" dirty="0">
+              <a:rPr lang="en-US" sz="950" b="1" dirty="0">
                 <a:solidFill>
                   <a:schemeClr val="accent2"/>
                 </a:solidFill>
               </a:rPr>
-              <a:t>Art. 12 lit. q) NRP-17 · US$100,774.28</a:t>
+              <a:t>Responsable</a:t>
             </a:r>
             <a:endParaRPr lang="en-US" sz="1000" dirty="0"/>
           </a:p>
+          <a:p>
+            <a:pPr indent="0" marL="0">
+              <a:buNone/>
+            </a:pPr>
+            <a:r>
+              <a:rPr lang="en-US" sz="1000" dirty="0">
+                <a:solidFill>
+                  <a:schemeClr val="tx1"/>
+                </a:solidFill>
+              </a:rPr>
+              <a:t>Gerencia Administrativa · Jefatura de Educación y Resp. Social</a:t>
+            </a:r>
+            <a:endParaRPr lang="en-US" sz="1000" dirty="0"/>
+          </a:p>
         </p:txBody>
       </p:sp>
       <p:sp>
@@ -8182,8 +8214,8 @@
         </p:nvSpPr>
         <p:spPr>
           <a:xfrm>
-            <a:off x="6310732" y="3749040"/>
-            <a:ext cx="2378126" cy="530352"/>
+            <a:off x="6297016" y="3712464"/>
+            <a:ext cx="2398700" cy="502920"/>
           </a:xfrm>
           <a:prstGeom prst="rect">
             <a:avLst/>
@@ -8212,14 +8244,14 @@
       </p:sp>
       <p:sp>
         <p:nvSpPr>
-          <p:cNvPr id="50" name="Responsable A-7"/>
-          <p:cNvSpPr txBox="1"/>
-          <p:nvPr/>
-        </p:nvSpPr>
-        <p:spPr>
-          <a:xfrm>
-            <a:off x="6310732" y="4270248"/>
-            <a:ext cx="2378126" cy="384048"/>
+          <p:cNvPr id="50" name="Respuesta A-7"/>
+          <p:cNvSpPr txBox="1"/>
+          <p:nvPr/>
+        </p:nvSpPr>
+        <p:spPr>
+          <a:xfrm>
+            <a:off x="6297016" y="4206240"/>
+            <a:ext cx="2398700" cy="329184"/>
           </a:xfrm>
           <a:prstGeom prst="rect">
             <a:avLst/>
@@ -8235,25 +8267,14 @@
               <a:buNone/>
             </a:pPr>
             <a:r>
-              <a:rPr lang="en-US" sz="1000" b="1" dirty="0">
+              <a:rPr lang="en-US" sz="950" i="1" dirty="0">
                 <a:solidFill>
                   <a:schemeClr val="accent5"/>
                 </a:solidFill>
               </a:rPr>
-              <a:t>Responsable: </a:t>
-            </a:r>
-            <a:pPr indent="0" marL="0">
-              <a:buNone/>
-            </a:pPr>
-            <a:r>
-              <a:rPr lang="en-US" sz="1000" dirty="0">
-                <a:solidFill>
-                  <a:schemeClr val="tx1"/>
-                </a:solidFill>
-              </a:rPr>
-              <a:t>Consejo de Administración (Memoria de Labores 2025)</a:t>
-            </a:r>
-            <a:endParaRPr lang="en-US" sz="1000" dirty="0"/>
+              <a:t>Respuesta: Memoria de Labores 2026 con conceptos y montos</a:t>
+            </a:r>
+            <a:endParaRPr lang="en-US" sz="950" dirty="0"/>
           </a:p>
         </p:txBody>
       </p:sp>
@@ -8265,12 +8286,12 @@
         </p:nvSpPr>
         <p:spPr>
           <a:xfrm>
-            <a:off x="8972321" y="3218688"/>
-            <a:ext cx="2670734" cy="1481328"/>
+            <a:off x="8951747" y="3127248"/>
+            <a:ext cx="2691308" cy="1444752"/>
           </a:xfrm>
           <a:prstGeom prst="roundRect">
             <a:avLst>
-              <a:gd name="adj" fmla="val 6173"/>
+              <a:gd name="adj" fmla="val 6329"/>
             </a:avLst>
           </a:prstGeom>
           <a:solidFill>
@@ -8294,7 +8315,7 @@
         </p:nvSpPr>
         <p:spPr>
           <a:xfrm>
-            <a:off x="9155201" y="3328416"/>
+            <a:off x="9134627" y="3218688"/>
             <a:ext cx="822960" cy="640080"/>
           </a:xfrm>
           <a:prstGeom prst="rect">
@@ -8333,8 +8354,8 @@
         </p:nvSpPr>
         <p:spPr>
           <a:xfrm>
-            <a:off x="9978161" y="3374136"/>
-            <a:ext cx="1527734" cy="548640"/>
+            <a:off x="9957587" y="3264408"/>
+            <a:ext cx="1548308" cy="548640"/>
           </a:xfrm>
           <a:prstGeom prst="rect">
             <a:avLst/>
@@ -8369,8 +8390,8 @@
         </p:nvSpPr>
         <p:spPr>
           <a:xfrm>
-            <a:off x="9155201" y="4041648"/>
-            <a:ext cx="2350694" cy="502920"/>
+            <a:off x="9134627" y="3931920"/>
+            <a:ext cx="2371268" cy="502920"/>
           </a:xfrm>
           <a:prstGeom prst="rect">
             <a:avLst/>
@@ -8419,7 +8440,7 @@
         </p:nvSpPr>
         <p:spPr>
           <a:xfrm>
-            <a:off x="548640" y="4828032"/>
+            <a:off x="548640" y="4663440"/>
             <a:ext cx="8229600" cy="237744"/>
           </a:xfrm>
           <a:prstGeom prst="rect">
@@ -8455,12 +8476,12 @@
         </p:nvSpPr>
         <p:spPr>
           <a:xfrm>
-            <a:off x="548640" y="5120640"/>
-            <a:ext cx="4074681" cy="1124712"/>
+            <a:off x="548640" y="4937760"/>
+            <a:ext cx="4091826" cy="1325880"/>
           </a:xfrm>
           <a:prstGeom prst="roundRect">
             <a:avLst>
-              <a:gd name="adj" fmla="val 8130"/>
+              <a:gd name="adj" fmla="val 6897"/>
             </a:avLst>
           </a:prstGeom>
           <a:solidFill>
@@ -8486,7 +8507,7 @@
         </p:nvSpPr>
         <p:spPr>
           <a:xfrm>
-            <a:off x="731520" y="5276088"/>
+            <a:off x="731520" y="5065776"/>
             <a:ext cx="1325880" cy="274320"/>
           </a:xfrm>
           <a:prstGeom prst="roundRect">
@@ -8515,7 +8536,7 @@
         </p:nvSpPr>
         <p:spPr>
           <a:xfrm>
-            <a:off x="731520" y="5276088"/>
+            <a:off x="731520" y="5065776"/>
             <a:ext cx="1325880" cy="274320"/>
           </a:xfrm>
           <a:prstGeom prst="rect">
@@ -8551,7 +8572,7 @@
         </p:nvSpPr>
         <p:spPr>
           <a:xfrm>
-            <a:off x="2194560" y="5276088"/>
+            <a:off x="2194560" y="5065776"/>
             <a:ext cx="1325880" cy="274320"/>
           </a:xfrm>
           <a:prstGeom prst="roundRect">
@@ -8580,7 +8601,7 @@
         </p:nvSpPr>
         <p:spPr>
           <a:xfrm>
-            <a:off x="2194560" y="5276088"/>
+            <a:off x="2194560" y="5065776"/>
             <a:ext cx="1325880" cy="274320"/>
           </a:xfrm>
           <a:prstGeom prst="rect">
@@ -8616,8 +8637,8 @@
         </p:nvSpPr>
         <p:spPr>
           <a:xfrm>
-            <a:off x="731520" y="5623560"/>
-            <a:ext cx="3708921" cy="256032"/>
+            <a:off x="731520" y="5394960"/>
+            <a:ext cx="3726066" cy="256032"/>
           </a:xfrm>
           <a:prstGeom prst="rect">
             <a:avLst/>
@@ -8652,8 +8673,8 @@
         </p:nvSpPr>
         <p:spPr>
           <a:xfrm>
-            <a:off x="731520" y="5888736"/>
-            <a:ext cx="3708921" cy="310896"/>
+            <a:off x="731520" y="5650992"/>
+            <a:ext cx="3726066" cy="219456"/>
           </a:xfrm>
           <a:prstGeom prst="rect">
             <a:avLst/>
@@ -8669,7 +8690,7 @@
               <a:buNone/>
             </a:pPr>
             <a:r>
-              <a:rPr lang="en-US" sz="1050" b="1" dirty="0">
+              <a:rPr lang="en-US" sz="1000" b="1" dirty="0">
                 <a:solidFill>
                   <a:schemeClr val="accent5"/>
                 </a:solidFill>
@@ -8680,31 +8701,78 @@
               <a:buNone/>
             </a:pPr>
             <a:r>
-              <a:rPr lang="en-US" sz="1050" dirty="0">
+              <a:rPr lang="en-US" sz="1000" dirty="0">
                 <a:solidFill>
                   <a:schemeClr val="tx1"/>
                 </a:solidFill>
               </a:rPr>
-              <a:t>Administración de Riesgo</a:t>
-            </a:r>
-            <a:endParaRPr lang="en-US" sz="1050" dirty="0"/>
-          </a:p>
-        </p:txBody>
-      </p:sp>
-      <p:sp>
-        <p:nvSpPr>
-          <p:cNvPr id="63" name="Anexo B-5"/>
+              <a:t>Gerencia General · Jefe de Administración de Riesgos</a:t>
+            </a:r>
+            <a:endParaRPr lang="en-US" sz="1000" dirty="0"/>
+          </a:p>
+        </p:txBody>
+      </p:sp>
+      <p:sp>
+        <p:nvSpPr>
+          <p:cNvPr id="63" name="Avance B-3"/>
+          <p:cNvSpPr txBox="1"/>
+          <p:nvPr/>
+        </p:nvSpPr>
+        <p:spPr>
+          <a:xfrm>
+            <a:off x="731520" y="5870448"/>
+            <a:ext cx="3726066" cy="365760"/>
+          </a:xfrm>
+          <a:prstGeom prst="rect">
+            <a:avLst/>
+          </a:prstGeom>
+          <a:noFill/>
+          <a:ln/>
+        </p:spPr>
+        <p:txBody>
+          <a:bodyPr wrap="square" lIns="0" tIns="0" rIns="0" bIns="0" rtlCol="0" anchor="t"/>
+          <a:lstStyle/>
+          <a:p>
+            <a:pPr indent="0" marL="0">
+              <a:buNone/>
+            </a:pPr>
+            <a:r>
+              <a:rPr lang="en-US" sz="950" b="1" dirty="0">
+                <a:solidFill>
+                  <a:schemeClr val="accent5"/>
+                </a:solidFill>
+              </a:rPr>
+              <a:t>Avance: </a:t>
+            </a:r>
+            <a:pPr indent="0" marL="0">
+              <a:buNone/>
+            </a:pPr>
+            <a:r>
+              <a:rPr lang="en-US" sz="950" dirty="0">
+                <a:solidFill>
+                  <a:schemeClr val="tx1"/>
+                </a:solidFill>
+              </a:rPr>
+              <a:t>Plan de solución: acciones aún sin registrar</a:t>
+            </a:r>
+            <a:endParaRPr lang="en-US" sz="950" dirty="0"/>
+          </a:p>
+        </p:txBody>
+      </p:sp>
+      <p:sp>
+        <p:nvSpPr>
+          <p:cNvPr id="64" name="Anexo B-5"/>
           <p:cNvSpPr/>
           <p:nvPr/>
         </p:nvSpPr>
         <p:spPr>
           <a:xfrm>
-            <a:off x="4760481" y="5120640"/>
-            <a:ext cx="4074681" cy="1124712"/>
+            <a:off x="4750194" y="4937760"/>
+            <a:ext cx="4091826" cy="1325880"/>
           </a:xfrm>
           <a:prstGeom prst="roundRect">
             <a:avLst>
-              <a:gd name="adj" fmla="val 8130"/>
+              <a:gd name="adj" fmla="val 6897"/>
             </a:avLst>
           </a:prstGeom>
           <a:solidFill>
@@ -8724,13 +8792,13 @@
       </p:sp>
       <p:sp>
         <p:nvSpPr>
-          <p:cNvPr id="64" name="Origen B-5 fondo"/>
+          <p:cNvPr id="65" name="Origen B-5 fondo"/>
           <p:cNvSpPr/>
           <p:nvPr/>
         </p:nvSpPr>
         <p:spPr>
           <a:xfrm>
-            <a:off x="4943361" y="5276088"/>
+            <a:off x="4933074" y="5065776"/>
             <a:ext cx="1325880" cy="274320"/>
           </a:xfrm>
           <a:prstGeom prst="roundRect">
@@ -8753,13 +8821,13 @@
       </p:sp>
       <p:sp>
         <p:nvSpPr>
-          <p:cNvPr id="65" name="Origen B-5"/>
-          <p:cNvSpPr txBox="1"/>
-          <p:nvPr/>
-        </p:nvSpPr>
-        <p:spPr>
-          <a:xfrm>
-            <a:off x="4943361" y="5276088"/>
+          <p:cNvPr id="66" name="Origen B-5"/>
+          <p:cNvSpPr txBox="1"/>
+          <p:nvPr/>
+        </p:nvSpPr>
+        <p:spPr>
+          <a:xfrm>
+            <a:off x="4933074" y="5065776"/>
             <a:ext cx="1325880" cy="274320"/>
           </a:xfrm>
           <a:prstGeom prst="rect">
@@ -8789,13 +8857,13 @@
       </p:sp>
       <p:sp>
         <p:nvSpPr>
-          <p:cNvPr id="66" name="Estado B-5 fondo"/>
+          <p:cNvPr id="67" name="Estado B-5 fondo"/>
           <p:cNvSpPr/>
           <p:nvPr/>
         </p:nvSpPr>
         <p:spPr>
           <a:xfrm>
-            <a:off x="6406401" y="5276088"/>
+            <a:off x="6396114" y="5065776"/>
             <a:ext cx="2194560" cy="274320"/>
           </a:xfrm>
           <a:prstGeom prst="roundRect">
@@ -8818,13 +8886,13 @@
       </p:sp>
       <p:sp>
         <p:nvSpPr>
-          <p:cNvPr id="67" name="Estado B-5"/>
-          <p:cNvSpPr txBox="1"/>
-          <p:nvPr/>
-        </p:nvSpPr>
-        <p:spPr>
-          <a:xfrm>
-            <a:off x="6406401" y="5276088"/>
+          <p:cNvPr id="68" name="Estado B-5"/>
+          <p:cNvSpPr txBox="1"/>
+          <p:nvPr/>
+        </p:nvSpPr>
+        <p:spPr>
+          <a:xfrm>
+            <a:off x="6396114" y="5065776"/>
             <a:ext cx="2194560" cy="274320"/>
           </a:xfrm>
           <a:prstGeom prst="rect">
@@ -8854,14 +8922,14 @@
       </p:sp>
       <p:sp>
         <p:nvSpPr>
-          <p:cNvPr id="68" name="Título B-5"/>
-          <p:cNvSpPr txBox="1"/>
-          <p:nvPr/>
-        </p:nvSpPr>
-        <p:spPr>
-          <a:xfrm>
-            <a:off x="4943361" y="5623560"/>
-            <a:ext cx="3708921" cy="256032"/>
+          <p:cNvPr id="69" name="Título B-5"/>
+          <p:cNvSpPr txBox="1"/>
+          <p:nvPr/>
+        </p:nvSpPr>
+        <p:spPr>
+          <a:xfrm>
+            <a:off x="4933074" y="5394960"/>
+            <a:ext cx="3726066" cy="256032"/>
           </a:xfrm>
           <a:prstGeom prst="rect">
             <a:avLst/>
@@ -8890,14 +8958,14 @@
       </p:sp>
       <p:sp>
         <p:nvSpPr>
-          <p:cNvPr id="69" name="Responsable B-5"/>
-          <p:cNvSpPr txBox="1"/>
-          <p:nvPr/>
-        </p:nvSpPr>
-        <p:spPr>
-          <a:xfrm>
-            <a:off x="4943361" y="5888736"/>
-            <a:ext cx="3708921" cy="310896"/>
+          <p:cNvPr id="70" name="Responsable B-5"/>
+          <p:cNvSpPr txBox="1"/>
+          <p:nvPr/>
+        </p:nvSpPr>
+        <p:spPr>
+          <a:xfrm>
+            <a:off x="4933074" y="5650992"/>
+            <a:ext cx="3726066" cy="219456"/>
           </a:xfrm>
           <a:prstGeom prst="rect">
             <a:avLst/>
@@ -8913,42 +8981,89 @@
               <a:buNone/>
             </a:pPr>
             <a:r>
-              <a:rPr lang="en-US" sz="1050" b="1" dirty="0">
+              <a:rPr lang="en-US" sz="1000" b="1" dirty="0">
                 <a:solidFill>
                   <a:schemeClr val="accent5"/>
                 </a:solidFill>
               </a:rPr>
-              <a:t>Responsables: </a:t>
-            </a:r>
-            <a:pPr indent="0" marL="0">
-              <a:buNone/>
-            </a:pPr>
-            <a:r>
-              <a:rPr lang="en-US" sz="1050" dirty="0">
+              <a:t>Responsable: </a:t>
+            </a:r>
+            <a:pPr indent="0" marL="0">
+              <a:buNone/>
+            </a:pPr>
+            <a:r>
+              <a:rPr lang="en-US" sz="1000" dirty="0">
                 <a:solidFill>
                   <a:schemeClr val="tx1"/>
                 </a:solidFill>
               </a:rPr>
-              <a:t>Auditoría Interna, Servicios Generales y Talento Humano</a:t>
-            </a:r>
-            <a:endParaRPr lang="en-US" sz="1050" dirty="0"/>
-          </a:p>
-        </p:txBody>
-      </p:sp>
-      <p:sp>
-        <p:nvSpPr>
-          <p:cNvPr id="70" name="Plazo Anexo B"/>
+              <a:t>Talento Humano · Auditor Interno · Servicios Generales</a:t>
+            </a:r>
+            <a:endParaRPr lang="en-US" sz="1000" dirty="0"/>
+          </a:p>
+        </p:txBody>
+      </p:sp>
+      <p:sp>
+        <p:nvSpPr>
+          <p:cNvPr id="71" name="Avance B-5"/>
+          <p:cNvSpPr txBox="1"/>
+          <p:nvPr/>
+        </p:nvSpPr>
+        <p:spPr>
+          <a:xfrm>
+            <a:off x="4933074" y="5870448"/>
+            <a:ext cx="3726066" cy="365760"/>
+          </a:xfrm>
+          <a:prstGeom prst="rect">
+            <a:avLst/>
+          </a:prstGeom>
+          <a:noFill/>
+          <a:ln/>
+        </p:spPr>
+        <p:txBody>
+          <a:bodyPr wrap="square" lIns="0" tIns="0" rIns="0" bIns="0" rtlCol="0" anchor="t"/>
+          <a:lstStyle/>
+          <a:p>
+            <a:pPr indent="0" marL="0">
+              <a:buNone/>
+            </a:pPr>
+            <a:r>
+              <a:rPr lang="en-US" sz="950" b="1" dirty="0">
+                <a:solidFill>
+                  <a:schemeClr val="accent5"/>
+                </a:solidFill>
+              </a:rPr>
+              <a:t>Avance: </a:t>
+            </a:r>
+            <a:pPr indent="0" marL="0">
+              <a:buNone/>
+            </a:pPr>
+            <a:r>
+              <a:rPr lang="en-US" sz="950" dirty="0">
+                <a:solidFill>
+                  <a:schemeClr val="tx1"/>
+                </a:solidFill>
+              </a:rPr>
+              <a:t>RIT y Manual de Compras en proceso · Reglamento del Comité de Auditoría aprobado (28/08/2026) y enviado al CA (05/10/2026)</a:t>
+            </a:r>
+            <a:endParaRPr lang="en-US" sz="950" dirty="0"/>
+          </a:p>
+        </p:txBody>
+      </p:sp>
+      <p:sp>
+        <p:nvSpPr>
+          <p:cNvPr id="72" name="Plazo Anexo B"/>
           <p:cNvSpPr/>
           <p:nvPr/>
         </p:nvSpPr>
         <p:spPr>
           <a:xfrm>
-            <a:off x="8972321" y="5120640"/>
-            <a:ext cx="2670734" cy="1124712"/>
+            <a:off x="8951747" y="4937760"/>
+            <a:ext cx="2691308" cy="1325880"/>
           </a:xfrm>
           <a:prstGeom prst="roundRect">
             <a:avLst>
-              <a:gd name="adj" fmla="val 8130"/>
+              <a:gd name="adj" fmla="val 6897"/>
             </a:avLst>
           </a:prstGeom>
           <a:solidFill>
@@ -8966,13 +9081,13 @@
       </p:sp>
       <p:sp>
         <p:nvSpPr>
-          <p:cNvPr id="71" name="Plazo B número"/>
-          <p:cNvSpPr txBox="1"/>
-          <p:nvPr/>
-        </p:nvSpPr>
-        <p:spPr>
-          <a:xfrm>
-            <a:off x="9155201" y="5138928"/>
+          <p:cNvPr id="73" name="Plazo B número"/>
+          <p:cNvSpPr txBox="1"/>
+          <p:nvPr/>
+        </p:nvSpPr>
+        <p:spPr>
+          <a:xfrm>
+            <a:off x="9134627" y="5010912"/>
             <a:ext cx="822960" cy="640080"/>
           </a:xfrm>
           <a:prstGeom prst="rect">
@@ -9005,14 +9120,14 @@
       </p:sp>
       <p:sp>
         <p:nvSpPr>
-          <p:cNvPr id="72" name="Plazo B título"/>
-          <p:cNvSpPr txBox="1"/>
-          <p:nvPr/>
-        </p:nvSpPr>
-        <p:spPr>
-          <a:xfrm>
-            <a:off x="9978161" y="5184648"/>
-            <a:ext cx="1527734" cy="548640"/>
+          <p:cNvPr id="74" name="Plazo B título"/>
+          <p:cNvSpPr txBox="1"/>
+          <p:nvPr/>
+        </p:nvSpPr>
+        <p:spPr>
+          <a:xfrm>
+            <a:off x="9957587" y="5056632"/>
+            <a:ext cx="1548308" cy="548640"/>
           </a:xfrm>
           <a:prstGeom prst="rect">
             <a:avLst/>
@@ -9041,14 +9156,14 @@
       </p:sp>
       <p:sp>
         <p:nvSpPr>
-          <p:cNvPr id="73" name="Plazo B detalle"/>
-          <p:cNvSpPr txBox="1"/>
-          <p:nvPr/>
-        </p:nvSpPr>
-        <p:spPr>
-          <a:xfrm>
-            <a:off x="9155201" y="5788152"/>
-            <a:ext cx="2396414" cy="411480"/>
+          <p:cNvPr id="75" name="Plazo B detalle"/>
+          <p:cNvSpPr txBox="1"/>
+          <p:nvPr/>
+        </p:nvSpPr>
+        <p:spPr>
+          <a:xfrm>
+            <a:off x="9134627" y="5715000"/>
+            <a:ext cx="2416988" cy="457200"/>
           </a:xfrm>
           <a:prstGeom prst="rect">
             <a:avLst/>
@@ -9246,8 +9361,8 @@
         </p:nvSpPr>
         <p:spPr>
           <a:xfrm>
-            <a:off x="1645920" y="1463040"/>
-            <a:ext cx="0" cy="2029968"/>
+            <a:off x="1645920" y="1444752"/>
+            <a:ext cx="0" cy="1796796"/>
           </a:xfrm>
           <a:prstGeom prst="line">
             <a:avLst/>
@@ -9269,8 +9384,8 @@
         </p:nvSpPr>
         <p:spPr>
           <a:xfrm>
-            <a:off x="1645920" y="3675888"/>
-            <a:ext cx="0" cy="512064"/>
+            <a:off x="1645920" y="3424428"/>
+            <a:ext cx="0" cy="416052"/>
           </a:xfrm>
           <a:prstGeom prst="line">
             <a:avLst/>
@@ -9292,8 +9407,8 @@
         </p:nvSpPr>
         <p:spPr>
           <a:xfrm>
-            <a:off x="1645920" y="4370832"/>
-            <a:ext cx="0" cy="1353312"/>
+            <a:off x="1645920" y="4023360"/>
+            <a:ext cx="0" cy="1796796"/>
           </a:xfrm>
           <a:prstGeom prst="line">
             <a:avLst/>
@@ -9315,7 +9430,7 @@
         </p:nvSpPr>
         <p:spPr>
           <a:xfrm>
-            <a:off x="548640" y="1426464"/>
+            <a:off x="548640" y="1408176"/>
             <a:ext cx="777240" cy="274320"/>
           </a:xfrm>
           <a:prstGeom prst="roundRect">
@@ -9344,7 +9459,7 @@
         </p:nvSpPr>
         <p:spPr>
           <a:xfrm>
-            <a:off x="548640" y="1426464"/>
+            <a:off x="548640" y="1408176"/>
             <a:ext cx="777240" cy="274320"/>
           </a:xfrm>
           <a:prstGeom prst="rect">
@@ -9380,7 +9495,7 @@
         </p:nvSpPr>
         <p:spPr>
           <a:xfrm>
-            <a:off x="548640" y="4334256"/>
+            <a:off x="548640" y="3986784"/>
             <a:ext cx="777240" cy="274320"/>
           </a:xfrm>
           <a:prstGeom prst="roundRect">
@@ -9409,7 +9524,7 @@
         </p:nvSpPr>
         <p:spPr>
           <a:xfrm>
-            <a:off x="548640" y="4334256"/>
+            <a:off x="548640" y="3986784"/>
             <a:ext cx="777240" cy="274320"/>
           </a:xfrm>
           <a:prstGeom prst="rect">
@@ -9445,7 +9560,7 @@
         </p:nvSpPr>
         <p:spPr>
           <a:xfrm>
-            <a:off x="502920" y="3840480"/>
+            <a:off x="502920" y="3541014"/>
             <a:ext cx="914400" cy="201168"/>
           </a:xfrm>
           <a:prstGeom prst="rect">
@@ -9481,12 +9596,12 @@
         </p:nvSpPr>
         <p:spPr>
           <a:xfrm>
-            <a:off x="1856232" y="1371600"/>
-            <a:ext cx="4754880" cy="621792"/>
+            <a:off x="1856232" y="1353312"/>
+            <a:ext cx="4754880" cy="544068"/>
           </a:xfrm>
           <a:prstGeom prst="roundRect">
             <a:avLst>
-              <a:gd name="adj" fmla="val 14706"/>
+              <a:gd name="adj" fmla="val 16807"/>
             </a:avLst>
           </a:prstGeom>
           <a:solidFill>
@@ -9512,7 +9627,7 @@
         </p:nvSpPr>
         <p:spPr>
           <a:xfrm>
-            <a:off x="1463040" y="1426464"/>
+            <a:off x="1463040" y="1408176"/>
             <a:ext cx="365760" cy="365760"/>
           </a:xfrm>
           <a:prstGeom prst="ellipse">
@@ -9541,7 +9656,7 @@
         </p:nvSpPr>
         <p:spPr>
           <a:xfrm>
-            <a:off x="1536192" y="1499616"/>
+            <a:off x="1536192" y="1481328"/>
             <a:ext cx="219456" cy="219456"/>
           </a:xfrm>
           <a:prstGeom prst="ellipse">
@@ -9566,7 +9681,7 @@
         </p:nvSpPr>
         <p:spPr>
           <a:xfrm>
-            <a:off x="1965960" y="1463040"/>
+            <a:off x="1965960" y="1444752"/>
             <a:ext cx="4572000" cy="274320"/>
           </a:xfrm>
           <a:prstGeom prst="rect">
@@ -9616,7 +9731,7 @@
         </p:nvSpPr>
         <p:spPr>
           <a:xfrm>
-            <a:off x="1965960" y="1737360"/>
+            <a:off x="1965960" y="1719072"/>
             <a:ext cx="4572000" cy="228600"/>
           </a:xfrm>
           <a:prstGeom prst="rect">
@@ -9652,7 +9767,7 @@
         </p:nvSpPr>
         <p:spPr>
           <a:xfrm>
-            <a:off x="1536192" y="2176272"/>
+            <a:off x="1536192" y="2080260"/>
             <a:ext cx="219456" cy="219456"/>
           </a:xfrm>
           <a:prstGeom prst="ellipse">
@@ -9677,7 +9792,7 @@
         </p:nvSpPr>
         <p:spPr>
           <a:xfrm>
-            <a:off x="1965960" y="2139696"/>
+            <a:off x="1965960" y="2043684"/>
             <a:ext cx="4572000" cy="274320"/>
           </a:xfrm>
           <a:prstGeom prst="rect">
@@ -9727,7 +9842,7 @@
         </p:nvSpPr>
         <p:spPr>
           <a:xfrm>
-            <a:off x="1965960" y="2414016"/>
+            <a:off x="1965960" y="2318004"/>
             <a:ext cx="4572000" cy="228600"/>
           </a:xfrm>
           <a:prstGeom prst="rect">
@@ -9763,7 +9878,7 @@
         </p:nvSpPr>
         <p:spPr>
           <a:xfrm>
-            <a:off x="1536192" y="2852928"/>
+            <a:off x="1536192" y="2679192"/>
             <a:ext cx="219456" cy="219456"/>
           </a:xfrm>
           <a:prstGeom prst="ellipse">
@@ -9788,7 +9903,7 @@
         </p:nvSpPr>
         <p:spPr>
           <a:xfrm>
-            <a:off x="1965960" y="2816352"/>
+            <a:off x="1965960" y="2642616"/>
             <a:ext cx="4572000" cy="274320"/>
           </a:xfrm>
           <a:prstGeom prst="rect">
@@ -9838,7 +9953,7 @@
         </p:nvSpPr>
         <p:spPr>
           <a:xfrm>
-            <a:off x="1536192" y="3529584"/>
+            <a:off x="1536192" y="3278124"/>
             <a:ext cx="219456" cy="219456"/>
           </a:xfrm>
           <a:prstGeom prst="ellipse">
@@ -9863,7 +9978,7 @@
         </p:nvSpPr>
         <p:spPr>
           <a:xfrm>
-            <a:off x="1965960" y="3493008"/>
+            <a:off x="1965960" y="3241548"/>
             <a:ext cx="4572000" cy="274320"/>
           </a:xfrm>
           <a:prstGeom prst="rect">
@@ -9913,7 +10028,7 @@
         </p:nvSpPr>
         <p:spPr>
           <a:xfrm>
-            <a:off x="1965960" y="3767328"/>
+            <a:off x="1965960" y="3515868"/>
             <a:ext cx="4572000" cy="228600"/>
           </a:xfrm>
           <a:prstGeom prst="rect">
@@ -9949,7 +10064,7 @@
         </p:nvSpPr>
         <p:spPr>
           <a:xfrm>
-            <a:off x="1536192" y="4407408"/>
+            <a:off x="1536192" y="4059936"/>
             <a:ext cx="219456" cy="219456"/>
           </a:xfrm>
           <a:prstGeom prst="ellipse">
@@ -9974,7 +10089,7 @@
         </p:nvSpPr>
         <p:spPr>
           <a:xfrm>
-            <a:off x="1965960" y="4370832"/>
+            <a:off x="1965960" y="4023360"/>
             <a:ext cx="4572000" cy="274320"/>
           </a:xfrm>
           <a:prstGeom prst="rect">
@@ -9999,7 +10114,7 @@
                 <a:ea typeface="Courier New" pitchFamily="34" charset="-122"/>
                 <a:cs typeface="Courier New" pitchFamily="34" charset="-120"/>
               </a:rPr>
-              <a:t>05 NOV 2025   </a:t>
+              <a:t>18 NOV 2025   </a:t>
             </a:r>
             <a:pPr indent="0" marL="0">
               <a:buNone/>
@@ -10010,7 +10125,7 @@
                   <a:schemeClr val="tx1"/>
                 </a:solidFill>
               </a:rPr>
-              <a:t>Informe preliminar · Circular 17003</a:t>
+              <a:t>Envío de descargos a la SSF</a:t>
             </a:r>
             <a:endParaRPr lang="en-US" sz="1400" dirty="0"/>
           </a:p>
@@ -10024,7 +10139,7 @@
         </p:nvSpPr>
         <p:spPr>
           <a:xfrm>
-            <a:off x="1965960" y="4645152"/>
+            <a:off x="1965960" y="4297680"/>
             <a:ext cx="4572000" cy="228600"/>
           </a:xfrm>
           <a:prstGeom prst="rect">
@@ -10046,7 +10161,7 @@
                   <a:schemeClr val="accent5"/>
                 </a:solidFill>
               </a:rPr>
-              <a:t>9 observaciones</a:t>
+              <a:t>Matriz de pruebas de descargo · ref. NB07-2025-974</a:t>
             </a:r>
             <a:endParaRPr lang="en-US" sz="1050" dirty="0"/>
           </a:p>
@@ -10060,7 +10175,7 @@
         </p:nvSpPr>
         <p:spPr>
           <a:xfrm>
-            <a:off x="1536192" y="5084064"/>
+            <a:off x="1536192" y="4658868"/>
             <a:ext cx="219456" cy="219456"/>
           </a:xfrm>
           <a:prstGeom prst="ellipse">
@@ -10085,7 +10200,7 @@
         </p:nvSpPr>
         <p:spPr>
           <a:xfrm>
-            <a:off x="1965960" y="5047488"/>
+            <a:off x="1965960" y="4622292"/>
             <a:ext cx="4572000" cy="274320"/>
           </a:xfrm>
           <a:prstGeom prst="rect">
@@ -10110,7 +10225,7 @@
                 <a:ea typeface="Courier New" pitchFamily="34" charset="-122"/>
                 <a:cs typeface="Courier New" pitchFamily="34" charset="-120"/>
               </a:rPr>
-              <a:t>19 MAY 2025   </a:t>
+              <a:t>05 NOV 2025   </a:t>
             </a:r>
             <a:pPr indent="0" marL="0">
               <a:buNone/>
@@ -10121,7 +10236,7 @@
                   <a:schemeClr val="tx1"/>
                 </a:solidFill>
               </a:rPr>
-              <a:t>Inicio formal de la visita en sitio</a:t>
+              <a:t>Informe preliminar · Circular 17003</a:t>
             </a:r>
             <a:endParaRPr lang="en-US" sz="1400" dirty="0"/>
           </a:p>
@@ -10129,13 +10244,49 @@
       </p:sp>
       <p:sp>
         <p:nvSpPr>
-          <p:cNvPr id="30" name="Hito 7"/>
+          <p:cNvPr id="30" name="Hito detalle 6"/>
+          <p:cNvSpPr txBox="1"/>
+          <p:nvPr/>
+        </p:nvSpPr>
+        <p:spPr>
+          <a:xfrm>
+            <a:off x="1965960" y="4896612"/>
+            <a:ext cx="4572000" cy="228600"/>
+          </a:xfrm>
+          <a:prstGeom prst="rect">
+            <a:avLst/>
+          </a:prstGeom>
+          <a:noFill/>
+          <a:ln/>
+        </p:spPr>
+        <p:txBody>
+          <a:bodyPr wrap="square" lIns="0" tIns="0" rIns="0" bIns="0" rtlCol="0" anchor="t"/>
+          <a:lstStyle/>
+          <a:p>
+            <a:pPr indent="0" marL="0">
+              <a:buNone/>
+            </a:pPr>
+            <a:r>
+              <a:rPr lang="en-US" sz="1050" dirty="0">
+                <a:solidFill>
+                  <a:schemeClr val="accent5"/>
+                </a:solidFill>
+              </a:rPr>
+              <a:t>9 observaciones</a:t>
+            </a:r>
+            <a:endParaRPr lang="en-US" sz="1050" dirty="0"/>
+          </a:p>
+        </p:txBody>
+      </p:sp>
+      <p:sp>
+        <p:nvSpPr>
+          <p:cNvPr id="31" name="Hito 7"/>
           <p:cNvSpPr/>
           <p:nvPr/>
         </p:nvSpPr>
         <p:spPr>
           <a:xfrm>
-            <a:off x="1536192" y="5760720"/>
+            <a:off x="1536192" y="5257800"/>
             <a:ext cx="219456" cy="219456"/>
           </a:xfrm>
           <a:prstGeom prst="ellipse">
@@ -10154,13 +10305,13 @@
       </p:sp>
       <p:sp>
         <p:nvSpPr>
-          <p:cNvPr id="31" name="Hito fecha 7"/>
-          <p:cNvSpPr txBox="1"/>
-          <p:nvPr/>
-        </p:nvSpPr>
-        <p:spPr>
-          <a:xfrm>
-            <a:off x="1965960" y="5724144"/>
+          <p:cNvPr id="32" name="Hito fecha 7"/>
+          <p:cNvSpPr txBox="1"/>
+          <p:nvPr/>
+        </p:nvSpPr>
+        <p:spPr>
+          <a:xfrm>
+            <a:off x="1965960" y="5221224"/>
             <a:ext cx="4572000" cy="274320"/>
           </a:xfrm>
           <a:prstGeom prst="rect">
@@ -10185,6 +10336,81 @@
                 <a:ea typeface="Courier New" pitchFamily="34" charset="-122"/>
                 <a:cs typeface="Courier New" pitchFamily="34" charset="-120"/>
               </a:rPr>
+              <a:t>19 MAY 2025   </a:t>
+            </a:r>
+            <a:pPr indent="0" marL="0">
+              <a:buNone/>
+            </a:pPr>
+            <a:r>
+              <a:rPr lang="en-US" sz="1250" b="1" dirty="0">
+                <a:solidFill>
+                  <a:schemeClr val="tx1"/>
+                </a:solidFill>
+              </a:rPr>
+              <a:t>Inicio formal de la visita en sitio</a:t>
+            </a:r>
+            <a:endParaRPr lang="en-US" sz="1400" dirty="0"/>
+          </a:p>
+        </p:txBody>
+      </p:sp>
+      <p:sp>
+        <p:nvSpPr>
+          <p:cNvPr id="33" name="Hito 8"/>
+          <p:cNvSpPr/>
+          <p:nvPr/>
+        </p:nvSpPr>
+        <p:spPr>
+          <a:xfrm>
+            <a:off x="1536192" y="5856732"/>
+            <a:ext cx="219456" cy="219456"/>
+          </a:xfrm>
+          <a:prstGeom prst="ellipse">
+            <a:avLst/>
+          </a:prstGeom>
+          <a:solidFill>
+            <a:schemeClr val="bg1"/>
+          </a:solidFill>
+          <a:ln w="31750">
+            <a:solidFill>
+              <a:schemeClr val="accent1"/>
+            </a:solidFill>
+            <a:prstDash val="solid"/>
+          </a:ln>
+        </p:spPr>
+      </p:sp>
+      <p:sp>
+        <p:nvSpPr>
+          <p:cNvPr id="34" name="Hito fecha 8"/>
+          <p:cNvSpPr txBox="1"/>
+          <p:nvPr/>
+        </p:nvSpPr>
+        <p:spPr>
+          <a:xfrm>
+            <a:off x="1965960" y="5820156"/>
+            <a:ext cx="4572000" cy="274320"/>
+          </a:xfrm>
+          <a:prstGeom prst="rect">
+            <a:avLst/>
+          </a:prstGeom>
+          <a:noFill/>
+          <a:ln/>
+        </p:spPr>
+        <p:txBody>
+          <a:bodyPr wrap="square" lIns="0" tIns="0" rIns="0" bIns="0" rtlCol="0" anchor="ctr"/>
+          <a:lstStyle/>
+          <a:p>
+            <a:pPr indent="0" marL="0">
+              <a:buNone/>
+            </a:pPr>
+            <a:r>
+              <a:rPr lang="en-US" sz="1150" b="1" dirty="0">
+                <a:solidFill>
+                  <a:schemeClr val="accent1"/>
+                </a:solidFill>
+                <a:latin typeface="Courier New" pitchFamily="34" charset="0"/>
+                <a:ea typeface="Courier New" pitchFamily="34" charset="-122"/>
+                <a:cs typeface="Courier New" pitchFamily="34" charset="-120"/>
+              </a:rPr>
               <a:t>09 ABR 2025   </a:t>
             </a:r>
             <a:pPr indent="0" marL="0">
@@ -10204,13 +10430,13 @@
       </p:sp>
       <p:sp>
         <p:nvSpPr>
-          <p:cNvPr id="32" name="Hito detalle 7"/>
-          <p:cNvSpPr txBox="1"/>
-          <p:nvPr/>
-        </p:nvSpPr>
-        <p:spPr>
-          <a:xfrm>
-            <a:off x="1965960" y="5998464"/>
+          <p:cNvPr id="35" name="Hito detalle 8"/>
+          <p:cNvSpPr txBox="1"/>
+          <p:nvPr/>
+        </p:nvSpPr>
+        <p:spPr>
+          <a:xfrm>
+            <a:off x="1965960" y="6094476"/>
             <a:ext cx="4572000" cy="228600"/>
           </a:xfrm>
           <a:prstGeom prst="rect">
@@ -10240,7 +10466,7 @@
       </p:sp>
       <p:sp>
         <p:nvSpPr>
-          <p:cNvPr id="33" name="Detalle 2026"/>
+          <p:cNvPr id="36" name="Detalle 2026"/>
           <p:cNvSpPr/>
           <p:nvPr/>
         </p:nvSpPr>
@@ -10271,7 +10497,7 @@
       </p:sp>
       <p:sp>
         <p:nvSpPr>
-          <p:cNvPr id="34" name="Detalle 2026 título"/>
+          <p:cNvPr id="37" name="Detalle 2026 título"/>
           <p:cNvSpPr txBox="1"/>
           <p:nvPr/>
         </p:nvSpPr>
@@ -10307,7 +10533,7 @@
       </p:sp>
       <p:sp>
         <p:nvSpPr>
-          <p:cNvPr id="35" name="Detalle 2026 texto"/>
+          <p:cNvPr id="38" name="Detalle 2026 texto"/>
           <p:cNvSpPr txBox="1"/>
           <p:nvPr/>
         </p:nvSpPr>
@@ -10391,7 +10617,7 @@
       </p:sp>
       <p:sp>
         <p:nvSpPr>
-          <p:cNvPr id="36" name="Detalle 2025"/>
+          <p:cNvPr id="39" name="Detalle 2025"/>
           <p:cNvSpPr/>
           <p:nvPr/>
         </p:nvSpPr>
@@ -10422,7 +10648,7 @@
       </p:sp>
       <p:sp>
         <p:nvSpPr>
-          <p:cNvPr id="37" name="Detalle 2025 título"/>
+          <p:cNvPr id="40" name="Detalle 2025 título"/>
           <p:cNvSpPr txBox="1"/>
           <p:nvPr/>
         </p:nvSpPr>
@@ -10458,7 +10684,7 @@
       </p:sp>
       <p:sp>
         <p:nvSpPr>
-          <p:cNvPr id="38" name="Detalle 2025 texto"/>
+          <p:cNvPr id="41" name="Detalle 2025 texto"/>
           <p:cNvSpPr txBox="1"/>
           <p:nvPr/>
         </p:nvSpPr>
@@ -10534,7 +10760,7 @@
       </p:sp>
       <p:sp>
         <p:nvSpPr>
-          <p:cNvPr id="39" name="Evolución título"/>
+          <p:cNvPr id="42" name="Evolución título"/>
           <p:cNvSpPr txBox="1"/>
           <p:nvPr/>
         </p:nvSpPr>
@@ -10570,7 +10796,7 @@
       </p:sp>
       <p:sp>
         <p:nvSpPr>
-          <p:cNvPr id="40" name="Evolución 1"/>
+          <p:cNvPr id="43" name="Evolución 1"/>
           <p:cNvSpPr/>
           <p:nvPr/>
         </p:nvSpPr>
@@ -10601,7 +10827,7 @@
       </p:sp>
       <p:sp>
         <p:nvSpPr>
-          <p:cNvPr id="41" name="Evolución estado 1 fondo"/>
+          <p:cNvPr id="44" name="Evolución estado 1 fondo"/>
           <p:cNvSpPr/>
           <p:nvPr/>
         </p:nvSpPr>
@@ -10630,7 +10856,7 @@
       </p:sp>
       <p:sp>
         <p:nvSpPr>
-          <p:cNvPr id="42" name="Evolución estado 1"/>
+          <p:cNvPr id="45" name="Evolución estado 1"/>
           <p:cNvSpPr txBox="1"/>
           <p:nvPr/>
         </p:nvSpPr>
@@ -10666,7 +10892,7 @@
       </p:sp>
       <p:sp>
         <p:nvSpPr>
-          <p:cNvPr id="43" name="Evolución tema 1"/>
+          <p:cNvPr id="46" name="Evolución tema 1"/>
           <p:cNvSpPr txBox="1"/>
           <p:nvPr/>
         </p:nvSpPr>
@@ -10702,7 +10928,7 @@
       </p:sp>
       <p:sp>
         <p:nvSpPr>
-          <p:cNvPr id="44" name="Evolución detalle 1"/>
+          <p:cNvPr id="47" name="Evolución detalle 1"/>
           <p:cNvSpPr txBox="1"/>
           <p:nvPr/>
         </p:nvSpPr>
@@ -10738,7 +10964,7 @@
       </p:sp>
       <p:sp>
         <p:nvSpPr>
-          <p:cNvPr id="45" name="Evolución 2"/>
+          <p:cNvPr id="48" name="Evolución 2"/>
           <p:cNvSpPr/>
           <p:nvPr/>
         </p:nvSpPr>
@@ -10769,7 +10995,7 @@
       </p:sp>
       <p:sp>
         <p:nvSpPr>
-          <p:cNvPr id="46" name="Evolución estado 2 fondo"/>
+          <p:cNvPr id="49" name="Evolución estado 2 fondo"/>
           <p:cNvSpPr/>
           <p:nvPr/>
         </p:nvSpPr>
@@ -10798,7 +11024,7 @@
       </p:sp>
       <p:sp>
         <p:nvSpPr>
-          <p:cNvPr id="47" name="Evolución estado 2"/>
+          <p:cNvPr id="50" name="Evolución estado 2"/>
           <p:cNvSpPr txBox="1"/>
           <p:nvPr/>
         </p:nvSpPr>
@@ -10834,7 +11060,7 @@
       </p:sp>
       <p:sp>
         <p:nvSpPr>
-          <p:cNvPr id="48" name="Evolución tema 2"/>
+          <p:cNvPr id="51" name="Evolución tema 2"/>
           <p:cNvSpPr txBox="1"/>
           <p:nvPr/>
         </p:nvSpPr>
@@ -10870,7 +11096,7 @@
       </p:sp>
       <p:sp>
         <p:nvSpPr>
-          <p:cNvPr id="49" name="Evolución detalle 2"/>
+          <p:cNvPr id="52" name="Evolución detalle 2"/>
           <p:cNvSpPr txBox="1"/>
           <p:nvPr/>
         </p:nvSpPr>
@@ -10906,7 +11132,7 @@
       </p:sp>
       <p:sp>
         <p:nvSpPr>
-          <p:cNvPr id="50" name="Evolución 3"/>
+          <p:cNvPr id="53" name="Evolución 3"/>
           <p:cNvSpPr/>
           <p:nvPr/>
         </p:nvSpPr>
@@ -10937,7 +11163,7 @@
       </p:sp>
       <p:sp>
         <p:nvSpPr>
-          <p:cNvPr id="51" name="Evolución estado 3 fondo"/>
+          <p:cNvPr id="54" name="Evolución estado 3 fondo"/>
           <p:cNvSpPr/>
           <p:nvPr/>
         </p:nvSpPr>
@@ -10966,7 +11192,7 @@
       </p:sp>
       <p:sp>
         <p:nvSpPr>
-          <p:cNvPr id="52" name="Evolución estado 3"/>
+          <p:cNvPr id="55" name="Evolución estado 3"/>
           <p:cNvSpPr txBox="1"/>
           <p:nvPr/>
         </p:nvSpPr>
@@ -11002,7 +11228,7 @@
       </p:sp>
       <p:sp>
         <p:nvSpPr>
-          <p:cNvPr id="53" name="Evolución tema 3"/>
+          <p:cNvPr id="56" name="Evolución tema 3"/>
           <p:cNvSpPr txBox="1"/>
           <p:nvPr/>
         </p:nvSpPr>
@@ -11038,7 +11264,7 @@
       </p:sp>
       <p:sp>
         <p:nvSpPr>
-          <p:cNvPr id="54" name="Evolución detalle 3"/>
+          <p:cNvPr id="57" name="Evolución detalle 3"/>
           <p:cNvSpPr txBox="1"/>
           <p:nvPr/>
         </p:nvSpPr>

</xml_diff>

<commit_message>
Remove timeline slide from the deck
Co-Authored-By: Claude Opus 5.5 <noreply@anthropic.com>
Claude-Session: https://claude.ai/code/session_01F1WXR13Nv8neEtLhaK3ELa
</commit_message>
<xml_diff>
--- a/supervision-gobierno-corporativo/Supervision_GC_SSF_COMEDICA_2025-2026.pptx
+++ b/supervision-gobierno-corporativo/Supervision_GC_SSF_COMEDICA_2025-2026.pptx
@@ -8,10 +8,9 @@
     <p:sldId id="256" r:id="rId2"/>
     <p:sldId id="257" r:id="rId3"/>
     <p:sldId id="258" r:id="rId4"/>
-    <p:sldId id="259" r:id="rId5"/>
   </p:sldIdLst>
   <p:notesMasterIdLst>
-    <p:notesMasterId r:id="rId6"/>
+    <p:notesMasterId r:id="rId5"/>
   </p:notesMasterIdLst>
   <p:sldSz cx="12192000" cy="6858000"/>
   <p:notesSz cx="6858000" cy="12192000"/>
@@ -110,24 +109,19 @@
   <p:extLst>
     <p:ext uri="{521415D9-36F7-43E2-AB2F-B90AF26B5E84}">
       <p14:sectionLst xmlns:p14="http://schemas.microsoft.com/office/powerpoint/2010/main">
-        <p14:section name="1 · Resumen de circulares SSF" id="{cd644b79-7029-ba89-e5ea-7a004caeb1d1}">
+        <p14:section name="1 · Resumen de circulares SSF" id="{5a24ffc2-a8e0-049f-ecc0-09267bc56beb}">
           <p14:sldIdLst>
             <p14:sldId id="256"/>
           </p14:sldIdLst>
         </p14:section>
-        <p14:section name="2 · Observaciones 2025" id="{47cc28b4-e155-0e32-ba32-07f05acc5604}">
+        <p14:section name="2 · Observaciones 2025" id="{700b8b80-88a2-9551-c054-5356091811fc}">
           <p14:sldIdLst>
             <p14:sldId id="257"/>
           </p14:sldIdLst>
         </p14:section>
-        <p14:section name="3 · Observaciones 2026" id="{ed885da7-e1e1-0cd8-2619-7ac6fb5c8e67}">
+        <p14:section name="3 · Observaciones 2026" id="{5f3d3702-92cf-fc86-202d-2e81c8a6ea34}">
           <p14:sldIdLst>
             <p14:sldId id="258"/>
-          </p14:sldIdLst>
-        </p14:section>
-        <p14:section name="4 · Línea de tiempo y evolución" id="{58fbf1f1-8a0d-6b19-fa7c-7d21a3e47fa0}">
-          <p14:sldIdLst>
-            <p14:sldId id="259"/>
           </p14:sldIdLst>
         </p14:section>
       </p14:sectionLst>
@@ -734,94 +728,6 @@
             <a:fld id="{F7021451-1387-4CA6-816F-3879F97B5CBC}" type="slidenum">
               <a:rPr lang="en-US"/>
               <a:t>3</a:t>
-            </a:fld>
-            <a:endParaRPr lang="en-US"/>
-          </a:p>
-        </p:txBody>
-      </p:sp>
-    </p:spTree>
-    <p:extLst>
-      <p:ext uri="{BB962C8B-B14F-4D97-AF65-F5344CB8AC3E}">
-        <p14:creationId xmlns:p14="http://schemas.microsoft.com/office/powerpoint/2010/main" val="1024086991"/>
-      </p:ext>
-    </p:extLst>
-  </p:cSld>
-  <p:clrMapOvr>
-    <a:masterClrMapping/>
-  </p:clrMapOvr>
-</p:notes>
-</file>
-
-<file path=ppt/notesSlides/notesSlide4.xml><?xml version="1.0" encoding="utf-8"?>
-<p:notes xmlns:a="http://schemas.openxmlformats.org/drawingml/2006/main" xmlns:r="http://schemas.openxmlformats.org/officeDocument/2006/relationships" xmlns:p="http://schemas.openxmlformats.org/presentationml/2006/main">
-  <p:cSld>
-    <p:spTree>
-      <p:nvGrpSpPr>
-        <p:cNvPr id="1" name=""/>
-        <p:cNvGrpSpPr/>
-        <p:nvPr/>
-      </p:nvGrpSpPr>
-      <p:grpSpPr>
-        <a:xfrm>
-          <a:off x="0" y="0"/>
-          <a:ext cx="0" cy="0"/>
-          <a:chOff x="0" y="0"/>
-          <a:chExt cx="0" cy="0"/>
-        </a:xfrm>
-      </p:grpSpPr>
-      <p:sp>
-        <p:nvSpPr>
-          <p:cNvPr id="2" name="Slide Image Placeholder 1"/>
-          <p:cNvSpPr>
-            <a:spLocks noGrp="1" noRot="1" noChangeAspect="1"/>
-          </p:cNvSpPr>
-          <p:nvPr>
-            <p:ph type="sldImg"/>
-          </p:nvPr>
-        </p:nvSpPr>
-        <p:spPr/>
-      </p:sp>
-      <p:sp>
-        <p:nvSpPr>
-          <p:cNvPr id="3" name="Notes Placeholder 2"/>
-          <p:cNvSpPr>
-            <a:spLocks noGrp="1"/>
-          </p:cNvSpPr>
-          <p:nvPr>
-            <p:ph type="body" idx="1"/>
-          </p:nvPr>
-        </p:nvSpPr>
-        <p:spPr/>
-        <p:txBody>
-          <a:bodyPr/>
-          <a:lstStyle/>
-          <a:p>
-            <a:r>
-              <a:rPr lang="en-US" dirty="0"/>
-              <a:t>La línea de tiempo se lee de arriba hacia abajo, de lo más reciente a lo más antiguo. Hoy corren los plazos: 10 días hábiles para descargos del Anexo A (aprox. 23/10/2026) y 15 días hábiles para el plan de solución del Anexo B (aprox. 30/10/2026). 2026: nombramiento 31/07, inicio 21/08 e informe preliminar 09/10 con 7 observaciones nuevas y seguimiento a las obs. 3 y 5 de 2025. 2025: nombramiento 09/04, inicio 19/05 e informe preliminar 05/11 con 9 observaciones. Seguimiento: obs. 3 no superada; obs. 5 parcialmente superada. El Fondo de Educación vuelve como tema, pero con observaciones nuevas.</a:t>
-            </a:r>
-            <a:endParaRPr lang="en-US" dirty="0"/>
-          </a:p>
-        </p:txBody>
-      </p:sp>
-      <p:sp>
-        <p:nvSpPr>
-          <p:cNvPr id="4" name="Slide Number Placeholder 3"/>
-          <p:cNvSpPr>
-            <a:spLocks noGrp="1"/>
-          </p:cNvSpPr>
-          <p:nvPr>
-            <p:ph type="sldNum" sz="quarter" idx="10"/>
-          </p:nvPr>
-        </p:nvSpPr>
-        <p:spPr/>
-        <p:txBody>
-          <a:bodyPr/>
-          <a:lstStyle/>
-          <a:p>
-            <a:fld id="{F7021451-1387-4CA6-816F-3879F97B5CBC}" type="slidenum">
-              <a:rPr lang="en-US"/>
-              <a:t>4</a:t>
             </a:fld>
             <a:endParaRPr lang="en-US"/>
           </a:p>
@@ -9244,2100 +9150,6 @@
             <a:fld id="{F7021451-1387-4CA6-816F-3879F97B5CBC}" type="slidenum">
               <a:rPr b="0" lang="en-US"/>
               <a:t>3</a:t>
-            </a:fld>
-            <a:endParaRPr lang="en-US"/>
-          </a:p>
-        </p:txBody>
-      </p:sp>
-    </p:spTree>
-  </p:cSld>
-  <p:clrMapOvr>
-    <a:masterClrMapping/>
-  </p:clrMapOvr>
-</p:sld>
-</file>
-
-<file path=ppt/slides/slide4.xml><?xml version="1.0" encoding="utf-8"?>
-<p:sld xmlns:a="http://schemas.openxmlformats.org/drawingml/2006/main" xmlns:r="http://schemas.openxmlformats.org/officeDocument/2006/relationships" xmlns:p="http://schemas.openxmlformats.org/presentationml/2006/main">
-  <p:cSld name="Slide 4">
-    <p:spTree>
-      <p:nvGrpSpPr>
-        <p:cNvPr id="1" name=""/>
-        <p:cNvGrpSpPr/>
-        <p:nvPr/>
-      </p:nvGrpSpPr>
-      <p:grpSpPr>
-        <a:xfrm>
-          <a:off x="0" y="0"/>
-          <a:ext cx="0" cy="0"/>
-          <a:chOff x="0" y="0"/>
-          <a:chExt cx="0" cy="0"/>
-        </a:xfrm>
-      </p:grpSpPr>
-      <p:sp>
-        <p:nvSpPr>
-          <p:cNvPr id="2" name="Text 0"/>
-          <p:cNvSpPr/>
-          <p:nvPr>
-            <p:ph idx="100" type="body" hasCustomPrompt="1"/>
-          </p:nvPr>
-        </p:nvSpPr>
-        <p:spPr>
-          <a:xfrm>
-            <a:off x="548640" y="320040"/>
-            <a:ext cx="8229600" cy="274320"/>
-          </a:xfrm>
-          <a:prstGeom prst="rect">
-            <a:avLst/>
-          </a:prstGeom>
-          <a:noFill/>
-          <a:ln/>
-        </p:spPr>
-        <p:txBody>
-          <a:bodyPr wrap="square" lIns="0" tIns="0" rIns="0" bIns="0" rtlCol="0"/>
-          <a:lstStyle/>
-          <a:p>
-            <a:pPr indent="0" marL="0">
-              <a:buNone/>
-            </a:pPr>
-            <a:r>
-              <a:rPr lang="en-US" sz="1100" b="1" spc="200" kern="0" dirty="0">
-                <a:solidFill>
-                  <a:schemeClr val="accent5"/>
-                </a:solidFill>
-              </a:rPr>
-              <a:t>LÍNEA DE TIEMPO COMPARATIVA Y EVOLUCIÓN DEL CUMPLIMIENTO</a:t>
-            </a:r>
-            <a:endParaRPr lang="en-US" sz="1100" dirty="0"/>
-          </a:p>
-        </p:txBody>
-      </p:sp>
-      <p:sp>
-        <p:nvSpPr>
-          <p:cNvPr id="3" name="Text 0"/>
-          <p:cNvSpPr/>
-          <p:nvPr>
-            <p:ph idx="101" type="title" hasCustomPrompt="1"/>
-          </p:nvPr>
-        </p:nvSpPr>
-        <p:spPr>
-          <a:xfrm>
-            <a:off x="548640" y="594360"/>
-            <a:ext cx="7863840" cy="640080"/>
-          </a:xfrm>
-          <a:prstGeom prst="rect">
-            <a:avLst/>
-          </a:prstGeom>
-          <a:noFill/>
-          <a:ln/>
-        </p:spPr>
-        <p:txBody>
-          <a:bodyPr wrap="square" lIns="0" tIns="0" rIns="0" bIns="0" rtlCol="0" anchor="t"/>
-          <a:lstStyle/>
-          <a:p>
-            <a:pPr algn="l" indent="0" marL="0">
-              <a:buNone/>
-            </a:pPr>
-            <a:r>
-              <a:rPr lang="en-US" sz="3000" b="1" dirty="0">
-                <a:solidFill>
-                  <a:schemeClr val="tx1"/>
-                </a:solidFill>
-                <a:latin typeface="Cambria" pitchFamily="34" charset="0"/>
-                <a:ea typeface="Cambria" pitchFamily="34" charset="-122"/>
-                <a:cs typeface="Cambria" pitchFamily="34" charset="-120"/>
-              </a:rPr>
-              <a:t>Línea de tiempo: de hoy a 2025</a:t>
-            </a:r>
-            <a:endParaRPr lang="en-US" sz="3000" dirty="0"/>
-          </a:p>
-        </p:txBody>
-      </p:sp>
-      <p:sp>
-        <p:nvSpPr>
-          <p:cNvPr id="4" name="Eje 2026"/>
-          <p:cNvSpPr/>
-          <p:nvPr/>
-        </p:nvSpPr>
-        <p:spPr>
-          <a:xfrm>
-            <a:off x="1645920" y="1444752"/>
-            <a:ext cx="0" cy="1796796"/>
-          </a:xfrm>
-          <a:prstGeom prst="line">
-            <a:avLst/>
-          </a:prstGeom>
-          <a:noFill/>
-          <a:ln w="38100">
-            <a:solidFill>
-              <a:schemeClr val="accent2"/>
-            </a:solidFill>
-            <a:prstDash val="solid"/>
-          </a:ln>
-        </p:spPr>
-      </p:sp>
-      <p:sp>
-        <p:nvSpPr>
-          <p:cNvPr id="5" name="Pausa entre visitas"/>
-          <p:cNvSpPr/>
-          <p:nvPr/>
-        </p:nvSpPr>
-        <p:spPr>
-          <a:xfrm>
-            <a:off x="1645920" y="3424428"/>
-            <a:ext cx="0" cy="416052"/>
-          </a:xfrm>
-          <a:prstGeom prst="line">
-            <a:avLst/>
-          </a:prstGeom>
-          <a:noFill/>
-          <a:ln w="19050">
-            <a:solidFill>
-              <a:schemeClr val="accent5"/>
-            </a:solidFill>
-            <a:prstDash val="dash"/>
-          </a:ln>
-        </p:spPr>
-      </p:sp>
-      <p:sp>
-        <p:nvSpPr>
-          <p:cNvPr id="6" name="Eje 2025"/>
-          <p:cNvSpPr/>
-          <p:nvPr/>
-        </p:nvSpPr>
-        <p:spPr>
-          <a:xfrm>
-            <a:off x="1645920" y="4023360"/>
-            <a:ext cx="0" cy="1796796"/>
-          </a:xfrm>
-          <a:prstGeom prst="line">
-            <a:avLst/>
-          </a:prstGeom>
-          <a:noFill/>
-          <a:ln w="38100">
-            <a:solidFill>
-              <a:schemeClr val="accent1"/>
-            </a:solidFill>
-            <a:prstDash val="solid"/>
-          </a:ln>
-        </p:spPr>
-      </p:sp>
-      <p:sp>
-        <p:nvSpPr>
-          <p:cNvPr id="7" name="Año 2026 fondo"/>
-          <p:cNvSpPr/>
-          <p:nvPr/>
-        </p:nvSpPr>
-        <p:spPr>
-          <a:xfrm>
-            <a:off x="548640" y="1408176"/>
-            <a:ext cx="777240" cy="274320"/>
-          </a:xfrm>
-          <a:prstGeom prst="roundRect">
-            <a:avLst>
-              <a:gd name="adj" fmla="val 50000"/>
-            </a:avLst>
-          </a:prstGeom>
-          <a:solidFill>
-            <a:schemeClr val="accent2"/>
-          </a:solidFill>
-          <a:ln w="12700">
-            <a:solidFill>
-              <a:schemeClr val="accent2">
-                <a:alpha val="0"/>
-              </a:schemeClr>
-            </a:solidFill>
-            <a:prstDash val="solid"/>
-          </a:ln>
-        </p:spPr>
-      </p:sp>
-      <p:sp>
-        <p:nvSpPr>
-          <p:cNvPr id="8" name="Año 2026"/>
-          <p:cNvSpPr txBox="1"/>
-          <p:nvPr/>
-        </p:nvSpPr>
-        <p:spPr>
-          <a:xfrm>
-            <a:off x="548640" y="1408176"/>
-            <a:ext cx="777240" cy="274320"/>
-          </a:xfrm>
-          <a:prstGeom prst="rect">
-            <a:avLst/>
-          </a:prstGeom>
-          <a:noFill/>
-          <a:ln/>
-        </p:spPr>
-        <p:txBody>
-          <a:bodyPr wrap="square" lIns="0" tIns="0" rIns="0" bIns="0" rtlCol="0" anchor="ctr"/>
-          <a:lstStyle/>
-          <a:p>
-            <a:pPr algn="ctr" indent="0" marL="0">
-              <a:buNone/>
-            </a:pPr>
-            <a:r>
-              <a:rPr lang="en-US" sz="1100" b="1" spc="100" kern="0" dirty="0">
-                <a:solidFill>
-                  <a:schemeClr val="bg1"/>
-                </a:solidFill>
-              </a:rPr>
-              <a:t>2026</a:t>
-            </a:r>
-            <a:endParaRPr lang="en-US" sz="1100" dirty="0"/>
-          </a:p>
-        </p:txBody>
-      </p:sp>
-      <p:sp>
-        <p:nvSpPr>
-          <p:cNvPr id="9" name="Año 2025 fondo"/>
-          <p:cNvSpPr/>
-          <p:nvPr/>
-        </p:nvSpPr>
-        <p:spPr>
-          <a:xfrm>
-            <a:off x="548640" y="3986784"/>
-            <a:ext cx="777240" cy="274320"/>
-          </a:xfrm>
-          <a:prstGeom prst="roundRect">
-            <a:avLst>
-              <a:gd name="adj" fmla="val 50000"/>
-            </a:avLst>
-          </a:prstGeom>
-          <a:solidFill>
-            <a:schemeClr val="accent1"/>
-          </a:solidFill>
-          <a:ln w="12700">
-            <a:solidFill>
-              <a:schemeClr val="accent1">
-                <a:alpha val="0"/>
-              </a:schemeClr>
-            </a:solidFill>
-            <a:prstDash val="solid"/>
-          </a:ln>
-        </p:spPr>
-      </p:sp>
-      <p:sp>
-        <p:nvSpPr>
-          <p:cNvPr id="10" name="Año 2025"/>
-          <p:cNvSpPr txBox="1"/>
-          <p:nvPr/>
-        </p:nvSpPr>
-        <p:spPr>
-          <a:xfrm>
-            <a:off x="548640" y="3986784"/>
-            <a:ext cx="777240" cy="274320"/>
-          </a:xfrm>
-          <a:prstGeom prst="rect">
-            <a:avLst/>
-          </a:prstGeom>
-          <a:noFill/>
-          <a:ln/>
-        </p:spPr>
-        <p:txBody>
-          <a:bodyPr wrap="square" lIns="0" tIns="0" rIns="0" bIns="0" rtlCol="0" anchor="ctr"/>
-          <a:lstStyle/>
-          <a:p>
-            <a:pPr algn="ctr" indent="0" marL="0">
-              <a:buNone/>
-            </a:pPr>
-            <a:r>
-              <a:rPr lang="en-US" sz="1100" b="1" spc="100" kern="0" dirty="0">
-                <a:solidFill>
-                  <a:schemeClr val="bg1"/>
-                </a:solidFill>
-              </a:rPr>
-              <a:t>2025</a:t>
-            </a:r>
-            <a:endParaRPr lang="en-US" sz="1100" dirty="0"/>
-          </a:p>
-        </p:txBody>
-      </p:sp>
-      <p:sp>
-        <p:nvSpPr>
-          <p:cNvPr id="11" name="Pausa texto"/>
-          <p:cNvSpPr txBox="1"/>
-          <p:nvPr/>
-        </p:nvSpPr>
-        <p:spPr>
-          <a:xfrm>
-            <a:off x="502920" y="3541014"/>
-            <a:ext cx="914400" cy="201168"/>
-          </a:xfrm>
-          <a:prstGeom prst="rect">
-            <a:avLst/>
-          </a:prstGeom>
-          <a:noFill/>
-          <a:ln/>
-        </p:spPr>
-        <p:txBody>
-          <a:bodyPr wrap="square" lIns="0" tIns="0" rIns="0" bIns="0" rtlCol="0" anchor="t"/>
-          <a:lstStyle/>
-          <a:p>
-            <a:pPr algn="ctr" indent="0" marL="0">
-              <a:buNone/>
-            </a:pPr>
-            <a:r>
-              <a:rPr lang="en-US" sz="1000" i="1" dirty="0">
-                <a:solidFill>
-                  <a:schemeClr val="accent5"/>
-                </a:solidFill>
-              </a:rPr>
-              <a:t>8 meses</a:t>
-            </a:r>
-            <a:endParaRPr lang="en-US" sz="1000" dirty="0"/>
-          </a:p>
-        </p:txBody>
-      </p:sp>
-      <p:sp>
-        <p:nvSpPr>
-          <p:cNvPr id="12" name="Fondo hoy"/>
-          <p:cNvSpPr/>
-          <p:nvPr/>
-        </p:nvSpPr>
-        <p:spPr>
-          <a:xfrm>
-            <a:off x="1856232" y="1353312"/>
-            <a:ext cx="4754880" cy="544068"/>
-          </a:xfrm>
-          <a:prstGeom prst="roundRect">
-            <a:avLst>
-              <a:gd name="adj" fmla="val 16807"/>
-            </a:avLst>
-          </a:prstGeom>
-          <a:solidFill>
-            <a:schemeClr val="accent2">
-              <a:alpha val="15000"/>
-            </a:schemeClr>
-          </a:solidFill>
-          <a:ln w="12700">
-            <a:solidFill>
-              <a:schemeClr val="accent2">
-                <a:alpha val="0"/>
-              </a:schemeClr>
-            </a:solidFill>
-            <a:prstDash val="solid"/>
-          </a:ln>
-        </p:spPr>
-      </p:sp>
-      <p:sp>
-        <p:nvSpPr>
-          <p:cNvPr id="13" name="Halo hoy"/>
-          <p:cNvSpPr/>
-          <p:nvPr/>
-        </p:nvSpPr>
-        <p:spPr>
-          <a:xfrm>
-            <a:off x="1463040" y="1408176"/>
-            <a:ext cx="365760" cy="365760"/>
-          </a:xfrm>
-          <a:prstGeom prst="ellipse">
-            <a:avLst/>
-          </a:prstGeom>
-          <a:solidFill>
-            <a:schemeClr val="accent2">
-              <a:alpha val="30000"/>
-            </a:schemeClr>
-          </a:solidFill>
-          <a:ln w="12700">
-            <a:solidFill>
-              <a:schemeClr val="accent2">
-                <a:alpha val="0"/>
-              </a:schemeClr>
-            </a:solidFill>
-            <a:prstDash val="solid"/>
-          </a:ln>
-        </p:spPr>
-      </p:sp>
-      <p:sp>
-        <p:nvSpPr>
-          <p:cNvPr id="14" name="Hito 1"/>
-          <p:cNvSpPr/>
-          <p:nvPr/>
-        </p:nvSpPr>
-        <p:spPr>
-          <a:xfrm>
-            <a:off x="1536192" y="1481328"/>
-            <a:ext cx="219456" cy="219456"/>
-          </a:xfrm>
-          <a:prstGeom prst="ellipse">
-            <a:avLst/>
-          </a:prstGeom>
-          <a:solidFill>
-            <a:schemeClr val="accent2"/>
-          </a:solidFill>
-          <a:ln w="31750">
-            <a:solidFill>
-              <a:schemeClr val="accent2"/>
-            </a:solidFill>
-            <a:prstDash val="solid"/>
-          </a:ln>
-        </p:spPr>
-      </p:sp>
-      <p:sp>
-        <p:nvSpPr>
-          <p:cNvPr id="15" name="Hito fecha 1"/>
-          <p:cNvSpPr txBox="1"/>
-          <p:nvPr/>
-        </p:nvSpPr>
-        <p:spPr>
-          <a:xfrm>
-            <a:off x="1965960" y="1444752"/>
-            <a:ext cx="4572000" cy="274320"/>
-          </a:xfrm>
-          <a:prstGeom prst="rect">
-            <a:avLst/>
-          </a:prstGeom>
-          <a:noFill/>
-          <a:ln/>
-        </p:spPr>
-        <p:txBody>
-          <a:bodyPr wrap="square" lIns="0" tIns="0" rIns="0" bIns="0" rtlCol="0" anchor="ctr"/>
-          <a:lstStyle/>
-          <a:p>
-            <a:pPr indent="0" marL="0">
-              <a:buNone/>
-            </a:pPr>
-            <a:r>
-              <a:rPr lang="en-US" sz="1150" b="1" dirty="0">
-                <a:solidFill>
-                  <a:schemeClr val="accent2"/>
-                </a:solidFill>
-                <a:latin typeface="Courier New" pitchFamily="34" charset="0"/>
-                <a:ea typeface="Courier New" pitchFamily="34" charset="-122"/>
-                <a:cs typeface="Courier New" pitchFamily="34" charset="-120"/>
-              </a:rPr>
-              <a:t>HOY   </a:t>
-            </a:r>
-            <a:pPr indent="0" marL="0">
-              <a:buNone/>
-            </a:pPr>
-            <a:r>
-              <a:rPr lang="en-US" sz="1250" b="1" dirty="0">
-                <a:solidFill>
-                  <a:schemeClr val="tx1"/>
-                </a:solidFill>
-              </a:rPr>
-              <a:t>Plazos de respuesta en curso</a:t>
-            </a:r>
-            <a:endParaRPr lang="en-US" sz="1400" dirty="0"/>
-          </a:p>
-        </p:txBody>
-      </p:sp>
-      <p:sp>
-        <p:nvSpPr>
-          <p:cNvPr id="16" name="Hito detalle 1"/>
-          <p:cNvSpPr txBox="1"/>
-          <p:nvPr/>
-        </p:nvSpPr>
-        <p:spPr>
-          <a:xfrm>
-            <a:off x="1965960" y="1719072"/>
-            <a:ext cx="4572000" cy="228600"/>
-          </a:xfrm>
-          <a:prstGeom prst="rect">
-            <a:avLst/>
-          </a:prstGeom>
-          <a:noFill/>
-          <a:ln/>
-        </p:spPr>
-        <p:txBody>
-          <a:bodyPr wrap="square" lIns="0" tIns="0" rIns="0" bIns="0" rtlCol="0" anchor="t"/>
-          <a:lstStyle/>
-          <a:p>
-            <a:pPr indent="0" marL="0">
-              <a:buNone/>
-            </a:pPr>
-            <a:r>
-              <a:rPr lang="en-US" sz="1050" dirty="0">
-                <a:solidFill>
-                  <a:schemeClr val="accent5"/>
-                </a:solidFill>
-              </a:rPr>
-              <a:t>Descargos 10 días hábiles (≈23/10) · Plan de solución 15 días hábiles (≈30/10)</a:t>
-            </a:r>
-            <a:endParaRPr lang="en-US" sz="1050" dirty="0"/>
-          </a:p>
-        </p:txBody>
-      </p:sp>
-      <p:sp>
-        <p:nvSpPr>
-          <p:cNvPr id="17" name="Hito 2"/>
-          <p:cNvSpPr/>
-          <p:nvPr/>
-        </p:nvSpPr>
-        <p:spPr>
-          <a:xfrm>
-            <a:off x="1536192" y="2080260"/>
-            <a:ext cx="219456" cy="219456"/>
-          </a:xfrm>
-          <a:prstGeom prst="ellipse">
-            <a:avLst/>
-          </a:prstGeom>
-          <a:solidFill>
-            <a:schemeClr val="bg1"/>
-          </a:solidFill>
-          <a:ln w="31750">
-            <a:solidFill>
-              <a:schemeClr val="accent2"/>
-            </a:solidFill>
-            <a:prstDash val="solid"/>
-          </a:ln>
-        </p:spPr>
-      </p:sp>
-      <p:sp>
-        <p:nvSpPr>
-          <p:cNvPr id="18" name="Hito fecha 2"/>
-          <p:cNvSpPr txBox="1"/>
-          <p:nvPr/>
-        </p:nvSpPr>
-        <p:spPr>
-          <a:xfrm>
-            <a:off x="1965960" y="2043684"/>
-            <a:ext cx="4572000" cy="274320"/>
-          </a:xfrm>
-          <a:prstGeom prst="rect">
-            <a:avLst/>
-          </a:prstGeom>
-          <a:noFill/>
-          <a:ln/>
-        </p:spPr>
-        <p:txBody>
-          <a:bodyPr wrap="square" lIns="0" tIns="0" rIns="0" bIns="0" rtlCol="0" anchor="ctr"/>
-          <a:lstStyle/>
-          <a:p>
-            <a:pPr indent="0" marL="0">
-              <a:buNone/>
-            </a:pPr>
-            <a:r>
-              <a:rPr lang="en-US" sz="1150" b="1" dirty="0">
-                <a:solidFill>
-                  <a:schemeClr val="accent2"/>
-                </a:solidFill>
-                <a:latin typeface="Courier New" pitchFamily="34" charset="0"/>
-                <a:ea typeface="Courier New" pitchFamily="34" charset="-122"/>
-                <a:cs typeface="Courier New" pitchFamily="34" charset="-120"/>
-              </a:rPr>
-              <a:t>09 OCT 2026   </a:t>
-            </a:r>
-            <a:pPr indent="0" marL="0">
-              <a:buNone/>
-            </a:pPr>
-            <a:r>
-              <a:rPr lang="en-US" sz="1250" b="1" dirty="0">
-                <a:solidFill>
-                  <a:schemeClr val="tx1"/>
-                </a:solidFill>
-              </a:rPr>
-              <a:t>Informe preliminar · Circular 22741</a:t>
-            </a:r>
-            <a:endParaRPr lang="en-US" sz="1400" dirty="0"/>
-          </a:p>
-        </p:txBody>
-      </p:sp>
-      <p:sp>
-        <p:nvSpPr>
-          <p:cNvPr id="19" name="Hito detalle 2"/>
-          <p:cNvSpPr txBox="1"/>
-          <p:nvPr/>
-        </p:nvSpPr>
-        <p:spPr>
-          <a:xfrm>
-            <a:off x="1965960" y="2318004"/>
-            <a:ext cx="4572000" cy="228600"/>
-          </a:xfrm>
-          <a:prstGeom prst="rect">
-            <a:avLst/>
-          </a:prstGeom>
-          <a:noFill/>
-          <a:ln/>
-        </p:spPr>
-        <p:txBody>
-          <a:bodyPr wrap="square" lIns="0" tIns="0" rIns="0" bIns="0" rtlCol="0" anchor="t"/>
-          <a:lstStyle/>
-          <a:p>
-            <a:pPr indent="0" marL="0">
-              <a:buNone/>
-            </a:pPr>
-            <a:r>
-              <a:rPr lang="en-US" sz="1050" dirty="0">
-                <a:solidFill>
-                  <a:schemeClr val="accent5"/>
-                </a:solidFill>
-              </a:rPr>
-              <a:t>7 nuevas (Anexo A) + seguimiento a obs. 3 y 5 de 2025 (Anexo B)</a:t>
-            </a:r>
-            <a:endParaRPr lang="en-US" sz="1050" dirty="0"/>
-          </a:p>
-        </p:txBody>
-      </p:sp>
-      <p:sp>
-        <p:nvSpPr>
-          <p:cNvPr id="20" name="Hito 3"/>
-          <p:cNvSpPr/>
-          <p:nvPr/>
-        </p:nvSpPr>
-        <p:spPr>
-          <a:xfrm>
-            <a:off x="1536192" y="2679192"/>
-            <a:ext cx="219456" cy="219456"/>
-          </a:xfrm>
-          <a:prstGeom prst="ellipse">
-            <a:avLst/>
-          </a:prstGeom>
-          <a:solidFill>
-            <a:schemeClr val="bg1"/>
-          </a:solidFill>
-          <a:ln w="31750">
-            <a:solidFill>
-              <a:schemeClr val="accent2"/>
-            </a:solidFill>
-            <a:prstDash val="solid"/>
-          </a:ln>
-        </p:spPr>
-      </p:sp>
-      <p:sp>
-        <p:nvSpPr>
-          <p:cNvPr id="21" name="Hito fecha 3"/>
-          <p:cNvSpPr txBox="1"/>
-          <p:nvPr/>
-        </p:nvSpPr>
-        <p:spPr>
-          <a:xfrm>
-            <a:off x="1965960" y="2642616"/>
-            <a:ext cx="4572000" cy="274320"/>
-          </a:xfrm>
-          <a:prstGeom prst="rect">
-            <a:avLst/>
-          </a:prstGeom>
-          <a:noFill/>
-          <a:ln/>
-        </p:spPr>
-        <p:txBody>
-          <a:bodyPr wrap="square" lIns="0" tIns="0" rIns="0" bIns="0" rtlCol="0" anchor="ctr"/>
-          <a:lstStyle/>
-          <a:p>
-            <a:pPr indent="0" marL="0">
-              <a:buNone/>
-            </a:pPr>
-            <a:r>
-              <a:rPr lang="en-US" sz="1150" b="1" dirty="0">
-                <a:solidFill>
-                  <a:schemeClr val="accent2"/>
-                </a:solidFill>
-                <a:latin typeface="Courier New" pitchFamily="34" charset="0"/>
-                <a:ea typeface="Courier New" pitchFamily="34" charset="-122"/>
-                <a:cs typeface="Courier New" pitchFamily="34" charset="-120"/>
-              </a:rPr>
-              <a:t>21 AGO 2026   </a:t>
-            </a:r>
-            <a:pPr indent="0" marL="0">
-              <a:buNone/>
-            </a:pPr>
-            <a:r>
-              <a:rPr lang="en-US" sz="1250" b="1" dirty="0">
-                <a:solidFill>
-                  <a:schemeClr val="tx1"/>
-                </a:solidFill>
-              </a:rPr>
-              <a:t>Inicio de la visita de supervisión ampliada</a:t>
-            </a:r>
-            <a:endParaRPr lang="en-US" sz="1400" dirty="0"/>
-          </a:p>
-        </p:txBody>
-      </p:sp>
-      <p:sp>
-        <p:nvSpPr>
-          <p:cNvPr id="22" name="Hito 4"/>
-          <p:cNvSpPr/>
-          <p:nvPr/>
-        </p:nvSpPr>
-        <p:spPr>
-          <a:xfrm>
-            <a:off x="1536192" y="3278124"/>
-            <a:ext cx="219456" cy="219456"/>
-          </a:xfrm>
-          <a:prstGeom prst="ellipse">
-            <a:avLst/>
-          </a:prstGeom>
-          <a:solidFill>
-            <a:schemeClr val="bg1"/>
-          </a:solidFill>
-          <a:ln w="31750">
-            <a:solidFill>
-              <a:schemeClr val="accent2"/>
-            </a:solidFill>
-            <a:prstDash val="solid"/>
-          </a:ln>
-        </p:spPr>
-      </p:sp>
-      <p:sp>
-        <p:nvSpPr>
-          <p:cNvPr id="23" name="Hito fecha 4"/>
-          <p:cNvSpPr txBox="1"/>
-          <p:nvPr/>
-        </p:nvSpPr>
-        <p:spPr>
-          <a:xfrm>
-            <a:off x="1965960" y="3241548"/>
-            <a:ext cx="4572000" cy="274320"/>
-          </a:xfrm>
-          <a:prstGeom prst="rect">
-            <a:avLst/>
-          </a:prstGeom>
-          <a:noFill/>
-          <a:ln/>
-        </p:spPr>
-        <p:txBody>
-          <a:bodyPr wrap="square" lIns="0" tIns="0" rIns="0" bIns="0" rtlCol="0" anchor="ctr"/>
-          <a:lstStyle/>
-          <a:p>
-            <a:pPr indent="0" marL="0">
-              <a:buNone/>
-            </a:pPr>
-            <a:r>
-              <a:rPr lang="en-US" sz="1150" b="1" dirty="0">
-                <a:solidFill>
-                  <a:schemeClr val="accent2"/>
-                </a:solidFill>
-                <a:latin typeface="Courier New" pitchFamily="34" charset="0"/>
-                <a:ea typeface="Courier New" pitchFamily="34" charset="-122"/>
-                <a:cs typeface="Courier New" pitchFamily="34" charset="-120"/>
-              </a:rPr>
-              <a:t>31 JUL 2026   </a:t>
-            </a:r>
-            <a:pPr indent="0" marL="0">
-              <a:buNone/>
-            </a:pPr>
-            <a:r>
-              <a:rPr lang="en-US" sz="1250" b="1" dirty="0">
-                <a:solidFill>
-                  <a:schemeClr val="tx1"/>
-                </a:solidFill>
-              </a:rPr>
-              <a:t>Nombramiento SSF · Circular 18432</a:t>
-            </a:r>
-            <a:endParaRPr lang="en-US" sz="1400" dirty="0"/>
-          </a:p>
-        </p:txBody>
-      </p:sp>
-      <p:sp>
-        <p:nvSpPr>
-          <p:cNvPr id="24" name="Hito detalle 4"/>
-          <p:cNvSpPr txBox="1"/>
-          <p:nvPr/>
-        </p:nvSpPr>
-        <p:spPr>
-          <a:xfrm>
-            <a:off x="1965960" y="3515868"/>
-            <a:ext cx="4572000" cy="228600"/>
-          </a:xfrm>
-          <a:prstGeom prst="rect">
-            <a:avLst/>
-          </a:prstGeom>
-          <a:noFill/>
-          <a:ln/>
-        </p:spPr>
-        <p:txBody>
-          <a:bodyPr wrap="square" lIns="0" tIns="0" rIns="0" bIns="0" rtlCol="0" anchor="t"/>
-          <a:lstStyle/>
-          <a:p>
-            <a:pPr indent="0" marL="0">
-              <a:buNone/>
-            </a:pPr>
-            <a:r>
-              <a:rPr lang="en-US" sz="1050" dirty="0">
-                <a:solidFill>
-                  <a:schemeClr val="accent5"/>
-                </a:solidFill>
-              </a:rPr>
-              <a:t>Visita con corte al 31/07/2026</a:t>
-            </a:r>
-            <a:endParaRPr lang="en-US" sz="1050" dirty="0"/>
-          </a:p>
-        </p:txBody>
-      </p:sp>
-      <p:sp>
-        <p:nvSpPr>
-          <p:cNvPr id="25" name="Hito 5"/>
-          <p:cNvSpPr/>
-          <p:nvPr/>
-        </p:nvSpPr>
-        <p:spPr>
-          <a:xfrm>
-            <a:off x="1536192" y="4059936"/>
-            <a:ext cx="219456" cy="219456"/>
-          </a:xfrm>
-          <a:prstGeom prst="ellipse">
-            <a:avLst/>
-          </a:prstGeom>
-          <a:solidFill>
-            <a:schemeClr val="bg1"/>
-          </a:solidFill>
-          <a:ln w="31750">
-            <a:solidFill>
-              <a:schemeClr val="accent1"/>
-            </a:solidFill>
-            <a:prstDash val="solid"/>
-          </a:ln>
-        </p:spPr>
-      </p:sp>
-      <p:sp>
-        <p:nvSpPr>
-          <p:cNvPr id="26" name="Hito fecha 5"/>
-          <p:cNvSpPr txBox="1"/>
-          <p:nvPr/>
-        </p:nvSpPr>
-        <p:spPr>
-          <a:xfrm>
-            <a:off x="1965960" y="4023360"/>
-            <a:ext cx="4572000" cy="274320"/>
-          </a:xfrm>
-          <a:prstGeom prst="rect">
-            <a:avLst/>
-          </a:prstGeom>
-          <a:noFill/>
-          <a:ln/>
-        </p:spPr>
-        <p:txBody>
-          <a:bodyPr wrap="square" lIns="0" tIns="0" rIns="0" bIns="0" rtlCol="0" anchor="ctr"/>
-          <a:lstStyle/>
-          <a:p>
-            <a:pPr indent="0" marL="0">
-              <a:buNone/>
-            </a:pPr>
-            <a:r>
-              <a:rPr lang="en-US" sz="1150" b="1" dirty="0">
-                <a:solidFill>
-                  <a:schemeClr val="accent1"/>
-                </a:solidFill>
-                <a:latin typeface="Courier New" pitchFamily="34" charset="0"/>
-                <a:ea typeface="Courier New" pitchFamily="34" charset="-122"/>
-                <a:cs typeface="Courier New" pitchFamily="34" charset="-120"/>
-              </a:rPr>
-              <a:t>18 NOV 2025   </a:t>
-            </a:r>
-            <a:pPr indent="0" marL="0">
-              <a:buNone/>
-            </a:pPr>
-            <a:r>
-              <a:rPr lang="en-US" sz="1250" b="1" dirty="0">
-                <a:solidFill>
-                  <a:schemeClr val="tx1"/>
-                </a:solidFill>
-              </a:rPr>
-              <a:t>Envío de descargos a la SSF</a:t>
-            </a:r>
-            <a:endParaRPr lang="en-US" sz="1400" dirty="0"/>
-          </a:p>
-        </p:txBody>
-      </p:sp>
-      <p:sp>
-        <p:nvSpPr>
-          <p:cNvPr id="27" name="Hito detalle 5"/>
-          <p:cNvSpPr txBox="1"/>
-          <p:nvPr/>
-        </p:nvSpPr>
-        <p:spPr>
-          <a:xfrm>
-            <a:off x="1965960" y="4297680"/>
-            <a:ext cx="4572000" cy="228600"/>
-          </a:xfrm>
-          <a:prstGeom prst="rect">
-            <a:avLst/>
-          </a:prstGeom>
-          <a:noFill/>
-          <a:ln/>
-        </p:spPr>
-        <p:txBody>
-          <a:bodyPr wrap="square" lIns="0" tIns="0" rIns="0" bIns="0" rtlCol="0" anchor="t"/>
-          <a:lstStyle/>
-          <a:p>
-            <a:pPr indent="0" marL="0">
-              <a:buNone/>
-            </a:pPr>
-            <a:r>
-              <a:rPr lang="en-US" sz="1050" dirty="0">
-                <a:solidFill>
-                  <a:schemeClr val="accent5"/>
-                </a:solidFill>
-              </a:rPr>
-              <a:t>Matriz de pruebas de descargo · ref. NB07-2025-974</a:t>
-            </a:r>
-            <a:endParaRPr lang="en-US" sz="1050" dirty="0"/>
-          </a:p>
-        </p:txBody>
-      </p:sp>
-      <p:sp>
-        <p:nvSpPr>
-          <p:cNvPr id="28" name="Hito 6"/>
-          <p:cNvSpPr/>
-          <p:nvPr/>
-        </p:nvSpPr>
-        <p:spPr>
-          <a:xfrm>
-            <a:off x="1536192" y="4658868"/>
-            <a:ext cx="219456" cy="219456"/>
-          </a:xfrm>
-          <a:prstGeom prst="ellipse">
-            <a:avLst/>
-          </a:prstGeom>
-          <a:solidFill>
-            <a:schemeClr val="bg1"/>
-          </a:solidFill>
-          <a:ln w="31750">
-            <a:solidFill>
-              <a:schemeClr val="accent1"/>
-            </a:solidFill>
-            <a:prstDash val="solid"/>
-          </a:ln>
-        </p:spPr>
-      </p:sp>
-      <p:sp>
-        <p:nvSpPr>
-          <p:cNvPr id="29" name="Hito fecha 6"/>
-          <p:cNvSpPr txBox="1"/>
-          <p:nvPr/>
-        </p:nvSpPr>
-        <p:spPr>
-          <a:xfrm>
-            <a:off x="1965960" y="4622292"/>
-            <a:ext cx="4572000" cy="274320"/>
-          </a:xfrm>
-          <a:prstGeom prst="rect">
-            <a:avLst/>
-          </a:prstGeom>
-          <a:noFill/>
-          <a:ln/>
-        </p:spPr>
-        <p:txBody>
-          <a:bodyPr wrap="square" lIns="0" tIns="0" rIns="0" bIns="0" rtlCol="0" anchor="ctr"/>
-          <a:lstStyle/>
-          <a:p>
-            <a:pPr indent="0" marL="0">
-              <a:buNone/>
-            </a:pPr>
-            <a:r>
-              <a:rPr lang="en-US" sz="1150" b="1" dirty="0">
-                <a:solidFill>
-                  <a:schemeClr val="accent1"/>
-                </a:solidFill>
-                <a:latin typeface="Courier New" pitchFamily="34" charset="0"/>
-                <a:ea typeface="Courier New" pitchFamily="34" charset="-122"/>
-                <a:cs typeface="Courier New" pitchFamily="34" charset="-120"/>
-              </a:rPr>
-              <a:t>05 NOV 2025   </a:t>
-            </a:r>
-            <a:pPr indent="0" marL="0">
-              <a:buNone/>
-            </a:pPr>
-            <a:r>
-              <a:rPr lang="en-US" sz="1250" b="1" dirty="0">
-                <a:solidFill>
-                  <a:schemeClr val="tx1"/>
-                </a:solidFill>
-              </a:rPr>
-              <a:t>Informe preliminar · Circular 17003</a:t>
-            </a:r>
-            <a:endParaRPr lang="en-US" sz="1400" dirty="0"/>
-          </a:p>
-        </p:txBody>
-      </p:sp>
-      <p:sp>
-        <p:nvSpPr>
-          <p:cNvPr id="30" name="Hito detalle 6"/>
-          <p:cNvSpPr txBox="1"/>
-          <p:nvPr/>
-        </p:nvSpPr>
-        <p:spPr>
-          <a:xfrm>
-            <a:off x="1965960" y="4896612"/>
-            <a:ext cx="4572000" cy="228600"/>
-          </a:xfrm>
-          <a:prstGeom prst="rect">
-            <a:avLst/>
-          </a:prstGeom>
-          <a:noFill/>
-          <a:ln/>
-        </p:spPr>
-        <p:txBody>
-          <a:bodyPr wrap="square" lIns="0" tIns="0" rIns="0" bIns="0" rtlCol="0" anchor="t"/>
-          <a:lstStyle/>
-          <a:p>
-            <a:pPr indent="0" marL="0">
-              <a:buNone/>
-            </a:pPr>
-            <a:r>
-              <a:rPr lang="en-US" sz="1050" dirty="0">
-                <a:solidFill>
-                  <a:schemeClr val="accent5"/>
-                </a:solidFill>
-              </a:rPr>
-              <a:t>9 observaciones</a:t>
-            </a:r>
-            <a:endParaRPr lang="en-US" sz="1050" dirty="0"/>
-          </a:p>
-        </p:txBody>
-      </p:sp>
-      <p:sp>
-        <p:nvSpPr>
-          <p:cNvPr id="31" name="Hito 7"/>
-          <p:cNvSpPr/>
-          <p:nvPr/>
-        </p:nvSpPr>
-        <p:spPr>
-          <a:xfrm>
-            <a:off x="1536192" y="5257800"/>
-            <a:ext cx="219456" cy="219456"/>
-          </a:xfrm>
-          <a:prstGeom prst="ellipse">
-            <a:avLst/>
-          </a:prstGeom>
-          <a:solidFill>
-            <a:schemeClr val="bg1"/>
-          </a:solidFill>
-          <a:ln w="31750">
-            <a:solidFill>
-              <a:schemeClr val="accent1"/>
-            </a:solidFill>
-            <a:prstDash val="solid"/>
-          </a:ln>
-        </p:spPr>
-      </p:sp>
-      <p:sp>
-        <p:nvSpPr>
-          <p:cNvPr id="32" name="Hito fecha 7"/>
-          <p:cNvSpPr txBox="1"/>
-          <p:nvPr/>
-        </p:nvSpPr>
-        <p:spPr>
-          <a:xfrm>
-            <a:off x="1965960" y="5221224"/>
-            <a:ext cx="4572000" cy="274320"/>
-          </a:xfrm>
-          <a:prstGeom prst="rect">
-            <a:avLst/>
-          </a:prstGeom>
-          <a:noFill/>
-          <a:ln/>
-        </p:spPr>
-        <p:txBody>
-          <a:bodyPr wrap="square" lIns="0" tIns="0" rIns="0" bIns="0" rtlCol="0" anchor="ctr"/>
-          <a:lstStyle/>
-          <a:p>
-            <a:pPr indent="0" marL="0">
-              <a:buNone/>
-            </a:pPr>
-            <a:r>
-              <a:rPr lang="en-US" sz="1150" b="1" dirty="0">
-                <a:solidFill>
-                  <a:schemeClr val="accent1"/>
-                </a:solidFill>
-                <a:latin typeface="Courier New" pitchFamily="34" charset="0"/>
-                <a:ea typeface="Courier New" pitchFamily="34" charset="-122"/>
-                <a:cs typeface="Courier New" pitchFamily="34" charset="-120"/>
-              </a:rPr>
-              <a:t>19 MAY 2025   </a:t>
-            </a:r>
-            <a:pPr indent="0" marL="0">
-              <a:buNone/>
-            </a:pPr>
-            <a:r>
-              <a:rPr lang="en-US" sz="1250" b="1" dirty="0">
-                <a:solidFill>
-                  <a:schemeClr val="tx1"/>
-                </a:solidFill>
-              </a:rPr>
-              <a:t>Inicio formal de la visita en sitio</a:t>
-            </a:r>
-            <a:endParaRPr lang="en-US" sz="1400" dirty="0"/>
-          </a:p>
-        </p:txBody>
-      </p:sp>
-      <p:sp>
-        <p:nvSpPr>
-          <p:cNvPr id="33" name="Hito 8"/>
-          <p:cNvSpPr/>
-          <p:nvPr/>
-        </p:nvSpPr>
-        <p:spPr>
-          <a:xfrm>
-            <a:off x="1536192" y="5856732"/>
-            <a:ext cx="219456" cy="219456"/>
-          </a:xfrm>
-          <a:prstGeom prst="ellipse">
-            <a:avLst/>
-          </a:prstGeom>
-          <a:solidFill>
-            <a:schemeClr val="bg1"/>
-          </a:solidFill>
-          <a:ln w="31750">
-            <a:solidFill>
-              <a:schemeClr val="accent1"/>
-            </a:solidFill>
-            <a:prstDash val="solid"/>
-          </a:ln>
-        </p:spPr>
-      </p:sp>
-      <p:sp>
-        <p:nvSpPr>
-          <p:cNvPr id="34" name="Hito fecha 8"/>
-          <p:cNvSpPr txBox="1"/>
-          <p:nvPr/>
-        </p:nvSpPr>
-        <p:spPr>
-          <a:xfrm>
-            <a:off x="1965960" y="5820156"/>
-            <a:ext cx="4572000" cy="274320"/>
-          </a:xfrm>
-          <a:prstGeom prst="rect">
-            <a:avLst/>
-          </a:prstGeom>
-          <a:noFill/>
-          <a:ln/>
-        </p:spPr>
-        <p:txBody>
-          <a:bodyPr wrap="square" lIns="0" tIns="0" rIns="0" bIns="0" rtlCol="0" anchor="ctr"/>
-          <a:lstStyle/>
-          <a:p>
-            <a:pPr indent="0" marL="0">
-              <a:buNone/>
-            </a:pPr>
-            <a:r>
-              <a:rPr lang="en-US" sz="1150" b="1" dirty="0">
-                <a:solidFill>
-                  <a:schemeClr val="accent1"/>
-                </a:solidFill>
-                <a:latin typeface="Courier New" pitchFamily="34" charset="0"/>
-                <a:ea typeface="Courier New" pitchFamily="34" charset="-122"/>
-                <a:cs typeface="Courier New" pitchFamily="34" charset="-120"/>
-              </a:rPr>
-              <a:t>09 ABR 2025   </a:t>
-            </a:r>
-            <a:pPr indent="0" marL="0">
-              <a:buNone/>
-            </a:pPr>
-            <a:r>
-              <a:rPr lang="en-US" sz="1250" b="1" dirty="0">
-                <a:solidFill>
-                  <a:schemeClr val="tx1"/>
-                </a:solidFill>
-              </a:rPr>
-              <a:t>Nombramiento SSF · Circular 9337</a:t>
-            </a:r>
-            <a:endParaRPr lang="en-US" sz="1400" dirty="0"/>
-          </a:p>
-        </p:txBody>
-      </p:sp>
-      <p:sp>
-        <p:nvSpPr>
-          <p:cNvPr id="35" name="Hito detalle 8"/>
-          <p:cNvSpPr txBox="1"/>
-          <p:nvPr/>
-        </p:nvSpPr>
-        <p:spPr>
-          <a:xfrm>
-            <a:off x="1965960" y="6094476"/>
-            <a:ext cx="4572000" cy="228600"/>
-          </a:xfrm>
-          <a:prstGeom prst="rect">
-            <a:avLst/>
-          </a:prstGeom>
-          <a:noFill/>
-          <a:ln/>
-        </p:spPr>
-        <p:txBody>
-          <a:bodyPr wrap="square" lIns="0" tIns="0" rIns="0" bIns="0" rtlCol="0" anchor="t"/>
-          <a:lstStyle/>
-          <a:p>
-            <a:pPr indent="0" marL="0">
-              <a:buNone/>
-            </a:pPr>
-            <a:r>
-              <a:rPr lang="en-US" sz="1050" dirty="0">
-                <a:solidFill>
-                  <a:schemeClr val="accent5"/>
-                </a:solidFill>
-              </a:rPr>
-              <a:t>Visita con corte al 30/04/2025</a:t>
-            </a:r>
-            <a:endParaRPr lang="en-US" sz="1050" dirty="0"/>
-          </a:p>
-        </p:txBody>
-      </p:sp>
-      <p:sp>
-        <p:nvSpPr>
-          <p:cNvPr id="36" name="Detalle 2026"/>
-          <p:cNvSpPr/>
-          <p:nvPr/>
-        </p:nvSpPr>
-        <p:spPr>
-          <a:xfrm>
-            <a:off x="6720840" y="1325880"/>
-            <a:ext cx="4922215" cy="1298448"/>
-          </a:xfrm>
-          <a:prstGeom prst="roundRect">
-            <a:avLst>
-              <a:gd name="adj" fmla="val 7042"/>
-            </a:avLst>
-          </a:prstGeom>
-          <a:solidFill>
-            <a:schemeClr val="accent2">
-              <a:alpha val="12000"/>
-            </a:schemeClr>
-          </a:solidFill>
-          <a:ln w="12700">
-            <a:solidFill>
-              <a:schemeClr val="accent2">
-                <a:alpha val="0"/>
-              </a:schemeClr>
-            </a:solidFill>
-            <a:prstDash val="solid"/>
-          </a:ln>
-        </p:spPr>
-      </p:sp>
-      <p:sp>
-        <p:nvSpPr>
-          <p:cNvPr id="37" name="Detalle 2026 título"/>
-          <p:cNvSpPr txBox="1"/>
-          <p:nvPr/>
-        </p:nvSpPr>
-        <p:spPr>
-          <a:xfrm>
-            <a:off x="6903720" y="1435608"/>
-            <a:ext cx="4556455" cy="256032"/>
-          </a:xfrm>
-          <a:prstGeom prst="rect">
-            <a:avLst/>
-          </a:prstGeom>
-          <a:noFill/>
-          <a:ln/>
-        </p:spPr>
-        <p:txBody>
-          <a:bodyPr wrap="square" lIns="0" tIns="0" rIns="0" bIns="0" rtlCol="0" anchor="t"/>
-          <a:lstStyle/>
-          <a:p>
-            <a:pPr indent="0" marL="0">
-              <a:buNone/>
-            </a:pPr>
-            <a:r>
-              <a:rPr lang="en-US" sz="1300" b="1" dirty="0">
-                <a:solidFill>
-                  <a:schemeClr val="accent2"/>
-                </a:solidFill>
-              </a:rPr>
-              <a:t>Resultado 2026 · Circular 22741</a:t>
-            </a:r>
-            <a:endParaRPr lang="en-US" sz="1300" dirty="0"/>
-          </a:p>
-        </p:txBody>
-      </p:sp>
-      <p:sp>
-        <p:nvSpPr>
-          <p:cNvPr id="38" name="Detalle 2026 texto"/>
-          <p:cNvSpPr txBox="1"/>
-          <p:nvPr/>
-        </p:nvSpPr>
-        <p:spPr>
-          <a:xfrm>
-            <a:off x="6903720" y="1755648"/>
-            <a:ext cx="4556455" cy="804672"/>
-          </a:xfrm>
-          <a:prstGeom prst="rect">
-            <a:avLst/>
-          </a:prstGeom>
-          <a:noFill/>
-          <a:ln/>
-        </p:spPr>
-        <p:txBody>
-          <a:bodyPr wrap="square" lIns="0" tIns="0" rIns="0" bIns="0" rtlCol="0" anchor="t"/>
-          <a:lstStyle/>
-          <a:p>
-            <a:pPr indent="0" marL="0">
-              <a:spcAft>
-                <a:spcPts val="300"/>
-              </a:spcAft>
-              <a:buNone/>
-            </a:pPr>
-            <a:r>
-              <a:rPr lang="en-US" sz="1150" b="1" dirty="0">
-                <a:solidFill>
-                  <a:schemeClr val="tx1"/>
-                </a:solidFill>
-              </a:rPr>
-              <a:t>Anexo A: </a:t>
-            </a:r>
-            <a:pPr indent="0" marL="0">
-              <a:spcAft>
-                <a:spcPts val="300"/>
-              </a:spcAft>
-              <a:buNone/>
-            </a:pPr>
-            <a:r>
-              <a:rPr lang="en-US" sz="1150" dirty="0">
-                <a:solidFill>
-                  <a:schemeClr val="tx1"/>
-                </a:solidFill>
-              </a:rPr>
-              <a:t>7 observaciones nuevas · descargos en 10 días hábiles</a:t>
-            </a:r>
-            <a:endParaRPr lang="en-US" sz="1150" dirty="0"/>
-          </a:p>
-          <a:p>
-            <a:pPr indent="0" marL="0">
-              <a:spcAft>
-                <a:spcPts val="300"/>
-              </a:spcAft>
-              <a:buNone/>
-            </a:pPr>
-            <a:r>
-              <a:rPr lang="en-US" sz="1150" b="1" dirty="0">
-                <a:solidFill>
-                  <a:schemeClr val="tx1"/>
-                </a:solidFill>
-              </a:rPr>
-              <a:t>Anexo B: </a:t>
-            </a:r>
-            <a:pPr indent="0" marL="0">
-              <a:spcAft>
-                <a:spcPts val="300"/>
-              </a:spcAft>
-              <a:buNone/>
-            </a:pPr>
-            <a:r>
-              <a:rPr lang="en-US" sz="1150" dirty="0">
-                <a:solidFill>
-                  <a:schemeClr val="tx1"/>
-                </a:solidFill>
-              </a:rPr>
-              <a:t>seguimiento a obs. 3 y 5 de 2025 · plan de solución en 15 días hábiles</a:t>
-            </a:r>
-            <a:endParaRPr lang="en-US" sz="1150" dirty="0"/>
-          </a:p>
-        </p:txBody>
-      </p:sp>
-      <p:sp>
-        <p:nvSpPr>
-          <p:cNvPr id="39" name="Detalle 2025"/>
-          <p:cNvSpPr/>
-          <p:nvPr/>
-        </p:nvSpPr>
-        <p:spPr>
-          <a:xfrm>
-            <a:off x="6720840" y="2761488"/>
-            <a:ext cx="4922215" cy="1143000"/>
-          </a:xfrm>
-          <a:prstGeom prst="roundRect">
-            <a:avLst>
-              <a:gd name="adj" fmla="val 8000"/>
-            </a:avLst>
-          </a:prstGeom>
-          <a:solidFill>
-            <a:schemeClr val="accent1">
-              <a:alpha val="12000"/>
-            </a:schemeClr>
-          </a:solidFill>
-          <a:ln w="12700">
-            <a:solidFill>
-              <a:schemeClr val="accent1">
-                <a:alpha val="0"/>
-              </a:schemeClr>
-            </a:solidFill>
-            <a:prstDash val="solid"/>
-          </a:ln>
-        </p:spPr>
-      </p:sp>
-      <p:sp>
-        <p:nvSpPr>
-          <p:cNvPr id="40" name="Detalle 2025 título"/>
-          <p:cNvSpPr txBox="1"/>
-          <p:nvPr/>
-        </p:nvSpPr>
-        <p:spPr>
-          <a:xfrm>
-            <a:off x="6903720" y="2871216"/>
-            <a:ext cx="4556455" cy="256032"/>
-          </a:xfrm>
-          <a:prstGeom prst="rect">
-            <a:avLst/>
-          </a:prstGeom>
-          <a:noFill/>
-          <a:ln/>
-        </p:spPr>
-        <p:txBody>
-          <a:bodyPr wrap="square" lIns="0" tIns="0" rIns="0" bIns="0" rtlCol="0" anchor="t"/>
-          <a:lstStyle/>
-          <a:p>
-            <a:pPr indent="0" marL="0">
-              <a:buNone/>
-            </a:pPr>
-            <a:r>
-              <a:rPr lang="en-US" sz="1300" b="1" dirty="0">
-                <a:solidFill>
-                  <a:schemeClr val="accent1"/>
-                </a:solidFill>
-              </a:rPr>
-              <a:t>Hallazgos críticos 2025 · Circular 17003</a:t>
-            </a:r>
-            <a:endParaRPr lang="en-US" sz="1300" dirty="0"/>
-          </a:p>
-        </p:txBody>
-      </p:sp>
-      <p:sp>
-        <p:nvSpPr>
-          <p:cNvPr id="41" name="Detalle 2025 texto"/>
-          <p:cNvSpPr txBox="1"/>
-          <p:nvPr/>
-        </p:nvSpPr>
-        <p:spPr>
-          <a:xfrm>
-            <a:off x="6903720" y="3182112"/>
-            <a:ext cx="4556455" cy="685800"/>
-          </a:xfrm>
-          <a:prstGeom prst="rect">
-            <a:avLst/>
-          </a:prstGeom>
-          <a:noFill/>
-          <a:ln/>
-        </p:spPr>
-        <p:txBody>
-          <a:bodyPr wrap="square" lIns="0" tIns="0" rIns="0" bIns="0" rtlCol="0" anchor="t"/>
-          <a:lstStyle/>
-          <a:p>
-            <a:pPr marL="342900" indent="-342900">
-              <a:spcAft>
-                <a:spcPts val="100"/>
-              </a:spcAft>
-              <a:buSzPct val="100000"/>
-              <a:buChar char="•"/>
-            </a:pPr>
-            <a:r>
-              <a:rPr lang="en-US" sz="1150" dirty="0">
-                <a:solidFill>
-                  <a:schemeClr val="tx1"/>
-                </a:solidFill>
-              </a:rPr>
-              <a:t>Ausencia de Política de Operaciones Vinculadas</a:t>
-            </a:r>
-            <a:endParaRPr lang="en-US" sz="1150" dirty="0"/>
-          </a:p>
-          <a:p>
-            <a:pPr marL="342900" indent="-342900">
-              <a:spcAft>
-                <a:spcPts val="100"/>
-              </a:spcAft>
-              <a:buSzPct val="100000"/>
-              <a:buChar char="•"/>
-            </a:pPr>
-            <a:r>
-              <a:rPr lang="en-US" sz="1150" dirty="0">
-                <a:solidFill>
-                  <a:schemeClr val="tx1"/>
-                </a:solidFill>
-              </a:rPr>
-              <a:t>Normativa interna desactualizada (9 documentos)</a:t>
-            </a:r>
-            <a:endParaRPr lang="en-US" sz="1150" dirty="0"/>
-          </a:p>
-          <a:p>
-            <a:pPr marL="342900" indent="-342900">
-              <a:spcAft>
-                <a:spcPts val="100"/>
-              </a:spcAft>
-              <a:buSzPct val="100000"/>
-              <a:buChar char="•"/>
-            </a:pPr>
-            <a:r>
-              <a:rPr lang="en-US" sz="1150" dirty="0">
-                <a:solidFill>
-                  <a:schemeClr val="tx1"/>
-                </a:solidFill>
-              </a:rPr>
-              <a:t>Uso inapropiado del Fondo de Educación</a:t>
-            </a:r>
-            <a:endParaRPr lang="en-US" sz="1150" dirty="0"/>
-          </a:p>
-        </p:txBody>
-      </p:sp>
-      <p:sp>
-        <p:nvSpPr>
-          <p:cNvPr id="42" name="Evolución título"/>
-          <p:cNvSpPr txBox="1"/>
-          <p:nvPr/>
-        </p:nvSpPr>
-        <p:spPr>
-          <a:xfrm>
-            <a:off x="6720840" y="4041648"/>
-            <a:ext cx="4922215" cy="237744"/>
-          </a:xfrm>
-          <a:prstGeom prst="rect">
-            <a:avLst/>
-          </a:prstGeom>
-          <a:noFill/>
-          <a:ln/>
-        </p:spPr>
-        <p:txBody>
-          <a:bodyPr wrap="square" lIns="0" tIns="0" rIns="0" bIns="0" rtlCol="0" anchor="t"/>
-          <a:lstStyle/>
-          <a:p>
-            <a:pPr indent="0" marL="0">
-              <a:buNone/>
-            </a:pPr>
-            <a:r>
-              <a:rPr lang="en-US" sz="1100" b="1" spc="200" kern="0" dirty="0">
-                <a:solidFill>
-                  <a:schemeClr val="accent5"/>
-                </a:solidFill>
-              </a:rPr>
-              <a:t>SEGUIMIENTO A OBSERVACIONES 2025</a:t>
-            </a:r>
-            <a:endParaRPr lang="en-US" sz="1100" dirty="0"/>
-          </a:p>
-        </p:txBody>
-      </p:sp>
-      <p:sp>
-        <p:nvSpPr>
-          <p:cNvPr id="43" name="Evolución 1"/>
-          <p:cNvSpPr/>
-          <p:nvPr/>
-        </p:nvSpPr>
-        <p:spPr>
-          <a:xfrm>
-            <a:off x="6720840" y="4343400"/>
-            <a:ext cx="4922215" cy="585216"/>
-          </a:xfrm>
-          <a:prstGeom prst="roundRect">
-            <a:avLst>
-              <a:gd name="adj" fmla="val 15625"/>
-            </a:avLst>
-          </a:prstGeom>
-          <a:solidFill>
-            <a:schemeClr val="accent3">
-              <a:alpha val="12000"/>
-            </a:schemeClr>
-          </a:solidFill>
-          <a:ln w="12700">
-            <a:solidFill>
-              <a:schemeClr val="accent3">
-                <a:alpha val="0"/>
-              </a:schemeClr>
-            </a:solidFill>
-            <a:prstDash val="solid"/>
-          </a:ln>
-        </p:spPr>
-      </p:sp>
-      <p:sp>
-        <p:nvSpPr>
-          <p:cNvPr id="44" name="Evolución estado 1 fondo"/>
-          <p:cNvSpPr/>
-          <p:nvPr/>
-        </p:nvSpPr>
-        <p:spPr>
-          <a:xfrm>
-            <a:off x="6858000" y="4498848"/>
-            <a:ext cx="2011680" cy="274320"/>
-          </a:xfrm>
-          <a:prstGeom prst="roundRect">
-            <a:avLst>
-              <a:gd name="adj" fmla="val 50000"/>
-            </a:avLst>
-          </a:prstGeom>
-          <a:solidFill>
-            <a:schemeClr val="accent3"/>
-          </a:solidFill>
-          <a:ln w="12700">
-            <a:solidFill>
-              <a:schemeClr val="accent3">
-                <a:alpha val="0"/>
-              </a:schemeClr>
-            </a:solidFill>
-            <a:prstDash val="solid"/>
-          </a:ln>
-        </p:spPr>
-      </p:sp>
-      <p:sp>
-        <p:nvSpPr>
-          <p:cNvPr id="45" name="Evolución estado 1"/>
-          <p:cNvSpPr txBox="1"/>
-          <p:nvPr/>
-        </p:nvSpPr>
-        <p:spPr>
-          <a:xfrm>
-            <a:off x="6858000" y="4498848"/>
-            <a:ext cx="2011680" cy="274320"/>
-          </a:xfrm>
-          <a:prstGeom prst="rect">
-            <a:avLst/>
-          </a:prstGeom>
-          <a:noFill/>
-          <a:ln/>
-        </p:spPr>
-        <p:txBody>
-          <a:bodyPr wrap="square" lIns="0" tIns="0" rIns="0" bIns="0" rtlCol="0" anchor="ctr"/>
-          <a:lstStyle/>
-          <a:p>
-            <a:pPr algn="ctr" indent="0" marL="0">
-              <a:buNone/>
-            </a:pPr>
-            <a:r>
-              <a:rPr lang="en-US" sz="1000" b="1" spc="100" kern="0" dirty="0">
-                <a:solidFill>
-                  <a:schemeClr val="bg1"/>
-                </a:solidFill>
-              </a:rPr>
-              <a:t>NO SUPERADA</a:t>
-            </a:r>
-            <a:endParaRPr lang="en-US" sz="1000" dirty="0"/>
-          </a:p>
-        </p:txBody>
-      </p:sp>
-      <p:sp>
-        <p:nvSpPr>
-          <p:cNvPr id="46" name="Evolución tema 1"/>
-          <p:cNvSpPr txBox="1"/>
-          <p:nvPr/>
-        </p:nvSpPr>
-        <p:spPr>
-          <a:xfrm>
-            <a:off x="9006840" y="4416552"/>
-            <a:ext cx="2544775" cy="237744"/>
-          </a:xfrm>
-          <a:prstGeom prst="rect">
-            <a:avLst/>
-          </a:prstGeom>
-          <a:noFill/>
-          <a:ln/>
-        </p:spPr>
-        <p:txBody>
-          <a:bodyPr wrap="square" lIns="0" tIns="0" rIns="0" bIns="0" rtlCol="0" anchor="t"/>
-          <a:lstStyle/>
-          <a:p>
-            <a:pPr indent="0" marL="0">
-              <a:buNone/>
-            </a:pPr>
-            <a:r>
-              <a:rPr lang="en-US" sz="1200" b="1" dirty="0">
-                <a:solidFill>
-                  <a:schemeClr val="tx1"/>
-                </a:solidFill>
-              </a:rPr>
-              <a:t>Comités de Apoyo sin ejecutivos</a:t>
-            </a:r>
-            <a:endParaRPr lang="en-US" sz="1200" dirty="0"/>
-          </a:p>
-        </p:txBody>
-      </p:sp>
-      <p:sp>
-        <p:nvSpPr>
-          <p:cNvPr id="47" name="Evolución detalle 1"/>
-          <p:cNvSpPr txBox="1"/>
-          <p:nvPr/>
-        </p:nvSpPr>
-        <p:spPr>
-          <a:xfrm>
-            <a:off x="9006840" y="4654296"/>
-            <a:ext cx="2544775" cy="219456"/>
-          </a:xfrm>
-          <a:prstGeom prst="rect">
-            <a:avLst/>
-          </a:prstGeom>
-          <a:noFill/>
-          <a:ln/>
-        </p:spPr>
-        <p:txBody>
-          <a:bodyPr wrap="square" lIns="0" tIns="0" rIns="0" bIns="0" rtlCol="0" anchor="t"/>
-          <a:lstStyle/>
-          <a:p>
-            <a:pPr indent="0" marL="0">
-              <a:buNone/>
-            </a:pPr>
-            <a:r>
-              <a:rPr lang="en-US" sz="1050" dirty="0">
-                <a:solidFill>
-                  <a:schemeClr val="accent5"/>
-                </a:solidFill>
-              </a:rPr>
-              <a:t>Obs. 3 de 2025 · Anexo B</a:t>
-            </a:r>
-            <a:endParaRPr lang="en-US" sz="1050" dirty="0"/>
-          </a:p>
-        </p:txBody>
-      </p:sp>
-      <p:sp>
-        <p:nvSpPr>
-          <p:cNvPr id="48" name="Evolución 2"/>
-          <p:cNvSpPr/>
-          <p:nvPr/>
-        </p:nvSpPr>
-        <p:spPr>
-          <a:xfrm>
-            <a:off x="6720840" y="5001768"/>
-            <a:ext cx="4922215" cy="585216"/>
-          </a:xfrm>
-          <a:prstGeom prst="roundRect">
-            <a:avLst>
-              <a:gd name="adj" fmla="val 15625"/>
-            </a:avLst>
-          </a:prstGeom>
-          <a:solidFill>
-            <a:schemeClr val="accent4">
-              <a:alpha val="12000"/>
-            </a:schemeClr>
-          </a:solidFill>
-          <a:ln w="12700">
-            <a:solidFill>
-              <a:schemeClr val="accent4">
-                <a:alpha val="0"/>
-              </a:schemeClr>
-            </a:solidFill>
-            <a:prstDash val="solid"/>
-          </a:ln>
-        </p:spPr>
-      </p:sp>
-      <p:sp>
-        <p:nvSpPr>
-          <p:cNvPr id="49" name="Evolución estado 2 fondo"/>
-          <p:cNvSpPr/>
-          <p:nvPr/>
-        </p:nvSpPr>
-        <p:spPr>
-          <a:xfrm>
-            <a:off x="6858000" y="5157216"/>
-            <a:ext cx="2011680" cy="274320"/>
-          </a:xfrm>
-          <a:prstGeom prst="roundRect">
-            <a:avLst>
-              <a:gd name="adj" fmla="val 50000"/>
-            </a:avLst>
-          </a:prstGeom>
-          <a:solidFill>
-            <a:schemeClr val="accent4"/>
-          </a:solidFill>
-          <a:ln w="12700">
-            <a:solidFill>
-              <a:schemeClr val="accent4">
-                <a:alpha val="0"/>
-              </a:schemeClr>
-            </a:solidFill>
-            <a:prstDash val="solid"/>
-          </a:ln>
-        </p:spPr>
-      </p:sp>
-      <p:sp>
-        <p:nvSpPr>
-          <p:cNvPr id="50" name="Evolución estado 2"/>
-          <p:cNvSpPr txBox="1"/>
-          <p:nvPr/>
-        </p:nvSpPr>
-        <p:spPr>
-          <a:xfrm>
-            <a:off x="6858000" y="5157216"/>
-            <a:ext cx="2011680" cy="274320"/>
-          </a:xfrm>
-          <a:prstGeom prst="rect">
-            <a:avLst/>
-          </a:prstGeom>
-          <a:noFill/>
-          <a:ln/>
-        </p:spPr>
-        <p:txBody>
-          <a:bodyPr wrap="square" lIns="0" tIns="0" rIns="0" bIns="0" rtlCol="0" anchor="ctr"/>
-          <a:lstStyle/>
-          <a:p>
-            <a:pPr algn="ctr" indent="0" marL="0">
-              <a:buNone/>
-            </a:pPr>
-            <a:r>
-              <a:rPr lang="en-US" sz="1000" b="1" spc="100" kern="0" dirty="0">
-                <a:solidFill>
-                  <a:schemeClr val="bg1"/>
-                </a:solidFill>
-              </a:rPr>
-              <a:t>PARCIALMENTE SUPERADA</a:t>
-            </a:r>
-            <a:endParaRPr lang="en-US" sz="1000" dirty="0"/>
-          </a:p>
-        </p:txBody>
-      </p:sp>
-      <p:sp>
-        <p:nvSpPr>
-          <p:cNvPr id="51" name="Evolución tema 2"/>
-          <p:cNvSpPr txBox="1"/>
-          <p:nvPr/>
-        </p:nvSpPr>
-        <p:spPr>
-          <a:xfrm>
-            <a:off x="9006840" y="5074920"/>
-            <a:ext cx="2544775" cy="237744"/>
-          </a:xfrm>
-          <a:prstGeom prst="rect">
-            <a:avLst/>
-          </a:prstGeom>
-          <a:noFill/>
-          <a:ln/>
-        </p:spPr>
-        <p:txBody>
-          <a:bodyPr wrap="square" lIns="0" tIns="0" rIns="0" bIns="0" rtlCol="0" anchor="t"/>
-          <a:lstStyle/>
-          <a:p>
-            <a:pPr indent="0" marL="0">
-              <a:buNone/>
-            </a:pPr>
-            <a:r>
-              <a:rPr lang="en-US" sz="1200" b="1" dirty="0">
-                <a:solidFill>
-                  <a:schemeClr val="tx1"/>
-                </a:solidFill>
-              </a:rPr>
-              <a:t>Normativa interna desactualizada</a:t>
-            </a:r>
-            <a:endParaRPr lang="en-US" sz="1200" dirty="0"/>
-          </a:p>
-        </p:txBody>
-      </p:sp>
-      <p:sp>
-        <p:nvSpPr>
-          <p:cNvPr id="52" name="Evolución detalle 2"/>
-          <p:cNvSpPr txBox="1"/>
-          <p:nvPr/>
-        </p:nvSpPr>
-        <p:spPr>
-          <a:xfrm>
-            <a:off x="9006840" y="5312664"/>
-            <a:ext cx="2544775" cy="219456"/>
-          </a:xfrm>
-          <a:prstGeom prst="rect">
-            <a:avLst/>
-          </a:prstGeom>
-          <a:noFill/>
-          <a:ln/>
-        </p:spPr>
-        <p:txBody>
-          <a:bodyPr wrap="square" lIns="0" tIns="0" rIns="0" bIns="0" rtlCol="0" anchor="t"/>
-          <a:lstStyle/>
-          <a:p>
-            <a:pPr indent="0" marL="0">
-              <a:buNone/>
-            </a:pPr>
-            <a:r>
-              <a:rPr lang="en-US" sz="1050" dirty="0">
-                <a:solidFill>
-                  <a:schemeClr val="accent5"/>
-                </a:solidFill>
-              </a:rPr>
-              <a:t>Obs. 5 de 2025 · Anexo B</a:t>
-            </a:r>
-            <a:endParaRPr lang="en-US" sz="1050" dirty="0"/>
-          </a:p>
-        </p:txBody>
-      </p:sp>
-      <p:sp>
-        <p:nvSpPr>
-          <p:cNvPr id="53" name="Evolución 3"/>
-          <p:cNvSpPr/>
-          <p:nvPr/>
-        </p:nvSpPr>
-        <p:spPr>
-          <a:xfrm>
-            <a:off x="6720840" y="5660136"/>
-            <a:ext cx="4922215" cy="585216"/>
-          </a:xfrm>
-          <a:prstGeom prst="roundRect">
-            <a:avLst>
-              <a:gd name="adj" fmla="val 15625"/>
-            </a:avLst>
-          </a:prstGeom>
-          <a:solidFill>
-            <a:schemeClr val="accent2">
-              <a:alpha val="12000"/>
-            </a:schemeClr>
-          </a:solidFill>
-          <a:ln w="12700">
-            <a:solidFill>
-              <a:schemeClr val="accent2">
-                <a:alpha val="0"/>
-              </a:schemeClr>
-            </a:solidFill>
-            <a:prstDash val="solid"/>
-          </a:ln>
-        </p:spPr>
-      </p:sp>
-      <p:sp>
-        <p:nvSpPr>
-          <p:cNvPr id="54" name="Evolución estado 3 fondo"/>
-          <p:cNvSpPr/>
-          <p:nvPr/>
-        </p:nvSpPr>
-        <p:spPr>
-          <a:xfrm>
-            <a:off x="6858000" y="5815584"/>
-            <a:ext cx="2011680" cy="274320"/>
-          </a:xfrm>
-          <a:prstGeom prst="roundRect">
-            <a:avLst>
-              <a:gd name="adj" fmla="val 50000"/>
-            </a:avLst>
-          </a:prstGeom>
-          <a:solidFill>
-            <a:schemeClr val="accent2"/>
-          </a:solidFill>
-          <a:ln w="12700">
-            <a:solidFill>
-              <a:schemeClr val="accent2">
-                <a:alpha val="0"/>
-              </a:schemeClr>
-            </a:solidFill>
-            <a:prstDash val="solid"/>
-          </a:ln>
-        </p:spPr>
-      </p:sp>
-      <p:sp>
-        <p:nvSpPr>
-          <p:cNvPr id="55" name="Evolución estado 3"/>
-          <p:cNvSpPr txBox="1"/>
-          <p:nvPr/>
-        </p:nvSpPr>
-        <p:spPr>
-          <a:xfrm>
-            <a:off x="6858000" y="5815584"/>
-            <a:ext cx="2011680" cy="274320"/>
-          </a:xfrm>
-          <a:prstGeom prst="rect">
-            <a:avLst/>
-          </a:prstGeom>
-          <a:noFill/>
-          <a:ln/>
-        </p:spPr>
-        <p:txBody>
-          <a:bodyPr wrap="square" lIns="0" tIns="0" rIns="0" bIns="0" rtlCol="0" anchor="ctr"/>
-          <a:lstStyle/>
-          <a:p>
-            <a:pPr algn="ctr" indent="0" marL="0">
-              <a:buNone/>
-            </a:pPr>
-            <a:r>
-              <a:rPr lang="en-US" sz="1000" b="1" spc="100" kern="0" dirty="0">
-                <a:solidFill>
-                  <a:schemeClr val="bg1"/>
-                </a:solidFill>
-              </a:rPr>
-              <a:t>MISMO TEMA · NUEVAS</a:t>
-            </a:r>
-            <a:endParaRPr lang="en-US" sz="1000" dirty="0"/>
-          </a:p>
-        </p:txBody>
-      </p:sp>
-      <p:sp>
-        <p:nvSpPr>
-          <p:cNvPr id="56" name="Evolución tema 3"/>
-          <p:cNvSpPr txBox="1"/>
-          <p:nvPr/>
-        </p:nvSpPr>
-        <p:spPr>
-          <a:xfrm>
-            <a:off x="9006840" y="5733288"/>
-            <a:ext cx="2544775" cy="237744"/>
-          </a:xfrm>
-          <a:prstGeom prst="rect">
-            <a:avLst/>
-          </a:prstGeom>
-          <a:noFill/>
-          <a:ln/>
-        </p:spPr>
-        <p:txBody>
-          <a:bodyPr wrap="square" lIns="0" tIns="0" rIns="0" bIns="0" rtlCol="0" anchor="t"/>
-          <a:lstStyle/>
-          <a:p>
-            <a:pPr indent="0" marL="0">
-              <a:buNone/>
-            </a:pPr>
-            <a:r>
-              <a:rPr lang="en-US" sz="1200" b="1" dirty="0">
-                <a:solidFill>
-                  <a:schemeClr val="tx1"/>
-                </a:solidFill>
-              </a:rPr>
-              <a:t>Fondo de Educación</a:t>
-            </a:r>
-            <a:endParaRPr lang="en-US" sz="1200" dirty="0"/>
-          </a:p>
-        </p:txBody>
-      </p:sp>
-      <p:sp>
-        <p:nvSpPr>
-          <p:cNvPr id="57" name="Evolución detalle 3"/>
-          <p:cNvSpPr txBox="1"/>
-          <p:nvPr/>
-        </p:nvSpPr>
-        <p:spPr>
-          <a:xfrm>
-            <a:off x="9006840" y="5971032"/>
-            <a:ext cx="2544775" cy="219456"/>
-          </a:xfrm>
-          <a:prstGeom prst="rect">
-            <a:avLst/>
-          </a:prstGeom>
-          <a:noFill/>
-          <a:ln/>
-        </p:spPr>
-        <p:txBody>
-          <a:bodyPr wrap="square" lIns="0" tIns="0" rIns="0" bIns="0" rtlCol="0" anchor="t"/>
-          <a:lstStyle/>
-          <a:p>
-            <a:pPr indent="0" marL="0">
-              <a:buNone/>
-            </a:pPr>
-            <a:r>
-              <a:rPr lang="en-US" sz="1050" dirty="0">
-                <a:solidFill>
-                  <a:schemeClr val="accent5"/>
-                </a:solidFill>
-              </a:rPr>
-              <a:t>Obs. 6 y 7 nuevas · no es seguimiento</a:t>
-            </a:r>
-            <a:endParaRPr lang="en-US" sz="1050" dirty="0"/>
-          </a:p>
-        </p:txBody>
-      </p:sp>
-      <p:sp>
-        <p:nvSpPr>
-          <p:cNvPr id="25" name="Slide Number Placeholder 0"/>
-          <p:cNvSpPr>
-            <a:spLocks noGrp="1"/>
-          </p:cNvSpPr>
-          <p:nvPr>
-            <p:ph type="sldNum" sz="quarter" idx="4294967295"/>
-          </p:nvPr>
-        </p:nvSpPr>
-        <p:spPr>
-          <a:xfrm>
-            <a:off x="11094415" y="6400800"/>
-            <a:ext cx="548640" cy="274320"/>
-          </a:xfrm>
-          <a:prstGeom prst="rect">
-            <a:avLst/>
-          </a:prstGeom>
-          <a:extLst>
-            <a:ext uri="{C572A759-6A51-4108-AA02-DFA0A04FC94B}">
-              <ma14:wrappingTextBoxFlag xmlns:ma14="http://schemas.microsoft.com/office/mac/drawingml/2011/main" val="0"/>
-            </a:ext>
-          </a:extLst>
-        </p:spPr>
-        <p:txBody>
-          <a:bodyPr/>
-          <a:lstStyle>
-            <a:lvl1pPr>
-              <a:defRPr sz="1000">
-                <a:solidFill>
-                  <a:schemeClr val="accent5"/>
-                </a:solidFill>
-              </a:defRPr>
-            </a:lvl1pPr>
-          </a:lstStyle>
-          <a:p>
-            <a:pPr algn="r"/>
-            <a:fld id="{F7021451-1387-4CA6-816F-3879F97B5CBC}" type="slidenum">
-              <a:rPr b="0" lang="en-US"/>
-              <a:t>4</a:t>
             </a:fld>
             <a:endParaRPr lang="en-US"/>
           </a:p>

</xml_diff>

<commit_message>
Slide 1: show start/end dates in date blocks and circular date beside its number
Co-Authored-By: Claude Opus 5.5 <noreply@anthropic.com>
Claude-Session: https://claude.ai/code/session_01F1WXR13Nv8neEtLhaK3ELa
</commit_message>
<xml_diff>
--- a/supervision-gobierno-corporativo/Supervision_GC_SSF_COMEDICA_2025-2026.pptx
+++ b/supervision-gobierno-corporativo/Supervision_GC_SSF_COMEDICA_2025-2026.pptx
@@ -109,17 +109,17 @@
   <p:extLst>
     <p:ext uri="{521415D9-36F7-43E2-AB2F-B90AF26B5E84}">
       <p14:sectionLst xmlns:p14="http://schemas.microsoft.com/office/powerpoint/2010/main">
-        <p14:section name="1 · Resumen de circulares SSF" id="{5a24ffc2-a8e0-049f-ecc0-09267bc56beb}">
+        <p14:section name="1 · Resumen de circulares SSF" id="{e69be941-a94f-d308-442c-34a0e39c01f9}">
           <p14:sldIdLst>
             <p14:sldId id="256"/>
           </p14:sldIdLst>
         </p14:section>
-        <p14:section name="2 · Observaciones 2025" id="{700b8b80-88a2-9551-c054-5356091811fc}">
+        <p14:section name="2 · Observaciones 2025" id="{8942b9e4-87d0-b071-6138-fe37218b960c}">
           <p14:sldIdLst>
             <p14:sldId id="257"/>
           </p14:sldIdLst>
         </p14:section>
-        <p14:section name="3 · Observaciones 2026" id="{5f3d3702-92cf-fc86-202d-2e81c8a6ea34}">
+        <p14:section name="3 · Observaciones 2026" id="{115ce71f-e2c6-9019-d686-5aeee9903dd7}">
           <p14:sldIdLst>
             <p14:sldId id="258"/>
           </p14:sldIdLst>
@@ -2438,18 +2438,18 @@
       </p:sp>
       <p:sp>
         <p:nvSpPr>
-          <p:cNvPr id="27" name="Fecha fondo 2025-1"/>
+          <p:cNvPr id="27" name="Fechas fondo 2025-1"/>
           <p:cNvSpPr/>
           <p:nvPr/>
         </p:nvSpPr>
         <p:spPr>
           <a:xfrm>
             <a:off x="4709160" y="1234440"/>
-            <a:ext cx="914400" cy="1828800"/>
+            <a:ext cx="1051560" cy="1828800"/>
           </a:xfrm>
           <a:prstGeom prst="roundRect">
             <a:avLst>
-              <a:gd name="adj" fmla="val 10000"/>
+              <a:gd name="adj" fmla="val 8696"/>
             </a:avLst>
           </a:prstGeom>
           <a:solidFill>
@@ -2467,14 +2467,50 @@
       </p:sp>
       <p:sp>
         <p:nvSpPr>
-          <p:cNvPr id="28" name="Fecha día 2025-1"/>
-          <p:cNvSpPr txBox="1"/>
-          <p:nvPr/>
-        </p:nvSpPr>
-        <p:spPr>
-          <a:xfrm>
-            <a:off x="4709160" y="1554480"/>
-            <a:ext cx="914400" cy="548640"/>
+          <p:cNvPr id="28" name="Fecha etiqueta 2025-1-0"/>
+          <p:cNvSpPr txBox="1"/>
+          <p:nvPr/>
+        </p:nvSpPr>
+        <p:spPr>
+          <a:xfrm>
+            <a:off x="4709160" y="1325880"/>
+            <a:ext cx="1051560" cy="182880"/>
+          </a:xfrm>
+          <a:prstGeom prst="rect">
+            <a:avLst/>
+          </a:prstGeom>
+          <a:noFill/>
+          <a:ln/>
+        </p:spPr>
+        <p:txBody>
+          <a:bodyPr wrap="square" lIns="0" tIns="0" rIns="0" bIns="0" rtlCol="0" anchor="t"/>
+          <a:lstStyle/>
+          <a:p>
+            <a:pPr algn="ctr" indent="0" marL="0">
+              <a:buNone/>
+            </a:pPr>
+            <a:r>
+              <a:rPr lang="en-US" sz="800" b="1" spc="100" kern="0" dirty="0">
+                <a:solidFill>
+                  <a:schemeClr val="bg1"/>
+                </a:solidFill>
+              </a:rPr>
+              <a:t>INICIO DE VISITA</a:t>
+            </a:r>
+            <a:endParaRPr lang="en-US" sz="800" dirty="0"/>
+          </a:p>
+        </p:txBody>
+      </p:sp>
+      <p:sp>
+        <p:nvSpPr>
+          <p:cNvPr id="29" name="Fecha día 2025-1-0"/>
+          <p:cNvSpPr txBox="1"/>
+          <p:nvPr/>
+        </p:nvSpPr>
+        <p:spPr>
+          <a:xfrm>
+            <a:off x="4709160" y="1508760"/>
+            <a:ext cx="1051560" cy="384048"/>
           </a:xfrm>
           <a:prstGeom prst="rect">
             <a:avLst/>
@@ -2490,7 +2526,7 @@
               <a:buNone/>
             </a:pPr>
             <a:r>
-              <a:rPr lang="en-US" sz="3400" b="1" dirty="0">
+              <a:rPr lang="en-US" sz="2400" b="1" dirty="0">
                 <a:solidFill>
                   <a:schemeClr val="bg1"/>
                 </a:solidFill>
@@ -2498,22 +2534,22 @@
                 <a:ea typeface="Cambria" pitchFamily="34" charset="-122"/>
                 <a:cs typeface="Cambria" pitchFamily="34" charset="-120"/>
               </a:rPr>
-              <a:t>09</a:t>
-            </a:r>
-            <a:endParaRPr lang="en-US" sz="3400" dirty="0"/>
-          </a:p>
-        </p:txBody>
-      </p:sp>
-      <p:sp>
-        <p:nvSpPr>
-          <p:cNvPr id="29" name="Fecha mes 2025-1"/>
-          <p:cNvSpPr txBox="1"/>
-          <p:nvPr/>
-        </p:nvSpPr>
-        <p:spPr>
-          <a:xfrm>
-            <a:off x="4709160" y="2121408"/>
-            <a:ext cx="914400" cy="274320"/>
+              <a:t>19</a:t>
+            </a:r>
+            <a:endParaRPr lang="en-US" sz="2400" dirty="0"/>
+          </a:p>
+        </p:txBody>
+      </p:sp>
+      <p:sp>
+        <p:nvSpPr>
+          <p:cNvPr id="30" name="Fecha mes 2025-1-0"/>
+          <p:cNvSpPr txBox="1"/>
+          <p:nvPr/>
+        </p:nvSpPr>
+        <p:spPr>
+          <a:xfrm>
+            <a:off x="4709160" y="1892808"/>
+            <a:ext cx="1051560" cy="201168"/>
           </a:xfrm>
           <a:prstGeom prst="rect">
             <a:avLst/>
@@ -2529,12 +2565,184 @@
               <a:buNone/>
             </a:pPr>
             <a:r>
-              <a:rPr lang="en-US" sz="1400" b="1" spc="200" kern="0" dirty="0">
+              <a:rPr lang="en-US" sz="1000" b="1" spc="100" kern="0" dirty="0">
                 <a:solidFill>
                   <a:schemeClr val="bg1"/>
                 </a:solidFill>
               </a:rPr>
-              <a:t>ABR</a:t>
+              <a:t>MAY 2025</a:t>
+            </a:r>
+            <a:endParaRPr lang="en-US" sz="1000" dirty="0"/>
+          </a:p>
+        </p:txBody>
+      </p:sp>
+      <p:sp>
+        <p:nvSpPr>
+          <p:cNvPr id="31" name="Fecha etiqueta 2025-1-1"/>
+          <p:cNvSpPr txBox="1"/>
+          <p:nvPr/>
+        </p:nvSpPr>
+        <p:spPr>
+          <a:xfrm>
+            <a:off x="4709160" y="2240280"/>
+            <a:ext cx="1051560" cy="182880"/>
+          </a:xfrm>
+          <a:prstGeom prst="rect">
+            <a:avLst/>
+          </a:prstGeom>
+          <a:noFill/>
+          <a:ln/>
+        </p:spPr>
+        <p:txBody>
+          <a:bodyPr wrap="square" lIns="0" tIns="0" rIns="0" bIns="0" rtlCol="0" anchor="t"/>
+          <a:lstStyle/>
+          <a:p>
+            <a:pPr algn="ctr" indent="0" marL="0">
+              <a:buNone/>
+            </a:pPr>
+            <a:r>
+              <a:rPr lang="en-US" sz="800" b="1" spc="100" kern="0" dirty="0">
+                <a:solidFill>
+                  <a:schemeClr val="bg1"/>
+                </a:solidFill>
+              </a:rPr>
+              <a:t>INFORME</a:t>
+            </a:r>
+            <a:endParaRPr lang="en-US" sz="800" dirty="0"/>
+          </a:p>
+        </p:txBody>
+      </p:sp>
+      <p:sp>
+        <p:nvSpPr>
+          <p:cNvPr id="32" name="Fecha día 2025-1-1"/>
+          <p:cNvSpPr txBox="1"/>
+          <p:nvPr/>
+        </p:nvSpPr>
+        <p:spPr>
+          <a:xfrm>
+            <a:off x="4709160" y="2423160"/>
+            <a:ext cx="1051560" cy="384048"/>
+          </a:xfrm>
+          <a:prstGeom prst="rect">
+            <a:avLst/>
+          </a:prstGeom>
+          <a:noFill/>
+          <a:ln/>
+        </p:spPr>
+        <p:txBody>
+          <a:bodyPr wrap="square" lIns="0" tIns="0" rIns="0" bIns="0" rtlCol="0" anchor="ctr"/>
+          <a:lstStyle/>
+          <a:p>
+            <a:pPr algn="ctr" indent="0" marL="0">
+              <a:buNone/>
+            </a:pPr>
+            <a:r>
+              <a:rPr lang="en-US" sz="2400" b="1" dirty="0">
+                <a:solidFill>
+                  <a:schemeClr val="bg1"/>
+                </a:solidFill>
+                <a:latin typeface="Cambria" pitchFamily="34" charset="0"/>
+                <a:ea typeface="Cambria" pitchFamily="34" charset="-122"/>
+                <a:cs typeface="Cambria" pitchFamily="34" charset="-120"/>
+              </a:rPr>
+              <a:t>05</a:t>
+            </a:r>
+            <a:endParaRPr lang="en-US" sz="2400" dirty="0"/>
+          </a:p>
+        </p:txBody>
+      </p:sp>
+      <p:sp>
+        <p:nvSpPr>
+          <p:cNvPr id="33" name="Fecha mes 2025-1-1"/>
+          <p:cNvSpPr txBox="1"/>
+          <p:nvPr/>
+        </p:nvSpPr>
+        <p:spPr>
+          <a:xfrm>
+            <a:off x="4709160" y="2807208"/>
+            <a:ext cx="1051560" cy="201168"/>
+          </a:xfrm>
+          <a:prstGeom prst="rect">
+            <a:avLst/>
+          </a:prstGeom>
+          <a:noFill/>
+          <a:ln/>
+        </p:spPr>
+        <p:txBody>
+          <a:bodyPr wrap="square" lIns="0" tIns="0" rIns="0" bIns="0" rtlCol="0" anchor="t"/>
+          <a:lstStyle/>
+          <a:p>
+            <a:pPr algn="ctr" indent="0" marL="0">
+              <a:buNone/>
+            </a:pPr>
+            <a:r>
+              <a:rPr lang="en-US" sz="1000" b="1" spc="100" kern="0" dirty="0">
+                <a:solidFill>
+                  <a:schemeClr val="bg1"/>
+                </a:solidFill>
+              </a:rPr>
+              <a:t>NOV 2025</a:t>
+            </a:r>
+            <a:endParaRPr lang="en-US" sz="1000" dirty="0"/>
+          </a:p>
+        </p:txBody>
+      </p:sp>
+      <p:sp>
+        <p:nvSpPr>
+          <p:cNvPr id="34" name="Fechas separador 2025-1"/>
+          <p:cNvSpPr/>
+          <p:nvPr/>
+        </p:nvSpPr>
+        <p:spPr>
+          <a:xfrm>
+            <a:off x="4892040" y="2148840"/>
+            <a:ext cx="685800" cy="0"/>
+          </a:xfrm>
+          <a:prstGeom prst="line">
+            <a:avLst/>
+          </a:prstGeom>
+          <a:noFill/>
+          <a:ln w="9525">
+            <a:solidFill>
+              <a:schemeClr val="bg1">
+                <a:alpha val="60000"/>
+              </a:schemeClr>
+            </a:solidFill>
+            <a:prstDash val="solid"/>
+          </a:ln>
+        </p:spPr>
+      </p:sp>
+      <p:sp>
+        <p:nvSpPr>
+          <p:cNvPr id="35" name="Tipo 2025-1"/>
+          <p:cNvSpPr txBox="1"/>
+          <p:nvPr/>
+        </p:nvSpPr>
+        <p:spPr>
+          <a:xfrm>
+            <a:off x="5916168" y="1234440"/>
+            <a:ext cx="1843888" cy="502920"/>
+          </a:xfrm>
+          <a:prstGeom prst="rect">
+            <a:avLst/>
+          </a:prstGeom>
+          <a:noFill/>
+          <a:ln/>
+        </p:spPr>
+        <p:txBody>
+          <a:bodyPr wrap="square" lIns="0" tIns="0" rIns="0" bIns="0" rtlCol="0" anchor="ctr"/>
+          <a:lstStyle/>
+          <a:p>
+            <a:pPr indent="0" marL="0">
+              <a:buNone/>
+            </a:pPr>
+            <a:r>
+              <a:rPr lang="en-US" sz="1400" b="1" dirty="0">
+                <a:solidFill>
+                  <a:schemeClr val="tx1"/>
+                </a:solidFill>
+              </a:rPr>
+              <a:t>Nombramiento de visita ampliada</a:t>
             </a:r>
             <a:endParaRPr lang="en-US" sz="1400" dirty="0"/>
           </a:p>
@@ -2542,14 +2750,14 @@
       </p:sp>
       <p:sp>
         <p:nvSpPr>
-          <p:cNvPr id="30" name="Fecha año 2025-1"/>
-          <p:cNvSpPr txBox="1"/>
-          <p:nvPr/>
-        </p:nvSpPr>
-        <p:spPr>
-          <a:xfrm>
-            <a:off x="4709160" y="2423160"/>
-            <a:ext cx="914400" cy="274320"/>
+          <p:cNvPr id="36" name="Circular 2025-1"/>
+          <p:cNvSpPr txBox="1"/>
+          <p:nvPr/>
+        </p:nvSpPr>
+        <p:spPr>
+          <a:xfrm>
+            <a:off x="5916168" y="1810512"/>
+            <a:ext cx="1843888" cy="457200"/>
           </a:xfrm>
           <a:prstGeom prst="rect">
             <a:avLst/>
@@ -2561,78 +2769,6 @@
           <a:bodyPr wrap="square" lIns="0" tIns="0" rIns="0" bIns="0" rtlCol="0" anchor="t"/>
           <a:lstStyle/>
           <a:p>
-            <a:pPr algn="ctr" indent="0" marL="0">
-              <a:buNone/>
-            </a:pPr>
-            <a:r>
-              <a:rPr lang="en-US" sz="1200" dirty="0">
-                <a:solidFill>
-                  <a:schemeClr val="bg1"/>
-                </a:solidFill>
-              </a:rPr>
-              <a:t>2025</a:t>
-            </a:r>
-            <a:endParaRPr lang="en-US" sz="1200" dirty="0"/>
-          </a:p>
-        </p:txBody>
-      </p:sp>
-      <p:sp>
-        <p:nvSpPr>
-          <p:cNvPr id="31" name="Tipo 2025-1"/>
-          <p:cNvSpPr txBox="1"/>
-          <p:nvPr/>
-        </p:nvSpPr>
-        <p:spPr>
-          <a:xfrm>
-            <a:off x="5806440" y="1261872"/>
-            <a:ext cx="1935328" cy="502920"/>
-          </a:xfrm>
-          <a:prstGeom prst="rect">
-            <a:avLst/>
-          </a:prstGeom>
-          <a:noFill/>
-          <a:ln/>
-        </p:spPr>
-        <p:txBody>
-          <a:bodyPr wrap="square" lIns="0" tIns="0" rIns="0" bIns="0" rtlCol="0" anchor="ctr"/>
-          <a:lstStyle/>
-          <a:p>
-            <a:pPr indent="0" marL="0">
-              <a:buNone/>
-            </a:pPr>
-            <a:r>
-              <a:rPr lang="en-US" sz="1400" b="1" dirty="0">
-                <a:solidFill>
-                  <a:schemeClr val="tx1"/>
-                </a:solidFill>
-              </a:rPr>
-              <a:t>Nombramiento de visita ampliada</a:t>
-            </a:r>
-            <a:endParaRPr lang="en-US" sz="1400" dirty="0"/>
-          </a:p>
-        </p:txBody>
-      </p:sp>
-      <p:sp>
-        <p:nvSpPr>
-          <p:cNvPr id="32" name="Circular 2025-1"/>
-          <p:cNvSpPr txBox="1"/>
-          <p:nvPr/>
-        </p:nvSpPr>
-        <p:spPr>
-          <a:xfrm>
-            <a:off x="5806440" y="1828800"/>
-            <a:ext cx="1935328" cy="438912"/>
-          </a:xfrm>
-          <a:prstGeom prst="rect">
-            <a:avLst/>
-          </a:prstGeom>
-          <a:noFill/>
-          <a:ln/>
-        </p:spPr>
-        <p:txBody>
-          <a:bodyPr wrap="square" lIns="0" tIns="0" rIns="0" bIns="0" rtlCol="0" anchor="t"/>
-          <a:lstStyle/>
-          <a:p>
             <a:pPr indent="0" marL="0">
               <a:buNone/>
             </a:pPr>
@@ -2642,7 +2778,18 @@
                   <a:schemeClr val="accent5"/>
                 </a:solidFill>
               </a:rPr>
-              <a:t>Circular No.</a:t>
+              <a:t>Circular No.  </a:t>
+            </a:r>
+            <a:pPr indent="0" marL="0">
+              <a:buNone/>
+            </a:pPr>
+            <a:r>
+              <a:rPr lang="en-US" sz="1050" b="1" dirty="0">
+                <a:solidFill>
+                  <a:schemeClr val="accent1"/>
+                </a:solidFill>
+              </a:rPr>
+              <a:t>09/04/2025</a:t>
             </a:r>
             <a:endParaRPr lang="en-US" sz="1100" dirty="0"/>
           </a:p>
@@ -2664,14 +2811,14 @@
       </p:sp>
       <p:sp>
         <p:nvSpPr>
-          <p:cNvPr id="33" name="Separador 2025-1-0"/>
+          <p:cNvPr id="37" name="Separador 2025-1-0"/>
           <p:cNvSpPr/>
           <p:nvPr/>
         </p:nvSpPr>
         <p:spPr>
           <a:xfrm>
-            <a:off x="5806440" y="2340864"/>
-            <a:ext cx="1935328" cy="0"/>
+            <a:off x="5916168" y="2340864"/>
+            <a:ext cx="1843888" cy="0"/>
           </a:xfrm>
           <a:prstGeom prst="line">
             <a:avLst/>
@@ -2687,14 +2834,14 @@
       </p:sp>
       <p:sp>
         <p:nvSpPr>
-          <p:cNvPr id="34" name="Dato 2025-1-0"/>
-          <p:cNvSpPr txBox="1"/>
-          <p:nvPr/>
-        </p:nvSpPr>
-        <p:spPr>
-          <a:xfrm>
-            <a:off x="5806440" y="2377440"/>
-            <a:ext cx="1935328" cy="310896"/>
+          <p:cNvPr id="38" name="Dato 2025-1-0"/>
+          <p:cNvSpPr txBox="1"/>
+          <p:nvPr/>
+        </p:nvSpPr>
+        <p:spPr>
+          <a:xfrm>
+            <a:off x="5916168" y="2377440"/>
+            <a:ext cx="1843888" cy="310896"/>
           </a:xfrm>
           <a:prstGeom prst="rect">
             <a:avLst/>
@@ -2710,7 +2857,7 @@
               <a:buNone/>
             </a:pPr>
             <a:r>
-              <a:rPr lang="en-US" sz="1150" dirty="0">
+              <a:rPr lang="en-US" sz="1100" dirty="0">
                 <a:solidFill>
                   <a:schemeClr val="accent5"/>
                 </a:solidFill>
@@ -2721,27 +2868,27 @@
               <a:buNone/>
             </a:pPr>
             <a:r>
-              <a:rPr lang="en-US" sz="1150" b="1" dirty="0">
+              <a:rPr lang="en-US" sz="1100" b="1" dirty="0">
                 <a:solidFill>
                   <a:schemeClr val="tx1"/>
                 </a:solidFill>
               </a:rPr>
               <a:t>30/04/2025</a:t>
             </a:r>
-            <a:endParaRPr lang="en-US" sz="1150" dirty="0"/>
-          </a:p>
-        </p:txBody>
-      </p:sp>
-      <p:sp>
-        <p:nvSpPr>
-          <p:cNvPr id="35" name="Separador 2025-1-1"/>
+            <a:endParaRPr lang="en-US" sz="1100" dirty="0"/>
+          </a:p>
+        </p:txBody>
+      </p:sp>
+      <p:sp>
+        <p:nvSpPr>
+          <p:cNvPr id="39" name="Separador 2025-1-1"/>
           <p:cNvSpPr/>
           <p:nvPr/>
         </p:nvSpPr>
         <p:spPr>
           <a:xfrm>
-            <a:off x="5806440" y="2706624"/>
-            <a:ext cx="1935328" cy="0"/>
+            <a:off x="5916168" y="2706624"/>
+            <a:ext cx="1843888" cy="0"/>
           </a:xfrm>
           <a:prstGeom prst="line">
             <a:avLst/>
@@ -2757,14 +2904,14 @@
       </p:sp>
       <p:sp>
         <p:nvSpPr>
-          <p:cNvPr id="36" name="Dato 2025-1-1"/>
-          <p:cNvSpPr txBox="1"/>
-          <p:nvPr/>
-        </p:nvSpPr>
-        <p:spPr>
-          <a:xfrm>
-            <a:off x="5806440" y="2743200"/>
-            <a:ext cx="1935328" cy="310896"/>
+          <p:cNvPr id="40" name="Dato 2025-1-1"/>
+          <p:cNvSpPr txBox="1"/>
+          <p:nvPr/>
+        </p:nvSpPr>
+        <p:spPr>
+          <a:xfrm>
+            <a:off x="5916168" y="2743200"/>
+            <a:ext cx="1843888" cy="310896"/>
           </a:xfrm>
           <a:prstGeom prst="rect">
             <a:avLst/>
@@ -2780,31 +2927,31 @@
               <a:buNone/>
             </a:pPr>
             <a:r>
-              <a:rPr lang="en-US" sz="1150" dirty="0">
+              <a:rPr lang="en-US" sz="1100" dirty="0">
                 <a:solidFill>
                   <a:schemeClr val="accent5"/>
                 </a:solidFill>
               </a:rPr>
-              <a:t>Inicio de visita  </a:t>
-            </a:r>
-            <a:pPr indent="0" marL="0">
-              <a:buNone/>
-            </a:pPr>
-            <a:r>
-              <a:rPr lang="en-US" sz="1150" b="1" dirty="0">
+              <a:t>Alcance  </a:t>
+            </a:r>
+            <a:pPr indent="0" marL="0">
+              <a:buNone/>
+            </a:pPr>
+            <a:r>
+              <a:rPr lang="en-US" sz="1100" b="1" dirty="0">
                 <a:solidFill>
                   <a:schemeClr val="tx1"/>
                 </a:solidFill>
               </a:rPr>
-              <a:t>19/05/2025</a:t>
-            </a:r>
-            <a:endParaRPr lang="en-US" sz="1150" dirty="0"/>
-          </a:p>
-        </p:txBody>
-      </p:sp>
-      <p:sp>
-        <p:nvSpPr>
-          <p:cNvPr id="37" name="Tarjeta 2025-2"/>
+              <a:t>Gobierno Corporativo</a:t>
+            </a:r>
+            <a:endParaRPr lang="en-US" sz="1100" dirty="0"/>
+          </a:p>
+        </p:txBody>
+      </p:sp>
+      <p:sp>
+        <p:nvSpPr>
+          <p:cNvPr id="41" name="Tarjeta 2025-2"/>
           <p:cNvSpPr/>
           <p:nvPr/>
         </p:nvSpPr>
@@ -2831,18 +2978,18 @@
       </p:sp>
       <p:sp>
         <p:nvSpPr>
-          <p:cNvPr id="38" name="Fecha fondo 2025-2"/>
+          <p:cNvPr id="42" name="Fechas fondo 2025-2"/>
           <p:cNvSpPr/>
           <p:nvPr/>
         </p:nvSpPr>
         <p:spPr>
           <a:xfrm>
             <a:off x="8473288" y="1234440"/>
-            <a:ext cx="914400" cy="1828800"/>
+            <a:ext cx="1051560" cy="1828800"/>
           </a:xfrm>
           <a:prstGeom prst="roundRect">
             <a:avLst>
-              <a:gd name="adj" fmla="val 10000"/>
+              <a:gd name="adj" fmla="val 8696"/>
             </a:avLst>
           </a:prstGeom>
           <a:solidFill>
@@ -2860,14 +3007,50 @@
       </p:sp>
       <p:sp>
         <p:nvSpPr>
-          <p:cNvPr id="39" name="Fecha día 2025-2"/>
-          <p:cNvSpPr txBox="1"/>
-          <p:nvPr/>
-        </p:nvSpPr>
-        <p:spPr>
-          <a:xfrm>
-            <a:off x="8473288" y="1554480"/>
-            <a:ext cx="914400" cy="548640"/>
+          <p:cNvPr id="43" name="Fecha etiqueta 2025-2-0"/>
+          <p:cNvSpPr txBox="1"/>
+          <p:nvPr/>
+        </p:nvSpPr>
+        <p:spPr>
+          <a:xfrm>
+            <a:off x="8473288" y="1325880"/>
+            <a:ext cx="1051560" cy="182880"/>
+          </a:xfrm>
+          <a:prstGeom prst="rect">
+            <a:avLst/>
+          </a:prstGeom>
+          <a:noFill/>
+          <a:ln/>
+        </p:spPr>
+        <p:txBody>
+          <a:bodyPr wrap="square" lIns="0" tIns="0" rIns="0" bIns="0" rtlCol="0" anchor="t"/>
+          <a:lstStyle/>
+          <a:p>
+            <a:pPr algn="ctr" indent="0" marL="0">
+              <a:buNone/>
+            </a:pPr>
+            <a:r>
+              <a:rPr lang="en-US" sz="800" b="1" spc="100" kern="0" dirty="0">
+                <a:solidFill>
+                  <a:schemeClr val="bg1"/>
+                </a:solidFill>
+              </a:rPr>
+              <a:t>RECEPCIÓN</a:t>
+            </a:r>
+            <a:endParaRPr lang="en-US" sz="800" dirty="0"/>
+          </a:p>
+        </p:txBody>
+      </p:sp>
+      <p:sp>
+        <p:nvSpPr>
+          <p:cNvPr id="44" name="Fecha día 2025-2-0"/>
+          <p:cNvSpPr txBox="1"/>
+          <p:nvPr/>
+        </p:nvSpPr>
+        <p:spPr>
+          <a:xfrm>
+            <a:off x="8473288" y="1508760"/>
+            <a:ext cx="1051560" cy="384048"/>
           </a:xfrm>
           <a:prstGeom prst="rect">
             <a:avLst/>
@@ -2883,7 +3066,7 @@
               <a:buNone/>
             </a:pPr>
             <a:r>
-              <a:rPr lang="en-US" sz="3400" b="1" dirty="0">
+              <a:rPr lang="en-US" sz="2400" b="1" dirty="0">
                 <a:solidFill>
                   <a:schemeClr val="bg1"/>
                 </a:solidFill>
@@ -2893,20 +3076,20 @@
               </a:rPr>
               <a:t>05</a:t>
             </a:r>
-            <a:endParaRPr lang="en-US" sz="3400" dirty="0"/>
-          </a:p>
-        </p:txBody>
-      </p:sp>
-      <p:sp>
-        <p:nvSpPr>
-          <p:cNvPr id="40" name="Fecha mes 2025-2"/>
-          <p:cNvSpPr txBox="1"/>
-          <p:nvPr/>
-        </p:nvSpPr>
-        <p:spPr>
-          <a:xfrm>
-            <a:off x="8473288" y="2121408"/>
-            <a:ext cx="914400" cy="274320"/>
+            <a:endParaRPr lang="en-US" sz="2400" dirty="0"/>
+          </a:p>
+        </p:txBody>
+      </p:sp>
+      <p:sp>
+        <p:nvSpPr>
+          <p:cNvPr id="45" name="Fecha mes 2025-2-0"/>
+          <p:cNvSpPr txBox="1"/>
+          <p:nvPr/>
+        </p:nvSpPr>
+        <p:spPr>
+          <a:xfrm>
+            <a:off x="8473288" y="1892808"/>
+            <a:ext cx="1051560" cy="201168"/>
           </a:xfrm>
           <a:prstGeom prst="rect">
             <a:avLst/>
@@ -2922,12 +3105,184 @@
               <a:buNone/>
             </a:pPr>
             <a:r>
-              <a:rPr lang="en-US" sz="1400" b="1" spc="200" kern="0" dirty="0">
+              <a:rPr lang="en-US" sz="1000" b="1" spc="100" kern="0" dirty="0">
                 <a:solidFill>
                   <a:schemeClr val="bg1"/>
                 </a:solidFill>
               </a:rPr>
-              <a:t>NOV</a:t>
+              <a:t>NOV 2025</a:t>
+            </a:r>
+            <a:endParaRPr lang="en-US" sz="1000" dirty="0"/>
+          </a:p>
+        </p:txBody>
+      </p:sp>
+      <p:sp>
+        <p:nvSpPr>
+          <p:cNvPr id="46" name="Fecha etiqueta 2025-2-1"/>
+          <p:cNvSpPr txBox="1"/>
+          <p:nvPr/>
+        </p:nvSpPr>
+        <p:spPr>
+          <a:xfrm>
+            <a:off x="8473288" y="2240280"/>
+            <a:ext cx="1051560" cy="182880"/>
+          </a:xfrm>
+          <a:prstGeom prst="rect">
+            <a:avLst/>
+          </a:prstGeom>
+          <a:noFill/>
+          <a:ln/>
+        </p:spPr>
+        <p:txBody>
+          <a:bodyPr wrap="square" lIns="0" tIns="0" rIns="0" bIns="0" rtlCol="0" anchor="t"/>
+          <a:lstStyle/>
+          <a:p>
+            <a:pPr algn="ctr" indent="0" marL="0">
+              <a:buNone/>
+            </a:pPr>
+            <a:r>
+              <a:rPr lang="en-US" sz="800" b="1" spc="100" kern="0" dirty="0">
+                <a:solidFill>
+                  <a:schemeClr val="bg1"/>
+                </a:solidFill>
+              </a:rPr>
+              <a:t>DESCARGOS</a:t>
+            </a:r>
+            <a:endParaRPr lang="en-US" sz="800" dirty="0"/>
+          </a:p>
+        </p:txBody>
+      </p:sp>
+      <p:sp>
+        <p:nvSpPr>
+          <p:cNvPr id="47" name="Fecha día 2025-2-1"/>
+          <p:cNvSpPr txBox="1"/>
+          <p:nvPr/>
+        </p:nvSpPr>
+        <p:spPr>
+          <a:xfrm>
+            <a:off x="8473288" y="2423160"/>
+            <a:ext cx="1051560" cy="384048"/>
+          </a:xfrm>
+          <a:prstGeom prst="rect">
+            <a:avLst/>
+          </a:prstGeom>
+          <a:noFill/>
+          <a:ln/>
+        </p:spPr>
+        <p:txBody>
+          <a:bodyPr wrap="square" lIns="0" tIns="0" rIns="0" bIns="0" rtlCol="0" anchor="ctr"/>
+          <a:lstStyle/>
+          <a:p>
+            <a:pPr algn="ctr" indent="0" marL="0">
+              <a:buNone/>
+            </a:pPr>
+            <a:r>
+              <a:rPr lang="en-US" sz="2400" b="1" dirty="0">
+                <a:solidFill>
+                  <a:schemeClr val="bg1"/>
+                </a:solidFill>
+                <a:latin typeface="Cambria" pitchFamily="34" charset="0"/>
+                <a:ea typeface="Cambria" pitchFamily="34" charset="-122"/>
+                <a:cs typeface="Cambria" pitchFamily="34" charset="-120"/>
+              </a:rPr>
+              <a:t>18</a:t>
+            </a:r>
+            <a:endParaRPr lang="en-US" sz="2400" dirty="0"/>
+          </a:p>
+        </p:txBody>
+      </p:sp>
+      <p:sp>
+        <p:nvSpPr>
+          <p:cNvPr id="48" name="Fecha mes 2025-2-1"/>
+          <p:cNvSpPr txBox="1"/>
+          <p:nvPr/>
+        </p:nvSpPr>
+        <p:spPr>
+          <a:xfrm>
+            <a:off x="8473288" y="2807208"/>
+            <a:ext cx="1051560" cy="201168"/>
+          </a:xfrm>
+          <a:prstGeom prst="rect">
+            <a:avLst/>
+          </a:prstGeom>
+          <a:noFill/>
+          <a:ln/>
+        </p:spPr>
+        <p:txBody>
+          <a:bodyPr wrap="square" lIns="0" tIns="0" rIns="0" bIns="0" rtlCol="0" anchor="t"/>
+          <a:lstStyle/>
+          <a:p>
+            <a:pPr algn="ctr" indent="0" marL="0">
+              <a:buNone/>
+            </a:pPr>
+            <a:r>
+              <a:rPr lang="en-US" sz="1000" b="1" spc="100" kern="0" dirty="0">
+                <a:solidFill>
+                  <a:schemeClr val="bg1"/>
+                </a:solidFill>
+              </a:rPr>
+              <a:t>NOV 2025</a:t>
+            </a:r>
+            <a:endParaRPr lang="en-US" sz="1000" dirty="0"/>
+          </a:p>
+        </p:txBody>
+      </p:sp>
+      <p:sp>
+        <p:nvSpPr>
+          <p:cNvPr id="49" name="Fechas separador 2025-2"/>
+          <p:cNvSpPr/>
+          <p:nvPr/>
+        </p:nvSpPr>
+        <p:spPr>
+          <a:xfrm>
+            <a:off x="8656168" y="2148840"/>
+            <a:ext cx="685800" cy="0"/>
+          </a:xfrm>
+          <a:prstGeom prst="line">
+            <a:avLst/>
+          </a:prstGeom>
+          <a:noFill/>
+          <a:ln w="9525">
+            <a:solidFill>
+              <a:schemeClr val="bg1">
+                <a:alpha val="60000"/>
+              </a:schemeClr>
+            </a:solidFill>
+            <a:prstDash val="solid"/>
+          </a:ln>
+        </p:spPr>
+      </p:sp>
+      <p:sp>
+        <p:nvSpPr>
+          <p:cNvPr id="50" name="Tipo 2025-2"/>
+          <p:cNvSpPr txBox="1"/>
+          <p:nvPr/>
+        </p:nvSpPr>
+        <p:spPr>
+          <a:xfrm>
+            <a:off x="9680296" y="1234440"/>
+            <a:ext cx="1843888" cy="502920"/>
+          </a:xfrm>
+          <a:prstGeom prst="rect">
+            <a:avLst/>
+          </a:prstGeom>
+          <a:noFill/>
+          <a:ln/>
+        </p:spPr>
+        <p:txBody>
+          <a:bodyPr wrap="square" lIns="0" tIns="0" rIns="0" bIns="0" rtlCol="0" anchor="ctr"/>
+          <a:lstStyle/>
+          <a:p>
+            <a:pPr indent="0" marL="0">
+              <a:buNone/>
+            </a:pPr>
+            <a:r>
+              <a:rPr lang="en-US" sz="1400" b="1" dirty="0">
+                <a:solidFill>
+                  <a:schemeClr val="tx1"/>
+                </a:solidFill>
+              </a:rPr>
+              <a:t>Resultados preliminares</a:t>
             </a:r>
             <a:endParaRPr lang="en-US" sz="1400" dirty="0"/>
           </a:p>
@@ -2935,14 +3290,14 @@
       </p:sp>
       <p:sp>
         <p:nvSpPr>
-          <p:cNvPr id="41" name="Fecha año 2025-2"/>
-          <p:cNvSpPr txBox="1"/>
-          <p:nvPr/>
-        </p:nvSpPr>
-        <p:spPr>
-          <a:xfrm>
-            <a:off x="8473288" y="2423160"/>
-            <a:ext cx="914400" cy="274320"/>
+          <p:cNvPr id="51" name="Circular 2025-2"/>
+          <p:cNvSpPr txBox="1"/>
+          <p:nvPr/>
+        </p:nvSpPr>
+        <p:spPr>
+          <a:xfrm>
+            <a:off x="9680296" y="1810512"/>
+            <a:ext cx="1843888" cy="457200"/>
           </a:xfrm>
           <a:prstGeom prst="rect">
             <a:avLst/>
@@ -2954,78 +3309,6 @@
           <a:bodyPr wrap="square" lIns="0" tIns="0" rIns="0" bIns="0" rtlCol="0" anchor="t"/>
           <a:lstStyle/>
           <a:p>
-            <a:pPr algn="ctr" indent="0" marL="0">
-              <a:buNone/>
-            </a:pPr>
-            <a:r>
-              <a:rPr lang="en-US" sz="1200" dirty="0">
-                <a:solidFill>
-                  <a:schemeClr val="bg1"/>
-                </a:solidFill>
-              </a:rPr>
-              <a:t>2025</a:t>
-            </a:r>
-            <a:endParaRPr lang="en-US" sz="1200" dirty="0"/>
-          </a:p>
-        </p:txBody>
-      </p:sp>
-      <p:sp>
-        <p:nvSpPr>
-          <p:cNvPr id="42" name="Tipo 2025-2"/>
-          <p:cNvSpPr txBox="1"/>
-          <p:nvPr/>
-        </p:nvSpPr>
-        <p:spPr>
-          <a:xfrm>
-            <a:off x="9570568" y="1261872"/>
-            <a:ext cx="1935328" cy="502920"/>
-          </a:xfrm>
-          <a:prstGeom prst="rect">
-            <a:avLst/>
-          </a:prstGeom>
-          <a:noFill/>
-          <a:ln/>
-        </p:spPr>
-        <p:txBody>
-          <a:bodyPr wrap="square" lIns="0" tIns="0" rIns="0" bIns="0" rtlCol="0" anchor="ctr"/>
-          <a:lstStyle/>
-          <a:p>
-            <a:pPr indent="0" marL="0">
-              <a:buNone/>
-            </a:pPr>
-            <a:r>
-              <a:rPr lang="en-US" sz="1400" b="1" dirty="0">
-                <a:solidFill>
-                  <a:schemeClr val="tx1"/>
-                </a:solidFill>
-              </a:rPr>
-              <a:t>Resultados preliminares</a:t>
-            </a:r>
-            <a:endParaRPr lang="en-US" sz="1400" dirty="0"/>
-          </a:p>
-        </p:txBody>
-      </p:sp>
-      <p:sp>
-        <p:nvSpPr>
-          <p:cNvPr id="43" name="Circular 2025-2"/>
-          <p:cNvSpPr txBox="1"/>
-          <p:nvPr/>
-        </p:nvSpPr>
-        <p:spPr>
-          <a:xfrm>
-            <a:off x="9570568" y="1828800"/>
-            <a:ext cx="1935328" cy="438912"/>
-          </a:xfrm>
-          <a:prstGeom prst="rect">
-            <a:avLst/>
-          </a:prstGeom>
-          <a:noFill/>
-          <a:ln/>
-        </p:spPr>
-        <p:txBody>
-          <a:bodyPr wrap="square" lIns="0" tIns="0" rIns="0" bIns="0" rtlCol="0" anchor="t"/>
-          <a:lstStyle/>
-          <a:p>
             <a:pPr indent="0" marL="0">
               <a:buNone/>
             </a:pPr>
@@ -3035,7 +3318,18 @@
                   <a:schemeClr val="accent5"/>
                 </a:solidFill>
               </a:rPr>
-              <a:t>Circular No.</a:t>
+              <a:t>Circular No.  </a:t>
+            </a:r>
+            <a:pPr indent="0" marL="0">
+              <a:buNone/>
+            </a:pPr>
+            <a:r>
+              <a:rPr lang="en-US" sz="1050" b="1" dirty="0">
+                <a:solidFill>
+                  <a:schemeClr val="accent1"/>
+                </a:solidFill>
+              </a:rPr>
+              <a:t>05/11/2025</a:t>
             </a:r>
             <a:endParaRPr lang="en-US" sz="1100" dirty="0"/>
           </a:p>
@@ -3057,14 +3351,14 @@
       </p:sp>
       <p:sp>
         <p:nvSpPr>
-          <p:cNvPr id="44" name="Separador 2025-2-0"/>
+          <p:cNvPr id="52" name="Separador 2025-2-0"/>
           <p:cNvSpPr/>
           <p:nvPr/>
         </p:nvSpPr>
         <p:spPr>
           <a:xfrm>
-            <a:off x="9570568" y="2340864"/>
-            <a:ext cx="1935328" cy="0"/>
+            <a:off x="9680296" y="2340864"/>
+            <a:ext cx="1843888" cy="0"/>
           </a:xfrm>
           <a:prstGeom prst="line">
             <a:avLst/>
@@ -3080,14 +3374,14 @@
       </p:sp>
       <p:sp>
         <p:nvSpPr>
-          <p:cNvPr id="45" name="Dato 2025-2-0"/>
-          <p:cNvSpPr txBox="1"/>
-          <p:nvPr/>
-        </p:nvSpPr>
-        <p:spPr>
-          <a:xfrm>
-            <a:off x="9570568" y="2377440"/>
-            <a:ext cx="1935328" cy="310896"/>
+          <p:cNvPr id="53" name="Dato 2025-2-0"/>
+          <p:cNvSpPr txBox="1"/>
+          <p:nvPr/>
+        </p:nvSpPr>
+        <p:spPr>
+          <a:xfrm>
+            <a:off x="9680296" y="2377440"/>
+            <a:ext cx="1843888" cy="310896"/>
           </a:xfrm>
           <a:prstGeom prst="rect">
             <a:avLst/>
@@ -3103,7 +3397,7 @@
               <a:buNone/>
             </a:pPr>
             <a:r>
-              <a:rPr lang="en-US" sz="1150" dirty="0">
+              <a:rPr lang="en-US" sz="1100" dirty="0">
                 <a:solidFill>
                   <a:schemeClr val="accent5"/>
                 </a:solidFill>
@@ -3114,27 +3408,27 @@
               <a:buNone/>
             </a:pPr>
             <a:r>
-              <a:rPr lang="en-US" sz="1150" b="1" dirty="0">
+              <a:rPr lang="en-US" sz="1100" b="1" dirty="0">
                 <a:solidFill>
                   <a:schemeClr val="tx1"/>
                 </a:solidFill>
               </a:rPr>
               <a:t>9 observaciones</a:t>
             </a:r>
-            <a:endParaRPr lang="en-US" sz="1150" dirty="0"/>
-          </a:p>
-        </p:txBody>
-      </p:sp>
-      <p:sp>
-        <p:nvSpPr>
-          <p:cNvPr id="46" name="Separador 2025-2-1"/>
+            <a:endParaRPr lang="en-US" sz="1100" dirty="0"/>
+          </a:p>
+        </p:txBody>
+      </p:sp>
+      <p:sp>
+        <p:nvSpPr>
+          <p:cNvPr id="54" name="Separador 2025-2-1"/>
           <p:cNvSpPr/>
           <p:nvPr/>
         </p:nvSpPr>
         <p:spPr>
           <a:xfrm>
-            <a:off x="9570568" y="2706624"/>
-            <a:ext cx="1935328" cy="0"/>
+            <a:off x="9680296" y="2706624"/>
+            <a:ext cx="1843888" cy="0"/>
           </a:xfrm>
           <a:prstGeom prst="line">
             <a:avLst/>
@@ -3150,14 +3444,14 @@
       </p:sp>
       <p:sp>
         <p:nvSpPr>
-          <p:cNvPr id="47" name="Dato 2025-2-1"/>
-          <p:cNvSpPr txBox="1"/>
-          <p:nvPr/>
-        </p:nvSpPr>
-        <p:spPr>
-          <a:xfrm>
-            <a:off x="9570568" y="2743200"/>
-            <a:ext cx="1935328" cy="310896"/>
+          <p:cNvPr id="55" name="Dato 2025-2-1"/>
+          <p:cNvSpPr txBox="1"/>
+          <p:nvPr/>
+        </p:nvSpPr>
+        <p:spPr>
+          <a:xfrm>
+            <a:off x="9680296" y="2743200"/>
+            <a:ext cx="1843888" cy="310896"/>
           </a:xfrm>
           <a:prstGeom prst="rect">
             <a:avLst/>
@@ -3173,31 +3467,31 @@
               <a:buNone/>
             </a:pPr>
             <a:r>
-              <a:rPr lang="en-US" sz="1150" dirty="0">
+              <a:rPr lang="en-US" sz="1100" dirty="0">
                 <a:solidFill>
                   <a:schemeClr val="accent5"/>
                 </a:solidFill>
               </a:rPr>
-              <a:t>Descargos  </a:t>
-            </a:r>
-            <a:pPr indent="0" marL="0">
-              <a:buNone/>
-            </a:pPr>
-            <a:r>
-              <a:rPr lang="en-US" sz="1150" b="1" dirty="0">
+              <a:t>Ref. envío  </a:t>
+            </a:r>
+            <a:pPr indent="0" marL="0">
+              <a:buNone/>
+            </a:pPr>
+            <a:r>
+              <a:rPr lang="en-US" sz="1100" b="1" dirty="0">
                 <a:solidFill>
                   <a:schemeClr val="tx1"/>
                 </a:solidFill>
               </a:rPr>
-              <a:t>18/11/2025</a:t>
-            </a:r>
-            <a:endParaRPr lang="en-US" sz="1150" dirty="0"/>
-          </a:p>
-        </p:txBody>
-      </p:sp>
-      <p:sp>
-        <p:nvSpPr>
-          <p:cNvPr id="48" name="Flecha 2025"/>
+              <a:t>NB07-2025-974</a:t>
+            </a:r>
+            <a:endParaRPr lang="en-US" sz="1100" dirty="0"/>
+          </a:p>
+        </p:txBody>
+      </p:sp>
+      <p:sp>
+        <p:nvSpPr>
+          <p:cNvPr id="56" name="Flecha 2025"/>
           <p:cNvSpPr/>
           <p:nvPr/>
         </p:nvSpPr>
@@ -3224,7 +3518,7 @@
       </p:sp>
       <p:sp>
         <p:nvSpPr>
-          <p:cNvPr id="49" name="Año 2026"/>
+          <p:cNvPr id="57" name="Año 2026"/>
           <p:cNvSpPr txBox="1"/>
           <p:nvPr/>
         </p:nvSpPr>
@@ -3263,7 +3557,7 @@
       </p:sp>
       <p:sp>
         <p:nvSpPr>
-          <p:cNvPr id="50" name="Visita 2026"/>
+          <p:cNvPr id="58" name="Visita 2026"/>
           <p:cNvSpPr txBox="1"/>
           <p:nvPr/>
         </p:nvSpPr>
@@ -3299,7 +3593,7 @@
       </p:sp>
       <p:sp>
         <p:nvSpPr>
-          <p:cNvPr id="51" name="Tarjeta 2026-1"/>
+          <p:cNvPr id="59" name="Tarjeta 2026-1"/>
           <p:cNvSpPr/>
           <p:nvPr/>
         </p:nvSpPr>
@@ -3326,18 +3620,18 @@
       </p:sp>
       <p:sp>
         <p:nvSpPr>
-          <p:cNvPr id="52" name="Fecha fondo 2026-1"/>
+          <p:cNvPr id="60" name="Fechas fondo 2026-1"/>
           <p:cNvSpPr/>
           <p:nvPr/>
         </p:nvSpPr>
         <p:spPr>
           <a:xfrm>
             <a:off x="4709160" y="4178808"/>
-            <a:ext cx="914400" cy="1828800"/>
+            <a:ext cx="1051560" cy="1828800"/>
           </a:xfrm>
           <a:prstGeom prst="roundRect">
             <a:avLst>
-              <a:gd name="adj" fmla="val 10000"/>
+              <a:gd name="adj" fmla="val 8696"/>
             </a:avLst>
           </a:prstGeom>
           <a:solidFill>
@@ -3355,14 +3649,50 @@
       </p:sp>
       <p:sp>
         <p:nvSpPr>
-          <p:cNvPr id="53" name="Fecha día 2026-1"/>
-          <p:cNvSpPr txBox="1"/>
-          <p:nvPr/>
-        </p:nvSpPr>
-        <p:spPr>
-          <a:xfrm>
-            <a:off x="4709160" y="4498848"/>
-            <a:ext cx="914400" cy="548640"/>
+          <p:cNvPr id="61" name="Fecha etiqueta 2026-1-0"/>
+          <p:cNvSpPr txBox="1"/>
+          <p:nvPr/>
+        </p:nvSpPr>
+        <p:spPr>
+          <a:xfrm>
+            <a:off x="4709160" y="4270248"/>
+            <a:ext cx="1051560" cy="182880"/>
+          </a:xfrm>
+          <a:prstGeom prst="rect">
+            <a:avLst/>
+          </a:prstGeom>
+          <a:noFill/>
+          <a:ln/>
+        </p:spPr>
+        <p:txBody>
+          <a:bodyPr wrap="square" lIns="0" tIns="0" rIns="0" bIns="0" rtlCol="0" anchor="t"/>
+          <a:lstStyle/>
+          <a:p>
+            <a:pPr algn="ctr" indent="0" marL="0">
+              <a:buNone/>
+            </a:pPr>
+            <a:r>
+              <a:rPr lang="en-US" sz="800" b="1" spc="100" kern="0" dirty="0">
+                <a:solidFill>
+                  <a:schemeClr val="bg1"/>
+                </a:solidFill>
+              </a:rPr>
+              <a:t>INICIO DE VISITA</a:t>
+            </a:r>
+            <a:endParaRPr lang="en-US" sz="800" dirty="0"/>
+          </a:p>
+        </p:txBody>
+      </p:sp>
+      <p:sp>
+        <p:nvSpPr>
+          <p:cNvPr id="62" name="Fecha día 2026-1-0"/>
+          <p:cNvSpPr txBox="1"/>
+          <p:nvPr/>
+        </p:nvSpPr>
+        <p:spPr>
+          <a:xfrm>
+            <a:off x="4709160" y="4453128"/>
+            <a:ext cx="1051560" cy="384048"/>
           </a:xfrm>
           <a:prstGeom prst="rect">
             <a:avLst/>
@@ -3378,7 +3708,7 @@
               <a:buNone/>
             </a:pPr>
             <a:r>
-              <a:rPr lang="en-US" sz="3400" b="1" dirty="0">
+              <a:rPr lang="en-US" sz="2400" b="1" dirty="0">
                 <a:solidFill>
                   <a:schemeClr val="bg1"/>
                 </a:solidFill>
@@ -3386,22 +3716,22 @@
                 <a:ea typeface="Cambria" pitchFamily="34" charset="-122"/>
                 <a:cs typeface="Cambria" pitchFamily="34" charset="-120"/>
               </a:rPr>
-              <a:t>31</a:t>
-            </a:r>
-            <a:endParaRPr lang="en-US" sz="3400" dirty="0"/>
-          </a:p>
-        </p:txBody>
-      </p:sp>
-      <p:sp>
-        <p:nvSpPr>
-          <p:cNvPr id="54" name="Fecha mes 2026-1"/>
-          <p:cNvSpPr txBox="1"/>
-          <p:nvPr/>
-        </p:nvSpPr>
-        <p:spPr>
-          <a:xfrm>
-            <a:off x="4709160" y="5065776"/>
-            <a:ext cx="914400" cy="274320"/>
+              <a:t>21</a:t>
+            </a:r>
+            <a:endParaRPr lang="en-US" sz="2400" dirty="0"/>
+          </a:p>
+        </p:txBody>
+      </p:sp>
+      <p:sp>
+        <p:nvSpPr>
+          <p:cNvPr id="63" name="Fecha mes 2026-1-0"/>
+          <p:cNvSpPr txBox="1"/>
+          <p:nvPr/>
+        </p:nvSpPr>
+        <p:spPr>
+          <a:xfrm>
+            <a:off x="4709160" y="4837176"/>
+            <a:ext cx="1051560" cy="201168"/>
           </a:xfrm>
           <a:prstGeom prst="rect">
             <a:avLst/>
@@ -3417,12 +3747,184 @@
               <a:buNone/>
             </a:pPr>
             <a:r>
-              <a:rPr lang="en-US" sz="1400" b="1" spc="200" kern="0" dirty="0">
+              <a:rPr lang="en-US" sz="1000" b="1" spc="100" kern="0" dirty="0">
                 <a:solidFill>
                   <a:schemeClr val="bg1"/>
                 </a:solidFill>
               </a:rPr>
-              <a:t>JUL</a:t>
+              <a:t>AGO 2026</a:t>
+            </a:r>
+            <a:endParaRPr lang="en-US" sz="1000" dirty="0"/>
+          </a:p>
+        </p:txBody>
+      </p:sp>
+      <p:sp>
+        <p:nvSpPr>
+          <p:cNvPr id="64" name="Fecha etiqueta 2026-1-1"/>
+          <p:cNvSpPr txBox="1"/>
+          <p:nvPr/>
+        </p:nvSpPr>
+        <p:spPr>
+          <a:xfrm>
+            <a:off x="4709160" y="5184648"/>
+            <a:ext cx="1051560" cy="182880"/>
+          </a:xfrm>
+          <a:prstGeom prst="rect">
+            <a:avLst/>
+          </a:prstGeom>
+          <a:noFill/>
+          <a:ln/>
+        </p:spPr>
+        <p:txBody>
+          <a:bodyPr wrap="square" lIns="0" tIns="0" rIns="0" bIns="0" rtlCol="0" anchor="t"/>
+          <a:lstStyle/>
+          <a:p>
+            <a:pPr algn="ctr" indent="0" marL="0">
+              <a:buNone/>
+            </a:pPr>
+            <a:r>
+              <a:rPr lang="en-US" sz="800" b="1" spc="100" kern="0" dirty="0">
+                <a:solidFill>
+                  <a:schemeClr val="bg1"/>
+                </a:solidFill>
+              </a:rPr>
+              <a:t>INFORME</a:t>
+            </a:r>
+            <a:endParaRPr lang="en-US" sz="800" dirty="0"/>
+          </a:p>
+        </p:txBody>
+      </p:sp>
+      <p:sp>
+        <p:nvSpPr>
+          <p:cNvPr id="65" name="Fecha día 2026-1-1"/>
+          <p:cNvSpPr txBox="1"/>
+          <p:nvPr/>
+        </p:nvSpPr>
+        <p:spPr>
+          <a:xfrm>
+            <a:off x="4709160" y="5367528"/>
+            <a:ext cx="1051560" cy="384048"/>
+          </a:xfrm>
+          <a:prstGeom prst="rect">
+            <a:avLst/>
+          </a:prstGeom>
+          <a:noFill/>
+          <a:ln/>
+        </p:spPr>
+        <p:txBody>
+          <a:bodyPr wrap="square" lIns="0" tIns="0" rIns="0" bIns="0" rtlCol="0" anchor="ctr"/>
+          <a:lstStyle/>
+          <a:p>
+            <a:pPr algn="ctr" indent="0" marL="0">
+              <a:buNone/>
+            </a:pPr>
+            <a:r>
+              <a:rPr lang="en-US" sz="2400" b="1" dirty="0">
+                <a:solidFill>
+                  <a:schemeClr val="bg1"/>
+                </a:solidFill>
+                <a:latin typeface="Cambria" pitchFamily="34" charset="0"/>
+                <a:ea typeface="Cambria" pitchFamily="34" charset="-122"/>
+                <a:cs typeface="Cambria" pitchFamily="34" charset="-120"/>
+              </a:rPr>
+              <a:t>09</a:t>
+            </a:r>
+            <a:endParaRPr lang="en-US" sz="2400" dirty="0"/>
+          </a:p>
+        </p:txBody>
+      </p:sp>
+      <p:sp>
+        <p:nvSpPr>
+          <p:cNvPr id="66" name="Fecha mes 2026-1-1"/>
+          <p:cNvSpPr txBox="1"/>
+          <p:nvPr/>
+        </p:nvSpPr>
+        <p:spPr>
+          <a:xfrm>
+            <a:off x="4709160" y="5751576"/>
+            <a:ext cx="1051560" cy="201168"/>
+          </a:xfrm>
+          <a:prstGeom prst="rect">
+            <a:avLst/>
+          </a:prstGeom>
+          <a:noFill/>
+          <a:ln/>
+        </p:spPr>
+        <p:txBody>
+          <a:bodyPr wrap="square" lIns="0" tIns="0" rIns="0" bIns="0" rtlCol="0" anchor="t"/>
+          <a:lstStyle/>
+          <a:p>
+            <a:pPr algn="ctr" indent="0" marL="0">
+              <a:buNone/>
+            </a:pPr>
+            <a:r>
+              <a:rPr lang="en-US" sz="1000" b="1" spc="100" kern="0" dirty="0">
+                <a:solidFill>
+                  <a:schemeClr val="bg1"/>
+                </a:solidFill>
+              </a:rPr>
+              <a:t>OCT 2026</a:t>
+            </a:r>
+            <a:endParaRPr lang="en-US" sz="1000" dirty="0"/>
+          </a:p>
+        </p:txBody>
+      </p:sp>
+      <p:sp>
+        <p:nvSpPr>
+          <p:cNvPr id="67" name="Fechas separador 2026-1"/>
+          <p:cNvSpPr/>
+          <p:nvPr/>
+        </p:nvSpPr>
+        <p:spPr>
+          <a:xfrm>
+            <a:off x="4892040" y="5093208"/>
+            <a:ext cx="685800" cy="0"/>
+          </a:xfrm>
+          <a:prstGeom prst="line">
+            <a:avLst/>
+          </a:prstGeom>
+          <a:noFill/>
+          <a:ln w="9525">
+            <a:solidFill>
+              <a:schemeClr val="bg1">
+                <a:alpha val="60000"/>
+              </a:schemeClr>
+            </a:solidFill>
+            <a:prstDash val="solid"/>
+          </a:ln>
+        </p:spPr>
+      </p:sp>
+      <p:sp>
+        <p:nvSpPr>
+          <p:cNvPr id="68" name="Tipo 2026-1"/>
+          <p:cNvSpPr txBox="1"/>
+          <p:nvPr/>
+        </p:nvSpPr>
+        <p:spPr>
+          <a:xfrm>
+            <a:off x="5916168" y="4178808"/>
+            <a:ext cx="1843888" cy="502920"/>
+          </a:xfrm>
+          <a:prstGeom prst="rect">
+            <a:avLst/>
+          </a:prstGeom>
+          <a:noFill/>
+          <a:ln/>
+        </p:spPr>
+        <p:txBody>
+          <a:bodyPr wrap="square" lIns="0" tIns="0" rIns="0" bIns="0" rtlCol="0" anchor="ctr"/>
+          <a:lstStyle/>
+          <a:p>
+            <a:pPr indent="0" marL="0">
+              <a:buNone/>
+            </a:pPr>
+            <a:r>
+              <a:rPr lang="en-US" sz="1400" b="1" dirty="0">
+                <a:solidFill>
+                  <a:schemeClr val="tx1"/>
+                </a:solidFill>
+              </a:rPr>
+              <a:t>Nombramiento de visita ampliada</a:t>
             </a:r>
             <a:endParaRPr lang="en-US" sz="1400" dirty="0"/>
           </a:p>
@@ -3430,14 +3932,14 @@
       </p:sp>
       <p:sp>
         <p:nvSpPr>
-          <p:cNvPr id="55" name="Fecha año 2026-1"/>
-          <p:cNvSpPr txBox="1"/>
-          <p:nvPr/>
-        </p:nvSpPr>
-        <p:spPr>
-          <a:xfrm>
-            <a:off x="4709160" y="5367528"/>
-            <a:ext cx="914400" cy="274320"/>
+          <p:cNvPr id="69" name="Circular 2026-1"/>
+          <p:cNvSpPr txBox="1"/>
+          <p:nvPr/>
+        </p:nvSpPr>
+        <p:spPr>
+          <a:xfrm>
+            <a:off x="5916168" y="4754880"/>
+            <a:ext cx="1843888" cy="457200"/>
           </a:xfrm>
           <a:prstGeom prst="rect">
             <a:avLst/>
@@ -3449,78 +3951,6 @@
           <a:bodyPr wrap="square" lIns="0" tIns="0" rIns="0" bIns="0" rtlCol="0" anchor="t"/>
           <a:lstStyle/>
           <a:p>
-            <a:pPr algn="ctr" indent="0" marL="0">
-              <a:buNone/>
-            </a:pPr>
-            <a:r>
-              <a:rPr lang="en-US" sz="1200" dirty="0">
-                <a:solidFill>
-                  <a:schemeClr val="bg1"/>
-                </a:solidFill>
-              </a:rPr>
-              <a:t>2026</a:t>
-            </a:r>
-            <a:endParaRPr lang="en-US" sz="1200" dirty="0"/>
-          </a:p>
-        </p:txBody>
-      </p:sp>
-      <p:sp>
-        <p:nvSpPr>
-          <p:cNvPr id="56" name="Tipo 2026-1"/>
-          <p:cNvSpPr txBox="1"/>
-          <p:nvPr/>
-        </p:nvSpPr>
-        <p:spPr>
-          <a:xfrm>
-            <a:off x="5806440" y="4206240"/>
-            <a:ext cx="1935328" cy="502920"/>
-          </a:xfrm>
-          <a:prstGeom prst="rect">
-            <a:avLst/>
-          </a:prstGeom>
-          <a:noFill/>
-          <a:ln/>
-        </p:spPr>
-        <p:txBody>
-          <a:bodyPr wrap="square" lIns="0" tIns="0" rIns="0" bIns="0" rtlCol="0" anchor="ctr"/>
-          <a:lstStyle/>
-          <a:p>
-            <a:pPr indent="0" marL="0">
-              <a:buNone/>
-            </a:pPr>
-            <a:r>
-              <a:rPr lang="en-US" sz="1400" b="1" dirty="0">
-                <a:solidFill>
-                  <a:schemeClr val="tx1"/>
-                </a:solidFill>
-              </a:rPr>
-              <a:t>Nombramiento de visita ampliada</a:t>
-            </a:r>
-            <a:endParaRPr lang="en-US" sz="1400" dirty="0"/>
-          </a:p>
-        </p:txBody>
-      </p:sp>
-      <p:sp>
-        <p:nvSpPr>
-          <p:cNvPr id="57" name="Circular 2026-1"/>
-          <p:cNvSpPr txBox="1"/>
-          <p:nvPr/>
-        </p:nvSpPr>
-        <p:spPr>
-          <a:xfrm>
-            <a:off x="5806440" y="4773168"/>
-            <a:ext cx="1935328" cy="438912"/>
-          </a:xfrm>
-          <a:prstGeom prst="rect">
-            <a:avLst/>
-          </a:prstGeom>
-          <a:noFill/>
-          <a:ln/>
-        </p:spPr>
-        <p:txBody>
-          <a:bodyPr wrap="square" lIns="0" tIns="0" rIns="0" bIns="0" rtlCol="0" anchor="t"/>
-          <a:lstStyle/>
-          <a:p>
             <a:pPr indent="0" marL="0">
               <a:buNone/>
             </a:pPr>
@@ -3530,7 +3960,18 @@
                   <a:schemeClr val="accent5"/>
                 </a:solidFill>
               </a:rPr>
-              <a:t>Circular No.</a:t>
+              <a:t>Circular No.  </a:t>
+            </a:r>
+            <a:pPr indent="0" marL="0">
+              <a:buNone/>
+            </a:pPr>
+            <a:r>
+              <a:rPr lang="en-US" sz="1050" b="1" dirty="0">
+                <a:solidFill>
+                  <a:schemeClr val="accent2"/>
+                </a:solidFill>
+              </a:rPr>
+              <a:t>31/07/2026</a:t>
             </a:r>
             <a:endParaRPr lang="en-US" sz="1100" dirty="0"/>
           </a:p>
@@ -3552,14 +3993,14 @@
       </p:sp>
       <p:sp>
         <p:nvSpPr>
-          <p:cNvPr id="58" name="Separador 2026-1-0"/>
+          <p:cNvPr id="70" name="Separador 2026-1-0"/>
           <p:cNvSpPr/>
           <p:nvPr/>
         </p:nvSpPr>
         <p:spPr>
           <a:xfrm>
-            <a:off x="5806440" y="5285232"/>
-            <a:ext cx="1935328" cy="0"/>
+            <a:off x="5916168" y="5285232"/>
+            <a:ext cx="1843888" cy="0"/>
           </a:xfrm>
           <a:prstGeom prst="line">
             <a:avLst/>
@@ -3575,14 +4016,14 @@
       </p:sp>
       <p:sp>
         <p:nvSpPr>
-          <p:cNvPr id="59" name="Dato 2026-1-0"/>
-          <p:cNvSpPr txBox="1"/>
-          <p:nvPr/>
-        </p:nvSpPr>
-        <p:spPr>
-          <a:xfrm>
-            <a:off x="5806440" y="5321808"/>
-            <a:ext cx="1935328" cy="310896"/>
+          <p:cNvPr id="71" name="Dato 2026-1-0"/>
+          <p:cNvSpPr txBox="1"/>
+          <p:nvPr/>
+        </p:nvSpPr>
+        <p:spPr>
+          <a:xfrm>
+            <a:off x="5916168" y="5321808"/>
+            <a:ext cx="1843888" cy="310896"/>
           </a:xfrm>
           <a:prstGeom prst="rect">
             <a:avLst/>
@@ -3598,7 +4039,7 @@
               <a:buNone/>
             </a:pPr>
             <a:r>
-              <a:rPr lang="en-US" sz="1150" dirty="0">
+              <a:rPr lang="en-US" sz="1100" dirty="0">
                 <a:solidFill>
                   <a:schemeClr val="accent5"/>
                 </a:solidFill>
@@ -3609,27 +4050,27 @@
               <a:buNone/>
             </a:pPr>
             <a:r>
-              <a:rPr lang="en-US" sz="1150" b="1" dirty="0">
+              <a:rPr lang="en-US" sz="1100" b="1" dirty="0">
                 <a:solidFill>
                   <a:schemeClr val="tx1"/>
                 </a:solidFill>
               </a:rPr>
               <a:t>31/07/2026</a:t>
             </a:r>
-            <a:endParaRPr lang="en-US" sz="1150" dirty="0"/>
-          </a:p>
-        </p:txBody>
-      </p:sp>
-      <p:sp>
-        <p:nvSpPr>
-          <p:cNvPr id="60" name="Separador 2026-1-1"/>
+            <a:endParaRPr lang="en-US" sz="1100" dirty="0"/>
+          </a:p>
+        </p:txBody>
+      </p:sp>
+      <p:sp>
+        <p:nvSpPr>
+          <p:cNvPr id="72" name="Separador 2026-1-1"/>
           <p:cNvSpPr/>
           <p:nvPr/>
         </p:nvSpPr>
         <p:spPr>
           <a:xfrm>
-            <a:off x="5806440" y="5650992"/>
-            <a:ext cx="1935328" cy="0"/>
+            <a:off x="5916168" y="5650992"/>
+            <a:ext cx="1843888" cy="0"/>
           </a:xfrm>
           <a:prstGeom prst="line">
             <a:avLst/>
@@ -3645,14 +4086,14 @@
       </p:sp>
       <p:sp>
         <p:nvSpPr>
-          <p:cNvPr id="61" name="Dato 2026-1-1"/>
-          <p:cNvSpPr txBox="1"/>
-          <p:nvPr/>
-        </p:nvSpPr>
-        <p:spPr>
-          <a:xfrm>
-            <a:off x="5806440" y="5687568"/>
-            <a:ext cx="1935328" cy="310896"/>
+          <p:cNvPr id="73" name="Dato 2026-1-1"/>
+          <p:cNvSpPr txBox="1"/>
+          <p:nvPr/>
+        </p:nvSpPr>
+        <p:spPr>
+          <a:xfrm>
+            <a:off x="5916168" y="5687568"/>
+            <a:ext cx="1843888" cy="310896"/>
           </a:xfrm>
           <a:prstGeom prst="rect">
             <a:avLst/>
@@ -3668,31 +4109,31 @@
               <a:buNone/>
             </a:pPr>
             <a:r>
-              <a:rPr lang="en-US" sz="1150" dirty="0">
+              <a:rPr lang="en-US" sz="1100" dirty="0">
                 <a:solidFill>
                   <a:schemeClr val="accent5"/>
                 </a:solidFill>
               </a:rPr>
-              <a:t>Inicio de visita  </a:t>
-            </a:r>
-            <a:pPr indent="0" marL="0">
-              <a:buNone/>
-            </a:pPr>
-            <a:r>
-              <a:rPr lang="en-US" sz="1150" b="1" dirty="0">
+              <a:t>Alcance  </a:t>
+            </a:r>
+            <a:pPr indent="0" marL="0">
+              <a:buNone/>
+            </a:pPr>
+            <a:r>
+              <a:rPr lang="en-US" sz="1100" b="1" dirty="0">
                 <a:solidFill>
                   <a:schemeClr val="tx1"/>
                 </a:solidFill>
               </a:rPr>
-              <a:t>21/08/2026</a:t>
-            </a:r>
-            <a:endParaRPr lang="en-US" sz="1150" dirty="0"/>
-          </a:p>
-        </p:txBody>
-      </p:sp>
-      <p:sp>
-        <p:nvSpPr>
-          <p:cNvPr id="62" name="Tarjeta 2026-2"/>
+              <a:t>GC + seguimiento</a:t>
+            </a:r>
+            <a:endParaRPr lang="en-US" sz="1100" dirty="0"/>
+          </a:p>
+        </p:txBody>
+      </p:sp>
+      <p:sp>
+        <p:nvSpPr>
+          <p:cNvPr id="74" name="Tarjeta 2026-2"/>
           <p:cNvSpPr/>
           <p:nvPr/>
         </p:nvSpPr>
@@ -3719,18 +4160,18 @@
       </p:sp>
       <p:sp>
         <p:nvSpPr>
-          <p:cNvPr id="63" name="Fecha fondo 2026-2"/>
+          <p:cNvPr id="75" name="Fechas fondo 2026-2"/>
           <p:cNvSpPr/>
           <p:nvPr/>
         </p:nvSpPr>
         <p:spPr>
           <a:xfrm>
             <a:off x="8473288" y="4178808"/>
-            <a:ext cx="914400" cy="1828800"/>
+            <a:ext cx="1051560" cy="1828800"/>
           </a:xfrm>
           <a:prstGeom prst="roundRect">
             <a:avLst>
-              <a:gd name="adj" fmla="val 10000"/>
+              <a:gd name="adj" fmla="val 8696"/>
             </a:avLst>
           </a:prstGeom>
           <a:solidFill>
@@ -3748,14 +4189,50 @@
       </p:sp>
       <p:sp>
         <p:nvSpPr>
-          <p:cNvPr id="64" name="Fecha día 2026-2"/>
-          <p:cNvSpPr txBox="1"/>
-          <p:nvPr/>
-        </p:nvSpPr>
-        <p:spPr>
-          <a:xfrm>
-            <a:off x="8473288" y="4498848"/>
-            <a:ext cx="914400" cy="548640"/>
+          <p:cNvPr id="76" name="Fecha etiqueta 2026-2-0"/>
+          <p:cNvSpPr txBox="1"/>
+          <p:nvPr/>
+        </p:nvSpPr>
+        <p:spPr>
+          <a:xfrm>
+            <a:off x="8473288" y="4270248"/>
+            <a:ext cx="1051560" cy="182880"/>
+          </a:xfrm>
+          <a:prstGeom prst="rect">
+            <a:avLst/>
+          </a:prstGeom>
+          <a:noFill/>
+          <a:ln/>
+        </p:spPr>
+        <p:txBody>
+          <a:bodyPr wrap="square" lIns="0" tIns="0" rIns="0" bIns="0" rtlCol="0" anchor="t"/>
+          <a:lstStyle/>
+          <a:p>
+            <a:pPr algn="ctr" indent="0" marL="0">
+              <a:buNone/>
+            </a:pPr>
+            <a:r>
+              <a:rPr lang="en-US" sz="800" b="1" spc="100" kern="0" dirty="0">
+                <a:solidFill>
+                  <a:schemeClr val="bg1"/>
+                </a:solidFill>
+              </a:rPr>
+              <a:t>RECEPCIÓN</a:t>
+            </a:r>
+            <a:endParaRPr lang="en-US" sz="800" dirty="0"/>
+          </a:p>
+        </p:txBody>
+      </p:sp>
+      <p:sp>
+        <p:nvSpPr>
+          <p:cNvPr id="77" name="Fecha día 2026-2-0"/>
+          <p:cNvSpPr txBox="1"/>
+          <p:nvPr/>
+        </p:nvSpPr>
+        <p:spPr>
+          <a:xfrm>
+            <a:off x="8473288" y="4453128"/>
+            <a:ext cx="1051560" cy="384048"/>
           </a:xfrm>
           <a:prstGeom prst="rect">
             <a:avLst/>
@@ -3771,7 +4248,7 @@
               <a:buNone/>
             </a:pPr>
             <a:r>
-              <a:rPr lang="en-US" sz="3400" b="1" dirty="0">
+              <a:rPr lang="en-US" sz="2400" b="1" dirty="0">
                 <a:solidFill>
                   <a:schemeClr val="bg1"/>
                 </a:solidFill>
@@ -3781,20 +4258,20 @@
               </a:rPr>
               <a:t>09</a:t>
             </a:r>
-            <a:endParaRPr lang="en-US" sz="3400" dirty="0"/>
-          </a:p>
-        </p:txBody>
-      </p:sp>
-      <p:sp>
-        <p:nvSpPr>
-          <p:cNvPr id="65" name="Fecha mes 2026-2"/>
-          <p:cNvSpPr txBox="1"/>
-          <p:nvPr/>
-        </p:nvSpPr>
-        <p:spPr>
-          <a:xfrm>
-            <a:off x="8473288" y="5065776"/>
-            <a:ext cx="914400" cy="274320"/>
+            <a:endParaRPr lang="en-US" sz="2400" dirty="0"/>
+          </a:p>
+        </p:txBody>
+      </p:sp>
+      <p:sp>
+        <p:nvSpPr>
+          <p:cNvPr id="78" name="Fecha mes 2026-2-0"/>
+          <p:cNvSpPr txBox="1"/>
+          <p:nvPr/>
+        </p:nvSpPr>
+        <p:spPr>
+          <a:xfrm>
+            <a:off x="8473288" y="4837176"/>
+            <a:ext cx="1051560" cy="201168"/>
           </a:xfrm>
           <a:prstGeom prst="rect">
             <a:avLst/>
@@ -3810,12 +4287,184 @@
               <a:buNone/>
             </a:pPr>
             <a:r>
-              <a:rPr lang="en-US" sz="1400" b="1" spc="200" kern="0" dirty="0">
+              <a:rPr lang="en-US" sz="1000" b="1" spc="100" kern="0" dirty="0">
                 <a:solidFill>
                   <a:schemeClr val="bg1"/>
                 </a:solidFill>
               </a:rPr>
-              <a:t>OCT</a:t>
+              <a:t>OCT 2026</a:t>
+            </a:r>
+            <a:endParaRPr lang="en-US" sz="1000" dirty="0"/>
+          </a:p>
+        </p:txBody>
+      </p:sp>
+      <p:sp>
+        <p:nvSpPr>
+          <p:cNvPr id="79" name="Fecha etiqueta 2026-2-1"/>
+          <p:cNvSpPr txBox="1"/>
+          <p:nvPr/>
+        </p:nvSpPr>
+        <p:spPr>
+          <a:xfrm>
+            <a:off x="8473288" y="5184648"/>
+            <a:ext cx="1051560" cy="182880"/>
+          </a:xfrm>
+          <a:prstGeom prst="rect">
+            <a:avLst/>
+          </a:prstGeom>
+          <a:noFill/>
+          <a:ln/>
+        </p:spPr>
+        <p:txBody>
+          <a:bodyPr wrap="square" lIns="0" tIns="0" rIns="0" bIns="0" rtlCol="0" anchor="t"/>
+          <a:lstStyle/>
+          <a:p>
+            <a:pPr algn="ctr" indent="0" marL="0">
+              <a:buNone/>
+            </a:pPr>
+            <a:r>
+              <a:rPr lang="en-US" sz="800" b="1" spc="100" kern="0" dirty="0">
+                <a:solidFill>
+                  <a:schemeClr val="bg1"/>
+                </a:solidFill>
+              </a:rPr>
+              <a:t>VENCE APROX.</a:t>
+            </a:r>
+            <a:endParaRPr lang="en-US" sz="800" dirty="0"/>
+          </a:p>
+        </p:txBody>
+      </p:sp>
+      <p:sp>
+        <p:nvSpPr>
+          <p:cNvPr id="80" name="Fecha día 2026-2-1"/>
+          <p:cNvSpPr txBox="1"/>
+          <p:nvPr/>
+        </p:nvSpPr>
+        <p:spPr>
+          <a:xfrm>
+            <a:off x="8473288" y="5367528"/>
+            <a:ext cx="1051560" cy="384048"/>
+          </a:xfrm>
+          <a:prstGeom prst="rect">
+            <a:avLst/>
+          </a:prstGeom>
+          <a:noFill/>
+          <a:ln/>
+        </p:spPr>
+        <p:txBody>
+          <a:bodyPr wrap="square" lIns="0" tIns="0" rIns="0" bIns="0" rtlCol="0" anchor="ctr"/>
+          <a:lstStyle/>
+          <a:p>
+            <a:pPr algn="ctr" indent="0" marL="0">
+              <a:buNone/>
+            </a:pPr>
+            <a:r>
+              <a:rPr lang="en-US" sz="2400" b="1" dirty="0">
+                <a:solidFill>
+                  <a:schemeClr val="bg1"/>
+                </a:solidFill>
+                <a:latin typeface="Cambria" pitchFamily="34" charset="0"/>
+                <a:ea typeface="Cambria" pitchFamily="34" charset="-122"/>
+                <a:cs typeface="Cambria" pitchFamily="34" charset="-120"/>
+              </a:rPr>
+              <a:t>23</a:t>
+            </a:r>
+            <a:endParaRPr lang="en-US" sz="2400" dirty="0"/>
+          </a:p>
+        </p:txBody>
+      </p:sp>
+      <p:sp>
+        <p:nvSpPr>
+          <p:cNvPr id="81" name="Fecha mes 2026-2-1"/>
+          <p:cNvSpPr txBox="1"/>
+          <p:nvPr/>
+        </p:nvSpPr>
+        <p:spPr>
+          <a:xfrm>
+            <a:off x="8473288" y="5751576"/>
+            <a:ext cx="1051560" cy="201168"/>
+          </a:xfrm>
+          <a:prstGeom prst="rect">
+            <a:avLst/>
+          </a:prstGeom>
+          <a:noFill/>
+          <a:ln/>
+        </p:spPr>
+        <p:txBody>
+          <a:bodyPr wrap="square" lIns="0" tIns="0" rIns="0" bIns="0" rtlCol="0" anchor="t"/>
+          <a:lstStyle/>
+          <a:p>
+            <a:pPr algn="ctr" indent="0" marL="0">
+              <a:buNone/>
+            </a:pPr>
+            <a:r>
+              <a:rPr lang="en-US" sz="1000" b="1" spc="100" kern="0" dirty="0">
+                <a:solidFill>
+                  <a:schemeClr val="bg1"/>
+                </a:solidFill>
+              </a:rPr>
+              <a:t>OCT 2026</a:t>
+            </a:r>
+            <a:endParaRPr lang="en-US" sz="1000" dirty="0"/>
+          </a:p>
+        </p:txBody>
+      </p:sp>
+      <p:sp>
+        <p:nvSpPr>
+          <p:cNvPr id="82" name="Fechas separador 2026-2"/>
+          <p:cNvSpPr/>
+          <p:nvPr/>
+        </p:nvSpPr>
+        <p:spPr>
+          <a:xfrm>
+            <a:off x="8656168" y="5093208"/>
+            <a:ext cx="685800" cy="0"/>
+          </a:xfrm>
+          <a:prstGeom prst="line">
+            <a:avLst/>
+          </a:prstGeom>
+          <a:noFill/>
+          <a:ln w="9525">
+            <a:solidFill>
+              <a:schemeClr val="bg1">
+                <a:alpha val="60000"/>
+              </a:schemeClr>
+            </a:solidFill>
+            <a:prstDash val="solid"/>
+          </a:ln>
+        </p:spPr>
+      </p:sp>
+      <p:sp>
+        <p:nvSpPr>
+          <p:cNvPr id="83" name="Tipo 2026-2"/>
+          <p:cNvSpPr txBox="1"/>
+          <p:nvPr/>
+        </p:nvSpPr>
+        <p:spPr>
+          <a:xfrm>
+            <a:off x="9680296" y="4178808"/>
+            <a:ext cx="1843888" cy="502920"/>
+          </a:xfrm>
+          <a:prstGeom prst="rect">
+            <a:avLst/>
+          </a:prstGeom>
+          <a:noFill/>
+          <a:ln/>
+        </p:spPr>
+        <p:txBody>
+          <a:bodyPr wrap="square" lIns="0" tIns="0" rIns="0" bIns="0" rtlCol="0" anchor="ctr"/>
+          <a:lstStyle/>
+          <a:p>
+            <a:pPr indent="0" marL="0">
+              <a:buNone/>
+            </a:pPr>
+            <a:r>
+              <a:rPr lang="en-US" sz="1400" b="1" dirty="0">
+                <a:solidFill>
+                  <a:schemeClr val="tx1"/>
+                </a:solidFill>
+              </a:rPr>
+              <a:t>Resultados preliminares</a:t>
             </a:r>
             <a:endParaRPr lang="en-US" sz="1400" dirty="0"/>
           </a:p>
@@ -3823,14 +4472,14 @@
       </p:sp>
       <p:sp>
         <p:nvSpPr>
-          <p:cNvPr id="66" name="Fecha año 2026-2"/>
-          <p:cNvSpPr txBox="1"/>
-          <p:nvPr/>
-        </p:nvSpPr>
-        <p:spPr>
-          <a:xfrm>
-            <a:off x="8473288" y="5367528"/>
-            <a:ext cx="914400" cy="274320"/>
+          <p:cNvPr id="84" name="Circular 2026-2"/>
+          <p:cNvSpPr txBox="1"/>
+          <p:nvPr/>
+        </p:nvSpPr>
+        <p:spPr>
+          <a:xfrm>
+            <a:off x="9680296" y="4754880"/>
+            <a:ext cx="1843888" cy="457200"/>
           </a:xfrm>
           <a:prstGeom prst="rect">
             <a:avLst/>
@@ -3842,78 +4491,6 @@
           <a:bodyPr wrap="square" lIns="0" tIns="0" rIns="0" bIns="0" rtlCol="0" anchor="t"/>
           <a:lstStyle/>
           <a:p>
-            <a:pPr algn="ctr" indent="0" marL="0">
-              <a:buNone/>
-            </a:pPr>
-            <a:r>
-              <a:rPr lang="en-US" sz="1200" dirty="0">
-                <a:solidFill>
-                  <a:schemeClr val="bg1"/>
-                </a:solidFill>
-              </a:rPr>
-              <a:t>2026</a:t>
-            </a:r>
-            <a:endParaRPr lang="en-US" sz="1200" dirty="0"/>
-          </a:p>
-        </p:txBody>
-      </p:sp>
-      <p:sp>
-        <p:nvSpPr>
-          <p:cNvPr id="67" name="Tipo 2026-2"/>
-          <p:cNvSpPr txBox="1"/>
-          <p:nvPr/>
-        </p:nvSpPr>
-        <p:spPr>
-          <a:xfrm>
-            <a:off x="9570568" y="4206240"/>
-            <a:ext cx="1935328" cy="502920"/>
-          </a:xfrm>
-          <a:prstGeom prst="rect">
-            <a:avLst/>
-          </a:prstGeom>
-          <a:noFill/>
-          <a:ln/>
-        </p:spPr>
-        <p:txBody>
-          <a:bodyPr wrap="square" lIns="0" tIns="0" rIns="0" bIns="0" rtlCol="0" anchor="ctr"/>
-          <a:lstStyle/>
-          <a:p>
-            <a:pPr indent="0" marL="0">
-              <a:buNone/>
-            </a:pPr>
-            <a:r>
-              <a:rPr lang="en-US" sz="1400" b="1" dirty="0">
-                <a:solidFill>
-                  <a:schemeClr val="tx1"/>
-                </a:solidFill>
-              </a:rPr>
-              <a:t>Resultados preliminares</a:t>
-            </a:r>
-            <a:endParaRPr lang="en-US" sz="1400" dirty="0"/>
-          </a:p>
-        </p:txBody>
-      </p:sp>
-      <p:sp>
-        <p:nvSpPr>
-          <p:cNvPr id="68" name="Circular 2026-2"/>
-          <p:cNvSpPr txBox="1"/>
-          <p:nvPr/>
-        </p:nvSpPr>
-        <p:spPr>
-          <a:xfrm>
-            <a:off x="9570568" y="4773168"/>
-            <a:ext cx="1935328" cy="438912"/>
-          </a:xfrm>
-          <a:prstGeom prst="rect">
-            <a:avLst/>
-          </a:prstGeom>
-          <a:noFill/>
-          <a:ln/>
-        </p:spPr>
-        <p:txBody>
-          <a:bodyPr wrap="square" lIns="0" tIns="0" rIns="0" bIns="0" rtlCol="0" anchor="t"/>
-          <a:lstStyle/>
-          <a:p>
             <a:pPr indent="0" marL="0">
               <a:buNone/>
             </a:pPr>
@@ -3923,7 +4500,18 @@
                   <a:schemeClr val="accent5"/>
                 </a:solidFill>
               </a:rPr>
-              <a:t>Circular No.</a:t>
+              <a:t>Circular No.  </a:t>
+            </a:r>
+            <a:pPr indent="0" marL="0">
+              <a:buNone/>
+            </a:pPr>
+            <a:r>
+              <a:rPr lang="en-US" sz="1050" b="1" dirty="0">
+                <a:solidFill>
+                  <a:schemeClr val="accent2"/>
+                </a:solidFill>
+              </a:rPr>
+              <a:t>09/10/2026</a:t>
             </a:r>
             <a:endParaRPr lang="en-US" sz="1100" dirty="0"/>
           </a:p>
@@ -3945,14 +4533,14 @@
       </p:sp>
       <p:sp>
         <p:nvSpPr>
-          <p:cNvPr id="69" name="Separador 2026-2-0"/>
+          <p:cNvPr id="85" name="Separador 2026-2-0"/>
           <p:cNvSpPr/>
           <p:nvPr/>
         </p:nvSpPr>
         <p:spPr>
           <a:xfrm>
-            <a:off x="9570568" y="5285232"/>
-            <a:ext cx="1935328" cy="0"/>
+            <a:off x="9680296" y="5285232"/>
+            <a:ext cx="1843888" cy="0"/>
           </a:xfrm>
           <a:prstGeom prst="line">
             <a:avLst/>
@@ -3968,14 +4556,14 @@
       </p:sp>
       <p:sp>
         <p:nvSpPr>
-          <p:cNvPr id="70" name="Dato 2026-2-0"/>
-          <p:cNvSpPr txBox="1"/>
-          <p:nvPr/>
-        </p:nvSpPr>
-        <p:spPr>
-          <a:xfrm>
-            <a:off x="9570568" y="5321808"/>
-            <a:ext cx="1935328" cy="310896"/>
+          <p:cNvPr id="86" name="Dato 2026-2-0"/>
+          <p:cNvSpPr txBox="1"/>
+          <p:nvPr/>
+        </p:nvSpPr>
+        <p:spPr>
+          <a:xfrm>
+            <a:off x="9680296" y="5321808"/>
+            <a:ext cx="1843888" cy="310896"/>
           </a:xfrm>
           <a:prstGeom prst="rect">
             <a:avLst/>
@@ -3991,7 +4579,7 @@
               <a:buNone/>
             </a:pPr>
             <a:r>
-              <a:rPr lang="en-US" sz="1150" dirty="0">
+              <a:rPr lang="en-US" sz="1100" dirty="0">
                 <a:solidFill>
                   <a:schemeClr val="accent5"/>
                 </a:solidFill>
@@ -4002,27 +4590,27 @@
               <a:buNone/>
             </a:pPr>
             <a:r>
-              <a:rPr lang="en-US" sz="1150" b="1" dirty="0">
+              <a:rPr lang="en-US" sz="1100" b="1" dirty="0">
                 <a:solidFill>
                   <a:schemeClr val="tx1"/>
                 </a:solidFill>
               </a:rPr>
               <a:t>7 nuevas</a:t>
             </a:r>
-            <a:endParaRPr lang="en-US" sz="1150" dirty="0"/>
-          </a:p>
-        </p:txBody>
-      </p:sp>
-      <p:sp>
-        <p:nvSpPr>
-          <p:cNvPr id="71" name="Separador 2026-2-1"/>
+            <a:endParaRPr lang="en-US" sz="1100" dirty="0"/>
+          </a:p>
+        </p:txBody>
+      </p:sp>
+      <p:sp>
+        <p:nvSpPr>
+          <p:cNvPr id="87" name="Separador 2026-2-1"/>
           <p:cNvSpPr/>
           <p:nvPr/>
         </p:nvSpPr>
         <p:spPr>
           <a:xfrm>
-            <a:off x="9570568" y="5650992"/>
-            <a:ext cx="1935328" cy="0"/>
+            <a:off x="9680296" y="5650992"/>
+            <a:ext cx="1843888" cy="0"/>
           </a:xfrm>
           <a:prstGeom prst="line">
             <a:avLst/>
@@ -4038,14 +4626,14 @@
       </p:sp>
       <p:sp>
         <p:nvSpPr>
-          <p:cNvPr id="72" name="Dato 2026-2-1"/>
-          <p:cNvSpPr txBox="1"/>
-          <p:nvPr/>
-        </p:nvSpPr>
-        <p:spPr>
-          <a:xfrm>
-            <a:off x="9570568" y="5687568"/>
-            <a:ext cx="1935328" cy="310896"/>
+          <p:cNvPr id="88" name="Dato 2026-2-1"/>
+          <p:cNvSpPr txBox="1"/>
+          <p:nvPr/>
+        </p:nvSpPr>
+        <p:spPr>
+          <a:xfrm>
+            <a:off x="9680296" y="5687568"/>
+            <a:ext cx="1843888" cy="310896"/>
           </a:xfrm>
           <a:prstGeom prst="rect">
             <a:avLst/>
@@ -4061,7 +4649,7 @@
               <a:buNone/>
             </a:pPr>
             <a:r>
-              <a:rPr lang="en-US" sz="1150" dirty="0">
+              <a:rPr lang="en-US" sz="1100" dirty="0">
                 <a:solidFill>
                   <a:schemeClr val="accent5"/>
                 </a:solidFill>
@@ -4072,20 +4660,20 @@
               <a:buNone/>
             </a:pPr>
             <a:r>
-              <a:rPr lang="en-US" sz="1150" b="1" dirty="0">
+              <a:rPr lang="en-US" sz="1100" b="1" dirty="0">
                 <a:solidFill>
                   <a:schemeClr val="tx1"/>
                 </a:solidFill>
               </a:rPr>
               <a:t>obs. 3 y 5 de 2025</a:t>
             </a:r>
-            <a:endParaRPr lang="en-US" sz="1150" dirty="0"/>
-          </a:p>
-        </p:txBody>
-      </p:sp>
-      <p:sp>
-        <p:nvSpPr>
-          <p:cNvPr id="73" name="Flecha 2026"/>
+            <a:endParaRPr lang="en-US" sz="1100" dirty="0"/>
+          </a:p>
+        </p:txBody>
+      </p:sp>
+      <p:sp>
+        <p:nvSpPr>
+          <p:cNvPr id="89" name="Flecha 2026"/>
           <p:cNvSpPr/>
           <p:nvPr/>
         </p:nvSpPr>

</xml_diff>

<commit_message>
Slide 1: list observations inside preliminary results cards
Co-Authored-By: Claude Opus 5.5 <noreply@anthropic.com>
Claude-Session: https://claude.ai/code/session_01F1WXR13Nv8neEtLhaK3ELa
</commit_message>
<xml_diff>
--- a/supervision-gobierno-corporativo/Supervision_GC_SSF_COMEDICA_2025-2026.pptx
+++ b/supervision-gobierno-corporativo/Supervision_GC_SSF_COMEDICA_2025-2026.pptx
@@ -109,17 +109,17 @@
   <p:extLst>
     <p:ext uri="{521415D9-36F7-43E2-AB2F-B90AF26B5E84}">
       <p14:sectionLst xmlns:p14="http://schemas.microsoft.com/office/powerpoint/2010/main">
-        <p14:section name="1 · Resumen de circulares SSF" id="{e69be941-a94f-d308-442c-34a0e39c01f9}">
+        <p14:section name="1 · Resumen de circulares SSF" id="{78b0aa3a-9ab5-fb95-9248-4383e14b6bcd}">
           <p14:sldIdLst>
             <p14:sldId id="256"/>
           </p14:sldIdLst>
         </p14:section>
-        <p14:section name="2 · Observaciones 2025" id="{8942b9e4-87d0-b071-6138-fe37218b960c}">
+        <p14:section name="2 · Observaciones 2025" id="{4562aab9-27b5-7725-6e3f-232541bde45e}">
           <p14:sldIdLst>
             <p14:sldId id="257"/>
           </p14:sldIdLst>
         </p14:section>
-        <p14:section name="3 · Observaciones 2026" id="{115ce71f-e2c6-9019-d686-5aeee9903dd7}">
+        <p14:section name="3 · Observaciones 2026" id="{3570cbb6-4c7d-6896-bc4c-b664d66295a0}">
           <p14:sldIdLst>
             <p14:sldId id="258"/>
           </p14:sldIdLst>
@@ -2342,8 +2342,8 @@
         </p:nvSpPr>
         <p:spPr>
           <a:xfrm>
-            <a:off x="4572000" y="457200"/>
-            <a:ext cx="1188720" cy="502920"/>
+            <a:off x="4572000" y="320040"/>
+            <a:ext cx="1188720" cy="457200"/>
           </a:xfrm>
           <a:prstGeom prst="rect">
             <a:avLst/>
@@ -2359,7 +2359,7 @@
               <a:buNone/>
             </a:pPr>
             <a:r>
-              <a:rPr lang="en-US" sz="3000" b="1" dirty="0">
+              <a:rPr lang="en-US" sz="2800" b="1" dirty="0">
                 <a:solidFill>
                   <a:schemeClr val="accent1"/>
                 </a:solidFill>
@@ -2369,7 +2369,7 @@
               </a:rPr>
               <a:t>2025</a:t>
             </a:r>
-            <a:endParaRPr lang="en-US" sz="3000" dirty="0"/>
+            <a:endParaRPr lang="en-US" sz="2800" dirty="0"/>
           </a:p>
         </p:txBody>
       </p:sp>
@@ -2381,8 +2381,8 @@
         </p:nvSpPr>
         <p:spPr>
           <a:xfrm>
-            <a:off x="5806440" y="457200"/>
-            <a:ext cx="3657600" cy="502920"/>
+            <a:off x="5760720" y="320040"/>
+            <a:ext cx="3657600" cy="457200"/>
           </a:xfrm>
           <a:prstGeom prst="rect">
             <a:avLst/>
@@ -2417,12 +2417,12 @@
         </p:nvSpPr>
         <p:spPr>
           <a:xfrm>
-            <a:off x="4572000" y="1097280"/>
-            <a:ext cx="3306928" cy="2103120"/>
+            <a:off x="4572000" y="868680"/>
+            <a:ext cx="2834640" cy="2377440"/>
           </a:xfrm>
           <a:prstGeom prst="roundRect">
             <a:avLst>
-              <a:gd name="adj" fmla="val 4348"/>
+              <a:gd name="adj" fmla="val 3846"/>
             </a:avLst>
           </a:prstGeom>
           <a:solidFill>
@@ -2444,12 +2444,12 @@
         </p:nvSpPr>
         <p:spPr>
           <a:xfrm>
-            <a:off x="4709160" y="1234440"/>
-            <a:ext cx="1051560" cy="1828800"/>
+            <a:off x="4690872" y="987552"/>
+            <a:ext cx="1005840" cy="2139696"/>
           </a:xfrm>
           <a:prstGeom prst="roundRect">
             <a:avLst>
-              <a:gd name="adj" fmla="val 8696"/>
+              <a:gd name="adj" fmla="val 9091"/>
             </a:avLst>
           </a:prstGeom>
           <a:solidFill>
@@ -2473,8 +2473,8 @@
         </p:nvSpPr>
         <p:spPr>
           <a:xfrm>
-            <a:off x="4709160" y="1325880"/>
-            <a:ext cx="1051560" cy="182880"/>
+            <a:off x="4690872" y="1152144"/>
+            <a:ext cx="1005840" cy="182880"/>
           </a:xfrm>
           <a:prstGeom prst="rect">
             <a:avLst/>
@@ -2509,8 +2509,8 @@
         </p:nvSpPr>
         <p:spPr>
           <a:xfrm>
-            <a:off x="4709160" y="1508760"/>
-            <a:ext cx="1051560" cy="384048"/>
+            <a:off x="4690872" y="1353312"/>
+            <a:ext cx="1005840" cy="411480"/>
           </a:xfrm>
           <a:prstGeom prst="rect">
             <a:avLst/>
@@ -2526,7 +2526,7 @@
               <a:buNone/>
             </a:pPr>
             <a:r>
-              <a:rPr lang="en-US" sz="2400" b="1" dirty="0">
+              <a:rPr lang="en-US" sz="2600" b="1" dirty="0">
                 <a:solidFill>
                   <a:schemeClr val="bg1"/>
                 </a:solidFill>
@@ -2536,7 +2536,7 @@
               </a:rPr>
               <a:t>19</a:t>
             </a:r>
-            <a:endParaRPr lang="en-US" sz="2400" dirty="0"/>
+            <a:endParaRPr lang="en-US" sz="2600" dirty="0"/>
           </a:p>
         </p:txBody>
       </p:sp>
@@ -2548,8 +2548,8 @@
         </p:nvSpPr>
         <p:spPr>
           <a:xfrm>
-            <a:off x="4709160" y="1892808"/>
-            <a:ext cx="1051560" cy="201168"/>
+            <a:off x="4690872" y="1773936"/>
+            <a:ext cx="1005840" cy="201168"/>
           </a:xfrm>
           <a:prstGeom prst="rect">
             <a:avLst/>
@@ -2584,8 +2584,8 @@
         </p:nvSpPr>
         <p:spPr>
           <a:xfrm>
-            <a:off x="4709160" y="2240280"/>
-            <a:ext cx="1051560" cy="182880"/>
+            <a:off x="4690872" y="2221992"/>
+            <a:ext cx="1005840" cy="182880"/>
           </a:xfrm>
           <a:prstGeom prst="rect">
             <a:avLst/>
@@ -2620,8 +2620,8 @@
         </p:nvSpPr>
         <p:spPr>
           <a:xfrm>
-            <a:off x="4709160" y="2423160"/>
-            <a:ext cx="1051560" cy="384048"/>
+            <a:off x="4690872" y="2423160"/>
+            <a:ext cx="1005840" cy="411480"/>
           </a:xfrm>
           <a:prstGeom prst="rect">
             <a:avLst/>
@@ -2637,7 +2637,7 @@
               <a:buNone/>
             </a:pPr>
             <a:r>
-              <a:rPr lang="en-US" sz="2400" b="1" dirty="0">
+              <a:rPr lang="en-US" sz="2600" b="1" dirty="0">
                 <a:solidFill>
                   <a:schemeClr val="bg1"/>
                 </a:solidFill>
@@ -2647,7 +2647,7 @@
               </a:rPr>
               <a:t>05</a:t>
             </a:r>
-            <a:endParaRPr lang="en-US" sz="2400" dirty="0"/>
+            <a:endParaRPr lang="en-US" sz="2600" dirty="0"/>
           </a:p>
         </p:txBody>
       </p:sp>
@@ -2659,8 +2659,8 @@
         </p:nvSpPr>
         <p:spPr>
           <a:xfrm>
-            <a:off x="4709160" y="2807208"/>
-            <a:ext cx="1051560" cy="201168"/>
+            <a:off x="4690872" y="2843784"/>
+            <a:ext cx="1005840" cy="201168"/>
           </a:xfrm>
           <a:prstGeom prst="rect">
             <a:avLst/>
@@ -2695,8 +2695,8 @@
         </p:nvSpPr>
         <p:spPr>
           <a:xfrm>
-            <a:off x="4892040" y="2148840"/>
-            <a:ext cx="685800" cy="0"/>
+            <a:off x="4873752" y="2057400"/>
+            <a:ext cx="640080" cy="0"/>
           </a:xfrm>
           <a:prstGeom prst="line">
             <a:avLst/>
@@ -2720,8 +2720,8 @@
         </p:nvSpPr>
         <p:spPr>
           <a:xfrm>
-            <a:off x="5916168" y="1234440"/>
-            <a:ext cx="1843888" cy="502920"/>
+            <a:off x="5852160" y="1005840"/>
+            <a:ext cx="1444752" cy="566928"/>
           </a:xfrm>
           <a:prstGeom prst="rect">
             <a:avLst/>
@@ -2737,14 +2737,14 @@
               <a:buNone/>
             </a:pPr>
             <a:r>
-              <a:rPr lang="en-US" sz="1400" b="1" dirty="0">
+              <a:rPr lang="en-US" sz="1300" b="1" dirty="0">
                 <a:solidFill>
                   <a:schemeClr val="tx1"/>
                 </a:solidFill>
               </a:rPr>
               <a:t>Nombramiento de visita ampliada</a:t>
             </a:r>
-            <a:endParaRPr lang="en-US" sz="1400" dirty="0"/>
+            <a:endParaRPr lang="en-US" sz="1300" dirty="0"/>
           </a:p>
         </p:txBody>
       </p:sp>
@@ -2756,8 +2756,8 @@
         </p:nvSpPr>
         <p:spPr>
           <a:xfrm>
-            <a:off x="5916168" y="1810512"/>
-            <a:ext cx="1843888" cy="457200"/>
+            <a:off x="5852160" y="1673352"/>
+            <a:ext cx="1444752" cy="457200"/>
           </a:xfrm>
           <a:prstGeom prst="rect">
             <a:avLst/>
@@ -2773,7 +2773,7 @@
               <a:buNone/>
             </a:pPr>
             <a:r>
-              <a:rPr lang="en-US" sz="1000" dirty="0">
+              <a:rPr lang="en-US" sz="950" dirty="0">
                 <a:solidFill>
                   <a:schemeClr val="accent5"/>
                 </a:solidFill>
@@ -2784,28 +2784,28 @@
               <a:buNone/>
             </a:pPr>
             <a:r>
-              <a:rPr lang="en-US" sz="1050" b="1" dirty="0">
+              <a:rPr lang="en-US" sz="1000" b="1" dirty="0">
                 <a:solidFill>
                   <a:schemeClr val="accent1"/>
                 </a:solidFill>
               </a:rPr>
               <a:t>09/04/2025</a:t>
             </a:r>
-            <a:endParaRPr lang="en-US" sz="1100" dirty="0"/>
-          </a:p>
-          <a:p>
-            <a:pPr indent="0" marL="0">
-              <a:buNone/>
-            </a:pPr>
-            <a:r>
-              <a:rPr lang="en-US" sz="1100" b="1" dirty="0">
+            <a:endParaRPr lang="en-US" sz="1000" dirty="0"/>
+          </a:p>
+          <a:p>
+            <a:pPr indent="0" marL="0">
+              <a:buNone/>
+            </a:pPr>
+            <a:r>
+              <a:rPr lang="en-US" sz="1000" b="1" dirty="0">
                 <a:solidFill>
                   <a:schemeClr val="accent1"/>
                 </a:solidFill>
               </a:rPr>
               <a:t>DS-SABAO-BCS-BC-9337</a:t>
             </a:r>
-            <a:endParaRPr lang="en-US" sz="1100" dirty="0"/>
+            <a:endParaRPr lang="en-US" sz="1000" dirty="0"/>
           </a:p>
         </p:txBody>
       </p:sp>
@@ -2817,8 +2817,8 @@
         </p:nvSpPr>
         <p:spPr>
           <a:xfrm>
-            <a:off x="5916168" y="2340864"/>
-            <a:ext cx="1843888" cy="0"/>
+            <a:off x="5852160" y="2313432"/>
+            <a:ext cx="1444752" cy="0"/>
           </a:xfrm>
           <a:prstGeom prst="line">
             <a:avLst/>
@@ -2840,8 +2840,8 @@
         </p:nvSpPr>
         <p:spPr>
           <a:xfrm>
-            <a:off x="5916168" y="2377440"/>
-            <a:ext cx="1843888" cy="310896"/>
+            <a:off x="5852160" y="2350008"/>
+            <a:ext cx="1444752" cy="310896"/>
           </a:xfrm>
           <a:prstGeom prst="rect">
             <a:avLst/>
@@ -2857,7 +2857,7 @@
               <a:buNone/>
             </a:pPr>
             <a:r>
-              <a:rPr lang="en-US" sz="1100" dirty="0">
+              <a:rPr lang="en-US" sz="1050" dirty="0">
                 <a:solidFill>
                   <a:schemeClr val="accent5"/>
                 </a:solidFill>
@@ -2868,14 +2868,14 @@
               <a:buNone/>
             </a:pPr>
             <a:r>
-              <a:rPr lang="en-US" sz="1100" b="1" dirty="0">
+              <a:rPr lang="en-US" sz="1050" b="1" dirty="0">
                 <a:solidFill>
                   <a:schemeClr val="tx1"/>
                 </a:solidFill>
               </a:rPr>
               <a:t>30/04/2025</a:t>
             </a:r>
-            <a:endParaRPr lang="en-US" sz="1100" dirty="0"/>
+            <a:endParaRPr lang="en-US" sz="1050" dirty="0"/>
           </a:p>
         </p:txBody>
       </p:sp>
@@ -2887,8 +2887,8 @@
         </p:nvSpPr>
         <p:spPr>
           <a:xfrm>
-            <a:off x="5916168" y="2706624"/>
-            <a:ext cx="1843888" cy="0"/>
+            <a:off x="5852160" y="2697480"/>
+            <a:ext cx="1444752" cy="0"/>
           </a:xfrm>
           <a:prstGeom prst="line">
             <a:avLst/>
@@ -2910,8 +2910,8 @@
         </p:nvSpPr>
         <p:spPr>
           <a:xfrm>
-            <a:off x="5916168" y="2743200"/>
-            <a:ext cx="1843888" cy="310896"/>
+            <a:off x="5852160" y="2734056"/>
+            <a:ext cx="1444752" cy="310896"/>
           </a:xfrm>
           <a:prstGeom prst="rect">
             <a:avLst/>
@@ -2927,7 +2927,7 @@
               <a:buNone/>
             </a:pPr>
             <a:r>
-              <a:rPr lang="en-US" sz="1100" dirty="0">
+              <a:rPr lang="en-US" sz="1050" dirty="0">
                 <a:solidFill>
                   <a:schemeClr val="accent5"/>
                 </a:solidFill>
@@ -2938,14 +2938,14 @@
               <a:buNone/>
             </a:pPr>
             <a:r>
-              <a:rPr lang="en-US" sz="1100" b="1" dirty="0">
+              <a:rPr lang="en-US" sz="1050" b="1" dirty="0">
                 <a:solidFill>
                   <a:schemeClr val="tx1"/>
                 </a:solidFill>
               </a:rPr>
-              <a:t>Gobierno Corporativo</a:t>
-            </a:r>
-            <a:endParaRPr lang="en-US" sz="1100" dirty="0"/>
+              <a:t>NRP-17</a:t>
+            </a:r>
+            <a:endParaRPr lang="en-US" sz="1050" dirty="0"/>
           </a:p>
         </p:txBody>
       </p:sp>
@@ -2957,12 +2957,12 @@
         </p:nvSpPr>
         <p:spPr>
           <a:xfrm>
-            <a:off x="8336128" y="1097280"/>
-            <a:ext cx="3306928" cy="2103120"/>
+            <a:off x="7754112" y="868680"/>
+            <a:ext cx="3888943" cy="2377440"/>
           </a:xfrm>
           <a:prstGeom prst="roundRect">
             <a:avLst>
-              <a:gd name="adj" fmla="val 4348"/>
+              <a:gd name="adj" fmla="val 3846"/>
             </a:avLst>
           </a:prstGeom>
           <a:solidFill>
@@ -2984,12 +2984,12 @@
         </p:nvSpPr>
         <p:spPr>
           <a:xfrm>
-            <a:off x="8473288" y="1234440"/>
-            <a:ext cx="1051560" cy="1828800"/>
+            <a:off x="7872984" y="987552"/>
+            <a:ext cx="1005840" cy="2139696"/>
           </a:xfrm>
           <a:prstGeom prst="roundRect">
             <a:avLst>
-              <a:gd name="adj" fmla="val 8696"/>
+              <a:gd name="adj" fmla="val 9091"/>
             </a:avLst>
           </a:prstGeom>
           <a:solidFill>
@@ -3013,8 +3013,8 @@
         </p:nvSpPr>
         <p:spPr>
           <a:xfrm>
-            <a:off x="8473288" y="1325880"/>
-            <a:ext cx="1051560" cy="182880"/>
+            <a:off x="7872984" y="1152144"/>
+            <a:ext cx="1005840" cy="182880"/>
           </a:xfrm>
           <a:prstGeom prst="rect">
             <a:avLst/>
@@ -3049,8 +3049,8 @@
         </p:nvSpPr>
         <p:spPr>
           <a:xfrm>
-            <a:off x="8473288" y="1508760"/>
-            <a:ext cx="1051560" cy="384048"/>
+            <a:off x="7872984" y="1353312"/>
+            <a:ext cx="1005840" cy="411480"/>
           </a:xfrm>
           <a:prstGeom prst="rect">
             <a:avLst/>
@@ -3066,7 +3066,7 @@
               <a:buNone/>
             </a:pPr>
             <a:r>
-              <a:rPr lang="en-US" sz="2400" b="1" dirty="0">
+              <a:rPr lang="en-US" sz="2600" b="1" dirty="0">
                 <a:solidFill>
                   <a:schemeClr val="bg1"/>
                 </a:solidFill>
@@ -3076,7 +3076,7 @@
               </a:rPr>
               <a:t>05</a:t>
             </a:r>
-            <a:endParaRPr lang="en-US" sz="2400" dirty="0"/>
+            <a:endParaRPr lang="en-US" sz="2600" dirty="0"/>
           </a:p>
         </p:txBody>
       </p:sp>
@@ -3088,8 +3088,8 @@
         </p:nvSpPr>
         <p:spPr>
           <a:xfrm>
-            <a:off x="8473288" y="1892808"/>
-            <a:ext cx="1051560" cy="201168"/>
+            <a:off x="7872984" y="1773936"/>
+            <a:ext cx="1005840" cy="201168"/>
           </a:xfrm>
           <a:prstGeom prst="rect">
             <a:avLst/>
@@ -3124,8 +3124,8 @@
         </p:nvSpPr>
         <p:spPr>
           <a:xfrm>
-            <a:off x="8473288" y="2240280"/>
-            <a:ext cx="1051560" cy="182880"/>
+            <a:off x="7872984" y="2221992"/>
+            <a:ext cx="1005840" cy="182880"/>
           </a:xfrm>
           <a:prstGeom prst="rect">
             <a:avLst/>
@@ -3160,8 +3160,8 @@
         </p:nvSpPr>
         <p:spPr>
           <a:xfrm>
-            <a:off x="8473288" y="2423160"/>
-            <a:ext cx="1051560" cy="384048"/>
+            <a:off x="7872984" y="2423160"/>
+            <a:ext cx="1005840" cy="411480"/>
           </a:xfrm>
           <a:prstGeom prst="rect">
             <a:avLst/>
@@ -3177,7 +3177,7 @@
               <a:buNone/>
             </a:pPr>
             <a:r>
-              <a:rPr lang="en-US" sz="2400" b="1" dirty="0">
+              <a:rPr lang="en-US" sz="2600" b="1" dirty="0">
                 <a:solidFill>
                   <a:schemeClr val="bg1"/>
                 </a:solidFill>
@@ -3187,7 +3187,7 @@
               </a:rPr>
               <a:t>18</a:t>
             </a:r>
-            <a:endParaRPr lang="en-US" sz="2400" dirty="0"/>
+            <a:endParaRPr lang="en-US" sz="2600" dirty="0"/>
           </a:p>
         </p:txBody>
       </p:sp>
@@ -3199,8 +3199,8 @@
         </p:nvSpPr>
         <p:spPr>
           <a:xfrm>
-            <a:off x="8473288" y="2807208"/>
-            <a:ext cx="1051560" cy="201168"/>
+            <a:off x="7872984" y="2843784"/>
+            <a:ext cx="1005840" cy="201168"/>
           </a:xfrm>
           <a:prstGeom prst="rect">
             <a:avLst/>
@@ -3235,8 +3235,8 @@
         </p:nvSpPr>
         <p:spPr>
           <a:xfrm>
-            <a:off x="8656168" y="2148840"/>
-            <a:ext cx="685800" cy="0"/>
+            <a:off x="8055864" y="2057400"/>
+            <a:ext cx="640080" cy="0"/>
           </a:xfrm>
           <a:prstGeom prst="line">
             <a:avLst/>
@@ -3260,8 +3260,8 @@
         </p:nvSpPr>
         <p:spPr>
           <a:xfrm>
-            <a:off x="9680296" y="1234440"/>
-            <a:ext cx="1843888" cy="502920"/>
+            <a:off x="9034272" y="978408"/>
+            <a:ext cx="2499055" cy="274320"/>
           </a:xfrm>
           <a:prstGeom prst="rect">
             <a:avLst/>
@@ -3277,14 +3277,14 @@
               <a:buNone/>
             </a:pPr>
             <a:r>
-              <a:rPr lang="en-US" sz="1400" b="1" dirty="0">
+              <a:rPr lang="en-US" sz="1300" b="1" dirty="0">
                 <a:solidFill>
                   <a:schemeClr val="tx1"/>
                 </a:solidFill>
               </a:rPr>
               <a:t>Resultados preliminares</a:t>
             </a:r>
-            <a:endParaRPr lang="en-US" sz="1400" dirty="0"/>
+            <a:endParaRPr lang="en-US" sz="1300" dirty="0"/>
           </a:p>
         </p:txBody>
       </p:sp>
@@ -3296,8 +3296,8 @@
         </p:nvSpPr>
         <p:spPr>
           <a:xfrm>
-            <a:off x="9680296" y="1810512"/>
-            <a:ext cx="1843888" cy="457200"/>
+            <a:off x="9034272" y="1261872"/>
+            <a:ext cx="2499055" cy="201168"/>
           </a:xfrm>
           <a:prstGeom prst="rect">
             <a:avLst/>
@@ -3313,52 +3313,27 @@
               <a:buNone/>
             </a:pPr>
             <a:r>
-              <a:rPr lang="en-US" sz="1000" dirty="0">
-                <a:solidFill>
-                  <a:schemeClr val="accent5"/>
-                </a:solidFill>
-              </a:rPr>
-              <a:t>Circular No.  </a:t>
-            </a:r>
-            <a:pPr indent="0" marL="0">
-              <a:buNone/>
-            </a:pPr>
-            <a:r>
-              <a:rPr lang="en-US" sz="1050" b="1" dirty="0">
+              <a:rPr lang="en-US" sz="950" b="1" dirty="0">
                 <a:solidFill>
                   <a:schemeClr val="accent1"/>
                 </a:solidFill>
               </a:rPr>
-              <a:t>05/11/2025</a:t>
-            </a:r>
-            <a:endParaRPr lang="en-US" sz="1100" dirty="0"/>
-          </a:p>
-          <a:p>
-            <a:pPr indent="0" marL="0">
-              <a:buNone/>
-            </a:pPr>
-            <a:r>
-              <a:rPr lang="en-US" sz="1100" b="1" dirty="0">
-                <a:solidFill>
-                  <a:schemeClr val="accent1"/>
-                </a:solidFill>
-              </a:rPr>
-              <a:t>DS-SABAO-BCS-BC-17003</a:t>
-            </a:r>
-            <a:endParaRPr lang="en-US" sz="1100" dirty="0"/>
-          </a:p>
-        </p:txBody>
-      </p:sp>
-      <p:sp>
-        <p:nvSpPr>
-          <p:cNvPr id="52" name="Separador 2025-2-0"/>
+              <a:t>DS-SABAO-BCS-BC-17003  ·  05/11/2025</a:t>
+            </a:r>
+            <a:endParaRPr lang="en-US" sz="950" dirty="0"/>
+          </a:p>
+        </p:txBody>
+      </p:sp>
+      <p:sp>
+        <p:nvSpPr>
+          <p:cNvPr id="52" name="Separador lista 2025-2"/>
           <p:cNvSpPr/>
           <p:nvPr/>
         </p:nvSpPr>
         <p:spPr>
           <a:xfrm>
-            <a:off x="9680296" y="2340864"/>
-            <a:ext cx="1843888" cy="0"/>
+            <a:off x="9034272" y="1527048"/>
+            <a:ext cx="2499055" cy="0"/>
           </a:xfrm>
           <a:prstGeom prst="line">
             <a:avLst/>
@@ -3374,131 +3349,360 @@
       </p:sp>
       <p:sp>
         <p:nvSpPr>
-          <p:cNvPr id="53" name="Dato 2025-2-0"/>
-          <p:cNvSpPr txBox="1"/>
-          <p:nvPr/>
-        </p:nvSpPr>
-        <p:spPr>
-          <a:xfrm>
-            <a:off x="9680296" y="2377440"/>
-            <a:ext cx="1843888" cy="310896"/>
-          </a:xfrm>
-          <a:prstGeom prst="rect">
-            <a:avLst/>
-          </a:prstGeom>
-          <a:noFill/>
-          <a:ln/>
-        </p:spPr>
-        <p:txBody>
-          <a:bodyPr wrap="square" lIns="0" tIns="0" rIns="0" bIns="0" rtlCol="0" anchor="ctr"/>
-          <a:lstStyle/>
-          <a:p>
-            <a:pPr indent="0" marL="0">
-              <a:buNone/>
-            </a:pPr>
-            <a:r>
-              <a:rPr lang="en-US" sz="1100" dirty="0">
-                <a:solidFill>
-                  <a:schemeClr val="accent5"/>
-                </a:solidFill>
-              </a:rPr>
-              <a:t>Resultado  </a:t>
-            </a:r>
-            <a:pPr indent="0" marL="0">
-              <a:buNone/>
-            </a:pPr>
-            <a:r>
-              <a:rPr lang="en-US" sz="1100" b="1" dirty="0">
+          <p:cNvPr id="53" name="Listado 2025-2"/>
+          <p:cNvSpPr txBox="1"/>
+          <p:nvPr/>
+        </p:nvSpPr>
+        <p:spPr>
+          <a:xfrm>
+            <a:off x="9034272" y="1581912"/>
+            <a:ext cx="2499055" cy="1572768"/>
+          </a:xfrm>
+          <a:prstGeom prst="rect">
+            <a:avLst/>
+          </a:prstGeom>
+          <a:noFill/>
+          <a:ln/>
+        </p:spPr>
+        <p:txBody>
+          <a:bodyPr wrap="square" lIns="0" tIns="0" rIns="0" bIns="0" rtlCol="0" anchor="t"/>
+          <a:lstStyle/>
+          <a:p>
+            <a:pPr indent="0" marL="0">
+              <a:lnSpc>
+                <a:spcPct val="92000"/>
+              </a:lnSpc>
+              <a:buNone/>
+            </a:pPr>
+            <a:r>
+              <a:rPr lang="en-US" sz="850" b="1" spc="100" kern="0" dirty="0">
+                <a:solidFill>
+                  <a:schemeClr val="accent1"/>
+                </a:solidFill>
+              </a:rPr>
+              <a:t>9 OBSERVACIONES</a:t>
+            </a:r>
+            <a:endParaRPr lang="en-US" sz="950" dirty="0"/>
+          </a:p>
+          <a:p>
+            <a:pPr indent="0" marL="0">
+              <a:lnSpc>
+                <a:spcPct val="92000"/>
+              </a:lnSpc>
+              <a:buNone/>
+            </a:pPr>
+            <a:r>
+              <a:rPr lang="en-US" sz="950" b="1" dirty="0">
+                <a:solidFill>
+                  <a:schemeClr val="accent1"/>
+                </a:solidFill>
+              </a:rPr>
+              <a:t>1  </a:t>
+            </a:r>
+            <a:pPr indent="0" marL="0">
+              <a:lnSpc>
+                <a:spcPct val="92000"/>
+              </a:lnSpc>
+              <a:buNone/>
+            </a:pPr>
+            <a:r>
+              <a:rPr lang="en-US" sz="950" dirty="0">
                 <a:solidFill>
                   <a:schemeClr val="tx1"/>
                 </a:solidFill>
               </a:rPr>
-              <a:t>9 observaciones</a:t>
-            </a:r>
-            <a:endParaRPr lang="en-US" sz="1100" dirty="0"/>
-          </a:p>
-        </p:txBody>
-      </p:sp>
-      <p:sp>
-        <p:nvSpPr>
-          <p:cNvPr id="54" name="Separador 2025-2-1"/>
+              <a:t>Política de Operaciones Vinculadas</a:t>
+            </a:r>
+            <a:endParaRPr lang="en-US" sz="950" dirty="0"/>
+          </a:p>
+          <a:p>
+            <a:pPr indent="0" marL="0">
+              <a:lnSpc>
+                <a:spcPct val="92000"/>
+              </a:lnSpc>
+              <a:buNone/>
+            </a:pPr>
+            <a:r>
+              <a:rPr lang="en-US" sz="950" b="1" dirty="0">
+                <a:solidFill>
+                  <a:schemeClr val="accent1"/>
+                </a:solidFill>
+              </a:rPr>
+              <a:t>2  </a:t>
+            </a:r>
+            <a:pPr indent="0" marL="0">
+              <a:lnSpc>
+                <a:spcPct val="92000"/>
+              </a:lnSpc>
+              <a:buNone/>
+            </a:pPr>
+            <a:r>
+              <a:rPr lang="en-US" sz="950" dirty="0">
+                <a:solidFill>
+                  <a:schemeClr val="tx1"/>
+                </a:solidFill>
+              </a:rPr>
+              <a:t>Confidencialidad e inducción en actas</a:t>
+            </a:r>
+            <a:endParaRPr lang="en-US" sz="950" dirty="0"/>
+          </a:p>
+          <a:p>
+            <a:pPr indent="0" marL="0">
+              <a:lnSpc>
+                <a:spcPct val="92000"/>
+              </a:lnSpc>
+              <a:buNone/>
+            </a:pPr>
+            <a:r>
+              <a:rPr lang="en-US" sz="950" b="1" dirty="0">
+                <a:solidFill>
+                  <a:schemeClr val="accent1"/>
+                </a:solidFill>
+              </a:rPr>
+              <a:t>3  </a:t>
+            </a:r>
+            <a:pPr indent="0" marL="0">
+              <a:lnSpc>
+                <a:spcPct val="92000"/>
+              </a:lnSpc>
+              <a:buNone/>
+            </a:pPr>
+            <a:r>
+              <a:rPr lang="en-US" sz="950" b="1" dirty="0">
+                <a:solidFill>
+                  <a:schemeClr val="accent3"/>
+                </a:solidFill>
+              </a:rPr>
+              <a:t>Comités sin personal ejecutivo</a:t>
+            </a:r>
+            <a:pPr indent="0" marL="0">
+              <a:lnSpc>
+                <a:spcPct val="92000"/>
+              </a:lnSpc>
+              <a:buNone/>
+            </a:pPr>
+            <a:r>
+              <a:rPr lang="en-US" sz="850" dirty="0">
+                <a:solidFill>
+                  <a:schemeClr val="accent3"/>
+                </a:solidFill>
+              </a:rPr>
+              <a:t>  · seguimiento</a:t>
+            </a:r>
+            <a:endParaRPr lang="en-US" sz="950" dirty="0"/>
+          </a:p>
+          <a:p>
+            <a:pPr indent="0" marL="0">
+              <a:lnSpc>
+                <a:spcPct val="92000"/>
+              </a:lnSpc>
+              <a:buNone/>
+            </a:pPr>
+            <a:r>
+              <a:rPr lang="en-US" sz="950" b="1" dirty="0">
+                <a:solidFill>
+                  <a:schemeClr val="accent1"/>
+                </a:solidFill>
+              </a:rPr>
+              <a:t>4  </a:t>
+            </a:r>
+            <a:pPr indent="0" marL="0">
+              <a:lnSpc>
+                <a:spcPct val="92000"/>
+              </a:lnSpc>
+              <a:buNone/>
+            </a:pPr>
+            <a:r>
+              <a:rPr lang="en-US" sz="950" dirty="0">
+                <a:solidFill>
+                  <a:schemeClr val="tx1"/>
+                </a:solidFill>
+              </a:rPr>
+              <a:t>Pago de dietas</a:t>
+            </a:r>
+            <a:endParaRPr lang="en-US" sz="950" dirty="0"/>
+          </a:p>
+          <a:p>
+            <a:pPr indent="0" marL="0">
+              <a:lnSpc>
+                <a:spcPct val="92000"/>
+              </a:lnSpc>
+              <a:buNone/>
+            </a:pPr>
+            <a:r>
+              <a:rPr lang="en-US" sz="950" b="1" dirty="0">
+                <a:solidFill>
+                  <a:schemeClr val="accent1"/>
+                </a:solidFill>
+              </a:rPr>
+              <a:t>5  </a:t>
+            </a:r>
+            <a:pPr indent="0" marL="0">
+              <a:lnSpc>
+                <a:spcPct val="92000"/>
+              </a:lnSpc>
+              <a:buNone/>
+            </a:pPr>
+            <a:r>
+              <a:rPr lang="en-US" sz="950" b="1" dirty="0">
+                <a:solidFill>
+                  <a:schemeClr val="accent3"/>
+                </a:solidFill>
+              </a:rPr>
+              <a:t>Normativa interna desactualizada</a:t>
+            </a:r>
+            <a:pPr indent="0" marL="0">
+              <a:lnSpc>
+                <a:spcPct val="92000"/>
+              </a:lnSpc>
+              <a:buNone/>
+            </a:pPr>
+            <a:r>
+              <a:rPr lang="en-US" sz="850" dirty="0">
+                <a:solidFill>
+                  <a:schemeClr val="accent3"/>
+                </a:solidFill>
+              </a:rPr>
+              <a:t>  · seguimiento</a:t>
+            </a:r>
+            <a:endParaRPr lang="en-US" sz="950" dirty="0"/>
+          </a:p>
+          <a:p>
+            <a:pPr indent="0" marL="0">
+              <a:lnSpc>
+                <a:spcPct val="92000"/>
+              </a:lnSpc>
+              <a:buNone/>
+            </a:pPr>
+            <a:r>
+              <a:rPr lang="en-US" sz="950" b="1" dirty="0">
+                <a:solidFill>
+                  <a:schemeClr val="accent1"/>
+                </a:solidFill>
+              </a:rPr>
+              <a:t>6  </a:t>
+            </a:r>
+            <a:pPr indent="0" marL="0">
+              <a:lnSpc>
+                <a:spcPct val="92000"/>
+              </a:lnSpc>
+              <a:buNone/>
+            </a:pPr>
+            <a:r>
+              <a:rPr lang="en-US" sz="950" dirty="0">
+                <a:solidFill>
+                  <a:schemeClr val="tx1"/>
+                </a:solidFill>
+              </a:rPr>
+              <a:t>Soporte de Ferias de Crédito</a:t>
+            </a:r>
+            <a:endParaRPr lang="en-US" sz="950" dirty="0"/>
+          </a:p>
+          <a:p>
+            <a:pPr indent="0" marL="0">
+              <a:lnSpc>
+                <a:spcPct val="92000"/>
+              </a:lnSpc>
+              <a:buNone/>
+            </a:pPr>
+            <a:r>
+              <a:rPr lang="en-US" sz="950" b="1" dirty="0">
+                <a:solidFill>
+                  <a:schemeClr val="accent1"/>
+                </a:solidFill>
+              </a:rPr>
+              <a:t>7  </a:t>
+            </a:r>
+            <a:pPr indent="0" marL="0">
+              <a:lnSpc>
+                <a:spcPct val="92000"/>
+              </a:lnSpc>
+              <a:buNone/>
+            </a:pPr>
+            <a:r>
+              <a:rPr lang="en-US" sz="950" dirty="0">
+                <a:solidFill>
+                  <a:schemeClr val="tx1"/>
+                </a:solidFill>
+              </a:rPr>
+              <a:t>Declaración jurada (NRP-75)</a:t>
+            </a:r>
+            <a:endParaRPr lang="en-US" sz="950" dirty="0"/>
+          </a:p>
+          <a:p>
+            <a:pPr indent="0" marL="0">
+              <a:lnSpc>
+                <a:spcPct val="92000"/>
+              </a:lnSpc>
+              <a:buNone/>
+            </a:pPr>
+            <a:r>
+              <a:rPr lang="en-US" sz="950" b="1" dirty="0">
+                <a:solidFill>
+                  <a:schemeClr val="accent1"/>
+                </a:solidFill>
+              </a:rPr>
+              <a:t>8  </a:t>
+            </a:r>
+            <a:pPr indent="0" marL="0">
+              <a:lnSpc>
+                <a:spcPct val="92000"/>
+              </a:lnSpc>
+              <a:buNone/>
+            </a:pPr>
+            <a:r>
+              <a:rPr lang="en-US" sz="950" dirty="0">
+                <a:solidFill>
+                  <a:schemeClr val="tx1"/>
+                </a:solidFill>
+              </a:rPr>
+              <a:t>Manual de Compras</a:t>
+            </a:r>
+            <a:endParaRPr lang="en-US" sz="950" dirty="0"/>
+          </a:p>
+          <a:p>
+            <a:pPr indent="0" marL="0">
+              <a:lnSpc>
+                <a:spcPct val="92000"/>
+              </a:lnSpc>
+              <a:buNone/>
+            </a:pPr>
+            <a:r>
+              <a:rPr lang="en-US" sz="950" b="1" dirty="0">
+                <a:solidFill>
+                  <a:schemeClr val="accent1"/>
+                </a:solidFill>
+              </a:rPr>
+              <a:t>9  </a:t>
+            </a:r>
+            <a:pPr indent="0" marL="0">
+              <a:lnSpc>
+                <a:spcPct val="92000"/>
+              </a:lnSpc>
+              <a:buNone/>
+            </a:pPr>
+            <a:r>
+              <a:rPr lang="en-US" sz="950" dirty="0">
+                <a:solidFill>
+                  <a:schemeClr val="tx1"/>
+                </a:solidFill>
+              </a:rPr>
+              <a:t>Uso del Fondo de Educación</a:t>
+            </a:r>
+            <a:endParaRPr lang="en-US" sz="950" dirty="0"/>
+          </a:p>
+        </p:txBody>
+      </p:sp>
+      <p:sp>
+        <p:nvSpPr>
+          <p:cNvPr id="54" name="Flecha 2025"/>
           <p:cNvSpPr/>
           <p:nvPr/>
         </p:nvSpPr>
         <p:spPr>
           <a:xfrm>
-            <a:off x="9680296" y="2706624"/>
-            <a:ext cx="1843888" cy="0"/>
-          </a:xfrm>
-          <a:prstGeom prst="line">
-            <a:avLst/>
-          </a:prstGeom>
-          <a:noFill/>
-          <a:ln w="9525">
-            <a:solidFill>
-              <a:srgbClr val="D9E0EA"/>
-            </a:solidFill>
-            <a:prstDash val="solid"/>
-          </a:ln>
-        </p:spPr>
-      </p:sp>
-      <p:sp>
-        <p:nvSpPr>
-          <p:cNvPr id="55" name="Dato 2025-2-1"/>
-          <p:cNvSpPr txBox="1"/>
-          <p:nvPr/>
-        </p:nvSpPr>
-        <p:spPr>
-          <a:xfrm>
-            <a:off x="9680296" y="2743200"/>
-            <a:ext cx="1843888" cy="310896"/>
-          </a:xfrm>
-          <a:prstGeom prst="rect">
-            <a:avLst/>
-          </a:prstGeom>
-          <a:noFill/>
-          <a:ln/>
-        </p:spPr>
-        <p:txBody>
-          <a:bodyPr wrap="square" lIns="0" tIns="0" rIns="0" bIns="0" rtlCol="0" anchor="ctr"/>
-          <a:lstStyle/>
-          <a:p>
-            <a:pPr indent="0" marL="0">
-              <a:buNone/>
-            </a:pPr>
-            <a:r>
-              <a:rPr lang="en-US" sz="1100" dirty="0">
-                <a:solidFill>
-                  <a:schemeClr val="accent5"/>
-                </a:solidFill>
-              </a:rPr>
-              <a:t>Ref. envío  </a:t>
-            </a:r>
-            <a:pPr indent="0" marL="0">
-              <a:buNone/>
-            </a:pPr>
-            <a:r>
-              <a:rPr lang="en-US" sz="1100" b="1" dirty="0">
-                <a:solidFill>
-                  <a:schemeClr val="tx1"/>
-                </a:solidFill>
-              </a:rPr>
-              <a:t>NB07-2025-974</a:t>
-            </a:r>
-            <a:endParaRPr lang="en-US" sz="1100" dirty="0"/>
-          </a:p>
-        </p:txBody>
-      </p:sp>
-      <p:sp>
-        <p:nvSpPr>
-          <p:cNvPr id="56" name="Flecha 2025"/>
-          <p:cNvSpPr/>
-          <p:nvPr/>
-        </p:nvSpPr>
-        <p:spPr>
-          <a:xfrm>
-            <a:off x="7970368" y="2011680"/>
-            <a:ext cx="274320" cy="274320"/>
+            <a:off x="7452360" y="1929384"/>
+            <a:ext cx="256032" cy="256032"/>
           </a:xfrm>
           <a:prstGeom prst="rightArrow">
             <a:avLst/>
@@ -3518,14 +3722,14 @@
       </p:sp>
       <p:sp>
         <p:nvSpPr>
-          <p:cNvPr id="57" name="Año 2026"/>
-          <p:cNvSpPr txBox="1"/>
-          <p:nvPr/>
-        </p:nvSpPr>
-        <p:spPr>
-          <a:xfrm>
-            <a:off x="4572000" y="3401568"/>
-            <a:ext cx="1188720" cy="502920"/>
+          <p:cNvPr id="55" name="Año 2026"/>
+          <p:cNvSpPr txBox="1"/>
+          <p:nvPr/>
+        </p:nvSpPr>
+        <p:spPr>
+          <a:xfrm>
+            <a:off x="4572000" y="3310128"/>
+            <a:ext cx="1188720" cy="457200"/>
           </a:xfrm>
           <a:prstGeom prst="rect">
             <a:avLst/>
@@ -3541,7 +3745,7 @@
               <a:buNone/>
             </a:pPr>
             <a:r>
-              <a:rPr lang="en-US" sz="3000" b="1" dirty="0">
+              <a:rPr lang="en-US" sz="2800" b="1" dirty="0">
                 <a:solidFill>
                   <a:schemeClr val="accent2"/>
                 </a:solidFill>
@@ -3551,20 +3755,20 @@
               </a:rPr>
               <a:t>2026</a:t>
             </a:r>
-            <a:endParaRPr lang="en-US" sz="3000" dirty="0"/>
-          </a:p>
-        </p:txBody>
-      </p:sp>
-      <p:sp>
-        <p:nvSpPr>
-          <p:cNvPr id="58" name="Visita 2026"/>
-          <p:cNvSpPr txBox="1"/>
-          <p:nvPr/>
-        </p:nvSpPr>
-        <p:spPr>
-          <a:xfrm>
-            <a:off x="5806440" y="3401568"/>
-            <a:ext cx="3657600" cy="502920"/>
+            <a:endParaRPr lang="en-US" sz="2800" dirty="0"/>
+          </a:p>
+        </p:txBody>
+      </p:sp>
+      <p:sp>
+        <p:nvSpPr>
+          <p:cNvPr id="56" name="Visita 2026"/>
+          <p:cNvSpPr txBox="1"/>
+          <p:nvPr/>
+        </p:nvSpPr>
+        <p:spPr>
+          <a:xfrm>
+            <a:off x="5760720" y="3310128"/>
+            <a:ext cx="3657600" cy="457200"/>
           </a:xfrm>
           <a:prstGeom prst="rect">
             <a:avLst/>
@@ -3593,18 +3797,18 @@
       </p:sp>
       <p:sp>
         <p:nvSpPr>
-          <p:cNvPr id="59" name="Tarjeta 2026-1"/>
+          <p:cNvPr id="57" name="Tarjeta 2026-1"/>
           <p:cNvSpPr/>
           <p:nvPr/>
         </p:nvSpPr>
         <p:spPr>
           <a:xfrm>
-            <a:off x="4572000" y="4041648"/>
-            <a:ext cx="3306928" cy="2103120"/>
+            <a:off x="4572000" y="3858768"/>
+            <a:ext cx="2834640" cy="2377440"/>
           </a:xfrm>
           <a:prstGeom prst="roundRect">
             <a:avLst>
-              <a:gd name="adj" fmla="val 4348"/>
+              <a:gd name="adj" fmla="val 3846"/>
             </a:avLst>
           </a:prstGeom>
           <a:solidFill>
@@ -3620,18 +3824,18 @@
       </p:sp>
       <p:sp>
         <p:nvSpPr>
-          <p:cNvPr id="60" name="Fechas fondo 2026-1"/>
+          <p:cNvPr id="58" name="Fechas fondo 2026-1"/>
           <p:cNvSpPr/>
           <p:nvPr/>
         </p:nvSpPr>
         <p:spPr>
           <a:xfrm>
-            <a:off x="4709160" y="4178808"/>
-            <a:ext cx="1051560" cy="1828800"/>
+            <a:off x="4690872" y="3977640"/>
+            <a:ext cx="1005840" cy="2139696"/>
           </a:xfrm>
           <a:prstGeom prst="roundRect">
             <a:avLst>
-              <a:gd name="adj" fmla="val 8696"/>
+              <a:gd name="adj" fmla="val 9091"/>
             </a:avLst>
           </a:prstGeom>
           <a:solidFill>
@@ -3649,14 +3853,14 @@
       </p:sp>
       <p:sp>
         <p:nvSpPr>
-          <p:cNvPr id="61" name="Fecha etiqueta 2026-1-0"/>
-          <p:cNvSpPr txBox="1"/>
-          <p:nvPr/>
-        </p:nvSpPr>
-        <p:spPr>
-          <a:xfrm>
-            <a:off x="4709160" y="4270248"/>
-            <a:ext cx="1051560" cy="182880"/>
+          <p:cNvPr id="59" name="Fecha etiqueta 2026-1-0"/>
+          <p:cNvSpPr txBox="1"/>
+          <p:nvPr/>
+        </p:nvSpPr>
+        <p:spPr>
+          <a:xfrm>
+            <a:off x="4690872" y="4142232"/>
+            <a:ext cx="1005840" cy="182880"/>
           </a:xfrm>
           <a:prstGeom prst="rect">
             <a:avLst/>
@@ -3685,14 +3889,14 @@
       </p:sp>
       <p:sp>
         <p:nvSpPr>
-          <p:cNvPr id="62" name="Fecha día 2026-1-0"/>
-          <p:cNvSpPr txBox="1"/>
-          <p:nvPr/>
-        </p:nvSpPr>
-        <p:spPr>
-          <a:xfrm>
-            <a:off x="4709160" y="4453128"/>
-            <a:ext cx="1051560" cy="384048"/>
+          <p:cNvPr id="60" name="Fecha día 2026-1-0"/>
+          <p:cNvSpPr txBox="1"/>
+          <p:nvPr/>
+        </p:nvSpPr>
+        <p:spPr>
+          <a:xfrm>
+            <a:off x="4690872" y="4343400"/>
+            <a:ext cx="1005840" cy="411480"/>
           </a:xfrm>
           <a:prstGeom prst="rect">
             <a:avLst/>
@@ -3708,7 +3912,7 @@
               <a:buNone/>
             </a:pPr>
             <a:r>
-              <a:rPr lang="en-US" sz="2400" b="1" dirty="0">
+              <a:rPr lang="en-US" sz="2600" b="1" dirty="0">
                 <a:solidFill>
                   <a:schemeClr val="bg1"/>
                 </a:solidFill>
@@ -3718,20 +3922,20 @@
               </a:rPr>
               <a:t>21</a:t>
             </a:r>
-            <a:endParaRPr lang="en-US" sz="2400" dirty="0"/>
-          </a:p>
-        </p:txBody>
-      </p:sp>
-      <p:sp>
-        <p:nvSpPr>
-          <p:cNvPr id="63" name="Fecha mes 2026-1-0"/>
-          <p:cNvSpPr txBox="1"/>
-          <p:nvPr/>
-        </p:nvSpPr>
-        <p:spPr>
-          <a:xfrm>
-            <a:off x="4709160" y="4837176"/>
-            <a:ext cx="1051560" cy="201168"/>
+            <a:endParaRPr lang="en-US" sz="2600" dirty="0"/>
+          </a:p>
+        </p:txBody>
+      </p:sp>
+      <p:sp>
+        <p:nvSpPr>
+          <p:cNvPr id="61" name="Fecha mes 2026-1-0"/>
+          <p:cNvSpPr txBox="1"/>
+          <p:nvPr/>
+        </p:nvSpPr>
+        <p:spPr>
+          <a:xfrm>
+            <a:off x="4690872" y="4764024"/>
+            <a:ext cx="1005840" cy="201168"/>
           </a:xfrm>
           <a:prstGeom prst="rect">
             <a:avLst/>
@@ -3760,14 +3964,14 @@
       </p:sp>
       <p:sp>
         <p:nvSpPr>
-          <p:cNvPr id="64" name="Fecha etiqueta 2026-1-1"/>
-          <p:cNvSpPr txBox="1"/>
-          <p:nvPr/>
-        </p:nvSpPr>
-        <p:spPr>
-          <a:xfrm>
-            <a:off x="4709160" y="5184648"/>
-            <a:ext cx="1051560" cy="182880"/>
+          <p:cNvPr id="62" name="Fecha etiqueta 2026-1-1"/>
+          <p:cNvSpPr txBox="1"/>
+          <p:nvPr/>
+        </p:nvSpPr>
+        <p:spPr>
+          <a:xfrm>
+            <a:off x="4690872" y="5212080"/>
+            <a:ext cx="1005840" cy="182880"/>
           </a:xfrm>
           <a:prstGeom prst="rect">
             <a:avLst/>
@@ -3796,14 +4000,14 @@
       </p:sp>
       <p:sp>
         <p:nvSpPr>
-          <p:cNvPr id="65" name="Fecha día 2026-1-1"/>
-          <p:cNvSpPr txBox="1"/>
-          <p:nvPr/>
-        </p:nvSpPr>
-        <p:spPr>
-          <a:xfrm>
-            <a:off x="4709160" y="5367528"/>
-            <a:ext cx="1051560" cy="384048"/>
+          <p:cNvPr id="63" name="Fecha día 2026-1-1"/>
+          <p:cNvSpPr txBox="1"/>
+          <p:nvPr/>
+        </p:nvSpPr>
+        <p:spPr>
+          <a:xfrm>
+            <a:off x="4690872" y="5413248"/>
+            <a:ext cx="1005840" cy="411480"/>
           </a:xfrm>
           <a:prstGeom prst="rect">
             <a:avLst/>
@@ -3819,7 +4023,7 @@
               <a:buNone/>
             </a:pPr>
             <a:r>
-              <a:rPr lang="en-US" sz="2400" b="1" dirty="0">
+              <a:rPr lang="en-US" sz="2600" b="1" dirty="0">
                 <a:solidFill>
                   <a:schemeClr val="bg1"/>
                 </a:solidFill>
@@ -3829,20 +4033,20 @@
               </a:rPr>
               <a:t>09</a:t>
             </a:r>
-            <a:endParaRPr lang="en-US" sz="2400" dirty="0"/>
-          </a:p>
-        </p:txBody>
-      </p:sp>
-      <p:sp>
-        <p:nvSpPr>
-          <p:cNvPr id="66" name="Fecha mes 2026-1-1"/>
-          <p:cNvSpPr txBox="1"/>
-          <p:nvPr/>
-        </p:nvSpPr>
-        <p:spPr>
-          <a:xfrm>
-            <a:off x="4709160" y="5751576"/>
-            <a:ext cx="1051560" cy="201168"/>
+            <a:endParaRPr lang="en-US" sz="2600" dirty="0"/>
+          </a:p>
+        </p:txBody>
+      </p:sp>
+      <p:sp>
+        <p:nvSpPr>
+          <p:cNvPr id="64" name="Fecha mes 2026-1-1"/>
+          <p:cNvSpPr txBox="1"/>
+          <p:nvPr/>
+        </p:nvSpPr>
+        <p:spPr>
+          <a:xfrm>
+            <a:off x="4690872" y="5833872"/>
+            <a:ext cx="1005840" cy="201168"/>
           </a:xfrm>
           <a:prstGeom prst="rect">
             <a:avLst/>
@@ -3871,14 +4075,14 @@
       </p:sp>
       <p:sp>
         <p:nvSpPr>
-          <p:cNvPr id="67" name="Fechas separador 2026-1"/>
+          <p:cNvPr id="65" name="Fechas separador 2026-1"/>
           <p:cNvSpPr/>
           <p:nvPr/>
         </p:nvSpPr>
         <p:spPr>
           <a:xfrm>
-            <a:off x="4892040" y="5093208"/>
-            <a:ext cx="685800" cy="0"/>
+            <a:off x="4873752" y="5047488"/>
+            <a:ext cx="640080" cy="0"/>
           </a:xfrm>
           <a:prstGeom prst="line">
             <a:avLst/>
@@ -3896,14 +4100,14 @@
       </p:sp>
       <p:sp>
         <p:nvSpPr>
-          <p:cNvPr id="68" name="Tipo 2026-1"/>
-          <p:cNvSpPr txBox="1"/>
-          <p:nvPr/>
-        </p:nvSpPr>
-        <p:spPr>
-          <a:xfrm>
-            <a:off x="5916168" y="4178808"/>
-            <a:ext cx="1843888" cy="502920"/>
+          <p:cNvPr id="66" name="Tipo 2026-1"/>
+          <p:cNvSpPr txBox="1"/>
+          <p:nvPr/>
+        </p:nvSpPr>
+        <p:spPr>
+          <a:xfrm>
+            <a:off x="5852160" y="3995928"/>
+            <a:ext cx="1444752" cy="566928"/>
           </a:xfrm>
           <a:prstGeom prst="rect">
             <a:avLst/>
@@ -3919,27 +4123,27 @@
               <a:buNone/>
             </a:pPr>
             <a:r>
-              <a:rPr lang="en-US" sz="1400" b="1" dirty="0">
+              <a:rPr lang="en-US" sz="1300" b="1" dirty="0">
                 <a:solidFill>
                   <a:schemeClr val="tx1"/>
                 </a:solidFill>
               </a:rPr>
               <a:t>Nombramiento de visita ampliada</a:t>
             </a:r>
-            <a:endParaRPr lang="en-US" sz="1400" dirty="0"/>
-          </a:p>
-        </p:txBody>
-      </p:sp>
-      <p:sp>
-        <p:nvSpPr>
-          <p:cNvPr id="69" name="Circular 2026-1"/>
-          <p:cNvSpPr txBox="1"/>
-          <p:nvPr/>
-        </p:nvSpPr>
-        <p:spPr>
-          <a:xfrm>
-            <a:off x="5916168" y="4754880"/>
-            <a:ext cx="1843888" cy="457200"/>
+            <a:endParaRPr lang="en-US" sz="1300" dirty="0"/>
+          </a:p>
+        </p:txBody>
+      </p:sp>
+      <p:sp>
+        <p:nvSpPr>
+          <p:cNvPr id="67" name="Circular 2026-1"/>
+          <p:cNvSpPr txBox="1"/>
+          <p:nvPr/>
+        </p:nvSpPr>
+        <p:spPr>
+          <a:xfrm>
+            <a:off x="5852160" y="4663440"/>
+            <a:ext cx="1444752" cy="457200"/>
           </a:xfrm>
           <a:prstGeom prst="rect">
             <a:avLst/>
@@ -3955,7 +4159,7 @@
               <a:buNone/>
             </a:pPr>
             <a:r>
-              <a:rPr lang="en-US" sz="1000" dirty="0">
+              <a:rPr lang="en-US" sz="950" dirty="0">
                 <a:solidFill>
                   <a:schemeClr val="accent5"/>
                 </a:solidFill>
@@ -3966,41 +4170,41 @@
               <a:buNone/>
             </a:pPr>
             <a:r>
-              <a:rPr lang="en-US" sz="1050" b="1" dirty="0">
+              <a:rPr lang="en-US" sz="1000" b="1" dirty="0">
                 <a:solidFill>
                   <a:schemeClr val="accent2"/>
                 </a:solidFill>
               </a:rPr>
               <a:t>31/07/2026</a:t>
             </a:r>
-            <a:endParaRPr lang="en-US" sz="1100" dirty="0"/>
-          </a:p>
-          <a:p>
-            <a:pPr indent="0" marL="0">
-              <a:buNone/>
-            </a:pPr>
-            <a:r>
-              <a:rPr lang="en-US" sz="1100" b="1" dirty="0">
+            <a:endParaRPr lang="en-US" sz="1000" dirty="0"/>
+          </a:p>
+          <a:p>
+            <a:pPr indent="0" marL="0">
+              <a:buNone/>
+            </a:pPr>
+            <a:r>
+              <a:rPr lang="en-US" sz="1000" b="1" dirty="0">
                 <a:solidFill>
                   <a:schemeClr val="accent2"/>
                 </a:solidFill>
               </a:rPr>
               <a:t>SABAO-BCS-BC-18432</a:t>
             </a:r>
-            <a:endParaRPr lang="en-US" sz="1100" dirty="0"/>
-          </a:p>
-        </p:txBody>
-      </p:sp>
-      <p:sp>
-        <p:nvSpPr>
-          <p:cNvPr id="70" name="Separador 2026-1-0"/>
+            <a:endParaRPr lang="en-US" sz="1000" dirty="0"/>
+          </a:p>
+        </p:txBody>
+      </p:sp>
+      <p:sp>
+        <p:nvSpPr>
+          <p:cNvPr id="68" name="Separador 2026-1-0"/>
           <p:cNvSpPr/>
           <p:nvPr/>
         </p:nvSpPr>
         <p:spPr>
           <a:xfrm>
-            <a:off x="5916168" y="5285232"/>
-            <a:ext cx="1843888" cy="0"/>
+            <a:off x="5852160" y="5303520"/>
+            <a:ext cx="1444752" cy="0"/>
           </a:xfrm>
           <a:prstGeom prst="line">
             <a:avLst/>
@@ -4016,14 +4220,14 @@
       </p:sp>
       <p:sp>
         <p:nvSpPr>
-          <p:cNvPr id="71" name="Dato 2026-1-0"/>
-          <p:cNvSpPr txBox="1"/>
-          <p:nvPr/>
-        </p:nvSpPr>
-        <p:spPr>
-          <a:xfrm>
-            <a:off x="5916168" y="5321808"/>
-            <a:ext cx="1843888" cy="310896"/>
+          <p:cNvPr id="69" name="Dato 2026-1-0"/>
+          <p:cNvSpPr txBox="1"/>
+          <p:nvPr/>
+        </p:nvSpPr>
+        <p:spPr>
+          <a:xfrm>
+            <a:off x="5852160" y="5340096"/>
+            <a:ext cx="1444752" cy="310896"/>
           </a:xfrm>
           <a:prstGeom prst="rect">
             <a:avLst/>
@@ -4039,7 +4243,7 @@
               <a:buNone/>
             </a:pPr>
             <a:r>
-              <a:rPr lang="en-US" sz="1100" dirty="0">
+              <a:rPr lang="en-US" sz="1050" dirty="0">
                 <a:solidFill>
                   <a:schemeClr val="accent5"/>
                 </a:solidFill>
@@ -4050,27 +4254,27 @@
               <a:buNone/>
             </a:pPr>
             <a:r>
-              <a:rPr lang="en-US" sz="1100" b="1" dirty="0">
+              <a:rPr lang="en-US" sz="1050" b="1" dirty="0">
                 <a:solidFill>
                   <a:schemeClr val="tx1"/>
                 </a:solidFill>
               </a:rPr>
               <a:t>31/07/2026</a:t>
             </a:r>
-            <a:endParaRPr lang="en-US" sz="1100" dirty="0"/>
-          </a:p>
-        </p:txBody>
-      </p:sp>
-      <p:sp>
-        <p:nvSpPr>
-          <p:cNvPr id="72" name="Separador 2026-1-1"/>
+            <a:endParaRPr lang="en-US" sz="1050" dirty="0"/>
+          </a:p>
+        </p:txBody>
+      </p:sp>
+      <p:sp>
+        <p:nvSpPr>
+          <p:cNvPr id="70" name="Separador 2026-1-1"/>
           <p:cNvSpPr/>
           <p:nvPr/>
         </p:nvSpPr>
         <p:spPr>
           <a:xfrm>
-            <a:off x="5916168" y="5650992"/>
-            <a:ext cx="1843888" cy="0"/>
+            <a:off x="5852160" y="5687568"/>
+            <a:ext cx="1444752" cy="0"/>
           </a:xfrm>
           <a:prstGeom prst="line">
             <a:avLst/>
@@ -4086,14 +4290,14 @@
       </p:sp>
       <p:sp>
         <p:nvSpPr>
-          <p:cNvPr id="73" name="Dato 2026-1-1"/>
-          <p:cNvSpPr txBox="1"/>
-          <p:nvPr/>
-        </p:nvSpPr>
-        <p:spPr>
-          <a:xfrm>
-            <a:off x="5916168" y="5687568"/>
-            <a:ext cx="1843888" cy="310896"/>
+          <p:cNvPr id="71" name="Dato 2026-1-1"/>
+          <p:cNvSpPr txBox="1"/>
+          <p:nvPr/>
+        </p:nvSpPr>
+        <p:spPr>
+          <a:xfrm>
+            <a:off x="5852160" y="5724144"/>
+            <a:ext cx="1444752" cy="310896"/>
           </a:xfrm>
           <a:prstGeom prst="rect">
             <a:avLst/>
@@ -4109,7 +4313,7 @@
               <a:buNone/>
             </a:pPr>
             <a:r>
-              <a:rPr lang="en-US" sz="1100" dirty="0">
+              <a:rPr lang="en-US" sz="1050" dirty="0">
                 <a:solidFill>
                   <a:schemeClr val="accent5"/>
                 </a:solidFill>
@@ -4120,31 +4324,31 @@
               <a:buNone/>
             </a:pPr>
             <a:r>
-              <a:rPr lang="en-US" sz="1100" b="1" dirty="0">
+              <a:rPr lang="en-US" sz="1050" b="1" dirty="0">
                 <a:solidFill>
                   <a:schemeClr val="tx1"/>
                 </a:solidFill>
               </a:rPr>
-              <a:t>GC + seguimiento</a:t>
-            </a:r>
-            <a:endParaRPr lang="en-US" sz="1100" dirty="0"/>
-          </a:p>
-        </p:txBody>
-      </p:sp>
-      <p:sp>
-        <p:nvSpPr>
-          <p:cNvPr id="74" name="Tarjeta 2026-2"/>
+              <a:t>NRP-17 + seguim.</a:t>
+            </a:r>
+            <a:endParaRPr lang="en-US" sz="1050" dirty="0"/>
+          </a:p>
+        </p:txBody>
+      </p:sp>
+      <p:sp>
+        <p:nvSpPr>
+          <p:cNvPr id="72" name="Tarjeta 2026-2"/>
           <p:cNvSpPr/>
           <p:nvPr/>
         </p:nvSpPr>
         <p:spPr>
           <a:xfrm>
-            <a:off x="8336128" y="4041648"/>
-            <a:ext cx="3306928" cy="2103120"/>
+            <a:off x="7754112" y="3858768"/>
+            <a:ext cx="3888943" cy="2377440"/>
           </a:xfrm>
           <a:prstGeom prst="roundRect">
             <a:avLst>
-              <a:gd name="adj" fmla="val 4348"/>
+              <a:gd name="adj" fmla="val 3846"/>
             </a:avLst>
           </a:prstGeom>
           <a:solidFill>
@@ -4160,18 +4364,18 @@
       </p:sp>
       <p:sp>
         <p:nvSpPr>
-          <p:cNvPr id="75" name="Fechas fondo 2026-2"/>
+          <p:cNvPr id="73" name="Fechas fondo 2026-2"/>
           <p:cNvSpPr/>
           <p:nvPr/>
         </p:nvSpPr>
         <p:spPr>
           <a:xfrm>
-            <a:off x="8473288" y="4178808"/>
-            <a:ext cx="1051560" cy="1828800"/>
+            <a:off x="7872984" y="3977640"/>
+            <a:ext cx="1005840" cy="2139696"/>
           </a:xfrm>
           <a:prstGeom prst="roundRect">
             <a:avLst>
-              <a:gd name="adj" fmla="val 8696"/>
+              <a:gd name="adj" fmla="val 9091"/>
             </a:avLst>
           </a:prstGeom>
           <a:solidFill>
@@ -4189,14 +4393,14 @@
       </p:sp>
       <p:sp>
         <p:nvSpPr>
-          <p:cNvPr id="76" name="Fecha etiqueta 2026-2-0"/>
-          <p:cNvSpPr txBox="1"/>
-          <p:nvPr/>
-        </p:nvSpPr>
-        <p:spPr>
-          <a:xfrm>
-            <a:off x="8473288" y="4270248"/>
-            <a:ext cx="1051560" cy="182880"/>
+          <p:cNvPr id="74" name="Fecha etiqueta 2026-2-0"/>
+          <p:cNvSpPr txBox="1"/>
+          <p:nvPr/>
+        </p:nvSpPr>
+        <p:spPr>
+          <a:xfrm>
+            <a:off x="7872984" y="4142232"/>
+            <a:ext cx="1005840" cy="182880"/>
           </a:xfrm>
           <a:prstGeom prst="rect">
             <a:avLst/>
@@ -4225,14 +4429,14 @@
       </p:sp>
       <p:sp>
         <p:nvSpPr>
-          <p:cNvPr id="77" name="Fecha día 2026-2-0"/>
-          <p:cNvSpPr txBox="1"/>
-          <p:nvPr/>
-        </p:nvSpPr>
-        <p:spPr>
-          <a:xfrm>
-            <a:off x="8473288" y="4453128"/>
-            <a:ext cx="1051560" cy="384048"/>
+          <p:cNvPr id="75" name="Fecha día 2026-2-0"/>
+          <p:cNvSpPr txBox="1"/>
+          <p:nvPr/>
+        </p:nvSpPr>
+        <p:spPr>
+          <a:xfrm>
+            <a:off x="7872984" y="4343400"/>
+            <a:ext cx="1005840" cy="411480"/>
           </a:xfrm>
           <a:prstGeom prst="rect">
             <a:avLst/>
@@ -4248,7 +4452,7 @@
               <a:buNone/>
             </a:pPr>
             <a:r>
-              <a:rPr lang="en-US" sz="2400" b="1" dirty="0">
+              <a:rPr lang="en-US" sz="2600" b="1" dirty="0">
                 <a:solidFill>
                   <a:schemeClr val="bg1"/>
                 </a:solidFill>
@@ -4258,20 +4462,20 @@
               </a:rPr>
               <a:t>09</a:t>
             </a:r>
-            <a:endParaRPr lang="en-US" sz="2400" dirty="0"/>
-          </a:p>
-        </p:txBody>
-      </p:sp>
-      <p:sp>
-        <p:nvSpPr>
-          <p:cNvPr id="78" name="Fecha mes 2026-2-0"/>
-          <p:cNvSpPr txBox="1"/>
-          <p:nvPr/>
-        </p:nvSpPr>
-        <p:spPr>
-          <a:xfrm>
-            <a:off x="8473288" y="4837176"/>
-            <a:ext cx="1051560" cy="201168"/>
+            <a:endParaRPr lang="en-US" sz="2600" dirty="0"/>
+          </a:p>
+        </p:txBody>
+      </p:sp>
+      <p:sp>
+        <p:nvSpPr>
+          <p:cNvPr id="76" name="Fecha mes 2026-2-0"/>
+          <p:cNvSpPr txBox="1"/>
+          <p:nvPr/>
+        </p:nvSpPr>
+        <p:spPr>
+          <a:xfrm>
+            <a:off x="7872984" y="4764024"/>
+            <a:ext cx="1005840" cy="201168"/>
           </a:xfrm>
           <a:prstGeom prst="rect">
             <a:avLst/>
@@ -4300,14 +4504,14 @@
       </p:sp>
       <p:sp>
         <p:nvSpPr>
-          <p:cNvPr id="79" name="Fecha etiqueta 2026-2-1"/>
-          <p:cNvSpPr txBox="1"/>
-          <p:nvPr/>
-        </p:nvSpPr>
-        <p:spPr>
-          <a:xfrm>
-            <a:off x="8473288" y="5184648"/>
-            <a:ext cx="1051560" cy="182880"/>
+          <p:cNvPr id="77" name="Fecha etiqueta 2026-2-1"/>
+          <p:cNvSpPr txBox="1"/>
+          <p:nvPr/>
+        </p:nvSpPr>
+        <p:spPr>
+          <a:xfrm>
+            <a:off x="7872984" y="5212080"/>
+            <a:ext cx="1005840" cy="182880"/>
           </a:xfrm>
           <a:prstGeom prst="rect">
             <a:avLst/>
@@ -4336,14 +4540,14 @@
       </p:sp>
       <p:sp>
         <p:nvSpPr>
-          <p:cNvPr id="80" name="Fecha día 2026-2-1"/>
-          <p:cNvSpPr txBox="1"/>
-          <p:nvPr/>
-        </p:nvSpPr>
-        <p:spPr>
-          <a:xfrm>
-            <a:off x="8473288" y="5367528"/>
-            <a:ext cx="1051560" cy="384048"/>
+          <p:cNvPr id="78" name="Fecha día 2026-2-1"/>
+          <p:cNvSpPr txBox="1"/>
+          <p:nvPr/>
+        </p:nvSpPr>
+        <p:spPr>
+          <a:xfrm>
+            <a:off x="7872984" y="5413248"/>
+            <a:ext cx="1005840" cy="411480"/>
           </a:xfrm>
           <a:prstGeom prst="rect">
             <a:avLst/>
@@ -4359,7 +4563,7 @@
               <a:buNone/>
             </a:pPr>
             <a:r>
-              <a:rPr lang="en-US" sz="2400" b="1" dirty="0">
+              <a:rPr lang="en-US" sz="2600" b="1" dirty="0">
                 <a:solidFill>
                   <a:schemeClr val="bg1"/>
                 </a:solidFill>
@@ -4369,20 +4573,20 @@
               </a:rPr>
               <a:t>23</a:t>
             </a:r>
-            <a:endParaRPr lang="en-US" sz="2400" dirty="0"/>
-          </a:p>
-        </p:txBody>
-      </p:sp>
-      <p:sp>
-        <p:nvSpPr>
-          <p:cNvPr id="81" name="Fecha mes 2026-2-1"/>
-          <p:cNvSpPr txBox="1"/>
-          <p:nvPr/>
-        </p:nvSpPr>
-        <p:spPr>
-          <a:xfrm>
-            <a:off x="8473288" y="5751576"/>
-            <a:ext cx="1051560" cy="201168"/>
+            <a:endParaRPr lang="en-US" sz="2600" dirty="0"/>
+          </a:p>
+        </p:txBody>
+      </p:sp>
+      <p:sp>
+        <p:nvSpPr>
+          <p:cNvPr id="79" name="Fecha mes 2026-2-1"/>
+          <p:cNvSpPr txBox="1"/>
+          <p:nvPr/>
+        </p:nvSpPr>
+        <p:spPr>
+          <a:xfrm>
+            <a:off x="7872984" y="5833872"/>
+            <a:ext cx="1005840" cy="201168"/>
           </a:xfrm>
           <a:prstGeom prst="rect">
             <a:avLst/>
@@ -4411,14 +4615,14 @@
       </p:sp>
       <p:sp>
         <p:nvSpPr>
-          <p:cNvPr id="82" name="Fechas separador 2026-2"/>
+          <p:cNvPr id="80" name="Fechas separador 2026-2"/>
           <p:cNvSpPr/>
           <p:nvPr/>
         </p:nvSpPr>
         <p:spPr>
           <a:xfrm>
-            <a:off x="8656168" y="5093208"/>
-            <a:ext cx="685800" cy="0"/>
+            <a:off x="8055864" y="5047488"/>
+            <a:ext cx="640080" cy="0"/>
           </a:xfrm>
           <a:prstGeom prst="line">
             <a:avLst/>
@@ -4436,14 +4640,14 @@
       </p:sp>
       <p:sp>
         <p:nvSpPr>
-          <p:cNvPr id="83" name="Tipo 2026-2"/>
-          <p:cNvSpPr txBox="1"/>
-          <p:nvPr/>
-        </p:nvSpPr>
-        <p:spPr>
-          <a:xfrm>
-            <a:off x="9680296" y="4178808"/>
-            <a:ext cx="1843888" cy="502920"/>
+          <p:cNvPr id="81" name="Tipo 2026-2"/>
+          <p:cNvSpPr txBox="1"/>
+          <p:nvPr/>
+        </p:nvSpPr>
+        <p:spPr>
+          <a:xfrm>
+            <a:off x="9034272" y="3968496"/>
+            <a:ext cx="2499055" cy="274320"/>
           </a:xfrm>
           <a:prstGeom prst="rect">
             <a:avLst/>
@@ -4459,27 +4663,27 @@
               <a:buNone/>
             </a:pPr>
             <a:r>
-              <a:rPr lang="en-US" sz="1400" b="1" dirty="0">
+              <a:rPr lang="en-US" sz="1300" b="1" dirty="0">
                 <a:solidFill>
                   <a:schemeClr val="tx1"/>
                 </a:solidFill>
               </a:rPr>
               <a:t>Resultados preliminares</a:t>
             </a:r>
-            <a:endParaRPr lang="en-US" sz="1400" dirty="0"/>
-          </a:p>
-        </p:txBody>
-      </p:sp>
-      <p:sp>
-        <p:nvSpPr>
-          <p:cNvPr id="84" name="Circular 2026-2"/>
-          <p:cNvSpPr txBox="1"/>
-          <p:nvPr/>
-        </p:nvSpPr>
-        <p:spPr>
-          <a:xfrm>
-            <a:off x="9680296" y="4754880"/>
-            <a:ext cx="1843888" cy="457200"/>
+            <a:endParaRPr lang="en-US" sz="1300" dirty="0"/>
+          </a:p>
+        </p:txBody>
+      </p:sp>
+      <p:sp>
+        <p:nvSpPr>
+          <p:cNvPr id="82" name="Circular 2026-2"/>
+          <p:cNvSpPr txBox="1"/>
+          <p:nvPr/>
+        </p:nvSpPr>
+        <p:spPr>
+          <a:xfrm>
+            <a:off x="9034272" y="4251960"/>
+            <a:ext cx="2499055" cy="201168"/>
           </a:xfrm>
           <a:prstGeom prst="rect">
             <a:avLst/>
@@ -4495,52 +4699,27 @@
               <a:buNone/>
             </a:pPr>
             <a:r>
-              <a:rPr lang="en-US" sz="1000" dirty="0">
-                <a:solidFill>
-                  <a:schemeClr val="accent5"/>
-                </a:solidFill>
-              </a:rPr>
-              <a:t>Circular No.  </a:t>
-            </a:r>
-            <a:pPr indent="0" marL="0">
-              <a:buNone/>
-            </a:pPr>
-            <a:r>
-              <a:rPr lang="en-US" sz="1050" b="1" dirty="0">
+              <a:rPr lang="en-US" sz="950" b="1" dirty="0">
                 <a:solidFill>
                   <a:schemeClr val="accent2"/>
                 </a:solidFill>
               </a:rPr>
-              <a:t>09/10/2026</a:t>
-            </a:r>
-            <a:endParaRPr lang="en-US" sz="1100" dirty="0"/>
-          </a:p>
-          <a:p>
-            <a:pPr indent="0" marL="0">
-              <a:buNone/>
-            </a:pPr>
-            <a:r>
-              <a:rPr lang="en-US" sz="1100" b="1" dirty="0">
-                <a:solidFill>
-                  <a:schemeClr val="accent2"/>
-                </a:solidFill>
-              </a:rPr>
-              <a:t>DS-SABAO-BCS-BC-22741</a:t>
-            </a:r>
-            <a:endParaRPr lang="en-US" sz="1100" dirty="0"/>
-          </a:p>
-        </p:txBody>
-      </p:sp>
-      <p:sp>
-        <p:nvSpPr>
-          <p:cNvPr id="85" name="Separador 2026-2-0"/>
+              <a:t>DS-SABAO-BCS-BC-22741  ·  09/10/2026</a:t>
+            </a:r>
+            <a:endParaRPr lang="en-US" sz="950" dirty="0"/>
+          </a:p>
+        </p:txBody>
+      </p:sp>
+      <p:sp>
+        <p:nvSpPr>
+          <p:cNvPr id="83" name="Separador lista 2026-2"/>
           <p:cNvSpPr/>
           <p:nvPr/>
         </p:nvSpPr>
         <p:spPr>
           <a:xfrm>
-            <a:off x="9680296" y="5285232"/>
-            <a:ext cx="1843888" cy="0"/>
+            <a:off x="9034272" y="4517136"/>
+            <a:ext cx="2499055" cy="0"/>
           </a:xfrm>
           <a:prstGeom prst="line">
             <a:avLst/>
@@ -4556,131 +4735,352 @@
       </p:sp>
       <p:sp>
         <p:nvSpPr>
-          <p:cNvPr id="86" name="Dato 2026-2-0"/>
-          <p:cNvSpPr txBox="1"/>
-          <p:nvPr/>
-        </p:nvSpPr>
-        <p:spPr>
-          <a:xfrm>
-            <a:off x="9680296" y="5321808"/>
-            <a:ext cx="1843888" cy="310896"/>
-          </a:xfrm>
-          <a:prstGeom prst="rect">
-            <a:avLst/>
-          </a:prstGeom>
-          <a:noFill/>
-          <a:ln/>
-        </p:spPr>
-        <p:txBody>
-          <a:bodyPr wrap="square" lIns="0" tIns="0" rIns="0" bIns="0" rtlCol="0" anchor="ctr"/>
-          <a:lstStyle/>
-          <a:p>
-            <a:pPr indent="0" marL="0">
-              <a:buNone/>
-            </a:pPr>
-            <a:r>
-              <a:rPr lang="en-US" sz="1100" dirty="0">
-                <a:solidFill>
-                  <a:schemeClr val="accent5"/>
-                </a:solidFill>
-              </a:rPr>
-              <a:t>Anexo A  </a:t>
-            </a:r>
-            <a:pPr indent="0" marL="0">
-              <a:buNone/>
-            </a:pPr>
-            <a:r>
-              <a:rPr lang="en-US" sz="1100" b="1" dirty="0">
+          <p:cNvPr id="84" name="Listado 2026-2"/>
+          <p:cNvSpPr txBox="1"/>
+          <p:nvPr/>
+        </p:nvSpPr>
+        <p:spPr>
+          <a:xfrm>
+            <a:off x="9034272" y="4572000"/>
+            <a:ext cx="2499055" cy="1572768"/>
+          </a:xfrm>
+          <a:prstGeom prst="rect">
+            <a:avLst/>
+          </a:prstGeom>
+          <a:noFill/>
+          <a:ln/>
+        </p:spPr>
+        <p:txBody>
+          <a:bodyPr wrap="square" lIns="0" tIns="0" rIns="0" bIns="0" rtlCol="0" anchor="t"/>
+          <a:lstStyle/>
+          <a:p>
+            <a:pPr indent="0" marL="0">
+              <a:lnSpc>
+                <a:spcPct val="92000"/>
+              </a:lnSpc>
+              <a:buNone/>
+            </a:pPr>
+            <a:r>
+              <a:rPr lang="en-US" sz="850" b="1" spc="100" kern="0" dirty="0">
+                <a:solidFill>
+                  <a:schemeClr val="accent2"/>
+                </a:solidFill>
+              </a:rPr>
+              <a:t>7 OBSERVACIONES NUEVAS · ANEXO A</a:t>
+            </a:r>
+            <a:endParaRPr lang="en-US" sz="950" dirty="0"/>
+          </a:p>
+          <a:p>
+            <a:pPr indent="0" marL="0">
+              <a:lnSpc>
+                <a:spcPct val="92000"/>
+              </a:lnSpc>
+              <a:buNone/>
+            </a:pPr>
+            <a:r>
+              <a:rPr lang="en-US" sz="950" b="1" dirty="0">
+                <a:solidFill>
+                  <a:schemeClr val="accent2"/>
+                </a:solidFill>
+              </a:rPr>
+              <a:t>1  </a:t>
+            </a:r>
+            <a:pPr indent="0" marL="0">
+              <a:lnSpc>
+                <a:spcPct val="92000"/>
+              </a:lnSpc>
+              <a:buNone/>
+            </a:pPr>
+            <a:r>
+              <a:rPr lang="en-US" sz="950" dirty="0">
                 <a:solidFill>
                   <a:schemeClr val="tx1"/>
                 </a:solidFill>
               </a:rPr>
-              <a:t>7 nuevas</a:t>
-            </a:r>
-            <a:endParaRPr lang="en-US" sz="1100" dirty="0"/>
-          </a:p>
-        </p:txBody>
-      </p:sp>
-      <p:sp>
-        <p:nvSpPr>
-          <p:cNvPr id="87" name="Separador 2026-2-1"/>
+              <a:t>Inducción sobre partidas de EEFF</a:t>
+            </a:r>
+            <a:endParaRPr lang="en-US" sz="950" dirty="0"/>
+          </a:p>
+          <a:p>
+            <a:pPr indent="0" marL="0">
+              <a:lnSpc>
+                <a:spcPct val="92000"/>
+              </a:lnSpc>
+              <a:buNone/>
+            </a:pPr>
+            <a:r>
+              <a:rPr lang="en-US" sz="950" b="1" dirty="0">
+                <a:solidFill>
+                  <a:schemeClr val="accent2"/>
+                </a:solidFill>
+              </a:rPr>
+              <a:t>2  </a:t>
+            </a:r>
+            <a:pPr indent="0" marL="0">
+              <a:lnSpc>
+                <a:spcPct val="92000"/>
+              </a:lnSpc>
+              <a:buNone/>
+            </a:pPr>
+            <a:r>
+              <a:rPr lang="en-US" sz="950" dirty="0">
+                <a:solidFill>
+                  <a:schemeClr val="tx1"/>
+                </a:solidFill>
+              </a:rPr>
+              <a:t>Certificación del Código de Conducta</a:t>
+            </a:r>
+            <a:endParaRPr lang="en-US" sz="950" dirty="0"/>
+          </a:p>
+          <a:p>
+            <a:pPr indent="0" marL="0">
+              <a:lnSpc>
+                <a:spcPct val="92000"/>
+              </a:lnSpc>
+              <a:buNone/>
+            </a:pPr>
+            <a:r>
+              <a:rPr lang="en-US" sz="950" b="1" dirty="0">
+                <a:solidFill>
+                  <a:schemeClr val="accent2"/>
+                </a:solidFill>
+              </a:rPr>
+              <a:t>3  </a:t>
+            </a:r>
+            <a:pPr indent="0" marL="0">
+              <a:lnSpc>
+                <a:spcPct val="92000"/>
+              </a:lnSpc>
+              <a:buNone/>
+            </a:pPr>
+            <a:r>
+              <a:rPr lang="en-US" sz="950" dirty="0">
+                <a:solidFill>
+                  <a:schemeClr val="tx1"/>
+                </a:solidFill>
+              </a:rPr>
+              <a:t>Políticas sin aprobar por el Consejo</a:t>
+            </a:r>
+            <a:endParaRPr lang="en-US" sz="950" dirty="0"/>
+          </a:p>
+          <a:p>
+            <a:pPr indent="0" marL="0">
+              <a:lnSpc>
+                <a:spcPct val="92000"/>
+              </a:lnSpc>
+              <a:buNone/>
+            </a:pPr>
+            <a:r>
+              <a:rPr lang="en-US" sz="950" b="1" dirty="0">
+                <a:solidFill>
+                  <a:schemeClr val="accent2"/>
+                </a:solidFill>
+              </a:rPr>
+              <a:t>4  </a:t>
+            </a:r>
+            <a:pPr indent="0" marL="0">
+              <a:lnSpc>
+                <a:spcPct val="92000"/>
+              </a:lnSpc>
+              <a:buNone/>
+            </a:pPr>
+            <a:r>
+              <a:rPr lang="en-US" sz="950" dirty="0">
+                <a:solidFill>
+                  <a:schemeClr val="tx1"/>
+                </a:solidFill>
+              </a:rPr>
+              <a:t>Sitio web de comités desactualizado</a:t>
+            </a:r>
+            <a:endParaRPr lang="en-US" sz="950" dirty="0"/>
+          </a:p>
+          <a:p>
+            <a:pPr indent="0" marL="0">
+              <a:lnSpc>
+                <a:spcPct val="92000"/>
+              </a:lnSpc>
+              <a:buNone/>
+            </a:pPr>
+            <a:r>
+              <a:rPr lang="en-US" sz="950" b="1" dirty="0">
+                <a:solidFill>
+                  <a:schemeClr val="accent2"/>
+                </a:solidFill>
+              </a:rPr>
+              <a:t>5  </a:t>
+            </a:r>
+            <a:pPr indent="0" marL="0">
+              <a:lnSpc>
+                <a:spcPct val="92000"/>
+              </a:lnSpc>
+              <a:buNone/>
+            </a:pPr>
+            <a:r>
+              <a:rPr lang="en-US" sz="950" dirty="0">
+                <a:solidFill>
+                  <a:schemeClr val="tx1"/>
+                </a:solidFill>
+              </a:rPr>
+              <a:t>Estatutos vs. Código de GC</a:t>
+            </a:r>
+            <a:endParaRPr lang="en-US" sz="950" dirty="0"/>
+          </a:p>
+          <a:p>
+            <a:pPr indent="0" marL="0">
+              <a:lnSpc>
+                <a:spcPct val="92000"/>
+              </a:lnSpc>
+              <a:buNone/>
+            </a:pPr>
+            <a:r>
+              <a:rPr lang="en-US" sz="950" b="1" dirty="0">
+                <a:solidFill>
+                  <a:schemeClr val="accent2"/>
+                </a:solidFill>
+              </a:rPr>
+              <a:t>6  </a:t>
+            </a:r>
+            <a:pPr indent="0" marL="0">
+              <a:lnSpc>
+                <a:spcPct val="92000"/>
+              </a:lnSpc>
+              <a:buNone/>
+            </a:pPr>
+            <a:r>
+              <a:rPr lang="en-US" sz="950" dirty="0">
+                <a:solidFill>
+                  <a:schemeClr val="tx1"/>
+                </a:solidFill>
+              </a:rPr>
+              <a:t>Reglamento del Fondo de Educación</a:t>
+            </a:r>
+            <a:endParaRPr lang="en-US" sz="950" dirty="0"/>
+          </a:p>
+          <a:p>
+            <a:pPr indent="0" marL="0">
+              <a:lnSpc>
+                <a:spcPct val="92000"/>
+              </a:lnSpc>
+              <a:buNone/>
+            </a:pPr>
+            <a:r>
+              <a:rPr lang="en-US" sz="950" b="1" dirty="0">
+                <a:solidFill>
+                  <a:schemeClr val="accent2"/>
+                </a:solidFill>
+              </a:rPr>
+              <a:t>7  </a:t>
+            </a:r>
+            <a:pPr indent="0" marL="0">
+              <a:lnSpc>
+                <a:spcPct val="92000"/>
+              </a:lnSpc>
+              <a:buNone/>
+            </a:pPr>
+            <a:r>
+              <a:rPr lang="en-US" sz="950" dirty="0">
+                <a:solidFill>
+                  <a:schemeClr val="tx1"/>
+                </a:solidFill>
+              </a:rPr>
+              <a:t>Transparencia del Fondo de Educación</a:t>
+            </a:r>
+            <a:endParaRPr lang="en-US" sz="950" dirty="0"/>
+          </a:p>
+          <a:p>
+            <a:pPr indent="0" marL="0">
+              <a:lnSpc>
+                <a:spcPct val="92000"/>
+              </a:lnSpc>
+              <a:spcBef>
+                <a:spcPts val="300"/>
+              </a:spcBef>
+              <a:buNone/>
+            </a:pPr>
+            <a:r>
+              <a:rPr lang="en-US" sz="850" b="1" spc="100" kern="0" dirty="0">
+                <a:solidFill>
+                  <a:schemeClr val="accent3"/>
+                </a:solidFill>
+              </a:rPr>
+              <a:t>2 EN SEGUIMIENTO DE 2025 · ANEXO B</a:t>
+            </a:r>
+            <a:endParaRPr lang="en-US" sz="950" dirty="0"/>
+          </a:p>
+          <a:p>
+            <a:pPr indent="0" marL="0">
+              <a:lnSpc>
+                <a:spcPct val="92000"/>
+              </a:lnSpc>
+              <a:buNone/>
+            </a:pPr>
+            <a:r>
+              <a:rPr lang="en-US" sz="950" b="1" dirty="0">
+                <a:solidFill>
+                  <a:schemeClr val="accent3"/>
+                </a:solidFill>
+              </a:rPr>
+              <a:t>Obs. 3  </a:t>
+            </a:r>
+            <a:pPr indent="0" marL="0">
+              <a:lnSpc>
+                <a:spcPct val="92000"/>
+              </a:lnSpc>
+              <a:buNone/>
+            </a:pPr>
+            <a:r>
+              <a:rPr lang="en-US" sz="950" dirty="0">
+                <a:solidFill>
+                  <a:schemeClr val="tx1"/>
+                </a:solidFill>
+              </a:rPr>
+              <a:t>Comités sin ejecutivos · No superada</a:t>
+            </a:r>
+            <a:endParaRPr lang="en-US" sz="950" dirty="0"/>
+          </a:p>
+          <a:p>
+            <a:pPr indent="0" marL="0">
+              <a:lnSpc>
+                <a:spcPct val="92000"/>
+              </a:lnSpc>
+              <a:buNone/>
+            </a:pPr>
+            <a:r>
+              <a:rPr lang="en-US" sz="950" b="1" dirty="0">
+                <a:solidFill>
+                  <a:schemeClr val="accent3"/>
+                </a:solidFill>
+              </a:rPr>
+              <a:t>Obs. 5  </a:t>
+            </a:r>
+            <a:pPr indent="0" marL="0">
+              <a:lnSpc>
+                <a:spcPct val="92000"/>
+              </a:lnSpc>
+              <a:buNone/>
+            </a:pPr>
+            <a:r>
+              <a:rPr lang="en-US" sz="950" dirty="0">
+                <a:solidFill>
+                  <a:schemeClr val="tx1"/>
+                </a:solidFill>
+              </a:rPr>
+              <a:t>Normativa interna · Parcialmente superada</a:t>
+            </a:r>
+            <a:endParaRPr lang="en-US" sz="950" dirty="0"/>
+          </a:p>
+        </p:txBody>
+      </p:sp>
+      <p:sp>
+        <p:nvSpPr>
+          <p:cNvPr id="85" name="Flecha 2026"/>
           <p:cNvSpPr/>
           <p:nvPr/>
         </p:nvSpPr>
         <p:spPr>
           <a:xfrm>
-            <a:off x="9680296" y="5650992"/>
-            <a:ext cx="1843888" cy="0"/>
-          </a:xfrm>
-          <a:prstGeom prst="line">
-            <a:avLst/>
-          </a:prstGeom>
-          <a:noFill/>
-          <a:ln w="9525">
-            <a:solidFill>
-              <a:srgbClr val="D9E0EA"/>
-            </a:solidFill>
-            <a:prstDash val="solid"/>
-          </a:ln>
-        </p:spPr>
-      </p:sp>
-      <p:sp>
-        <p:nvSpPr>
-          <p:cNvPr id="88" name="Dato 2026-2-1"/>
-          <p:cNvSpPr txBox="1"/>
-          <p:nvPr/>
-        </p:nvSpPr>
-        <p:spPr>
-          <a:xfrm>
-            <a:off x="9680296" y="5687568"/>
-            <a:ext cx="1843888" cy="310896"/>
-          </a:xfrm>
-          <a:prstGeom prst="rect">
-            <a:avLst/>
-          </a:prstGeom>
-          <a:noFill/>
-          <a:ln/>
-        </p:spPr>
-        <p:txBody>
-          <a:bodyPr wrap="square" lIns="0" tIns="0" rIns="0" bIns="0" rtlCol="0" anchor="ctr"/>
-          <a:lstStyle/>
-          <a:p>
-            <a:pPr indent="0" marL="0">
-              <a:buNone/>
-            </a:pPr>
-            <a:r>
-              <a:rPr lang="en-US" sz="1100" dirty="0">
-                <a:solidFill>
-                  <a:schemeClr val="accent5"/>
-                </a:solidFill>
-              </a:rPr>
-              <a:t>Anexo B  </a:t>
-            </a:r>
-            <a:pPr indent="0" marL="0">
-              <a:buNone/>
-            </a:pPr>
-            <a:r>
-              <a:rPr lang="en-US" sz="1100" b="1" dirty="0">
-                <a:solidFill>
-                  <a:schemeClr val="tx1"/>
-                </a:solidFill>
-              </a:rPr>
-              <a:t>obs. 3 y 5 de 2025</a:t>
-            </a:r>
-            <a:endParaRPr lang="en-US" sz="1100" dirty="0"/>
-          </a:p>
-        </p:txBody>
-      </p:sp>
-      <p:sp>
-        <p:nvSpPr>
-          <p:cNvPr id="89" name="Flecha 2026"/>
-          <p:cNvSpPr/>
-          <p:nvPr/>
-        </p:nvSpPr>
-        <p:spPr>
-          <a:xfrm>
-            <a:off x="7970368" y="4956048"/>
-            <a:ext cx="274320" cy="274320"/>
+            <a:off x="7452360" y="4919472"/>
+            <a:ext cx="256032" cy="256032"/>
           </a:xfrm>
           <a:prstGeom prst="rightArrow">
             <a:avLst/>

</xml_diff>

<commit_message>
Slide 1: restore start/end date cards without observation lists
Co-Authored-By: Claude Opus 5.5 <noreply@anthropic.com>
Claude-Session: https://claude.ai/code/session_01F1WXR13Nv8neEtLhaK3ELa
</commit_message>
<xml_diff>
--- a/supervision-gobierno-corporativo/Supervision_GC_SSF_COMEDICA_2025-2026.pptx
+++ b/supervision-gobierno-corporativo/Supervision_GC_SSF_COMEDICA_2025-2026.pptx
@@ -109,17 +109,17 @@
   <p:extLst>
     <p:ext uri="{521415D9-36F7-43E2-AB2F-B90AF26B5E84}">
       <p14:sectionLst xmlns:p14="http://schemas.microsoft.com/office/powerpoint/2010/main">
-        <p14:section name="1 · Resumen de circulares SSF" id="{78b0aa3a-9ab5-fb95-9248-4383e14b6bcd}">
+        <p14:section name="1 · Resumen de circulares SSF" id="{3d5ab828-53ea-a767-01b0-db9abe728243}">
           <p14:sldIdLst>
             <p14:sldId id="256"/>
           </p14:sldIdLst>
         </p14:section>
-        <p14:section name="2 · Observaciones 2025" id="{4562aab9-27b5-7725-6e3f-232541bde45e}">
+        <p14:section name="2 · Observaciones 2025" id="{df8d5321-8e28-4c9f-283b-5907fad14477}">
           <p14:sldIdLst>
             <p14:sldId id="257"/>
           </p14:sldIdLst>
         </p14:section>
-        <p14:section name="3 · Observaciones 2026" id="{3570cbb6-4c7d-6896-bc4c-b664d66295a0}">
+        <p14:section name="3 · Observaciones 2026" id="{9a001d32-34a3-54fa-c898-7c4459d281fc}">
           <p14:sldIdLst>
             <p14:sldId id="258"/>
           </p14:sldIdLst>
@@ -2342,8 +2342,8 @@
         </p:nvSpPr>
         <p:spPr>
           <a:xfrm>
-            <a:off x="4572000" y="320040"/>
-            <a:ext cx="1188720" cy="457200"/>
+            <a:off x="4572000" y="457200"/>
+            <a:ext cx="1188720" cy="502920"/>
           </a:xfrm>
           <a:prstGeom prst="rect">
             <a:avLst/>
@@ -2359,7 +2359,7 @@
               <a:buNone/>
             </a:pPr>
             <a:r>
-              <a:rPr lang="en-US" sz="2800" b="1" dirty="0">
+              <a:rPr lang="en-US" sz="3000" b="1" dirty="0">
                 <a:solidFill>
                   <a:schemeClr val="accent1"/>
                 </a:solidFill>
@@ -2369,7 +2369,7 @@
               </a:rPr>
               <a:t>2025</a:t>
             </a:r>
-            <a:endParaRPr lang="en-US" sz="2800" dirty="0"/>
+            <a:endParaRPr lang="en-US" sz="3000" dirty="0"/>
           </a:p>
         </p:txBody>
       </p:sp>
@@ -2381,8 +2381,8 @@
         </p:nvSpPr>
         <p:spPr>
           <a:xfrm>
-            <a:off x="5760720" y="320040"/>
-            <a:ext cx="3657600" cy="457200"/>
+            <a:off x="5806440" y="457200"/>
+            <a:ext cx="3657600" cy="502920"/>
           </a:xfrm>
           <a:prstGeom prst="rect">
             <a:avLst/>
@@ -2417,12 +2417,12 @@
         </p:nvSpPr>
         <p:spPr>
           <a:xfrm>
-            <a:off x="4572000" y="868680"/>
-            <a:ext cx="2834640" cy="2377440"/>
+            <a:off x="4572000" y="1097280"/>
+            <a:ext cx="3306928" cy="2103120"/>
           </a:xfrm>
           <a:prstGeom prst="roundRect">
             <a:avLst>
-              <a:gd name="adj" fmla="val 3846"/>
+              <a:gd name="adj" fmla="val 4348"/>
             </a:avLst>
           </a:prstGeom>
           <a:solidFill>
@@ -2444,12 +2444,12 @@
         </p:nvSpPr>
         <p:spPr>
           <a:xfrm>
-            <a:off x="4690872" y="987552"/>
-            <a:ext cx="1005840" cy="2139696"/>
+            <a:off x="4709160" y="1234440"/>
+            <a:ext cx="1051560" cy="1828800"/>
           </a:xfrm>
           <a:prstGeom prst="roundRect">
             <a:avLst>
-              <a:gd name="adj" fmla="val 9091"/>
+              <a:gd name="adj" fmla="val 8696"/>
             </a:avLst>
           </a:prstGeom>
           <a:solidFill>
@@ -2473,8 +2473,8 @@
         </p:nvSpPr>
         <p:spPr>
           <a:xfrm>
-            <a:off x="4690872" y="1152144"/>
-            <a:ext cx="1005840" cy="182880"/>
+            <a:off x="4709160" y="1325880"/>
+            <a:ext cx="1051560" cy="182880"/>
           </a:xfrm>
           <a:prstGeom prst="rect">
             <a:avLst/>
@@ -2509,8 +2509,8 @@
         </p:nvSpPr>
         <p:spPr>
           <a:xfrm>
-            <a:off x="4690872" y="1353312"/>
-            <a:ext cx="1005840" cy="411480"/>
+            <a:off x="4709160" y="1508760"/>
+            <a:ext cx="1051560" cy="384048"/>
           </a:xfrm>
           <a:prstGeom prst="rect">
             <a:avLst/>
@@ -2526,7 +2526,7 @@
               <a:buNone/>
             </a:pPr>
             <a:r>
-              <a:rPr lang="en-US" sz="2600" b="1" dirty="0">
+              <a:rPr lang="en-US" sz="2400" b="1" dirty="0">
                 <a:solidFill>
                   <a:schemeClr val="bg1"/>
                 </a:solidFill>
@@ -2536,7 +2536,7 @@
               </a:rPr>
               <a:t>19</a:t>
             </a:r>
-            <a:endParaRPr lang="en-US" sz="2600" dirty="0"/>
+            <a:endParaRPr lang="en-US" sz="2400" dirty="0"/>
           </a:p>
         </p:txBody>
       </p:sp>
@@ -2548,8 +2548,8 @@
         </p:nvSpPr>
         <p:spPr>
           <a:xfrm>
-            <a:off x="4690872" y="1773936"/>
-            <a:ext cx="1005840" cy="201168"/>
+            <a:off x="4709160" y="1892808"/>
+            <a:ext cx="1051560" cy="201168"/>
           </a:xfrm>
           <a:prstGeom prst="rect">
             <a:avLst/>
@@ -2584,8 +2584,8 @@
         </p:nvSpPr>
         <p:spPr>
           <a:xfrm>
-            <a:off x="4690872" y="2221992"/>
-            <a:ext cx="1005840" cy="182880"/>
+            <a:off x="4709160" y="2240280"/>
+            <a:ext cx="1051560" cy="182880"/>
           </a:xfrm>
           <a:prstGeom prst="rect">
             <a:avLst/>
@@ -2620,8 +2620,8 @@
         </p:nvSpPr>
         <p:spPr>
           <a:xfrm>
-            <a:off x="4690872" y="2423160"/>
-            <a:ext cx="1005840" cy="411480"/>
+            <a:off x="4709160" y="2423160"/>
+            <a:ext cx="1051560" cy="384048"/>
           </a:xfrm>
           <a:prstGeom prst="rect">
             <a:avLst/>
@@ -2637,7 +2637,7 @@
               <a:buNone/>
             </a:pPr>
             <a:r>
-              <a:rPr lang="en-US" sz="2600" b="1" dirty="0">
+              <a:rPr lang="en-US" sz="2400" b="1" dirty="0">
                 <a:solidFill>
                   <a:schemeClr val="bg1"/>
                 </a:solidFill>
@@ -2647,7 +2647,7 @@
               </a:rPr>
               <a:t>05</a:t>
             </a:r>
-            <a:endParaRPr lang="en-US" sz="2600" dirty="0"/>
+            <a:endParaRPr lang="en-US" sz="2400" dirty="0"/>
           </a:p>
         </p:txBody>
       </p:sp>
@@ -2659,8 +2659,8 @@
         </p:nvSpPr>
         <p:spPr>
           <a:xfrm>
-            <a:off x="4690872" y="2843784"/>
-            <a:ext cx="1005840" cy="201168"/>
+            <a:off x="4709160" y="2807208"/>
+            <a:ext cx="1051560" cy="201168"/>
           </a:xfrm>
           <a:prstGeom prst="rect">
             <a:avLst/>
@@ -2695,8 +2695,8 @@
         </p:nvSpPr>
         <p:spPr>
           <a:xfrm>
-            <a:off x="4873752" y="2057400"/>
-            <a:ext cx="640080" cy="0"/>
+            <a:off x="4892040" y="2148840"/>
+            <a:ext cx="685800" cy="0"/>
           </a:xfrm>
           <a:prstGeom prst="line">
             <a:avLst/>
@@ -2720,8 +2720,8 @@
         </p:nvSpPr>
         <p:spPr>
           <a:xfrm>
-            <a:off x="5852160" y="1005840"/>
-            <a:ext cx="1444752" cy="566928"/>
+            <a:off x="5916168" y="1234440"/>
+            <a:ext cx="1843888" cy="502920"/>
           </a:xfrm>
           <a:prstGeom prst="rect">
             <a:avLst/>
@@ -2737,14 +2737,14 @@
               <a:buNone/>
             </a:pPr>
             <a:r>
-              <a:rPr lang="en-US" sz="1300" b="1" dirty="0">
+              <a:rPr lang="en-US" sz="1400" b="1" dirty="0">
                 <a:solidFill>
                   <a:schemeClr val="tx1"/>
                 </a:solidFill>
               </a:rPr>
               <a:t>Nombramiento de visita ampliada</a:t>
             </a:r>
-            <a:endParaRPr lang="en-US" sz="1300" dirty="0"/>
+            <a:endParaRPr lang="en-US" sz="1400" dirty="0"/>
           </a:p>
         </p:txBody>
       </p:sp>
@@ -2756,8 +2756,8 @@
         </p:nvSpPr>
         <p:spPr>
           <a:xfrm>
-            <a:off x="5852160" y="1673352"/>
-            <a:ext cx="1444752" cy="457200"/>
+            <a:off x="5916168" y="1810512"/>
+            <a:ext cx="1843888" cy="457200"/>
           </a:xfrm>
           <a:prstGeom prst="rect">
             <a:avLst/>
@@ -2773,7 +2773,7 @@
               <a:buNone/>
             </a:pPr>
             <a:r>
-              <a:rPr lang="en-US" sz="950" dirty="0">
+              <a:rPr lang="en-US" sz="1000" dirty="0">
                 <a:solidFill>
                   <a:schemeClr val="accent5"/>
                 </a:solidFill>
@@ -2784,28 +2784,28 @@
               <a:buNone/>
             </a:pPr>
             <a:r>
-              <a:rPr lang="en-US" sz="1000" b="1" dirty="0">
+              <a:rPr lang="en-US" sz="1050" b="1" dirty="0">
                 <a:solidFill>
                   <a:schemeClr val="accent1"/>
                 </a:solidFill>
               </a:rPr>
               <a:t>09/04/2025</a:t>
             </a:r>
-            <a:endParaRPr lang="en-US" sz="1000" dirty="0"/>
-          </a:p>
-          <a:p>
-            <a:pPr indent="0" marL="0">
-              <a:buNone/>
-            </a:pPr>
-            <a:r>
-              <a:rPr lang="en-US" sz="1000" b="1" dirty="0">
+            <a:endParaRPr lang="en-US" sz="1100" dirty="0"/>
+          </a:p>
+          <a:p>
+            <a:pPr indent="0" marL="0">
+              <a:buNone/>
+            </a:pPr>
+            <a:r>
+              <a:rPr lang="en-US" sz="1100" b="1" dirty="0">
                 <a:solidFill>
                   <a:schemeClr val="accent1"/>
                 </a:solidFill>
               </a:rPr>
               <a:t>DS-SABAO-BCS-BC-9337</a:t>
             </a:r>
-            <a:endParaRPr lang="en-US" sz="1000" dirty="0"/>
+            <a:endParaRPr lang="en-US" sz="1100" dirty="0"/>
           </a:p>
         </p:txBody>
       </p:sp>
@@ -2817,8 +2817,8 @@
         </p:nvSpPr>
         <p:spPr>
           <a:xfrm>
-            <a:off x="5852160" y="2313432"/>
-            <a:ext cx="1444752" cy="0"/>
+            <a:off x="5916168" y="2340864"/>
+            <a:ext cx="1843888" cy="0"/>
           </a:xfrm>
           <a:prstGeom prst="line">
             <a:avLst/>
@@ -2840,8 +2840,8 @@
         </p:nvSpPr>
         <p:spPr>
           <a:xfrm>
-            <a:off x="5852160" y="2350008"/>
-            <a:ext cx="1444752" cy="310896"/>
+            <a:off x="5916168" y="2377440"/>
+            <a:ext cx="1843888" cy="310896"/>
           </a:xfrm>
           <a:prstGeom prst="rect">
             <a:avLst/>
@@ -2857,7 +2857,7 @@
               <a:buNone/>
             </a:pPr>
             <a:r>
-              <a:rPr lang="en-US" sz="1050" dirty="0">
+              <a:rPr lang="en-US" sz="1100" dirty="0">
                 <a:solidFill>
                   <a:schemeClr val="accent5"/>
                 </a:solidFill>
@@ -2868,14 +2868,14 @@
               <a:buNone/>
             </a:pPr>
             <a:r>
-              <a:rPr lang="en-US" sz="1050" b="1" dirty="0">
+              <a:rPr lang="en-US" sz="1100" b="1" dirty="0">
                 <a:solidFill>
                   <a:schemeClr val="tx1"/>
                 </a:solidFill>
               </a:rPr>
               <a:t>30/04/2025</a:t>
             </a:r>
-            <a:endParaRPr lang="en-US" sz="1050" dirty="0"/>
+            <a:endParaRPr lang="en-US" sz="1100" dirty="0"/>
           </a:p>
         </p:txBody>
       </p:sp>
@@ -2887,8 +2887,8 @@
         </p:nvSpPr>
         <p:spPr>
           <a:xfrm>
-            <a:off x="5852160" y="2697480"/>
-            <a:ext cx="1444752" cy="0"/>
+            <a:off x="5916168" y="2706624"/>
+            <a:ext cx="1843888" cy="0"/>
           </a:xfrm>
           <a:prstGeom prst="line">
             <a:avLst/>
@@ -2910,8 +2910,8 @@
         </p:nvSpPr>
         <p:spPr>
           <a:xfrm>
-            <a:off x="5852160" y="2734056"/>
-            <a:ext cx="1444752" cy="310896"/>
+            <a:off x="5916168" y="2743200"/>
+            <a:ext cx="1843888" cy="310896"/>
           </a:xfrm>
           <a:prstGeom prst="rect">
             <a:avLst/>
@@ -2927,7 +2927,7 @@
               <a:buNone/>
             </a:pPr>
             <a:r>
-              <a:rPr lang="en-US" sz="1050" dirty="0">
+              <a:rPr lang="en-US" sz="1100" dirty="0">
                 <a:solidFill>
                   <a:schemeClr val="accent5"/>
                 </a:solidFill>
@@ -2938,14 +2938,14 @@
               <a:buNone/>
             </a:pPr>
             <a:r>
-              <a:rPr lang="en-US" sz="1050" b="1" dirty="0">
+              <a:rPr lang="en-US" sz="1100" b="1" dirty="0">
                 <a:solidFill>
                   <a:schemeClr val="tx1"/>
                 </a:solidFill>
               </a:rPr>
-              <a:t>NRP-17</a:t>
-            </a:r>
-            <a:endParaRPr lang="en-US" sz="1050" dirty="0"/>
+              <a:t>Gobierno Corporativo</a:t>
+            </a:r>
+            <a:endParaRPr lang="en-US" sz="1100" dirty="0"/>
           </a:p>
         </p:txBody>
       </p:sp>
@@ -2957,12 +2957,12 @@
         </p:nvSpPr>
         <p:spPr>
           <a:xfrm>
-            <a:off x="7754112" y="868680"/>
-            <a:ext cx="3888943" cy="2377440"/>
+            <a:off x="8336128" y="1097280"/>
+            <a:ext cx="3306928" cy="2103120"/>
           </a:xfrm>
           <a:prstGeom prst="roundRect">
             <a:avLst>
-              <a:gd name="adj" fmla="val 3846"/>
+              <a:gd name="adj" fmla="val 4348"/>
             </a:avLst>
           </a:prstGeom>
           <a:solidFill>
@@ -2984,12 +2984,12 @@
         </p:nvSpPr>
         <p:spPr>
           <a:xfrm>
-            <a:off x="7872984" y="987552"/>
-            <a:ext cx="1005840" cy="2139696"/>
+            <a:off x="8473288" y="1234440"/>
+            <a:ext cx="1051560" cy="1828800"/>
           </a:xfrm>
           <a:prstGeom prst="roundRect">
             <a:avLst>
-              <a:gd name="adj" fmla="val 9091"/>
+              <a:gd name="adj" fmla="val 8696"/>
             </a:avLst>
           </a:prstGeom>
           <a:solidFill>
@@ -3013,8 +3013,8 @@
         </p:nvSpPr>
         <p:spPr>
           <a:xfrm>
-            <a:off x="7872984" y="1152144"/>
-            <a:ext cx="1005840" cy="182880"/>
+            <a:off x="8473288" y="1325880"/>
+            <a:ext cx="1051560" cy="182880"/>
           </a:xfrm>
           <a:prstGeom prst="rect">
             <a:avLst/>
@@ -3049,8 +3049,8 @@
         </p:nvSpPr>
         <p:spPr>
           <a:xfrm>
-            <a:off x="7872984" y="1353312"/>
-            <a:ext cx="1005840" cy="411480"/>
+            <a:off x="8473288" y="1508760"/>
+            <a:ext cx="1051560" cy="384048"/>
           </a:xfrm>
           <a:prstGeom prst="rect">
             <a:avLst/>
@@ -3066,7 +3066,7 @@
               <a:buNone/>
             </a:pPr>
             <a:r>
-              <a:rPr lang="en-US" sz="2600" b="1" dirty="0">
+              <a:rPr lang="en-US" sz="2400" b="1" dirty="0">
                 <a:solidFill>
                   <a:schemeClr val="bg1"/>
                 </a:solidFill>
@@ -3076,7 +3076,7 @@
               </a:rPr>
               <a:t>05</a:t>
             </a:r>
-            <a:endParaRPr lang="en-US" sz="2600" dirty="0"/>
+            <a:endParaRPr lang="en-US" sz="2400" dirty="0"/>
           </a:p>
         </p:txBody>
       </p:sp>
@@ -3088,8 +3088,8 @@
         </p:nvSpPr>
         <p:spPr>
           <a:xfrm>
-            <a:off x="7872984" y="1773936"/>
-            <a:ext cx="1005840" cy="201168"/>
+            <a:off x="8473288" y="1892808"/>
+            <a:ext cx="1051560" cy="201168"/>
           </a:xfrm>
           <a:prstGeom prst="rect">
             <a:avLst/>
@@ -3124,8 +3124,8 @@
         </p:nvSpPr>
         <p:spPr>
           <a:xfrm>
-            <a:off x="7872984" y="2221992"/>
-            <a:ext cx="1005840" cy="182880"/>
+            <a:off x="8473288" y="2240280"/>
+            <a:ext cx="1051560" cy="182880"/>
           </a:xfrm>
           <a:prstGeom prst="rect">
             <a:avLst/>
@@ -3160,8 +3160,8 @@
         </p:nvSpPr>
         <p:spPr>
           <a:xfrm>
-            <a:off x="7872984" y="2423160"/>
-            <a:ext cx="1005840" cy="411480"/>
+            <a:off x="8473288" y="2423160"/>
+            <a:ext cx="1051560" cy="384048"/>
           </a:xfrm>
           <a:prstGeom prst="rect">
             <a:avLst/>
@@ -3177,7 +3177,7 @@
               <a:buNone/>
             </a:pPr>
             <a:r>
-              <a:rPr lang="en-US" sz="2600" b="1" dirty="0">
+              <a:rPr lang="en-US" sz="2400" b="1" dirty="0">
                 <a:solidFill>
                   <a:schemeClr val="bg1"/>
                 </a:solidFill>
@@ -3187,7 +3187,7 @@
               </a:rPr>
               <a:t>18</a:t>
             </a:r>
-            <a:endParaRPr lang="en-US" sz="2600" dirty="0"/>
+            <a:endParaRPr lang="en-US" sz="2400" dirty="0"/>
           </a:p>
         </p:txBody>
       </p:sp>
@@ -3199,8 +3199,8 @@
         </p:nvSpPr>
         <p:spPr>
           <a:xfrm>
-            <a:off x="7872984" y="2843784"/>
-            <a:ext cx="1005840" cy="201168"/>
+            <a:off x="8473288" y="2807208"/>
+            <a:ext cx="1051560" cy="201168"/>
           </a:xfrm>
           <a:prstGeom prst="rect">
             <a:avLst/>
@@ -3235,8 +3235,8 @@
         </p:nvSpPr>
         <p:spPr>
           <a:xfrm>
-            <a:off x="8055864" y="2057400"/>
-            <a:ext cx="640080" cy="0"/>
+            <a:off x="8656168" y="2148840"/>
+            <a:ext cx="685800" cy="0"/>
           </a:xfrm>
           <a:prstGeom prst="line">
             <a:avLst/>
@@ -3260,8 +3260,8 @@
         </p:nvSpPr>
         <p:spPr>
           <a:xfrm>
-            <a:off x="9034272" y="978408"/>
-            <a:ext cx="2499055" cy="274320"/>
+            <a:off x="9680296" y="1234440"/>
+            <a:ext cx="1843888" cy="502920"/>
           </a:xfrm>
           <a:prstGeom prst="rect">
             <a:avLst/>
@@ -3277,14 +3277,14 @@
               <a:buNone/>
             </a:pPr>
             <a:r>
-              <a:rPr lang="en-US" sz="1300" b="1" dirty="0">
+              <a:rPr lang="en-US" sz="1400" b="1" dirty="0">
                 <a:solidFill>
                   <a:schemeClr val="tx1"/>
                 </a:solidFill>
               </a:rPr>
               <a:t>Resultados preliminares</a:t>
             </a:r>
-            <a:endParaRPr lang="en-US" sz="1300" dirty="0"/>
+            <a:endParaRPr lang="en-US" sz="1400" dirty="0"/>
           </a:p>
         </p:txBody>
       </p:sp>
@@ -3296,8 +3296,8 @@
         </p:nvSpPr>
         <p:spPr>
           <a:xfrm>
-            <a:off x="9034272" y="1261872"/>
-            <a:ext cx="2499055" cy="201168"/>
+            <a:off x="9680296" y="1810512"/>
+            <a:ext cx="1843888" cy="457200"/>
           </a:xfrm>
           <a:prstGeom prst="rect">
             <a:avLst/>
@@ -3313,27 +3313,52 @@
               <a:buNone/>
             </a:pPr>
             <a:r>
-              <a:rPr lang="en-US" sz="950" b="1" dirty="0">
+              <a:rPr lang="en-US" sz="1000" dirty="0">
+                <a:solidFill>
+                  <a:schemeClr val="accent5"/>
+                </a:solidFill>
+              </a:rPr>
+              <a:t>Circular No.  </a:t>
+            </a:r>
+            <a:pPr indent="0" marL="0">
+              <a:buNone/>
+            </a:pPr>
+            <a:r>
+              <a:rPr lang="en-US" sz="1050" b="1" dirty="0">
                 <a:solidFill>
                   <a:schemeClr val="accent1"/>
                 </a:solidFill>
               </a:rPr>
-              <a:t>DS-SABAO-BCS-BC-17003  ·  05/11/2025</a:t>
-            </a:r>
-            <a:endParaRPr lang="en-US" sz="950" dirty="0"/>
-          </a:p>
-        </p:txBody>
-      </p:sp>
-      <p:sp>
-        <p:nvSpPr>
-          <p:cNvPr id="52" name="Separador lista 2025-2"/>
+              <a:t>05/11/2025</a:t>
+            </a:r>
+            <a:endParaRPr lang="en-US" sz="1100" dirty="0"/>
+          </a:p>
+          <a:p>
+            <a:pPr indent="0" marL="0">
+              <a:buNone/>
+            </a:pPr>
+            <a:r>
+              <a:rPr lang="en-US" sz="1100" b="1" dirty="0">
+                <a:solidFill>
+                  <a:schemeClr val="accent1"/>
+                </a:solidFill>
+              </a:rPr>
+              <a:t>DS-SABAO-BCS-BC-17003</a:t>
+            </a:r>
+            <a:endParaRPr lang="en-US" sz="1100" dirty="0"/>
+          </a:p>
+        </p:txBody>
+      </p:sp>
+      <p:sp>
+        <p:nvSpPr>
+          <p:cNvPr id="52" name="Separador 2025-2-0"/>
           <p:cNvSpPr/>
           <p:nvPr/>
         </p:nvSpPr>
         <p:spPr>
           <a:xfrm>
-            <a:off x="9034272" y="1527048"/>
-            <a:ext cx="2499055" cy="0"/>
+            <a:off x="9680296" y="2340864"/>
+            <a:ext cx="1843888" cy="0"/>
           </a:xfrm>
           <a:prstGeom prst="line">
             <a:avLst/>
@@ -3349,360 +3374,131 @@
       </p:sp>
       <p:sp>
         <p:nvSpPr>
-          <p:cNvPr id="53" name="Listado 2025-2"/>
-          <p:cNvSpPr txBox="1"/>
-          <p:nvPr/>
-        </p:nvSpPr>
-        <p:spPr>
-          <a:xfrm>
-            <a:off x="9034272" y="1581912"/>
-            <a:ext cx="2499055" cy="1572768"/>
-          </a:xfrm>
-          <a:prstGeom prst="rect">
-            <a:avLst/>
-          </a:prstGeom>
-          <a:noFill/>
-          <a:ln/>
-        </p:spPr>
-        <p:txBody>
-          <a:bodyPr wrap="square" lIns="0" tIns="0" rIns="0" bIns="0" rtlCol="0" anchor="t"/>
-          <a:lstStyle/>
-          <a:p>
-            <a:pPr indent="0" marL="0">
-              <a:lnSpc>
-                <a:spcPct val="92000"/>
-              </a:lnSpc>
-              <a:buNone/>
-            </a:pPr>
-            <a:r>
-              <a:rPr lang="en-US" sz="850" b="1" spc="100" kern="0" dirty="0">
-                <a:solidFill>
-                  <a:schemeClr val="accent1"/>
-                </a:solidFill>
-              </a:rPr>
-              <a:t>9 OBSERVACIONES</a:t>
-            </a:r>
-            <a:endParaRPr lang="en-US" sz="950" dirty="0"/>
-          </a:p>
-          <a:p>
-            <a:pPr indent="0" marL="0">
-              <a:lnSpc>
-                <a:spcPct val="92000"/>
-              </a:lnSpc>
-              <a:buNone/>
-            </a:pPr>
-            <a:r>
-              <a:rPr lang="en-US" sz="950" b="1" dirty="0">
-                <a:solidFill>
-                  <a:schemeClr val="accent1"/>
-                </a:solidFill>
-              </a:rPr>
-              <a:t>1  </a:t>
-            </a:r>
-            <a:pPr indent="0" marL="0">
-              <a:lnSpc>
-                <a:spcPct val="92000"/>
-              </a:lnSpc>
-              <a:buNone/>
-            </a:pPr>
-            <a:r>
-              <a:rPr lang="en-US" sz="950" dirty="0">
+          <p:cNvPr id="53" name="Dato 2025-2-0"/>
+          <p:cNvSpPr txBox="1"/>
+          <p:nvPr/>
+        </p:nvSpPr>
+        <p:spPr>
+          <a:xfrm>
+            <a:off x="9680296" y="2377440"/>
+            <a:ext cx="1843888" cy="310896"/>
+          </a:xfrm>
+          <a:prstGeom prst="rect">
+            <a:avLst/>
+          </a:prstGeom>
+          <a:noFill/>
+          <a:ln/>
+        </p:spPr>
+        <p:txBody>
+          <a:bodyPr wrap="square" lIns="0" tIns="0" rIns="0" bIns="0" rtlCol="0" anchor="ctr"/>
+          <a:lstStyle/>
+          <a:p>
+            <a:pPr indent="0" marL="0">
+              <a:buNone/>
+            </a:pPr>
+            <a:r>
+              <a:rPr lang="en-US" sz="1100" dirty="0">
+                <a:solidFill>
+                  <a:schemeClr val="accent5"/>
+                </a:solidFill>
+              </a:rPr>
+              <a:t>Resultado  </a:t>
+            </a:r>
+            <a:pPr indent="0" marL="0">
+              <a:buNone/>
+            </a:pPr>
+            <a:r>
+              <a:rPr lang="en-US" sz="1100" b="1" dirty="0">
                 <a:solidFill>
                   <a:schemeClr val="tx1"/>
                 </a:solidFill>
               </a:rPr>
-              <a:t>Política de Operaciones Vinculadas</a:t>
-            </a:r>
-            <a:endParaRPr lang="en-US" sz="950" dirty="0"/>
-          </a:p>
-          <a:p>
-            <a:pPr indent="0" marL="0">
-              <a:lnSpc>
-                <a:spcPct val="92000"/>
-              </a:lnSpc>
-              <a:buNone/>
-            </a:pPr>
-            <a:r>
-              <a:rPr lang="en-US" sz="950" b="1" dirty="0">
-                <a:solidFill>
-                  <a:schemeClr val="accent1"/>
-                </a:solidFill>
-              </a:rPr>
-              <a:t>2  </a:t>
-            </a:r>
-            <a:pPr indent="0" marL="0">
-              <a:lnSpc>
-                <a:spcPct val="92000"/>
-              </a:lnSpc>
-              <a:buNone/>
-            </a:pPr>
-            <a:r>
-              <a:rPr lang="en-US" sz="950" dirty="0">
+              <a:t>9 observaciones</a:t>
+            </a:r>
+            <a:endParaRPr lang="en-US" sz="1100" dirty="0"/>
+          </a:p>
+        </p:txBody>
+      </p:sp>
+      <p:sp>
+        <p:nvSpPr>
+          <p:cNvPr id="54" name="Separador 2025-2-1"/>
+          <p:cNvSpPr/>
+          <p:nvPr/>
+        </p:nvSpPr>
+        <p:spPr>
+          <a:xfrm>
+            <a:off x="9680296" y="2706624"/>
+            <a:ext cx="1843888" cy="0"/>
+          </a:xfrm>
+          <a:prstGeom prst="line">
+            <a:avLst/>
+          </a:prstGeom>
+          <a:noFill/>
+          <a:ln w="9525">
+            <a:solidFill>
+              <a:srgbClr val="D9E0EA"/>
+            </a:solidFill>
+            <a:prstDash val="solid"/>
+          </a:ln>
+        </p:spPr>
+      </p:sp>
+      <p:sp>
+        <p:nvSpPr>
+          <p:cNvPr id="55" name="Dato 2025-2-1"/>
+          <p:cNvSpPr txBox="1"/>
+          <p:nvPr/>
+        </p:nvSpPr>
+        <p:spPr>
+          <a:xfrm>
+            <a:off x="9680296" y="2743200"/>
+            <a:ext cx="1843888" cy="310896"/>
+          </a:xfrm>
+          <a:prstGeom prst="rect">
+            <a:avLst/>
+          </a:prstGeom>
+          <a:noFill/>
+          <a:ln/>
+        </p:spPr>
+        <p:txBody>
+          <a:bodyPr wrap="square" lIns="0" tIns="0" rIns="0" bIns="0" rtlCol="0" anchor="ctr"/>
+          <a:lstStyle/>
+          <a:p>
+            <a:pPr indent="0" marL="0">
+              <a:buNone/>
+            </a:pPr>
+            <a:r>
+              <a:rPr lang="en-US" sz="1100" dirty="0">
+                <a:solidFill>
+                  <a:schemeClr val="accent5"/>
+                </a:solidFill>
+              </a:rPr>
+              <a:t>Ref. envío  </a:t>
+            </a:r>
+            <a:pPr indent="0" marL="0">
+              <a:buNone/>
+            </a:pPr>
+            <a:r>
+              <a:rPr lang="en-US" sz="1100" b="1" dirty="0">
                 <a:solidFill>
                   <a:schemeClr val="tx1"/>
                 </a:solidFill>
               </a:rPr>
-              <a:t>Confidencialidad e inducción en actas</a:t>
-            </a:r>
-            <a:endParaRPr lang="en-US" sz="950" dirty="0"/>
-          </a:p>
-          <a:p>
-            <a:pPr indent="0" marL="0">
-              <a:lnSpc>
-                <a:spcPct val="92000"/>
-              </a:lnSpc>
-              <a:buNone/>
-            </a:pPr>
-            <a:r>
-              <a:rPr lang="en-US" sz="950" b="1" dirty="0">
-                <a:solidFill>
-                  <a:schemeClr val="accent1"/>
-                </a:solidFill>
-              </a:rPr>
-              <a:t>3  </a:t>
-            </a:r>
-            <a:pPr indent="0" marL="0">
-              <a:lnSpc>
-                <a:spcPct val="92000"/>
-              </a:lnSpc>
-              <a:buNone/>
-            </a:pPr>
-            <a:r>
-              <a:rPr lang="en-US" sz="950" b="1" dirty="0">
-                <a:solidFill>
-                  <a:schemeClr val="accent3"/>
-                </a:solidFill>
-              </a:rPr>
-              <a:t>Comités sin personal ejecutivo</a:t>
-            </a:r>
-            <a:pPr indent="0" marL="0">
-              <a:lnSpc>
-                <a:spcPct val="92000"/>
-              </a:lnSpc>
-              <a:buNone/>
-            </a:pPr>
-            <a:r>
-              <a:rPr lang="en-US" sz="850" dirty="0">
-                <a:solidFill>
-                  <a:schemeClr val="accent3"/>
-                </a:solidFill>
-              </a:rPr>
-              <a:t>  · seguimiento</a:t>
-            </a:r>
-            <a:endParaRPr lang="en-US" sz="950" dirty="0"/>
-          </a:p>
-          <a:p>
-            <a:pPr indent="0" marL="0">
-              <a:lnSpc>
-                <a:spcPct val="92000"/>
-              </a:lnSpc>
-              <a:buNone/>
-            </a:pPr>
-            <a:r>
-              <a:rPr lang="en-US" sz="950" b="1" dirty="0">
-                <a:solidFill>
-                  <a:schemeClr val="accent1"/>
-                </a:solidFill>
-              </a:rPr>
-              <a:t>4  </a:t>
-            </a:r>
-            <a:pPr indent="0" marL="0">
-              <a:lnSpc>
-                <a:spcPct val="92000"/>
-              </a:lnSpc>
-              <a:buNone/>
-            </a:pPr>
-            <a:r>
-              <a:rPr lang="en-US" sz="950" dirty="0">
-                <a:solidFill>
-                  <a:schemeClr val="tx1"/>
-                </a:solidFill>
-              </a:rPr>
-              <a:t>Pago de dietas</a:t>
-            </a:r>
-            <a:endParaRPr lang="en-US" sz="950" dirty="0"/>
-          </a:p>
-          <a:p>
-            <a:pPr indent="0" marL="0">
-              <a:lnSpc>
-                <a:spcPct val="92000"/>
-              </a:lnSpc>
-              <a:buNone/>
-            </a:pPr>
-            <a:r>
-              <a:rPr lang="en-US" sz="950" b="1" dirty="0">
-                <a:solidFill>
-                  <a:schemeClr val="accent1"/>
-                </a:solidFill>
-              </a:rPr>
-              <a:t>5  </a:t>
-            </a:r>
-            <a:pPr indent="0" marL="0">
-              <a:lnSpc>
-                <a:spcPct val="92000"/>
-              </a:lnSpc>
-              <a:buNone/>
-            </a:pPr>
-            <a:r>
-              <a:rPr lang="en-US" sz="950" b="1" dirty="0">
-                <a:solidFill>
-                  <a:schemeClr val="accent3"/>
-                </a:solidFill>
-              </a:rPr>
-              <a:t>Normativa interna desactualizada</a:t>
-            </a:r>
-            <a:pPr indent="0" marL="0">
-              <a:lnSpc>
-                <a:spcPct val="92000"/>
-              </a:lnSpc>
-              <a:buNone/>
-            </a:pPr>
-            <a:r>
-              <a:rPr lang="en-US" sz="850" dirty="0">
-                <a:solidFill>
-                  <a:schemeClr val="accent3"/>
-                </a:solidFill>
-              </a:rPr>
-              <a:t>  · seguimiento</a:t>
-            </a:r>
-            <a:endParaRPr lang="en-US" sz="950" dirty="0"/>
-          </a:p>
-          <a:p>
-            <a:pPr indent="0" marL="0">
-              <a:lnSpc>
-                <a:spcPct val="92000"/>
-              </a:lnSpc>
-              <a:buNone/>
-            </a:pPr>
-            <a:r>
-              <a:rPr lang="en-US" sz="950" b="1" dirty="0">
-                <a:solidFill>
-                  <a:schemeClr val="accent1"/>
-                </a:solidFill>
-              </a:rPr>
-              <a:t>6  </a:t>
-            </a:r>
-            <a:pPr indent="0" marL="0">
-              <a:lnSpc>
-                <a:spcPct val="92000"/>
-              </a:lnSpc>
-              <a:buNone/>
-            </a:pPr>
-            <a:r>
-              <a:rPr lang="en-US" sz="950" dirty="0">
-                <a:solidFill>
-                  <a:schemeClr val="tx1"/>
-                </a:solidFill>
-              </a:rPr>
-              <a:t>Soporte de Ferias de Crédito</a:t>
-            </a:r>
-            <a:endParaRPr lang="en-US" sz="950" dirty="0"/>
-          </a:p>
-          <a:p>
-            <a:pPr indent="0" marL="0">
-              <a:lnSpc>
-                <a:spcPct val="92000"/>
-              </a:lnSpc>
-              <a:buNone/>
-            </a:pPr>
-            <a:r>
-              <a:rPr lang="en-US" sz="950" b="1" dirty="0">
-                <a:solidFill>
-                  <a:schemeClr val="accent1"/>
-                </a:solidFill>
-              </a:rPr>
-              <a:t>7  </a:t>
-            </a:r>
-            <a:pPr indent="0" marL="0">
-              <a:lnSpc>
-                <a:spcPct val="92000"/>
-              </a:lnSpc>
-              <a:buNone/>
-            </a:pPr>
-            <a:r>
-              <a:rPr lang="en-US" sz="950" dirty="0">
-                <a:solidFill>
-                  <a:schemeClr val="tx1"/>
-                </a:solidFill>
-              </a:rPr>
-              <a:t>Declaración jurada (NRP-75)</a:t>
-            </a:r>
-            <a:endParaRPr lang="en-US" sz="950" dirty="0"/>
-          </a:p>
-          <a:p>
-            <a:pPr indent="0" marL="0">
-              <a:lnSpc>
-                <a:spcPct val="92000"/>
-              </a:lnSpc>
-              <a:buNone/>
-            </a:pPr>
-            <a:r>
-              <a:rPr lang="en-US" sz="950" b="1" dirty="0">
-                <a:solidFill>
-                  <a:schemeClr val="accent1"/>
-                </a:solidFill>
-              </a:rPr>
-              <a:t>8  </a:t>
-            </a:r>
-            <a:pPr indent="0" marL="0">
-              <a:lnSpc>
-                <a:spcPct val="92000"/>
-              </a:lnSpc>
-              <a:buNone/>
-            </a:pPr>
-            <a:r>
-              <a:rPr lang="en-US" sz="950" dirty="0">
-                <a:solidFill>
-                  <a:schemeClr val="tx1"/>
-                </a:solidFill>
-              </a:rPr>
-              <a:t>Manual de Compras</a:t>
-            </a:r>
-            <a:endParaRPr lang="en-US" sz="950" dirty="0"/>
-          </a:p>
-          <a:p>
-            <a:pPr indent="0" marL="0">
-              <a:lnSpc>
-                <a:spcPct val="92000"/>
-              </a:lnSpc>
-              <a:buNone/>
-            </a:pPr>
-            <a:r>
-              <a:rPr lang="en-US" sz="950" b="1" dirty="0">
-                <a:solidFill>
-                  <a:schemeClr val="accent1"/>
-                </a:solidFill>
-              </a:rPr>
-              <a:t>9  </a:t>
-            </a:r>
-            <a:pPr indent="0" marL="0">
-              <a:lnSpc>
-                <a:spcPct val="92000"/>
-              </a:lnSpc>
-              <a:buNone/>
-            </a:pPr>
-            <a:r>
-              <a:rPr lang="en-US" sz="950" dirty="0">
-                <a:solidFill>
-                  <a:schemeClr val="tx1"/>
-                </a:solidFill>
-              </a:rPr>
-              <a:t>Uso del Fondo de Educación</a:t>
-            </a:r>
-            <a:endParaRPr lang="en-US" sz="950" dirty="0"/>
-          </a:p>
-        </p:txBody>
-      </p:sp>
-      <p:sp>
-        <p:nvSpPr>
-          <p:cNvPr id="54" name="Flecha 2025"/>
+              <a:t>NB07-2025-974</a:t>
+            </a:r>
+            <a:endParaRPr lang="en-US" sz="1100" dirty="0"/>
+          </a:p>
+        </p:txBody>
+      </p:sp>
+      <p:sp>
+        <p:nvSpPr>
+          <p:cNvPr id="56" name="Flecha 2025"/>
           <p:cNvSpPr/>
           <p:nvPr/>
         </p:nvSpPr>
         <p:spPr>
           <a:xfrm>
-            <a:off x="7452360" y="1929384"/>
-            <a:ext cx="256032" cy="256032"/>
+            <a:off x="7970368" y="2011680"/>
+            <a:ext cx="274320" cy="274320"/>
           </a:xfrm>
           <a:prstGeom prst="rightArrow">
             <a:avLst/>
@@ -3722,14 +3518,14 @@
       </p:sp>
       <p:sp>
         <p:nvSpPr>
-          <p:cNvPr id="55" name="Año 2026"/>
-          <p:cNvSpPr txBox="1"/>
-          <p:nvPr/>
-        </p:nvSpPr>
-        <p:spPr>
-          <a:xfrm>
-            <a:off x="4572000" y="3310128"/>
-            <a:ext cx="1188720" cy="457200"/>
+          <p:cNvPr id="57" name="Año 2026"/>
+          <p:cNvSpPr txBox="1"/>
+          <p:nvPr/>
+        </p:nvSpPr>
+        <p:spPr>
+          <a:xfrm>
+            <a:off x="4572000" y="3401568"/>
+            <a:ext cx="1188720" cy="502920"/>
           </a:xfrm>
           <a:prstGeom prst="rect">
             <a:avLst/>
@@ -3745,7 +3541,7 @@
               <a:buNone/>
             </a:pPr>
             <a:r>
-              <a:rPr lang="en-US" sz="2800" b="1" dirty="0">
+              <a:rPr lang="en-US" sz="3000" b="1" dirty="0">
                 <a:solidFill>
                   <a:schemeClr val="accent2"/>
                 </a:solidFill>
@@ -3755,20 +3551,20 @@
               </a:rPr>
               <a:t>2026</a:t>
             </a:r>
-            <a:endParaRPr lang="en-US" sz="2800" dirty="0"/>
-          </a:p>
-        </p:txBody>
-      </p:sp>
-      <p:sp>
-        <p:nvSpPr>
-          <p:cNvPr id="56" name="Visita 2026"/>
-          <p:cNvSpPr txBox="1"/>
-          <p:nvPr/>
-        </p:nvSpPr>
-        <p:spPr>
-          <a:xfrm>
-            <a:off x="5760720" y="3310128"/>
-            <a:ext cx="3657600" cy="457200"/>
+            <a:endParaRPr lang="en-US" sz="3000" dirty="0"/>
+          </a:p>
+        </p:txBody>
+      </p:sp>
+      <p:sp>
+        <p:nvSpPr>
+          <p:cNvPr id="58" name="Visita 2026"/>
+          <p:cNvSpPr txBox="1"/>
+          <p:nvPr/>
+        </p:nvSpPr>
+        <p:spPr>
+          <a:xfrm>
+            <a:off x="5806440" y="3401568"/>
+            <a:ext cx="3657600" cy="502920"/>
           </a:xfrm>
           <a:prstGeom prst="rect">
             <a:avLst/>
@@ -3797,18 +3593,18 @@
       </p:sp>
       <p:sp>
         <p:nvSpPr>
-          <p:cNvPr id="57" name="Tarjeta 2026-1"/>
+          <p:cNvPr id="59" name="Tarjeta 2026-1"/>
           <p:cNvSpPr/>
           <p:nvPr/>
         </p:nvSpPr>
         <p:spPr>
           <a:xfrm>
-            <a:off x="4572000" y="3858768"/>
-            <a:ext cx="2834640" cy="2377440"/>
+            <a:off x="4572000" y="4041648"/>
+            <a:ext cx="3306928" cy="2103120"/>
           </a:xfrm>
           <a:prstGeom prst="roundRect">
             <a:avLst>
-              <a:gd name="adj" fmla="val 3846"/>
+              <a:gd name="adj" fmla="val 4348"/>
             </a:avLst>
           </a:prstGeom>
           <a:solidFill>
@@ -3824,18 +3620,18 @@
       </p:sp>
       <p:sp>
         <p:nvSpPr>
-          <p:cNvPr id="58" name="Fechas fondo 2026-1"/>
+          <p:cNvPr id="60" name="Fechas fondo 2026-1"/>
           <p:cNvSpPr/>
           <p:nvPr/>
         </p:nvSpPr>
         <p:spPr>
           <a:xfrm>
-            <a:off x="4690872" y="3977640"/>
-            <a:ext cx="1005840" cy="2139696"/>
+            <a:off x="4709160" y="4178808"/>
+            <a:ext cx="1051560" cy="1828800"/>
           </a:xfrm>
           <a:prstGeom prst="roundRect">
             <a:avLst>
-              <a:gd name="adj" fmla="val 9091"/>
+              <a:gd name="adj" fmla="val 8696"/>
             </a:avLst>
           </a:prstGeom>
           <a:solidFill>
@@ -3853,14 +3649,14 @@
       </p:sp>
       <p:sp>
         <p:nvSpPr>
-          <p:cNvPr id="59" name="Fecha etiqueta 2026-1-0"/>
-          <p:cNvSpPr txBox="1"/>
-          <p:nvPr/>
-        </p:nvSpPr>
-        <p:spPr>
-          <a:xfrm>
-            <a:off x="4690872" y="4142232"/>
-            <a:ext cx="1005840" cy="182880"/>
+          <p:cNvPr id="61" name="Fecha etiqueta 2026-1-0"/>
+          <p:cNvSpPr txBox="1"/>
+          <p:nvPr/>
+        </p:nvSpPr>
+        <p:spPr>
+          <a:xfrm>
+            <a:off x="4709160" y="4270248"/>
+            <a:ext cx="1051560" cy="182880"/>
           </a:xfrm>
           <a:prstGeom prst="rect">
             <a:avLst/>
@@ -3889,14 +3685,14 @@
       </p:sp>
       <p:sp>
         <p:nvSpPr>
-          <p:cNvPr id="60" name="Fecha día 2026-1-0"/>
-          <p:cNvSpPr txBox="1"/>
-          <p:nvPr/>
-        </p:nvSpPr>
-        <p:spPr>
-          <a:xfrm>
-            <a:off x="4690872" y="4343400"/>
-            <a:ext cx="1005840" cy="411480"/>
+          <p:cNvPr id="62" name="Fecha día 2026-1-0"/>
+          <p:cNvSpPr txBox="1"/>
+          <p:nvPr/>
+        </p:nvSpPr>
+        <p:spPr>
+          <a:xfrm>
+            <a:off x="4709160" y="4453128"/>
+            <a:ext cx="1051560" cy="384048"/>
           </a:xfrm>
           <a:prstGeom prst="rect">
             <a:avLst/>
@@ -3912,7 +3708,7 @@
               <a:buNone/>
             </a:pPr>
             <a:r>
-              <a:rPr lang="en-US" sz="2600" b="1" dirty="0">
+              <a:rPr lang="en-US" sz="2400" b="1" dirty="0">
                 <a:solidFill>
                   <a:schemeClr val="bg1"/>
                 </a:solidFill>
@@ -3922,20 +3718,20 @@
               </a:rPr>
               <a:t>21</a:t>
             </a:r>
-            <a:endParaRPr lang="en-US" sz="2600" dirty="0"/>
-          </a:p>
-        </p:txBody>
-      </p:sp>
-      <p:sp>
-        <p:nvSpPr>
-          <p:cNvPr id="61" name="Fecha mes 2026-1-0"/>
-          <p:cNvSpPr txBox="1"/>
-          <p:nvPr/>
-        </p:nvSpPr>
-        <p:spPr>
-          <a:xfrm>
-            <a:off x="4690872" y="4764024"/>
-            <a:ext cx="1005840" cy="201168"/>
+            <a:endParaRPr lang="en-US" sz="2400" dirty="0"/>
+          </a:p>
+        </p:txBody>
+      </p:sp>
+      <p:sp>
+        <p:nvSpPr>
+          <p:cNvPr id="63" name="Fecha mes 2026-1-0"/>
+          <p:cNvSpPr txBox="1"/>
+          <p:nvPr/>
+        </p:nvSpPr>
+        <p:spPr>
+          <a:xfrm>
+            <a:off x="4709160" y="4837176"/>
+            <a:ext cx="1051560" cy="201168"/>
           </a:xfrm>
           <a:prstGeom prst="rect">
             <a:avLst/>
@@ -3964,14 +3760,14 @@
       </p:sp>
       <p:sp>
         <p:nvSpPr>
-          <p:cNvPr id="62" name="Fecha etiqueta 2026-1-1"/>
-          <p:cNvSpPr txBox="1"/>
-          <p:nvPr/>
-        </p:nvSpPr>
-        <p:spPr>
-          <a:xfrm>
-            <a:off x="4690872" y="5212080"/>
-            <a:ext cx="1005840" cy="182880"/>
+          <p:cNvPr id="64" name="Fecha etiqueta 2026-1-1"/>
+          <p:cNvSpPr txBox="1"/>
+          <p:nvPr/>
+        </p:nvSpPr>
+        <p:spPr>
+          <a:xfrm>
+            <a:off x="4709160" y="5184648"/>
+            <a:ext cx="1051560" cy="182880"/>
           </a:xfrm>
           <a:prstGeom prst="rect">
             <a:avLst/>
@@ -4000,14 +3796,14 @@
       </p:sp>
       <p:sp>
         <p:nvSpPr>
-          <p:cNvPr id="63" name="Fecha día 2026-1-1"/>
-          <p:cNvSpPr txBox="1"/>
-          <p:nvPr/>
-        </p:nvSpPr>
-        <p:spPr>
-          <a:xfrm>
-            <a:off x="4690872" y="5413248"/>
-            <a:ext cx="1005840" cy="411480"/>
+          <p:cNvPr id="65" name="Fecha día 2026-1-1"/>
+          <p:cNvSpPr txBox="1"/>
+          <p:nvPr/>
+        </p:nvSpPr>
+        <p:spPr>
+          <a:xfrm>
+            <a:off x="4709160" y="5367528"/>
+            <a:ext cx="1051560" cy="384048"/>
           </a:xfrm>
           <a:prstGeom prst="rect">
             <a:avLst/>
@@ -4023,7 +3819,7 @@
               <a:buNone/>
             </a:pPr>
             <a:r>
-              <a:rPr lang="en-US" sz="2600" b="1" dirty="0">
+              <a:rPr lang="en-US" sz="2400" b="1" dirty="0">
                 <a:solidFill>
                   <a:schemeClr val="bg1"/>
                 </a:solidFill>
@@ -4033,20 +3829,20 @@
               </a:rPr>
               <a:t>09</a:t>
             </a:r>
-            <a:endParaRPr lang="en-US" sz="2600" dirty="0"/>
-          </a:p>
-        </p:txBody>
-      </p:sp>
-      <p:sp>
-        <p:nvSpPr>
-          <p:cNvPr id="64" name="Fecha mes 2026-1-1"/>
-          <p:cNvSpPr txBox="1"/>
-          <p:nvPr/>
-        </p:nvSpPr>
-        <p:spPr>
-          <a:xfrm>
-            <a:off x="4690872" y="5833872"/>
-            <a:ext cx="1005840" cy="201168"/>
+            <a:endParaRPr lang="en-US" sz="2400" dirty="0"/>
+          </a:p>
+        </p:txBody>
+      </p:sp>
+      <p:sp>
+        <p:nvSpPr>
+          <p:cNvPr id="66" name="Fecha mes 2026-1-1"/>
+          <p:cNvSpPr txBox="1"/>
+          <p:nvPr/>
+        </p:nvSpPr>
+        <p:spPr>
+          <a:xfrm>
+            <a:off x="4709160" y="5751576"/>
+            <a:ext cx="1051560" cy="201168"/>
           </a:xfrm>
           <a:prstGeom prst="rect">
             <a:avLst/>
@@ -4075,14 +3871,14 @@
       </p:sp>
       <p:sp>
         <p:nvSpPr>
-          <p:cNvPr id="65" name="Fechas separador 2026-1"/>
+          <p:cNvPr id="67" name="Fechas separador 2026-1"/>
           <p:cNvSpPr/>
           <p:nvPr/>
         </p:nvSpPr>
         <p:spPr>
           <a:xfrm>
-            <a:off x="4873752" y="5047488"/>
-            <a:ext cx="640080" cy="0"/>
+            <a:off x="4892040" y="5093208"/>
+            <a:ext cx="685800" cy="0"/>
           </a:xfrm>
           <a:prstGeom prst="line">
             <a:avLst/>
@@ -4100,14 +3896,14 @@
       </p:sp>
       <p:sp>
         <p:nvSpPr>
-          <p:cNvPr id="66" name="Tipo 2026-1"/>
-          <p:cNvSpPr txBox="1"/>
-          <p:nvPr/>
-        </p:nvSpPr>
-        <p:spPr>
-          <a:xfrm>
-            <a:off x="5852160" y="3995928"/>
-            <a:ext cx="1444752" cy="566928"/>
+          <p:cNvPr id="68" name="Tipo 2026-1"/>
+          <p:cNvSpPr txBox="1"/>
+          <p:nvPr/>
+        </p:nvSpPr>
+        <p:spPr>
+          <a:xfrm>
+            <a:off x="5916168" y="4178808"/>
+            <a:ext cx="1843888" cy="502920"/>
           </a:xfrm>
           <a:prstGeom prst="rect">
             <a:avLst/>
@@ -4123,27 +3919,27 @@
               <a:buNone/>
             </a:pPr>
             <a:r>
-              <a:rPr lang="en-US" sz="1300" b="1" dirty="0">
+              <a:rPr lang="en-US" sz="1400" b="1" dirty="0">
                 <a:solidFill>
                   <a:schemeClr val="tx1"/>
                 </a:solidFill>
               </a:rPr>
               <a:t>Nombramiento de visita ampliada</a:t>
             </a:r>
-            <a:endParaRPr lang="en-US" sz="1300" dirty="0"/>
-          </a:p>
-        </p:txBody>
-      </p:sp>
-      <p:sp>
-        <p:nvSpPr>
-          <p:cNvPr id="67" name="Circular 2026-1"/>
-          <p:cNvSpPr txBox="1"/>
-          <p:nvPr/>
-        </p:nvSpPr>
-        <p:spPr>
-          <a:xfrm>
-            <a:off x="5852160" y="4663440"/>
-            <a:ext cx="1444752" cy="457200"/>
+            <a:endParaRPr lang="en-US" sz="1400" dirty="0"/>
+          </a:p>
+        </p:txBody>
+      </p:sp>
+      <p:sp>
+        <p:nvSpPr>
+          <p:cNvPr id="69" name="Circular 2026-1"/>
+          <p:cNvSpPr txBox="1"/>
+          <p:nvPr/>
+        </p:nvSpPr>
+        <p:spPr>
+          <a:xfrm>
+            <a:off x="5916168" y="4754880"/>
+            <a:ext cx="1843888" cy="457200"/>
           </a:xfrm>
           <a:prstGeom prst="rect">
             <a:avLst/>
@@ -4159,7 +3955,7 @@
               <a:buNone/>
             </a:pPr>
             <a:r>
-              <a:rPr lang="en-US" sz="950" dirty="0">
+              <a:rPr lang="en-US" sz="1000" dirty="0">
                 <a:solidFill>
                   <a:schemeClr val="accent5"/>
                 </a:solidFill>
@@ -4170,41 +3966,41 @@
               <a:buNone/>
             </a:pPr>
             <a:r>
-              <a:rPr lang="en-US" sz="1000" b="1" dirty="0">
+              <a:rPr lang="en-US" sz="1050" b="1" dirty="0">
                 <a:solidFill>
                   <a:schemeClr val="accent2"/>
                 </a:solidFill>
               </a:rPr>
               <a:t>31/07/2026</a:t>
             </a:r>
-            <a:endParaRPr lang="en-US" sz="1000" dirty="0"/>
-          </a:p>
-          <a:p>
-            <a:pPr indent="0" marL="0">
-              <a:buNone/>
-            </a:pPr>
-            <a:r>
-              <a:rPr lang="en-US" sz="1000" b="1" dirty="0">
+            <a:endParaRPr lang="en-US" sz="1100" dirty="0"/>
+          </a:p>
+          <a:p>
+            <a:pPr indent="0" marL="0">
+              <a:buNone/>
+            </a:pPr>
+            <a:r>
+              <a:rPr lang="en-US" sz="1100" b="1" dirty="0">
                 <a:solidFill>
                   <a:schemeClr val="accent2"/>
                 </a:solidFill>
               </a:rPr>
               <a:t>SABAO-BCS-BC-18432</a:t>
             </a:r>
-            <a:endParaRPr lang="en-US" sz="1000" dirty="0"/>
-          </a:p>
-        </p:txBody>
-      </p:sp>
-      <p:sp>
-        <p:nvSpPr>
-          <p:cNvPr id="68" name="Separador 2026-1-0"/>
+            <a:endParaRPr lang="en-US" sz="1100" dirty="0"/>
+          </a:p>
+        </p:txBody>
+      </p:sp>
+      <p:sp>
+        <p:nvSpPr>
+          <p:cNvPr id="70" name="Separador 2026-1-0"/>
           <p:cNvSpPr/>
           <p:nvPr/>
         </p:nvSpPr>
         <p:spPr>
           <a:xfrm>
-            <a:off x="5852160" y="5303520"/>
-            <a:ext cx="1444752" cy="0"/>
+            <a:off x="5916168" y="5285232"/>
+            <a:ext cx="1843888" cy="0"/>
           </a:xfrm>
           <a:prstGeom prst="line">
             <a:avLst/>
@@ -4220,14 +4016,14 @@
       </p:sp>
       <p:sp>
         <p:nvSpPr>
-          <p:cNvPr id="69" name="Dato 2026-1-0"/>
-          <p:cNvSpPr txBox="1"/>
-          <p:nvPr/>
-        </p:nvSpPr>
-        <p:spPr>
-          <a:xfrm>
-            <a:off x="5852160" y="5340096"/>
-            <a:ext cx="1444752" cy="310896"/>
+          <p:cNvPr id="71" name="Dato 2026-1-0"/>
+          <p:cNvSpPr txBox="1"/>
+          <p:nvPr/>
+        </p:nvSpPr>
+        <p:spPr>
+          <a:xfrm>
+            <a:off x="5916168" y="5321808"/>
+            <a:ext cx="1843888" cy="310896"/>
           </a:xfrm>
           <a:prstGeom prst="rect">
             <a:avLst/>
@@ -4243,7 +4039,7 @@
               <a:buNone/>
             </a:pPr>
             <a:r>
-              <a:rPr lang="en-US" sz="1050" dirty="0">
+              <a:rPr lang="en-US" sz="1100" dirty="0">
                 <a:solidFill>
                   <a:schemeClr val="accent5"/>
                 </a:solidFill>
@@ -4254,27 +4050,27 @@
               <a:buNone/>
             </a:pPr>
             <a:r>
-              <a:rPr lang="en-US" sz="1050" b="1" dirty="0">
+              <a:rPr lang="en-US" sz="1100" b="1" dirty="0">
                 <a:solidFill>
                   <a:schemeClr val="tx1"/>
                 </a:solidFill>
               </a:rPr>
               <a:t>31/07/2026</a:t>
             </a:r>
-            <a:endParaRPr lang="en-US" sz="1050" dirty="0"/>
-          </a:p>
-        </p:txBody>
-      </p:sp>
-      <p:sp>
-        <p:nvSpPr>
-          <p:cNvPr id="70" name="Separador 2026-1-1"/>
+            <a:endParaRPr lang="en-US" sz="1100" dirty="0"/>
+          </a:p>
+        </p:txBody>
+      </p:sp>
+      <p:sp>
+        <p:nvSpPr>
+          <p:cNvPr id="72" name="Separador 2026-1-1"/>
           <p:cNvSpPr/>
           <p:nvPr/>
         </p:nvSpPr>
         <p:spPr>
           <a:xfrm>
-            <a:off x="5852160" y="5687568"/>
-            <a:ext cx="1444752" cy="0"/>
+            <a:off x="5916168" y="5650992"/>
+            <a:ext cx="1843888" cy="0"/>
           </a:xfrm>
           <a:prstGeom prst="line">
             <a:avLst/>
@@ -4290,14 +4086,14 @@
       </p:sp>
       <p:sp>
         <p:nvSpPr>
-          <p:cNvPr id="71" name="Dato 2026-1-1"/>
-          <p:cNvSpPr txBox="1"/>
-          <p:nvPr/>
-        </p:nvSpPr>
-        <p:spPr>
-          <a:xfrm>
-            <a:off x="5852160" y="5724144"/>
-            <a:ext cx="1444752" cy="310896"/>
+          <p:cNvPr id="73" name="Dato 2026-1-1"/>
+          <p:cNvSpPr txBox="1"/>
+          <p:nvPr/>
+        </p:nvSpPr>
+        <p:spPr>
+          <a:xfrm>
+            <a:off x="5916168" y="5687568"/>
+            <a:ext cx="1843888" cy="310896"/>
           </a:xfrm>
           <a:prstGeom prst="rect">
             <a:avLst/>
@@ -4313,7 +4109,7 @@
               <a:buNone/>
             </a:pPr>
             <a:r>
-              <a:rPr lang="en-US" sz="1050" dirty="0">
+              <a:rPr lang="en-US" sz="1100" dirty="0">
                 <a:solidFill>
                   <a:schemeClr val="accent5"/>
                 </a:solidFill>
@@ -4324,31 +4120,31 @@
               <a:buNone/>
             </a:pPr>
             <a:r>
-              <a:rPr lang="en-US" sz="1050" b="1" dirty="0">
+              <a:rPr lang="en-US" sz="1100" b="1" dirty="0">
                 <a:solidFill>
                   <a:schemeClr val="tx1"/>
                 </a:solidFill>
               </a:rPr>
-              <a:t>NRP-17 + seguim.</a:t>
-            </a:r>
-            <a:endParaRPr lang="en-US" sz="1050" dirty="0"/>
-          </a:p>
-        </p:txBody>
-      </p:sp>
-      <p:sp>
-        <p:nvSpPr>
-          <p:cNvPr id="72" name="Tarjeta 2026-2"/>
+              <a:t>GC + seguimiento</a:t>
+            </a:r>
+            <a:endParaRPr lang="en-US" sz="1100" dirty="0"/>
+          </a:p>
+        </p:txBody>
+      </p:sp>
+      <p:sp>
+        <p:nvSpPr>
+          <p:cNvPr id="74" name="Tarjeta 2026-2"/>
           <p:cNvSpPr/>
           <p:nvPr/>
         </p:nvSpPr>
         <p:spPr>
           <a:xfrm>
-            <a:off x="7754112" y="3858768"/>
-            <a:ext cx="3888943" cy="2377440"/>
+            <a:off x="8336128" y="4041648"/>
+            <a:ext cx="3306928" cy="2103120"/>
           </a:xfrm>
           <a:prstGeom prst="roundRect">
             <a:avLst>
-              <a:gd name="adj" fmla="val 3846"/>
+              <a:gd name="adj" fmla="val 4348"/>
             </a:avLst>
           </a:prstGeom>
           <a:solidFill>
@@ -4364,18 +4160,18 @@
       </p:sp>
       <p:sp>
         <p:nvSpPr>
-          <p:cNvPr id="73" name="Fechas fondo 2026-2"/>
+          <p:cNvPr id="75" name="Fechas fondo 2026-2"/>
           <p:cNvSpPr/>
           <p:nvPr/>
         </p:nvSpPr>
         <p:spPr>
           <a:xfrm>
-            <a:off x="7872984" y="3977640"/>
-            <a:ext cx="1005840" cy="2139696"/>
+            <a:off x="8473288" y="4178808"/>
+            <a:ext cx="1051560" cy="1828800"/>
           </a:xfrm>
           <a:prstGeom prst="roundRect">
             <a:avLst>
-              <a:gd name="adj" fmla="val 9091"/>
+              <a:gd name="adj" fmla="val 8696"/>
             </a:avLst>
           </a:prstGeom>
           <a:solidFill>
@@ -4393,14 +4189,14 @@
       </p:sp>
       <p:sp>
         <p:nvSpPr>
-          <p:cNvPr id="74" name="Fecha etiqueta 2026-2-0"/>
-          <p:cNvSpPr txBox="1"/>
-          <p:nvPr/>
-        </p:nvSpPr>
-        <p:spPr>
-          <a:xfrm>
-            <a:off x="7872984" y="4142232"/>
-            <a:ext cx="1005840" cy="182880"/>
+          <p:cNvPr id="76" name="Fecha etiqueta 2026-2-0"/>
+          <p:cNvSpPr txBox="1"/>
+          <p:nvPr/>
+        </p:nvSpPr>
+        <p:spPr>
+          <a:xfrm>
+            <a:off x="8473288" y="4270248"/>
+            <a:ext cx="1051560" cy="182880"/>
           </a:xfrm>
           <a:prstGeom prst="rect">
             <a:avLst/>
@@ -4429,14 +4225,14 @@
       </p:sp>
       <p:sp>
         <p:nvSpPr>
-          <p:cNvPr id="75" name="Fecha día 2026-2-0"/>
-          <p:cNvSpPr txBox="1"/>
-          <p:nvPr/>
-        </p:nvSpPr>
-        <p:spPr>
-          <a:xfrm>
-            <a:off x="7872984" y="4343400"/>
-            <a:ext cx="1005840" cy="411480"/>
+          <p:cNvPr id="77" name="Fecha día 2026-2-0"/>
+          <p:cNvSpPr txBox="1"/>
+          <p:nvPr/>
+        </p:nvSpPr>
+        <p:spPr>
+          <a:xfrm>
+            <a:off x="8473288" y="4453128"/>
+            <a:ext cx="1051560" cy="384048"/>
           </a:xfrm>
           <a:prstGeom prst="rect">
             <a:avLst/>
@@ -4452,7 +4248,7 @@
               <a:buNone/>
             </a:pPr>
             <a:r>
-              <a:rPr lang="en-US" sz="2600" b="1" dirty="0">
+              <a:rPr lang="en-US" sz="2400" b="1" dirty="0">
                 <a:solidFill>
                   <a:schemeClr val="bg1"/>
                 </a:solidFill>
@@ -4462,20 +4258,20 @@
               </a:rPr>
               <a:t>09</a:t>
             </a:r>
-            <a:endParaRPr lang="en-US" sz="2600" dirty="0"/>
-          </a:p>
-        </p:txBody>
-      </p:sp>
-      <p:sp>
-        <p:nvSpPr>
-          <p:cNvPr id="76" name="Fecha mes 2026-2-0"/>
-          <p:cNvSpPr txBox="1"/>
-          <p:nvPr/>
-        </p:nvSpPr>
-        <p:spPr>
-          <a:xfrm>
-            <a:off x="7872984" y="4764024"/>
-            <a:ext cx="1005840" cy="201168"/>
+            <a:endParaRPr lang="en-US" sz="2400" dirty="0"/>
+          </a:p>
+        </p:txBody>
+      </p:sp>
+      <p:sp>
+        <p:nvSpPr>
+          <p:cNvPr id="78" name="Fecha mes 2026-2-0"/>
+          <p:cNvSpPr txBox="1"/>
+          <p:nvPr/>
+        </p:nvSpPr>
+        <p:spPr>
+          <a:xfrm>
+            <a:off x="8473288" y="4837176"/>
+            <a:ext cx="1051560" cy="201168"/>
           </a:xfrm>
           <a:prstGeom prst="rect">
             <a:avLst/>
@@ -4504,14 +4300,14 @@
       </p:sp>
       <p:sp>
         <p:nvSpPr>
-          <p:cNvPr id="77" name="Fecha etiqueta 2026-2-1"/>
-          <p:cNvSpPr txBox="1"/>
-          <p:nvPr/>
-        </p:nvSpPr>
-        <p:spPr>
-          <a:xfrm>
-            <a:off x="7872984" y="5212080"/>
-            <a:ext cx="1005840" cy="182880"/>
+          <p:cNvPr id="79" name="Fecha etiqueta 2026-2-1"/>
+          <p:cNvSpPr txBox="1"/>
+          <p:nvPr/>
+        </p:nvSpPr>
+        <p:spPr>
+          <a:xfrm>
+            <a:off x="8473288" y="5184648"/>
+            <a:ext cx="1051560" cy="182880"/>
           </a:xfrm>
           <a:prstGeom prst="rect">
             <a:avLst/>
@@ -4540,14 +4336,14 @@
       </p:sp>
       <p:sp>
         <p:nvSpPr>
-          <p:cNvPr id="78" name="Fecha día 2026-2-1"/>
-          <p:cNvSpPr txBox="1"/>
-          <p:nvPr/>
-        </p:nvSpPr>
-        <p:spPr>
-          <a:xfrm>
-            <a:off x="7872984" y="5413248"/>
-            <a:ext cx="1005840" cy="411480"/>
+          <p:cNvPr id="80" name="Fecha día 2026-2-1"/>
+          <p:cNvSpPr txBox="1"/>
+          <p:nvPr/>
+        </p:nvSpPr>
+        <p:spPr>
+          <a:xfrm>
+            <a:off x="8473288" y="5367528"/>
+            <a:ext cx="1051560" cy="384048"/>
           </a:xfrm>
           <a:prstGeom prst="rect">
             <a:avLst/>
@@ -4563,7 +4359,7 @@
               <a:buNone/>
             </a:pPr>
             <a:r>
-              <a:rPr lang="en-US" sz="2600" b="1" dirty="0">
+              <a:rPr lang="en-US" sz="2400" b="1" dirty="0">
                 <a:solidFill>
                   <a:schemeClr val="bg1"/>
                 </a:solidFill>
@@ -4573,20 +4369,20 @@
               </a:rPr>
               <a:t>23</a:t>
             </a:r>
-            <a:endParaRPr lang="en-US" sz="2600" dirty="0"/>
-          </a:p>
-        </p:txBody>
-      </p:sp>
-      <p:sp>
-        <p:nvSpPr>
-          <p:cNvPr id="79" name="Fecha mes 2026-2-1"/>
-          <p:cNvSpPr txBox="1"/>
-          <p:nvPr/>
-        </p:nvSpPr>
-        <p:spPr>
-          <a:xfrm>
-            <a:off x="7872984" y="5833872"/>
-            <a:ext cx="1005840" cy="201168"/>
+            <a:endParaRPr lang="en-US" sz="2400" dirty="0"/>
+          </a:p>
+        </p:txBody>
+      </p:sp>
+      <p:sp>
+        <p:nvSpPr>
+          <p:cNvPr id="81" name="Fecha mes 2026-2-1"/>
+          <p:cNvSpPr txBox="1"/>
+          <p:nvPr/>
+        </p:nvSpPr>
+        <p:spPr>
+          <a:xfrm>
+            <a:off x="8473288" y="5751576"/>
+            <a:ext cx="1051560" cy="201168"/>
           </a:xfrm>
           <a:prstGeom prst="rect">
             <a:avLst/>
@@ -4615,14 +4411,14 @@
       </p:sp>
       <p:sp>
         <p:nvSpPr>
-          <p:cNvPr id="80" name="Fechas separador 2026-2"/>
+          <p:cNvPr id="82" name="Fechas separador 2026-2"/>
           <p:cNvSpPr/>
           <p:nvPr/>
         </p:nvSpPr>
         <p:spPr>
           <a:xfrm>
-            <a:off x="8055864" y="5047488"/>
-            <a:ext cx="640080" cy="0"/>
+            <a:off x="8656168" y="5093208"/>
+            <a:ext cx="685800" cy="0"/>
           </a:xfrm>
           <a:prstGeom prst="line">
             <a:avLst/>
@@ -4640,14 +4436,14 @@
       </p:sp>
       <p:sp>
         <p:nvSpPr>
-          <p:cNvPr id="81" name="Tipo 2026-2"/>
-          <p:cNvSpPr txBox="1"/>
-          <p:nvPr/>
-        </p:nvSpPr>
-        <p:spPr>
-          <a:xfrm>
-            <a:off x="9034272" y="3968496"/>
-            <a:ext cx="2499055" cy="274320"/>
+          <p:cNvPr id="83" name="Tipo 2026-2"/>
+          <p:cNvSpPr txBox="1"/>
+          <p:nvPr/>
+        </p:nvSpPr>
+        <p:spPr>
+          <a:xfrm>
+            <a:off x="9680296" y="4178808"/>
+            <a:ext cx="1843888" cy="502920"/>
           </a:xfrm>
           <a:prstGeom prst="rect">
             <a:avLst/>
@@ -4663,27 +4459,27 @@
               <a:buNone/>
             </a:pPr>
             <a:r>
-              <a:rPr lang="en-US" sz="1300" b="1" dirty="0">
+              <a:rPr lang="en-US" sz="1400" b="1" dirty="0">
                 <a:solidFill>
                   <a:schemeClr val="tx1"/>
                 </a:solidFill>
               </a:rPr>
               <a:t>Resultados preliminares</a:t>
             </a:r>
-            <a:endParaRPr lang="en-US" sz="1300" dirty="0"/>
-          </a:p>
-        </p:txBody>
-      </p:sp>
-      <p:sp>
-        <p:nvSpPr>
-          <p:cNvPr id="82" name="Circular 2026-2"/>
-          <p:cNvSpPr txBox="1"/>
-          <p:nvPr/>
-        </p:nvSpPr>
-        <p:spPr>
-          <a:xfrm>
-            <a:off x="9034272" y="4251960"/>
-            <a:ext cx="2499055" cy="201168"/>
+            <a:endParaRPr lang="en-US" sz="1400" dirty="0"/>
+          </a:p>
+        </p:txBody>
+      </p:sp>
+      <p:sp>
+        <p:nvSpPr>
+          <p:cNvPr id="84" name="Circular 2026-2"/>
+          <p:cNvSpPr txBox="1"/>
+          <p:nvPr/>
+        </p:nvSpPr>
+        <p:spPr>
+          <a:xfrm>
+            <a:off x="9680296" y="4754880"/>
+            <a:ext cx="1843888" cy="457200"/>
           </a:xfrm>
           <a:prstGeom prst="rect">
             <a:avLst/>
@@ -4699,27 +4495,52 @@
               <a:buNone/>
             </a:pPr>
             <a:r>
-              <a:rPr lang="en-US" sz="950" b="1" dirty="0">
+              <a:rPr lang="en-US" sz="1000" dirty="0">
+                <a:solidFill>
+                  <a:schemeClr val="accent5"/>
+                </a:solidFill>
+              </a:rPr>
+              <a:t>Circular No.  </a:t>
+            </a:r>
+            <a:pPr indent="0" marL="0">
+              <a:buNone/>
+            </a:pPr>
+            <a:r>
+              <a:rPr lang="en-US" sz="1050" b="1" dirty="0">
                 <a:solidFill>
                   <a:schemeClr val="accent2"/>
                 </a:solidFill>
               </a:rPr>
-              <a:t>DS-SABAO-BCS-BC-22741  ·  09/10/2026</a:t>
-            </a:r>
-            <a:endParaRPr lang="en-US" sz="950" dirty="0"/>
-          </a:p>
-        </p:txBody>
-      </p:sp>
-      <p:sp>
-        <p:nvSpPr>
-          <p:cNvPr id="83" name="Separador lista 2026-2"/>
+              <a:t>09/10/2026</a:t>
+            </a:r>
+            <a:endParaRPr lang="en-US" sz="1100" dirty="0"/>
+          </a:p>
+          <a:p>
+            <a:pPr indent="0" marL="0">
+              <a:buNone/>
+            </a:pPr>
+            <a:r>
+              <a:rPr lang="en-US" sz="1100" b="1" dirty="0">
+                <a:solidFill>
+                  <a:schemeClr val="accent2"/>
+                </a:solidFill>
+              </a:rPr>
+              <a:t>DS-SABAO-BCS-BC-22741</a:t>
+            </a:r>
+            <a:endParaRPr lang="en-US" sz="1100" dirty="0"/>
+          </a:p>
+        </p:txBody>
+      </p:sp>
+      <p:sp>
+        <p:nvSpPr>
+          <p:cNvPr id="85" name="Separador 2026-2-0"/>
           <p:cNvSpPr/>
           <p:nvPr/>
         </p:nvSpPr>
         <p:spPr>
           <a:xfrm>
-            <a:off x="9034272" y="4517136"/>
-            <a:ext cx="2499055" cy="0"/>
+            <a:off x="9680296" y="5285232"/>
+            <a:ext cx="1843888" cy="0"/>
           </a:xfrm>
           <a:prstGeom prst="line">
             <a:avLst/>
@@ -4735,352 +4556,131 @@
       </p:sp>
       <p:sp>
         <p:nvSpPr>
-          <p:cNvPr id="84" name="Listado 2026-2"/>
-          <p:cNvSpPr txBox="1"/>
-          <p:nvPr/>
-        </p:nvSpPr>
-        <p:spPr>
-          <a:xfrm>
-            <a:off x="9034272" y="4572000"/>
-            <a:ext cx="2499055" cy="1572768"/>
-          </a:xfrm>
-          <a:prstGeom prst="rect">
-            <a:avLst/>
-          </a:prstGeom>
-          <a:noFill/>
-          <a:ln/>
-        </p:spPr>
-        <p:txBody>
-          <a:bodyPr wrap="square" lIns="0" tIns="0" rIns="0" bIns="0" rtlCol="0" anchor="t"/>
-          <a:lstStyle/>
-          <a:p>
-            <a:pPr indent="0" marL="0">
-              <a:lnSpc>
-                <a:spcPct val="92000"/>
-              </a:lnSpc>
-              <a:buNone/>
-            </a:pPr>
-            <a:r>
-              <a:rPr lang="en-US" sz="850" b="1" spc="100" kern="0" dirty="0">
-                <a:solidFill>
-                  <a:schemeClr val="accent2"/>
-                </a:solidFill>
-              </a:rPr>
-              <a:t>7 OBSERVACIONES NUEVAS · ANEXO A</a:t>
-            </a:r>
-            <a:endParaRPr lang="en-US" sz="950" dirty="0"/>
-          </a:p>
-          <a:p>
-            <a:pPr indent="0" marL="0">
-              <a:lnSpc>
-                <a:spcPct val="92000"/>
-              </a:lnSpc>
-              <a:buNone/>
-            </a:pPr>
-            <a:r>
-              <a:rPr lang="en-US" sz="950" b="1" dirty="0">
-                <a:solidFill>
-                  <a:schemeClr val="accent2"/>
-                </a:solidFill>
-              </a:rPr>
-              <a:t>1  </a:t>
-            </a:r>
-            <a:pPr indent="0" marL="0">
-              <a:lnSpc>
-                <a:spcPct val="92000"/>
-              </a:lnSpc>
-              <a:buNone/>
-            </a:pPr>
-            <a:r>
-              <a:rPr lang="en-US" sz="950" dirty="0">
+          <p:cNvPr id="86" name="Dato 2026-2-0"/>
+          <p:cNvSpPr txBox="1"/>
+          <p:nvPr/>
+        </p:nvSpPr>
+        <p:spPr>
+          <a:xfrm>
+            <a:off x="9680296" y="5321808"/>
+            <a:ext cx="1843888" cy="310896"/>
+          </a:xfrm>
+          <a:prstGeom prst="rect">
+            <a:avLst/>
+          </a:prstGeom>
+          <a:noFill/>
+          <a:ln/>
+        </p:spPr>
+        <p:txBody>
+          <a:bodyPr wrap="square" lIns="0" tIns="0" rIns="0" bIns="0" rtlCol="0" anchor="ctr"/>
+          <a:lstStyle/>
+          <a:p>
+            <a:pPr indent="0" marL="0">
+              <a:buNone/>
+            </a:pPr>
+            <a:r>
+              <a:rPr lang="en-US" sz="1100" dirty="0">
+                <a:solidFill>
+                  <a:schemeClr val="accent5"/>
+                </a:solidFill>
+              </a:rPr>
+              <a:t>Anexo A  </a:t>
+            </a:r>
+            <a:pPr indent="0" marL="0">
+              <a:buNone/>
+            </a:pPr>
+            <a:r>
+              <a:rPr lang="en-US" sz="1100" b="1" dirty="0">
                 <a:solidFill>
                   <a:schemeClr val="tx1"/>
                 </a:solidFill>
               </a:rPr>
-              <a:t>Inducción sobre partidas de EEFF</a:t>
-            </a:r>
-            <a:endParaRPr lang="en-US" sz="950" dirty="0"/>
-          </a:p>
-          <a:p>
-            <a:pPr indent="0" marL="0">
-              <a:lnSpc>
-                <a:spcPct val="92000"/>
-              </a:lnSpc>
-              <a:buNone/>
-            </a:pPr>
-            <a:r>
-              <a:rPr lang="en-US" sz="950" b="1" dirty="0">
-                <a:solidFill>
-                  <a:schemeClr val="accent2"/>
-                </a:solidFill>
-              </a:rPr>
-              <a:t>2  </a:t>
-            </a:r>
-            <a:pPr indent="0" marL="0">
-              <a:lnSpc>
-                <a:spcPct val="92000"/>
-              </a:lnSpc>
-              <a:buNone/>
-            </a:pPr>
-            <a:r>
-              <a:rPr lang="en-US" sz="950" dirty="0">
+              <a:t>7 nuevas</a:t>
+            </a:r>
+            <a:endParaRPr lang="en-US" sz="1100" dirty="0"/>
+          </a:p>
+        </p:txBody>
+      </p:sp>
+      <p:sp>
+        <p:nvSpPr>
+          <p:cNvPr id="87" name="Separador 2026-2-1"/>
+          <p:cNvSpPr/>
+          <p:nvPr/>
+        </p:nvSpPr>
+        <p:spPr>
+          <a:xfrm>
+            <a:off x="9680296" y="5650992"/>
+            <a:ext cx="1843888" cy="0"/>
+          </a:xfrm>
+          <a:prstGeom prst="line">
+            <a:avLst/>
+          </a:prstGeom>
+          <a:noFill/>
+          <a:ln w="9525">
+            <a:solidFill>
+              <a:srgbClr val="D9E0EA"/>
+            </a:solidFill>
+            <a:prstDash val="solid"/>
+          </a:ln>
+        </p:spPr>
+      </p:sp>
+      <p:sp>
+        <p:nvSpPr>
+          <p:cNvPr id="88" name="Dato 2026-2-1"/>
+          <p:cNvSpPr txBox="1"/>
+          <p:nvPr/>
+        </p:nvSpPr>
+        <p:spPr>
+          <a:xfrm>
+            <a:off x="9680296" y="5687568"/>
+            <a:ext cx="1843888" cy="310896"/>
+          </a:xfrm>
+          <a:prstGeom prst="rect">
+            <a:avLst/>
+          </a:prstGeom>
+          <a:noFill/>
+          <a:ln/>
+        </p:spPr>
+        <p:txBody>
+          <a:bodyPr wrap="square" lIns="0" tIns="0" rIns="0" bIns="0" rtlCol="0" anchor="ctr"/>
+          <a:lstStyle/>
+          <a:p>
+            <a:pPr indent="0" marL="0">
+              <a:buNone/>
+            </a:pPr>
+            <a:r>
+              <a:rPr lang="en-US" sz="1100" dirty="0">
+                <a:solidFill>
+                  <a:schemeClr val="accent5"/>
+                </a:solidFill>
+              </a:rPr>
+              <a:t>Anexo B  </a:t>
+            </a:r>
+            <a:pPr indent="0" marL="0">
+              <a:buNone/>
+            </a:pPr>
+            <a:r>
+              <a:rPr lang="en-US" sz="1100" b="1" dirty="0">
                 <a:solidFill>
                   <a:schemeClr val="tx1"/>
                 </a:solidFill>
               </a:rPr>
-              <a:t>Certificación del Código de Conducta</a:t>
-            </a:r>
-            <a:endParaRPr lang="en-US" sz="950" dirty="0"/>
-          </a:p>
-          <a:p>
-            <a:pPr indent="0" marL="0">
-              <a:lnSpc>
-                <a:spcPct val="92000"/>
-              </a:lnSpc>
-              <a:buNone/>
-            </a:pPr>
-            <a:r>
-              <a:rPr lang="en-US" sz="950" b="1" dirty="0">
-                <a:solidFill>
-                  <a:schemeClr val="accent2"/>
-                </a:solidFill>
-              </a:rPr>
-              <a:t>3  </a:t>
-            </a:r>
-            <a:pPr indent="0" marL="0">
-              <a:lnSpc>
-                <a:spcPct val="92000"/>
-              </a:lnSpc>
-              <a:buNone/>
-            </a:pPr>
-            <a:r>
-              <a:rPr lang="en-US" sz="950" dirty="0">
-                <a:solidFill>
-                  <a:schemeClr val="tx1"/>
-                </a:solidFill>
-              </a:rPr>
-              <a:t>Políticas sin aprobar por el Consejo</a:t>
-            </a:r>
-            <a:endParaRPr lang="en-US" sz="950" dirty="0"/>
-          </a:p>
-          <a:p>
-            <a:pPr indent="0" marL="0">
-              <a:lnSpc>
-                <a:spcPct val="92000"/>
-              </a:lnSpc>
-              <a:buNone/>
-            </a:pPr>
-            <a:r>
-              <a:rPr lang="en-US" sz="950" b="1" dirty="0">
-                <a:solidFill>
-                  <a:schemeClr val="accent2"/>
-                </a:solidFill>
-              </a:rPr>
-              <a:t>4  </a:t>
-            </a:r>
-            <a:pPr indent="0" marL="0">
-              <a:lnSpc>
-                <a:spcPct val="92000"/>
-              </a:lnSpc>
-              <a:buNone/>
-            </a:pPr>
-            <a:r>
-              <a:rPr lang="en-US" sz="950" dirty="0">
-                <a:solidFill>
-                  <a:schemeClr val="tx1"/>
-                </a:solidFill>
-              </a:rPr>
-              <a:t>Sitio web de comités desactualizado</a:t>
-            </a:r>
-            <a:endParaRPr lang="en-US" sz="950" dirty="0"/>
-          </a:p>
-          <a:p>
-            <a:pPr indent="0" marL="0">
-              <a:lnSpc>
-                <a:spcPct val="92000"/>
-              </a:lnSpc>
-              <a:buNone/>
-            </a:pPr>
-            <a:r>
-              <a:rPr lang="en-US" sz="950" b="1" dirty="0">
-                <a:solidFill>
-                  <a:schemeClr val="accent2"/>
-                </a:solidFill>
-              </a:rPr>
-              <a:t>5  </a:t>
-            </a:r>
-            <a:pPr indent="0" marL="0">
-              <a:lnSpc>
-                <a:spcPct val="92000"/>
-              </a:lnSpc>
-              <a:buNone/>
-            </a:pPr>
-            <a:r>
-              <a:rPr lang="en-US" sz="950" dirty="0">
-                <a:solidFill>
-                  <a:schemeClr val="tx1"/>
-                </a:solidFill>
-              </a:rPr>
-              <a:t>Estatutos vs. Código de GC</a:t>
-            </a:r>
-            <a:endParaRPr lang="en-US" sz="950" dirty="0"/>
-          </a:p>
-          <a:p>
-            <a:pPr indent="0" marL="0">
-              <a:lnSpc>
-                <a:spcPct val="92000"/>
-              </a:lnSpc>
-              <a:buNone/>
-            </a:pPr>
-            <a:r>
-              <a:rPr lang="en-US" sz="950" b="1" dirty="0">
-                <a:solidFill>
-                  <a:schemeClr val="accent2"/>
-                </a:solidFill>
-              </a:rPr>
-              <a:t>6  </a:t>
-            </a:r>
-            <a:pPr indent="0" marL="0">
-              <a:lnSpc>
-                <a:spcPct val="92000"/>
-              </a:lnSpc>
-              <a:buNone/>
-            </a:pPr>
-            <a:r>
-              <a:rPr lang="en-US" sz="950" dirty="0">
-                <a:solidFill>
-                  <a:schemeClr val="tx1"/>
-                </a:solidFill>
-              </a:rPr>
-              <a:t>Reglamento del Fondo de Educación</a:t>
-            </a:r>
-            <a:endParaRPr lang="en-US" sz="950" dirty="0"/>
-          </a:p>
-          <a:p>
-            <a:pPr indent="0" marL="0">
-              <a:lnSpc>
-                <a:spcPct val="92000"/>
-              </a:lnSpc>
-              <a:buNone/>
-            </a:pPr>
-            <a:r>
-              <a:rPr lang="en-US" sz="950" b="1" dirty="0">
-                <a:solidFill>
-                  <a:schemeClr val="accent2"/>
-                </a:solidFill>
-              </a:rPr>
-              <a:t>7  </a:t>
-            </a:r>
-            <a:pPr indent="0" marL="0">
-              <a:lnSpc>
-                <a:spcPct val="92000"/>
-              </a:lnSpc>
-              <a:buNone/>
-            </a:pPr>
-            <a:r>
-              <a:rPr lang="en-US" sz="950" dirty="0">
-                <a:solidFill>
-                  <a:schemeClr val="tx1"/>
-                </a:solidFill>
-              </a:rPr>
-              <a:t>Transparencia del Fondo de Educación</a:t>
-            </a:r>
-            <a:endParaRPr lang="en-US" sz="950" dirty="0"/>
-          </a:p>
-          <a:p>
-            <a:pPr indent="0" marL="0">
-              <a:lnSpc>
-                <a:spcPct val="92000"/>
-              </a:lnSpc>
-              <a:spcBef>
-                <a:spcPts val="300"/>
-              </a:spcBef>
-              <a:buNone/>
-            </a:pPr>
-            <a:r>
-              <a:rPr lang="en-US" sz="850" b="1" spc="100" kern="0" dirty="0">
-                <a:solidFill>
-                  <a:schemeClr val="accent3"/>
-                </a:solidFill>
-              </a:rPr>
-              <a:t>2 EN SEGUIMIENTO DE 2025 · ANEXO B</a:t>
-            </a:r>
-            <a:endParaRPr lang="en-US" sz="950" dirty="0"/>
-          </a:p>
-          <a:p>
-            <a:pPr indent="0" marL="0">
-              <a:lnSpc>
-                <a:spcPct val="92000"/>
-              </a:lnSpc>
-              <a:buNone/>
-            </a:pPr>
-            <a:r>
-              <a:rPr lang="en-US" sz="950" b="1" dirty="0">
-                <a:solidFill>
-                  <a:schemeClr val="accent3"/>
-                </a:solidFill>
-              </a:rPr>
-              <a:t>Obs. 3  </a:t>
-            </a:r>
-            <a:pPr indent="0" marL="0">
-              <a:lnSpc>
-                <a:spcPct val="92000"/>
-              </a:lnSpc>
-              <a:buNone/>
-            </a:pPr>
-            <a:r>
-              <a:rPr lang="en-US" sz="950" dirty="0">
-                <a:solidFill>
-                  <a:schemeClr val="tx1"/>
-                </a:solidFill>
-              </a:rPr>
-              <a:t>Comités sin ejecutivos · No superada</a:t>
-            </a:r>
-            <a:endParaRPr lang="en-US" sz="950" dirty="0"/>
-          </a:p>
-          <a:p>
-            <a:pPr indent="0" marL="0">
-              <a:lnSpc>
-                <a:spcPct val="92000"/>
-              </a:lnSpc>
-              <a:buNone/>
-            </a:pPr>
-            <a:r>
-              <a:rPr lang="en-US" sz="950" b="1" dirty="0">
-                <a:solidFill>
-                  <a:schemeClr val="accent3"/>
-                </a:solidFill>
-              </a:rPr>
-              <a:t>Obs. 5  </a:t>
-            </a:r>
-            <a:pPr indent="0" marL="0">
-              <a:lnSpc>
-                <a:spcPct val="92000"/>
-              </a:lnSpc>
-              <a:buNone/>
-            </a:pPr>
-            <a:r>
-              <a:rPr lang="en-US" sz="950" dirty="0">
-                <a:solidFill>
-                  <a:schemeClr val="tx1"/>
-                </a:solidFill>
-              </a:rPr>
-              <a:t>Normativa interna · Parcialmente superada</a:t>
-            </a:r>
-            <a:endParaRPr lang="en-US" sz="950" dirty="0"/>
-          </a:p>
-        </p:txBody>
-      </p:sp>
-      <p:sp>
-        <p:nvSpPr>
-          <p:cNvPr id="85" name="Flecha 2026"/>
+              <a:t>obs. 3 y 5 de 2025</a:t>
+            </a:r>
+            <a:endParaRPr lang="en-US" sz="1100" dirty="0"/>
+          </a:p>
+        </p:txBody>
+      </p:sp>
+      <p:sp>
+        <p:nvSpPr>
+          <p:cNvPr id="89" name="Flecha 2026"/>
           <p:cNvSpPr/>
           <p:nvPr/>
         </p:nvSpPr>
         <p:spPr>
           <a:xfrm>
-            <a:off x="7452360" y="4919472"/>
-            <a:ext cx="256032" cy="256032"/>
+            <a:off x="7970368" y="4956048"/>
+            <a:ext cx="274320" cy="274320"/>
           </a:xfrm>
           <a:prstGeom prst="rightArrow">
             <a:avLst/>

</xml_diff>

<commit_message>
Use full names for responsible areas, no abbreviations
Co-Authored-By: Claude Opus 5.5 <noreply@anthropic.com>
Claude-Session: https://claude.ai/code/session_01F1WXR13Nv8neEtLhaK3ELa
</commit_message>
<xml_diff>
--- a/supervision-gobierno-corporativo/Supervision_GC_SSF_COMEDICA_2025-2026.pptx
+++ b/supervision-gobierno-corporativo/Supervision_GC_SSF_COMEDICA_2025-2026.pptx
@@ -109,17 +109,17 @@
   <p:extLst>
     <p:ext uri="{521415D9-36F7-43E2-AB2F-B90AF26B5E84}">
       <p14:sectionLst xmlns:p14="http://schemas.microsoft.com/office/powerpoint/2010/main">
-        <p14:section name="1 · Resumen de circulares SSF" id="{053381d0-761d-f6b6-f977-fde5b3573169}">
+        <p14:section name="1 · Resumen de circulares SSF" id="{d4bc93ea-717b-1db4-cd05-3e25cc7e6455}">
           <p14:sldIdLst>
             <p14:sldId id="256"/>
           </p14:sldIdLst>
         </p14:section>
-        <p14:section name="2 · Observaciones 2025" id="{f51dc04f-8995-6099-0852-0281e2725331}">
+        <p14:section name="2 · Observaciones 2025" id="{61f120e5-cd73-3034-85ec-dec39749f4c7}">
           <p14:sldIdLst>
             <p14:sldId id="257"/>
           </p14:sldIdLst>
         </p14:section>
-        <p14:section name="3 · Observaciones 2026" id="{ced64fc8-b254-a65e-7087-8f0096c56593}">
+        <p14:section name="3 · Observaciones 2026" id="{0da0406f-48c1-0cf5-d2f7-a9a0666b2a08}">
           <p14:sldIdLst>
             <p14:sldId id="258"/>
           </p14:sldIdLst>
@@ -4217,7 +4217,7 @@
                   <a:schemeClr val="tx1"/>
                 </a:solidFill>
               </a:rPr>
-              <a:t>Inducción sobre partidas de EEFF</a:t>
+              <a:t>Inducción sobre estados financieros</a:t>
             </a:r>
             <a:endParaRPr lang="en-US" sz="950" dirty="0"/>
           </a:p>
@@ -4341,7 +4341,7 @@
                   <a:schemeClr val="tx1"/>
                 </a:solidFill>
               </a:rPr>
-              <a:t>Estatutos vs. Código de GC</a:t>
+              <a:t>Integración de Comités de Apoyo</a:t>
             </a:r>
             <a:endParaRPr lang="en-US" sz="950" dirty="0"/>
           </a:p>
@@ -5043,7 +5043,7 @@
                   <a:schemeClr val="tx1"/>
                 </a:solidFill>
               </a:rPr>
-              <a:t>ADR / Jefe de Riesgos</a:t>
+              <a:t>Gerencia General / Jefe de Administración de Riesgos</a:t>
             </a:r>
             <a:endParaRPr lang="en-US" sz="1000" dirty="0"/>
           </a:p>
@@ -5074,7 +5074,7 @@
                   <a:schemeClr val="tx1"/>
                 </a:solidFill>
               </a:rPr>
-              <a:t>Se creará la política: Comité de Riesgos y aprobación del Consejo</a:t>
+              <a:t>Se creará la política para aprobación del Consejo de Administración</a:t>
             </a:r>
             <a:endParaRPr lang="en-US" sz="1000" dirty="0"/>
           </a:p>
@@ -5258,7 +5258,7 @@
                   <a:schemeClr val="tx1"/>
                 </a:solidFill>
               </a:rPr>
-              <a:t>ADR / Jefe de Riesgos</a:t>
+              <a:t>Gerencia General / Jefe de Administración de Riesgos</a:t>
             </a:r>
             <a:endParaRPr lang="en-US" sz="1000" dirty="0"/>
           </a:p>
@@ -5289,7 +5289,7 @@
                   <a:schemeClr val="tx1"/>
                 </a:solidFill>
               </a:rPr>
-              <a:t>Acta CA 2579 (28/04/2025): convenio sin efecto y fechas de inducción aprobadas</a:t>
+              <a:t>Acta 2579 del Consejo de Administración: fechas de inducción aprobadas</a:t>
             </a:r>
             <a:endParaRPr lang="en-US" sz="1000" dirty="0"/>
           </a:p>
@@ -5473,7 +5473,7 @@
                   <a:schemeClr val="tx1"/>
                 </a:solidFill>
               </a:rPr>
-              <a:t>ADR / Jefe de Riesgos</a:t>
+              <a:t>Gerencia General / Jefe de Administración de Riesgos</a:t>
             </a:r>
             <a:endParaRPr lang="en-US" sz="1000" dirty="0"/>
           </a:p>
@@ -5705,7 +5705,7 @@
                   <a:schemeClr val="tx1"/>
                 </a:solidFill>
               </a:rPr>
-              <a:t>Jefe de Administración de Riesgos</a:t>
+              <a:t>Gerencia General / Jefe de Administración de Riesgos</a:t>
             </a:r>
             <a:endParaRPr lang="en-US" sz="1000" dirty="0"/>
           </a:p>
@@ -5920,7 +5920,7 @@
                   <a:schemeClr val="tx1"/>
                 </a:solidFill>
               </a:rPr>
-              <a:t>ADR, Auditoría Interna, G. Financiera, Seg. de la Información y G. Administrativa</a:t>
+              <a:t>Gerencia General / Jefe de Administración de Riesgos, Auditoría Interna, Gerencia de Finanzas, Seguridad de la Información y Gerencia Administrativa</a:t>
             </a:r>
             <a:endParaRPr lang="en-US" sz="1000" dirty="0"/>
           </a:p>
@@ -6183,7 +6183,7 @@
                   <a:schemeClr val="tx1"/>
                 </a:solidFill>
               </a:rPr>
-              <a:t>Se remitieron resoluciones y acuerdos del CA de cada feria</a:t>
+              <a:t>Se enviaron resoluciones y acuerdos del Consejo de cada feria</a:t>
             </a:r>
             <a:endParaRPr lang="en-US" sz="1000" dirty="0"/>
           </a:p>
@@ -6367,7 +6367,7 @@
                   <a:schemeClr val="tx1"/>
                 </a:solidFill>
               </a:rPr>
-              <a:t>ADR / Jefe de Riesgos</a:t>
+              <a:t>Gerencia General / Jefe de Administración de Riesgos</a:t>
             </a:r>
             <a:endParaRPr lang="en-US" sz="1000" dirty="0"/>
           </a:p>
@@ -6582,7 +6582,7 @@
                   <a:schemeClr val="tx1"/>
                 </a:solidFill>
               </a:rPr>
-              <a:t>Gerencia Administrativa / Gerente Administrativa</a:t>
+              <a:t>Gerencia Administrativa</a:t>
             </a:r>
             <a:endParaRPr lang="en-US" sz="1000" dirty="0"/>
           </a:p>
@@ -6613,7 +6613,7 @@
                   <a:schemeClr val="tx1"/>
                 </a:solidFill>
               </a:rPr>
-              <a:t>Firmas de Mercadeo y Gerencia General; contrato DLF terminado</a:t>
+              <a:t>Firmas de Mercadeo y Gerencia General; contrato terminado</a:t>
             </a:r>
             <a:endParaRPr lang="en-US" sz="1000" dirty="0"/>
           </a:p>
@@ -6797,7 +6797,7 @@
                   <a:schemeClr val="tx1"/>
                 </a:solidFill>
               </a:rPr>
-              <a:t>Jefe de Administración de Riesgos</a:t>
+              <a:t>Gerencia General / Jefe de Administración de Riesgos</a:t>
             </a:r>
             <a:endParaRPr lang="en-US" sz="1000" dirty="0"/>
           </a:p>
@@ -6828,7 +6828,7 @@
                   <a:schemeClr val="tx1"/>
                 </a:solidFill>
               </a:rPr>
-              <a:t>CA suspendió el Comité Sociocultural (Acta 2576, 07/04/2025)</a:t>
+              <a:t>El Consejo de Administración suspendió el Comité Sociocultural (Acta 2576)</a:t>
             </a:r>
             <a:endParaRPr lang="en-US" sz="1000" dirty="0"/>
           </a:p>
@@ -7320,7 +7320,7 @@
                   <a:schemeClr val="tx1"/>
                 </a:solidFill>
               </a:rPr>
-              <a:t>Falta de inducción sobre partidas relevantes de EEFF a nuevos miembros</a:t>
+              <a:t>Falta de inducción sobre estados financieros a nuevos miembros</a:t>
             </a:r>
             <a:endParaRPr lang="en-US" sz="1150" dirty="0"/>
           </a:p>
@@ -7718,7 +7718,7 @@
                   <a:schemeClr val="tx1"/>
                 </a:solidFill>
               </a:rPr>
-              <a:t>Talento Humano · Depto. de Procesos</a:t>
+              <a:t>Talento Humano · Departamento de Procesos</a:t>
             </a:r>
             <a:endParaRPr lang="en-US" sz="1000" dirty="0"/>
           </a:p>
@@ -7790,7 +7790,7 @@
                   <a:schemeClr val="accent5"/>
                 </a:solidFill>
               </a:rPr>
-              <a:t>Respuesta: Se elaborará la Política de Retribución para aprobación del CA</a:t>
+              <a:t>Respuesta: Se elaborará la Política de Retribución para aprobación del Consejo</a:t>
             </a:r>
             <a:endParaRPr lang="en-US" sz="950" dirty="0"/>
           </a:p>
@@ -8369,7 +8369,7 @@
                   <a:schemeClr val="tx1"/>
                 </a:solidFill>
               </a:rPr>
-              <a:t>Gerencia Administrativa · Jefe de Educación y Resp. Social</a:t>
+              <a:t>Gerencia Administrativa · Jefe de Educación y Responsabilidad Social</a:t>
             </a:r>
             <a:endParaRPr lang="en-US" sz="1000" dirty="0"/>
           </a:p>
@@ -8586,7 +8586,7 @@
                   <a:schemeClr val="tx1"/>
                 </a:solidFill>
               </a:rPr>
-              <a:t>Gerencia Administrativa · Jefatura de Educación y Resp. Social</a:t>
+              <a:t>Gerencia Administrativa · Jefatura de Educación y Responsabilidad Social</a:t>
             </a:r>
             <a:endParaRPr lang="en-US" sz="1000" dirty="0"/>
           </a:p>
@@ -9430,7 +9430,7 @@
                   <a:schemeClr val="tx1"/>
                 </a:solidFill>
               </a:rPr>
-              <a:t>RIT y Manual de Compras en proceso · Reglamento del Comité de Auditoría aprobado (28/08/2026) y enviado al CA (05/10/2026)</a:t>
+              <a:t>RIT y Manual de Compras en proceso · Reglamento del Comité de Auditoría aprobado (28/08/2026) y enviado al Consejo (05/10/2026)</a:t>
             </a:r>
             <a:endParaRPr lang="en-US" sz="950" dirty="0"/>
           </a:p>

</xml_diff>

<commit_message>
Slide 1: 2025 visit ends at closing act (04/07/2025); note SSF receipt of descargos
Co-Authored-By: Claude Opus 5.5 <noreply@anthropic.com>
Claude-Session: https://claude.ai/code/session_01F1WXR13Nv8neEtLhaK3ELa
</commit_message>
<xml_diff>
--- a/supervision-gobierno-corporativo/Supervision_GC_SSF_COMEDICA_2025-2026.pptx
+++ b/supervision-gobierno-corporativo/Supervision_GC_SSF_COMEDICA_2025-2026.pptx
@@ -109,17 +109,17 @@
   <p:extLst>
     <p:ext uri="{521415D9-36F7-43E2-AB2F-B90AF26B5E84}">
       <p14:sectionLst xmlns:p14="http://schemas.microsoft.com/office/powerpoint/2010/main">
-        <p14:section name="1 · Resumen de circulares SSF" id="{d4bc93ea-717b-1db4-cd05-3e25cc7e6455}">
+        <p14:section name="1 · Resumen de circulares SSF" id="{274dc936-8f47-9020-68c2-a3006cb3f2dd}">
           <p14:sldIdLst>
             <p14:sldId id="256"/>
           </p14:sldIdLst>
         </p14:section>
-        <p14:section name="2 · Observaciones 2025" id="{61f120e5-cd73-3034-85ec-dec39749f4c7}">
+        <p14:section name="2 · Observaciones 2025" id="{900813a9-6b02-a453-8ef4-21ed10ae526d}">
           <p14:sldIdLst>
             <p14:sldId id="257"/>
           </p14:sldIdLst>
         </p14:section>
-        <p14:section name="3 · Observaciones 2026" id="{0da0406f-48c1-0cf5-d2f7-a9a0666b2a08}">
+        <p14:section name="3 · Observaciones 2026" id="{b0d7eb78-6bba-0edc-3e48-97ffc1d1f42c}">
           <p14:sldIdLst>
             <p14:sldId id="258"/>
           </p14:sldIdLst>
@@ -528,7 +528,7 @@
           <a:p>
             <a:r>
               <a:rPr lang="en-US" dirty="0"/>
-              <a:t>Cuatro circulares de la SSF. Cada año la SSF primero notifica el nombramiento de la visita ampliada y luego remite los resultados preliminares. 2025: Circular 17003 con 9 observaciones. 2026: Circular 22741 con 7 observaciones nuevas (Anexo A) y seguimiento a 2 de las 9 observaciones de 2025 (Anexo B): la obs. 3 no superada y la obs. 5 parcialmente superada.</a:t>
+              <a:t>Cuatro circulares de la SSF. Cada año la SSF primero notifica el nombramiento de la visita ampliada y luego remite los resultados preliminares. 2025: visita del 19/05/2025 al 04/07/2025 (Acta de Cierre de Visita); Circular 17003 con 9 observaciones; descargos recibidos por la SSF el 18/11/2025 a las 5:19 p. m. (constancia de recepción, archivo RESPUESTA SSF NOTA DS-SABAO-BCS-BC-17003). 2026: Circular 22741 con 7 observaciones nuevas (Anexo A) y seguimiento a 2 de las 9 observaciones de 2025 (Anexo B): la obs. 3 no superada y la obs. 5 parcialmente superada.</a:t>
             </a:r>
             <a:endParaRPr lang="en-US" dirty="0"/>
           </a:p>
@@ -1936,7 +1936,7 @@
                   <a:schemeClr val="bg1"/>
                 </a:solidFill>
               </a:rPr>
-              <a:t>INFORME</a:t>
+              <a:t>ACTA DE CIERRE</a:t>
             </a:r>
             <a:endParaRPr lang="en-US" sz="800" dirty="0"/>
           </a:p>
@@ -1975,7 +1975,7 @@
                 <a:ea typeface="Cambria" pitchFamily="34" charset="-122"/>
                 <a:cs typeface="Cambria" pitchFamily="34" charset="-120"/>
               </a:rPr>
-              <a:t>05</a:t>
+              <a:t>04</a:t>
             </a:r>
             <a:endParaRPr lang="en-US" sz="2600" dirty="0"/>
           </a:p>
@@ -2011,7 +2011,7 @@
                   <a:schemeClr val="bg1"/>
                 </a:solidFill>
               </a:rPr>
-              <a:t>NOV 2025</a:t>
+              <a:t>JUL 2025</a:t>
             </a:r>
             <a:endParaRPr lang="en-US" sz="1000" dirty="0"/>
           </a:p>

</xml_diff>

<commit_message>
Slide 1: show closing act date in 2025 appointment card
Co-Authored-By: Claude Opus 5.5 <noreply@anthropic.com>
Claude-Session: https://claude.ai/code/session_01F1WXR13Nv8neEtLhaK3ELa
</commit_message>
<xml_diff>
--- a/supervision-gobierno-corporativo/Supervision_GC_SSF_COMEDICA_2025-2026.pptx
+++ b/supervision-gobierno-corporativo/Supervision_GC_SSF_COMEDICA_2025-2026.pptx
@@ -109,17 +109,17 @@
   <p:extLst>
     <p:ext uri="{521415D9-36F7-43E2-AB2F-B90AF26B5E84}">
       <p14:sectionLst xmlns:p14="http://schemas.microsoft.com/office/powerpoint/2010/main">
-        <p14:section name="1 · Resumen de circulares SSF" id="{274dc936-8f47-9020-68c2-a3006cb3f2dd}">
+        <p14:section name="1 · Resumen de circulares SSF" id="{001a14f8-15c8-3251-b2a6-5d2391b2f99c}">
           <p14:sldIdLst>
             <p14:sldId id="256"/>
           </p14:sldIdLst>
         </p14:section>
-        <p14:section name="2 · Observaciones 2025" id="{900813a9-6b02-a453-8ef4-21ed10ae526d}">
+        <p14:section name="2 · Observaciones 2025" id="{1f8f54c3-2083-665f-648f-595b44268cff}">
           <p14:sldIdLst>
             <p14:sldId id="257"/>
           </p14:sldIdLst>
         </p14:section>
-        <p14:section name="3 · Observaciones 2026" id="{b0d7eb78-6bba-0edc-3e48-97ffc1d1f42c}">
+        <p14:section name="3 · Observaciones 2026" id="{f056e2df-fa4f-64fb-6513-0ac09d03959e}">
           <p14:sldIdLst>
             <p14:sldId id="258"/>
           </p14:sldIdLst>
@@ -2262,7 +2262,7 @@
                   <a:schemeClr val="accent5"/>
                 </a:solidFill>
               </a:rPr>
-              <a:t>Norma  </a:t>
+              <a:t>Acta de cierre  </a:t>
             </a:r>
             <a:pPr indent="0" marL="0">
               <a:buNone/>
@@ -2273,7 +2273,7 @@
                   <a:schemeClr val="tx1"/>
                 </a:solidFill>
               </a:rPr>
-              <a:t>NRP-17</a:t>
+              <a:t>04/07/2025</a:t>
             </a:r>
             <a:endParaRPr lang="en-US" sz="1050" dirty="0"/>
           </a:p>

</xml_diff>

<commit_message>
Slide 1: add 2026 visit closing act date (22/09/2026)
Co-Authored-By: Claude Opus 5.5 <noreply@anthropic.com>
Claude-Session: https://claude.ai/code/session_01F1WXR13Nv8neEtLhaK3ELa
</commit_message>
<xml_diff>
--- a/supervision-gobierno-corporativo/Supervision_GC_SSF_COMEDICA_2025-2026.pptx
+++ b/supervision-gobierno-corporativo/Supervision_GC_SSF_COMEDICA_2025-2026.pptx
@@ -304,7 +304,7 @@
           <a:p>
             <a:r>
               <a:rPr lang="en-US" dirty="0"/>
-              <a:t>Cuatro circulares de la SSF. Cada año la SSF primero notifica el nombramiento de la visita ampliada y luego remite los resultados preliminares. 2025: visita del 19/05/2025 al 04/07/2025 (Acta de Cierre de Visita); Circular 17003 con 9 observaciones; descargos recibidos por la SSF el 18/11/2025 a las 5:19 p. m. (constancia de recepción). 2026: Circular 22741 con 7 observaciones nuevas (Anexo A) y seguimiento a 2 de las 9 observaciones de 2025 (Anexo B): la obs. 3 no superada y la obs. 5 parcialmente superada.</a:t>
+              <a:t>Cuatro circulares de la SSF. Cada año la SSF primero notifica el nombramiento de la visita ampliada y luego remite los resultados preliminares. 2025: visita del 19/05/2025 al 04/07/2025 (Acta de Cierre de Visita); Circular 17003 con 9 observaciones; descargos recibidos por la SSF el 18/11/2025 a las 5:19 p. m. (constancia de recepción). 2026: visita del 21/08/2026 al 22/09/2026 (Acta de Cierre de Visita); Circular 22741 con 7 observaciones nuevas (Anexo A) y seguimiento a 2 de las 9 observaciones de 2025 (Anexo B): la obs. 3 no superada y la obs. 5 parcialmente superada.</a:t>
             </a:r>
           </a:p>
         </p:txBody>
@@ -3090,7 +3090,7 @@
                   <a:schemeClr val="bg1"/>
                 </a:solidFill>
               </a:rPr>
-              <a:t>INFORME</a:t>
+              <a:t>ACTA DE CIERRE</a:t>
             </a:r>
             <a:endParaRPr lang="en-US" sz="800" dirty="0"/>
           </a:p>
@@ -3129,7 +3129,7 @@
                 <a:ea typeface="Cambria" pitchFamily="34" charset="-122"/>
                 <a:cs typeface="Cambria" pitchFamily="34" charset="-120"/>
               </a:rPr>
-              <a:t>09</a:t>
+              <a:t>22</a:t>
             </a:r>
             <a:endParaRPr lang="en-US" sz="2600" dirty="0"/>
           </a:p>
@@ -3165,7 +3165,7 @@
                   <a:schemeClr val="bg1"/>
                 </a:solidFill>
               </a:rPr>
-              <a:t>OCT 2026</a:t>
+              <a:t>SEP 2026</a:t>
             </a:r>
             <a:endParaRPr lang="en-US" sz="1000" dirty="0"/>
           </a:p>
@@ -3431,7 +3431,7 @@
                   <a:schemeClr val="accent5"/>
                 </a:solidFill>
               </a:rPr>
-              <a:t>Norma  </a:t>
+              <a:t>Acta de cierre  </a:t>
             </a:r>
             <a:r>
               <a:rPr lang="en-US" sz="1050" b="1" dirty="0">
@@ -3439,7 +3439,7 @@
                   <a:schemeClr val="tx1"/>
                 </a:solidFill>
               </a:rPr>
-              <a:t>NRP-17</a:t>
+              <a:t>22/09/2026</a:t>
             </a:r>
             <a:endParaRPr lang="en-US" sz="1050" dirty="0"/>
           </a:p>

</xml_diff>

<commit_message>
Slide 1: 2026 results card shows 7 new and 2 follow-up counts with dates beside
Co-Authored-By: Claude Opus 5.5 <noreply@anthropic.com>
Claude-Session: https://claude.ai/code/session_01F1WXR13Nv8neEtLhaK3ELa
</commit_message>
<xml_diff>
--- a/supervision-gobierno-corporativo/Supervision_GC_SSF_COMEDICA_2025-2026.pptx
+++ b/supervision-gobierno-corporativo/Supervision_GC_SSF_COMEDICA_2025-2026.pptx
@@ -3545,7 +3545,7 @@
                   <a:schemeClr val="bg1"/>
                 </a:solidFill>
               </a:rPr>
-              <a:t>RECEPCIÓN</a:t>
+              <a:t>ANEXO A</a:t>
             </a:r>
             <a:endParaRPr lang="en-US" sz="800" dirty="0"/>
           </a:p>
@@ -3584,7 +3584,7 @@
                 <a:ea typeface="Cambria" pitchFamily="34" charset="-122"/>
                 <a:cs typeface="Cambria" pitchFamily="34" charset="-120"/>
               </a:rPr>
-              <a:t>09</a:t>
+              <a:t>7</a:t>
             </a:r>
             <a:endParaRPr lang="en-US" sz="2600" dirty="0"/>
           </a:p>
@@ -3620,7 +3620,7 @@
                   <a:schemeClr val="bg1"/>
                 </a:solidFill>
               </a:rPr>
-              <a:t>OCT 2026</a:t>
+              <a:t>NUEVAS</a:t>
             </a:r>
             <a:endParaRPr lang="en-US" sz="1000" dirty="0"/>
           </a:p>
@@ -3656,7 +3656,7 @@
                   <a:schemeClr val="bg1"/>
                 </a:solidFill>
               </a:rPr>
-              <a:t>VENCE APROX.</a:t>
+              <a:t>ANEXO B</a:t>
             </a:r>
             <a:endParaRPr lang="en-US" sz="800" dirty="0"/>
           </a:p>
@@ -3695,7 +3695,7 @@
                 <a:ea typeface="Cambria" pitchFamily="34" charset="-122"/>
                 <a:cs typeface="Cambria" pitchFamily="34" charset="-120"/>
               </a:rPr>
-              <a:t>23</a:t>
+              <a:t>2</a:t>
             </a:r>
             <a:endParaRPr lang="en-US" sz="2600" dirty="0"/>
           </a:p>
@@ -3726,12 +3726,12 @@
               <a:buNone/>
             </a:pPr>
             <a:r>
-              <a:rPr lang="en-US" sz="1000" b="1" kern="0" spc="100" dirty="0">
+              <a:rPr lang="en-US" sz="850" b="1" kern="0" spc="100" dirty="0">
                 <a:solidFill>
                   <a:schemeClr val="bg1"/>
                 </a:solidFill>
               </a:rPr>
-              <a:t>OCT 2026</a:t>
+              <a:t>SEGUIMIENTO</a:t>
             </a:r>
             <a:endParaRPr lang="en-US" sz="1000" dirty="0"/>
           </a:p>
@@ -3876,381 +3876,6 @@
           <a:lstStyle/>
           <a:p>
             <a:endParaRPr lang="es-SV"/>
-          </a:p>
-        </p:txBody>
-      </p:sp>
-      <p:sp>
-        <p:nvSpPr>
-          <p:cNvPr id="67" name="Grupo 2026-2-0"/>
-          <p:cNvSpPr txBox="1"/>
-          <p:nvPr/>
-        </p:nvSpPr>
-        <p:spPr>
-          <a:xfrm>
-            <a:off x="7406640" y="4736592"/>
-            <a:ext cx="2194560" cy="201168"/>
-          </a:xfrm>
-          <a:prstGeom prst="rect">
-            <a:avLst/>
-          </a:prstGeom>
-          <a:noFill/>
-          <a:ln/>
-        </p:spPr>
-        <p:txBody>
-          <a:bodyPr wrap="square" lIns="0" tIns="0" rIns="0" bIns="0" rtlCol="0" anchor="t"/>
-          <a:lstStyle/>
-          <a:p>
-            <a:pPr marL="0" indent="0">
-              <a:buNone/>
-            </a:pPr>
-            <a:r>
-              <a:rPr lang="en-US" sz="900" b="1" kern="0" spc="100" dirty="0">
-                <a:solidFill>
-                  <a:schemeClr val="accent2"/>
-                </a:solidFill>
-              </a:rPr>
-              <a:t>7 NUEVAS · ANEXO A</a:t>
-            </a:r>
-            <a:endParaRPr lang="en-US" sz="900" dirty="0"/>
-          </a:p>
-        </p:txBody>
-      </p:sp>
-      <p:sp>
-        <p:nvSpPr>
-          <p:cNvPr id="68" name="Lista 2026-2-0"/>
-          <p:cNvSpPr txBox="1"/>
-          <p:nvPr/>
-        </p:nvSpPr>
-        <p:spPr>
-          <a:xfrm>
-            <a:off x="7406640" y="4983480"/>
-            <a:ext cx="2176272" cy="1234440"/>
-          </a:xfrm>
-          <a:prstGeom prst="rect">
-            <a:avLst/>
-          </a:prstGeom>
-          <a:noFill/>
-          <a:ln/>
-        </p:spPr>
-        <p:txBody>
-          <a:bodyPr wrap="square" lIns="0" tIns="0" rIns="0" bIns="0" rtlCol="0" anchor="t"/>
-          <a:lstStyle/>
-          <a:p>
-            <a:pPr marL="0" indent="0">
-              <a:spcAft>
-                <a:spcPts val="100"/>
-              </a:spcAft>
-              <a:buNone/>
-            </a:pPr>
-            <a:r>
-              <a:rPr lang="en-US" sz="950" b="1" dirty="0">
-                <a:solidFill>
-                  <a:schemeClr val="accent2"/>
-                </a:solidFill>
-              </a:rPr>
-              <a:t>1  </a:t>
-            </a:r>
-            <a:r>
-              <a:rPr lang="en-US" sz="950" dirty="0">
-                <a:solidFill>
-                  <a:schemeClr val="tx1"/>
-                </a:solidFill>
-              </a:rPr>
-              <a:t>Inducción sobre estados financieros</a:t>
-            </a:r>
-            <a:endParaRPr lang="en-US" sz="950" dirty="0"/>
-          </a:p>
-          <a:p>
-            <a:pPr marL="0" indent="0">
-              <a:spcAft>
-                <a:spcPts val="100"/>
-              </a:spcAft>
-              <a:buNone/>
-            </a:pPr>
-            <a:r>
-              <a:rPr lang="en-US" sz="950" b="1" dirty="0">
-                <a:solidFill>
-                  <a:schemeClr val="accent2"/>
-                </a:solidFill>
-              </a:rPr>
-              <a:t>2  </a:t>
-            </a:r>
-            <a:r>
-              <a:rPr lang="en-US" sz="950" dirty="0">
-                <a:solidFill>
-                  <a:schemeClr val="tx1"/>
-                </a:solidFill>
-              </a:rPr>
-              <a:t>Certificación del Código de Conducta</a:t>
-            </a:r>
-            <a:endParaRPr lang="en-US" sz="950" dirty="0"/>
-          </a:p>
-          <a:p>
-            <a:pPr marL="0" indent="0">
-              <a:spcAft>
-                <a:spcPts val="100"/>
-              </a:spcAft>
-              <a:buNone/>
-            </a:pPr>
-            <a:r>
-              <a:rPr lang="en-US" sz="950" b="1" dirty="0">
-                <a:solidFill>
-                  <a:schemeClr val="accent2"/>
-                </a:solidFill>
-              </a:rPr>
-              <a:t>3  </a:t>
-            </a:r>
-            <a:r>
-              <a:rPr lang="en-US" sz="950" dirty="0">
-                <a:solidFill>
-                  <a:schemeClr val="tx1"/>
-                </a:solidFill>
-              </a:rPr>
-              <a:t>Políticas sin aprobar por el Consejo</a:t>
-            </a:r>
-            <a:endParaRPr lang="en-US" sz="950" dirty="0"/>
-          </a:p>
-          <a:p>
-            <a:pPr marL="0" indent="0">
-              <a:spcAft>
-                <a:spcPts val="100"/>
-              </a:spcAft>
-              <a:buNone/>
-            </a:pPr>
-            <a:r>
-              <a:rPr lang="en-US" sz="950" b="1" dirty="0">
-                <a:solidFill>
-                  <a:schemeClr val="accent2"/>
-                </a:solidFill>
-              </a:rPr>
-              <a:t>4  </a:t>
-            </a:r>
-            <a:r>
-              <a:rPr lang="en-US" sz="950" dirty="0">
-                <a:solidFill>
-                  <a:schemeClr val="tx1"/>
-                </a:solidFill>
-              </a:rPr>
-              <a:t>Sitio web de comités desactualizado</a:t>
-            </a:r>
-            <a:endParaRPr lang="en-US" sz="950" dirty="0"/>
-          </a:p>
-          <a:p>
-            <a:pPr marL="0" indent="0">
-              <a:spcAft>
-                <a:spcPts val="100"/>
-              </a:spcAft>
-              <a:buNone/>
-            </a:pPr>
-            <a:r>
-              <a:rPr lang="en-US" sz="950" b="1" dirty="0">
-                <a:solidFill>
-                  <a:schemeClr val="accent2"/>
-                </a:solidFill>
-              </a:rPr>
-              <a:t>5  </a:t>
-            </a:r>
-            <a:r>
-              <a:rPr lang="en-US" sz="950" dirty="0">
-                <a:solidFill>
-                  <a:schemeClr val="tx1"/>
-                </a:solidFill>
-              </a:rPr>
-              <a:t>Integración de Comités de Apoyo</a:t>
-            </a:r>
-            <a:endParaRPr lang="en-US" sz="950" dirty="0"/>
-          </a:p>
-          <a:p>
-            <a:pPr marL="0" indent="0">
-              <a:spcAft>
-                <a:spcPts val="100"/>
-              </a:spcAft>
-              <a:buNone/>
-            </a:pPr>
-            <a:r>
-              <a:rPr lang="en-US" sz="950" b="1" dirty="0">
-                <a:solidFill>
-                  <a:schemeClr val="accent2"/>
-                </a:solidFill>
-              </a:rPr>
-              <a:t>6  </a:t>
-            </a:r>
-            <a:r>
-              <a:rPr lang="en-US" sz="950" dirty="0">
-                <a:solidFill>
-                  <a:schemeClr val="tx1"/>
-                </a:solidFill>
-              </a:rPr>
-              <a:t>Reglamento del Fondo de Educación</a:t>
-            </a:r>
-            <a:endParaRPr lang="en-US" sz="950" dirty="0"/>
-          </a:p>
-          <a:p>
-            <a:pPr marL="0" indent="0">
-              <a:spcAft>
-                <a:spcPts val="100"/>
-              </a:spcAft>
-              <a:buNone/>
-            </a:pPr>
-            <a:r>
-              <a:rPr lang="en-US" sz="950" b="1" dirty="0">
-                <a:solidFill>
-                  <a:schemeClr val="accent2"/>
-                </a:solidFill>
-              </a:rPr>
-              <a:t>7  </a:t>
-            </a:r>
-            <a:r>
-              <a:rPr lang="en-US" sz="950" dirty="0">
-                <a:solidFill>
-                  <a:schemeClr val="tx1"/>
-                </a:solidFill>
-              </a:rPr>
-              <a:t>Transparencia ante la Asamblea</a:t>
-            </a:r>
-            <a:endParaRPr lang="en-US" sz="950" dirty="0"/>
-          </a:p>
-        </p:txBody>
-      </p:sp>
-      <p:sp>
-        <p:nvSpPr>
-          <p:cNvPr id="69" name="Grupo 2026-2-1"/>
-          <p:cNvSpPr txBox="1"/>
-          <p:nvPr/>
-        </p:nvSpPr>
-        <p:spPr>
-          <a:xfrm>
-            <a:off x="9692640" y="4736592"/>
-            <a:ext cx="1721815" cy="201168"/>
-          </a:xfrm>
-          <a:prstGeom prst="rect">
-            <a:avLst/>
-          </a:prstGeom>
-          <a:noFill/>
-          <a:ln/>
-        </p:spPr>
-        <p:txBody>
-          <a:bodyPr wrap="square" lIns="0" tIns="0" rIns="0" bIns="0" rtlCol="0" anchor="t"/>
-          <a:lstStyle/>
-          <a:p>
-            <a:pPr marL="0" indent="0">
-              <a:buNone/>
-            </a:pPr>
-            <a:r>
-              <a:rPr lang="en-US" sz="900" b="1" kern="0" spc="100" dirty="0">
-                <a:solidFill>
-                  <a:schemeClr val="accent3"/>
-                </a:solidFill>
-              </a:rPr>
-              <a:t>2 EN SEGUIMIENTO</a:t>
-            </a:r>
-            <a:endParaRPr lang="en-US" sz="900" dirty="0"/>
-          </a:p>
-        </p:txBody>
-      </p:sp>
-      <p:sp>
-        <p:nvSpPr>
-          <p:cNvPr id="70" name="Lista 2026-2-1"/>
-          <p:cNvSpPr txBox="1"/>
-          <p:nvPr/>
-        </p:nvSpPr>
-        <p:spPr>
-          <a:xfrm>
-            <a:off x="9692640" y="4983480"/>
-            <a:ext cx="1703527" cy="1234440"/>
-          </a:xfrm>
-          <a:prstGeom prst="rect">
-            <a:avLst/>
-          </a:prstGeom>
-          <a:noFill/>
-          <a:ln/>
-        </p:spPr>
-        <p:txBody>
-          <a:bodyPr wrap="square" lIns="0" tIns="0" rIns="0" bIns="0" rtlCol="0" anchor="t"/>
-          <a:lstStyle/>
-          <a:p>
-            <a:pPr marL="0" indent="0">
-              <a:spcAft>
-                <a:spcPts val="300"/>
-              </a:spcAft>
-              <a:buNone/>
-            </a:pPr>
-            <a:r>
-              <a:rPr lang="en-US" sz="1000" b="1" dirty="0">
-                <a:solidFill>
-                  <a:schemeClr val="accent3"/>
-                </a:solidFill>
-              </a:rPr>
-              <a:t>Obs. 3  </a:t>
-            </a:r>
-            <a:r>
-              <a:rPr lang="en-US" sz="1000" dirty="0">
-                <a:solidFill>
-                  <a:schemeClr val="tx1"/>
-                </a:solidFill>
-              </a:rPr>
-              <a:t>Comités sin ejecutivos</a:t>
-            </a:r>
-            <a:endParaRPr lang="en-US" sz="1000" dirty="0"/>
-          </a:p>
-          <a:p>
-            <a:pPr marL="0" indent="0">
-              <a:spcAft>
-                <a:spcPts val="300"/>
-              </a:spcAft>
-              <a:buNone/>
-            </a:pPr>
-            <a:r>
-              <a:rPr lang="en-US" sz="950" b="1" dirty="0">
-                <a:solidFill>
-                  <a:schemeClr val="accent3"/>
-                </a:solidFill>
-              </a:rPr>
-              <a:t>No superada</a:t>
-            </a:r>
-            <a:endParaRPr lang="en-US" sz="1000" dirty="0"/>
-          </a:p>
-          <a:p>
-            <a:pPr marL="0" indent="0">
-              <a:spcAft>
-                <a:spcPts val="300"/>
-              </a:spcAft>
-              <a:buNone/>
-            </a:pPr>
-            <a:r>
-              <a:rPr lang="en-US" sz="1000" b="1" dirty="0">
-                <a:solidFill>
-                  <a:schemeClr val="accent3"/>
-                </a:solidFill>
-              </a:rPr>
-              <a:t>Obs. 5  </a:t>
-            </a:r>
-            <a:r>
-              <a:rPr lang="en-US" sz="1000" dirty="0">
-                <a:solidFill>
-                  <a:schemeClr val="tx1"/>
-                </a:solidFill>
-              </a:rPr>
-              <a:t>Normativa interna</a:t>
-            </a:r>
-            <a:endParaRPr lang="en-US" sz="1000" dirty="0"/>
-          </a:p>
-          <a:p>
-            <a:pPr marL="0" indent="0">
-              <a:spcAft>
-                <a:spcPts val="300"/>
-              </a:spcAft>
-              <a:buNone/>
-            </a:pPr>
-            <a:r>
-              <a:rPr lang="en-US" sz="950" b="1" dirty="0">
-                <a:solidFill>
-                  <a:schemeClr val="accent3"/>
-                </a:solidFill>
-              </a:rPr>
-              <a:t>Parcialmente superada</a:t>
-            </a:r>
-            <a:endParaRPr lang="en-US" sz="1000" dirty="0"/>
           </a:p>
         </p:txBody>
       </p:sp>
@@ -4445,6 +4070,169 @@
               <a:t>Visita de supervisión ampliada para evaluar el Gobierno Corporativo</a:t>
             </a:r>
             <a:endParaRPr lang="es-SV" sz="1400" noProof="0" dirty="0"/>
+          </a:p>
+        </p:txBody>
+      </p:sp>
+      <p:sp>
+        <p:nvSpPr>
+          <p:cNvPr id="79" name="Resumen Anexo A 2026"/>
+          <p:cNvSpPr txBox="1"/>
+          <p:nvPr/>
+        </p:nvSpPr>
+        <p:spPr>
+          <a:xfrm>
+            <a:off x="7406640" y="4773168"/>
+            <a:ext cx="4096512" cy="566928"/>
+          </a:xfrm>
+          <a:prstGeom prst="rect">
+            <a:avLst/>
+          </a:prstGeom>
+          <a:noFill/>
+        </p:spPr>
+        <p:txBody>
+          <a:bodyPr wrap="square" lIns="0" rIns="0" tIns="0" bIns="0">
+            <a:spAutoFit/>
+          </a:bodyPr>
+          <a:lstStyle/>
+          <a:p>
+            <a:r>
+              <a:rPr sz="1300" b="1">
+                <a:solidFill>
+                  <a:srgbClr val="1D7A4B"/>
+                </a:solidFill>
+              </a:rPr>
+              <a:t>7 observaciones nuevas</a:t>
+            </a:r>
+          </a:p>
+          <a:p>
+            <a:pPr>
+              <a:spcBef>
+                <a:spcPts val="300"/>
+              </a:spcBef>
+            </a:pPr>
+            <a:r>
+              <a:rPr sz="1050" b="0">
+                <a:solidFill>
+                  <a:srgbClr val="586579"/>
+                </a:solidFill>
+              </a:rPr>
+              <a:t>Recepción  </a:t>
+            </a:r>
+            <a:r>
+              <a:rPr sz="1050" b="1">
+                <a:solidFill>
+                  <a:srgbClr val="142033"/>
+                </a:solidFill>
+              </a:rPr>
+              <a:t>09/10/2026</a:t>
+            </a:r>
+            <a:r>
+              <a:rPr sz="1050" b="0">
+                <a:solidFill>
+                  <a:srgbClr val="586579"/>
+                </a:solidFill>
+              </a:rPr>
+              <a:t>   ·   Descargos vencen aprox.  </a:t>
+            </a:r>
+            <a:r>
+              <a:rPr sz="1050" b="1">
+                <a:solidFill>
+                  <a:srgbClr val="142033"/>
+                </a:solidFill>
+              </a:rPr>
+              <a:t>23/10/2026</a:t>
+            </a:r>
+          </a:p>
+        </p:txBody>
+      </p:sp>
+      <p:cxnSp>
+        <p:nvCxnSpPr>
+          <p:cNvPr id="80" name="Separador anexos 2026"/>
+          <p:cNvCxnSpPr/>
+          <p:nvPr/>
+        </p:nvCxnSpPr>
+        <p:spPr>
+          <a:xfrm>
+            <a:off x="7406640" y="5440680"/>
+            <a:ext cx="4096512" cy="0"/>
+          </a:xfrm>
+          <a:prstGeom prst="line">
+            <a:avLst/>
+          </a:prstGeom>
+          <a:ln w="9525">
+            <a:solidFill>
+              <a:srgbClr val="D9E0EA"/>
+            </a:solidFill>
+          </a:ln>
+        </p:spPr>
+        <p:style>
+          <a:lnRef idx="2">
+            <a:schemeClr val="accent1"/>
+          </a:lnRef>
+          <a:fillRef idx="0">
+            <a:schemeClr val="accent1"/>
+          </a:fillRef>
+          <a:effectRef idx="1">
+            <a:schemeClr val="accent1"/>
+          </a:effectRef>
+          <a:fontRef idx="minor">
+            <a:schemeClr val="tx1"/>
+          </a:fontRef>
+        </p:style>
+      </p:cxnSp>
+      <p:sp>
+        <p:nvSpPr>
+          <p:cNvPr id="81" name="Resumen Anexo B 2026"/>
+          <p:cNvSpPr txBox="1"/>
+          <p:nvPr/>
+        </p:nvSpPr>
+        <p:spPr>
+          <a:xfrm>
+            <a:off x="7406640" y="5559552"/>
+            <a:ext cx="4096512" cy="566928"/>
+          </a:xfrm>
+          <a:prstGeom prst="rect">
+            <a:avLst/>
+          </a:prstGeom>
+          <a:noFill/>
+        </p:spPr>
+        <p:txBody>
+          <a:bodyPr wrap="square" lIns="0" rIns="0" tIns="0" bIns="0">
+            <a:spAutoFit/>
+          </a:bodyPr>
+          <a:lstStyle/>
+          <a:p>
+            <a:r>
+              <a:rPr sz="1300" b="1">
+                <a:solidFill>
+                  <a:srgbClr val="B42318"/>
+                </a:solidFill>
+              </a:rPr>
+              <a:t>2 observaciones en seguimiento</a:t>
+            </a:r>
+          </a:p>
+          <a:p>
+            <a:pPr>
+              <a:spcBef>
+                <a:spcPts val="300"/>
+              </a:spcBef>
+            </a:pPr>
+            <a:r>
+              <a:rPr sz="1050" b="0">
+                <a:solidFill>
+                  <a:srgbClr val="586579"/>
+                </a:solidFill>
+              </a:rPr>
+              <a:t>Obs. 3 y 5 de 2025   ·   Plan de solución vence aprox.  </a:t>
+            </a:r>
+            <a:r>
+              <a:rPr sz="1050" b="1">
+                <a:solidFill>
+                  <a:srgbClr val="142033"/>
+                </a:solidFill>
+              </a:rPr>
+              <a:t>30/10/2026</a:t>
+            </a:r>
           </a:p>
         </p:txBody>
       </p:sp>

</xml_diff>

<commit_message>
Slide 1: 2025 results card shows counts with dates beside, like 2026
Co-Authored-By: Claude Opus 5.5 <noreply@anthropic.com>
Claude-Session: https://claude.ai/code/session_01F1WXR13Nv8neEtLhaK3ELa
</commit_message>
<xml_diff>
--- a/supervision-gobierno-corporativo/Supervision_GC_SSF_COMEDICA_2025-2026.pptx
+++ b/supervision-gobierno-corporativo/Supervision_GC_SSF_COMEDICA_2025-2026.pptx
@@ -2147,7 +2147,7 @@
                   <a:schemeClr val="bg1"/>
                 </a:solidFill>
               </a:rPr>
-              <a:t>RECEPCIÓN</a:t>
+              <a:t>RESULTADO</a:t>
             </a:r>
             <a:endParaRPr lang="en-US" sz="800" dirty="0"/>
           </a:p>
@@ -2186,7 +2186,7 @@
                 <a:ea typeface="Cambria" pitchFamily="34" charset="-122"/>
                 <a:cs typeface="Cambria" pitchFamily="34" charset="-120"/>
               </a:rPr>
-              <a:t>05</a:t>
+              <a:t>9</a:t>
             </a:r>
             <a:endParaRPr lang="en-US" sz="2600" dirty="0"/>
           </a:p>
@@ -2217,12 +2217,12 @@
               <a:buNone/>
             </a:pPr>
             <a:r>
-              <a:rPr lang="en-US" sz="1000" b="1" kern="0" spc="100" dirty="0">
+              <a:rPr lang="en-US" sz="800" b="1" kern="0" spc="100" dirty="0">
                 <a:solidFill>
                   <a:schemeClr val="bg1"/>
                 </a:solidFill>
               </a:rPr>
-              <a:t>NOV 2025</a:t>
+              <a:t>OBSERVACIONES</a:t>
             </a:r>
             <a:endParaRPr lang="en-US" sz="1000" dirty="0"/>
           </a:p>
@@ -2258,7 +2258,7 @@
                   <a:schemeClr val="bg1"/>
                 </a:solidFill>
               </a:rPr>
-              <a:t>DESCARGOS</a:t>
+              <a:t>VISITA 2026</a:t>
             </a:r>
             <a:endParaRPr lang="en-US" sz="800" dirty="0"/>
           </a:p>
@@ -2297,7 +2297,7 @@
                 <a:ea typeface="Cambria" pitchFamily="34" charset="-122"/>
                 <a:cs typeface="Cambria" pitchFamily="34" charset="-120"/>
               </a:rPr>
-              <a:t>18</a:t>
+              <a:t>2</a:t>
             </a:r>
             <a:endParaRPr lang="en-US" sz="2600" dirty="0"/>
           </a:p>
@@ -2328,12 +2328,12 @@
               <a:buNone/>
             </a:pPr>
             <a:r>
-              <a:rPr lang="en-US" sz="1000" b="1" kern="0" spc="100" dirty="0">
+              <a:rPr lang="en-US" sz="850" b="1" kern="0" spc="100" dirty="0">
                 <a:solidFill>
                   <a:schemeClr val="bg1"/>
                 </a:solidFill>
               </a:rPr>
-              <a:t>NOV 2025</a:t>
+              <a:t>SEGUIMIENTO</a:t>
             </a:r>
             <a:endParaRPr lang="en-US" sz="1000" dirty="0"/>
           </a:p>
@@ -2478,331 +2478,6 @@
           <a:lstStyle/>
           <a:p>
             <a:endParaRPr lang="es-SV"/>
-          </a:p>
-        </p:txBody>
-      </p:sp>
-      <p:sp>
-        <p:nvSpPr>
-          <p:cNvPr id="33" name="Grupo 2025-2-0"/>
-          <p:cNvSpPr txBox="1"/>
-          <p:nvPr/>
-        </p:nvSpPr>
-        <p:spPr>
-          <a:xfrm>
-            <a:off x="7406640" y="1691640"/>
-            <a:ext cx="4007815" cy="201168"/>
-          </a:xfrm>
-          <a:prstGeom prst="rect">
-            <a:avLst/>
-          </a:prstGeom>
-          <a:noFill/>
-          <a:ln/>
-        </p:spPr>
-        <p:txBody>
-          <a:bodyPr wrap="square" lIns="0" tIns="0" rIns="0" bIns="0" rtlCol="0" anchor="t"/>
-          <a:lstStyle/>
-          <a:p>
-            <a:pPr marL="0" indent="0">
-              <a:buNone/>
-            </a:pPr>
-            <a:r>
-              <a:rPr lang="en-US" sz="900" b="1" kern="0" spc="100" dirty="0">
-                <a:solidFill>
-                  <a:schemeClr val="accent1"/>
-                </a:solidFill>
-              </a:rPr>
-              <a:t>9 OBSERVACIONES</a:t>
-            </a:r>
-            <a:endParaRPr lang="en-US" sz="900" dirty="0"/>
-          </a:p>
-        </p:txBody>
-      </p:sp>
-      <p:sp>
-        <p:nvSpPr>
-          <p:cNvPr id="34" name="Lista 2025-2-0"/>
-          <p:cNvSpPr txBox="1"/>
-          <p:nvPr/>
-        </p:nvSpPr>
-        <p:spPr>
-          <a:xfrm>
-            <a:off x="7406640" y="1938528"/>
-            <a:ext cx="1939900" cy="1234440"/>
-          </a:xfrm>
-          <a:prstGeom prst="rect">
-            <a:avLst/>
-          </a:prstGeom>
-          <a:noFill/>
-          <a:ln/>
-        </p:spPr>
-        <p:txBody>
-          <a:bodyPr wrap="square" lIns="0" tIns="0" rIns="0" bIns="0" rtlCol="0" anchor="t"/>
-          <a:lstStyle/>
-          <a:p>
-            <a:pPr marL="0" indent="0">
-              <a:spcAft>
-                <a:spcPts val="300"/>
-              </a:spcAft>
-              <a:buNone/>
-            </a:pPr>
-            <a:r>
-              <a:rPr lang="en-US" sz="1000" b="1" dirty="0">
-                <a:solidFill>
-                  <a:schemeClr val="accent1"/>
-                </a:solidFill>
-              </a:rPr>
-              <a:t>1  </a:t>
-            </a:r>
-            <a:r>
-              <a:rPr lang="en-US" sz="1000" dirty="0">
-                <a:solidFill>
-                  <a:schemeClr val="tx1"/>
-                </a:solidFill>
-              </a:rPr>
-              <a:t>Política de Operaciones Vinculadas</a:t>
-            </a:r>
-            <a:endParaRPr lang="en-US" sz="1000" dirty="0"/>
-          </a:p>
-          <a:p>
-            <a:pPr marL="0" indent="0">
-              <a:spcAft>
-                <a:spcPts val="300"/>
-              </a:spcAft>
-              <a:buNone/>
-            </a:pPr>
-            <a:r>
-              <a:rPr lang="en-US" sz="1000" b="1" dirty="0">
-                <a:solidFill>
-                  <a:schemeClr val="accent1"/>
-                </a:solidFill>
-              </a:rPr>
-              <a:t>2  </a:t>
-            </a:r>
-            <a:r>
-              <a:rPr lang="en-US" sz="1000" dirty="0">
-                <a:solidFill>
-                  <a:schemeClr val="tx1"/>
-                </a:solidFill>
-              </a:rPr>
-              <a:t>Confidencialidad e inducción</a:t>
-            </a:r>
-            <a:endParaRPr lang="en-US" sz="1000" dirty="0"/>
-          </a:p>
-          <a:p>
-            <a:pPr marL="0" indent="0">
-              <a:spcAft>
-                <a:spcPts val="300"/>
-              </a:spcAft>
-              <a:buNone/>
-            </a:pPr>
-            <a:r>
-              <a:rPr lang="en-US" sz="1000" b="1" dirty="0">
-                <a:solidFill>
-                  <a:schemeClr val="accent3"/>
-                </a:solidFill>
-              </a:rPr>
-              <a:t>3  Comités sin personal ejecutivo</a:t>
-            </a:r>
-            <a:endParaRPr lang="en-US" sz="1000" dirty="0"/>
-          </a:p>
-          <a:p>
-            <a:pPr marL="0" indent="0">
-              <a:spcAft>
-                <a:spcPts val="300"/>
-              </a:spcAft>
-              <a:buNone/>
-            </a:pPr>
-            <a:r>
-              <a:rPr lang="en-US" sz="1000" b="1" dirty="0">
-                <a:solidFill>
-                  <a:schemeClr val="accent1"/>
-                </a:solidFill>
-              </a:rPr>
-              <a:t>4  </a:t>
-            </a:r>
-            <a:r>
-              <a:rPr lang="en-US" sz="1000" dirty="0">
-                <a:solidFill>
-                  <a:schemeClr val="tx1"/>
-                </a:solidFill>
-              </a:rPr>
-              <a:t>Pago de dietas</a:t>
-            </a:r>
-            <a:endParaRPr lang="en-US" sz="1000" dirty="0"/>
-          </a:p>
-          <a:p>
-            <a:pPr marL="0" indent="0">
-              <a:spcAft>
-                <a:spcPts val="300"/>
-              </a:spcAft>
-              <a:buNone/>
-            </a:pPr>
-            <a:r>
-              <a:rPr lang="en-US" sz="1000" b="1" dirty="0">
-                <a:solidFill>
-                  <a:schemeClr val="accent3"/>
-                </a:solidFill>
-              </a:rPr>
-              <a:t>5  Normativa interna desactualizada</a:t>
-            </a:r>
-            <a:endParaRPr lang="en-US" sz="1000" dirty="0"/>
-          </a:p>
-        </p:txBody>
-      </p:sp>
-      <p:sp>
-        <p:nvSpPr>
-          <p:cNvPr id="35" name="Lista 2025-2-1"/>
-          <p:cNvSpPr txBox="1"/>
-          <p:nvPr/>
-        </p:nvSpPr>
-        <p:spPr>
-          <a:xfrm>
-            <a:off x="9456268" y="1938528"/>
-            <a:ext cx="1939900" cy="1234440"/>
-          </a:xfrm>
-          <a:prstGeom prst="rect">
-            <a:avLst/>
-          </a:prstGeom>
-          <a:noFill/>
-          <a:ln/>
-        </p:spPr>
-        <p:txBody>
-          <a:bodyPr wrap="square" lIns="0" tIns="0" rIns="0" bIns="0" rtlCol="0" anchor="t"/>
-          <a:lstStyle/>
-          <a:p>
-            <a:pPr marL="0" indent="0">
-              <a:spcAft>
-                <a:spcPts val="300"/>
-              </a:spcAft>
-              <a:buNone/>
-            </a:pPr>
-            <a:r>
-              <a:rPr lang="en-US" sz="1000" b="1" dirty="0">
-                <a:solidFill>
-                  <a:schemeClr val="accent1"/>
-                </a:solidFill>
-              </a:rPr>
-              <a:t>6  </a:t>
-            </a:r>
-            <a:r>
-              <a:rPr lang="en-US" sz="1000" dirty="0">
-                <a:solidFill>
-                  <a:schemeClr val="tx1"/>
-                </a:solidFill>
-              </a:rPr>
-              <a:t>Soporte de Ferias de Crédito</a:t>
-            </a:r>
-            <a:endParaRPr lang="en-US" sz="1000" dirty="0"/>
-          </a:p>
-          <a:p>
-            <a:pPr marL="0" indent="0">
-              <a:spcAft>
-                <a:spcPts val="300"/>
-              </a:spcAft>
-              <a:buNone/>
-            </a:pPr>
-            <a:r>
-              <a:rPr lang="en-US" sz="1000" b="1" dirty="0">
-                <a:solidFill>
-                  <a:schemeClr val="accent1"/>
-                </a:solidFill>
-              </a:rPr>
-              <a:t>7  </a:t>
-            </a:r>
-            <a:r>
-              <a:rPr lang="en-US" sz="1000" dirty="0">
-                <a:solidFill>
-                  <a:schemeClr val="tx1"/>
-                </a:solidFill>
-              </a:rPr>
-              <a:t>Declaración jurada (NRP-75)</a:t>
-            </a:r>
-            <a:endParaRPr lang="en-US" sz="1000" dirty="0"/>
-          </a:p>
-          <a:p>
-            <a:pPr marL="0" indent="0">
-              <a:spcAft>
-                <a:spcPts val="300"/>
-              </a:spcAft>
-              <a:buNone/>
-            </a:pPr>
-            <a:r>
-              <a:rPr lang="en-US" sz="1000" b="1" dirty="0">
-                <a:solidFill>
-                  <a:schemeClr val="accent1"/>
-                </a:solidFill>
-              </a:rPr>
-              <a:t>8  </a:t>
-            </a:r>
-            <a:r>
-              <a:rPr lang="en-US" sz="1000" dirty="0">
-                <a:solidFill>
-                  <a:schemeClr val="tx1"/>
-                </a:solidFill>
-              </a:rPr>
-              <a:t>Manual de Compras</a:t>
-            </a:r>
-            <a:endParaRPr lang="en-US" sz="1000" dirty="0"/>
-          </a:p>
-          <a:p>
-            <a:pPr marL="0" indent="0">
-              <a:spcAft>
-                <a:spcPts val="300"/>
-              </a:spcAft>
-              <a:buNone/>
-            </a:pPr>
-            <a:r>
-              <a:rPr lang="en-US" sz="1000" b="1" dirty="0">
-                <a:solidFill>
-                  <a:schemeClr val="accent1"/>
-                </a:solidFill>
-              </a:rPr>
-              <a:t>9  </a:t>
-            </a:r>
-            <a:r>
-              <a:rPr lang="en-US" sz="1000" dirty="0">
-                <a:solidFill>
-                  <a:schemeClr val="tx1"/>
-                </a:solidFill>
-              </a:rPr>
-              <a:t>Uso del Fondo de Educación</a:t>
-            </a:r>
-            <a:endParaRPr lang="en-US" sz="1000" dirty="0"/>
-          </a:p>
-        </p:txBody>
-      </p:sp>
-      <p:sp>
-        <p:nvSpPr>
-          <p:cNvPr id="36" name="Nota rojo"/>
-          <p:cNvSpPr txBox="1"/>
-          <p:nvPr/>
-        </p:nvSpPr>
-        <p:spPr>
-          <a:xfrm>
-            <a:off x="9456268" y="2935224"/>
-            <a:ext cx="1939900" cy="201168"/>
-          </a:xfrm>
-          <a:prstGeom prst="rect">
-            <a:avLst/>
-          </a:prstGeom>
-          <a:noFill/>
-          <a:ln/>
-        </p:spPr>
-        <p:txBody>
-          <a:bodyPr wrap="square" lIns="0" tIns="0" rIns="0" bIns="0" rtlCol="0" anchor="t"/>
-          <a:lstStyle/>
-          <a:p>
-            <a:pPr marL="0" indent="0">
-              <a:buNone/>
-            </a:pPr>
-            <a:r>
-              <a:rPr lang="en-US" sz="900" i="1" dirty="0">
-                <a:solidFill>
-                  <a:schemeClr val="accent3"/>
-                </a:solidFill>
-              </a:rPr>
-              <a:t>En rojo: con seguimiento de la SSF en 2026</a:t>
-            </a:r>
-            <a:endParaRPr lang="en-US" sz="900" dirty="0"/>
           </a:p>
         </p:txBody>
       </p:sp>
@@ -4232,6 +3907,161 @@
                 </a:solidFill>
               </a:rPr>
               <a:t>30/10/2026</a:t>
+            </a:r>
+          </a:p>
+        </p:txBody>
+      </p:sp>
+      <p:sp>
+        <p:nvSpPr>
+          <p:cNvPr id="82" name="Resumen resultados 2025"/>
+          <p:cNvSpPr txBox="1"/>
+          <p:nvPr/>
+        </p:nvSpPr>
+        <p:spPr>
+          <a:xfrm>
+            <a:off x="7406640" y="1728216"/>
+            <a:ext cx="4096512" cy="566928"/>
+          </a:xfrm>
+          <a:prstGeom prst="rect">
+            <a:avLst/>
+          </a:prstGeom>
+          <a:noFill/>
+        </p:spPr>
+        <p:txBody>
+          <a:bodyPr wrap="square" lIns="0" rIns="0" tIns="0" bIns="0">
+            <a:spAutoFit/>
+          </a:bodyPr>
+          <a:lstStyle/>
+          <a:p>
+            <a:r>
+              <a:rPr sz="1300" b="1">
+                <a:solidFill>
+                  <a:srgbClr val="173A6E"/>
+                </a:solidFill>
+              </a:rPr>
+              <a:t>9 observaciones</a:t>
+            </a:r>
+          </a:p>
+          <a:p>
+            <a:pPr>
+              <a:spcBef>
+                <a:spcPts val="300"/>
+              </a:spcBef>
+            </a:pPr>
+            <a:r>
+              <a:rPr sz="1050" b="0">
+                <a:solidFill>
+                  <a:srgbClr val="586579"/>
+                </a:solidFill>
+              </a:rPr>
+              <a:t>Recepción  </a:t>
+            </a:r>
+            <a:r>
+              <a:rPr sz="1050" b="1">
+                <a:solidFill>
+                  <a:srgbClr val="142033"/>
+                </a:solidFill>
+              </a:rPr>
+              <a:t>05/11/2025</a:t>
+            </a:r>
+            <a:r>
+              <a:rPr sz="1050" b="0">
+                <a:solidFill>
+                  <a:srgbClr val="586579"/>
+                </a:solidFill>
+              </a:rPr>
+              <a:t>   ·   Descargos enviados  </a:t>
+            </a:r>
+            <a:r>
+              <a:rPr sz="1050" b="1">
+                <a:solidFill>
+                  <a:srgbClr val="142033"/>
+                </a:solidFill>
+              </a:rPr>
+              <a:t>18/11/2025</a:t>
+            </a:r>
+          </a:p>
+        </p:txBody>
+      </p:sp>
+      <p:cxnSp>
+        <p:nvCxnSpPr>
+          <p:cNvPr id="83" name="Separador resultados 2025"/>
+          <p:cNvCxnSpPr/>
+          <p:nvPr/>
+        </p:nvCxnSpPr>
+        <p:spPr>
+          <a:xfrm>
+            <a:off x="7406640" y="2395728"/>
+            <a:ext cx="4096512" cy="0"/>
+          </a:xfrm>
+          <a:prstGeom prst="line">
+            <a:avLst/>
+          </a:prstGeom>
+          <a:ln w="9525">
+            <a:solidFill>
+              <a:srgbClr val="D9E0EA"/>
+            </a:solidFill>
+          </a:ln>
+        </p:spPr>
+        <p:style>
+          <a:lnRef idx="2">
+            <a:schemeClr val="accent1"/>
+          </a:lnRef>
+          <a:fillRef idx="0">
+            <a:schemeClr val="accent1"/>
+          </a:fillRef>
+          <a:effectRef idx="1">
+            <a:schemeClr val="accent1"/>
+          </a:effectRef>
+          <a:fontRef idx="minor">
+            <a:schemeClr val="tx1"/>
+          </a:fontRef>
+        </p:style>
+      </p:cxnSp>
+      <p:sp>
+        <p:nvSpPr>
+          <p:cNvPr id="84" name="Resumen seguimiento 2025"/>
+          <p:cNvSpPr txBox="1"/>
+          <p:nvPr/>
+        </p:nvSpPr>
+        <p:spPr>
+          <a:xfrm>
+            <a:off x="7406640" y="2514600"/>
+            <a:ext cx="4096512" cy="566928"/>
+          </a:xfrm>
+          <a:prstGeom prst="rect">
+            <a:avLst/>
+          </a:prstGeom>
+          <a:noFill/>
+        </p:spPr>
+        <p:txBody>
+          <a:bodyPr wrap="square" lIns="0" rIns="0" tIns="0" bIns="0">
+            <a:spAutoFit/>
+          </a:bodyPr>
+          <a:lstStyle/>
+          <a:p>
+            <a:r>
+              <a:rPr sz="1300" b="1">
+                <a:solidFill>
+                  <a:srgbClr val="B42318"/>
+                </a:solidFill>
+              </a:rPr>
+              <a:t>2 con seguimiento en 2026</a:t>
+            </a:r>
+          </a:p>
+          <a:p>
+            <a:pPr>
+              <a:spcBef>
+                <a:spcPts val="300"/>
+              </a:spcBef>
+            </a:pPr>
+            <a:r>
+              <a:rPr sz="1050" b="0">
+                <a:solidFill>
+                  <a:srgbClr val="586579"/>
+                </a:solidFill>
+              </a:rPr>
+              <a:t>Obs. 3 y 5   ·   Revisadas en la visita 2026 (Anexo B)</a:t>
             </a:r>
           </a:p>
         </p:txBody>

</xml_diff>

<commit_message>
Use official observation titles from SSF circulars; update 2025 obs. 1-2 descargos
Co-Authored-By: Claude Opus 5.5 <noreply@anthropic.com>
Claude-Session: https://claude.ai/code/session_01F1WXR13Nv8neEtLhaK3ELa
</commit_message>
<xml_diff>
--- a/supervision-gobierno-corporativo/Supervision_GC_SSF_COMEDICA_2025-2026.pptx
+++ b/supervision-gobierno-corporativo/Supervision_GC_SSF_COMEDICA_2025-2026.pptx
@@ -4431,8 +4431,8 @@
         </p:nvSpPr>
         <p:spPr>
           <a:xfrm>
-            <a:off x="1234440" y="1444752"/>
-            <a:ext cx="2738018" cy="566928"/>
+            <a:off x="1234440" y="1399032"/>
+            <a:ext cx="2738018" cy="713232"/>
           </a:xfrm>
           <a:prstGeom prst="rect">
             <a:avLst/>
@@ -4448,12 +4448,12 @@
               <a:buNone/>
             </a:pPr>
             <a:r>
-              <a:rPr lang="en-US" sz="1250" b="1" dirty="0">
+              <a:rPr lang="en-US" sz="1000" b="1" dirty="0">
                 <a:solidFill>
                   <a:schemeClr val="tx1"/>
                 </a:solidFill>
               </a:rPr>
-              <a:t>Falta de Política de Operaciones Vinculadas</a:t>
+              <a:t>La Entidad no cuenta con una Política de Operaciones Vinculadas</a:t>
             </a:r>
             <a:endParaRPr lang="en-US" sz="1250" dirty="0"/>
           </a:p>
@@ -4467,8 +4467,8 @@
         </p:nvSpPr>
         <p:spPr>
           <a:xfrm>
-            <a:off x="731520" y="2075688"/>
-            <a:ext cx="3240938" cy="795528"/>
+            <a:off x="731520" y="2148840"/>
+            <a:ext cx="3240938" cy="731520"/>
           </a:xfrm>
           <a:prstGeom prst="rect">
             <a:avLst/>
@@ -4487,7 +4487,7 @@
               <a:buNone/>
             </a:pPr>
             <a:r>
-              <a:rPr lang="en-US" sz="1000" b="1" dirty="0">
+              <a:rPr lang="en-US" sz="950" b="1" dirty="0">
                 <a:solidFill>
                   <a:schemeClr val="accent5"/>
                 </a:solidFill>
@@ -4495,7 +4495,7 @@
               <a:t>Responsable  </a:t>
             </a:r>
             <a:r>
-              <a:rPr lang="en-US" sz="1000" dirty="0">
+              <a:rPr lang="en-US" sz="950" dirty="0">
                 <a:solidFill>
                   <a:schemeClr val="tx1"/>
                 </a:solidFill>
@@ -4512,7 +4512,7 @@
               <a:buNone/>
             </a:pPr>
             <a:r>
-              <a:rPr lang="en-US" sz="1000" b="1" dirty="0">
+              <a:rPr lang="en-US" sz="950" b="1" dirty="0">
                 <a:solidFill>
                   <a:schemeClr val="accent5"/>
                 </a:solidFill>
@@ -4520,12 +4520,12 @@
               <a:t>Descargo  </a:t>
             </a:r>
             <a:r>
-              <a:rPr lang="en-US" sz="1000" dirty="0">
+              <a:rPr lang="en-US" sz="950" dirty="0">
                 <a:solidFill>
                   <a:schemeClr val="tx1"/>
                 </a:solidFill>
               </a:rPr>
-              <a:t>Se creará la política para aprobación del Consejo de Administración</a:t>
+              <a:t>Se creó la Política de Operaciones Vinculadas y Relacionadas en sesión del Consejo de Administración (Acta 2623, 12/01/2026)</a:t>
             </a:r>
             <a:endParaRPr lang="en-US" sz="1000" dirty="0"/>
           </a:p>
@@ -4648,8 +4648,8 @@
         </p:nvSpPr>
         <p:spPr>
           <a:xfrm>
-            <a:off x="4978298" y="1444752"/>
-            <a:ext cx="2738018" cy="566928"/>
+            <a:off x="4978298" y="1399032"/>
+            <a:ext cx="2738018" cy="713232"/>
           </a:xfrm>
           <a:prstGeom prst="rect">
             <a:avLst/>
@@ -4665,12 +4665,12 @@
               <a:buNone/>
             </a:pPr>
             <a:r>
-              <a:rPr lang="en-US" sz="1250" b="1" dirty="0">
+              <a:rPr lang="en-US" sz="1000" b="1" dirty="0">
                 <a:solidFill>
                   <a:schemeClr val="tx1"/>
                 </a:solidFill>
               </a:rPr>
-              <a:t>Sin evidencia de firma de confidencialidad ni fechas de inducción en actas</a:t>
+              <a:t>No se tuvo evidencia de la firma del acuerdo de confidencialidad de los nuevos miembros de Consejo de Administración, Junta de Vigilancia y Comités ni se programó las fechas de inducción en la primera sesión del Consejo de Administración</a:t>
             </a:r>
             <a:endParaRPr lang="en-US" sz="1250" dirty="0"/>
           </a:p>
@@ -4684,8 +4684,8 @@
         </p:nvSpPr>
         <p:spPr>
           <a:xfrm>
-            <a:off x="4475378" y="2075688"/>
-            <a:ext cx="3240938" cy="795528"/>
+            <a:off x="4475378" y="2148840"/>
+            <a:ext cx="3240938" cy="731520"/>
           </a:xfrm>
           <a:prstGeom prst="rect">
             <a:avLst/>
@@ -4704,7 +4704,7 @@
               <a:buNone/>
             </a:pPr>
             <a:r>
-              <a:rPr lang="en-US" sz="1000" b="1" dirty="0">
+              <a:rPr lang="en-US" sz="950" b="1" dirty="0">
                 <a:solidFill>
                   <a:schemeClr val="accent5"/>
                 </a:solidFill>
@@ -4712,7 +4712,7 @@
               <a:t>Responsable  </a:t>
             </a:r>
             <a:r>
-              <a:rPr lang="en-US" sz="1000" dirty="0">
+              <a:rPr lang="en-US" sz="950" dirty="0">
                 <a:solidFill>
                   <a:schemeClr val="tx1"/>
                 </a:solidFill>
@@ -4729,7 +4729,7 @@
               <a:buNone/>
             </a:pPr>
             <a:r>
-              <a:rPr lang="en-US" sz="1000" b="1" dirty="0">
+              <a:rPr lang="en-US" sz="950" b="1" dirty="0">
                 <a:solidFill>
                   <a:schemeClr val="accent5"/>
                 </a:solidFill>
@@ -4737,12 +4737,12 @@
               <a:t>Descargo  </a:t>
             </a:r>
             <a:r>
-              <a:rPr lang="en-US" sz="1000" dirty="0">
+              <a:rPr lang="en-US" sz="950" dirty="0">
                 <a:solidFill>
                   <a:schemeClr val="tx1"/>
                 </a:solidFill>
               </a:rPr>
-              <a:t>Acta 2579 del Consejo de Administración: fechas de inducción aprobadas</a:t>
+              <a:t>Punto de Acta 2579 (28/04/2025): se derogó el convenio de confidencialidad del Consejo de Administración, Junta de Vigilancia y miembros de comités</a:t>
             </a:r>
             <a:endParaRPr lang="en-US" sz="1000" dirty="0"/>
           </a:p>
@@ -4865,8 +4865,8 @@
         </p:nvSpPr>
         <p:spPr>
           <a:xfrm>
-            <a:off x="8722157" y="1444752"/>
-            <a:ext cx="2738018" cy="566928"/>
+            <a:off x="8722157" y="1399032"/>
+            <a:ext cx="2738018" cy="713232"/>
           </a:xfrm>
           <a:prstGeom prst="rect">
             <a:avLst/>
@@ -4882,12 +4882,12 @@
               <a:buNone/>
             </a:pPr>
             <a:r>
-              <a:rPr lang="en-US" sz="1250" b="1" dirty="0">
+              <a:rPr lang="en-US" sz="1000" b="1" dirty="0">
                 <a:solidFill>
                   <a:schemeClr val="tx1"/>
                 </a:solidFill>
               </a:rPr>
-              <a:t>Comités de Apoyo no integran personal ejecutivo</a:t>
+              <a:t>Comités de Junta Directiva y Comités de Apoyo no cumplen con las especificaciones establecidas en el literal h) del Art. 3 de las Normas NRP-17</a:t>
             </a:r>
             <a:endParaRPr lang="en-US" sz="1250" dirty="0"/>
           </a:p>
@@ -4901,8 +4901,8 @@
         </p:nvSpPr>
         <p:spPr>
           <a:xfrm>
-            <a:off x="8219237" y="2075688"/>
-            <a:ext cx="3240938" cy="795528"/>
+            <a:off x="8219237" y="2148840"/>
+            <a:ext cx="3240938" cy="731520"/>
           </a:xfrm>
           <a:prstGeom prst="rect">
             <a:avLst/>
@@ -4921,7 +4921,7 @@
               <a:buNone/>
             </a:pPr>
             <a:r>
-              <a:rPr lang="en-US" sz="1000" b="1" dirty="0">
+              <a:rPr lang="en-US" sz="950" b="1" dirty="0">
                 <a:solidFill>
                   <a:schemeClr val="accent5"/>
                 </a:solidFill>
@@ -4929,7 +4929,7 @@
               <a:t>Responsable  </a:t>
             </a:r>
             <a:r>
-              <a:rPr lang="en-US" sz="1000" dirty="0">
+              <a:rPr lang="en-US" sz="950" dirty="0">
                 <a:solidFill>
                   <a:schemeClr val="tx1"/>
                 </a:solidFill>
@@ -4946,7 +4946,7 @@
               <a:buNone/>
             </a:pPr>
             <a:r>
-              <a:rPr lang="en-US" sz="1000" b="1" dirty="0">
+              <a:rPr lang="en-US" sz="950" b="1" dirty="0">
                 <a:solidFill>
                   <a:schemeClr val="accent5"/>
                 </a:solidFill>
@@ -4954,7 +4954,7 @@
               <a:t>Descargo  </a:t>
             </a:r>
             <a:r>
-              <a:rPr lang="en-US" sz="1000" dirty="0">
+              <a:rPr lang="en-US" sz="950" dirty="0">
                 <a:solidFill>
                   <a:schemeClr val="tx1"/>
                 </a:solidFill>
@@ -4971,7 +4971,7 @@
               <a:buNone/>
             </a:pPr>
             <a:r>
-              <a:rPr lang="en-US" sz="1000" b="1" dirty="0">
+              <a:rPr lang="en-US" sz="950" b="1" dirty="0">
                 <a:solidFill>
                   <a:schemeClr val="accent3"/>
                 </a:solidFill>
@@ -5099,8 +5099,8 @@
         </p:nvSpPr>
         <p:spPr>
           <a:xfrm>
-            <a:off x="1234440" y="3182112"/>
-            <a:ext cx="2738018" cy="566928"/>
+            <a:off x="1234440" y="3136392"/>
+            <a:ext cx="2738018" cy="713232"/>
           </a:xfrm>
           <a:prstGeom prst="rect">
             <a:avLst/>
@@ -5116,12 +5116,12 @@
               <a:buNone/>
             </a:pPr>
             <a:r>
-              <a:rPr lang="en-US" sz="1250" b="1" dirty="0">
+              <a:rPr lang="en-US" sz="1000" b="1" dirty="0">
                 <a:solidFill>
                   <a:schemeClr val="tx1"/>
                 </a:solidFill>
               </a:rPr>
-              <a:t>Inconsistencia en pago de dietas (Reglamento vs. Asamblea General)</a:t>
+              <a:t>Inconsistencia entre el pago de dietas establecido en el Reglamento de Compensaciones Económicas para Directivos y lo informado a la Asamblea General de Asociados en los puntos varios</a:t>
             </a:r>
             <a:endParaRPr lang="en-US" sz="1250" dirty="0"/>
           </a:p>
@@ -5135,8 +5135,8 @@
         </p:nvSpPr>
         <p:spPr>
           <a:xfrm>
-            <a:off x="731520" y="3813048"/>
-            <a:ext cx="3240938" cy="795528"/>
+            <a:off x="731520" y="3886200"/>
+            <a:ext cx="3240938" cy="731520"/>
           </a:xfrm>
           <a:prstGeom prst="rect">
             <a:avLst/>
@@ -5155,7 +5155,7 @@
               <a:buNone/>
             </a:pPr>
             <a:r>
-              <a:rPr lang="en-US" sz="1000" b="1" dirty="0">
+              <a:rPr lang="en-US" sz="950" b="1" dirty="0">
                 <a:solidFill>
                   <a:schemeClr val="accent5"/>
                 </a:solidFill>
@@ -5163,7 +5163,7 @@
               <a:t>Responsable  </a:t>
             </a:r>
             <a:r>
-              <a:rPr lang="en-US" sz="1000" dirty="0">
+              <a:rPr lang="en-US" sz="950" dirty="0">
                 <a:solidFill>
                   <a:schemeClr val="tx1"/>
                 </a:solidFill>
@@ -5180,7 +5180,7 @@
               <a:buNone/>
             </a:pPr>
             <a:r>
-              <a:rPr lang="en-US" sz="1000" b="1" dirty="0">
+              <a:rPr lang="en-US" sz="950" b="1" dirty="0">
                 <a:solidFill>
                   <a:schemeClr val="accent5"/>
                 </a:solidFill>
@@ -5188,7 +5188,7 @@
               <a:t>Descargo  </a:t>
             </a:r>
             <a:r>
-              <a:rPr lang="en-US" sz="1000" dirty="0">
+              <a:rPr lang="en-US" sz="950" dirty="0">
                 <a:solidFill>
                   <a:schemeClr val="tx1"/>
                 </a:solidFill>
@@ -5316,8 +5316,8 @@
         </p:nvSpPr>
         <p:spPr>
           <a:xfrm>
-            <a:off x="4978298" y="3182112"/>
-            <a:ext cx="2738018" cy="566928"/>
+            <a:off x="4978298" y="3136392"/>
+            <a:ext cx="2738018" cy="713232"/>
           </a:xfrm>
           <a:prstGeom prst="rect">
             <a:avLst/>
@@ -5333,12 +5333,12 @@
               <a:buNone/>
             </a:pPr>
             <a:r>
-              <a:rPr lang="en-US" sz="1250" b="1" dirty="0">
+              <a:rPr lang="en-US" sz="1000" b="1" dirty="0">
                 <a:solidFill>
                   <a:schemeClr val="tx1"/>
                 </a:solidFill>
               </a:rPr>
-              <a:t>Normativa interna desactualizada (más de 2 años sin revisión)</a:t>
+              <a:t>Normativa interna desactualizada</a:t>
             </a:r>
             <a:endParaRPr lang="en-US" sz="1250" dirty="0"/>
           </a:p>
@@ -5352,8 +5352,8 @@
         </p:nvSpPr>
         <p:spPr>
           <a:xfrm>
-            <a:off x="4475378" y="3813048"/>
-            <a:ext cx="3240938" cy="795528"/>
+            <a:off x="4475378" y="3886200"/>
+            <a:ext cx="3240938" cy="731520"/>
           </a:xfrm>
           <a:prstGeom prst="rect">
             <a:avLst/>
@@ -5372,7 +5372,7 @@
               <a:buNone/>
             </a:pPr>
             <a:r>
-              <a:rPr lang="en-US" sz="1000" b="1" dirty="0">
+              <a:rPr lang="en-US" sz="950" b="1" dirty="0">
                 <a:solidFill>
                   <a:schemeClr val="accent5"/>
                 </a:solidFill>
@@ -5380,7 +5380,7 @@
               <a:t>Responsable  </a:t>
             </a:r>
             <a:r>
-              <a:rPr lang="en-US" sz="1000" dirty="0">
+              <a:rPr lang="en-US" sz="950" dirty="0">
                 <a:solidFill>
                   <a:schemeClr val="tx1"/>
                 </a:solidFill>
@@ -5397,7 +5397,7 @@
               <a:buNone/>
             </a:pPr>
             <a:r>
-              <a:rPr lang="en-US" sz="1000" b="1" dirty="0">
+              <a:rPr lang="en-US" sz="950" b="1" dirty="0">
                 <a:solidFill>
                   <a:schemeClr val="accent5"/>
                 </a:solidFill>
@@ -5405,7 +5405,7 @@
               <a:t>Descargo  </a:t>
             </a:r>
             <a:r>
-              <a:rPr lang="en-US" sz="1000" dirty="0">
+              <a:rPr lang="en-US" sz="950" dirty="0">
                 <a:solidFill>
                   <a:schemeClr val="tx1"/>
                 </a:solidFill>
@@ -5422,7 +5422,7 @@
               <a:buNone/>
             </a:pPr>
             <a:r>
-              <a:rPr lang="en-US" sz="1000" b="1" dirty="0">
+              <a:rPr lang="en-US" sz="950" b="1" dirty="0">
                 <a:solidFill>
                   <a:schemeClr val="accent3"/>
                 </a:solidFill>
@@ -5550,8 +5550,8 @@
         </p:nvSpPr>
         <p:spPr>
           <a:xfrm>
-            <a:off x="8722157" y="3182112"/>
-            <a:ext cx="2738018" cy="566928"/>
+            <a:off x="8722157" y="3136392"/>
+            <a:ext cx="2738018" cy="713232"/>
           </a:xfrm>
           <a:prstGeom prst="rect">
             <a:avLst/>
@@ -5567,12 +5567,12 @@
               <a:buNone/>
             </a:pPr>
             <a:r>
-              <a:rPr lang="en-US" sz="1250" b="1" dirty="0">
+              <a:rPr lang="en-US" sz="1000" b="1" dirty="0">
                 <a:solidFill>
                   <a:schemeClr val="tx1"/>
                 </a:solidFill>
               </a:rPr>
-              <a:t>Falta de soporte en expedientes de créditos de Ferias de Crédito</a:t>
+              <a:t>Falta de documentación soporte en los expedientes de créditos otorgados mediante Ferias de Créditos</a:t>
             </a:r>
             <a:endParaRPr lang="en-US" sz="1250" dirty="0"/>
           </a:p>
@@ -5586,8 +5586,8 @@
         </p:nvSpPr>
         <p:spPr>
           <a:xfrm>
-            <a:off x="8219237" y="3813048"/>
-            <a:ext cx="3240938" cy="795528"/>
+            <a:off x="8219237" y="3886200"/>
+            <a:ext cx="3240938" cy="731520"/>
           </a:xfrm>
           <a:prstGeom prst="rect">
             <a:avLst/>
@@ -5606,7 +5606,7 @@
               <a:buNone/>
             </a:pPr>
             <a:r>
-              <a:rPr lang="en-US" sz="1000" b="1" dirty="0">
+              <a:rPr lang="en-US" sz="950" b="1" dirty="0">
                 <a:solidFill>
                   <a:schemeClr val="accent5"/>
                 </a:solidFill>
@@ -5614,7 +5614,7 @@
               <a:t>Responsable  </a:t>
             </a:r>
             <a:r>
-              <a:rPr lang="en-US" sz="1000" dirty="0">
+              <a:rPr lang="en-US" sz="950" dirty="0">
                 <a:solidFill>
                   <a:schemeClr val="tx1"/>
                 </a:solidFill>
@@ -5631,7 +5631,7 @@
               <a:buNone/>
             </a:pPr>
             <a:r>
-              <a:rPr lang="en-US" sz="1000" b="1" dirty="0">
+              <a:rPr lang="en-US" sz="950" b="1" dirty="0">
                 <a:solidFill>
                   <a:schemeClr val="accent5"/>
                 </a:solidFill>
@@ -5639,7 +5639,7 @@
               <a:t>Descargo  </a:t>
             </a:r>
             <a:r>
-              <a:rPr lang="en-US" sz="1000" dirty="0">
+              <a:rPr lang="en-US" sz="950" dirty="0">
                 <a:solidFill>
                   <a:schemeClr val="tx1"/>
                 </a:solidFill>
@@ -5767,8 +5767,8 @@
         </p:nvSpPr>
         <p:spPr>
           <a:xfrm>
-            <a:off x="1234440" y="4919472"/>
-            <a:ext cx="2738018" cy="566928"/>
+            <a:off x="1234440" y="4873752"/>
+            <a:ext cx="2738018" cy="713232"/>
           </a:xfrm>
           <a:prstGeom prst="rect">
             <a:avLst/>
@@ -5784,12 +5784,12 @@
               <a:buNone/>
             </a:pPr>
             <a:r>
-              <a:rPr lang="en-US" sz="1250" b="1" dirty="0">
+              <a:rPr lang="en-US" sz="1000" b="1" dirty="0">
                 <a:solidFill>
                   <a:schemeClr val="tx1"/>
                 </a:solidFill>
               </a:rPr>
-              <a:t>Falta de información obligatoria en declaración jurada de personas relacionadas</a:t>
+              <a:t>Falta de información obligatoria en la declaración jurada de personas relacionadas conforme a lo dispuesto en el Art. 9 de las Normas NRP-75</a:t>
             </a:r>
             <a:endParaRPr lang="en-US" sz="1250" dirty="0"/>
           </a:p>
@@ -5803,8 +5803,8 @@
         </p:nvSpPr>
         <p:spPr>
           <a:xfrm>
-            <a:off x="731520" y="5550408"/>
-            <a:ext cx="3240938" cy="795528"/>
+            <a:off x="731520" y="5623560"/>
+            <a:ext cx="3240938" cy="731520"/>
           </a:xfrm>
           <a:prstGeom prst="rect">
             <a:avLst/>
@@ -5823,7 +5823,7 @@
               <a:buNone/>
             </a:pPr>
             <a:r>
-              <a:rPr lang="en-US" sz="1000" b="1" dirty="0">
+              <a:rPr lang="en-US" sz="950" b="1" dirty="0">
                 <a:solidFill>
                   <a:schemeClr val="accent5"/>
                 </a:solidFill>
@@ -5831,7 +5831,7 @@
               <a:t>Responsable  </a:t>
             </a:r>
             <a:r>
-              <a:rPr lang="en-US" sz="1000" dirty="0">
+              <a:rPr lang="en-US" sz="950" dirty="0">
                 <a:solidFill>
                   <a:schemeClr val="tx1"/>
                 </a:solidFill>
@@ -5848,7 +5848,7 @@
               <a:buNone/>
             </a:pPr>
             <a:r>
-              <a:rPr lang="en-US" sz="1000" b="1" dirty="0">
+              <a:rPr lang="en-US" sz="950" b="1" dirty="0">
                 <a:solidFill>
                   <a:schemeClr val="accent5"/>
                 </a:solidFill>
@@ -5856,7 +5856,7 @@
               <a:t>Descargo  </a:t>
             </a:r>
             <a:r>
-              <a:rPr lang="en-US" sz="1000" dirty="0">
+              <a:rPr lang="en-US" sz="950" dirty="0">
                 <a:solidFill>
                   <a:schemeClr val="tx1"/>
                 </a:solidFill>
@@ -5984,8 +5984,8 @@
         </p:nvSpPr>
         <p:spPr>
           <a:xfrm>
-            <a:off x="4978298" y="4919472"/>
-            <a:ext cx="2738018" cy="566928"/>
+            <a:off x="4978298" y="4873752"/>
+            <a:ext cx="2738018" cy="713232"/>
           </a:xfrm>
           <a:prstGeom prst="rect">
             <a:avLst/>
@@ -6001,12 +6001,12 @@
               <a:buNone/>
             </a:pPr>
             <a:r>
-              <a:rPr lang="en-US" sz="1250" b="1" dirty="0">
+              <a:rPr lang="en-US" sz="1000" b="1" dirty="0">
                 <a:solidFill>
                   <a:schemeClr val="tx1"/>
                 </a:solidFill>
               </a:rPr>
-              <a:t>Omisiones en procedimientos del Manual de Compras de Bienes y Servicios</a:t>
+              <a:t>Falta de aplicación de procedimientos internos establecidos en el Manual de Compras de Bienes y Servicios</a:t>
             </a:r>
             <a:endParaRPr lang="en-US" sz="1250" dirty="0"/>
           </a:p>
@@ -6020,8 +6020,8 @@
         </p:nvSpPr>
         <p:spPr>
           <a:xfrm>
-            <a:off x="4475378" y="5550408"/>
-            <a:ext cx="3240938" cy="795528"/>
+            <a:off x="4475378" y="5623560"/>
+            <a:ext cx="3240938" cy="731520"/>
           </a:xfrm>
           <a:prstGeom prst="rect">
             <a:avLst/>
@@ -6040,7 +6040,7 @@
               <a:buNone/>
             </a:pPr>
             <a:r>
-              <a:rPr lang="en-US" sz="1000" b="1" dirty="0">
+              <a:rPr lang="en-US" sz="950" b="1" dirty="0">
                 <a:solidFill>
                   <a:schemeClr val="accent5"/>
                 </a:solidFill>
@@ -6048,7 +6048,7 @@
               <a:t>Responsable  </a:t>
             </a:r>
             <a:r>
-              <a:rPr lang="en-US" sz="1000" dirty="0">
+              <a:rPr lang="en-US" sz="950" dirty="0">
                 <a:solidFill>
                   <a:schemeClr val="tx1"/>
                 </a:solidFill>
@@ -6065,7 +6065,7 @@
               <a:buNone/>
             </a:pPr>
             <a:r>
-              <a:rPr lang="en-US" sz="1000" b="1" dirty="0">
+              <a:rPr lang="en-US" sz="950" b="1" dirty="0">
                 <a:solidFill>
                   <a:schemeClr val="accent5"/>
                 </a:solidFill>
@@ -6073,7 +6073,7 @@
               <a:t>Descargo  </a:t>
             </a:r>
             <a:r>
-              <a:rPr lang="en-US" sz="1000" dirty="0">
+              <a:rPr lang="en-US" sz="950" dirty="0">
                 <a:solidFill>
                   <a:schemeClr val="tx1"/>
                 </a:solidFill>
@@ -6201,8 +6201,8 @@
         </p:nvSpPr>
         <p:spPr>
           <a:xfrm>
-            <a:off x="8722157" y="4919472"/>
-            <a:ext cx="2738018" cy="566928"/>
+            <a:off x="8722157" y="4873752"/>
+            <a:ext cx="2738018" cy="713232"/>
           </a:xfrm>
           <a:prstGeom prst="rect">
             <a:avLst/>
@@ -6218,12 +6218,12 @@
               <a:buNone/>
             </a:pPr>
             <a:r>
-              <a:rPr lang="en-US" sz="1250" b="1" dirty="0">
+              <a:rPr lang="en-US" sz="1000" b="1" dirty="0">
                 <a:solidFill>
                   <a:schemeClr val="tx1"/>
                 </a:solidFill>
               </a:rPr>
-              <a:t>Uso del Fondo de Educación en fines distintos a los legales</a:t>
+              <a:t>Utilización del Fondo de Educación con fines distintos a los establecidos en el marco legal</a:t>
             </a:r>
             <a:endParaRPr lang="en-US" sz="1250" dirty="0"/>
           </a:p>
@@ -6237,8 +6237,8 @@
         </p:nvSpPr>
         <p:spPr>
           <a:xfrm>
-            <a:off x="8219237" y="5550408"/>
-            <a:ext cx="3240938" cy="795528"/>
+            <a:off x="8219237" y="5623560"/>
+            <a:ext cx="3240938" cy="731520"/>
           </a:xfrm>
           <a:prstGeom prst="rect">
             <a:avLst/>
@@ -6257,7 +6257,7 @@
               <a:buNone/>
             </a:pPr>
             <a:r>
-              <a:rPr lang="en-US" sz="1000" b="1" dirty="0">
+              <a:rPr lang="en-US" sz="950" b="1" dirty="0">
                 <a:solidFill>
                   <a:schemeClr val="accent5"/>
                 </a:solidFill>
@@ -6265,7 +6265,7 @@
               <a:t>Responsable  </a:t>
             </a:r>
             <a:r>
-              <a:rPr lang="en-US" sz="1000" dirty="0">
+              <a:rPr lang="en-US" sz="950" dirty="0">
                 <a:solidFill>
                   <a:schemeClr val="tx1"/>
                 </a:solidFill>
@@ -6282,7 +6282,7 @@
               <a:buNone/>
             </a:pPr>
             <a:r>
-              <a:rPr lang="en-US" sz="1000" b="1" dirty="0">
+              <a:rPr lang="en-US" sz="950" b="1" dirty="0">
                 <a:solidFill>
                   <a:schemeClr val="accent5"/>
                 </a:solidFill>
@@ -6290,7 +6290,7 @@
               <a:t>Descargo  </a:t>
             </a:r>
             <a:r>
-              <a:rPr lang="en-US" sz="1000" dirty="0">
+              <a:rPr lang="en-US" sz="950" dirty="0">
                 <a:solidFill>
                   <a:schemeClr val="tx1"/>
                 </a:solidFill>
@@ -6797,8 +6797,8 @@
         </p:nvSpPr>
         <p:spPr>
           <a:xfrm>
-            <a:off x="694944" y="2157984"/>
-            <a:ext cx="2398700" cy="502920"/>
+            <a:off x="694944" y="2121408"/>
+            <a:ext cx="2398700" cy="585216"/>
           </a:xfrm>
           <a:prstGeom prst="rect">
             <a:avLst/>
@@ -6814,12 +6814,12 @@
               <a:buNone/>
             </a:pPr>
             <a:r>
-              <a:rPr lang="en-US" sz="1150" b="1" dirty="0">
+              <a:rPr lang="en-US" sz="950" b="1" dirty="0">
                 <a:solidFill>
                   <a:schemeClr val="tx1"/>
                 </a:solidFill>
               </a:rPr>
-              <a:t>Falta de inducción sobre estados financieros a nuevos miembros</a:t>
+              <a:t>Falta de evidencia de inducción sobre las partidas relevantes de los estados financieros a nuevos miembros de los órganos de gobierno</a:t>
             </a:r>
             <a:endParaRPr lang="en-US" sz="1150" dirty="0"/>
           </a:p>
@@ -6833,8 +6833,8 @@
         </p:nvSpPr>
         <p:spPr>
           <a:xfrm>
-            <a:off x="694944" y="2651760"/>
-            <a:ext cx="2398700" cy="329184"/>
+            <a:off x="694944" y="2715768"/>
+            <a:ext cx="2398700" cy="283464"/>
           </a:xfrm>
           <a:prstGeom prst="rect">
             <a:avLst/>
@@ -6850,7 +6850,7 @@
               <a:buNone/>
             </a:pPr>
             <a:r>
-              <a:rPr lang="en-US" sz="950" i="1" dirty="0">
+              <a:rPr lang="en-US" sz="850" i="1" dirty="0">
                 <a:solidFill>
                   <a:schemeClr val="accent5"/>
                 </a:solidFill>
@@ -7028,8 +7028,8 @@
         </p:nvSpPr>
         <p:spPr>
           <a:xfrm>
-            <a:off x="3495980" y="2157984"/>
-            <a:ext cx="2398700" cy="502920"/>
+            <a:off x="3495980" y="2121408"/>
+            <a:ext cx="2398700" cy="585216"/>
           </a:xfrm>
           <a:prstGeom prst="rect">
             <a:avLst/>
@@ -7045,12 +7045,12 @@
               <a:buNone/>
             </a:pPr>
             <a:r>
-              <a:rPr lang="en-US" sz="1150" b="1" dirty="0">
+              <a:rPr lang="en-US" sz="950" b="1" dirty="0">
                 <a:solidFill>
                   <a:schemeClr val="tx1"/>
                 </a:solidFill>
               </a:rPr>
-              <a:t>Falta de Certificación de Lectura del Código de Conducta</a:t>
+              <a:t>Falta de evidencia de Certificación de Lectura del Código de Conducta de miembros de Junta de Vigilancia y Comités de Apoyo</a:t>
             </a:r>
             <a:endParaRPr lang="en-US" sz="1150" dirty="0"/>
           </a:p>
@@ -7064,8 +7064,8 @@
         </p:nvSpPr>
         <p:spPr>
           <a:xfrm>
-            <a:off x="3495980" y="2651760"/>
-            <a:ext cx="2398700" cy="329184"/>
+            <a:off x="3495980" y="2715768"/>
+            <a:ext cx="2398700" cy="283464"/>
           </a:xfrm>
           <a:prstGeom prst="rect">
             <a:avLst/>
@@ -7081,7 +7081,7 @@
               <a:buNone/>
             </a:pPr>
             <a:r>
-              <a:rPr lang="en-US" sz="950" i="1" dirty="0">
+              <a:rPr lang="en-US" sz="850" i="1" dirty="0">
                 <a:solidFill>
                   <a:schemeClr val="accent5"/>
                 </a:solidFill>
@@ -7259,8 +7259,8 @@
         </p:nvSpPr>
         <p:spPr>
           <a:xfrm>
-            <a:off x="6297016" y="2157984"/>
-            <a:ext cx="2398700" cy="502920"/>
+            <a:off x="6297016" y="2121408"/>
+            <a:ext cx="2398700" cy="585216"/>
           </a:xfrm>
           <a:prstGeom prst="rect">
             <a:avLst/>
@@ -7276,12 +7276,12 @@
               <a:buNone/>
             </a:pPr>
             <a:r>
-              <a:rPr lang="en-US" sz="1150" b="1" dirty="0">
+              <a:rPr lang="en-US" sz="950" b="1" dirty="0">
                 <a:solidFill>
                   <a:schemeClr val="tx1"/>
                 </a:solidFill>
               </a:rPr>
-              <a:t>Falta de formalización y aprobación de políticas</a:t>
+              <a:t>Falta de formalización y aprobación de políticas por parte del Consejo de Administración</a:t>
             </a:r>
             <a:endParaRPr lang="en-US" sz="1150" dirty="0"/>
           </a:p>
@@ -7295,8 +7295,8 @@
         </p:nvSpPr>
         <p:spPr>
           <a:xfrm>
-            <a:off x="6297016" y="2651760"/>
-            <a:ext cx="2398700" cy="329184"/>
+            <a:off x="6297016" y="2715768"/>
+            <a:ext cx="2398700" cy="283464"/>
           </a:xfrm>
           <a:prstGeom prst="rect">
             <a:avLst/>
@@ -7312,7 +7312,7 @@
               <a:buNone/>
             </a:pPr>
             <a:r>
-              <a:rPr lang="en-US" sz="950" i="1" dirty="0">
+              <a:rPr lang="en-US" sz="850" i="1" dirty="0">
                 <a:solidFill>
                   <a:schemeClr val="accent5"/>
                 </a:solidFill>
@@ -7490,8 +7490,8 @@
         </p:nvSpPr>
         <p:spPr>
           <a:xfrm>
-            <a:off x="9098051" y="2157984"/>
-            <a:ext cx="2398700" cy="502920"/>
+            <a:off x="9098051" y="2121408"/>
+            <a:ext cx="2398700" cy="585216"/>
           </a:xfrm>
           <a:prstGeom prst="rect">
             <a:avLst/>
@@ -7507,12 +7507,12 @@
               <a:buNone/>
             </a:pPr>
             <a:r>
-              <a:rPr lang="en-US" sz="1150" b="1" dirty="0">
+              <a:rPr lang="en-US" sz="950" b="1" dirty="0">
                 <a:solidFill>
                   <a:schemeClr val="tx1"/>
                 </a:solidFill>
               </a:rPr>
-              <a:t>Información de comités desactualizada en el sitio web</a:t>
+              <a:t>Información divulgada sobre los comités de apoyo no se encuentra actualizada ni alineada con el Código de Gobierno Corporativo vigente</a:t>
             </a:r>
             <a:endParaRPr lang="en-US" sz="1150" dirty="0"/>
           </a:p>
@@ -7526,8 +7526,8 @@
         </p:nvSpPr>
         <p:spPr>
           <a:xfrm>
-            <a:off x="9098051" y="2651760"/>
-            <a:ext cx="2398700" cy="329184"/>
+            <a:off x="9098051" y="2715768"/>
+            <a:ext cx="2398700" cy="283464"/>
           </a:xfrm>
           <a:prstGeom prst="rect">
             <a:avLst/>
@@ -7543,7 +7543,7 @@
               <a:buNone/>
             </a:pPr>
             <a:r>
-              <a:rPr lang="en-US" sz="950" i="1" dirty="0">
+              <a:rPr lang="en-US" sz="850" i="1" dirty="0">
                 <a:solidFill>
                   <a:schemeClr val="accent5"/>
                 </a:solidFill>
@@ -7721,8 +7721,8 @@
         </p:nvSpPr>
         <p:spPr>
           <a:xfrm>
-            <a:off x="694944" y="3712464"/>
-            <a:ext cx="2398700" cy="502920"/>
+            <a:off x="694944" y="3675888"/>
+            <a:ext cx="2398700" cy="585216"/>
           </a:xfrm>
           <a:prstGeom prst="rect">
             <a:avLst/>
@@ -7738,12 +7738,12 @@
               <a:buNone/>
             </a:pPr>
             <a:r>
-              <a:rPr lang="en-US" sz="1150" b="1" dirty="0">
+              <a:rPr lang="en-US" sz="950" b="1" dirty="0">
                 <a:solidFill>
                   <a:schemeClr val="tx1"/>
                 </a:solidFill>
               </a:rPr>
-              <a:t>Incongruencia entre Estatutos y Código de Gobierno Corporativo</a:t>
+              <a:t>Incongruencia en las disposiciones internas para la integración de los Comités de Apoyo</a:t>
             </a:r>
             <a:endParaRPr lang="en-US" sz="1150" dirty="0"/>
           </a:p>
@@ -7757,8 +7757,8 @@
         </p:nvSpPr>
         <p:spPr>
           <a:xfrm>
-            <a:off x="694944" y="4206240"/>
-            <a:ext cx="2398700" cy="329184"/>
+            <a:off x="694944" y="4270248"/>
+            <a:ext cx="2398700" cy="283464"/>
           </a:xfrm>
           <a:prstGeom prst="rect">
             <a:avLst/>
@@ -7774,7 +7774,7 @@
               <a:buNone/>
             </a:pPr>
             <a:r>
-              <a:rPr lang="en-US" sz="950" i="1" dirty="0">
+              <a:rPr lang="en-US" sz="850" i="1" dirty="0">
                 <a:solidFill>
                   <a:schemeClr val="accent5"/>
                 </a:solidFill>
@@ -7952,8 +7952,8 @@
         </p:nvSpPr>
         <p:spPr>
           <a:xfrm>
-            <a:off x="3495980" y="3712464"/>
-            <a:ext cx="2398700" cy="502920"/>
+            <a:off x="3495980" y="3675888"/>
+            <a:ext cx="2398700" cy="585216"/>
           </a:xfrm>
           <a:prstGeom prst="rect">
             <a:avLst/>
@@ -7969,12 +7969,12 @@
               <a:buNone/>
             </a:pPr>
             <a:r>
-              <a:rPr lang="en-US" sz="1150" b="1" dirty="0">
+              <a:rPr lang="en-US" sz="950" b="1" dirty="0">
                 <a:solidFill>
                   <a:schemeClr val="tx1"/>
                 </a:solidFill>
               </a:rPr>
-              <a:t>Reglamento del Fondo de Educación con conceptos no delimitados por Ley</a:t>
+              <a:t>La regulación interna del Fondo de Educación incorpora conceptos cuya relación con la finalidad prevista en la Ley no se encuentra suficientemente delimitada</a:t>
             </a:r>
             <a:endParaRPr lang="en-US" sz="1150" dirty="0"/>
           </a:p>
@@ -7988,8 +7988,8 @@
         </p:nvSpPr>
         <p:spPr>
           <a:xfrm>
-            <a:off x="3495980" y="4206240"/>
-            <a:ext cx="2398700" cy="329184"/>
+            <a:off x="3495980" y="4270248"/>
+            <a:ext cx="2398700" cy="283464"/>
           </a:xfrm>
           <a:prstGeom prst="rect">
             <a:avLst/>
@@ -8005,7 +8005,7 @@
               <a:buNone/>
             </a:pPr>
             <a:r>
-              <a:rPr lang="en-US" sz="950" i="1" dirty="0">
+              <a:rPr lang="en-US" sz="850" i="1" dirty="0">
                 <a:solidFill>
                   <a:schemeClr val="accent5"/>
                 </a:solidFill>
@@ -8183,8 +8183,8 @@
         </p:nvSpPr>
         <p:spPr>
           <a:xfrm>
-            <a:off x="6297016" y="3712464"/>
-            <a:ext cx="2398700" cy="502920"/>
+            <a:off x="6297016" y="3675888"/>
+            <a:ext cx="2398700" cy="585216"/>
           </a:xfrm>
           <a:prstGeom prst="rect">
             <a:avLst/>
@@ -8200,12 +8200,12 @@
               <a:buNone/>
             </a:pPr>
             <a:r>
-              <a:rPr lang="en-US" sz="1150" b="1" dirty="0">
+              <a:rPr lang="en-US" sz="950" b="1" dirty="0">
                 <a:solidFill>
                   <a:schemeClr val="tx1"/>
                 </a:solidFill>
               </a:rPr>
-              <a:t>Limitada transparencia a la Asamblea sobre el Fondo de Educación</a:t>
+              <a:t>Limitada transparencia en la información presentada a la Asamblea General Ordinaria de Asociados respecto del uso del Fondo de Educación</a:t>
             </a:r>
             <a:endParaRPr lang="en-US" sz="1150" dirty="0"/>
           </a:p>
@@ -8219,8 +8219,8 @@
         </p:nvSpPr>
         <p:spPr>
           <a:xfrm>
-            <a:off x="6297016" y="4206240"/>
-            <a:ext cx="2398700" cy="329184"/>
+            <a:off x="6297016" y="4270248"/>
+            <a:ext cx="2398700" cy="283464"/>
           </a:xfrm>
           <a:prstGeom prst="rect">
             <a:avLst/>
@@ -8236,7 +8236,7 @@
               <a:buNone/>
             </a:pPr>
             <a:r>
-              <a:rPr lang="en-US" sz="950" i="1" dirty="0">
+              <a:rPr lang="en-US" sz="850" i="1" dirty="0">
                 <a:solidFill>
                   <a:schemeClr val="accent5"/>
                 </a:solidFill>
@@ -8635,7 +8635,7 @@
         <p:spPr>
           <a:xfrm>
             <a:off x="731520" y="5394960"/>
-            <a:ext cx="3726066" cy="256032"/>
+            <a:ext cx="3726066" cy="329184"/>
           </a:xfrm>
           <a:prstGeom prst="rect">
             <a:avLst/>
@@ -8651,12 +8651,12 @@
               <a:buNone/>
             </a:pPr>
             <a:r>
-              <a:rPr lang="en-US" sz="1250" b="1" dirty="0">
+              <a:rPr lang="en-US" sz="1050" b="1" dirty="0">
                 <a:solidFill>
                   <a:schemeClr val="tx1"/>
                 </a:solidFill>
               </a:rPr>
-              <a:t>Comités de Apoyo no integran personal ejecutivo</a:t>
+              <a:t>Comités de Apoyo no cumplen con las especificaciones establecidas en el literal i) del Artículo 3 de las Normas NRP-17</a:t>
             </a:r>
             <a:endParaRPr lang="en-US" sz="1250" dirty="0"/>
           </a:p>
@@ -8670,7 +8670,7 @@
         </p:nvSpPr>
         <p:spPr>
           <a:xfrm>
-            <a:off x="731520" y="5650992"/>
+            <a:off x="731520" y="5760720"/>
             <a:ext cx="3726066" cy="219456"/>
           </a:xfrm>
           <a:prstGeom prst="rect">
@@ -8714,7 +8714,7 @@
         </p:nvSpPr>
         <p:spPr>
           <a:xfrm>
-            <a:off x="731520" y="5870448"/>
+            <a:off x="731520" y="5961888"/>
             <a:ext cx="3726066" cy="365760"/>
           </a:xfrm>
           <a:prstGeom prst="rect">
@@ -8941,7 +8941,7 @@
         <p:spPr>
           <a:xfrm>
             <a:off x="4933074" y="5394960"/>
-            <a:ext cx="3726066" cy="256032"/>
+            <a:ext cx="3726066" cy="329184"/>
           </a:xfrm>
           <a:prstGeom prst="rect">
             <a:avLst/>
@@ -8957,7 +8957,7 @@
               <a:buNone/>
             </a:pPr>
             <a:r>
-              <a:rPr lang="en-US" sz="1250" b="1" dirty="0">
+              <a:rPr lang="en-US" sz="1050" b="1" dirty="0">
                 <a:solidFill>
                   <a:schemeClr val="tx1"/>
                 </a:solidFill>

</xml_diff>

<commit_message>
Rearrange observation cards so full titles read cleanly
Co-Authored-By: Claude Opus 5.5 <noreply@anthropic.com>
Claude-Session: https://claude.ai/code/session_01F1WXR13Nv8neEtLhaK3ELa
</commit_message>
<xml_diff>
--- a/supervision-gobierno-corporativo/Supervision_GC_SSF_COMEDICA_2025-2026.pptx
+++ b/supervision-gobierno-corporativo/Supervision_GC_SSF_COMEDICA_2025-2026.pptx
@@ -4358,8 +4358,8 @@
         </p:nvSpPr>
         <p:spPr>
           <a:xfrm>
-            <a:off x="731520" y="1508760"/>
-            <a:ext cx="384048" cy="384048"/>
+            <a:off x="713232" y="1453896"/>
+            <a:ext cx="347472" cy="347472"/>
           </a:xfrm>
           <a:prstGeom prst="ellipse">
             <a:avLst/>
@@ -4392,8 +4392,8 @@
         </p:nvSpPr>
         <p:spPr>
           <a:xfrm>
-            <a:off x="731520" y="1508760"/>
-            <a:ext cx="384048" cy="384048"/>
+            <a:off x="713232" y="1453896"/>
+            <a:ext cx="347472" cy="347472"/>
           </a:xfrm>
           <a:prstGeom prst="rect">
             <a:avLst/>
@@ -4431,17 +4431,17 @@
         </p:nvSpPr>
         <p:spPr>
           <a:xfrm>
-            <a:off x="1234440" y="1399032"/>
-            <a:ext cx="2738018" cy="713232"/>
-          </a:xfrm>
-          <a:prstGeom prst="rect">
-            <a:avLst/>
-          </a:prstGeom>
-          <a:noFill/>
-          <a:ln/>
-        </p:spPr>
-        <p:txBody>
-          <a:bodyPr wrap="square" lIns="0" tIns="0" rIns="0" bIns="0" rtlCol="0" anchor="ctr"/>
+            <a:off x="713232" y="1911096"/>
+            <a:ext cx="3277514" cy="603504"/>
+          </a:xfrm>
+          <a:prstGeom prst="rect">
+            <a:avLst/>
+          </a:prstGeom>
+          <a:noFill/>
+          <a:ln/>
+        </p:spPr>
+        <p:txBody>
+          <a:bodyPr wrap="square" lIns="0" tIns="0" rIns="0" bIns="0" rtlCol="0" anchor="t"/>
           <a:lstStyle/>
           <a:p>
             <a:pPr marL="0" indent="0">
@@ -4450,7 +4450,7 @@
             <a:r>
               <a:rPr lang="en-US" sz="1000" b="1" dirty="0">
                 <a:solidFill>
-                  <a:schemeClr val="tx1"/>
+                  <a:srgbClr val="173A6E"/>
                 </a:solidFill>
               </a:rPr>
               <a:t>La Entidad no cuenta con una Política de Operaciones Vinculadas</a:t>
@@ -4467,17 +4467,17 @@
         </p:nvSpPr>
         <p:spPr>
           <a:xfrm>
-            <a:off x="731520" y="2148840"/>
-            <a:ext cx="3240938" cy="731520"/>
-          </a:xfrm>
-          <a:prstGeom prst="rect">
-            <a:avLst/>
-          </a:prstGeom>
-          <a:noFill/>
-          <a:ln/>
-        </p:spPr>
-        <p:txBody>
-          <a:bodyPr wrap="square" lIns="0" tIns="0" rIns="0" bIns="0" rtlCol="0" anchor="t"/>
+            <a:off x="713232" y="2423160"/>
+            <a:ext cx="3277514" cy="429768"/>
+          </a:xfrm>
+          <a:prstGeom prst="rect">
+            <a:avLst/>
+          </a:prstGeom>
+          <a:noFill/>
+          <a:ln/>
+        </p:spPr>
+        <p:txBody>
+          <a:bodyPr wrap="square" lIns="0" tIns="0" rIns="0" bIns="0" rtlCol="0" anchor="b"/>
           <a:lstStyle/>
           <a:p>
             <a:pPr marL="0" indent="0">
@@ -4487,40 +4487,15 @@
               <a:buNone/>
             </a:pPr>
             <a:r>
-              <a:rPr lang="en-US" sz="950" b="1" dirty="0">
+              <a:rPr lang="en-US" sz="900" b="1" dirty="0">
                 <a:solidFill>
                   <a:schemeClr val="accent5"/>
                 </a:solidFill>
               </a:rPr>
-              <a:t>Responsable  </a:t>
-            </a:r>
-            <a:r>
-              <a:rPr lang="en-US" sz="950" dirty="0">
-                <a:solidFill>
-                  <a:schemeClr val="tx1"/>
-                </a:solidFill>
-              </a:rPr>
-              <a:t>Gerencia General / Jefe de Administración de Riesgos</a:t>
-            </a:r>
-            <a:endParaRPr lang="en-US" sz="1000" dirty="0"/>
-          </a:p>
-          <a:p>
-            <a:pPr marL="0" indent="0">
-              <a:spcAft>
-                <a:spcPts val="100"/>
-              </a:spcAft>
-              <a:buNone/>
-            </a:pPr>
-            <a:r>
-              <a:rPr lang="en-US" sz="950" b="1" dirty="0">
-                <a:solidFill>
-                  <a:schemeClr val="accent5"/>
-                </a:solidFill>
-              </a:rPr>
               <a:t>Descargo  </a:t>
             </a:r>
             <a:r>
-              <a:rPr lang="en-US" sz="950" dirty="0">
+              <a:rPr lang="en-US" sz="900" dirty="0">
                 <a:solidFill>
                   <a:schemeClr val="tx1"/>
                 </a:solidFill>
@@ -4575,8 +4550,8 @@
         </p:nvSpPr>
         <p:spPr>
           <a:xfrm>
-            <a:off x="4475378" y="1508760"/>
-            <a:ext cx="384048" cy="384048"/>
+            <a:off x="4457090" y="1453896"/>
+            <a:ext cx="347472" cy="347472"/>
           </a:xfrm>
           <a:prstGeom prst="ellipse">
             <a:avLst/>
@@ -4609,8 +4584,8 @@
         </p:nvSpPr>
         <p:spPr>
           <a:xfrm>
-            <a:off x="4475378" y="1508760"/>
-            <a:ext cx="384048" cy="384048"/>
+            <a:off x="4457090" y="1453896"/>
+            <a:ext cx="347472" cy="347472"/>
           </a:xfrm>
           <a:prstGeom prst="rect">
             <a:avLst/>
@@ -4648,26 +4623,26 @@
         </p:nvSpPr>
         <p:spPr>
           <a:xfrm>
-            <a:off x="4978298" y="1399032"/>
-            <a:ext cx="2738018" cy="713232"/>
-          </a:xfrm>
-          <a:prstGeom prst="rect">
-            <a:avLst/>
-          </a:prstGeom>
-          <a:noFill/>
-          <a:ln/>
-        </p:spPr>
-        <p:txBody>
-          <a:bodyPr wrap="square" lIns="0" tIns="0" rIns="0" bIns="0" rtlCol="0" anchor="ctr"/>
-          <a:lstStyle/>
-          <a:p>
-            <a:pPr marL="0" indent="0">
-              <a:buNone/>
-            </a:pPr>
-            <a:r>
-              <a:rPr lang="en-US" sz="1000" b="1" dirty="0">
-                <a:solidFill>
-                  <a:schemeClr val="tx1"/>
+            <a:off x="4457090" y="1911096"/>
+            <a:ext cx="3277514" cy="603504"/>
+          </a:xfrm>
+          <a:prstGeom prst="rect">
+            <a:avLst/>
+          </a:prstGeom>
+          <a:noFill/>
+          <a:ln/>
+        </p:spPr>
+        <p:txBody>
+          <a:bodyPr wrap="square" lIns="0" tIns="0" rIns="0" bIns="0" rtlCol="0" anchor="t"/>
+          <a:lstStyle/>
+          <a:p>
+            <a:pPr marL="0" indent="0">
+              <a:buNone/>
+            </a:pPr>
+            <a:r>
+              <a:rPr lang="en-US" sz="950" b="1" dirty="0">
+                <a:solidFill>
+                  <a:srgbClr val="173A6E"/>
                 </a:solidFill>
               </a:rPr>
               <a:t>No se tuvo evidencia de la firma del acuerdo de confidencialidad de los nuevos miembros de Consejo de Administración, Junta de Vigilancia y Comités ni se programó las fechas de inducción en la primera sesión del Consejo de Administración</a:t>
@@ -4684,17 +4659,17 @@
         </p:nvSpPr>
         <p:spPr>
           <a:xfrm>
-            <a:off x="4475378" y="2148840"/>
-            <a:ext cx="3240938" cy="731520"/>
-          </a:xfrm>
-          <a:prstGeom prst="rect">
-            <a:avLst/>
-          </a:prstGeom>
-          <a:noFill/>
-          <a:ln/>
-        </p:spPr>
-        <p:txBody>
-          <a:bodyPr wrap="square" lIns="0" tIns="0" rIns="0" bIns="0" rtlCol="0" anchor="t"/>
+            <a:off x="4457090" y="2423160"/>
+            <a:ext cx="3277514" cy="429768"/>
+          </a:xfrm>
+          <a:prstGeom prst="rect">
+            <a:avLst/>
+          </a:prstGeom>
+          <a:noFill/>
+          <a:ln/>
+        </p:spPr>
+        <p:txBody>
+          <a:bodyPr wrap="square" lIns="0" tIns="0" rIns="0" bIns="0" rtlCol="0" anchor="b"/>
           <a:lstStyle/>
           <a:p>
             <a:pPr marL="0" indent="0">
@@ -4704,45 +4679,20 @@
               <a:buNone/>
             </a:pPr>
             <a:r>
-              <a:rPr lang="en-US" sz="950" b="1" dirty="0">
+              <a:rPr lang="en-US" sz="900" b="1" dirty="0">
                 <a:solidFill>
                   <a:schemeClr val="accent5"/>
                 </a:solidFill>
               </a:rPr>
-              <a:t>Responsable  </a:t>
-            </a:r>
-            <a:r>
-              <a:rPr lang="en-US" sz="950" dirty="0">
+              <a:t>Descargo  </a:t>
+            </a:r>
+            <a:r>
+              <a:rPr lang="en-US" sz="900" dirty="0">
                 <a:solidFill>
                   <a:schemeClr val="tx1"/>
                 </a:solidFill>
               </a:rPr>
-              <a:t>Gerencia General / Jefe de Administración de Riesgos</a:t>
-            </a:r>
-            <a:endParaRPr lang="en-US" sz="1000" dirty="0"/>
-          </a:p>
-          <a:p>
-            <a:pPr marL="0" indent="0">
-              <a:spcAft>
-                <a:spcPts val="100"/>
-              </a:spcAft>
-              <a:buNone/>
-            </a:pPr>
-            <a:r>
-              <a:rPr lang="en-US" sz="950" b="1" dirty="0">
-                <a:solidFill>
-                  <a:schemeClr val="accent5"/>
-                </a:solidFill>
-              </a:rPr>
-              <a:t>Descargo  </a:t>
-            </a:r>
-            <a:r>
-              <a:rPr lang="en-US" sz="950" dirty="0">
-                <a:solidFill>
-                  <a:schemeClr val="tx1"/>
-                </a:solidFill>
-              </a:rPr>
-              <a:t>Punto de Acta 2579 (28/04/2025): se derogó el convenio de confidencialidad del Consejo de Administración, Junta de Vigilancia y miembros de comités</a:t>
+              <a:t>Acta 2579 (28/04/2025): se derogó el convenio de confidencialidad</a:t>
             </a:r>
             <a:endParaRPr lang="en-US" sz="1000" dirty="0"/>
           </a:p>
@@ -4792,8 +4742,8 @@
         </p:nvSpPr>
         <p:spPr>
           <a:xfrm>
-            <a:off x="8219237" y="1508760"/>
-            <a:ext cx="384048" cy="384048"/>
+            <a:off x="8200949" y="1453896"/>
+            <a:ext cx="347472" cy="347472"/>
           </a:xfrm>
           <a:prstGeom prst="ellipse">
             <a:avLst/>
@@ -4826,8 +4776,8 @@
         </p:nvSpPr>
         <p:spPr>
           <a:xfrm>
-            <a:off x="8219237" y="1508760"/>
-            <a:ext cx="384048" cy="384048"/>
+            <a:off x="8200949" y="1453896"/>
+            <a:ext cx="347472" cy="347472"/>
           </a:xfrm>
           <a:prstGeom prst="rect">
             <a:avLst/>
@@ -4865,17 +4815,17 @@
         </p:nvSpPr>
         <p:spPr>
           <a:xfrm>
-            <a:off x="8722157" y="1399032"/>
-            <a:ext cx="2738018" cy="713232"/>
-          </a:xfrm>
-          <a:prstGeom prst="rect">
-            <a:avLst/>
-          </a:prstGeom>
-          <a:noFill/>
-          <a:ln/>
-        </p:spPr>
-        <p:txBody>
-          <a:bodyPr wrap="square" lIns="0" tIns="0" rIns="0" bIns="0" rtlCol="0" anchor="ctr"/>
+            <a:off x="8200949" y="1911096"/>
+            <a:ext cx="3277514" cy="603504"/>
+          </a:xfrm>
+          <a:prstGeom prst="rect">
+            <a:avLst/>
+          </a:prstGeom>
+          <a:noFill/>
+          <a:ln/>
+        </p:spPr>
+        <p:txBody>
+          <a:bodyPr wrap="square" lIns="0" tIns="0" rIns="0" bIns="0" rtlCol="0" anchor="t"/>
           <a:lstStyle/>
           <a:p>
             <a:pPr marL="0" indent="0">
@@ -4884,7 +4834,7 @@
             <a:r>
               <a:rPr lang="en-US" sz="1000" b="1" dirty="0">
                 <a:solidFill>
-                  <a:schemeClr val="tx1"/>
+                  <a:srgbClr val="173A6E"/>
                 </a:solidFill>
               </a:rPr>
               <a:t>Comités de Junta Directiva y Comités de Apoyo no cumplen con las especificaciones establecidas en el literal h) del Art. 3 de las Normas NRP-17</a:t>
@@ -4901,17 +4851,17 @@
         </p:nvSpPr>
         <p:spPr>
           <a:xfrm>
-            <a:off x="8219237" y="2148840"/>
-            <a:ext cx="3240938" cy="731520"/>
-          </a:xfrm>
-          <a:prstGeom prst="rect">
-            <a:avLst/>
-          </a:prstGeom>
-          <a:noFill/>
-          <a:ln/>
-        </p:spPr>
-        <p:txBody>
-          <a:bodyPr wrap="square" lIns="0" tIns="0" rIns="0" bIns="0" rtlCol="0" anchor="t"/>
+            <a:off x="8200949" y="2423160"/>
+            <a:ext cx="3277514" cy="429768"/>
+          </a:xfrm>
+          <a:prstGeom prst="rect">
+            <a:avLst/>
+          </a:prstGeom>
+          <a:noFill/>
+          <a:ln/>
+        </p:spPr>
+        <p:txBody>
+          <a:bodyPr wrap="square" lIns="0" tIns="0" rIns="0" bIns="0" rtlCol="0" anchor="b"/>
           <a:lstStyle/>
           <a:p>
             <a:pPr marL="0" indent="0">
@@ -4921,20 +4871,20 @@
               <a:buNone/>
             </a:pPr>
             <a:r>
-              <a:rPr lang="en-US" sz="950" b="1" dirty="0">
+              <a:rPr lang="en-US" sz="900" b="1" dirty="0">
                 <a:solidFill>
                   <a:schemeClr val="accent5"/>
                 </a:solidFill>
               </a:rPr>
-              <a:t>Responsable  </a:t>
-            </a:r>
-            <a:r>
-              <a:rPr lang="en-US" sz="950" dirty="0">
+              <a:t>Descargo  </a:t>
+            </a:r>
+            <a:r>
+              <a:rPr lang="en-US" sz="900" dirty="0">
                 <a:solidFill>
                   <a:schemeClr val="tx1"/>
                 </a:solidFill>
               </a:rPr>
-              <a:t>Gerencia General / Jefe de Administración de Riesgos</a:t>
+              <a:t>Integración sustentada en Estatutos (arts. 61 y 73)</a:t>
             </a:r>
             <a:endParaRPr lang="en-US" sz="1000" dirty="0"/>
           </a:p>
@@ -4946,32 +4896,7 @@
               <a:buNone/>
             </a:pPr>
             <a:r>
-              <a:rPr lang="en-US" sz="950" b="1" dirty="0">
-                <a:solidFill>
-                  <a:schemeClr val="accent5"/>
-                </a:solidFill>
-              </a:rPr>
-              <a:t>Descargo  </a:t>
-            </a:r>
-            <a:r>
-              <a:rPr lang="en-US" sz="950" dirty="0">
-                <a:solidFill>
-                  <a:schemeClr val="tx1"/>
-                </a:solidFill>
-              </a:rPr>
-              <a:t>Integración sustentada en Estatutos (arts. 61 y 73)</a:t>
-            </a:r>
-            <a:endParaRPr lang="en-US" sz="1000" dirty="0"/>
-          </a:p>
-          <a:p>
-            <a:pPr marL="0" indent="0">
-              <a:spcAft>
-                <a:spcPts val="100"/>
-              </a:spcAft>
-              <a:buNone/>
-            </a:pPr>
-            <a:r>
-              <a:rPr lang="en-US" sz="950" b="1" dirty="0">
+              <a:rPr lang="en-US" sz="900" b="1" dirty="0">
                 <a:solidFill>
                   <a:schemeClr val="accent3"/>
                 </a:solidFill>
@@ -5026,8 +4951,8 @@
         </p:nvSpPr>
         <p:spPr>
           <a:xfrm>
-            <a:off x="731520" y="3246120"/>
-            <a:ext cx="384048" cy="384048"/>
+            <a:off x="713232" y="3191256"/>
+            <a:ext cx="347472" cy="347472"/>
           </a:xfrm>
           <a:prstGeom prst="ellipse">
             <a:avLst/>
@@ -5060,8 +4985,8 @@
         </p:nvSpPr>
         <p:spPr>
           <a:xfrm>
-            <a:off x="731520" y="3246120"/>
-            <a:ext cx="384048" cy="384048"/>
+            <a:off x="713232" y="3191256"/>
+            <a:ext cx="347472" cy="347472"/>
           </a:xfrm>
           <a:prstGeom prst="rect">
             <a:avLst/>
@@ -5099,26 +5024,26 @@
         </p:nvSpPr>
         <p:spPr>
           <a:xfrm>
-            <a:off x="1234440" y="3136392"/>
-            <a:ext cx="2738018" cy="713232"/>
-          </a:xfrm>
-          <a:prstGeom prst="rect">
-            <a:avLst/>
-          </a:prstGeom>
-          <a:noFill/>
-          <a:ln/>
-        </p:spPr>
-        <p:txBody>
-          <a:bodyPr wrap="square" lIns="0" tIns="0" rIns="0" bIns="0" rtlCol="0" anchor="ctr"/>
-          <a:lstStyle/>
-          <a:p>
-            <a:pPr marL="0" indent="0">
-              <a:buNone/>
-            </a:pPr>
-            <a:r>
-              <a:rPr lang="en-US" sz="1000" b="1" dirty="0">
-                <a:solidFill>
-                  <a:schemeClr val="tx1"/>
+            <a:off x="713232" y="3648456"/>
+            <a:ext cx="3277514" cy="603504"/>
+          </a:xfrm>
+          <a:prstGeom prst="rect">
+            <a:avLst/>
+          </a:prstGeom>
+          <a:noFill/>
+          <a:ln/>
+        </p:spPr>
+        <p:txBody>
+          <a:bodyPr wrap="square" lIns="0" tIns="0" rIns="0" bIns="0" rtlCol="0" anchor="t"/>
+          <a:lstStyle/>
+          <a:p>
+            <a:pPr marL="0" indent="0">
+              <a:buNone/>
+            </a:pPr>
+            <a:r>
+              <a:rPr lang="en-US" sz="950" b="1" dirty="0">
+                <a:solidFill>
+                  <a:srgbClr val="173A6E"/>
                 </a:solidFill>
               </a:rPr>
               <a:t>Inconsistencia entre el pago de dietas establecido en el Reglamento de Compensaciones Económicas para Directivos y lo informado a la Asamblea General de Asociados en los puntos varios</a:t>
@@ -5135,17 +5060,17 @@
         </p:nvSpPr>
         <p:spPr>
           <a:xfrm>
-            <a:off x="731520" y="3886200"/>
-            <a:ext cx="3240938" cy="731520"/>
-          </a:xfrm>
-          <a:prstGeom prst="rect">
-            <a:avLst/>
-          </a:prstGeom>
-          <a:noFill/>
-          <a:ln/>
-        </p:spPr>
-        <p:txBody>
-          <a:bodyPr wrap="square" lIns="0" tIns="0" rIns="0" bIns="0" rtlCol="0" anchor="t"/>
+            <a:off x="713232" y="4160520"/>
+            <a:ext cx="3277514" cy="429768"/>
+          </a:xfrm>
+          <a:prstGeom prst="rect">
+            <a:avLst/>
+          </a:prstGeom>
+          <a:noFill/>
+          <a:ln/>
+        </p:spPr>
+        <p:txBody>
+          <a:bodyPr wrap="square" lIns="0" tIns="0" rIns="0" bIns="0" rtlCol="0" anchor="b"/>
           <a:lstStyle/>
           <a:p>
             <a:pPr marL="0" indent="0">
@@ -5155,40 +5080,15 @@
               <a:buNone/>
             </a:pPr>
             <a:r>
-              <a:rPr lang="en-US" sz="950" b="1" dirty="0">
+              <a:rPr lang="en-US" sz="900" b="1" dirty="0">
                 <a:solidFill>
                   <a:schemeClr val="accent5"/>
                 </a:solidFill>
               </a:rPr>
-              <a:t>Responsable  </a:t>
-            </a:r>
-            <a:r>
-              <a:rPr lang="en-US" sz="950" dirty="0">
-                <a:solidFill>
-                  <a:schemeClr val="tx1"/>
-                </a:solidFill>
-              </a:rPr>
-              <a:t>Gerencia General / Jefe de Administración de Riesgos</a:t>
-            </a:r>
-            <a:endParaRPr lang="en-US" sz="1000" dirty="0"/>
-          </a:p>
-          <a:p>
-            <a:pPr marL="0" indent="0">
-              <a:spcAft>
-                <a:spcPts val="100"/>
-              </a:spcAft>
-              <a:buNone/>
-            </a:pPr>
-            <a:r>
-              <a:rPr lang="en-US" sz="950" b="1" dirty="0">
-                <a:solidFill>
-                  <a:schemeClr val="accent5"/>
-                </a:solidFill>
-              </a:rPr>
               <a:t>Descargo  </a:t>
             </a:r>
             <a:r>
-              <a:rPr lang="en-US" sz="950" dirty="0">
+              <a:rPr lang="en-US" sz="900" dirty="0">
                 <a:solidFill>
                   <a:schemeClr val="tx1"/>
                 </a:solidFill>
@@ -5243,8 +5143,8 @@
         </p:nvSpPr>
         <p:spPr>
           <a:xfrm>
-            <a:off x="4475378" y="3246120"/>
-            <a:ext cx="384048" cy="384048"/>
+            <a:off x="4457090" y="3191256"/>
+            <a:ext cx="347472" cy="347472"/>
           </a:xfrm>
           <a:prstGeom prst="ellipse">
             <a:avLst/>
@@ -5277,8 +5177,8 @@
         </p:nvSpPr>
         <p:spPr>
           <a:xfrm>
-            <a:off x="4475378" y="3246120"/>
-            <a:ext cx="384048" cy="384048"/>
+            <a:off x="4457090" y="3191256"/>
+            <a:ext cx="347472" cy="347472"/>
           </a:xfrm>
           <a:prstGeom prst="rect">
             <a:avLst/>
@@ -5316,17 +5216,17 @@
         </p:nvSpPr>
         <p:spPr>
           <a:xfrm>
-            <a:off x="4978298" y="3136392"/>
-            <a:ext cx="2738018" cy="713232"/>
-          </a:xfrm>
-          <a:prstGeom prst="rect">
-            <a:avLst/>
-          </a:prstGeom>
-          <a:noFill/>
-          <a:ln/>
-        </p:spPr>
-        <p:txBody>
-          <a:bodyPr wrap="square" lIns="0" tIns="0" rIns="0" bIns="0" rtlCol="0" anchor="ctr"/>
+            <a:off x="4457090" y="3739896"/>
+            <a:ext cx="3277514" cy="603504"/>
+          </a:xfrm>
+          <a:prstGeom prst="rect">
+            <a:avLst/>
+          </a:prstGeom>
+          <a:noFill/>
+          <a:ln/>
+        </p:spPr>
+        <p:txBody>
+          <a:bodyPr wrap="square" lIns="0" tIns="0" rIns="0" bIns="0" rtlCol="0" anchor="t"/>
           <a:lstStyle/>
           <a:p>
             <a:pPr marL="0" indent="0">
@@ -5335,7 +5235,7 @@
             <a:r>
               <a:rPr lang="en-US" sz="1000" b="1" dirty="0">
                 <a:solidFill>
-                  <a:schemeClr val="tx1"/>
+                  <a:srgbClr val="173A6E"/>
                 </a:solidFill>
               </a:rPr>
               <a:t>Normativa interna desactualizada</a:t>
@@ -5352,17 +5252,17 @@
         </p:nvSpPr>
         <p:spPr>
           <a:xfrm>
-            <a:off x="4475378" y="3886200"/>
-            <a:ext cx="3240938" cy="731520"/>
-          </a:xfrm>
-          <a:prstGeom prst="rect">
-            <a:avLst/>
-          </a:prstGeom>
-          <a:noFill/>
-          <a:ln/>
-        </p:spPr>
-        <p:txBody>
-          <a:bodyPr wrap="square" lIns="0" tIns="0" rIns="0" bIns="0" rtlCol="0" anchor="t"/>
+            <a:off x="4457090" y="4160520"/>
+            <a:ext cx="3277514" cy="429768"/>
+          </a:xfrm>
+          <a:prstGeom prst="rect">
+            <a:avLst/>
+          </a:prstGeom>
+          <a:noFill/>
+          <a:ln/>
+        </p:spPr>
+        <p:txBody>
+          <a:bodyPr wrap="square" lIns="0" tIns="0" rIns="0" bIns="0" rtlCol="0" anchor="b"/>
           <a:lstStyle/>
           <a:p>
             <a:pPr marL="0" indent="0">
@@ -5372,20 +5272,20 @@
               <a:buNone/>
             </a:pPr>
             <a:r>
-              <a:rPr lang="en-US" sz="950" b="1" dirty="0">
+              <a:rPr lang="en-US" sz="900" b="1" dirty="0">
                 <a:solidFill>
                   <a:schemeClr val="accent5"/>
                 </a:solidFill>
               </a:rPr>
-              <a:t>Responsable  </a:t>
-            </a:r>
-            <a:r>
-              <a:rPr lang="en-US" sz="950" dirty="0">
+              <a:t>Descargo  </a:t>
+            </a:r>
+            <a:r>
+              <a:rPr lang="en-US" sz="900" dirty="0">
                 <a:solidFill>
                   <a:schemeClr val="tx1"/>
                 </a:solidFill>
               </a:rPr>
-              <a:t>Gerencia General / Jefe de Administración de Riesgos, Auditoría Interna, Gerencia de Finanzas, Seguridad de la Información y Gerencia Administrativa</a:t>
+              <a:t>3 de 9 documentos actualizados; el resto en proceso</a:t>
             </a:r>
             <a:endParaRPr lang="en-US" sz="1000" dirty="0"/>
           </a:p>
@@ -5397,32 +5297,7 @@
               <a:buNone/>
             </a:pPr>
             <a:r>
-              <a:rPr lang="en-US" sz="950" b="1" dirty="0">
-                <a:solidFill>
-                  <a:schemeClr val="accent5"/>
-                </a:solidFill>
-              </a:rPr>
-              <a:t>Descargo  </a:t>
-            </a:r>
-            <a:r>
-              <a:rPr lang="en-US" sz="950" dirty="0">
-                <a:solidFill>
-                  <a:schemeClr val="tx1"/>
-                </a:solidFill>
-              </a:rPr>
-              <a:t>3 de 9 documentos actualizados; el resto en proceso</a:t>
-            </a:r>
-            <a:endParaRPr lang="en-US" sz="1000" dirty="0"/>
-          </a:p>
-          <a:p>
-            <a:pPr marL="0" indent="0">
-              <a:spcAft>
-                <a:spcPts val="100"/>
-              </a:spcAft>
-              <a:buNone/>
-            </a:pPr>
-            <a:r>
-              <a:rPr lang="en-US" sz="950" b="1" dirty="0">
+              <a:rPr lang="en-US" sz="900" b="1" dirty="0">
                 <a:solidFill>
                   <a:schemeClr val="accent3"/>
                 </a:solidFill>
@@ -5477,8 +5352,8 @@
         </p:nvSpPr>
         <p:spPr>
           <a:xfrm>
-            <a:off x="8219237" y="3246120"/>
-            <a:ext cx="384048" cy="384048"/>
+            <a:off x="8200949" y="3191256"/>
+            <a:ext cx="347472" cy="347472"/>
           </a:xfrm>
           <a:prstGeom prst="ellipse">
             <a:avLst/>
@@ -5511,8 +5386,8 @@
         </p:nvSpPr>
         <p:spPr>
           <a:xfrm>
-            <a:off x="8219237" y="3246120"/>
-            <a:ext cx="384048" cy="384048"/>
+            <a:off x="8200949" y="3191256"/>
+            <a:ext cx="347472" cy="347472"/>
           </a:xfrm>
           <a:prstGeom prst="rect">
             <a:avLst/>
@@ -5550,17 +5425,17 @@
         </p:nvSpPr>
         <p:spPr>
           <a:xfrm>
-            <a:off x="8722157" y="3136392"/>
-            <a:ext cx="2738018" cy="713232"/>
-          </a:xfrm>
-          <a:prstGeom prst="rect">
-            <a:avLst/>
-          </a:prstGeom>
-          <a:noFill/>
-          <a:ln/>
-        </p:spPr>
-        <p:txBody>
-          <a:bodyPr wrap="square" lIns="0" tIns="0" rIns="0" bIns="0" rtlCol="0" anchor="ctr"/>
+            <a:off x="8200949" y="3648456"/>
+            <a:ext cx="3277514" cy="603504"/>
+          </a:xfrm>
+          <a:prstGeom prst="rect">
+            <a:avLst/>
+          </a:prstGeom>
+          <a:noFill/>
+          <a:ln/>
+        </p:spPr>
+        <p:txBody>
+          <a:bodyPr wrap="square" lIns="0" tIns="0" rIns="0" bIns="0" rtlCol="0" anchor="t"/>
           <a:lstStyle/>
           <a:p>
             <a:pPr marL="0" indent="0">
@@ -5569,7 +5444,7 @@
             <a:r>
               <a:rPr lang="en-US" sz="1000" b="1" dirty="0">
                 <a:solidFill>
-                  <a:schemeClr val="tx1"/>
+                  <a:srgbClr val="173A6E"/>
                 </a:solidFill>
               </a:rPr>
               <a:t>Falta de documentación soporte en los expedientes de créditos otorgados mediante Ferias de Créditos</a:t>
@@ -5586,17 +5461,17 @@
         </p:nvSpPr>
         <p:spPr>
           <a:xfrm>
-            <a:off x="8219237" y="3886200"/>
-            <a:ext cx="3240938" cy="731520"/>
-          </a:xfrm>
-          <a:prstGeom prst="rect">
-            <a:avLst/>
-          </a:prstGeom>
-          <a:noFill/>
-          <a:ln/>
-        </p:spPr>
-        <p:txBody>
-          <a:bodyPr wrap="square" lIns="0" tIns="0" rIns="0" bIns="0" rtlCol="0" anchor="t"/>
+            <a:off x="8200949" y="4160520"/>
+            <a:ext cx="3277514" cy="429768"/>
+          </a:xfrm>
+          <a:prstGeom prst="rect">
+            <a:avLst/>
+          </a:prstGeom>
+          <a:noFill/>
+          <a:ln/>
+        </p:spPr>
+        <p:txBody>
+          <a:bodyPr wrap="square" lIns="0" tIns="0" rIns="0" bIns="0" rtlCol="0" anchor="b"/>
           <a:lstStyle/>
           <a:p>
             <a:pPr marL="0" indent="0">
@@ -5606,40 +5481,15 @@
               <a:buNone/>
             </a:pPr>
             <a:r>
-              <a:rPr lang="en-US" sz="950" b="1" dirty="0">
+              <a:rPr lang="en-US" sz="900" b="1" dirty="0">
                 <a:solidFill>
                   <a:schemeClr val="accent5"/>
                 </a:solidFill>
               </a:rPr>
-              <a:t>Responsable  </a:t>
-            </a:r>
-            <a:r>
-              <a:rPr lang="en-US" sz="950" dirty="0">
-                <a:solidFill>
-                  <a:schemeClr val="tx1"/>
-                </a:solidFill>
-              </a:rPr>
-              <a:t>Gerencia de Negocios / Administración de Cartera</a:t>
-            </a:r>
-            <a:endParaRPr lang="en-US" sz="1000" dirty="0"/>
-          </a:p>
-          <a:p>
-            <a:pPr marL="0" indent="0">
-              <a:spcAft>
-                <a:spcPts val="100"/>
-              </a:spcAft>
-              <a:buNone/>
-            </a:pPr>
-            <a:r>
-              <a:rPr lang="en-US" sz="950" b="1" dirty="0">
-                <a:solidFill>
-                  <a:schemeClr val="accent5"/>
-                </a:solidFill>
-              </a:rPr>
               <a:t>Descargo  </a:t>
             </a:r>
             <a:r>
-              <a:rPr lang="en-US" sz="950" dirty="0">
+              <a:rPr lang="en-US" sz="900" dirty="0">
                 <a:solidFill>
                   <a:schemeClr val="tx1"/>
                 </a:solidFill>
@@ -5694,8 +5544,8 @@
         </p:nvSpPr>
         <p:spPr>
           <a:xfrm>
-            <a:off x="731520" y="4983480"/>
-            <a:ext cx="384048" cy="384048"/>
+            <a:off x="713232" y="4928616"/>
+            <a:ext cx="347472" cy="347472"/>
           </a:xfrm>
           <a:prstGeom prst="ellipse">
             <a:avLst/>
@@ -5728,8 +5578,8 @@
         </p:nvSpPr>
         <p:spPr>
           <a:xfrm>
-            <a:off x="731520" y="4983480"/>
-            <a:ext cx="384048" cy="384048"/>
+            <a:off x="713232" y="4928616"/>
+            <a:ext cx="347472" cy="347472"/>
           </a:xfrm>
           <a:prstGeom prst="rect">
             <a:avLst/>
@@ -5767,17 +5617,17 @@
         </p:nvSpPr>
         <p:spPr>
           <a:xfrm>
-            <a:off x="1234440" y="4873752"/>
-            <a:ext cx="2738018" cy="713232"/>
-          </a:xfrm>
-          <a:prstGeom prst="rect">
-            <a:avLst/>
-          </a:prstGeom>
-          <a:noFill/>
-          <a:ln/>
-        </p:spPr>
-        <p:txBody>
-          <a:bodyPr wrap="square" lIns="0" tIns="0" rIns="0" bIns="0" rtlCol="0" anchor="ctr"/>
+            <a:off x="713232" y="5385816"/>
+            <a:ext cx="3277514" cy="603504"/>
+          </a:xfrm>
+          <a:prstGeom prst="rect">
+            <a:avLst/>
+          </a:prstGeom>
+          <a:noFill/>
+          <a:ln/>
+        </p:spPr>
+        <p:txBody>
+          <a:bodyPr wrap="square" lIns="0" tIns="0" rIns="0" bIns="0" rtlCol="0" anchor="t"/>
           <a:lstStyle/>
           <a:p>
             <a:pPr marL="0" indent="0">
@@ -5786,7 +5636,7 @@
             <a:r>
               <a:rPr lang="en-US" sz="1000" b="1" dirty="0">
                 <a:solidFill>
-                  <a:schemeClr val="tx1"/>
+                  <a:srgbClr val="173A6E"/>
                 </a:solidFill>
               </a:rPr>
               <a:t>Falta de información obligatoria en la declaración jurada de personas relacionadas conforme a lo dispuesto en el Art. 9 de las Normas NRP-75</a:t>
@@ -5803,17 +5653,17 @@
         </p:nvSpPr>
         <p:spPr>
           <a:xfrm>
-            <a:off x="731520" y="5623560"/>
-            <a:ext cx="3240938" cy="731520"/>
-          </a:xfrm>
-          <a:prstGeom prst="rect">
-            <a:avLst/>
-          </a:prstGeom>
-          <a:noFill/>
-          <a:ln/>
-        </p:spPr>
-        <p:txBody>
-          <a:bodyPr wrap="square" lIns="0" tIns="0" rIns="0" bIns="0" rtlCol="0" anchor="t"/>
+            <a:off x="713232" y="5897880"/>
+            <a:ext cx="3277514" cy="429768"/>
+          </a:xfrm>
+          <a:prstGeom prst="rect">
+            <a:avLst/>
+          </a:prstGeom>
+          <a:noFill/>
+          <a:ln/>
+        </p:spPr>
+        <p:txBody>
+          <a:bodyPr wrap="square" lIns="0" tIns="0" rIns="0" bIns="0" rtlCol="0" anchor="b"/>
           <a:lstStyle/>
           <a:p>
             <a:pPr marL="0" indent="0">
@@ -5823,40 +5673,15 @@
               <a:buNone/>
             </a:pPr>
             <a:r>
-              <a:rPr lang="en-US" sz="950" b="1" dirty="0">
+              <a:rPr lang="en-US" sz="900" b="1" dirty="0">
                 <a:solidFill>
                   <a:schemeClr val="accent5"/>
                 </a:solidFill>
               </a:rPr>
-              <a:t>Responsable  </a:t>
-            </a:r>
-            <a:r>
-              <a:rPr lang="en-US" sz="950" dirty="0">
-                <a:solidFill>
-                  <a:schemeClr val="tx1"/>
-                </a:solidFill>
-              </a:rPr>
-              <a:t>Gerencia General / Jefe de Administración de Riesgos</a:t>
-            </a:r>
-            <a:endParaRPr lang="en-US" sz="1000" dirty="0"/>
-          </a:p>
-          <a:p>
-            <a:pPr marL="0" indent="0">
-              <a:spcAft>
-                <a:spcPts val="100"/>
-              </a:spcAft>
-              <a:buNone/>
-            </a:pPr>
-            <a:r>
-              <a:rPr lang="en-US" sz="950" b="1" dirty="0">
-                <a:solidFill>
-                  <a:schemeClr val="accent5"/>
-                </a:solidFill>
-              </a:rPr>
               <a:t>Descargo  </a:t>
             </a:r>
             <a:r>
-              <a:rPr lang="en-US" sz="950" dirty="0">
+              <a:rPr lang="en-US" sz="900" dirty="0">
                 <a:solidFill>
                   <a:schemeClr val="tx1"/>
                 </a:solidFill>
@@ -5911,8 +5736,8 @@
         </p:nvSpPr>
         <p:spPr>
           <a:xfrm>
-            <a:off x="4475378" y="4983480"/>
-            <a:ext cx="384048" cy="384048"/>
+            <a:off x="4457090" y="4928616"/>
+            <a:ext cx="347472" cy="347472"/>
           </a:xfrm>
           <a:prstGeom prst="ellipse">
             <a:avLst/>
@@ -5945,8 +5770,8 @@
         </p:nvSpPr>
         <p:spPr>
           <a:xfrm>
-            <a:off x="4475378" y="4983480"/>
-            <a:ext cx="384048" cy="384048"/>
+            <a:off x="4457090" y="4928616"/>
+            <a:ext cx="347472" cy="347472"/>
           </a:xfrm>
           <a:prstGeom prst="rect">
             <a:avLst/>
@@ -5984,17 +5809,17 @@
         </p:nvSpPr>
         <p:spPr>
           <a:xfrm>
-            <a:off x="4978298" y="4873752"/>
-            <a:ext cx="2738018" cy="713232"/>
-          </a:xfrm>
-          <a:prstGeom prst="rect">
-            <a:avLst/>
-          </a:prstGeom>
-          <a:noFill/>
-          <a:ln/>
-        </p:spPr>
-        <p:txBody>
-          <a:bodyPr wrap="square" lIns="0" tIns="0" rIns="0" bIns="0" rtlCol="0" anchor="ctr"/>
+            <a:off x="4457090" y="5385816"/>
+            <a:ext cx="3277514" cy="603504"/>
+          </a:xfrm>
+          <a:prstGeom prst="rect">
+            <a:avLst/>
+          </a:prstGeom>
+          <a:noFill/>
+          <a:ln/>
+        </p:spPr>
+        <p:txBody>
+          <a:bodyPr wrap="square" lIns="0" tIns="0" rIns="0" bIns="0" rtlCol="0" anchor="t"/>
           <a:lstStyle/>
           <a:p>
             <a:pPr marL="0" indent="0">
@@ -6003,7 +5828,7 @@
             <a:r>
               <a:rPr lang="en-US" sz="1000" b="1" dirty="0">
                 <a:solidFill>
-                  <a:schemeClr val="tx1"/>
+                  <a:srgbClr val="173A6E"/>
                 </a:solidFill>
               </a:rPr>
               <a:t>Falta de aplicación de procedimientos internos establecidos en el Manual de Compras de Bienes y Servicios</a:t>
@@ -6020,17 +5845,17 @@
         </p:nvSpPr>
         <p:spPr>
           <a:xfrm>
-            <a:off x="4475378" y="5623560"/>
-            <a:ext cx="3240938" cy="731520"/>
-          </a:xfrm>
-          <a:prstGeom prst="rect">
-            <a:avLst/>
-          </a:prstGeom>
-          <a:noFill/>
-          <a:ln/>
-        </p:spPr>
-        <p:txBody>
-          <a:bodyPr wrap="square" lIns="0" tIns="0" rIns="0" bIns="0" rtlCol="0" anchor="t"/>
+            <a:off x="4457090" y="5897880"/>
+            <a:ext cx="3277514" cy="429768"/>
+          </a:xfrm>
+          <a:prstGeom prst="rect">
+            <a:avLst/>
+          </a:prstGeom>
+          <a:noFill/>
+          <a:ln/>
+        </p:spPr>
+        <p:txBody>
+          <a:bodyPr wrap="square" lIns="0" tIns="0" rIns="0" bIns="0" rtlCol="0" anchor="b"/>
           <a:lstStyle/>
           <a:p>
             <a:pPr marL="0" indent="0">
@@ -6040,40 +5865,15 @@
               <a:buNone/>
             </a:pPr>
             <a:r>
-              <a:rPr lang="en-US" sz="950" b="1" dirty="0">
+              <a:rPr lang="en-US" sz="900" b="1" dirty="0">
                 <a:solidFill>
                   <a:schemeClr val="accent5"/>
                 </a:solidFill>
               </a:rPr>
-              <a:t>Responsable  </a:t>
-            </a:r>
-            <a:r>
-              <a:rPr lang="en-US" sz="950" dirty="0">
-                <a:solidFill>
-                  <a:schemeClr val="tx1"/>
-                </a:solidFill>
-              </a:rPr>
-              <a:t>Gerencia Administrativa</a:t>
-            </a:r>
-            <a:endParaRPr lang="en-US" sz="1000" dirty="0"/>
-          </a:p>
-          <a:p>
-            <a:pPr marL="0" indent="0">
-              <a:spcAft>
-                <a:spcPts val="100"/>
-              </a:spcAft>
-              <a:buNone/>
-            </a:pPr>
-            <a:r>
-              <a:rPr lang="en-US" sz="950" b="1" dirty="0">
-                <a:solidFill>
-                  <a:schemeClr val="accent5"/>
-                </a:solidFill>
-              </a:rPr>
               <a:t>Descargo  </a:t>
             </a:r>
             <a:r>
-              <a:rPr lang="en-US" sz="950" dirty="0">
+              <a:rPr lang="en-US" sz="900" dirty="0">
                 <a:solidFill>
                   <a:schemeClr val="tx1"/>
                 </a:solidFill>
@@ -6128,8 +5928,8 @@
         </p:nvSpPr>
         <p:spPr>
           <a:xfrm>
-            <a:off x="8219237" y="4983480"/>
-            <a:ext cx="384048" cy="384048"/>
+            <a:off x="8200949" y="4928616"/>
+            <a:ext cx="347472" cy="347472"/>
           </a:xfrm>
           <a:prstGeom prst="ellipse">
             <a:avLst/>
@@ -6162,8 +5962,8 @@
         </p:nvSpPr>
         <p:spPr>
           <a:xfrm>
-            <a:off x="8219237" y="4983480"/>
-            <a:ext cx="384048" cy="384048"/>
+            <a:off x="8200949" y="4928616"/>
+            <a:ext cx="347472" cy="347472"/>
           </a:xfrm>
           <a:prstGeom prst="rect">
             <a:avLst/>
@@ -6201,17 +6001,17 @@
         </p:nvSpPr>
         <p:spPr>
           <a:xfrm>
-            <a:off x="8722157" y="4873752"/>
-            <a:ext cx="2738018" cy="713232"/>
-          </a:xfrm>
-          <a:prstGeom prst="rect">
-            <a:avLst/>
-          </a:prstGeom>
-          <a:noFill/>
-          <a:ln/>
-        </p:spPr>
-        <p:txBody>
-          <a:bodyPr wrap="square" lIns="0" tIns="0" rIns="0" bIns="0" rtlCol="0" anchor="ctr"/>
+            <a:off x="8200949" y="5385816"/>
+            <a:ext cx="3277514" cy="603504"/>
+          </a:xfrm>
+          <a:prstGeom prst="rect">
+            <a:avLst/>
+          </a:prstGeom>
+          <a:noFill/>
+          <a:ln/>
+        </p:spPr>
+        <p:txBody>
+          <a:bodyPr wrap="square" lIns="0" tIns="0" rIns="0" bIns="0" rtlCol="0" anchor="t"/>
           <a:lstStyle/>
           <a:p>
             <a:pPr marL="0" indent="0">
@@ -6220,7 +6020,7 @@
             <a:r>
               <a:rPr lang="en-US" sz="1000" b="1" dirty="0">
                 <a:solidFill>
-                  <a:schemeClr val="tx1"/>
+                  <a:srgbClr val="173A6E"/>
                 </a:solidFill>
               </a:rPr>
               <a:t>Utilización del Fondo de Educación con fines distintos a los establecidos en el marco legal</a:t>
@@ -6237,17 +6037,17 @@
         </p:nvSpPr>
         <p:spPr>
           <a:xfrm>
-            <a:off x="8219237" y="5623560"/>
-            <a:ext cx="3240938" cy="731520"/>
-          </a:xfrm>
-          <a:prstGeom prst="rect">
-            <a:avLst/>
-          </a:prstGeom>
-          <a:noFill/>
-          <a:ln/>
-        </p:spPr>
-        <p:txBody>
-          <a:bodyPr wrap="square" lIns="0" tIns="0" rIns="0" bIns="0" rtlCol="0" anchor="t"/>
+            <a:off x="8200949" y="5897880"/>
+            <a:ext cx="3277514" cy="429768"/>
+          </a:xfrm>
+          <a:prstGeom prst="rect">
+            <a:avLst/>
+          </a:prstGeom>
+          <a:noFill/>
+          <a:ln/>
+        </p:spPr>
+        <p:txBody>
+          <a:bodyPr wrap="square" lIns="0" tIns="0" rIns="0" bIns="0" rtlCol="0" anchor="b"/>
           <a:lstStyle/>
           <a:p>
             <a:pPr marL="0" indent="0">
@@ -6257,40 +6057,15 @@
               <a:buNone/>
             </a:pPr>
             <a:r>
-              <a:rPr lang="en-US" sz="950" b="1" dirty="0">
+              <a:rPr lang="en-US" sz="900" b="1" dirty="0">
                 <a:solidFill>
                   <a:schemeClr val="accent5"/>
                 </a:solidFill>
               </a:rPr>
-              <a:t>Responsable  </a:t>
-            </a:r>
-            <a:r>
-              <a:rPr lang="en-US" sz="950" dirty="0">
-                <a:solidFill>
-                  <a:schemeClr val="tx1"/>
-                </a:solidFill>
-              </a:rPr>
-              <a:t>Gerencia General / Jefe de Administración de Riesgos</a:t>
-            </a:r>
-            <a:endParaRPr lang="en-US" sz="1000" dirty="0"/>
-          </a:p>
-          <a:p>
-            <a:pPr marL="0" indent="0">
-              <a:spcAft>
-                <a:spcPts val="100"/>
-              </a:spcAft>
-              <a:buNone/>
-            </a:pPr>
-            <a:r>
-              <a:rPr lang="en-US" sz="950" b="1" dirty="0">
-                <a:solidFill>
-                  <a:schemeClr val="accent5"/>
-                </a:solidFill>
-              </a:rPr>
               <a:t>Descargo  </a:t>
             </a:r>
             <a:r>
-              <a:rPr lang="en-US" sz="950" dirty="0">
+              <a:rPr lang="en-US" sz="900" dirty="0">
                 <a:solidFill>
                   <a:schemeClr val="tx1"/>
                 </a:solidFill>
@@ -6343,6 +6118,456 @@
               <a:t>2</a:t>
             </a:fld>
             <a:endParaRPr lang="en-US"/>
+          </a:p>
+        </p:txBody>
+      </p:sp>
+      <p:sp>
+        <p:nvSpPr>
+          <p:cNvPr id="11" name="Responsable 2025-1"/>
+          <p:cNvSpPr txBox="1"/>
+          <p:nvPr/>
+        </p:nvSpPr>
+        <p:spPr>
+          <a:xfrm>
+            <a:off x="1170432" y="1417320"/>
+            <a:ext cx="2829458" cy="420624"/>
+          </a:xfrm>
+          <a:prstGeom prst="rect">
+            <a:avLst/>
+          </a:prstGeom>
+          <a:noFill/>
+          <a:ln/>
+        </p:spPr>
+        <p:txBody>
+          <a:bodyPr wrap="square" lIns="0" tIns="0" rIns="0" bIns="0" rtlCol="0" anchor="ctr"/>
+          <a:lstStyle/>
+          <a:p>
+            <a:pPr marL="0" indent="0">
+              <a:buNone/>
+            </a:pPr>
+            <a:r>
+              <a:rPr lang="en-US" sz="800" b="1" dirty="0">
+                <a:solidFill>
+                  <a:srgbClr val="586579"/>
+                </a:solidFill>
+              </a:rPr>
+              <a:t>RESPONSABLE</a:t>
+            </a:r>
+            <a:endParaRPr lang="en-US" sz="1250" dirty="0"/>
+          </a:p>
+          <a:p>
+            <a:pPr marL="0" indent="0">
+              <a:buNone/>
+            </a:pPr>
+            <a:r>
+              <a:rPr lang="en-US" sz="900" b="0" dirty="0">
+                <a:solidFill>
+                  <a:srgbClr val="142033"/>
+                </a:solidFill>
+              </a:rPr>
+              <a:t>Gerencia General / Jefe de Administración de Riesgos</a:t>
+            </a:r>
+            <a:endParaRPr lang="en-US" sz="1250" dirty="0"/>
+          </a:p>
+        </p:txBody>
+      </p:sp>
+      <p:sp>
+        <p:nvSpPr>
+          <p:cNvPr id="16" name="Responsable 2025-2"/>
+          <p:cNvSpPr txBox="1"/>
+          <p:nvPr/>
+        </p:nvSpPr>
+        <p:spPr>
+          <a:xfrm>
+            <a:off x="4914290" y="1417320"/>
+            <a:ext cx="2829458" cy="420624"/>
+          </a:xfrm>
+          <a:prstGeom prst="rect">
+            <a:avLst/>
+          </a:prstGeom>
+          <a:noFill/>
+          <a:ln/>
+        </p:spPr>
+        <p:txBody>
+          <a:bodyPr wrap="square" lIns="0" tIns="0" rIns="0" bIns="0" rtlCol="0" anchor="ctr"/>
+          <a:lstStyle/>
+          <a:p>
+            <a:pPr marL="0" indent="0">
+              <a:buNone/>
+            </a:pPr>
+            <a:r>
+              <a:rPr lang="en-US" sz="800" b="1" dirty="0">
+                <a:solidFill>
+                  <a:srgbClr val="586579"/>
+                </a:solidFill>
+              </a:rPr>
+              <a:t>RESPONSABLE</a:t>
+            </a:r>
+            <a:endParaRPr lang="en-US" sz="1250" dirty="0"/>
+          </a:p>
+          <a:p>
+            <a:pPr marL="0" indent="0">
+              <a:buNone/>
+            </a:pPr>
+            <a:r>
+              <a:rPr lang="en-US" sz="900" b="0" dirty="0">
+                <a:solidFill>
+                  <a:srgbClr val="142033"/>
+                </a:solidFill>
+              </a:rPr>
+              <a:t>Gerencia General / Jefe de Administración de Riesgos</a:t>
+            </a:r>
+            <a:endParaRPr lang="en-US" sz="1250" dirty="0"/>
+          </a:p>
+        </p:txBody>
+      </p:sp>
+      <p:sp>
+        <p:nvSpPr>
+          <p:cNvPr id="21" name="Responsable 2025-3"/>
+          <p:cNvSpPr txBox="1"/>
+          <p:nvPr/>
+        </p:nvSpPr>
+        <p:spPr>
+          <a:xfrm>
+            <a:off x="8658149" y="1417320"/>
+            <a:ext cx="2829458" cy="420624"/>
+          </a:xfrm>
+          <a:prstGeom prst="rect">
+            <a:avLst/>
+          </a:prstGeom>
+          <a:noFill/>
+          <a:ln/>
+        </p:spPr>
+        <p:txBody>
+          <a:bodyPr wrap="square" lIns="0" tIns="0" rIns="0" bIns="0" rtlCol="0" anchor="ctr"/>
+          <a:lstStyle/>
+          <a:p>
+            <a:pPr marL="0" indent="0">
+              <a:buNone/>
+            </a:pPr>
+            <a:r>
+              <a:rPr lang="en-US" sz="800" b="1" dirty="0">
+                <a:solidFill>
+                  <a:srgbClr val="586579"/>
+                </a:solidFill>
+              </a:rPr>
+              <a:t>RESPONSABLE</a:t>
+            </a:r>
+            <a:endParaRPr lang="en-US" sz="1250" dirty="0"/>
+          </a:p>
+          <a:p>
+            <a:pPr marL="0" indent="0">
+              <a:buNone/>
+            </a:pPr>
+            <a:r>
+              <a:rPr lang="en-US" sz="900" b="0" dirty="0">
+                <a:solidFill>
+                  <a:srgbClr val="142033"/>
+                </a:solidFill>
+              </a:rPr>
+              <a:t>Gerencia General / Jefe de Administración de Riesgos</a:t>
+            </a:r>
+            <a:endParaRPr lang="en-US" sz="1250" dirty="0"/>
+          </a:p>
+        </p:txBody>
+      </p:sp>
+      <p:sp>
+        <p:nvSpPr>
+          <p:cNvPr id="26" name="Responsable 2025-4"/>
+          <p:cNvSpPr txBox="1"/>
+          <p:nvPr/>
+        </p:nvSpPr>
+        <p:spPr>
+          <a:xfrm>
+            <a:off x="1170432" y="3154680"/>
+            <a:ext cx="2829458" cy="420624"/>
+          </a:xfrm>
+          <a:prstGeom prst="rect">
+            <a:avLst/>
+          </a:prstGeom>
+          <a:noFill/>
+          <a:ln/>
+        </p:spPr>
+        <p:txBody>
+          <a:bodyPr wrap="square" lIns="0" tIns="0" rIns="0" bIns="0" rtlCol="0" anchor="ctr"/>
+          <a:lstStyle/>
+          <a:p>
+            <a:pPr marL="0" indent="0">
+              <a:buNone/>
+            </a:pPr>
+            <a:r>
+              <a:rPr lang="en-US" sz="800" b="1" dirty="0">
+                <a:solidFill>
+                  <a:srgbClr val="586579"/>
+                </a:solidFill>
+              </a:rPr>
+              <a:t>RESPONSABLE</a:t>
+            </a:r>
+            <a:endParaRPr lang="en-US" sz="1250" dirty="0"/>
+          </a:p>
+          <a:p>
+            <a:pPr marL="0" indent="0">
+              <a:buNone/>
+            </a:pPr>
+            <a:r>
+              <a:rPr lang="en-US" sz="900" b="0" dirty="0">
+                <a:solidFill>
+                  <a:srgbClr val="142033"/>
+                </a:solidFill>
+              </a:rPr>
+              <a:t>Gerencia General / Jefe de Administración de Riesgos</a:t>
+            </a:r>
+            <a:endParaRPr lang="en-US" sz="1250" dirty="0"/>
+          </a:p>
+        </p:txBody>
+      </p:sp>
+      <p:sp>
+        <p:nvSpPr>
+          <p:cNvPr id="31" name="Responsable 2025-5"/>
+          <p:cNvSpPr txBox="1"/>
+          <p:nvPr/>
+        </p:nvSpPr>
+        <p:spPr>
+          <a:xfrm>
+            <a:off x="4914290" y="3108960"/>
+            <a:ext cx="2829458" cy="585216"/>
+          </a:xfrm>
+          <a:prstGeom prst="rect">
+            <a:avLst/>
+          </a:prstGeom>
+          <a:noFill/>
+          <a:ln/>
+        </p:spPr>
+        <p:txBody>
+          <a:bodyPr wrap="square" lIns="0" tIns="0" rIns="0" bIns="0" rtlCol="0" anchor="ctr"/>
+          <a:lstStyle/>
+          <a:p>
+            <a:pPr marL="0" indent="0">
+              <a:buNone/>
+            </a:pPr>
+            <a:r>
+              <a:rPr lang="en-US" sz="800" b="1" dirty="0">
+                <a:solidFill>
+                  <a:srgbClr val="586579"/>
+                </a:solidFill>
+              </a:rPr>
+              <a:t>RESPONSABLE</a:t>
+            </a:r>
+            <a:endParaRPr lang="en-US" sz="1250" dirty="0"/>
+          </a:p>
+          <a:p>
+            <a:pPr marL="0" indent="0">
+              <a:buNone/>
+            </a:pPr>
+            <a:r>
+              <a:rPr lang="en-US" sz="900" b="0" dirty="0">
+                <a:solidFill>
+                  <a:srgbClr val="142033"/>
+                </a:solidFill>
+              </a:rPr>
+              <a:t>Gerencia General / Jefe de Administración de Riesgos, Auditoría Interna, Gerencia de Finanzas, Seguridad de la Información y Gerencia Administrativa</a:t>
+            </a:r>
+            <a:endParaRPr lang="en-US" sz="1250" dirty="0"/>
+          </a:p>
+        </p:txBody>
+      </p:sp>
+      <p:sp>
+        <p:nvSpPr>
+          <p:cNvPr id="36" name="Responsable 2025-6"/>
+          <p:cNvSpPr txBox="1"/>
+          <p:nvPr/>
+        </p:nvSpPr>
+        <p:spPr>
+          <a:xfrm>
+            <a:off x="8658149" y="3154680"/>
+            <a:ext cx="2829458" cy="420624"/>
+          </a:xfrm>
+          <a:prstGeom prst="rect">
+            <a:avLst/>
+          </a:prstGeom>
+          <a:noFill/>
+          <a:ln/>
+        </p:spPr>
+        <p:txBody>
+          <a:bodyPr wrap="square" lIns="0" tIns="0" rIns="0" bIns="0" rtlCol="0" anchor="ctr"/>
+          <a:lstStyle/>
+          <a:p>
+            <a:pPr marL="0" indent="0">
+              <a:buNone/>
+            </a:pPr>
+            <a:r>
+              <a:rPr lang="en-US" sz="800" b="1" dirty="0">
+                <a:solidFill>
+                  <a:srgbClr val="586579"/>
+                </a:solidFill>
+              </a:rPr>
+              <a:t>RESPONSABLE</a:t>
+            </a:r>
+            <a:endParaRPr lang="en-US" sz="1250" dirty="0"/>
+          </a:p>
+          <a:p>
+            <a:pPr marL="0" indent="0">
+              <a:buNone/>
+            </a:pPr>
+            <a:r>
+              <a:rPr lang="en-US" sz="900" b="0" dirty="0">
+                <a:solidFill>
+                  <a:srgbClr val="142033"/>
+                </a:solidFill>
+              </a:rPr>
+              <a:t>Gerencia de Negocios / Administración de Cartera</a:t>
+            </a:r>
+            <a:endParaRPr lang="en-US" sz="1250" dirty="0"/>
+          </a:p>
+        </p:txBody>
+      </p:sp>
+      <p:sp>
+        <p:nvSpPr>
+          <p:cNvPr id="41" name="Responsable 2025-7"/>
+          <p:cNvSpPr txBox="1"/>
+          <p:nvPr/>
+        </p:nvSpPr>
+        <p:spPr>
+          <a:xfrm>
+            <a:off x="1170432" y="4892040"/>
+            <a:ext cx="2829458" cy="420624"/>
+          </a:xfrm>
+          <a:prstGeom prst="rect">
+            <a:avLst/>
+          </a:prstGeom>
+          <a:noFill/>
+          <a:ln/>
+        </p:spPr>
+        <p:txBody>
+          <a:bodyPr wrap="square" lIns="0" tIns="0" rIns="0" bIns="0" rtlCol="0" anchor="ctr"/>
+          <a:lstStyle/>
+          <a:p>
+            <a:pPr marL="0" indent="0">
+              <a:buNone/>
+            </a:pPr>
+            <a:r>
+              <a:rPr lang="en-US" sz="800" b="1" dirty="0">
+                <a:solidFill>
+                  <a:srgbClr val="586579"/>
+                </a:solidFill>
+              </a:rPr>
+              <a:t>RESPONSABLE</a:t>
+            </a:r>
+            <a:endParaRPr lang="en-US" sz="1250" dirty="0"/>
+          </a:p>
+          <a:p>
+            <a:pPr marL="0" indent="0">
+              <a:buNone/>
+            </a:pPr>
+            <a:r>
+              <a:rPr lang="en-US" sz="900" b="0" dirty="0">
+                <a:solidFill>
+                  <a:srgbClr val="142033"/>
+                </a:solidFill>
+              </a:rPr>
+              <a:t>Gerencia General / Jefe de Administración de Riesgos</a:t>
+            </a:r>
+            <a:endParaRPr lang="en-US" sz="1250" dirty="0"/>
+          </a:p>
+        </p:txBody>
+      </p:sp>
+      <p:sp>
+        <p:nvSpPr>
+          <p:cNvPr id="46" name="Responsable 2025-8"/>
+          <p:cNvSpPr txBox="1"/>
+          <p:nvPr/>
+        </p:nvSpPr>
+        <p:spPr>
+          <a:xfrm>
+            <a:off x="4914290" y="4892040"/>
+            <a:ext cx="2829458" cy="420624"/>
+          </a:xfrm>
+          <a:prstGeom prst="rect">
+            <a:avLst/>
+          </a:prstGeom>
+          <a:noFill/>
+          <a:ln/>
+        </p:spPr>
+        <p:txBody>
+          <a:bodyPr wrap="square" lIns="0" tIns="0" rIns="0" bIns="0" rtlCol="0" anchor="ctr"/>
+          <a:lstStyle/>
+          <a:p>
+            <a:pPr marL="0" indent="0">
+              <a:buNone/>
+            </a:pPr>
+            <a:r>
+              <a:rPr lang="en-US" sz="800" b="1" dirty="0">
+                <a:solidFill>
+                  <a:srgbClr val="586579"/>
+                </a:solidFill>
+              </a:rPr>
+              <a:t>RESPONSABLE</a:t>
+            </a:r>
+            <a:endParaRPr lang="en-US" sz="1250" dirty="0"/>
+          </a:p>
+          <a:p>
+            <a:pPr marL="0" indent="0">
+              <a:buNone/>
+            </a:pPr>
+            <a:r>
+              <a:rPr lang="en-US" sz="900" b="0" dirty="0">
+                <a:solidFill>
+                  <a:srgbClr val="142033"/>
+                </a:solidFill>
+              </a:rPr>
+              <a:t>Gerencia Administrativa</a:t>
+            </a:r>
+            <a:endParaRPr lang="en-US" sz="1250" dirty="0"/>
+          </a:p>
+        </p:txBody>
+      </p:sp>
+      <p:sp>
+        <p:nvSpPr>
+          <p:cNvPr id="51" name="Responsable 2025-9"/>
+          <p:cNvSpPr txBox="1"/>
+          <p:nvPr/>
+        </p:nvSpPr>
+        <p:spPr>
+          <a:xfrm>
+            <a:off x="8658149" y="4892040"/>
+            <a:ext cx="2829458" cy="420624"/>
+          </a:xfrm>
+          <a:prstGeom prst="rect">
+            <a:avLst/>
+          </a:prstGeom>
+          <a:noFill/>
+          <a:ln/>
+        </p:spPr>
+        <p:txBody>
+          <a:bodyPr wrap="square" lIns="0" tIns="0" rIns="0" bIns="0" rtlCol="0" anchor="ctr"/>
+          <a:lstStyle/>
+          <a:p>
+            <a:pPr marL="0" indent="0">
+              <a:buNone/>
+            </a:pPr>
+            <a:r>
+              <a:rPr lang="en-US" sz="800" b="1" dirty="0">
+                <a:solidFill>
+                  <a:srgbClr val="586579"/>
+                </a:solidFill>
+              </a:rPr>
+              <a:t>RESPONSABLE</a:t>
+            </a:r>
+            <a:endParaRPr lang="en-US" sz="1250" dirty="0"/>
+          </a:p>
+          <a:p>
+            <a:pPr marL="0" indent="0">
+              <a:buNone/>
+            </a:pPr>
+            <a:r>
+              <a:rPr lang="en-US" sz="900" b="0" dirty="0">
+                <a:solidFill>
+                  <a:srgbClr val="142033"/>
+                </a:solidFill>
+              </a:rPr>
+              <a:t>Gerencia General / Jefe de Administración de Riesgos</a:t>
+            </a:r>
+            <a:endParaRPr lang="en-US" sz="1250" dirty="0"/>
           </a:p>
         </p:txBody>
       </p:sp>
@@ -6797,8 +7022,8 @@
         </p:nvSpPr>
         <p:spPr>
           <a:xfrm>
-            <a:off x="694944" y="2121408"/>
-            <a:ext cx="2398700" cy="585216"/>
+            <a:off x="694944" y="2139696"/>
+            <a:ext cx="2398700" cy="566928"/>
           </a:xfrm>
           <a:prstGeom prst="rect">
             <a:avLst/>
@@ -6833,17 +7058,17 @@
         </p:nvSpPr>
         <p:spPr>
           <a:xfrm>
-            <a:off x="694944" y="2715768"/>
-            <a:ext cx="2398700" cy="283464"/>
-          </a:xfrm>
-          <a:prstGeom prst="rect">
-            <a:avLst/>
-          </a:prstGeom>
-          <a:noFill/>
-          <a:ln/>
-        </p:spPr>
-        <p:txBody>
-          <a:bodyPr wrap="square" lIns="0" tIns="0" rIns="0" bIns="0" rtlCol="0" anchor="t"/>
+            <a:off x="694944" y="2651760"/>
+            <a:ext cx="2398700" cy="310896"/>
+          </a:xfrm>
+          <a:prstGeom prst="rect">
+            <a:avLst/>
+          </a:prstGeom>
+          <a:noFill/>
+          <a:ln/>
+        </p:spPr>
+        <p:txBody>
+          <a:bodyPr wrap="square" lIns="0" tIns="0" rIns="0" bIns="0" rtlCol="0" anchor="b"/>
           <a:lstStyle/>
           <a:p>
             <a:pPr marL="0" indent="0">
@@ -7028,8 +7253,8 @@
         </p:nvSpPr>
         <p:spPr>
           <a:xfrm>
-            <a:off x="3495980" y="2121408"/>
-            <a:ext cx="2398700" cy="585216"/>
+            <a:off x="3495980" y="2139696"/>
+            <a:ext cx="2398700" cy="566928"/>
           </a:xfrm>
           <a:prstGeom prst="rect">
             <a:avLst/>
@@ -7064,17 +7289,17 @@
         </p:nvSpPr>
         <p:spPr>
           <a:xfrm>
-            <a:off x="3495980" y="2715768"/>
-            <a:ext cx="2398700" cy="283464"/>
-          </a:xfrm>
-          <a:prstGeom prst="rect">
-            <a:avLst/>
-          </a:prstGeom>
-          <a:noFill/>
-          <a:ln/>
-        </p:spPr>
-        <p:txBody>
-          <a:bodyPr wrap="square" lIns="0" tIns="0" rIns="0" bIns="0" rtlCol="0" anchor="t"/>
+            <a:off x="3495980" y="2651760"/>
+            <a:ext cx="2398700" cy="310896"/>
+          </a:xfrm>
+          <a:prstGeom prst="rect">
+            <a:avLst/>
+          </a:prstGeom>
+          <a:noFill/>
+          <a:ln/>
+        </p:spPr>
+        <p:txBody>
+          <a:bodyPr wrap="square" lIns="0" tIns="0" rIns="0" bIns="0" rtlCol="0" anchor="b"/>
           <a:lstStyle/>
           <a:p>
             <a:pPr marL="0" indent="0">
@@ -7259,8 +7484,8 @@
         </p:nvSpPr>
         <p:spPr>
           <a:xfrm>
-            <a:off x="6297016" y="2121408"/>
-            <a:ext cx="2398700" cy="585216"/>
+            <a:off x="6297016" y="2139696"/>
+            <a:ext cx="2398700" cy="566928"/>
           </a:xfrm>
           <a:prstGeom prst="rect">
             <a:avLst/>
@@ -7295,17 +7520,17 @@
         </p:nvSpPr>
         <p:spPr>
           <a:xfrm>
-            <a:off x="6297016" y="2715768"/>
-            <a:ext cx="2398700" cy="283464"/>
-          </a:xfrm>
-          <a:prstGeom prst="rect">
-            <a:avLst/>
-          </a:prstGeom>
-          <a:noFill/>
-          <a:ln/>
-        </p:spPr>
-        <p:txBody>
-          <a:bodyPr wrap="square" lIns="0" tIns="0" rIns="0" bIns="0" rtlCol="0" anchor="t"/>
+            <a:off x="6297016" y="2651760"/>
+            <a:ext cx="2398700" cy="310896"/>
+          </a:xfrm>
+          <a:prstGeom prst="rect">
+            <a:avLst/>
+          </a:prstGeom>
+          <a:noFill/>
+          <a:ln/>
+        </p:spPr>
+        <p:txBody>
+          <a:bodyPr wrap="square" lIns="0" tIns="0" rIns="0" bIns="0" rtlCol="0" anchor="b"/>
           <a:lstStyle/>
           <a:p>
             <a:pPr marL="0" indent="0">
@@ -7490,8 +7715,8 @@
         </p:nvSpPr>
         <p:spPr>
           <a:xfrm>
-            <a:off x="9098051" y="2121408"/>
-            <a:ext cx="2398700" cy="585216"/>
+            <a:off x="9098051" y="2139696"/>
+            <a:ext cx="2398700" cy="566928"/>
           </a:xfrm>
           <a:prstGeom prst="rect">
             <a:avLst/>
@@ -7526,17 +7751,17 @@
         </p:nvSpPr>
         <p:spPr>
           <a:xfrm>
-            <a:off x="9098051" y="2715768"/>
-            <a:ext cx="2398700" cy="283464"/>
-          </a:xfrm>
-          <a:prstGeom prst="rect">
-            <a:avLst/>
-          </a:prstGeom>
-          <a:noFill/>
-          <a:ln/>
-        </p:spPr>
-        <p:txBody>
-          <a:bodyPr wrap="square" lIns="0" tIns="0" rIns="0" bIns="0" rtlCol="0" anchor="t"/>
+            <a:off x="9098051" y="2651760"/>
+            <a:ext cx="2398700" cy="310896"/>
+          </a:xfrm>
+          <a:prstGeom prst="rect">
+            <a:avLst/>
+          </a:prstGeom>
+          <a:noFill/>
+          <a:ln/>
+        </p:spPr>
+        <p:txBody>
+          <a:bodyPr wrap="square" lIns="0" tIns="0" rIns="0" bIns="0" rtlCol="0" anchor="b"/>
           <a:lstStyle/>
           <a:p>
             <a:pPr marL="0" indent="0">
@@ -7721,8 +7946,8 @@
         </p:nvSpPr>
         <p:spPr>
           <a:xfrm>
-            <a:off x="694944" y="3675888"/>
-            <a:ext cx="2398700" cy="585216"/>
+            <a:off x="694944" y="3694176"/>
+            <a:ext cx="2398700" cy="566928"/>
           </a:xfrm>
           <a:prstGeom prst="rect">
             <a:avLst/>
@@ -7757,17 +7982,17 @@
         </p:nvSpPr>
         <p:spPr>
           <a:xfrm>
-            <a:off x="694944" y="4270248"/>
-            <a:ext cx="2398700" cy="283464"/>
-          </a:xfrm>
-          <a:prstGeom prst="rect">
-            <a:avLst/>
-          </a:prstGeom>
-          <a:noFill/>
-          <a:ln/>
-        </p:spPr>
-        <p:txBody>
-          <a:bodyPr wrap="square" lIns="0" tIns="0" rIns="0" bIns="0" rtlCol="0" anchor="t"/>
+            <a:off x="694944" y="4206240"/>
+            <a:ext cx="2398700" cy="310896"/>
+          </a:xfrm>
+          <a:prstGeom prst="rect">
+            <a:avLst/>
+          </a:prstGeom>
+          <a:noFill/>
+          <a:ln/>
+        </p:spPr>
+        <p:txBody>
+          <a:bodyPr wrap="square" lIns="0" tIns="0" rIns="0" bIns="0" rtlCol="0" anchor="b"/>
           <a:lstStyle/>
           <a:p>
             <a:pPr marL="0" indent="0">
@@ -7952,8 +8177,8 @@
         </p:nvSpPr>
         <p:spPr>
           <a:xfrm>
-            <a:off x="3495980" y="3675888"/>
-            <a:ext cx="2398700" cy="585216"/>
+            <a:off x="3495980" y="3694176"/>
+            <a:ext cx="2398700" cy="566928"/>
           </a:xfrm>
           <a:prstGeom prst="rect">
             <a:avLst/>
@@ -7988,17 +8213,17 @@
         </p:nvSpPr>
         <p:spPr>
           <a:xfrm>
-            <a:off x="3495980" y="4270248"/>
-            <a:ext cx="2398700" cy="283464"/>
-          </a:xfrm>
-          <a:prstGeom prst="rect">
-            <a:avLst/>
-          </a:prstGeom>
-          <a:noFill/>
-          <a:ln/>
-        </p:spPr>
-        <p:txBody>
-          <a:bodyPr wrap="square" lIns="0" tIns="0" rIns="0" bIns="0" rtlCol="0" anchor="t"/>
+            <a:off x="3495980" y="4206240"/>
+            <a:ext cx="2398700" cy="310896"/>
+          </a:xfrm>
+          <a:prstGeom prst="rect">
+            <a:avLst/>
+          </a:prstGeom>
+          <a:noFill/>
+          <a:ln/>
+        </p:spPr>
+        <p:txBody>
+          <a:bodyPr wrap="square" lIns="0" tIns="0" rIns="0" bIns="0" rtlCol="0" anchor="b"/>
           <a:lstStyle/>
           <a:p>
             <a:pPr marL="0" indent="0">
@@ -8183,8 +8408,8 @@
         </p:nvSpPr>
         <p:spPr>
           <a:xfrm>
-            <a:off x="6297016" y="3675888"/>
-            <a:ext cx="2398700" cy="585216"/>
+            <a:off x="6297016" y="3694176"/>
+            <a:ext cx="2398700" cy="566928"/>
           </a:xfrm>
           <a:prstGeom prst="rect">
             <a:avLst/>
@@ -8219,17 +8444,17 @@
         </p:nvSpPr>
         <p:spPr>
           <a:xfrm>
-            <a:off x="6297016" y="4270248"/>
-            <a:ext cx="2398700" cy="283464"/>
-          </a:xfrm>
-          <a:prstGeom prst="rect">
-            <a:avLst/>
-          </a:prstGeom>
-          <a:noFill/>
-          <a:ln/>
-        </p:spPr>
-        <p:txBody>
-          <a:bodyPr wrap="square" lIns="0" tIns="0" rIns="0" bIns="0" rtlCol="0" anchor="t"/>
+            <a:off x="6297016" y="4206240"/>
+            <a:ext cx="2398700" cy="310896"/>
+          </a:xfrm>
+          <a:prstGeom prst="rect">
+            <a:avLst/>
+          </a:prstGeom>
+          <a:noFill/>
+          <a:ln/>
+        </p:spPr>
+        <p:txBody>
+          <a:bodyPr wrap="square" lIns="0" tIns="0" rIns="0" bIns="0" rtlCol="0" anchor="b"/>
           <a:lstStyle/>
           <a:p>
             <a:pPr marL="0" indent="0">
@@ -8241,7 +8466,7 @@
                   <a:schemeClr val="accent5"/>
                 </a:solidFill>
               </a:rPr>
-              <a:t>Respuesta: Memoria de Labores 2026 con conceptos y montos</a:t>
+              <a:t>Respuesta: Memoria de Labores 2026 detallada</a:t>
             </a:r>
             <a:endParaRPr lang="en-US" sz="950" dirty="0"/>
           </a:p>

</xml_diff>

<commit_message>
Slide 1: remove repeated counts beside result blocks; slide 2: obs. 4 regulation approved
Co-Authored-By: Claude Opus 5.5 <noreply@anthropic.com>
Claude-Session: https://claude.ai/code/session_01F1WXR13Nv8neEtLhaK3ELa
</commit_message>
<xml_diff>
--- a/supervision-gobierno-corporativo/Supervision_GC_SSF_COMEDICA_2025-2026.pptx
+++ b/supervision-gobierno-corporativo/Supervision_GC_SSF_COMEDICA_2025-2026.pptx
@@ -3776,7 +3776,7 @@
                   <a:srgbClr val="1D7A4B"/>
                 </a:solidFill>
               </a:rPr>
-              <a:t>7 observaciones nuevas</a:t>
+              <a:t>Descargos</a:t>
             </a:r>
           </a:p>
           <a:p>
@@ -3791,7 +3791,7 @@
                   <a:srgbClr val="586579"/>
                 </a:solidFill>
               </a:rPr>
-              <a:t>Recepción  </a:t>
+              <a:t>Plazo de 10 días hábiles  ·  vence aprox.  </a:t>
             </a:r>
             <a:r>
               <a:rPr sz="1050" b="1">
@@ -3799,7 +3799,7 @@
                   <a:srgbClr val="142033"/>
                 </a:solidFill>
               </a:rPr>
-              <a:t>09/10/2026</a:t>
+              <a:t>23/10/2026</a:t>
             </a:r>
             <a:r>
               <a:rPr sz="1050" b="0">
@@ -3807,7 +3807,7 @@
                   <a:srgbClr val="586579"/>
                 </a:solidFill>
               </a:rPr>
-              <a:t>   ·   Descargos vencen aprox.  </a:t>
+              <a:t/>
             </a:r>
             <a:r>
               <a:rPr sz="1050" b="1">
@@ -3815,7 +3815,7 @@
                   <a:srgbClr val="142033"/>
                 </a:solidFill>
               </a:rPr>
-              <a:t>23/10/2026</a:t>
+              <a:t/>
             </a:r>
           </a:p>
         </p:txBody>
@@ -3883,7 +3883,7 @@
                   <a:srgbClr val="B42318"/>
                 </a:solidFill>
               </a:rPr>
-              <a:t>2 observaciones en seguimiento</a:t>
+              <a:t>Obs. 3 y 5 de 2025</a:t>
             </a:r>
           </a:p>
           <a:p>
@@ -3898,7 +3898,7 @@
                   <a:srgbClr val="586579"/>
                 </a:solidFill>
               </a:rPr>
-              <a:t>Obs. 3 y 5 de 2025   ·   Plan de solución vence aprox.  </a:t>
+              <a:t>Plan de solución en 15 días hábiles  ·  vence aprox.  </a:t>
             </a:r>
             <a:r>
               <a:rPr sz="1050" b="1">
@@ -3939,7 +3939,7 @@
                   <a:srgbClr val="173A6E"/>
                 </a:solidFill>
               </a:rPr>
-              <a:t>9 observaciones</a:t>
+              <a:t>Descargos presentados a la SSF</a:t>
             </a:r>
           </a:p>
           <a:p>
@@ -3954,7 +3954,7 @@
                   <a:srgbClr val="586579"/>
                 </a:solidFill>
               </a:rPr>
-              <a:t>Recepción  </a:t>
+              <a:t>Enviados  </a:t>
             </a:r>
             <a:r>
               <a:rPr sz="1050" b="1">
@@ -3962,7 +3962,7 @@
                   <a:srgbClr val="142033"/>
                 </a:solidFill>
               </a:rPr>
-              <a:t>05/11/2025</a:t>
+              <a:t>18/11/2025</a:t>
             </a:r>
             <a:r>
               <a:rPr sz="1050" b="0">
@@ -3970,7 +3970,7 @@
                   <a:srgbClr val="586579"/>
                 </a:solidFill>
               </a:rPr>
-              <a:t>   ·   Descargos enviados  </a:t>
+              <a:t>   ·   Constancia de recepción SSF</a:t>
             </a:r>
             <a:r>
               <a:rPr sz="1050" b="1">
@@ -3978,7 +3978,7 @@
                   <a:srgbClr val="142033"/>
                 </a:solidFill>
               </a:rPr>
-              <a:t>18/11/2025</a:t>
+              <a:t/>
             </a:r>
           </a:p>
         </p:txBody>
@@ -4046,7 +4046,7 @@
                   <a:srgbClr val="B42318"/>
                 </a:solidFill>
               </a:rPr>
-              <a:t>2 con seguimiento en 2026</a:t>
+              <a:t>Obs. 3 y 5</a:t>
             </a:r>
           </a:p>
           <a:p>
@@ -4061,7 +4061,7 @@
                   <a:srgbClr val="586579"/>
                 </a:solidFill>
               </a:rPr>
-              <a:t>Obs. 3 y 5   ·   Revisadas en la visita 2026 (Anexo B)</a:t>
+              <a:t>Revisadas por la SSF en la visita 2026 (Anexo B)</a:t>
             </a:r>
           </a:p>
         </p:txBody>
@@ -5093,7 +5093,7 @@
                   <a:schemeClr val="tx1"/>
                 </a:solidFill>
               </a:rPr>
-              <a:t>Se actualizará el Reglamento de Compensaciones Económicas</a:t>
+              <a:t>Fue aprobada la modificación al Reglamento de Compensaciones Económicas para Directivos</a:t>
             </a:r>
             <a:endParaRPr lang="en-US" sz="1000" dirty="0"/>
           </a:p>

</xml_diff>

<commit_message>
Slide 1: label 2026 block as 7 new observations and 2 follow-ups of 2025
Co-Authored-By: Claude Opus 5.5 <noreply@anthropic.com>
Claude-Session: https://claude.ai/code/session_01F1WXR13Nv8neEtLhaK3ELa
</commit_message>
<xml_diff>
--- a/supervision-gobierno-corporativo/Supervision_GC_SSF_COMEDICA_2025-2026.pptx
+++ b/supervision-gobierno-corporativo/Supervision_GC_SSF_COMEDICA_2025-2026.pptx
@@ -3234,7 +3234,7 @@
         </p:nvSpPr>
         <p:spPr>
           <a:xfrm>
-            <a:off x="6263640" y="4416552"/>
+            <a:off x="6263640" y="4379976"/>
             <a:ext cx="987552" cy="411480"/>
           </a:xfrm>
           <a:prstGeom prst="rect">
@@ -3273,8 +3273,8 @@
         </p:nvSpPr>
         <p:spPr>
           <a:xfrm>
-            <a:off x="6263640" y="4837176"/>
-            <a:ext cx="987552" cy="201168"/>
+            <a:off x="6263640" y="4809744"/>
+            <a:ext cx="987552" cy="292608"/>
           </a:xfrm>
           <a:prstGeom prst="rect">
             <a:avLst/>
@@ -3290,12 +3290,26 @@
               <a:buNone/>
             </a:pPr>
             <a:r>
-              <a:rPr lang="en-US" sz="1000" b="1" kern="0" spc="100" dirty="0">
+              <a:rPr lang="en-US" sz="750" b="1" kern="0" spc="100" dirty="0">
                 <a:solidFill>
                   <a:schemeClr val="bg1"/>
                 </a:solidFill>
               </a:rPr>
               <a:t>NUEVAS</a:t>
+            </a:r>
+            <a:endParaRPr lang="en-US" sz="1000" dirty="0"/>
+          </a:p>
+          <a:p>
+            <a:pPr marL="0" indent="0" algn="ctr">
+              <a:buNone/>
+            </a:pPr>
+            <a:r>
+              <a:rPr lang="en-US" sz="750" b="1" kern="0" spc="100" dirty="0">
+                <a:solidFill>
+                  <a:schemeClr val="bg1"/>
+                </a:solidFill>
+              </a:rPr>
+              <a:t>OBSERVACIONES</a:t>
             </a:r>
             <a:endParaRPr lang="en-US" sz="1000" dirty="0"/>
           </a:p>
@@ -3331,7 +3345,7 @@
                   <a:schemeClr val="bg1"/>
                 </a:solidFill>
               </a:rPr>
-              <a:t>ANEXO B</a:t>
+              <a:t>SEGUIMIENTO</a:t>
             </a:r>
             <a:endParaRPr lang="en-US" sz="800" dirty="0"/>
           </a:p>
@@ -3345,7 +3359,7 @@
         </p:nvSpPr>
         <p:spPr>
           <a:xfrm>
-            <a:off x="6263640" y="5495544"/>
+            <a:off x="6263640" y="5458968"/>
             <a:ext cx="987552" cy="411480"/>
           </a:xfrm>
           <a:prstGeom prst="rect">
@@ -3384,8 +3398,8 @@
         </p:nvSpPr>
         <p:spPr>
           <a:xfrm>
-            <a:off x="6263640" y="5916168"/>
-            <a:ext cx="987552" cy="201168"/>
+            <a:off x="6263640" y="5888736"/>
+            <a:ext cx="987552" cy="292608"/>
           </a:xfrm>
           <a:prstGeom prst="rect">
             <a:avLst/>
@@ -3401,12 +3415,26 @@
               <a:buNone/>
             </a:pPr>
             <a:r>
-              <a:rPr lang="en-US" sz="850" b="1" kern="0" spc="100" dirty="0">
+              <a:rPr lang="en-US" sz="750" b="1" kern="0" spc="100" dirty="0">
                 <a:solidFill>
                   <a:schemeClr val="bg1"/>
                 </a:solidFill>
               </a:rPr>
-              <a:t>SEGUIMIENTO</a:t>
+              <a:t>OBSERVACIONES</a:t>
+            </a:r>
+            <a:endParaRPr lang="en-US" sz="1000" dirty="0"/>
+          </a:p>
+          <a:p>
+            <a:pPr marL="0" indent="0" algn="ctr">
+              <a:buNone/>
+            </a:pPr>
+            <a:r>
+              <a:rPr lang="en-US" sz="750" b="1" kern="0" spc="100" dirty="0">
+                <a:solidFill>
+                  <a:schemeClr val="bg1"/>
+                </a:solidFill>
+              </a:rPr>
+              <a:t>2025</a:t>
             </a:r>
             <a:endParaRPr lang="en-US" sz="1000" dirty="0"/>
           </a:p>

</xml_diff>

<commit_message>
Slide 1: 2025 results block shows only 9 observations and 2 follow-ups
Co-Authored-By: Claude Opus 5.5 <noreply@anthropic.com>
Claude-Session: https://claude.ai/code/session_01F1WXR13Nv8neEtLhaK3ELa
</commit_message>
<xml_diff>
--- a/supervision-gobierno-corporativo/Supervision_GC_SSF_COMEDICA_2025-2026.pptx
+++ b/supervision-gobierno-corporativo/Supervision_GC_SSF_COMEDICA_2025-2026.pptx
@@ -2119,49 +2119,13 @@
       </p:sp>
       <p:sp>
         <p:nvSpPr>
-          <p:cNvPr id="23" name="Fecha etiqueta 2025-2-0"/>
-          <p:cNvSpPr txBox="1"/>
-          <p:nvPr/>
-        </p:nvSpPr>
-        <p:spPr>
-          <a:xfrm>
-            <a:off x="6263640" y="1170432"/>
-            <a:ext cx="987552" cy="182880"/>
-          </a:xfrm>
-          <a:prstGeom prst="rect">
-            <a:avLst/>
-          </a:prstGeom>
-          <a:noFill/>
-          <a:ln/>
-        </p:spPr>
-        <p:txBody>
-          <a:bodyPr wrap="square" lIns="0" tIns="0" rIns="0" bIns="0" rtlCol="0" anchor="t"/>
-          <a:lstStyle/>
-          <a:p>
-            <a:pPr marL="0" indent="0" algn="ctr">
-              <a:buNone/>
-            </a:pPr>
-            <a:r>
-              <a:rPr lang="en-US" sz="800" b="1" kern="0" spc="100" dirty="0">
-                <a:solidFill>
-                  <a:schemeClr val="bg1"/>
-                </a:solidFill>
-              </a:rPr>
-              <a:t>RESULTADO</a:t>
-            </a:r>
-            <a:endParaRPr lang="en-US" sz="800" dirty="0"/>
-          </a:p>
-        </p:txBody>
-      </p:sp>
-      <p:sp>
-        <p:nvSpPr>
           <p:cNvPr id="24" name="Fecha día 2025-2-0"/>
           <p:cNvSpPr txBox="1"/>
           <p:nvPr/>
         </p:nvSpPr>
         <p:spPr>
           <a:xfrm>
-            <a:off x="6263640" y="1371600"/>
+            <a:off x="6263640" y="1298448"/>
             <a:ext cx="987552" cy="411480"/>
           </a:xfrm>
           <a:prstGeom prst="rect">
@@ -2200,7 +2164,7 @@
         </p:nvSpPr>
         <p:spPr>
           <a:xfrm>
-            <a:off x="6263640" y="1792224"/>
+            <a:off x="6263640" y="1719072"/>
             <a:ext cx="987552" cy="201168"/>
           </a:xfrm>
           <a:prstGeom prst="rect">
@@ -2230,49 +2194,13 @@
       </p:sp>
       <p:sp>
         <p:nvSpPr>
-          <p:cNvPr id="26" name="Fecha etiqueta 2025-2-1"/>
-          <p:cNvSpPr txBox="1"/>
-          <p:nvPr/>
-        </p:nvSpPr>
-        <p:spPr>
-          <a:xfrm>
-            <a:off x="6263640" y="2249424"/>
-            <a:ext cx="987552" cy="182880"/>
-          </a:xfrm>
-          <a:prstGeom prst="rect">
-            <a:avLst/>
-          </a:prstGeom>
-          <a:noFill/>
-          <a:ln/>
-        </p:spPr>
-        <p:txBody>
-          <a:bodyPr wrap="square" lIns="0" tIns="0" rIns="0" bIns="0" rtlCol="0" anchor="t"/>
-          <a:lstStyle/>
-          <a:p>
-            <a:pPr marL="0" indent="0" algn="ctr">
-              <a:buNone/>
-            </a:pPr>
-            <a:r>
-              <a:rPr lang="en-US" sz="800" b="1" kern="0" spc="100" dirty="0">
-                <a:solidFill>
-                  <a:schemeClr val="bg1"/>
-                </a:solidFill>
-              </a:rPr>
-              <a:t>VISITA 2026</a:t>
-            </a:r>
-            <a:endParaRPr lang="en-US" sz="800" dirty="0"/>
-          </a:p>
-        </p:txBody>
-      </p:sp>
-      <p:sp>
-        <p:nvSpPr>
           <p:cNvPr id="27" name="Fecha día 2025-2-1"/>
           <p:cNvSpPr txBox="1"/>
           <p:nvPr/>
         </p:nvSpPr>
         <p:spPr>
           <a:xfrm>
-            <a:off x="6263640" y="2450592"/>
+            <a:off x="6263640" y="2377440"/>
             <a:ext cx="987552" cy="411480"/>
           </a:xfrm>
           <a:prstGeom prst="rect">
@@ -2311,7 +2239,7 @@
         </p:nvSpPr>
         <p:spPr>
           <a:xfrm>
-            <a:off x="6263640" y="2871216"/>
+            <a:off x="6263640" y="2798064"/>
             <a:ext cx="987552" cy="201168"/>
           </a:xfrm>
           <a:prstGeom prst="rect">

</xml_diff>

<commit_message>
Slide 1: circular code with date below; 2025 results shows only 9 observaciones
Co-Authored-By: Claude Opus 5.5 <noreply@anthropic.com>
Claude-Session: https://claude.ai/code/session_01F1WXR13Nv8neEtLhaK3ELa
</commit_message>
<xml_diff>
--- a/supervision-gobierno-corporativo/Supervision_GC_SSF_COMEDICA_2025-2026.pptx
+++ b/supervision-gobierno-corporativo/Supervision_GC_SSF_COMEDICA_2025-2026.pptx
@@ -1849,8 +1849,8 @@
         </p:nvSpPr>
         <p:spPr>
           <a:xfrm>
-            <a:off x="4233672" y="1691640"/>
-            <a:ext cx="1389888" cy="457200"/>
+            <a:off x="4233672" y="1645920"/>
+            <a:ext cx="1389888" cy="566928"/>
           </a:xfrm>
           <a:prstGeom prst="rect">
             <a:avLst/>
@@ -1871,29 +1871,35 @@
                   <a:schemeClr val="accent5"/>
                 </a:solidFill>
               </a:rPr>
-              <a:t>Circular No.  </a:t>
-            </a:r>
+              <a:t>Circular No.</a:t>
+            </a:r>
+            <a:endParaRPr lang="en-US" sz="1050" dirty="0"/>
+          </a:p>
+          <a:p>
+            <a:pPr marL="0" indent="0">
+              <a:buNone/>
+            </a:pPr>
             <a:r>
               <a:rPr lang="en-US" sz="1050" b="1" dirty="0">
                 <a:solidFill>
                   <a:schemeClr val="accent1"/>
                 </a:solidFill>
               </a:rPr>
+              <a:t>DS-SABAO-BCS-BC-9337</a:t>
+            </a:r>
+            <a:endParaRPr lang="en-US" sz="1050" dirty="0"/>
+          </a:p>
+          <a:p>
+            <a:pPr marL="0" indent="0">
+              <a:buNone/>
+            </a:pPr>
+            <a:r>
+              <a:rPr lang="en-US" sz="1050" b="1" dirty="0">
+                <a:solidFill>
+                  <a:schemeClr val="accent1"/>
+                </a:solidFill>
+              </a:rPr>
               <a:t>09/04/2025</a:t>
-            </a:r>
-            <a:endParaRPr lang="en-US" sz="1050" dirty="0"/>
-          </a:p>
-          <a:p>
-            <a:pPr marL="0" indent="0">
-              <a:buNone/>
-            </a:pPr>
-            <a:r>
-              <a:rPr lang="en-US" sz="1050" b="1" dirty="0">
-                <a:solidFill>
-                  <a:schemeClr val="accent1"/>
-                </a:solidFill>
-              </a:rPr>
-              <a:t>DS-SABAO-BCS-BC-9337</a:t>
             </a:r>
             <a:endParaRPr lang="en-US" sz="1050" dirty="0"/>
           </a:p>
@@ -2344,7 +2350,7 @@
         <p:spPr>
           <a:xfrm>
             <a:off x="7406640" y="1298448"/>
-            <a:ext cx="4099255" cy="219456"/>
+            <a:ext cx="4099255" cy="411480"/>
           </a:xfrm>
           <a:prstGeom prst="rect">
             <a:avLst/>
@@ -2373,7 +2379,21 @@
                   <a:schemeClr val="accent1"/>
                 </a:solidFill>
               </a:rPr>
-              <a:t>05/11/2025  ·  DS-SABAO-BCS-BC-17003</a:t>
+              <a:t>DS-SABAO-BCS-BC-17003</a:t>
+            </a:r>
+            <a:endParaRPr lang="en-US" sz="1000" dirty="0"/>
+          </a:p>
+          <a:p>
+            <a:pPr marL="0" indent="0">
+              <a:buNone/>
+            </a:pPr>
+            <a:r>
+              <a:rPr lang="en-US" sz="1000" b="1" dirty="0">
+                <a:solidFill>
+                  <a:schemeClr val="accent1"/>
+                </a:solidFill>
+              </a:rPr>
+              <a:t>05/11/2025</a:t>
             </a:r>
             <a:endParaRPr lang="en-US" sz="1000" dirty="0"/>
           </a:p>
@@ -2387,7 +2407,7 @@
         </p:nvSpPr>
         <p:spPr>
           <a:xfrm>
-            <a:off x="7406640" y="1600200"/>
+            <a:off x="7406640" y="1783080"/>
             <a:ext cx="4099255" cy="0"/>
           </a:xfrm>
           <a:prstGeom prst="line">
@@ -2850,8 +2870,8 @@
         </p:nvSpPr>
         <p:spPr>
           <a:xfrm>
-            <a:off x="4233672" y="4736592"/>
-            <a:ext cx="1389888" cy="457200"/>
+            <a:off x="4233672" y="4690872"/>
+            <a:ext cx="1389888" cy="566928"/>
           </a:xfrm>
           <a:prstGeom prst="rect">
             <a:avLst/>
@@ -2872,29 +2892,35 @@
                   <a:schemeClr val="accent5"/>
                 </a:solidFill>
               </a:rPr>
-              <a:t>Circular No.  </a:t>
-            </a:r>
+              <a:t>Circular No.</a:t>
+            </a:r>
+            <a:endParaRPr lang="en-US" sz="1050" dirty="0"/>
+          </a:p>
+          <a:p>
+            <a:pPr marL="0" indent="0">
+              <a:buNone/>
+            </a:pPr>
             <a:r>
               <a:rPr lang="en-US" sz="1050" b="1" dirty="0">
                 <a:solidFill>
                   <a:schemeClr val="accent2"/>
                 </a:solidFill>
               </a:rPr>
+              <a:t>SABAO-BCS-BC-18432</a:t>
+            </a:r>
+            <a:endParaRPr lang="en-US" sz="1050" dirty="0"/>
+          </a:p>
+          <a:p>
+            <a:pPr marL="0" indent="0">
+              <a:buNone/>
+            </a:pPr>
+            <a:r>
+              <a:rPr lang="en-US" sz="1050" b="1" dirty="0">
+                <a:solidFill>
+                  <a:schemeClr val="accent2"/>
+                </a:solidFill>
+              </a:rPr>
               <a:t>31/07/2026</a:t>
-            </a:r>
-            <a:endParaRPr lang="en-US" sz="1050" dirty="0"/>
-          </a:p>
-          <a:p>
-            <a:pPr marL="0" indent="0">
-              <a:buNone/>
-            </a:pPr>
-            <a:r>
-              <a:rPr lang="en-US" sz="1050" b="1" dirty="0">
-                <a:solidFill>
-                  <a:schemeClr val="accent2"/>
-                </a:solidFill>
-              </a:rPr>
-              <a:t>SABAO-BCS-BC-18432</a:t>
             </a:r>
             <a:endParaRPr lang="en-US" sz="1050" dirty="0"/>
           </a:p>
@@ -3445,7 +3471,7 @@
         <p:spPr>
           <a:xfrm>
             <a:off x="7406640" y="4343400"/>
-            <a:ext cx="4099255" cy="219456"/>
+            <a:ext cx="4099255" cy="411480"/>
           </a:xfrm>
           <a:prstGeom prst="rect">
             <a:avLst/>
@@ -3474,7 +3500,21 @@
                   <a:schemeClr val="accent2"/>
                 </a:solidFill>
               </a:rPr>
-              <a:t>09/10/2026  ·  DS-SABAO-BCS-BC-22741</a:t>
+              <a:t>DS-SABAO-BCS-BC-22741</a:t>
+            </a:r>
+            <a:endParaRPr lang="en-US" sz="1000" dirty="0"/>
+          </a:p>
+          <a:p>
+            <a:pPr marL="0" indent="0">
+              <a:buNone/>
+            </a:pPr>
+            <a:r>
+              <a:rPr lang="en-US" sz="1000" b="1" dirty="0">
+                <a:solidFill>
+                  <a:schemeClr val="accent2"/>
+                </a:solidFill>
+              </a:rPr>
+              <a:t>09/10/2026</a:t>
             </a:r>
             <a:endParaRPr lang="en-US" sz="1000" dirty="0"/>
           </a:p>
@@ -3488,7 +3528,7 @@
         </p:nvSpPr>
         <p:spPr>
           <a:xfrm>
-            <a:off x="7406640" y="4645152"/>
+            <a:off x="7406640" y="4828032"/>
             <a:ext cx="4099255" cy="0"/>
           </a:xfrm>
           <a:prstGeom prst="line">
@@ -3712,7 +3752,7 @@
         </p:nvSpPr>
         <p:spPr>
           <a:xfrm>
-            <a:off x="7406640" y="4773168"/>
+            <a:off x="7406640" y="4919472"/>
             <a:ext cx="4096512" cy="566928"/>
           </a:xfrm>
           <a:prstGeom prst="rect">
@@ -3784,7 +3824,7 @@
         </p:nvCxnSpPr>
         <p:spPr>
           <a:xfrm>
-            <a:off x="7406640" y="5440680"/>
+            <a:off x="7406640" y="5541264"/>
             <a:ext cx="4096512" cy="0"/>
           </a:xfrm>
           <a:prstGeom prst="line">
@@ -3819,7 +3859,7 @@
         </p:nvSpPr>
         <p:spPr>
           <a:xfrm>
-            <a:off x="7406640" y="5559552"/>
+            <a:off x="7406640" y="5632704"/>
             <a:ext cx="4096512" cy="566928"/>
           </a:xfrm>
           <a:prstGeom prst="rect">
@@ -3875,7 +3915,7 @@
         </p:nvSpPr>
         <p:spPr>
           <a:xfrm>
-            <a:off x="7406640" y="1728216"/>
+            <a:off x="7406640" y="1901952"/>
             <a:ext cx="4096512" cy="566928"/>
           </a:xfrm>
           <a:prstGeom prst="rect">
@@ -3895,129 +3935,7 @@
                   <a:srgbClr val="173A6E"/>
                 </a:solidFill>
               </a:rPr>
-              <a:t>Descargos presentados a la SSF</a:t>
-            </a:r>
-          </a:p>
-          <a:p>
-            <a:pPr>
-              <a:spcBef>
-                <a:spcPts val="300"/>
-              </a:spcBef>
-            </a:pPr>
-            <a:r>
-              <a:rPr sz="1050" b="0">
-                <a:solidFill>
-                  <a:srgbClr val="586579"/>
-                </a:solidFill>
-              </a:rPr>
-              <a:t>Enviados  </a:t>
-            </a:r>
-            <a:r>
-              <a:rPr sz="1050" b="1">
-                <a:solidFill>
-                  <a:srgbClr val="142033"/>
-                </a:solidFill>
-              </a:rPr>
-              <a:t>18/11/2025</a:t>
-            </a:r>
-            <a:r>
-              <a:rPr sz="1050" b="0">
-                <a:solidFill>
-                  <a:srgbClr val="586579"/>
-                </a:solidFill>
-              </a:rPr>
-              <a:t>   ·   Constancia de recepción SSF</a:t>
-            </a:r>
-            <a:r>
-              <a:rPr sz="1050" b="1">
-                <a:solidFill>
-                  <a:srgbClr val="142033"/>
-                </a:solidFill>
-              </a:rPr>
-              <a:t/>
-            </a:r>
-          </a:p>
-        </p:txBody>
-      </p:sp>
-      <p:cxnSp>
-        <p:nvCxnSpPr>
-          <p:cNvPr id="83" name="Separador resultados 2025"/>
-          <p:cNvCxnSpPr/>
-          <p:nvPr/>
-        </p:nvCxnSpPr>
-        <p:spPr>
-          <a:xfrm>
-            <a:off x="7406640" y="2395728"/>
-            <a:ext cx="4096512" cy="0"/>
-          </a:xfrm>
-          <a:prstGeom prst="line">
-            <a:avLst/>
-          </a:prstGeom>
-          <a:ln w="9525">
-            <a:solidFill>
-              <a:srgbClr val="D9E0EA"/>
-            </a:solidFill>
-          </a:ln>
-        </p:spPr>
-        <p:style>
-          <a:lnRef idx="2">
-            <a:schemeClr val="accent1"/>
-          </a:lnRef>
-          <a:fillRef idx="0">
-            <a:schemeClr val="accent1"/>
-          </a:fillRef>
-          <a:effectRef idx="1">
-            <a:schemeClr val="accent1"/>
-          </a:effectRef>
-          <a:fontRef idx="minor">
-            <a:schemeClr val="tx1"/>
-          </a:fontRef>
-        </p:style>
-      </p:cxnSp>
-      <p:sp>
-        <p:nvSpPr>
-          <p:cNvPr id="84" name="Resumen seguimiento 2025"/>
-          <p:cNvSpPr txBox="1"/>
-          <p:nvPr/>
-        </p:nvSpPr>
-        <p:spPr>
-          <a:xfrm>
-            <a:off x="7406640" y="2514600"/>
-            <a:ext cx="4096512" cy="566928"/>
-          </a:xfrm>
-          <a:prstGeom prst="rect">
-            <a:avLst/>
-          </a:prstGeom>
-          <a:noFill/>
-        </p:spPr>
-        <p:txBody>
-          <a:bodyPr wrap="square" lIns="0" rIns="0" tIns="0" bIns="0">
-            <a:spAutoFit/>
-          </a:bodyPr>
-          <a:lstStyle/>
-          <a:p>
-            <a:r>
-              <a:rPr sz="1300" b="1">
-                <a:solidFill>
-                  <a:srgbClr val="B42318"/>
-                </a:solidFill>
-              </a:rPr>
-              <a:t>Obs. 3 y 5</a:t>
-            </a:r>
-          </a:p>
-          <a:p>
-            <a:pPr>
-              <a:spcBef>
-                <a:spcPts val="300"/>
-              </a:spcBef>
-            </a:pPr>
-            <a:r>
-              <a:rPr sz="1050" b="0">
-                <a:solidFill>
-                  <a:srgbClr val="586579"/>
-                </a:solidFill>
-              </a:rPr>
-              <a:t>Revisadas por la SSF en la visita 2026 (Anexo B)</a:t>
+              <a:t>9 observaciones</a:t>
             </a:r>
           </a:p>
         </p:txBody>

</xml_diff>

<commit_message>
Slide 1: remove follow-up count from 2025 results block
Co-Authored-By: Claude Opus 5.5 <noreply@anthropic.com>
Claude-Session: https://claude.ai/code/session_01F1WXR13Nv8neEtLhaK3ELa
</commit_message>
<xml_diff>
--- a/supervision-gobierno-corporativo/Supervision_GC_SSF_COMEDICA_2025-2026.pptx
+++ b/supervision-gobierno-corporativo/Supervision_GC_SSF_COMEDICA_2025-2026.pptx
@@ -2131,7 +2131,7 @@
         </p:nvSpPr>
         <p:spPr>
           <a:xfrm>
-            <a:off x="6263640" y="1298448"/>
+            <a:off x="6263640" y="1682496"/>
             <a:ext cx="987552" cy="411480"/>
           </a:xfrm>
           <a:prstGeom prst="rect">
@@ -2170,7 +2170,7 @@
         </p:nvSpPr>
         <p:spPr>
           <a:xfrm>
-            <a:off x="6263640" y="1719072"/>
+            <a:off x="6263640" y="2139696"/>
             <a:ext cx="987552" cy="201168"/>
           </a:xfrm>
           <a:prstGeom prst="rect">
@@ -2195,113 +2195,6 @@
               <a:t>OBSERVACIONES</a:t>
             </a:r>
             <a:endParaRPr lang="en-US" sz="1000" dirty="0"/>
-          </a:p>
-        </p:txBody>
-      </p:sp>
-      <p:sp>
-        <p:nvSpPr>
-          <p:cNvPr id="27" name="Fecha día 2025-2-1"/>
-          <p:cNvSpPr txBox="1"/>
-          <p:nvPr/>
-        </p:nvSpPr>
-        <p:spPr>
-          <a:xfrm>
-            <a:off x="6263640" y="2377440"/>
-            <a:ext cx="987552" cy="411480"/>
-          </a:xfrm>
-          <a:prstGeom prst="rect">
-            <a:avLst/>
-          </a:prstGeom>
-          <a:noFill/>
-          <a:ln/>
-        </p:spPr>
-        <p:txBody>
-          <a:bodyPr wrap="square" lIns="0" tIns="0" rIns="0" bIns="0" rtlCol="0" anchor="ctr"/>
-          <a:lstStyle/>
-          <a:p>
-            <a:pPr marL="0" indent="0" algn="ctr">
-              <a:buNone/>
-            </a:pPr>
-            <a:r>
-              <a:rPr lang="en-US" sz="2600" b="1" dirty="0">
-                <a:solidFill>
-                  <a:schemeClr val="bg1"/>
-                </a:solidFill>
-                <a:latin typeface="Cambria" pitchFamily="34" charset="0"/>
-                <a:ea typeface="Cambria" pitchFamily="34" charset="-122"/>
-                <a:cs typeface="Cambria" pitchFamily="34" charset="-120"/>
-              </a:rPr>
-              <a:t>2</a:t>
-            </a:r>
-            <a:endParaRPr lang="en-US" sz="2600" dirty="0"/>
-          </a:p>
-        </p:txBody>
-      </p:sp>
-      <p:sp>
-        <p:nvSpPr>
-          <p:cNvPr id="28" name="Fecha mes 2025-2-1"/>
-          <p:cNvSpPr txBox="1"/>
-          <p:nvPr/>
-        </p:nvSpPr>
-        <p:spPr>
-          <a:xfrm>
-            <a:off x="6263640" y="2798064"/>
-            <a:ext cx="987552" cy="201168"/>
-          </a:xfrm>
-          <a:prstGeom prst="rect">
-            <a:avLst/>
-          </a:prstGeom>
-          <a:noFill/>
-          <a:ln/>
-        </p:spPr>
-        <p:txBody>
-          <a:bodyPr wrap="square" lIns="0" tIns="0" rIns="0" bIns="0" rtlCol="0" anchor="t"/>
-          <a:lstStyle/>
-          <a:p>
-            <a:pPr marL="0" indent="0" algn="ctr">
-              <a:buNone/>
-            </a:pPr>
-            <a:r>
-              <a:rPr lang="en-US" sz="850" b="1" kern="0" spc="100" dirty="0">
-                <a:solidFill>
-                  <a:schemeClr val="bg1"/>
-                </a:solidFill>
-              </a:rPr>
-              <a:t>SEGUIMIENTO</a:t>
-            </a:r>
-            <a:endParaRPr lang="en-US" sz="1000" dirty="0"/>
-          </a:p>
-        </p:txBody>
-      </p:sp>
-      <p:sp>
-        <p:nvSpPr>
-          <p:cNvPr id="29" name="Fechas separador 2025-2"/>
-          <p:cNvSpPr/>
-          <p:nvPr/>
-        </p:nvSpPr>
-        <p:spPr>
-          <a:xfrm>
-            <a:off x="6446520" y="2066544"/>
-            <a:ext cx="621792" cy="0"/>
-          </a:xfrm>
-          <a:prstGeom prst="line">
-            <a:avLst/>
-          </a:prstGeom>
-          <a:noFill/>
-          <a:ln w="9525">
-            <a:solidFill>
-              <a:schemeClr val="bg1">
-                <a:alpha val="60000"/>
-              </a:schemeClr>
-            </a:solidFill>
-            <a:prstDash val="solid"/>
-          </a:ln>
-        </p:spPr>
-        <p:txBody>
-          <a:bodyPr/>
-          <a:lstStyle/>
-          <a:p>
-            <a:endParaRPr lang="es-SV"/>
           </a:p>
         </p:txBody>
       </p:sp>

</xml_diff>

<commit_message>
Slide 1: list the 9 observations in 2025 results card
Co-Authored-By: Claude Opus 5.5 <noreply@anthropic.com>
Claude-Session: https://claude.ai/code/session_01F1WXR13Nv8neEtLhaK3ELa
</commit_message>
<xml_diff>
--- a/supervision-gobierno-corporativo/Supervision_GC_SSF_COMEDICA_2025-2026.pptx
+++ b/supervision-gobierno-corporativo/Supervision_GC_SSF_COMEDICA_2025-2026.pptx
@@ -3829,6 +3829,259 @@
                 </a:solidFill>
               </a:rPr>
               <a:t>9 observaciones</a:t>
+            </a:r>
+          </a:p>
+        </p:txBody>
+      </p:sp>
+      <p:sp>
+        <p:nvSpPr>
+          <p:cNvPr id="83" name="Lista observaciones 2025-0"/>
+          <p:cNvSpPr txBox="1"/>
+          <p:nvPr/>
+        </p:nvSpPr>
+        <p:spPr>
+          <a:xfrm>
+            <a:off x="7406640" y="2240280"/>
+            <a:ext cx="2084831" cy="914400"/>
+          </a:xfrm>
+          <a:prstGeom prst="rect">
+            <a:avLst/>
+          </a:prstGeom>
+          <a:noFill/>
+        </p:spPr>
+        <p:txBody>
+          <a:bodyPr wrap="square" lIns="0" rIns="0" tIns="0" bIns="0">
+            <a:spAutoFit/>
+          </a:bodyPr>
+          <a:lstStyle/>
+          <a:p>
+            <a:pPr>
+              <a:spcAft>
+                <a:spcPts val="200"/>
+              </a:spcAft>
+            </a:pPr>
+            <a:r>
+              <a:rPr b="1" sz="950">
+                <a:solidFill>
+                  <a:srgbClr val="173A6E"/>
+                </a:solidFill>
+              </a:rPr>
+              <a:t>1  </a:t>
+            </a:r>
+            <a:r>
+              <a:rPr sz="950">
+                <a:solidFill>
+                  <a:srgbClr val="142033"/>
+                </a:solidFill>
+              </a:rPr>
+              <a:t>Política de Operaciones Vinculadas</a:t>
+            </a:r>
+          </a:p>
+          <a:p>
+            <a:pPr>
+              <a:spcAft>
+                <a:spcPts val="200"/>
+              </a:spcAft>
+            </a:pPr>
+            <a:r>
+              <a:rPr b="1" sz="950">
+                <a:solidFill>
+                  <a:srgbClr val="173A6E"/>
+                </a:solidFill>
+              </a:rPr>
+              <a:t>2  </a:t>
+            </a:r>
+            <a:r>
+              <a:rPr sz="950">
+                <a:solidFill>
+                  <a:srgbClr val="142033"/>
+                </a:solidFill>
+              </a:rPr>
+              <a:t>Confidencialidad e inducción</a:t>
+            </a:r>
+          </a:p>
+          <a:p>
+            <a:pPr>
+              <a:spcAft>
+                <a:spcPts val="200"/>
+              </a:spcAft>
+            </a:pPr>
+            <a:r>
+              <a:rPr b="1" sz="950">
+                <a:solidFill>
+                  <a:srgbClr val="173A6E"/>
+                </a:solidFill>
+              </a:rPr>
+              <a:t>3  </a:t>
+            </a:r>
+            <a:r>
+              <a:rPr sz="950">
+                <a:solidFill>
+                  <a:srgbClr val="142033"/>
+                </a:solidFill>
+              </a:rPr>
+              <a:t>Integración de Comités de Apoyo</a:t>
+            </a:r>
+          </a:p>
+          <a:p>
+            <a:pPr>
+              <a:spcAft>
+                <a:spcPts val="200"/>
+              </a:spcAft>
+            </a:pPr>
+            <a:r>
+              <a:rPr b="1" sz="950">
+                <a:solidFill>
+                  <a:srgbClr val="173A6E"/>
+                </a:solidFill>
+              </a:rPr>
+              <a:t>4  </a:t>
+            </a:r>
+            <a:r>
+              <a:rPr sz="950">
+                <a:solidFill>
+                  <a:srgbClr val="142033"/>
+                </a:solidFill>
+              </a:rPr>
+              <a:t>Pago de dietas a directivos</a:t>
+            </a:r>
+          </a:p>
+          <a:p>
+            <a:pPr>
+              <a:spcAft>
+                <a:spcPts val="200"/>
+              </a:spcAft>
+            </a:pPr>
+            <a:r>
+              <a:rPr b="1" sz="950">
+                <a:solidFill>
+                  <a:srgbClr val="173A6E"/>
+                </a:solidFill>
+              </a:rPr>
+              <a:t>5  </a:t>
+            </a:r>
+            <a:r>
+              <a:rPr sz="950">
+                <a:solidFill>
+                  <a:srgbClr val="142033"/>
+                </a:solidFill>
+              </a:rPr>
+              <a:t>Normativa interna desactualizada</a:t>
+            </a:r>
+          </a:p>
+        </p:txBody>
+      </p:sp>
+      <p:sp>
+        <p:nvSpPr>
+          <p:cNvPr id="84" name="Lista observaciones 2025-1"/>
+          <p:cNvSpPr txBox="1"/>
+          <p:nvPr/>
+        </p:nvSpPr>
+        <p:spPr>
+          <a:xfrm>
+            <a:off x="9528048" y="2240280"/>
+            <a:ext cx="2084831" cy="914400"/>
+          </a:xfrm>
+          <a:prstGeom prst="rect">
+            <a:avLst/>
+          </a:prstGeom>
+          <a:noFill/>
+        </p:spPr>
+        <p:txBody>
+          <a:bodyPr wrap="square" lIns="0" rIns="0" tIns="0" bIns="0">
+            <a:spAutoFit/>
+          </a:bodyPr>
+          <a:lstStyle/>
+          <a:p>
+            <a:pPr>
+              <a:spcAft>
+                <a:spcPts val="200"/>
+              </a:spcAft>
+            </a:pPr>
+            <a:r>
+              <a:rPr b="1" sz="950">
+                <a:solidFill>
+                  <a:srgbClr val="173A6E"/>
+                </a:solidFill>
+              </a:rPr>
+              <a:t>6  </a:t>
+            </a:r>
+            <a:r>
+              <a:rPr sz="950">
+                <a:solidFill>
+                  <a:srgbClr val="142033"/>
+                </a:solidFill>
+              </a:rPr>
+              <a:t>Soporte de Ferias de Créditos</a:t>
+            </a:r>
+          </a:p>
+          <a:p>
+            <a:pPr>
+              <a:spcAft>
+                <a:spcPts val="200"/>
+              </a:spcAft>
+            </a:pPr>
+            <a:r>
+              <a:rPr b="1" sz="950">
+                <a:solidFill>
+                  <a:srgbClr val="173A6E"/>
+                </a:solidFill>
+              </a:rPr>
+              <a:t>7  </a:t>
+            </a:r>
+            <a:r>
+              <a:rPr sz="950">
+                <a:solidFill>
+                  <a:srgbClr val="142033"/>
+                </a:solidFill>
+              </a:rPr>
+              <a:t>Declaración jurada (NRP-75)</a:t>
+            </a:r>
+          </a:p>
+          <a:p>
+            <a:pPr>
+              <a:spcAft>
+                <a:spcPts val="200"/>
+              </a:spcAft>
+            </a:pPr>
+            <a:r>
+              <a:rPr b="1" sz="950">
+                <a:solidFill>
+                  <a:srgbClr val="173A6E"/>
+                </a:solidFill>
+              </a:rPr>
+              <a:t>8  </a:t>
+            </a:r>
+            <a:r>
+              <a:rPr sz="950">
+                <a:solidFill>
+                  <a:srgbClr val="142033"/>
+                </a:solidFill>
+              </a:rPr>
+              <a:t>Procedimientos del Manual de Compras</a:t>
+            </a:r>
+          </a:p>
+          <a:p>
+            <a:pPr>
+              <a:spcAft>
+                <a:spcPts val="200"/>
+              </a:spcAft>
+            </a:pPr>
+            <a:r>
+              <a:rPr b="1" sz="950">
+                <a:solidFill>
+                  <a:srgbClr val="173A6E"/>
+                </a:solidFill>
+              </a:rPr>
+              <a:t>9  </a:t>
+            </a:r>
+            <a:r>
+              <a:rPr sz="950">
+                <a:solidFill>
+                  <a:srgbClr val="142033"/>
+                </a:solidFill>
+              </a:rPr>
+              <a:t>Uso del Fondo de Educación</a:t>
             </a:r>
           </a:p>
         </p:txBody>

</xml_diff>